<commit_message>
Refine README pipeline teaser alignment
</commit_message>
<xml_diff>
--- a/docs/assets/readme-slides/mdpr-pipeline-teaser.pptx
+++ b/docs/assets/readme-slides/mdpr-pipeline-teaser.pptx
@@ -129,7 +129,7 @@
           <p:cNvPr id="2" name="제목 1">
             <a:extLst>
               <a:ext uri="{FF2B5EF4-FFF2-40B4-BE49-F238E27FC236}">
-                <a16:creationId xmlns:a16="http://schemas.microsoft.com/office/drawing/2014/main" id="{9D866012-F9F2-9917-4D3A-0D8A33AB69C4}"/>
+                <a16:creationId xmlns:a16="http://schemas.microsoft.com/office/drawing/2014/main" id="{15A30246-0E6D-449F-9B3A-0C50B528A0AA}"/>
               </a:ext>
             </a:extLst>
           </p:cNvPr>
@@ -166,7 +166,7 @@
           <p:cNvPr id="3" name="부제목 2">
             <a:extLst>
               <a:ext uri="{FF2B5EF4-FFF2-40B4-BE49-F238E27FC236}">
-                <a16:creationId xmlns:a16="http://schemas.microsoft.com/office/drawing/2014/main" id="{8A1DB47B-55C9-8632-3974-2EE9B942D1A7}"/>
+                <a16:creationId xmlns:a16="http://schemas.microsoft.com/office/drawing/2014/main" id="{AF22FECA-46E4-2756-9589-AC2EEF9E484F}"/>
               </a:ext>
             </a:extLst>
           </p:cNvPr>
@@ -236,7 +236,7 @@
           <p:cNvPr id="4" name="날짜 개체 틀 3">
             <a:extLst>
               <a:ext uri="{FF2B5EF4-FFF2-40B4-BE49-F238E27FC236}">
-                <a16:creationId xmlns:a16="http://schemas.microsoft.com/office/drawing/2014/main" id="{0054542E-DB74-C756-B37E-8E68991F87E5}"/>
+                <a16:creationId xmlns:a16="http://schemas.microsoft.com/office/drawing/2014/main" id="{416B1F31-CA79-9F61-2253-9F61253A3519}"/>
               </a:ext>
             </a:extLst>
           </p:cNvPr>
@@ -252,7 +252,7 @@
           <a:bodyPr/>
           <a:lstStyle/>
           <a:p>
-            <a:fld id="{B103BB0C-C4A9-4DBD-94E1-487EC0344102}" type="datetimeFigureOut">
+            <a:fld id="{A63FB5EC-CF88-4035-A752-ACC250E0626A}" type="datetimeFigureOut">
               <a:rPr lang="ko-KR" altLang="en-US" smtClean="0"/>
               <a:t>2026-06-20</a:t>
             </a:fld>
@@ -265,7 +265,7 @@
           <p:cNvPr id="5" name="바닥글 개체 틀 4">
             <a:extLst>
               <a:ext uri="{FF2B5EF4-FFF2-40B4-BE49-F238E27FC236}">
-                <a16:creationId xmlns:a16="http://schemas.microsoft.com/office/drawing/2014/main" id="{449FF34E-51DE-D3F7-9371-BE3AC47CB71B}"/>
+                <a16:creationId xmlns:a16="http://schemas.microsoft.com/office/drawing/2014/main" id="{5E8C68ED-AD92-B13A-4673-0600DC7699D9}"/>
               </a:ext>
             </a:extLst>
           </p:cNvPr>
@@ -290,7 +290,7 @@
           <p:cNvPr id="6" name="슬라이드 번호 개체 틀 5">
             <a:extLst>
               <a:ext uri="{FF2B5EF4-FFF2-40B4-BE49-F238E27FC236}">
-                <a16:creationId xmlns:a16="http://schemas.microsoft.com/office/drawing/2014/main" id="{13D03A3C-AF63-72DF-E6FE-E6D78A269D9C}"/>
+                <a16:creationId xmlns:a16="http://schemas.microsoft.com/office/drawing/2014/main" id="{06271CB9-E2BB-92E1-14BB-7EE0BD355B8A}"/>
               </a:ext>
             </a:extLst>
           </p:cNvPr>
@@ -306,7 +306,7 @@
           <a:bodyPr/>
           <a:lstStyle/>
           <a:p>
-            <a:fld id="{CBA3825E-68D6-403F-A3BD-24E345D7196E}" type="slidenum">
+            <a:fld id="{FE9BD0AC-AD16-4498-B7AD-B58A3BA041BF}" type="slidenum">
               <a:rPr lang="ko-KR" altLang="en-US" smtClean="0"/>
               <a:t>‹#›</a:t>
             </a:fld>
@@ -317,7 +317,7 @@
     </p:spTree>
     <p:extLst>
       <p:ext uri="{BB962C8B-B14F-4D97-AF65-F5344CB8AC3E}">
-        <p14:creationId xmlns:p14="http://schemas.microsoft.com/office/powerpoint/2010/main" val="745503651"/>
+        <p14:creationId xmlns:p14="http://schemas.microsoft.com/office/powerpoint/2010/main" val="3827427534"/>
       </p:ext>
     </p:extLst>
   </p:cSld>
@@ -349,7 +349,7 @@
           <p:cNvPr id="2" name="제목 1">
             <a:extLst>
               <a:ext uri="{FF2B5EF4-FFF2-40B4-BE49-F238E27FC236}">
-                <a16:creationId xmlns:a16="http://schemas.microsoft.com/office/drawing/2014/main" id="{B0E5A51B-9FEC-6A5F-E23B-DA203176563A}"/>
+                <a16:creationId xmlns:a16="http://schemas.microsoft.com/office/drawing/2014/main" id="{F79C07E5-FC2E-86C9-A456-149F7D6E4E68}"/>
               </a:ext>
             </a:extLst>
           </p:cNvPr>
@@ -377,7 +377,7 @@
           <p:cNvPr id="3" name="세로 텍스트 개체 틀 2">
             <a:extLst>
               <a:ext uri="{FF2B5EF4-FFF2-40B4-BE49-F238E27FC236}">
-                <a16:creationId xmlns:a16="http://schemas.microsoft.com/office/drawing/2014/main" id="{59B6ADF3-A70D-B6A6-66E3-18F4C8FE52E6}"/>
+                <a16:creationId xmlns:a16="http://schemas.microsoft.com/office/drawing/2014/main" id="{EB98D82B-FB08-43AA-10E1-6F1DF21F23FC}"/>
               </a:ext>
             </a:extLst>
           </p:cNvPr>
@@ -434,7 +434,7 @@
           <p:cNvPr id="4" name="날짜 개체 틀 3">
             <a:extLst>
               <a:ext uri="{FF2B5EF4-FFF2-40B4-BE49-F238E27FC236}">
-                <a16:creationId xmlns:a16="http://schemas.microsoft.com/office/drawing/2014/main" id="{ECC7A339-95F1-345B-3052-C6448AC2041C}"/>
+                <a16:creationId xmlns:a16="http://schemas.microsoft.com/office/drawing/2014/main" id="{43B822AA-8B28-581C-05E8-359B209A7DEC}"/>
               </a:ext>
             </a:extLst>
           </p:cNvPr>
@@ -450,7 +450,7 @@
           <a:bodyPr/>
           <a:lstStyle/>
           <a:p>
-            <a:fld id="{B103BB0C-C4A9-4DBD-94E1-487EC0344102}" type="datetimeFigureOut">
+            <a:fld id="{A63FB5EC-CF88-4035-A752-ACC250E0626A}" type="datetimeFigureOut">
               <a:rPr lang="ko-KR" altLang="en-US" smtClean="0"/>
               <a:t>2026-06-20</a:t>
             </a:fld>
@@ -463,7 +463,7 @@
           <p:cNvPr id="5" name="바닥글 개체 틀 4">
             <a:extLst>
               <a:ext uri="{FF2B5EF4-FFF2-40B4-BE49-F238E27FC236}">
-                <a16:creationId xmlns:a16="http://schemas.microsoft.com/office/drawing/2014/main" id="{756B5D18-6640-33FA-E59F-04A3D62E40EA}"/>
+                <a16:creationId xmlns:a16="http://schemas.microsoft.com/office/drawing/2014/main" id="{E332C1FC-3250-F78E-1F4A-37B2F52B7093}"/>
               </a:ext>
             </a:extLst>
           </p:cNvPr>
@@ -488,7 +488,7 @@
           <p:cNvPr id="6" name="슬라이드 번호 개체 틀 5">
             <a:extLst>
               <a:ext uri="{FF2B5EF4-FFF2-40B4-BE49-F238E27FC236}">
-                <a16:creationId xmlns:a16="http://schemas.microsoft.com/office/drawing/2014/main" id="{383A11AB-C70E-DC86-0C46-2E5D64220CC2}"/>
+                <a16:creationId xmlns:a16="http://schemas.microsoft.com/office/drawing/2014/main" id="{176EBE82-1459-339B-8AB7-F3204EB6211C}"/>
               </a:ext>
             </a:extLst>
           </p:cNvPr>
@@ -504,7 +504,7 @@
           <a:bodyPr/>
           <a:lstStyle/>
           <a:p>
-            <a:fld id="{CBA3825E-68D6-403F-A3BD-24E345D7196E}" type="slidenum">
+            <a:fld id="{FE9BD0AC-AD16-4498-B7AD-B58A3BA041BF}" type="slidenum">
               <a:rPr lang="ko-KR" altLang="en-US" smtClean="0"/>
               <a:t>‹#›</a:t>
             </a:fld>
@@ -515,7 +515,7 @@
     </p:spTree>
     <p:extLst>
       <p:ext uri="{BB962C8B-B14F-4D97-AF65-F5344CB8AC3E}">
-        <p14:creationId xmlns:p14="http://schemas.microsoft.com/office/powerpoint/2010/main" val="2505586801"/>
+        <p14:creationId xmlns:p14="http://schemas.microsoft.com/office/powerpoint/2010/main" val="1469090259"/>
       </p:ext>
     </p:extLst>
   </p:cSld>
@@ -547,7 +547,7 @@
           <p:cNvPr id="2" name="세로 제목 1">
             <a:extLst>
               <a:ext uri="{FF2B5EF4-FFF2-40B4-BE49-F238E27FC236}">
-                <a16:creationId xmlns:a16="http://schemas.microsoft.com/office/drawing/2014/main" id="{63DD31E9-2FA4-79C8-E270-BE0ED0C499AD}"/>
+                <a16:creationId xmlns:a16="http://schemas.microsoft.com/office/drawing/2014/main" id="{ED01F664-A3A9-DB48-1FA6-4D9DC7E1E3E7}"/>
               </a:ext>
             </a:extLst>
           </p:cNvPr>
@@ -580,7 +580,7 @@
           <p:cNvPr id="3" name="세로 텍스트 개체 틀 2">
             <a:extLst>
               <a:ext uri="{FF2B5EF4-FFF2-40B4-BE49-F238E27FC236}">
-                <a16:creationId xmlns:a16="http://schemas.microsoft.com/office/drawing/2014/main" id="{E445E7CD-8D16-FBAB-D7A9-17EDAF310AB9}"/>
+                <a16:creationId xmlns:a16="http://schemas.microsoft.com/office/drawing/2014/main" id="{001DEA81-3A86-31AB-AFAC-BE39EF8E9A3D}"/>
               </a:ext>
             </a:extLst>
           </p:cNvPr>
@@ -642,7 +642,7 @@
           <p:cNvPr id="4" name="날짜 개체 틀 3">
             <a:extLst>
               <a:ext uri="{FF2B5EF4-FFF2-40B4-BE49-F238E27FC236}">
-                <a16:creationId xmlns:a16="http://schemas.microsoft.com/office/drawing/2014/main" id="{EBE7176D-8B6A-B812-C7F5-668FAA1FAE51}"/>
+                <a16:creationId xmlns:a16="http://schemas.microsoft.com/office/drawing/2014/main" id="{F06C1E78-CC28-43FB-3894-1EE3043D3B7A}"/>
               </a:ext>
             </a:extLst>
           </p:cNvPr>
@@ -658,7 +658,7 @@
           <a:bodyPr/>
           <a:lstStyle/>
           <a:p>
-            <a:fld id="{B103BB0C-C4A9-4DBD-94E1-487EC0344102}" type="datetimeFigureOut">
+            <a:fld id="{A63FB5EC-CF88-4035-A752-ACC250E0626A}" type="datetimeFigureOut">
               <a:rPr lang="ko-KR" altLang="en-US" smtClean="0"/>
               <a:t>2026-06-20</a:t>
             </a:fld>
@@ -671,7 +671,7 @@
           <p:cNvPr id="5" name="바닥글 개체 틀 4">
             <a:extLst>
               <a:ext uri="{FF2B5EF4-FFF2-40B4-BE49-F238E27FC236}">
-                <a16:creationId xmlns:a16="http://schemas.microsoft.com/office/drawing/2014/main" id="{3A9EAC77-B0DB-3D60-0683-C2A0B94C8D57}"/>
+                <a16:creationId xmlns:a16="http://schemas.microsoft.com/office/drawing/2014/main" id="{1FAF613B-D8EC-25B5-4AB7-6BC803DDF2BC}"/>
               </a:ext>
             </a:extLst>
           </p:cNvPr>
@@ -696,7 +696,7 @@
           <p:cNvPr id="6" name="슬라이드 번호 개체 틀 5">
             <a:extLst>
               <a:ext uri="{FF2B5EF4-FFF2-40B4-BE49-F238E27FC236}">
-                <a16:creationId xmlns:a16="http://schemas.microsoft.com/office/drawing/2014/main" id="{82ACF984-C3F5-6886-E2DD-C3C0CAF74E2B}"/>
+                <a16:creationId xmlns:a16="http://schemas.microsoft.com/office/drawing/2014/main" id="{D83C513E-B149-F056-15E8-C26740BCAC9D}"/>
               </a:ext>
             </a:extLst>
           </p:cNvPr>
@@ -712,7 +712,7 @@
           <a:bodyPr/>
           <a:lstStyle/>
           <a:p>
-            <a:fld id="{CBA3825E-68D6-403F-A3BD-24E345D7196E}" type="slidenum">
+            <a:fld id="{FE9BD0AC-AD16-4498-B7AD-B58A3BA041BF}" type="slidenum">
               <a:rPr lang="ko-KR" altLang="en-US" smtClean="0"/>
               <a:t>‹#›</a:t>
             </a:fld>
@@ -723,7 +723,7 @@
     </p:spTree>
     <p:extLst>
       <p:ext uri="{BB962C8B-B14F-4D97-AF65-F5344CB8AC3E}">
-        <p14:creationId xmlns:p14="http://schemas.microsoft.com/office/powerpoint/2010/main" val="3729346522"/>
+        <p14:creationId xmlns:p14="http://schemas.microsoft.com/office/powerpoint/2010/main" val="2026523762"/>
       </p:ext>
     </p:extLst>
   </p:cSld>
@@ -755,7 +755,7 @@
           <p:cNvPr id="2" name="제목 1">
             <a:extLst>
               <a:ext uri="{FF2B5EF4-FFF2-40B4-BE49-F238E27FC236}">
-                <a16:creationId xmlns:a16="http://schemas.microsoft.com/office/drawing/2014/main" id="{49198A24-B9A6-696A-1523-BDC606E526F6}"/>
+                <a16:creationId xmlns:a16="http://schemas.microsoft.com/office/drawing/2014/main" id="{B88D2776-BC68-728A-5C2A-70240FD142A8}"/>
               </a:ext>
             </a:extLst>
           </p:cNvPr>
@@ -783,7 +783,7 @@
           <p:cNvPr id="3" name="내용 개체 틀 2">
             <a:extLst>
               <a:ext uri="{FF2B5EF4-FFF2-40B4-BE49-F238E27FC236}">
-                <a16:creationId xmlns:a16="http://schemas.microsoft.com/office/drawing/2014/main" id="{BB60D129-D37E-8C6F-60F0-6BFC2D762679}"/>
+                <a16:creationId xmlns:a16="http://schemas.microsoft.com/office/drawing/2014/main" id="{512AFB13-35B8-7D85-FE1E-D14FB7334703}"/>
               </a:ext>
             </a:extLst>
           </p:cNvPr>
@@ -840,7 +840,7 @@
           <p:cNvPr id="4" name="날짜 개체 틀 3">
             <a:extLst>
               <a:ext uri="{FF2B5EF4-FFF2-40B4-BE49-F238E27FC236}">
-                <a16:creationId xmlns:a16="http://schemas.microsoft.com/office/drawing/2014/main" id="{5901A1F6-B7F0-1509-BE32-9F0AD062DC04}"/>
+                <a16:creationId xmlns:a16="http://schemas.microsoft.com/office/drawing/2014/main" id="{5C3435F3-765F-A191-063A-AE4BC7F05C04}"/>
               </a:ext>
             </a:extLst>
           </p:cNvPr>
@@ -856,7 +856,7 @@
           <a:bodyPr/>
           <a:lstStyle/>
           <a:p>
-            <a:fld id="{B103BB0C-C4A9-4DBD-94E1-487EC0344102}" type="datetimeFigureOut">
+            <a:fld id="{A63FB5EC-CF88-4035-A752-ACC250E0626A}" type="datetimeFigureOut">
               <a:rPr lang="ko-KR" altLang="en-US" smtClean="0"/>
               <a:t>2026-06-20</a:t>
             </a:fld>
@@ -869,7 +869,7 @@
           <p:cNvPr id="5" name="바닥글 개체 틀 4">
             <a:extLst>
               <a:ext uri="{FF2B5EF4-FFF2-40B4-BE49-F238E27FC236}">
-                <a16:creationId xmlns:a16="http://schemas.microsoft.com/office/drawing/2014/main" id="{223ADACA-3E71-A94E-7D1D-41855356D960}"/>
+                <a16:creationId xmlns:a16="http://schemas.microsoft.com/office/drawing/2014/main" id="{268C1387-2417-D030-D3CB-DE01F8538F87}"/>
               </a:ext>
             </a:extLst>
           </p:cNvPr>
@@ -894,7 +894,7 @@
           <p:cNvPr id="6" name="슬라이드 번호 개체 틀 5">
             <a:extLst>
               <a:ext uri="{FF2B5EF4-FFF2-40B4-BE49-F238E27FC236}">
-                <a16:creationId xmlns:a16="http://schemas.microsoft.com/office/drawing/2014/main" id="{801C8E84-3FC9-98E8-09FC-32EEE27D58C1}"/>
+                <a16:creationId xmlns:a16="http://schemas.microsoft.com/office/drawing/2014/main" id="{E18E1C98-4564-FF41-331D-ADD882B08195}"/>
               </a:ext>
             </a:extLst>
           </p:cNvPr>
@@ -910,7 +910,7 @@
           <a:bodyPr/>
           <a:lstStyle/>
           <a:p>
-            <a:fld id="{CBA3825E-68D6-403F-A3BD-24E345D7196E}" type="slidenum">
+            <a:fld id="{FE9BD0AC-AD16-4498-B7AD-B58A3BA041BF}" type="slidenum">
               <a:rPr lang="ko-KR" altLang="en-US" smtClean="0"/>
               <a:t>‹#›</a:t>
             </a:fld>
@@ -921,7 +921,7 @@
     </p:spTree>
     <p:extLst>
       <p:ext uri="{BB962C8B-B14F-4D97-AF65-F5344CB8AC3E}">
-        <p14:creationId xmlns:p14="http://schemas.microsoft.com/office/powerpoint/2010/main" val="1368065185"/>
+        <p14:creationId xmlns:p14="http://schemas.microsoft.com/office/powerpoint/2010/main" val="3499918860"/>
       </p:ext>
     </p:extLst>
   </p:cSld>
@@ -953,7 +953,7 @@
           <p:cNvPr id="2" name="제목 1">
             <a:extLst>
               <a:ext uri="{FF2B5EF4-FFF2-40B4-BE49-F238E27FC236}">
-                <a16:creationId xmlns:a16="http://schemas.microsoft.com/office/drawing/2014/main" id="{093125D4-6319-707E-80CD-635359873A35}"/>
+                <a16:creationId xmlns:a16="http://schemas.microsoft.com/office/drawing/2014/main" id="{5184698F-18AB-3425-96E0-5BDF601E4CF0}"/>
               </a:ext>
             </a:extLst>
           </p:cNvPr>
@@ -990,7 +990,7 @@
           <p:cNvPr id="3" name="텍스트 개체 틀 2">
             <a:extLst>
               <a:ext uri="{FF2B5EF4-FFF2-40B4-BE49-F238E27FC236}">
-                <a16:creationId xmlns:a16="http://schemas.microsoft.com/office/drawing/2014/main" id="{B5450EFF-1608-7941-252A-CB340B913201}"/>
+                <a16:creationId xmlns:a16="http://schemas.microsoft.com/office/drawing/2014/main" id="{AFEFB3E4-FB01-1A7E-A225-F236DF241136}"/>
               </a:ext>
             </a:extLst>
           </p:cNvPr>
@@ -1115,7 +1115,7 @@
           <p:cNvPr id="4" name="날짜 개체 틀 3">
             <a:extLst>
               <a:ext uri="{FF2B5EF4-FFF2-40B4-BE49-F238E27FC236}">
-                <a16:creationId xmlns:a16="http://schemas.microsoft.com/office/drawing/2014/main" id="{E7BF1C81-4705-B1B0-0475-C33CE8B491F5}"/>
+                <a16:creationId xmlns:a16="http://schemas.microsoft.com/office/drawing/2014/main" id="{CA5C1B1E-8E2D-F2BF-1EAD-7F56E7277ADC}"/>
               </a:ext>
             </a:extLst>
           </p:cNvPr>
@@ -1131,7 +1131,7 @@
           <a:bodyPr/>
           <a:lstStyle/>
           <a:p>
-            <a:fld id="{B103BB0C-C4A9-4DBD-94E1-487EC0344102}" type="datetimeFigureOut">
+            <a:fld id="{A63FB5EC-CF88-4035-A752-ACC250E0626A}" type="datetimeFigureOut">
               <a:rPr lang="ko-KR" altLang="en-US" smtClean="0"/>
               <a:t>2026-06-20</a:t>
             </a:fld>
@@ -1144,7 +1144,7 @@
           <p:cNvPr id="5" name="바닥글 개체 틀 4">
             <a:extLst>
               <a:ext uri="{FF2B5EF4-FFF2-40B4-BE49-F238E27FC236}">
-                <a16:creationId xmlns:a16="http://schemas.microsoft.com/office/drawing/2014/main" id="{19AF6C6F-2E12-CA8F-2922-46123610336B}"/>
+                <a16:creationId xmlns:a16="http://schemas.microsoft.com/office/drawing/2014/main" id="{454B87B4-8A9F-F60E-84C8-C9E7E2750096}"/>
               </a:ext>
             </a:extLst>
           </p:cNvPr>
@@ -1169,7 +1169,7 @@
           <p:cNvPr id="6" name="슬라이드 번호 개체 틀 5">
             <a:extLst>
               <a:ext uri="{FF2B5EF4-FFF2-40B4-BE49-F238E27FC236}">
-                <a16:creationId xmlns:a16="http://schemas.microsoft.com/office/drawing/2014/main" id="{7107CCFB-B352-901C-6F5D-A678E5617D23}"/>
+                <a16:creationId xmlns:a16="http://schemas.microsoft.com/office/drawing/2014/main" id="{5AB70A2E-4204-29D2-F4F5-83DAD68AC59C}"/>
               </a:ext>
             </a:extLst>
           </p:cNvPr>
@@ -1185,7 +1185,7 @@
           <a:bodyPr/>
           <a:lstStyle/>
           <a:p>
-            <a:fld id="{CBA3825E-68D6-403F-A3BD-24E345D7196E}" type="slidenum">
+            <a:fld id="{FE9BD0AC-AD16-4498-B7AD-B58A3BA041BF}" type="slidenum">
               <a:rPr lang="ko-KR" altLang="en-US" smtClean="0"/>
               <a:t>‹#›</a:t>
             </a:fld>
@@ -1196,7 +1196,7 @@
     </p:spTree>
     <p:extLst>
       <p:ext uri="{BB962C8B-B14F-4D97-AF65-F5344CB8AC3E}">
-        <p14:creationId xmlns:p14="http://schemas.microsoft.com/office/powerpoint/2010/main" val="2747562684"/>
+        <p14:creationId xmlns:p14="http://schemas.microsoft.com/office/powerpoint/2010/main" val="4201571969"/>
       </p:ext>
     </p:extLst>
   </p:cSld>
@@ -1228,7 +1228,7 @@
           <p:cNvPr id="2" name="제목 1">
             <a:extLst>
               <a:ext uri="{FF2B5EF4-FFF2-40B4-BE49-F238E27FC236}">
-                <a16:creationId xmlns:a16="http://schemas.microsoft.com/office/drawing/2014/main" id="{29FAC64E-045A-C6F4-ABCB-E59D7E913DAE}"/>
+                <a16:creationId xmlns:a16="http://schemas.microsoft.com/office/drawing/2014/main" id="{7801D98D-AA22-4536-F635-827CC2688881}"/>
               </a:ext>
             </a:extLst>
           </p:cNvPr>
@@ -1256,7 +1256,7 @@
           <p:cNvPr id="3" name="내용 개체 틀 2">
             <a:extLst>
               <a:ext uri="{FF2B5EF4-FFF2-40B4-BE49-F238E27FC236}">
-                <a16:creationId xmlns:a16="http://schemas.microsoft.com/office/drawing/2014/main" id="{92D31720-9EAA-0535-22B8-97283F4DAD67}"/>
+                <a16:creationId xmlns:a16="http://schemas.microsoft.com/office/drawing/2014/main" id="{B57BC3E7-0E70-5D9D-2C3C-705FC5557879}"/>
               </a:ext>
             </a:extLst>
           </p:cNvPr>
@@ -1318,7 +1318,7 @@
           <p:cNvPr id="4" name="내용 개체 틀 3">
             <a:extLst>
               <a:ext uri="{FF2B5EF4-FFF2-40B4-BE49-F238E27FC236}">
-                <a16:creationId xmlns:a16="http://schemas.microsoft.com/office/drawing/2014/main" id="{5EA5839F-1F73-674A-3694-DC6D15D876D1}"/>
+                <a16:creationId xmlns:a16="http://schemas.microsoft.com/office/drawing/2014/main" id="{4B367486-0AF0-5D65-AF99-55448FE406A0}"/>
               </a:ext>
             </a:extLst>
           </p:cNvPr>
@@ -1380,7 +1380,7 @@
           <p:cNvPr id="5" name="날짜 개체 틀 4">
             <a:extLst>
               <a:ext uri="{FF2B5EF4-FFF2-40B4-BE49-F238E27FC236}">
-                <a16:creationId xmlns:a16="http://schemas.microsoft.com/office/drawing/2014/main" id="{C67E2F8E-8ABA-6239-F597-8B4E9C3AA408}"/>
+                <a16:creationId xmlns:a16="http://schemas.microsoft.com/office/drawing/2014/main" id="{7B9A1818-C229-431F-1EBA-6D4BC55201D4}"/>
               </a:ext>
             </a:extLst>
           </p:cNvPr>
@@ -1396,7 +1396,7 @@
           <a:bodyPr/>
           <a:lstStyle/>
           <a:p>
-            <a:fld id="{B103BB0C-C4A9-4DBD-94E1-487EC0344102}" type="datetimeFigureOut">
+            <a:fld id="{A63FB5EC-CF88-4035-A752-ACC250E0626A}" type="datetimeFigureOut">
               <a:rPr lang="ko-KR" altLang="en-US" smtClean="0"/>
               <a:t>2026-06-20</a:t>
             </a:fld>
@@ -1409,7 +1409,7 @@
           <p:cNvPr id="6" name="바닥글 개체 틀 5">
             <a:extLst>
               <a:ext uri="{FF2B5EF4-FFF2-40B4-BE49-F238E27FC236}">
-                <a16:creationId xmlns:a16="http://schemas.microsoft.com/office/drawing/2014/main" id="{080A00FB-3CC1-F88D-8D40-605AE292250C}"/>
+                <a16:creationId xmlns:a16="http://schemas.microsoft.com/office/drawing/2014/main" id="{57A12F3B-3F33-D2CF-2B32-61AA7DFBBBA0}"/>
               </a:ext>
             </a:extLst>
           </p:cNvPr>
@@ -1434,7 +1434,7 @@
           <p:cNvPr id="7" name="슬라이드 번호 개체 틀 6">
             <a:extLst>
               <a:ext uri="{FF2B5EF4-FFF2-40B4-BE49-F238E27FC236}">
-                <a16:creationId xmlns:a16="http://schemas.microsoft.com/office/drawing/2014/main" id="{F72F7E1F-09A4-9255-237D-91C1FB9C5737}"/>
+                <a16:creationId xmlns:a16="http://schemas.microsoft.com/office/drawing/2014/main" id="{CEFE1BF6-DED9-320A-5A25-E40A9823C881}"/>
               </a:ext>
             </a:extLst>
           </p:cNvPr>
@@ -1450,7 +1450,7 @@
           <a:bodyPr/>
           <a:lstStyle/>
           <a:p>
-            <a:fld id="{CBA3825E-68D6-403F-A3BD-24E345D7196E}" type="slidenum">
+            <a:fld id="{FE9BD0AC-AD16-4498-B7AD-B58A3BA041BF}" type="slidenum">
               <a:rPr lang="ko-KR" altLang="en-US" smtClean="0"/>
               <a:t>‹#›</a:t>
             </a:fld>
@@ -1461,7 +1461,7 @@
     </p:spTree>
     <p:extLst>
       <p:ext uri="{BB962C8B-B14F-4D97-AF65-F5344CB8AC3E}">
-        <p14:creationId xmlns:p14="http://schemas.microsoft.com/office/powerpoint/2010/main" val="1779964153"/>
+        <p14:creationId xmlns:p14="http://schemas.microsoft.com/office/powerpoint/2010/main" val="790113431"/>
       </p:ext>
     </p:extLst>
   </p:cSld>
@@ -1493,7 +1493,7 @@
           <p:cNvPr id="2" name="제목 1">
             <a:extLst>
               <a:ext uri="{FF2B5EF4-FFF2-40B4-BE49-F238E27FC236}">
-                <a16:creationId xmlns:a16="http://schemas.microsoft.com/office/drawing/2014/main" id="{13F7D7FB-AE62-4EE0-6858-EB0FB6AB3E24}"/>
+                <a16:creationId xmlns:a16="http://schemas.microsoft.com/office/drawing/2014/main" id="{2E255485-E140-E320-19C3-E8613EF2695E}"/>
               </a:ext>
             </a:extLst>
           </p:cNvPr>
@@ -1526,7 +1526,7 @@
           <p:cNvPr id="3" name="텍스트 개체 틀 2">
             <a:extLst>
               <a:ext uri="{FF2B5EF4-FFF2-40B4-BE49-F238E27FC236}">
-                <a16:creationId xmlns:a16="http://schemas.microsoft.com/office/drawing/2014/main" id="{AC921FF1-1033-5FF1-6431-B40712811817}"/>
+                <a16:creationId xmlns:a16="http://schemas.microsoft.com/office/drawing/2014/main" id="{0D633DD1-AF81-8F4B-52A8-0BF8C465A9AC}"/>
               </a:ext>
             </a:extLst>
           </p:cNvPr>
@@ -1597,7 +1597,7 @@
           <p:cNvPr id="4" name="내용 개체 틀 3">
             <a:extLst>
               <a:ext uri="{FF2B5EF4-FFF2-40B4-BE49-F238E27FC236}">
-                <a16:creationId xmlns:a16="http://schemas.microsoft.com/office/drawing/2014/main" id="{8F895B9B-970C-3487-3014-27589A59F7D4}"/>
+                <a16:creationId xmlns:a16="http://schemas.microsoft.com/office/drawing/2014/main" id="{F26CF5B2-BA2F-0A78-BCBD-AB5F57C08AB9}"/>
               </a:ext>
             </a:extLst>
           </p:cNvPr>
@@ -1659,7 +1659,7 @@
           <p:cNvPr id="5" name="텍스트 개체 틀 4">
             <a:extLst>
               <a:ext uri="{FF2B5EF4-FFF2-40B4-BE49-F238E27FC236}">
-                <a16:creationId xmlns:a16="http://schemas.microsoft.com/office/drawing/2014/main" id="{D85AC8D8-A3A8-075B-232B-7A9AD4B06D61}"/>
+                <a16:creationId xmlns:a16="http://schemas.microsoft.com/office/drawing/2014/main" id="{D5F982DE-DF20-1613-8078-FBFB275E711E}"/>
               </a:ext>
             </a:extLst>
           </p:cNvPr>
@@ -1730,7 +1730,7 @@
           <p:cNvPr id="6" name="내용 개체 틀 5">
             <a:extLst>
               <a:ext uri="{FF2B5EF4-FFF2-40B4-BE49-F238E27FC236}">
-                <a16:creationId xmlns:a16="http://schemas.microsoft.com/office/drawing/2014/main" id="{5678DD18-2C11-CFE8-54E0-A0FCB6F2A9DA}"/>
+                <a16:creationId xmlns:a16="http://schemas.microsoft.com/office/drawing/2014/main" id="{1CE62BB1-43C6-AC19-AD90-1FCFA8ECE930}"/>
               </a:ext>
             </a:extLst>
           </p:cNvPr>
@@ -1792,7 +1792,7 @@
           <p:cNvPr id="7" name="날짜 개체 틀 6">
             <a:extLst>
               <a:ext uri="{FF2B5EF4-FFF2-40B4-BE49-F238E27FC236}">
-                <a16:creationId xmlns:a16="http://schemas.microsoft.com/office/drawing/2014/main" id="{6089894B-DB5F-63FD-C259-18222B30DEB4}"/>
+                <a16:creationId xmlns:a16="http://schemas.microsoft.com/office/drawing/2014/main" id="{566CAD9C-8FB4-6C5C-208A-5FCE57E33A2C}"/>
               </a:ext>
             </a:extLst>
           </p:cNvPr>
@@ -1808,7 +1808,7 @@
           <a:bodyPr/>
           <a:lstStyle/>
           <a:p>
-            <a:fld id="{B103BB0C-C4A9-4DBD-94E1-487EC0344102}" type="datetimeFigureOut">
+            <a:fld id="{A63FB5EC-CF88-4035-A752-ACC250E0626A}" type="datetimeFigureOut">
               <a:rPr lang="ko-KR" altLang="en-US" smtClean="0"/>
               <a:t>2026-06-20</a:t>
             </a:fld>
@@ -1821,7 +1821,7 @@
           <p:cNvPr id="8" name="바닥글 개체 틀 7">
             <a:extLst>
               <a:ext uri="{FF2B5EF4-FFF2-40B4-BE49-F238E27FC236}">
-                <a16:creationId xmlns:a16="http://schemas.microsoft.com/office/drawing/2014/main" id="{9DC9A4A2-0B8D-7CDC-437E-044159A65738}"/>
+                <a16:creationId xmlns:a16="http://schemas.microsoft.com/office/drawing/2014/main" id="{BCF37FC1-ECA5-5022-EBAC-0A8A0854A8F1}"/>
               </a:ext>
             </a:extLst>
           </p:cNvPr>
@@ -1846,7 +1846,7 @@
           <p:cNvPr id="9" name="슬라이드 번호 개체 틀 8">
             <a:extLst>
               <a:ext uri="{FF2B5EF4-FFF2-40B4-BE49-F238E27FC236}">
-                <a16:creationId xmlns:a16="http://schemas.microsoft.com/office/drawing/2014/main" id="{626F08F8-1D7A-947A-5930-BAAAC49DA7B9}"/>
+                <a16:creationId xmlns:a16="http://schemas.microsoft.com/office/drawing/2014/main" id="{9D7E44CB-288F-AFE4-F475-1B304C80FABE}"/>
               </a:ext>
             </a:extLst>
           </p:cNvPr>
@@ -1862,7 +1862,7 @@
           <a:bodyPr/>
           <a:lstStyle/>
           <a:p>
-            <a:fld id="{CBA3825E-68D6-403F-A3BD-24E345D7196E}" type="slidenum">
+            <a:fld id="{FE9BD0AC-AD16-4498-B7AD-B58A3BA041BF}" type="slidenum">
               <a:rPr lang="ko-KR" altLang="en-US" smtClean="0"/>
               <a:t>‹#›</a:t>
             </a:fld>
@@ -1873,7 +1873,7 @@
     </p:spTree>
     <p:extLst>
       <p:ext uri="{BB962C8B-B14F-4D97-AF65-F5344CB8AC3E}">
-        <p14:creationId xmlns:p14="http://schemas.microsoft.com/office/powerpoint/2010/main" val="2801962673"/>
+        <p14:creationId xmlns:p14="http://schemas.microsoft.com/office/powerpoint/2010/main" val="3071882999"/>
       </p:ext>
     </p:extLst>
   </p:cSld>
@@ -1905,7 +1905,7 @@
           <p:cNvPr id="2" name="제목 1">
             <a:extLst>
               <a:ext uri="{FF2B5EF4-FFF2-40B4-BE49-F238E27FC236}">
-                <a16:creationId xmlns:a16="http://schemas.microsoft.com/office/drawing/2014/main" id="{6BFD9874-6B4E-2FBE-B606-5332197E1827}"/>
+                <a16:creationId xmlns:a16="http://schemas.microsoft.com/office/drawing/2014/main" id="{B649E272-78F2-2B83-BEBF-E41E97B9597C}"/>
               </a:ext>
             </a:extLst>
           </p:cNvPr>
@@ -1933,7 +1933,7 @@
           <p:cNvPr id="3" name="날짜 개체 틀 2">
             <a:extLst>
               <a:ext uri="{FF2B5EF4-FFF2-40B4-BE49-F238E27FC236}">
-                <a16:creationId xmlns:a16="http://schemas.microsoft.com/office/drawing/2014/main" id="{67331581-222C-CFBE-C1F9-64DFFC0BA49B}"/>
+                <a16:creationId xmlns:a16="http://schemas.microsoft.com/office/drawing/2014/main" id="{CC8CA0BB-26F0-8C6D-2616-13AA54AFAB88}"/>
               </a:ext>
             </a:extLst>
           </p:cNvPr>
@@ -1949,7 +1949,7 @@
           <a:bodyPr/>
           <a:lstStyle/>
           <a:p>
-            <a:fld id="{B103BB0C-C4A9-4DBD-94E1-487EC0344102}" type="datetimeFigureOut">
+            <a:fld id="{A63FB5EC-CF88-4035-A752-ACC250E0626A}" type="datetimeFigureOut">
               <a:rPr lang="ko-KR" altLang="en-US" smtClean="0"/>
               <a:t>2026-06-20</a:t>
             </a:fld>
@@ -1962,7 +1962,7 @@
           <p:cNvPr id="4" name="바닥글 개체 틀 3">
             <a:extLst>
               <a:ext uri="{FF2B5EF4-FFF2-40B4-BE49-F238E27FC236}">
-                <a16:creationId xmlns:a16="http://schemas.microsoft.com/office/drawing/2014/main" id="{715DD2BF-1558-A26B-3192-30EBE1CC0100}"/>
+                <a16:creationId xmlns:a16="http://schemas.microsoft.com/office/drawing/2014/main" id="{8F71F9C2-F25F-EB90-F7B1-9B3C99404B7A}"/>
               </a:ext>
             </a:extLst>
           </p:cNvPr>
@@ -1987,7 +1987,7 @@
           <p:cNvPr id="5" name="슬라이드 번호 개체 틀 4">
             <a:extLst>
               <a:ext uri="{FF2B5EF4-FFF2-40B4-BE49-F238E27FC236}">
-                <a16:creationId xmlns:a16="http://schemas.microsoft.com/office/drawing/2014/main" id="{DD155633-4563-394C-A20C-31AA948F3882}"/>
+                <a16:creationId xmlns:a16="http://schemas.microsoft.com/office/drawing/2014/main" id="{58C0C6B3-3EC2-85F0-3EC4-5941C6A8207A}"/>
               </a:ext>
             </a:extLst>
           </p:cNvPr>
@@ -2003,7 +2003,7 @@
           <a:bodyPr/>
           <a:lstStyle/>
           <a:p>
-            <a:fld id="{CBA3825E-68D6-403F-A3BD-24E345D7196E}" type="slidenum">
+            <a:fld id="{FE9BD0AC-AD16-4498-B7AD-B58A3BA041BF}" type="slidenum">
               <a:rPr lang="ko-KR" altLang="en-US" smtClean="0"/>
               <a:t>‹#›</a:t>
             </a:fld>
@@ -2014,7 +2014,7 @@
     </p:spTree>
     <p:extLst>
       <p:ext uri="{BB962C8B-B14F-4D97-AF65-F5344CB8AC3E}">
-        <p14:creationId xmlns:p14="http://schemas.microsoft.com/office/powerpoint/2010/main" val="1659110734"/>
+        <p14:creationId xmlns:p14="http://schemas.microsoft.com/office/powerpoint/2010/main" val="1292972361"/>
       </p:ext>
     </p:extLst>
   </p:cSld>
@@ -2046,7 +2046,7 @@
           <p:cNvPr id="2" name="날짜 개체 틀 1">
             <a:extLst>
               <a:ext uri="{FF2B5EF4-FFF2-40B4-BE49-F238E27FC236}">
-                <a16:creationId xmlns:a16="http://schemas.microsoft.com/office/drawing/2014/main" id="{76E3F466-F917-B1D9-309B-A9AC47DB553A}"/>
+                <a16:creationId xmlns:a16="http://schemas.microsoft.com/office/drawing/2014/main" id="{38484E79-289E-9D57-B116-D49B45ADB1D9}"/>
               </a:ext>
             </a:extLst>
           </p:cNvPr>
@@ -2062,7 +2062,7 @@
           <a:bodyPr/>
           <a:lstStyle/>
           <a:p>
-            <a:fld id="{B103BB0C-C4A9-4DBD-94E1-487EC0344102}" type="datetimeFigureOut">
+            <a:fld id="{A63FB5EC-CF88-4035-A752-ACC250E0626A}" type="datetimeFigureOut">
               <a:rPr lang="ko-KR" altLang="en-US" smtClean="0"/>
               <a:t>2026-06-20</a:t>
             </a:fld>
@@ -2075,7 +2075,7 @@
           <p:cNvPr id="3" name="바닥글 개체 틀 2">
             <a:extLst>
               <a:ext uri="{FF2B5EF4-FFF2-40B4-BE49-F238E27FC236}">
-                <a16:creationId xmlns:a16="http://schemas.microsoft.com/office/drawing/2014/main" id="{86233ECE-A0C2-F40B-B1D6-F006272DEC14}"/>
+                <a16:creationId xmlns:a16="http://schemas.microsoft.com/office/drawing/2014/main" id="{D067095C-997D-082B-96DA-700CCBE9672B}"/>
               </a:ext>
             </a:extLst>
           </p:cNvPr>
@@ -2100,7 +2100,7 @@
           <p:cNvPr id="4" name="슬라이드 번호 개체 틀 3">
             <a:extLst>
               <a:ext uri="{FF2B5EF4-FFF2-40B4-BE49-F238E27FC236}">
-                <a16:creationId xmlns:a16="http://schemas.microsoft.com/office/drawing/2014/main" id="{4991FC5D-9667-FC98-48AF-B40FE907E7FE}"/>
+                <a16:creationId xmlns:a16="http://schemas.microsoft.com/office/drawing/2014/main" id="{670FD8FF-AEFC-B07E-AAE8-B959FBBA70B2}"/>
               </a:ext>
             </a:extLst>
           </p:cNvPr>
@@ -2116,7 +2116,7 @@
           <a:bodyPr/>
           <a:lstStyle/>
           <a:p>
-            <a:fld id="{CBA3825E-68D6-403F-A3BD-24E345D7196E}" type="slidenum">
+            <a:fld id="{FE9BD0AC-AD16-4498-B7AD-B58A3BA041BF}" type="slidenum">
               <a:rPr lang="ko-KR" altLang="en-US" smtClean="0"/>
               <a:t>‹#›</a:t>
             </a:fld>
@@ -2127,7 +2127,7 @@
     </p:spTree>
     <p:extLst>
       <p:ext uri="{BB962C8B-B14F-4D97-AF65-F5344CB8AC3E}">
-        <p14:creationId xmlns:p14="http://schemas.microsoft.com/office/powerpoint/2010/main" val="649421511"/>
+        <p14:creationId xmlns:p14="http://schemas.microsoft.com/office/powerpoint/2010/main" val="2709282295"/>
       </p:ext>
     </p:extLst>
   </p:cSld>
@@ -2159,7 +2159,7 @@
           <p:cNvPr id="2" name="제목 1">
             <a:extLst>
               <a:ext uri="{FF2B5EF4-FFF2-40B4-BE49-F238E27FC236}">
-                <a16:creationId xmlns:a16="http://schemas.microsoft.com/office/drawing/2014/main" id="{FC7A746C-C131-D33C-EB63-08212C75FC84}"/>
+                <a16:creationId xmlns:a16="http://schemas.microsoft.com/office/drawing/2014/main" id="{EE6297A1-35F5-DE8E-DD21-3D4CA9729511}"/>
               </a:ext>
             </a:extLst>
           </p:cNvPr>
@@ -2196,7 +2196,7 @@
           <p:cNvPr id="3" name="내용 개체 틀 2">
             <a:extLst>
               <a:ext uri="{FF2B5EF4-FFF2-40B4-BE49-F238E27FC236}">
-                <a16:creationId xmlns:a16="http://schemas.microsoft.com/office/drawing/2014/main" id="{8A637BF9-7C5F-B24E-4F12-A9668824B2CA}"/>
+                <a16:creationId xmlns:a16="http://schemas.microsoft.com/office/drawing/2014/main" id="{A5B10768-D974-5682-569D-306BE94FEA1A}"/>
               </a:ext>
             </a:extLst>
           </p:cNvPr>
@@ -2286,7 +2286,7 @@
           <p:cNvPr id="4" name="텍스트 개체 틀 3">
             <a:extLst>
               <a:ext uri="{FF2B5EF4-FFF2-40B4-BE49-F238E27FC236}">
-                <a16:creationId xmlns:a16="http://schemas.microsoft.com/office/drawing/2014/main" id="{97208866-B90C-7972-A13B-08541393BEAF}"/>
+                <a16:creationId xmlns:a16="http://schemas.microsoft.com/office/drawing/2014/main" id="{15A8D91C-5922-425A-90C7-FB9216F9C816}"/>
               </a:ext>
             </a:extLst>
           </p:cNvPr>
@@ -2357,7 +2357,7 @@
           <p:cNvPr id="5" name="날짜 개체 틀 4">
             <a:extLst>
               <a:ext uri="{FF2B5EF4-FFF2-40B4-BE49-F238E27FC236}">
-                <a16:creationId xmlns:a16="http://schemas.microsoft.com/office/drawing/2014/main" id="{BD7880E2-29CC-E30E-C124-A0BCF022CBBF}"/>
+                <a16:creationId xmlns:a16="http://schemas.microsoft.com/office/drawing/2014/main" id="{984769B0-3055-6673-F0C1-5F5D5D24AFAD}"/>
               </a:ext>
             </a:extLst>
           </p:cNvPr>
@@ -2373,7 +2373,7 @@
           <a:bodyPr/>
           <a:lstStyle/>
           <a:p>
-            <a:fld id="{B103BB0C-C4A9-4DBD-94E1-487EC0344102}" type="datetimeFigureOut">
+            <a:fld id="{A63FB5EC-CF88-4035-A752-ACC250E0626A}" type="datetimeFigureOut">
               <a:rPr lang="ko-KR" altLang="en-US" smtClean="0"/>
               <a:t>2026-06-20</a:t>
             </a:fld>
@@ -2386,7 +2386,7 @@
           <p:cNvPr id="6" name="바닥글 개체 틀 5">
             <a:extLst>
               <a:ext uri="{FF2B5EF4-FFF2-40B4-BE49-F238E27FC236}">
-                <a16:creationId xmlns:a16="http://schemas.microsoft.com/office/drawing/2014/main" id="{FB14CF99-382D-7B4D-4A23-04F9B600DB30}"/>
+                <a16:creationId xmlns:a16="http://schemas.microsoft.com/office/drawing/2014/main" id="{F8BDC113-C5B6-00DA-6988-C89D5CD19FB7}"/>
               </a:ext>
             </a:extLst>
           </p:cNvPr>
@@ -2411,7 +2411,7 @@
           <p:cNvPr id="7" name="슬라이드 번호 개체 틀 6">
             <a:extLst>
               <a:ext uri="{FF2B5EF4-FFF2-40B4-BE49-F238E27FC236}">
-                <a16:creationId xmlns:a16="http://schemas.microsoft.com/office/drawing/2014/main" id="{E824D76A-DDF4-4D52-FCAD-78A07C8755D8}"/>
+                <a16:creationId xmlns:a16="http://schemas.microsoft.com/office/drawing/2014/main" id="{1F1C4F4A-1FF0-77DA-8B03-AEBE1CF54B1D}"/>
               </a:ext>
             </a:extLst>
           </p:cNvPr>
@@ -2427,7 +2427,7 @@
           <a:bodyPr/>
           <a:lstStyle/>
           <a:p>
-            <a:fld id="{CBA3825E-68D6-403F-A3BD-24E345D7196E}" type="slidenum">
+            <a:fld id="{FE9BD0AC-AD16-4498-B7AD-B58A3BA041BF}" type="slidenum">
               <a:rPr lang="ko-KR" altLang="en-US" smtClean="0"/>
               <a:t>‹#›</a:t>
             </a:fld>
@@ -2438,7 +2438,7 @@
     </p:spTree>
     <p:extLst>
       <p:ext uri="{BB962C8B-B14F-4D97-AF65-F5344CB8AC3E}">
-        <p14:creationId xmlns:p14="http://schemas.microsoft.com/office/powerpoint/2010/main" val="3869323568"/>
+        <p14:creationId xmlns:p14="http://schemas.microsoft.com/office/powerpoint/2010/main" val="1809156513"/>
       </p:ext>
     </p:extLst>
   </p:cSld>
@@ -2470,7 +2470,7 @@
           <p:cNvPr id="2" name="제목 1">
             <a:extLst>
               <a:ext uri="{FF2B5EF4-FFF2-40B4-BE49-F238E27FC236}">
-                <a16:creationId xmlns:a16="http://schemas.microsoft.com/office/drawing/2014/main" id="{A3BCBEE4-A75B-5DE2-99B5-22EB45BE0778}"/>
+                <a16:creationId xmlns:a16="http://schemas.microsoft.com/office/drawing/2014/main" id="{EDEB0B9B-22C0-5642-5F96-CF8BB941605B}"/>
               </a:ext>
             </a:extLst>
           </p:cNvPr>
@@ -2507,7 +2507,7 @@
           <p:cNvPr id="3" name="그림 개체 틀 2">
             <a:extLst>
               <a:ext uri="{FF2B5EF4-FFF2-40B4-BE49-F238E27FC236}">
-                <a16:creationId xmlns:a16="http://schemas.microsoft.com/office/drawing/2014/main" id="{E75124F0-D286-DFC1-E312-6F71E33CBCAC}"/>
+                <a16:creationId xmlns:a16="http://schemas.microsoft.com/office/drawing/2014/main" id="{1CF96DA0-CE99-BA11-CED8-3C65AE79900F}"/>
               </a:ext>
             </a:extLst>
           </p:cNvPr>
@@ -2574,7 +2574,7 @@
           <p:cNvPr id="4" name="텍스트 개체 틀 3">
             <a:extLst>
               <a:ext uri="{FF2B5EF4-FFF2-40B4-BE49-F238E27FC236}">
-                <a16:creationId xmlns:a16="http://schemas.microsoft.com/office/drawing/2014/main" id="{4F5BBCA8-E817-8CE4-C161-0E6B2EA236AA}"/>
+                <a16:creationId xmlns:a16="http://schemas.microsoft.com/office/drawing/2014/main" id="{5F821E12-CDB5-45C1-E45B-CBA6092C5219}"/>
               </a:ext>
             </a:extLst>
           </p:cNvPr>
@@ -2645,7 +2645,7 @@
           <p:cNvPr id="5" name="날짜 개체 틀 4">
             <a:extLst>
               <a:ext uri="{FF2B5EF4-FFF2-40B4-BE49-F238E27FC236}">
-                <a16:creationId xmlns:a16="http://schemas.microsoft.com/office/drawing/2014/main" id="{298B4E0A-3692-AC92-E84F-1787F5819D97}"/>
+                <a16:creationId xmlns:a16="http://schemas.microsoft.com/office/drawing/2014/main" id="{F511C10F-D807-7335-170B-85FF52F24674}"/>
               </a:ext>
             </a:extLst>
           </p:cNvPr>
@@ -2661,7 +2661,7 @@
           <a:bodyPr/>
           <a:lstStyle/>
           <a:p>
-            <a:fld id="{B103BB0C-C4A9-4DBD-94E1-487EC0344102}" type="datetimeFigureOut">
+            <a:fld id="{A63FB5EC-CF88-4035-A752-ACC250E0626A}" type="datetimeFigureOut">
               <a:rPr lang="ko-KR" altLang="en-US" smtClean="0"/>
               <a:t>2026-06-20</a:t>
             </a:fld>
@@ -2674,7 +2674,7 @@
           <p:cNvPr id="6" name="바닥글 개체 틀 5">
             <a:extLst>
               <a:ext uri="{FF2B5EF4-FFF2-40B4-BE49-F238E27FC236}">
-                <a16:creationId xmlns:a16="http://schemas.microsoft.com/office/drawing/2014/main" id="{E39735F8-8D22-35E4-9F0D-0F77FAD8E24E}"/>
+                <a16:creationId xmlns:a16="http://schemas.microsoft.com/office/drawing/2014/main" id="{C338F221-3BF3-BCDC-3DC5-7E082E84C715}"/>
               </a:ext>
             </a:extLst>
           </p:cNvPr>
@@ -2699,7 +2699,7 @@
           <p:cNvPr id="7" name="슬라이드 번호 개체 틀 6">
             <a:extLst>
               <a:ext uri="{FF2B5EF4-FFF2-40B4-BE49-F238E27FC236}">
-                <a16:creationId xmlns:a16="http://schemas.microsoft.com/office/drawing/2014/main" id="{B4E76A9E-5275-8475-CE63-B903256D5369}"/>
+                <a16:creationId xmlns:a16="http://schemas.microsoft.com/office/drawing/2014/main" id="{63D78494-F116-A918-26DA-7F102F1AE673}"/>
               </a:ext>
             </a:extLst>
           </p:cNvPr>
@@ -2715,7 +2715,7 @@
           <a:bodyPr/>
           <a:lstStyle/>
           <a:p>
-            <a:fld id="{CBA3825E-68D6-403F-A3BD-24E345D7196E}" type="slidenum">
+            <a:fld id="{FE9BD0AC-AD16-4498-B7AD-B58A3BA041BF}" type="slidenum">
               <a:rPr lang="ko-KR" altLang="en-US" smtClean="0"/>
               <a:t>‹#›</a:t>
             </a:fld>
@@ -2726,7 +2726,7 @@
     </p:spTree>
     <p:extLst>
       <p:ext uri="{BB962C8B-B14F-4D97-AF65-F5344CB8AC3E}">
-        <p14:creationId xmlns:p14="http://schemas.microsoft.com/office/powerpoint/2010/main" val="1743403862"/>
+        <p14:creationId xmlns:p14="http://schemas.microsoft.com/office/powerpoint/2010/main" val="3190563830"/>
       </p:ext>
     </p:extLst>
   </p:cSld>
@@ -2763,7 +2763,7 @@
           <p:cNvPr id="2" name="제목 개체 틀 1">
             <a:extLst>
               <a:ext uri="{FF2B5EF4-FFF2-40B4-BE49-F238E27FC236}">
-                <a16:creationId xmlns:a16="http://schemas.microsoft.com/office/drawing/2014/main" id="{AA8C46B3-DC0B-D020-AEA6-3E940129CD30}"/>
+                <a16:creationId xmlns:a16="http://schemas.microsoft.com/office/drawing/2014/main" id="{01183E73-7F38-2E97-3029-B4E0EC818C8C}"/>
               </a:ext>
             </a:extLst>
           </p:cNvPr>
@@ -2801,7 +2801,7 @@
           <p:cNvPr id="3" name="텍스트 개체 틀 2">
             <a:extLst>
               <a:ext uri="{FF2B5EF4-FFF2-40B4-BE49-F238E27FC236}">
-                <a16:creationId xmlns:a16="http://schemas.microsoft.com/office/drawing/2014/main" id="{09980230-05E0-638B-4F42-C59556226FC4}"/>
+                <a16:creationId xmlns:a16="http://schemas.microsoft.com/office/drawing/2014/main" id="{79D892E7-9763-76F4-90A6-02E6E2ABF407}"/>
               </a:ext>
             </a:extLst>
           </p:cNvPr>
@@ -2868,7 +2868,7 @@
           <p:cNvPr id="4" name="날짜 개체 틀 3">
             <a:extLst>
               <a:ext uri="{FF2B5EF4-FFF2-40B4-BE49-F238E27FC236}">
-                <a16:creationId xmlns:a16="http://schemas.microsoft.com/office/drawing/2014/main" id="{760D5608-81B8-C510-1DA3-02559A2480EE}"/>
+                <a16:creationId xmlns:a16="http://schemas.microsoft.com/office/drawing/2014/main" id="{617ED005-CED8-B543-EDDD-FDC148565AE5}"/>
               </a:ext>
             </a:extLst>
           </p:cNvPr>
@@ -2902,7 +2902,7 @@
             </a:lvl1pPr>
           </a:lstStyle>
           <a:p>
-            <a:fld id="{B103BB0C-C4A9-4DBD-94E1-487EC0344102}" type="datetimeFigureOut">
+            <a:fld id="{A63FB5EC-CF88-4035-A752-ACC250E0626A}" type="datetimeFigureOut">
               <a:rPr lang="ko-KR" altLang="en-US" smtClean="0"/>
               <a:t>2026-06-20</a:t>
             </a:fld>
@@ -2915,7 +2915,7 @@
           <p:cNvPr id="5" name="바닥글 개체 틀 4">
             <a:extLst>
               <a:ext uri="{FF2B5EF4-FFF2-40B4-BE49-F238E27FC236}">
-                <a16:creationId xmlns:a16="http://schemas.microsoft.com/office/drawing/2014/main" id="{98AAA252-434A-6D4E-2959-4207D8ED5092}"/>
+                <a16:creationId xmlns:a16="http://schemas.microsoft.com/office/drawing/2014/main" id="{F72BDFCF-B4AF-DA01-109C-D8C7AD182495}"/>
               </a:ext>
             </a:extLst>
           </p:cNvPr>
@@ -2958,7 +2958,7 @@
           <p:cNvPr id="6" name="슬라이드 번호 개체 틀 5">
             <a:extLst>
               <a:ext uri="{FF2B5EF4-FFF2-40B4-BE49-F238E27FC236}">
-                <a16:creationId xmlns:a16="http://schemas.microsoft.com/office/drawing/2014/main" id="{507A9F14-26D9-C68D-E4E2-5AD29C4A21A1}"/>
+                <a16:creationId xmlns:a16="http://schemas.microsoft.com/office/drawing/2014/main" id="{AF63665B-B821-F6D3-DA43-1C52F3C8A113}"/>
               </a:ext>
             </a:extLst>
           </p:cNvPr>
@@ -2992,7 +2992,7 @@
             </a:lvl1pPr>
           </a:lstStyle>
           <a:p>
-            <a:fld id="{CBA3825E-68D6-403F-A3BD-24E345D7196E}" type="slidenum">
+            <a:fld id="{FE9BD0AC-AD16-4498-B7AD-B58A3BA041BF}" type="slidenum">
               <a:rPr lang="ko-KR" altLang="en-US" smtClean="0"/>
               <a:t>‹#›</a:t>
             </a:fld>
@@ -3003,7 +3003,7 @@
     </p:spTree>
     <p:extLst>
       <p:ext uri="{BB962C8B-B14F-4D97-AF65-F5344CB8AC3E}">
-        <p14:creationId xmlns:p14="http://schemas.microsoft.com/office/powerpoint/2010/main" val="664521501"/>
+        <p14:creationId xmlns:p14="http://schemas.microsoft.com/office/powerpoint/2010/main" val="3277023161"/>
       </p:ext>
     </p:extLst>
   </p:cSld>
@@ -3326,7 +3326,7 @@
           <p:cNvPr id="2" name="z00_grid_top">
             <a:extLst>
               <a:ext uri="{FF2B5EF4-FFF2-40B4-BE49-F238E27FC236}">
-                <a16:creationId xmlns:a16="http://schemas.microsoft.com/office/drawing/2014/main" id="{8E41F5A5-216F-6777-04FB-3406CC289ABC}"/>
+                <a16:creationId xmlns:a16="http://schemas.microsoft.com/office/drawing/2014/main" id="{7722F11C-4892-0F23-BB55-52003F5EFE7F}"/>
               </a:ext>
             </a:extLst>
           </p:cNvPr>
@@ -3369,7 +3369,7 @@
           <p:cNvPr id="3" name="z00_grid_bottom">
             <a:extLst>
               <a:ext uri="{FF2B5EF4-FFF2-40B4-BE49-F238E27FC236}">
-                <a16:creationId xmlns:a16="http://schemas.microsoft.com/office/drawing/2014/main" id="{8E550511-86AA-C7C6-B258-CE50FCBCCC81}"/>
+                <a16:creationId xmlns:a16="http://schemas.microsoft.com/office/drawing/2014/main" id="{81507C64-5907-30A5-ACF7-ACAB4B9EA9F3}"/>
               </a:ext>
             </a:extLst>
           </p:cNvPr>
@@ -3412,7 +3412,7 @@
           <p:cNvPr id="4" name="z00_grid_v_0">
             <a:extLst>
               <a:ext uri="{FF2B5EF4-FFF2-40B4-BE49-F238E27FC236}">
-                <a16:creationId xmlns:a16="http://schemas.microsoft.com/office/drawing/2014/main" id="{7AD820B3-1D55-0AF6-2650-C4D09A1AA830}"/>
+                <a16:creationId xmlns:a16="http://schemas.microsoft.com/office/drawing/2014/main" id="{C903421C-E5B4-C411-DB6E-FECDB5FFE612}"/>
               </a:ext>
             </a:extLst>
           </p:cNvPr>
@@ -3455,7 +3455,7 @@
           <p:cNvPr id="5" name="z00_grid_v_1">
             <a:extLst>
               <a:ext uri="{FF2B5EF4-FFF2-40B4-BE49-F238E27FC236}">
-                <a16:creationId xmlns:a16="http://schemas.microsoft.com/office/drawing/2014/main" id="{77261A17-D0EB-9B75-6DFF-6FA2D3C5D5F2}"/>
+                <a16:creationId xmlns:a16="http://schemas.microsoft.com/office/drawing/2014/main" id="{EDAC0E4F-45B2-E0D7-BAD2-11DCFD443B14}"/>
               </a:ext>
             </a:extLst>
           </p:cNvPr>
@@ -3498,7 +3498,7 @@
           <p:cNvPr id="6" name="z00_grid_v_2">
             <a:extLst>
               <a:ext uri="{FF2B5EF4-FFF2-40B4-BE49-F238E27FC236}">
-                <a16:creationId xmlns:a16="http://schemas.microsoft.com/office/drawing/2014/main" id="{9E12C6B0-AF03-E1CF-8AE1-B24EC38CFDE6}"/>
+                <a16:creationId xmlns:a16="http://schemas.microsoft.com/office/drawing/2014/main" id="{98FB07C9-1198-B655-437B-D1D736A738D7}"/>
               </a:ext>
             </a:extLst>
           </p:cNvPr>
@@ -3541,7 +3541,7 @@
           <p:cNvPr id="7" name="header_title">
             <a:extLst>
               <a:ext uri="{FF2B5EF4-FFF2-40B4-BE49-F238E27FC236}">
-                <a16:creationId xmlns:a16="http://schemas.microsoft.com/office/drawing/2014/main" id="{975E17A7-AA73-4100-8B82-AE89C4275F1A}"/>
+                <a16:creationId xmlns:a16="http://schemas.microsoft.com/office/drawing/2014/main" id="{8C6F9F3A-138F-8068-17E3-D6B3E55ABB84}"/>
               </a:ext>
             </a:extLst>
           </p:cNvPr>
@@ -3587,7 +3587,7 @@
           <p:cNvPr id="8" name="header_subtitle">
             <a:extLst>
               <a:ext uri="{FF2B5EF4-FFF2-40B4-BE49-F238E27FC236}">
-                <a16:creationId xmlns:a16="http://schemas.microsoft.com/office/drawing/2014/main" id="{E6A594DF-B86A-EA9A-621E-970342E8E5EF}"/>
+                <a16:creationId xmlns:a16="http://schemas.microsoft.com/office/drawing/2014/main" id="{1278923A-9C24-6C68-DB5B-652B7CCD90E9}"/>
               </a:ext>
             </a:extLst>
           </p:cNvPr>
@@ -3633,7 +3633,7 @@
           <p:cNvPr id="9" name="zone_content_panel">
             <a:extLst>
               <a:ext uri="{FF2B5EF4-FFF2-40B4-BE49-F238E27FC236}">
-                <a16:creationId xmlns:a16="http://schemas.microsoft.com/office/drawing/2014/main" id="{C17B2C7A-DA64-1F9F-C1CE-351253AFABE7}"/>
+                <a16:creationId xmlns:a16="http://schemas.microsoft.com/office/drawing/2014/main" id="{E238D4A7-6AE3-52FE-432A-9485760A29BD}"/>
               </a:ext>
             </a:extLst>
           </p:cNvPr>
@@ -3694,7 +3694,7 @@
           <p:cNvPr id="10" name="zone_content_title">
             <a:extLst>
               <a:ext uri="{FF2B5EF4-FFF2-40B4-BE49-F238E27FC236}">
-                <a16:creationId xmlns:a16="http://schemas.microsoft.com/office/drawing/2014/main" id="{50CF204C-12CC-3A64-0BF1-16CE930E1FBA}"/>
+                <a16:creationId xmlns:a16="http://schemas.microsoft.com/office/drawing/2014/main" id="{0C51956F-EAF5-6383-A9DC-4458C1905A75}"/>
               </a:ext>
             </a:extLst>
           </p:cNvPr>
@@ -3740,7 +3740,7 @@
           <p:cNvPr id="11" name="zone_content_subtitle">
             <a:extLst>
               <a:ext uri="{FF2B5EF4-FFF2-40B4-BE49-F238E27FC236}">
-                <a16:creationId xmlns:a16="http://schemas.microsoft.com/office/drawing/2014/main" id="{920A5A43-A47F-7377-220B-2E73D5C5A077}"/>
+                <a16:creationId xmlns:a16="http://schemas.microsoft.com/office/drawing/2014/main" id="{9CAA5B4D-2EE0-0C96-AA29-DC08C026A178}"/>
               </a:ext>
             </a:extLst>
           </p:cNvPr>
@@ -3786,7 +3786,7 @@
           <p:cNvPr id="12" name="zone_reasoning_panel">
             <a:extLst>
               <a:ext uri="{FF2B5EF4-FFF2-40B4-BE49-F238E27FC236}">
-                <a16:creationId xmlns:a16="http://schemas.microsoft.com/office/drawing/2014/main" id="{BF2E2A58-4BB1-2E5C-D67F-297821ADF458}"/>
+                <a16:creationId xmlns:a16="http://schemas.microsoft.com/office/drawing/2014/main" id="{F4A2EE2F-FBF2-CD9B-33E6-16FCB47DE534}"/>
               </a:ext>
             </a:extLst>
           </p:cNvPr>
@@ -3796,7 +3796,7 @@
         <p:spPr>
           <a:xfrm>
             <a:off x="3439800" y="1308434"/>
-            <a:ext cx="2438339" cy="3750845"/>
+            <a:ext cx="2351255" cy="3750845"/>
           </a:xfrm>
           <a:prstGeom prst="roundRect">
             <a:avLst/>
@@ -3847,7 +3847,7 @@
           <p:cNvPr id="13" name="zone_reasoning_title">
             <a:extLst>
               <a:ext uri="{FF2B5EF4-FFF2-40B4-BE49-F238E27FC236}">
-                <a16:creationId xmlns:a16="http://schemas.microsoft.com/office/drawing/2014/main" id="{59732B1D-A79E-F6BB-CEE5-ED0759693403}"/>
+                <a16:creationId xmlns:a16="http://schemas.microsoft.com/office/drawing/2014/main" id="{485CAA72-4ADD-A2F3-D5F1-0FD150F3AB76}"/>
               </a:ext>
             </a:extLst>
           </p:cNvPr>
@@ -3857,7 +3857,7 @@
         <p:spPr>
           <a:xfrm>
             <a:off x="3631383" y="1526507"/>
-            <a:ext cx="2055171" cy="285806"/>
+            <a:ext cx="1968088" cy="285806"/>
           </a:xfrm>
           <a:prstGeom prst="rect">
             <a:avLst/>
@@ -3893,7 +3893,7 @@
           <p:cNvPr id="14" name="zone_reasoning_subtitle">
             <a:extLst>
               <a:ext uri="{FF2B5EF4-FFF2-40B4-BE49-F238E27FC236}">
-                <a16:creationId xmlns:a16="http://schemas.microsoft.com/office/drawing/2014/main" id="{49848A74-CB6D-3748-B702-421DE2D10944}"/>
+                <a16:creationId xmlns:a16="http://schemas.microsoft.com/office/drawing/2014/main" id="{6CCEC35B-B323-7F5D-D4CE-0791B3E61F65}"/>
               </a:ext>
             </a:extLst>
           </p:cNvPr>
@@ -3903,7 +3903,7 @@
         <p:spPr>
           <a:xfrm>
             <a:off x="3631383" y="1831808"/>
-            <a:ext cx="2055171" cy="285806"/>
+            <a:ext cx="1968088" cy="285806"/>
           </a:xfrm>
           <a:prstGeom prst="rect">
             <a:avLst/>
@@ -3939,7 +3939,7 @@
           <p:cNvPr id="15" name="zone_rules_panel">
             <a:extLst>
               <a:ext uri="{FF2B5EF4-FFF2-40B4-BE49-F238E27FC236}">
-                <a16:creationId xmlns:a16="http://schemas.microsoft.com/office/drawing/2014/main" id="{4F776D08-EF99-1ABE-92B9-951ABEA1E025}"/>
+                <a16:creationId xmlns:a16="http://schemas.microsoft.com/office/drawing/2014/main" id="{F4E78355-AE73-436A-A680-A07337B4DEA4}"/>
               </a:ext>
             </a:extLst>
           </p:cNvPr>
@@ -3948,8 +3948,8 @@
         </p:nvSpPr>
         <p:spPr>
           <a:xfrm>
-            <a:off x="6095848" y="1308434"/>
-            <a:ext cx="3439799" cy="3750845"/>
+            <a:off x="5886847" y="1308434"/>
+            <a:ext cx="3901343" cy="3750845"/>
           </a:xfrm>
           <a:prstGeom prst="roundRect">
             <a:avLst/>
@@ -4000,7 +4000,7 @@
           <p:cNvPr id="16" name="zone_rules_title">
             <a:extLst>
               <a:ext uri="{FF2B5EF4-FFF2-40B4-BE49-F238E27FC236}">
-                <a16:creationId xmlns:a16="http://schemas.microsoft.com/office/drawing/2014/main" id="{DACA111E-E58F-F5E4-D131-69FABA0BB7DA}"/>
+                <a16:creationId xmlns:a16="http://schemas.microsoft.com/office/drawing/2014/main" id="{4E217526-C679-EE99-7AB0-1923C9482F3A}"/>
               </a:ext>
             </a:extLst>
           </p:cNvPr>
@@ -4009,8 +4009,8 @@
         </p:nvSpPr>
         <p:spPr>
           <a:xfrm>
-            <a:off x="6287431" y="1526507"/>
-            <a:ext cx="3056632" cy="285806"/>
+            <a:off x="6078431" y="1526507"/>
+            <a:ext cx="3518175" cy="285806"/>
           </a:xfrm>
           <a:prstGeom prst="rect">
             <a:avLst/>
@@ -4046,7 +4046,7 @@
           <p:cNvPr id="17" name="zone_rules_subtitle">
             <a:extLst>
               <a:ext uri="{FF2B5EF4-FFF2-40B4-BE49-F238E27FC236}">
-                <a16:creationId xmlns:a16="http://schemas.microsoft.com/office/drawing/2014/main" id="{D52D1F2B-CA8F-0CD7-60FE-A6714E482CB5}"/>
+                <a16:creationId xmlns:a16="http://schemas.microsoft.com/office/drawing/2014/main" id="{3ECE5EB2-7B56-F577-FD36-EE7769739378}"/>
               </a:ext>
             </a:extLst>
           </p:cNvPr>
@@ -4055,8 +4055,8 @@
         </p:nvSpPr>
         <p:spPr>
           <a:xfrm>
-            <a:off x="6287431" y="1831808"/>
-            <a:ext cx="3056632" cy="285806"/>
+            <a:off x="6078431" y="1831808"/>
+            <a:ext cx="3518175" cy="285806"/>
           </a:xfrm>
           <a:prstGeom prst="rect">
             <a:avLst/>
@@ -4092,7 +4092,7 @@
           <p:cNvPr id="18" name="zone_outputs_panel">
             <a:extLst>
               <a:ext uri="{FF2B5EF4-FFF2-40B4-BE49-F238E27FC236}">
-                <a16:creationId xmlns:a16="http://schemas.microsoft.com/office/drawing/2014/main" id="{00356D85-1DAB-5FB3-92B5-D899E6C07026}"/>
+                <a16:creationId xmlns:a16="http://schemas.microsoft.com/office/drawing/2014/main" id="{AB39D39D-A08F-7470-0CD5-689B9E11EC29}"/>
               </a:ext>
             </a:extLst>
           </p:cNvPr>
@@ -4101,8 +4101,8 @@
         </p:nvSpPr>
         <p:spPr>
           <a:xfrm>
-            <a:off x="9753356" y="1308434"/>
-            <a:ext cx="2177088" cy="3750845"/>
+            <a:off x="9927523" y="1308434"/>
+            <a:ext cx="2002922" cy="3750845"/>
           </a:xfrm>
           <a:prstGeom prst="roundRect">
             <a:avLst/>
@@ -4153,7 +4153,7 @@
           <p:cNvPr id="19" name="zone_outputs_title">
             <a:extLst>
               <a:ext uri="{FF2B5EF4-FFF2-40B4-BE49-F238E27FC236}">
-                <a16:creationId xmlns:a16="http://schemas.microsoft.com/office/drawing/2014/main" id="{538E7FC3-6910-621F-580A-DB44CF76F6F1}"/>
+                <a16:creationId xmlns:a16="http://schemas.microsoft.com/office/drawing/2014/main" id="{E7E9B0E1-D152-C312-6A7A-D8A697DB9C0D}"/>
               </a:ext>
             </a:extLst>
           </p:cNvPr>
@@ -4162,8 +4162,8 @@
         </p:nvSpPr>
         <p:spPr>
           <a:xfrm>
-            <a:off x="9944940" y="1526507"/>
-            <a:ext cx="1793921" cy="285806"/>
+            <a:off x="10119107" y="1526507"/>
+            <a:ext cx="1619754" cy="285806"/>
           </a:xfrm>
           <a:prstGeom prst="rect">
             <a:avLst/>
@@ -4199,7 +4199,7 @@
           <p:cNvPr id="20" name="zone_outputs_subtitle">
             <a:extLst>
               <a:ext uri="{FF2B5EF4-FFF2-40B4-BE49-F238E27FC236}">
-                <a16:creationId xmlns:a16="http://schemas.microsoft.com/office/drawing/2014/main" id="{031CD366-E1D5-5D44-417E-752FB58E8CF5}"/>
+                <a16:creationId xmlns:a16="http://schemas.microsoft.com/office/drawing/2014/main" id="{B89429F1-362C-1D44-A4B7-A7009245945F}"/>
               </a:ext>
             </a:extLst>
           </p:cNvPr>
@@ -4208,8 +4208,8 @@
         </p:nvSpPr>
         <p:spPr>
           <a:xfrm>
-            <a:off x="9944940" y="1831808"/>
-            <a:ext cx="1793921" cy="285806"/>
+            <a:off x="10119107" y="1831808"/>
+            <a:ext cx="1619754" cy="285806"/>
           </a:xfrm>
           <a:prstGeom prst="rect">
             <a:avLst/>
@@ -4245,7 +4245,7 @@
           <p:cNvPr id="21" name="main_start_markdown">
             <a:extLst>
               <a:ext uri="{FF2B5EF4-FFF2-40B4-BE49-F238E27FC236}">
-                <a16:creationId xmlns:a16="http://schemas.microsoft.com/office/drawing/2014/main" id="{AC151358-B371-69C1-C7F1-9D6165D719D1}"/>
+                <a16:creationId xmlns:a16="http://schemas.microsoft.com/office/drawing/2014/main" id="{26A49D9C-7DF6-A1C5-4411-3921DBA0F21B}"/>
               </a:ext>
             </a:extLst>
           </p:cNvPr>
@@ -4254,8 +4254,8 @@
         </p:nvCxnSpPr>
         <p:spPr>
           <a:xfrm>
-            <a:off x="2002921" y="2442411"/>
-            <a:ext cx="0" cy="226795"/>
+            <a:off x="2002921" y="2477302"/>
+            <a:ext cx="0" cy="209350"/>
           </a:xfrm>
           <a:prstGeom prst="line">
             <a:avLst/>
@@ -4288,7 +4288,7 @@
           <p:cNvPr id="22" name="main_markdown_splitter">
             <a:extLst>
               <a:ext uri="{FF2B5EF4-FFF2-40B4-BE49-F238E27FC236}">
-                <a16:creationId xmlns:a16="http://schemas.microsoft.com/office/drawing/2014/main" id="{9442DF3F-D031-FB37-8179-66083F859D5C}"/>
+                <a16:creationId xmlns:a16="http://schemas.microsoft.com/office/drawing/2014/main" id="{DA4482F0-294C-3E66-E138-D54E5C162A29}"/>
               </a:ext>
             </a:extLst>
           </p:cNvPr>
@@ -4297,8 +4297,8 @@
         </p:nvCxnSpPr>
         <p:spPr>
           <a:xfrm>
-            <a:off x="2002921" y="3585110"/>
-            <a:ext cx="0" cy="322747"/>
+            <a:off x="2002921" y="3628724"/>
+            <a:ext cx="0" cy="279133"/>
           </a:xfrm>
           <a:prstGeom prst="line">
             <a:avLst/>
@@ -4331,7 +4331,7 @@
           <p:cNvPr id="23" name="main_splitter_ir_seg_1">
             <a:extLst>
               <a:ext uri="{FF2B5EF4-FFF2-40B4-BE49-F238E27FC236}">
-                <a16:creationId xmlns:a16="http://schemas.microsoft.com/office/drawing/2014/main" id="{74035F2C-A7D1-3D5D-902A-A49048C1A80D}"/>
+                <a16:creationId xmlns:a16="http://schemas.microsoft.com/office/drawing/2014/main" id="{E68131D9-6CAA-0B9D-3573-0BDE93ED67F4}"/>
               </a:ext>
             </a:extLst>
           </p:cNvPr>
@@ -4340,8 +4340,8 @@
         </p:nvCxnSpPr>
         <p:spPr>
           <a:xfrm>
-            <a:off x="3004382" y="4396339"/>
-            <a:ext cx="330918" cy="0"/>
+            <a:off x="2995674" y="4396339"/>
+            <a:ext cx="330917" cy="0"/>
           </a:xfrm>
           <a:prstGeom prst="line">
             <a:avLst/>
@@ -4374,7 +4374,7 @@
           <p:cNvPr id="24" name="main_splitter_ir_seg_2">
             <a:extLst>
               <a:ext uri="{FF2B5EF4-FFF2-40B4-BE49-F238E27FC236}">
-                <a16:creationId xmlns:a16="http://schemas.microsoft.com/office/drawing/2014/main" id="{B50B2413-8572-AD2A-DB9E-4F800DACF51F}"/>
+                <a16:creationId xmlns:a16="http://schemas.microsoft.com/office/drawing/2014/main" id="{972B8B13-DA58-DB33-B135-80B0FD37341C}"/>
               </a:ext>
             </a:extLst>
           </p:cNvPr>
@@ -4383,8 +4383,8 @@
         </p:nvCxnSpPr>
         <p:spPr>
           <a:xfrm flipV="1">
-            <a:off x="3335300" y="2494748"/>
-            <a:ext cx="0" cy="1901591"/>
+            <a:off x="3326591" y="2534001"/>
+            <a:ext cx="0" cy="1862338"/>
           </a:xfrm>
           <a:prstGeom prst="line">
             <a:avLst/>
@@ -4417,7 +4417,7 @@
           <p:cNvPr id="25" name="main_splitter_ir_seg_3">
             <a:extLst>
               <a:ext uri="{FF2B5EF4-FFF2-40B4-BE49-F238E27FC236}">
-                <a16:creationId xmlns:a16="http://schemas.microsoft.com/office/drawing/2014/main" id="{1AE3C45A-360D-90F1-EC95-70815B1B655C}"/>
+                <a16:creationId xmlns:a16="http://schemas.microsoft.com/office/drawing/2014/main" id="{DE7E84EF-133B-A5F0-6306-CE81D0CCC327}"/>
               </a:ext>
             </a:extLst>
           </p:cNvPr>
@@ -4426,8 +4426,8 @@
         </p:nvCxnSpPr>
         <p:spPr>
           <a:xfrm>
-            <a:off x="3335300" y="2494748"/>
-            <a:ext cx="365750" cy="0"/>
+            <a:off x="3326591" y="2534001"/>
+            <a:ext cx="330918" cy="0"/>
           </a:xfrm>
           <a:prstGeom prst="line">
             <a:avLst/>
@@ -4460,7 +4460,7 @@
           <p:cNvPr id="26" name="hint_ir_reasoning">
             <a:extLst>
               <a:ext uri="{FF2B5EF4-FFF2-40B4-BE49-F238E27FC236}">
-                <a16:creationId xmlns:a16="http://schemas.microsoft.com/office/drawing/2014/main" id="{25ED6D03-8E39-2C33-12C8-92380A380B7A}"/>
+                <a16:creationId xmlns:a16="http://schemas.microsoft.com/office/drawing/2014/main" id="{FDD78AAB-68FE-04D7-C1C5-7F62B6AB5BF4}"/>
               </a:ext>
             </a:extLst>
           </p:cNvPr>
@@ -4469,8 +4469,8 @@
         </p:nvCxnSpPr>
         <p:spPr>
           <a:xfrm>
-            <a:off x="4658969" y="2983230"/>
-            <a:ext cx="0" cy="418699"/>
+            <a:off x="4615428" y="2991953"/>
+            <a:ext cx="0" cy="497205"/>
           </a:xfrm>
           <a:prstGeom prst="line">
             <a:avLst/>
@@ -4504,7 +4504,7 @@
           <p:cNvPr id="27" name="main_ir_rules">
             <a:extLst>
               <a:ext uri="{FF2B5EF4-FFF2-40B4-BE49-F238E27FC236}">
-                <a16:creationId xmlns:a16="http://schemas.microsoft.com/office/drawing/2014/main" id="{AC719C91-C608-D5EE-2D4D-EDA2C57FF545}"/>
+                <a16:creationId xmlns:a16="http://schemas.microsoft.com/office/drawing/2014/main" id="{6C30D4B0-D0CC-BA83-BF1F-E9A47CABA730}"/>
               </a:ext>
             </a:extLst>
           </p:cNvPr>
@@ -4513,8 +4513,8 @@
         </p:nvCxnSpPr>
         <p:spPr>
           <a:xfrm>
-            <a:off x="5616888" y="2494748"/>
-            <a:ext cx="740210" cy="0"/>
+            <a:off x="5573346" y="2534001"/>
+            <a:ext cx="653127" cy="0"/>
           </a:xfrm>
           <a:prstGeom prst="line">
             <a:avLst/>
@@ -4547,7 +4547,7 @@
           <p:cNvPr id="28" name="hint_reasoning_rules_seg_1">
             <a:extLst>
               <a:ext uri="{FF2B5EF4-FFF2-40B4-BE49-F238E27FC236}">
-                <a16:creationId xmlns:a16="http://schemas.microsoft.com/office/drawing/2014/main" id="{A32CB938-E426-E812-B131-6864ECDE7219}"/>
+                <a16:creationId xmlns:a16="http://schemas.microsoft.com/office/drawing/2014/main" id="{68CF229D-BEC2-E5DE-4F1B-30EE9D721292}"/>
               </a:ext>
             </a:extLst>
           </p:cNvPr>
@@ -4556,7 +4556,7 @@
         </p:nvCxnSpPr>
         <p:spPr>
           <a:xfrm>
-            <a:off x="5616888" y="4143375"/>
+            <a:off x="5573346" y="4186989"/>
             <a:ext cx="330918" cy="0"/>
           </a:xfrm>
           <a:prstGeom prst="line">
@@ -4591,7 +4591,7 @@
           <p:cNvPr id="29" name="hint_reasoning_rules_seg_2">
             <a:extLst>
               <a:ext uri="{FF2B5EF4-FFF2-40B4-BE49-F238E27FC236}">
-                <a16:creationId xmlns:a16="http://schemas.microsoft.com/office/drawing/2014/main" id="{3CD70FBF-9FA7-F3E6-D05F-A9119436A386}"/>
+                <a16:creationId xmlns:a16="http://schemas.microsoft.com/office/drawing/2014/main" id="{20B3587C-4EE5-4597-1D4F-B61AB1D8A48E}"/>
               </a:ext>
             </a:extLst>
           </p:cNvPr>
@@ -4600,8 +4600,8 @@
         </p:nvCxnSpPr>
         <p:spPr>
           <a:xfrm flipV="1">
-            <a:off x="5947806" y="3340869"/>
-            <a:ext cx="0" cy="802506"/>
+            <a:off x="5904264" y="3453394"/>
+            <a:ext cx="0" cy="733595"/>
           </a:xfrm>
           <a:prstGeom prst="line">
             <a:avLst/>
@@ -4635,7 +4635,7 @@
           <p:cNvPr id="30" name="hint_reasoning_rules_seg_3">
             <a:extLst>
               <a:ext uri="{FF2B5EF4-FFF2-40B4-BE49-F238E27FC236}">
-                <a16:creationId xmlns:a16="http://schemas.microsoft.com/office/drawing/2014/main" id="{B2544806-2E59-6A3A-7104-CC968432BDDA}"/>
+                <a16:creationId xmlns:a16="http://schemas.microsoft.com/office/drawing/2014/main" id="{5E57C18A-0853-3D98-759A-41C482D99C1E}"/>
               </a:ext>
             </a:extLst>
           </p:cNvPr>
@@ -4644,8 +4644,8 @@
         </p:nvCxnSpPr>
         <p:spPr>
           <a:xfrm>
-            <a:off x="5947806" y="3340869"/>
-            <a:ext cx="261250" cy="0"/>
+            <a:off x="5904264" y="3453394"/>
+            <a:ext cx="156750" cy="0"/>
           </a:xfrm>
           <a:prstGeom prst="line">
             <a:avLst/>
@@ -4679,7 +4679,7 @@
           <p:cNvPr id="31" name="rule_features_recipes">
             <a:extLst>
               <a:ext uri="{FF2B5EF4-FFF2-40B4-BE49-F238E27FC236}">
-                <a16:creationId xmlns:a16="http://schemas.microsoft.com/office/drawing/2014/main" id="{14400E9C-72E0-999E-9C79-028C832BC968}"/>
+                <a16:creationId xmlns:a16="http://schemas.microsoft.com/office/drawing/2014/main" id="{E1FB2039-2F79-4B7C-F723-7CC156EE6441}"/>
               </a:ext>
             </a:extLst>
           </p:cNvPr>
@@ -4688,8 +4688,8 @@
         </p:nvCxnSpPr>
         <p:spPr>
           <a:xfrm>
-            <a:off x="7219225" y="3384483"/>
-            <a:ext cx="113209" cy="0"/>
+            <a:off x="7140850" y="3497881"/>
+            <a:ext cx="156750" cy="0"/>
           </a:xfrm>
           <a:prstGeom prst="line">
             <a:avLst/>
@@ -4722,7 +4722,7 @@
           <p:cNvPr id="32" name="rule_recipes_theme">
             <a:extLst>
               <a:ext uri="{FF2B5EF4-FFF2-40B4-BE49-F238E27FC236}">
-                <a16:creationId xmlns:a16="http://schemas.microsoft.com/office/drawing/2014/main" id="{DFE5083D-8DBB-750C-A14A-374CEF834A24}"/>
+                <a16:creationId xmlns:a16="http://schemas.microsoft.com/office/drawing/2014/main" id="{152B82B3-43CA-48FF-CD4C-40D34EC88D2B}"/>
               </a:ext>
             </a:extLst>
           </p:cNvPr>
@@ -4731,8 +4731,8 @@
         </p:nvCxnSpPr>
         <p:spPr>
           <a:xfrm>
-            <a:off x="8342603" y="3384483"/>
-            <a:ext cx="113209" cy="0"/>
+            <a:off x="8377436" y="3497881"/>
+            <a:ext cx="156751" cy="0"/>
           </a:xfrm>
           <a:prstGeom prst="line">
             <a:avLst/>
@@ -4765,7 +4765,7 @@
           <p:cNvPr id="33" name="rule_features_compose">
             <a:extLst>
               <a:ext uri="{FF2B5EF4-FFF2-40B4-BE49-F238E27FC236}">
-                <a16:creationId xmlns:a16="http://schemas.microsoft.com/office/drawing/2014/main" id="{5D7912DC-139B-2B39-030B-B6C6C1BB5505}"/>
+                <a16:creationId xmlns:a16="http://schemas.microsoft.com/office/drawing/2014/main" id="{FB07F8C2-3ECB-153C-5C95-509750899E23}"/>
               </a:ext>
             </a:extLst>
           </p:cNvPr>
@@ -4774,8 +4774,8 @@
         </p:nvCxnSpPr>
         <p:spPr>
           <a:xfrm>
-            <a:off x="6714141" y="3820628"/>
-            <a:ext cx="0" cy="226795"/>
+            <a:off x="6600932" y="3942748"/>
+            <a:ext cx="0" cy="104675"/>
           </a:xfrm>
           <a:prstGeom prst="line">
             <a:avLst/>
@@ -4808,7 +4808,7 @@
           <p:cNvPr id="34" name="rule_recipes_objects">
             <a:extLst>
               <a:ext uri="{FF2B5EF4-FFF2-40B4-BE49-F238E27FC236}">
-                <a16:creationId xmlns:a16="http://schemas.microsoft.com/office/drawing/2014/main" id="{6C3E1BC0-0384-D06B-F7C4-B0B29591AD66}"/>
+                <a16:creationId xmlns:a16="http://schemas.microsoft.com/office/drawing/2014/main" id="{9CEFB7CA-A0D6-0425-ADC9-A680C5F375D9}"/>
               </a:ext>
             </a:extLst>
           </p:cNvPr>
@@ -4817,8 +4817,8 @@
         </p:nvCxnSpPr>
         <p:spPr>
           <a:xfrm>
-            <a:off x="7837519" y="3820628"/>
-            <a:ext cx="0" cy="226795"/>
+            <a:off x="7837519" y="3942748"/>
+            <a:ext cx="0" cy="104675"/>
           </a:xfrm>
           <a:prstGeom prst="line">
             <a:avLst/>
@@ -4851,7 +4851,7 @@
           <p:cNvPr id="35" name="rule_theme_decorate">
             <a:extLst>
               <a:ext uri="{FF2B5EF4-FFF2-40B4-BE49-F238E27FC236}">
-                <a16:creationId xmlns:a16="http://schemas.microsoft.com/office/drawing/2014/main" id="{4532EF39-4C00-B999-8303-DABC8DB76472}"/>
+                <a16:creationId xmlns:a16="http://schemas.microsoft.com/office/drawing/2014/main" id="{CA3EA1C7-C922-F100-4C20-B39C6ADCE156}"/>
               </a:ext>
             </a:extLst>
           </p:cNvPr>
@@ -4860,8 +4860,8 @@
         </p:nvCxnSpPr>
         <p:spPr>
           <a:xfrm>
-            <a:off x="8960896" y="3820628"/>
-            <a:ext cx="0" cy="226795"/>
+            <a:off x="9074104" y="3942748"/>
+            <a:ext cx="0" cy="104675"/>
           </a:xfrm>
           <a:prstGeom prst="line">
             <a:avLst/>
@@ -4894,7 +4894,7 @@
           <p:cNvPr id="36" name="rule_compose_objects">
             <a:extLst>
               <a:ext uri="{FF2B5EF4-FFF2-40B4-BE49-F238E27FC236}">
-                <a16:creationId xmlns:a16="http://schemas.microsoft.com/office/drawing/2014/main" id="{FD2252AA-699A-6DCB-0D68-2C99C66F70C9}"/>
+                <a16:creationId xmlns:a16="http://schemas.microsoft.com/office/drawing/2014/main" id="{6B8486F3-499D-10BC-C4C3-A81DEB7942ED}"/>
               </a:ext>
             </a:extLst>
           </p:cNvPr>
@@ -4903,8 +4903,8 @@
         </p:nvCxnSpPr>
         <p:spPr>
           <a:xfrm>
-            <a:off x="7219225" y="4483568"/>
-            <a:ext cx="113209" cy="0"/>
+            <a:off x="7140850" y="4492291"/>
+            <a:ext cx="156750" cy="0"/>
           </a:xfrm>
           <a:prstGeom prst="line">
             <a:avLst/>
@@ -4937,7 +4937,7 @@
           <p:cNvPr id="37" name="rule_objects_decorate">
             <a:extLst>
               <a:ext uri="{FF2B5EF4-FFF2-40B4-BE49-F238E27FC236}">
-                <a16:creationId xmlns:a16="http://schemas.microsoft.com/office/drawing/2014/main" id="{859E1A73-886F-615C-8189-5417D488FC36}"/>
+                <a16:creationId xmlns:a16="http://schemas.microsoft.com/office/drawing/2014/main" id="{571E6CC1-A8DB-8026-62BD-E0DB4F3EE398}"/>
               </a:ext>
             </a:extLst>
           </p:cNvPr>
@@ -4946,8 +4946,8 @@
         </p:nvCxnSpPr>
         <p:spPr>
           <a:xfrm>
-            <a:off x="8342603" y="4483568"/>
-            <a:ext cx="113209" cy="0"/>
+            <a:off x="8377436" y="4492291"/>
+            <a:ext cx="156751" cy="0"/>
           </a:xfrm>
           <a:prstGeom prst="line">
             <a:avLst/>
@@ -4980,7 +4980,7 @@
           <p:cNvPr id="38" name="main_rules_styled_ir">
             <a:extLst>
               <a:ext uri="{FF2B5EF4-FFF2-40B4-BE49-F238E27FC236}">
-                <a16:creationId xmlns:a16="http://schemas.microsoft.com/office/drawing/2014/main" id="{93E6DBB1-C5F5-B23B-B0A8-A17526B7CB0B}"/>
+                <a16:creationId xmlns:a16="http://schemas.microsoft.com/office/drawing/2014/main" id="{1D441198-26CC-D9F4-B018-D42FCA786F54}"/>
               </a:ext>
             </a:extLst>
           </p:cNvPr>
@@ -4989,8 +4989,8 @@
         </p:nvCxnSpPr>
         <p:spPr>
           <a:xfrm>
-            <a:off x="9361481" y="2494748"/>
-            <a:ext cx="609584" cy="0"/>
+            <a:off x="9448564" y="2534001"/>
+            <a:ext cx="627002" cy="0"/>
           </a:xfrm>
           <a:prstGeom prst="line">
             <a:avLst/>
@@ -5023,7 +5023,7 @@
           <p:cNvPr id="39" name="main_styled_renderers">
             <a:extLst>
               <a:ext uri="{FF2B5EF4-FFF2-40B4-BE49-F238E27FC236}">
-                <a16:creationId xmlns:a16="http://schemas.microsoft.com/office/drawing/2014/main" id="{F1E9F211-D4E1-5927-F0C0-E7F42398FD75}"/>
+                <a16:creationId xmlns:a16="http://schemas.microsoft.com/office/drawing/2014/main" id="{7765697B-F77B-F908-EBE3-8E4B27CC9827}"/>
               </a:ext>
             </a:extLst>
           </p:cNvPr>
@@ -5032,8 +5032,8 @@
         </p:nvCxnSpPr>
         <p:spPr>
           <a:xfrm>
-            <a:off x="10841900" y="2952700"/>
-            <a:ext cx="0" cy="449229"/>
+            <a:off x="10928984" y="2991953"/>
+            <a:ext cx="0" cy="409976"/>
           </a:xfrm>
           <a:prstGeom prst="line">
             <a:avLst/>
@@ -5066,7 +5066,7 @@
           <p:cNvPr id="40" name="validation_loop">
             <a:extLst>
               <a:ext uri="{FF2B5EF4-FFF2-40B4-BE49-F238E27FC236}">
-                <a16:creationId xmlns:a16="http://schemas.microsoft.com/office/drawing/2014/main" id="{3F16F976-FEBB-51D1-502F-B09C6D8F99D0}"/>
+                <a16:creationId xmlns:a16="http://schemas.microsoft.com/office/drawing/2014/main" id="{858378A6-F29A-79E1-AD48-98030ADA18E8}"/>
               </a:ext>
             </a:extLst>
           </p:cNvPr>
@@ -5075,8 +5075,8 @@
         </p:nvCxnSpPr>
         <p:spPr>
           <a:xfrm>
-            <a:off x="10841900" y="4317833"/>
-            <a:ext cx="0" cy="148289"/>
+            <a:off x="10928984" y="4317833"/>
+            <a:ext cx="0" cy="95952"/>
           </a:xfrm>
           <a:prstGeom prst="line">
             <a:avLst/>
@@ -5109,7 +5109,7 @@
           <p:cNvPr id="41" name="source_chip">
             <a:extLst>
               <a:ext uri="{FF2B5EF4-FFF2-40B4-BE49-F238E27FC236}">
-                <a16:creationId xmlns:a16="http://schemas.microsoft.com/office/drawing/2014/main" id="{B484AE61-F13B-7D63-2467-D65046D04E47}"/>
+                <a16:creationId xmlns:a16="http://schemas.microsoft.com/office/drawing/2014/main" id="{D92CD025-D8D3-432B-9AD0-DC651A884602}"/>
               </a:ext>
             </a:extLst>
           </p:cNvPr>
@@ -5118,8 +5118,8 @@
         </p:nvSpPr>
         <p:spPr>
           <a:xfrm>
-            <a:off x="1654587" y="2145832"/>
-            <a:ext cx="696669" cy="296579"/>
+            <a:off x="1654587" y="2163278"/>
+            <a:ext cx="696669" cy="314024"/>
           </a:xfrm>
           <a:prstGeom prst="roundRect">
             <a:avLst/>
@@ -5170,7 +5170,7 @@
           <p:cNvPr id="42" name="source_chip_text">
             <a:extLst>
               <a:ext uri="{FF2B5EF4-FFF2-40B4-BE49-F238E27FC236}">
-                <a16:creationId xmlns:a16="http://schemas.microsoft.com/office/drawing/2014/main" id="{61210FE8-A2F7-5C13-A7F7-047190A18817}"/>
+                <a16:creationId xmlns:a16="http://schemas.microsoft.com/office/drawing/2014/main" id="{819F1BE0-E948-E0AE-2A99-56CA87F6C5AC}"/>
               </a:ext>
             </a:extLst>
           </p:cNvPr>
@@ -5179,7 +5179,7 @@
         </p:nvSpPr>
         <p:spPr>
           <a:xfrm>
-            <a:off x="1724254" y="2180724"/>
+            <a:off x="1724254" y="2198170"/>
             <a:ext cx="557335" cy="285806"/>
           </a:xfrm>
           <a:prstGeom prst="rect">
@@ -5217,7 +5217,7 @@
           <p:cNvPr id="43" name="markdown_card">
             <a:extLst>
               <a:ext uri="{FF2B5EF4-FFF2-40B4-BE49-F238E27FC236}">
-                <a16:creationId xmlns:a16="http://schemas.microsoft.com/office/drawing/2014/main" id="{A68C9986-6FFE-EB71-122F-252EBCDC736F}"/>
+                <a16:creationId xmlns:a16="http://schemas.microsoft.com/office/drawing/2014/main" id="{919D73DE-14E9-6038-072A-873A6371A81F}"/>
               </a:ext>
             </a:extLst>
           </p:cNvPr>
@@ -5226,8 +5226,8 @@
         </p:nvSpPr>
         <p:spPr>
           <a:xfrm>
-            <a:off x="1001461" y="2669206"/>
-            <a:ext cx="2002921" cy="915904"/>
+            <a:off x="1010169" y="2686652"/>
+            <a:ext cx="1985505" cy="942072"/>
           </a:xfrm>
           <a:prstGeom prst="roundRect">
             <a:avLst/>
@@ -5278,7 +5278,7 @@
           <p:cNvPr id="44" name="markdown_icon_dot">
             <a:extLst>
               <a:ext uri="{FF2B5EF4-FFF2-40B4-BE49-F238E27FC236}">
-                <a16:creationId xmlns:a16="http://schemas.microsoft.com/office/drawing/2014/main" id="{A24A08A0-5723-D8AF-8E09-5E7011227738}"/>
+                <a16:creationId xmlns:a16="http://schemas.microsoft.com/office/drawing/2014/main" id="{FB51F82D-A4D1-534B-D123-C5FF5A32B8EC}"/>
               </a:ext>
             </a:extLst>
           </p:cNvPr>
@@ -5287,8 +5287,8 @@
         </p:nvSpPr>
         <p:spPr>
           <a:xfrm>
-            <a:off x="1158211" y="2896001"/>
-            <a:ext cx="191584" cy="191904"/>
+            <a:off x="1184336" y="2913447"/>
+            <a:ext cx="191584" cy="191903"/>
           </a:xfrm>
           <a:prstGeom prst="ellipse">
             <a:avLst/>
@@ -5332,7 +5332,7 @@
           <p:cNvPr id="45" name="markdown_icon_label">
             <a:extLst>
               <a:ext uri="{FF2B5EF4-FFF2-40B4-BE49-F238E27FC236}">
-                <a16:creationId xmlns:a16="http://schemas.microsoft.com/office/drawing/2014/main" id="{CC1A724C-3B06-6AA4-BEC6-2C6F13EDA739}"/>
+                <a16:creationId xmlns:a16="http://schemas.microsoft.com/office/drawing/2014/main" id="{DDBEF82A-82CF-AE06-BCD5-BD9F00028D04}"/>
               </a:ext>
             </a:extLst>
           </p:cNvPr>
@@ -5341,7 +5341,7 @@
         </p:nvSpPr>
         <p:spPr>
           <a:xfrm>
-            <a:off x="1158211" y="2903677"/>
+            <a:off x="1184336" y="2921123"/>
             <a:ext cx="191584" cy="285806"/>
           </a:xfrm>
           <a:prstGeom prst="rect">
@@ -5379,7 +5379,7 @@
           <p:cNvPr id="46" name="markdown_title">
             <a:extLst>
               <a:ext uri="{FF2B5EF4-FFF2-40B4-BE49-F238E27FC236}">
-                <a16:creationId xmlns:a16="http://schemas.microsoft.com/office/drawing/2014/main" id="{B685693D-873B-3881-9717-BEA97B02C6DC}"/>
+                <a16:creationId xmlns:a16="http://schemas.microsoft.com/office/drawing/2014/main" id="{274FB7A1-A2B1-A7AF-5913-6BE4DF835EF1}"/>
               </a:ext>
             </a:extLst>
           </p:cNvPr>
@@ -5388,8 +5388,8 @@
         </p:nvSpPr>
         <p:spPr>
           <a:xfrm>
-            <a:off x="1463003" y="2887278"/>
-            <a:ext cx="1471712" cy="285806"/>
+            <a:off x="1515254" y="2904724"/>
+            <a:ext cx="1358503" cy="285806"/>
           </a:xfrm>
           <a:prstGeom prst="rect">
             <a:avLst/>
@@ -5403,7 +5403,7 @@
           <a:lstStyle/>
           <a:p>
             <a:r>
-              <a:rPr lang="en-US" altLang="ko-KR" sz="1168" b="1">
+              <a:rPr lang="en-US" altLang="ko-KR" sz="1095" b="1">
                 <a:solidFill>
                   <a:srgbClr val="111827"/>
                 </a:solidFill>
@@ -5411,7 +5411,7 @@
               </a:rPr>
               <a:t>Markdown</a:t>
             </a:r>
-            <a:endParaRPr lang="ko-KR" altLang="en-US" sz="1168" b="1">
+            <a:endParaRPr lang="ko-KR" altLang="en-US" sz="1095" b="1">
               <a:solidFill>
                 <a:srgbClr val="111827"/>
               </a:solidFill>
@@ -5425,7 +5425,7 @@
           <p:cNvPr id="47" name="markdown_line_0">
             <a:extLst>
               <a:ext uri="{FF2B5EF4-FFF2-40B4-BE49-F238E27FC236}">
-                <a16:creationId xmlns:a16="http://schemas.microsoft.com/office/drawing/2014/main" id="{945978A1-CB8C-2B1F-6CD5-43A53F8CCC10}"/>
+                <a16:creationId xmlns:a16="http://schemas.microsoft.com/office/drawing/2014/main" id="{F59EB15F-9B76-7167-4DCF-B5E501C61670}"/>
               </a:ext>
             </a:extLst>
           </p:cNvPr>
@@ -5434,8 +5434,8 @@
         </p:nvSpPr>
         <p:spPr>
           <a:xfrm>
-            <a:off x="1254003" y="3227471"/>
-            <a:ext cx="1645879" cy="285806"/>
+            <a:off x="1297545" y="3244917"/>
+            <a:ext cx="1576212" cy="285806"/>
           </a:xfrm>
           <a:prstGeom prst="rect">
             <a:avLst/>
@@ -5471,7 +5471,7 @@
           <p:cNvPr id="48" name="markdown_line_1">
             <a:extLst>
               <a:ext uri="{FF2B5EF4-FFF2-40B4-BE49-F238E27FC236}">
-                <a16:creationId xmlns:a16="http://schemas.microsoft.com/office/drawing/2014/main" id="{E6870D9C-0640-A0C1-1279-6C1D4F9CAC45}"/>
+                <a16:creationId xmlns:a16="http://schemas.microsoft.com/office/drawing/2014/main" id="{C5544588-6744-8F7E-96C3-FB12CC530D83}"/>
               </a:ext>
             </a:extLst>
           </p:cNvPr>
@@ -5480,8 +5480,8 @@
         </p:nvSpPr>
         <p:spPr>
           <a:xfrm>
-            <a:off x="1254003" y="3393206"/>
-            <a:ext cx="1645879" cy="285806"/>
+            <a:off x="1297545" y="3410652"/>
+            <a:ext cx="1576212" cy="285806"/>
           </a:xfrm>
           <a:prstGeom prst="rect">
             <a:avLst/>
@@ -5517,7 +5517,7 @@
           <p:cNvPr id="49" name="splitter_card">
             <a:extLst>
               <a:ext uri="{FF2B5EF4-FFF2-40B4-BE49-F238E27FC236}">
-                <a16:creationId xmlns:a16="http://schemas.microsoft.com/office/drawing/2014/main" id="{989F9826-6E1F-0B68-A19A-1E9996B4267C}"/>
+                <a16:creationId xmlns:a16="http://schemas.microsoft.com/office/drawing/2014/main" id="{FB29592F-CE9B-893A-F91B-52C85E2C77FA}"/>
               </a:ext>
             </a:extLst>
           </p:cNvPr>
@@ -5526,8 +5526,8 @@
         </p:nvSpPr>
         <p:spPr>
           <a:xfrm>
-            <a:off x="1001461" y="3907857"/>
-            <a:ext cx="2002921" cy="976964"/>
+            <a:off x="1010169" y="3907857"/>
+            <a:ext cx="1985505" cy="976964"/>
           </a:xfrm>
           <a:prstGeom prst="roundRect">
             <a:avLst/>
@@ -5578,7 +5578,7 @@
           <p:cNvPr id="50" name="splitter_icon_dot">
             <a:extLst>
               <a:ext uri="{FF2B5EF4-FFF2-40B4-BE49-F238E27FC236}">
-                <a16:creationId xmlns:a16="http://schemas.microsoft.com/office/drawing/2014/main" id="{D2BC80E1-A763-E5D7-2FF3-9DC85CDC3A20}"/>
+                <a16:creationId xmlns:a16="http://schemas.microsoft.com/office/drawing/2014/main" id="{9A7C96D9-7FFA-3D10-B975-D7031646E617}"/>
               </a:ext>
             </a:extLst>
           </p:cNvPr>
@@ -5587,7 +5587,7 @@
         </p:nvSpPr>
         <p:spPr>
           <a:xfrm>
-            <a:off x="1158211" y="4134652"/>
+            <a:off x="1184336" y="4134652"/>
             <a:ext cx="191584" cy="191904"/>
           </a:xfrm>
           <a:prstGeom prst="ellipse">
@@ -5632,7 +5632,7 @@
           <p:cNvPr id="51" name="splitter_icon_label">
             <a:extLst>
               <a:ext uri="{FF2B5EF4-FFF2-40B4-BE49-F238E27FC236}">
-                <a16:creationId xmlns:a16="http://schemas.microsoft.com/office/drawing/2014/main" id="{7F9A4153-D64F-9C0E-A59E-A19A720C11D9}"/>
+                <a16:creationId xmlns:a16="http://schemas.microsoft.com/office/drawing/2014/main" id="{687B4862-0C82-F0B3-EA74-5CC797A05C8E}"/>
               </a:ext>
             </a:extLst>
           </p:cNvPr>
@@ -5641,7 +5641,7 @@
         </p:nvSpPr>
         <p:spPr>
           <a:xfrm>
-            <a:off x="1158211" y="4142328"/>
+            <a:off x="1184336" y="4142328"/>
             <a:ext cx="191584" cy="285806"/>
           </a:xfrm>
           <a:prstGeom prst="rect">
@@ -5679,7 +5679,7 @@
           <p:cNvPr id="52" name="splitter_title">
             <a:extLst>
               <a:ext uri="{FF2B5EF4-FFF2-40B4-BE49-F238E27FC236}">
-                <a16:creationId xmlns:a16="http://schemas.microsoft.com/office/drawing/2014/main" id="{D9B9D4A0-8041-1386-916E-93ECAC03BC93}"/>
+                <a16:creationId xmlns:a16="http://schemas.microsoft.com/office/drawing/2014/main" id="{F8262AD8-C222-6AF9-1230-75020BEC3B5E}"/>
               </a:ext>
             </a:extLst>
           </p:cNvPr>
@@ -5688,8 +5688,8 @@
         </p:nvSpPr>
         <p:spPr>
           <a:xfrm>
-            <a:off x="1463003" y="4125929"/>
-            <a:ext cx="1471712" cy="285806"/>
+            <a:off x="1515254" y="4125929"/>
+            <a:ext cx="1358503" cy="285806"/>
           </a:xfrm>
           <a:prstGeom prst="rect">
             <a:avLst/>
@@ -5703,7 +5703,7 @@
           <a:lstStyle/>
           <a:p>
             <a:r>
-              <a:rPr lang="en-US" altLang="ko-KR" sz="1168" b="1">
+              <a:rPr lang="en-US" altLang="ko-KR" sz="1095" b="1">
                 <a:solidFill>
                   <a:srgbClr val="111827"/>
                 </a:solidFill>
@@ -5711,7 +5711,7 @@
               </a:rPr>
               <a:t>MDPR Splitter</a:t>
             </a:r>
-            <a:endParaRPr lang="ko-KR" altLang="en-US" sz="1168" b="1">
+            <a:endParaRPr lang="ko-KR" altLang="en-US" sz="1095" b="1">
               <a:solidFill>
                 <a:srgbClr val="111827"/>
               </a:solidFill>
@@ -5725,7 +5725,7 @@
           <p:cNvPr id="53" name="splitter_line_0">
             <a:extLst>
               <a:ext uri="{FF2B5EF4-FFF2-40B4-BE49-F238E27FC236}">
-                <a16:creationId xmlns:a16="http://schemas.microsoft.com/office/drawing/2014/main" id="{109E834D-5C54-9263-826D-369A60844C6B}"/>
+                <a16:creationId xmlns:a16="http://schemas.microsoft.com/office/drawing/2014/main" id="{215FCEC1-468B-E7C4-1BBD-FE4ED15312FC}"/>
               </a:ext>
             </a:extLst>
           </p:cNvPr>
@@ -5734,8 +5734,8 @@
         </p:nvSpPr>
         <p:spPr>
           <a:xfrm>
-            <a:off x="1254003" y="4466122"/>
-            <a:ext cx="1645879" cy="285806"/>
+            <a:off x="1297545" y="4466122"/>
+            <a:ext cx="1576212" cy="285806"/>
           </a:xfrm>
           <a:prstGeom prst="rect">
             <a:avLst/>
@@ -5771,7 +5771,7 @@
           <p:cNvPr id="54" name="splitter_line_1">
             <a:extLst>
               <a:ext uri="{FF2B5EF4-FFF2-40B4-BE49-F238E27FC236}">
-                <a16:creationId xmlns:a16="http://schemas.microsoft.com/office/drawing/2014/main" id="{9AEE5024-4CD0-B9A1-750E-D72880A8ED07}"/>
+                <a16:creationId xmlns:a16="http://schemas.microsoft.com/office/drawing/2014/main" id="{CC883366-7924-EEB5-2510-1060C4976F88}"/>
               </a:ext>
             </a:extLst>
           </p:cNvPr>
@@ -5780,8 +5780,8 @@
         </p:nvSpPr>
         <p:spPr>
           <a:xfrm>
-            <a:off x="1254003" y="4631857"/>
-            <a:ext cx="1645879" cy="285806"/>
+            <a:off x="1297545" y="4631857"/>
+            <a:ext cx="1576212" cy="285806"/>
           </a:xfrm>
           <a:prstGeom prst="rect">
             <a:avLst/>
@@ -5817,7 +5817,7 @@
           <p:cNvPr id="55" name="ir_core_card">
             <a:extLst>
               <a:ext uri="{FF2B5EF4-FFF2-40B4-BE49-F238E27FC236}">
-                <a16:creationId xmlns:a16="http://schemas.microsoft.com/office/drawing/2014/main" id="{28B4F0AE-CA9D-4592-32B7-4A0067543666}"/>
+                <a16:creationId xmlns:a16="http://schemas.microsoft.com/office/drawing/2014/main" id="{76FC1939-B799-878C-3435-4A9D460CA9A9}"/>
               </a:ext>
             </a:extLst>
           </p:cNvPr>
@@ -5826,8 +5826,8 @@
         </p:nvSpPr>
         <p:spPr>
           <a:xfrm>
-            <a:off x="3701050" y="2006266"/>
-            <a:ext cx="1915838" cy="976964"/>
+            <a:off x="3657509" y="2076049"/>
+            <a:ext cx="1915838" cy="915904"/>
           </a:xfrm>
           <a:prstGeom prst="roundRect">
             <a:avLst/>
@@ -5878,7 +5878,7 @@
           <p:cNvPr id="56" name="ir_core_icon_dot">
             <a:extLst>
               <a:ext uri="{FF2B5EF4-FFF2-40B4-BE49-F238E27FC236}">
-                <a16:creationId xmlns:a16="http://schemas.microsoft.com/office/drawing/2014/main" id="{4269C1F1-2240-7CE4-2274-04A1809463FA}"/>
+                <a16:creationId xmlns:a16="http://schemas.microsoft.com/office/drawing/2014/main" id="{58466E76-7884-C3C6-ED83-3BDBF45519AD}"/>
               </a:ext>
             </a:extLst>
           </p:cNvPr>
@@ -5887,7 +5887,7 @@
         </p:nvSpPr>
         <p:spPr>
           <a:xfrm>
-            <a:off x="3857801" y="2233061"/>
+            <a:off x="3831676" y="2302844"/>
             <a:ext cx="191583" cy="191904"/>
           </a:xfrm>
           <a:prstGeom prst="ellipse">
@@ -5932,7 +5932,7 @@
           <p:cNvPr id="57" name="ir_core_icon_label">
             <a:extLst>
               <a:ext uri="{FF2B5EF4-FFF2-40B4-BE49-F238E27FC236}">
-                <a16:creationId xmlns:a16="http://schemas.microsoft.com/office/drawing/2014/main" id="{8EE26747-9CE9-AC74-774C-ABBC79AE51A9}"/>
+                <a16:creationId xmlns:a16="http://schemas.microsoft.com/office/drawing/2014/main" id="{5E896E8D-CD80-9244-F6F1-FF6DC4B94927}"/>
               </a:ext>
             </a:extLst>
           </p:cNvPr>
@@ -5941,7 +5941,7 @@
         </p:nvSpPr>
         <p:spPr>
           <a:xfrm>
-            <a:off x="3857801" y="2240737"/>
+            <a:off x="3831676" y="2310520"/>
             <a:ext cx="191584" cy="285806"/>
           </a:xfrm>
           <a:prstGeom prst="rect">
@@ -5979,7 +5979,7 @@
           <p:cNvPr id="58" name="ir_core_title">
             <a:extLst>
               <a:ext uri="{FF2B5EF4-FFF2-40B4-BE49-F238E27FC236}">
-                <a16:creationId xmlns:a16="http://schemas.microsoft.com/office/drawing/2014/main" id="{6C7C98E4-F880-D8F8-AA1C-1B20961B7B4D}"/>
+                <a16:creationId xmlns:a16="http://schemas.microsoft.com/office/drawing/2014/main" id="{82F687E8-E358-F176-AA71-E206B05005C4}"/>
               </a:ext>
             </a:extLst>
           </p:cNvPr>
@@ -5988,8 +5988,8 @@
         </p:nvSpPr>
         <p:spPr>
           <a:xfrm>
-            <a:off x="4162593" y="2224338"/>
-            <a:ext cx="1384628" cy="285806"/>
+            <a:off x="4162593" y="2294121"/>
+            <a:ext cx="1288836" cy="285806"/>
           </a:xfrm>
           <a:prstGeom prst="rect">
             <a:avLst/>
@@ -6003,7 +6003,7 @@
           <a:lstStyle/>
           <a:p>
             <a:r>
-              <a:rPr lang="en-US" altLang="ko-KR" sz="1168" b="1">
+              <a:rPr lang="en-US" altLang="ko-KR" sz="1095" b="1">
                 <a:solidFill>
                   <a:srgbClr val="111827"/>
                 </a:solidFill>
@@ -6011,7 +6011,7 @@
               </a:rPr>
               <a:t>Slide Element IR</a:t>
             </a:r>
-            <a:endParaRPr lang="ko-KR" altLang="en-US" sz="1168" b="1">
+            <a:endParaRPr lang="ko-KR" altLang="en-US" sz="1095" b="1">
               <a:solidFill>
                 <a:srgbClr val="111827"/>
               </a:solidFill>
@@ -6025,7 +6025,7 @@
           <p:cNvPr id="59" name="ir_core_line_0">
             <a:extLst>
               <a:ext uri="{FF2B5EF4-FFF2-40B4-BE49-F238E27FC236}">
-                <a16:creationId xmlns:a16="http://schemas.microsoft.com/office/drawing/2014/main" id="{F4D8268C-3532-E9E5-C77F-35550CC8D7E3}"/>
+                <a16:creationId xmlns:a16="http://schemas.microsoft.com/office/drawing/2014/main" id="{13CF376B-1605-7CE2-DD60-E8B51A6FB5CD}"/>
               </a:ext>
             </a:extLst>
           </p:cNvPr>
@@ -6034,8 +6034,8 @@
         </p:nvSpPr>
         <p:spPr>
           <a:xfrm>
-            <a:off x="3953592" y="2564531"/>
-            <a:ext cx="1558795" cy="285806"/>
+            <a:off x="3944884" y="2634314"/>
+            <a:ext cx="1506545" cy="285806"/>
           </a:xfrm>
           <a:prstGeom prst="rect">
             <a:avLst/>
@@ -6071,7 +6071,7 @@
           <p:cNvPr id="60" name="ir_core_line_1">
             <a:extLst>
               <a:ext uri="{FF2B5EF4-FFF2-40B4-BE49-F238E27FC236}">
-                <a16:creationId xmlns:a16="http://schemas.microsoft.com/office/drawing/2014/main" id="{E7C2E4C6-40B6-75A5-A409-0E00CCD68C81}"/>
+                <a16:creationId xmlns:a16="http://schemas.microsoft.com/office/drawing/2014/main" id="{1CEC2F10-4B09-4E7E-C7A5-76157FE764B7}"/>
               </a:ext>
             </a:extLst>
           </p:cNvPr>
@@ -6080,8 +6080,8 @@
         </p:nvSpPr>
         <p:spPr>
           <a:xfrm>
-            <a:off x="3953592" y="2730266"/>
-            <a:ext cx="1558795" cy="285806"/>
+            <a:off x="3944884" y="2800049"/>
+            <a:ext cx="1506545" cy="285806"/>
           </a:xfrm>
           <a:prstGeom prst="rect">
             <a:avLst/>
@@ -6117,7 +6117,7 @@
           <p:cNvPr id="61" name="reasoning_card">
             <a:extLst>
               <a:ext uri="{FF2B5EF4-FFF2-40B4-BE49-F238E27FC236}">
-                <a16:creationId xmlns:a16="http://schemas.microsoft.com/office/drawing/2014/main" id="{FD6007CD-AF27-EEFB-D4C5-EB74BC96C6DE}"/>
+                <a16:creationId xmlns:a16="http://schemas.microsoft.com/office/drawing/2014/main" id="{BF305F44-1B15-F0CD-BC4D-A25A66EA88C4}"/>
               </a:ext>
             </a:extLst>
           </p:cNvPr>
@@ -6126,8 +6126,8 @@
         </p:nvSpPr>
         <p:spPr>
           <a:xfrm>
-            <a:off x="3701050" y="3401929"/>
-            <a:ext cx="1915838" cy="1482892"/>
+            <a:off x="3657509" y="3489158"/>
+            <a:ext cx="1915838" cy="1395663"/>
           </a:xfrm>
           <a:prstGeom prst="roundRect">
             <a:avLst/>
@@ -6178,7 +6178,7 @@
           <p:cNvPr id="62" name="reasoning_icon_dot">
             <a:extLst>
               <a:ext uri="{FF2B5EF4-FFF2-40B4-BE49-F238E27FC236}">
-                <a16:creationId xmlns:a16="http://schemas.microsoft.com/office/drawing/2014/main" id="{D665E25B-EDF1-34B2-DD63-92FB054953A2}"/>
+                <a16:creationId xmlns:a16="http://schemas.microsoft.com/office/drawing/2014/main" id="{A2241C7B-433F-44F0-0E02-41491790943A}"/>
               </a:ext>
             </a:extLst>
           </p:cNvPr>
@@ -6187,7 +6187,7 @@
         </p:nvSpPr>
         <p:spPr>
           <a:xfrm>
-            <a:off x="3857801" y="3628724"/>
+            <a:off x="3831676" y="3715953"/>
             <a:ext cx="191583" cy="191904"/>
           </a:xfrm>
           <a:prstGeom prst="ellipse">
@@ -6232,7 +6232,7 @@
           <p:cNvPr id="63" name="reasoning_icon_label">
             <a:extLst>
               <a:ext uri="{FF2B5EF4-FFF2-40B4-BE49-F238E27FC236}">
-                <a16:creationId xmlns:a16="http://schemas.microsoft.com/office/drawing/2014/main" id="{60CE65D1-F935-9F31-00DD-893B611E94FF}"/>
+                <a16:creationId xmlns:a16="http://schemas.microsoft.com/office/drawing/2014/main" id="{39668B04-52AE-F4E6-700B-A361F3A9415F}"/>
               </a:ext>
             </a:extLst>
           </p:cNvPr>
@@ -6241,7 +6241,7 @@
         </p:nvSpPr>
         <p:spPr>
           <a:xfrm>
-            <a:off x="3857801" y="3636401"/>
+            <a:off x="3831676" y="3723629"/>
             <a:ext cx="191584" cy="285806"/>
           </a:xfrm>
           <a:prstGeom prst="rect">
@@ -6279,7 +6279,7 @@
           <p:cNvPr id="64" name="reasoning_title">
             <a:extLst>
               <a:ext uri="{FF2B5EF4-FFF2-40B4-BE49-F238E27FC236}">
-                <a16:creationId xmlns:a16="http://schemas.microsoft.com/office/drawing/2014/main" id="{E0055879-3455-32F3-B04A-2399D2400AF1}"/>
+                <a16:creationId xmlns:a16="http://schemas.microsoft.com/office/drawing/2014/main" id="{265DB8B5-85FF-0FA9-B92E-3AA9EAD31757}"/>
               </a:ext>
             </a:extLst>
           </p:cNvPr>
@@ -6288,8 +6288,8 @@
         </p:nvSpPr>
         <p:spPr>
           <a:xfrm>
-            <a:off x="4162593" y="3620001"/>
-            <a:ext cx="1384628" cy="285806"/>
+            <a:off x="4162593" y="3707230"/>
+            <a:ext cx="1288836" cy="285806"/>
           </a:xfrm>
           <a:prstGeom prst="rect">
             <a:avLst/>
@@ -6303,7 +6303,7 @@
           <a:lstStyle/>
           <a:p>
             <a:r>
-              <a:rPr lang="en-US" altLang="ko-KR" sz="1168" b="1">
+              <a:rPr lang="en-US" altLang="ko-KR" sz="1095" b="1">
                 <a:solidFill>
                   <a:srgbClr val="111827"/>
                 </a:solidFill>
@@ -6311,7 +6311,7 @@
               </a:rPr>
               <a:t>Hint Packet</a:t>
             </a:r>
-            <a:endParaRPr lang="ko-KR" altLang="en-US" sz="1168" b="1">
+            <a:endParaRPr lang="ko-KR" altLang="en-US" sz="1095" b="1">
               <a:solidFill>
                 <a:srgbClr val="111827"/>
               </a:solidFill>
@@ -6325,7 +6325,7 @@
           <p:cNvPr id="65" name="reasoning_line_0">
             <a:extLst>
               <a:ext uri="{FF2B5EF4-FFF2-40B4-BE49-F238E27FC236}">
-                <a16:creationId xmlns:a16="http://schemas.microsoft.com/office/drawing/2014/main" id="{0610CB4C-8A90-EA5C-BEBB-8F4313D29B4D}"/>
+                <a16:creationId xmlns:a16="http://schemas.microsoft.com/office/drawing/2014/main" id="{3DBABB2E-4751-D7A9-C022-0625847658E6}"/>
               </a:ext>
             </a:extLst>
           </p:cNvPr>
@@ -6334,8 +6334,8 @@
         </p:nvSpPr>
         <p:spPr>
           <a:xfrm>
-            <a:off x="3953592" y="3960194"/>
-            <a:ext cx="1558795" cy="285806"/>
+            <a:off x="3944884" y="4047423"/>
+            <a:ext cx="1506545" cy="285806"/>
           </a:xfrm>
           <a:prstGeom prst="rect">
             <a:avLst/>
@@ -6371,7 +6371,7 @@
           <p:cNvPr id="66" name="reasoning_guard">
             <a:extLst>
               <a:ext uri="{FF2B5EF4-FFF2-40B4-BE49-F238E27FC236}">
-                <a16:creationId xmlns:a16="http://schemas.microsoft.com/office/drawing/2014/main" id="{44C1EA27-E3C6-E5FC-0D03-4AD99341A145}"/>
+                <a16:creationId xmlns:a16="http://schemas.microsoft.com/office/drawing/2014/main" id="{6322EA6A-C933-7CF6-6708-AAB3446F9D59}"/>
               </a:ext>
             </a:extLst>
           </p:cNvPr>
@@ -6380,8 +6380,8 @@
         </p:nvSpPr>
         <p:spPr>
           <a:xfrm>
-            <a:off x="3918759" y="4239327"/>
-            <a:ext cx="1480420" cy="296578"/>
+            <a:off x="3901342" y="4309110"/>
+            <a:ext cx="1428171" cy="314024"/>
           </a:xfrm>
           <a:prstGeom prst="roundRect">
             <a:avLst/>
@@ -6432,7 +6432,7 @@
           <p:cNvPr id="67" name="reasoning_guard_text">
             <a:extLst>
               <a:ext uri="{FF2B5EF4-FFF2-40B4-BE49-F238E27FC236}">
-                <a16:creationId xmlns:a16="http://schemas.microsoft.com/office/drawing/2014/main" id="{0731C377-06DD-48F4-41D6-1FDB83E3A15C}"/>
+                <a16:creationId xmlns:a16="http://schemas.microsoft.com/office/drawing/2014/main" id="{0CFE2C52-02DB-CC9C-4C9A-08EB9B96B87F}"/>
               </a:ext>
             </a:extLst>
           </p:cNvPr>
@@ -6441,8 +6441,8 @@
         </p:nvSpPr>
         <p:spPr>
           <a:xfrm>
-            <a:off x="3988426" y="4274219"/>
-            <a:ext cx="1341086" cy="285806"/>
+            <a:off x="3971009" y="4344002"/>
+            <a:ext cx="1288836" cy="285806"/>
           </a:xfrm>
           <a:prstGeom prst="rect">
             <a:avLst/>
@@ -6479,7 +6479,7 @@
           <p:cNvPr id="68" name="reasoning_limit">
             <a:extLst>
               <a:ext uri="{FF2B5EF4-FFF2-40B4-BE49-F238E27FC236}">
-                <a16:creationId xmlns:a16="http://schemas.microsoft.com/office/drawing/2014/main" id="{E6D44BE6-AAEA-9601-BDDC-84E9D658A503}"/>
+                <a16:creationId xmlns:a16="http://schemas.microsoft.com/office/drawing/2014/main" id="{C7A18C9D-80E6-FA0D-0C29-2BA1AA242F81}"/>
               </a:ext>
             </a:extLst>
           </p:cNvPr>
@@ -6488,7 +6488,7 @@
         </p:nvSpPr>
         <p:spPr>
           <a:xfrm>
-            <a:off x="3918759" y="4518459"/>
+            <a:off x="3875217" y="4570797"/>
             <a:ext cx="1480420" cy="285806"/>
           </a:xfrm>
           <a:prstGeom prst="rect">
@@ -6509,7 +6509,7 @@
                 </a:solidFill>
                 <a:latin typeface="Aptos" panose="020B0004020202020204" pitchFamily="34" charset="0"/>
               </a:rPr>
-              <a:t>no coordinates or styles</a:t>
+              <a:t>no coords/styles</a:t>
             </a:r>
             <a:endParaRPr lang="ko-KR" altLang="en-US" sz="980" b="1">
               <a:solidFill>
@@ -6525,7 +6525,7 @@
           <p:cNvPr id="69" name="rule_engine_card">
             <a:extLst>
               <a:ext uri="{FF2B5EF4-FFF2-40B4-BE49-F238E27FC236}">
-                <a16:creationId xmlns:a16="http://schemas.microsoft.com/office/drawing/2014/main" id="{9501165F-BC55-9C36-46D7-D587FD5087FE}"/>
+                <a16:creationId xmlns:a16="http://schemas.microsoft.com/office/drawing/2014/main" id="{F40B79DC-8184-388F-7DC4-5B4E69D4A1E9}"/>
               </a:ext>
             </a:extLst>
           </p:cNvPr>
@@ -6534,8 +6534,8 @@
         </p:nvSpPr>
         <p:spPr>
           <a:xfrm>
-            <a:off x="6357098" y="2145832"/>
-            <a:ext cx="3004383" cy="697832"/>
+            <a:off x="6226473" y="2185085"/>
+            <a:ext cx="3222091" cy="697832"/>
           </a:xfrm>
           <a:prstGeom prst="roundRect">
             <a:avLst/>
@@ -6586,7 +6586,7 @@
           <p:cNvPr id="70" name="rule_engine_title">
             <a:extLst>
               <a:ext uri="{FF2B5EF4-FFF2-40B4-BE49-F238E27FC236}">
-                <a16:creationId xmlns:a16="http://schemas.microsoft.com/office/drawing/2014/main" id="{39A27FFB-C562-8817-7611-24DB88B437F2}"/>
+                <a16:creationId xmlns:a16="http://schemas.microsoft.com/office/drawing/2014/main" id="{0203DD24-A6D4-95A6-9BE4-02A5B7C0385B}"/>
               </a:ext>
             </a:extLst>
           </p:cNvPr>
@@ -6595,8 +6595,8 @@
         </p:nvSpPr>
         <p:spPr>
           <a:xfrm>
-            <a:off x="6618349" y="2267953"/>
-            <a:ext cx="2481881" cy="285806"/>
+            <a:off x="6487723" y="2307206"/>
+            <a:ext cx="2699590" cy="285806"/>
           </a:xfrm>
           <a:prstGeom prst="rect">
             <a:avLst/>
@@ -6632,7 +6632,7 @@
           <p:cNvPr id="71" name="rule_engine_body">
             <a:extLst>
               <a:ext uri="{FF2B5EF4-FFF2-40B4-BE49-F238E27FC236}">
-                <a16:creationId xmlns:a16="http://schemas.microsoft.com/office/drawing/2014/main" id="{E689129A-DDBE-DD87-6094-665DC2F6CF5E}"/>
+                <a16:creationId xmlns:a16="http://schemas.microsoft.com/office/drawing/2014/main" id="{59FBF9B6-C76C-E668-42F8-95B7B95C3F69}"/>
               </a:ext>
             </a:extLst>
           </p:cNvPr>
@@ -6641,8 +6641,8 @@
         </p:nvSpPr>
         <p:spPr>
           <a:xfrm>
-            <a:off x="6618349" y="2538362"/>
-            <a:ext cx="2481881" cy="285806"/>
+            <a:off x="6487723" y="2577615"/>
+            <a:ext cx="2699590" cy="285806"/>
           </a:xfrm>
           <a:prstGeom prst="rect">
             <a:avLst/>
@@ -6678,7 +6678,7 @@
           <p:cNvPr id="72" name="features_card">
             <a:extLst>
               <a:ext uri="{FF2B5EF4-FFF2-40B4-BE49-F238E27FC236}">
-                <a16:creationId xmlns:a16="http://schemas.microsoft.com/office/drawing/2014/main" id="{41D2DFC8-DA91-CE85-C78A-A1AA65429CAB}"/>
+                <a16:creationId xmlns:a16="http://schemas.microsoft.com/office/drawing/2014/main" id="{506C96CA-20DB-0A91-FD37-60D8791185E3}"/>
               </a:ext>
             </a:extLst>
           </p:cNvPr>
@@ -6687,8 +6687,8 @@
         </p:nvSpPr>
         <p:spPr>
           <a:xfrm>
-            <a:off x="6209056" y="2948338"/>
-            <a:ext cx="1010169" cy="872290"/>
+            <a:off x="6061014" y="3053013"/>
+            <a:ext cx="1079836" cy="889735"/>
           </a:xfrm>
           <a:prstGeom prst="roundRect">
             <a:avLst/>
@@ -6739,7 +6739,7 @@
           <p:cNvPr id="73" name="features_icon_dot">
             <a:extLst>
               <a:ext uri="{FF2B5EF4-FFF2-40B4-BE49-F238E27FC236}">
-                <a16:creationId xmlns:a16="http://schemas.microsoft.com/office/drawing/2014/main" id="{72CB381B-39CD-435F-4BA5-80A2C548A16E}"/>
+                <a16:creationId xmlns:a16="http://schemas.microsoft.com/office/drawing/2014/main" id="{28CCB6FA-A87E-5903-4DCD-2958D518011D}"/>
               </a:ext>
             </a:extLst>
           </p:cNvPr>
@@ -6748,7 +6748,7 @@
         </p:nvSpPr>
         <p:spPr>
           <a:xfrm>
-            <a:off x="6322265" y="3148965"/>
+            <a:off x="6182931" y="3253640"/>
             <a:ext cx="139334" cy="139566"/>
           </a:xfrm>
           <a:prstGeom prst="ellipse">
@@ -6793,7 +6793,7 @@
           <p:cNvPr id="74" name="features_icon_label">
             <a:extLst>
               <a:ext uri="{FF2B5EF4-FFF2-40B4-BE49-F238E27FC236}">
-                <a16:creationId xmlns:a16="http://schemas.microsoft.com/office/drawing/2014/main" id="{953220B9-209F-59D7-ACD4-8471217C9450}"/>
+                <a16:creationId xmlns:a16="http://schemas.microsoft.com/office/drawing/2014/main" id="{6D49A6E7-F439-F3F4-BF36-A7D9DEA2D0C4}"/>
               </a:ext>
             </a:extLst>
           </p:cNvPr>
@@ -6802,7 +6802,7 @@
         </p:nvSpPr>
         <p:spPr>
           <a:xfrm>
-            <a:off x="6322265" y="3154548"/>
+            <a:off x="6182931" y="3259222"/>
             <a:ext cx="139334" cy="285806"/>
           </a:xfrm>
           <a:prstGeom prst="rect">
@@ -6840,7 +6840,7 @@
           <p:cNvPr id="75" name="features_title">
             <a:extLst>
               <a:ext uri="{FF2B5EF4-FFF2-40B4-BE49-F238E27FC236}">
-                <a16:creationId xmlns:a16="http://schemas.microsoft.com/office/drawing/2014/main" id="{D730A8CA-C772-35F3-F9FF-E59BE98BAA83}"/>
+                <a16:creationId xmlns:a16="http://schemas.microsoft.com/office/drawing/2014/main" id="{D38F9349-E920-CF0F-2A74-681855C317DE}"/>
               </a:ext>
             </a:extLst>
           </p:cNvPr>
@@ -6849,8 +6849,8 @@
         </p:nvSpPr>
         <p:spPr>
           <a:xfrm>
-            <a:off x="6531265" y="3114073"/>
-            <a:ext cx="618293" cy="285806"/>
+            <a:off x="6426765" y="3218748"/>
+            <a:ext cx="592168" cy="285806"/>
           </a:xfrm>
           <a:prstGeom prst="rect">
             <a:avLst/>
@@ -6886,7 +6886,7 @@
           <p:cNvPr id="76" name="features_line_0">
             <a:extLst>
               <a:ext uri="{FF2B5EF4-FFF2-40B4-BE49-F238E27FC236}">
-                <a16:creationId xmlns:a16="http://schemas.microsoft.com/office/drawing/2014/main" id="{9BE929A8-52CE-5280-5475-28DD1DF393C0}"/>
+                <a16:creationId xmlns:a16="http://schemas.microsoft.com/office/drawing/2014/main" id="{1F50CE6C-1A48-1D2C-50CD-84794C383489}"/>
               </a:ext>
             </a:extLst>
           </p:cNvPr>
@@ -6895,8 +6895,8 @@
         </p:nvSpPr>
         <p:spPr>
           <a:xfrm>
-            <a:off x="6383223" y="3454266"/>
-            <a:ext cx="731502" cy="285806"/>
+            <a:off x="6252598" y="3558941"/>
+            <a:ext cx="766335" cy="285806"/>
           </a:xfrm>
           <a:prstGeom prst="rect">
             <a:avLst/>
@@ -6932,7 +6932,7 @@
           <p:cNvPr id="77" name="features_line_1">
             <a:extLst>
               <a:ext uri="{FF2B5EF4-FFF2-40B4-BE49-F238E27FC236}">
-                <a16:creationId xmlns:a16="http://schemas.microsoft.com/office/drawing/2014/main" id="{0975D1F7-B6E4-7AA9-E8F6-32D53C2E2250}"/>
+                <a16:creationId xmlns:a16="http://schemas.microsoft.com/office/drawing/2014/main" id="{D3EDCC3D-35A8-38F1-F6F8-DF99C21E9D92}"/>
               </a:ext>
             </a:extLst>
           </p:cNvPr>
@@ -6941,8 +6941,8 @@
         </p:nvSpPr>
         <p:spPr>
           <a:xfrm>
-            <a:off x="6383223" y="3628724"/>
-            <a:ext cx="731502" cy="285806"/>
+            <a:off x="6252598" y="3733399"/>
+            <a:ext cx="766335" cy="285806"/>
           </a:xfrm>
           <a:prstGeom prst="rect">
             <a:avLst/>
@@ -6978,7 +6978,7 @@
           <p:cNvPr id="78" name="recipes_card">
             <a:extLst>
               <a:ext uri="{FF2B5EF4-FFF2-40B4-BE49-F238E27FC236}">
-                <a16:creationId xmlns:a16="http://schemas.microsoft.com/office/drawing/2014/main" id="{AD10896E-3BCA-7452-0999-D3A38947395C}"/>
+                <a16:creationId xmlns:a16="http://schemas.microsoft.com/office/drawing/2014/main" id="{D3A5E7EE-A62D-FE6F-B17C-613D9AD62F67}"/>
               </a:ext>
             </a:extLst>
           </p:cNvPr>
@@ -6987,8 +6987,8 @@
         </p:nvSpPr>
         <p:spPr>
           <a:xfrm>
-            <a:off x="7332434" y="2948338"/>
-            <a:ext cx="1010169" cy="872290"/>
+            <a:off x="7297600" y="3053013"/>
+            <a:ext cx="1079836" cy="889735"/>
           </a:xfrm>
           <a:prstGeom prst="roundRect">
             <a:avLst/>
@@ -7039,7 +7039,7 @@
           <p:cNvPr id="79" name="recipes_icon_dot">
             <a:extLst>
               <a:ext uri="{FF2B5EF4-FFF2-40B4-BE49-F238E27FC236}">
-                <a16:creationId xmlns:a16="http://schemas.microsoft.com/office/drawing/2014/main" id="{616CD0B9-357D-1283-3597-CF156D7DE1B7}"/>
+                <a16:creationId xmlns:a16="http://schemas.microsoft.com/office/drawing/2014/main" id="{5A9E6E92-AD97-5BE4-3AB7-16042FA22163}"/>
               </a:ext>
             </a:extLst>
           </p:cNvPr>
@@ -7048,8 +7048,8 @@
         </p:nvSpPr>
         <p:spPr>
           <a:xfrm>
-            <a:off x="7445642" y="3148965"/>
-            <a:ext cx="139334" cy="139566"/>
+            <a:off x="7419518" y="3253640"/>
+            <a:ext cx="139333" cy="139566"/>
           </a:xfrm>
           <a:prstGeom prst="ellipse">
             <a:avLst/>
@@ -7093,7 +7093,7 @@
           <p:cNvPr id="80" name="recipes_icon_label">
             <a:extLst>
               <a:ext uri="{FF2B5EF4-FFF2-40B4-BE49-F238E27FC236}">
-                <a16:creationId xmlns:a16="http://schemas.microsoft.com/office/drawing/2014/main" id="{F1541B30-AC80-4411-E98C-2E74D9CE305B}"/>
+                <a16:creationId xmlns:a16="http://schemas.microsoft.com/office/drawing/2014/main" id="{3150AD95-D9AC-9342-DEE2-E4E1288AEEAF}"/>
               </a:ext>
             </a:extLst>
           </p:cNvPr>
@@ -7102,7 +7102,7 @@
         </p:nvSpPr>
         <p:spPr>
           <a:xfrm>
-            <a:off x="7445642" y="3154548"/>
+            <a:off x="7419518" y="3259222"/>
             <a:ext cx="139334" cy="285806"/>
           </a:xfrm>
           <a:prstGeom prst="rect">
@@ -7140,7 +7140,7 @@
           <p:cNvPr id="81" name="recipes_title">
             <a:extLst>
               <a:ext uri="{FF2B5EF4-FFF2-40B4-BE49-F238E27FC236}">
-                <a16:creationId xmlns:a16="http://schemas.microsoft.com/office/drawing/2014/main" id="{A61DCB61-B901-AB99-485E-99FD7424885D}"/>
+                <a16:creationId xmlns:a16="http://schemas.microsoft.com/office/drawing/2014/main" id="{A6BD999C-711B-5F89-27B9-5824DB57685D}"/>
               </a:ext>
             </a:extLst>
           </p:cNvPr>
@@ -7149,8 +7149,8 @@
         </p:nvSpPr>
         <p:spPr>
           <a:xfrm>
-            <a:off x="7654643" y="3114073"/>
-            <a:ext cx="618293" cy="285806"/>
+            <a:off x="7663352" y="3218748"/>
+            <a:ext cx="592168" cy="285806"/>
           </a:xfrm>
           <a:prstGeom prst="rect">
             <a:avLst/>
@@ -7186,7 +7186,7 @@
           <p:cNvPr id="82" name="recipes_line_0">
             <a:extLst>
               <a:ext uri="{FF2B5EF4-FFF2-40B4-BE49-F238E27FC236}">
-                <a16:creationId xmlns:a16="http://schemas.microsoft.com/office/drawing/2014/main" id="{6531451B-1DAB-EAF3-5EC0-93BCFB807E5D}"/>
+                <a16:creationId xmlns:a16="http://schemas.microsoft.com/office/drawing/2014/main" id="{B8D370F3-0086-4F15-C738-87CDAB5AF620}"/>
               </a:ext>
             </a:extLst>
           </p:cNvPr>
@@ -7195,8 +7195,8 @@
         </p:nvSpPr>
         <p:spPr>
           <a:xfrm>
-            <a:off x="7506601" y="3454266"/>
-            <a:ext cx="731502" cy="285806"/>
+            <a:off x="7489184" y="3558941"/>
+            <a:ext cx="766335" cy="285806"/>
           </a:xfrm>
           <a:prstGeom prst="rect">
             <a:avLst/>
@@ -7232,7 +7232,7 @@
           <p:cNvPr id="83" name="recipes_line_1">
             <a:extLst>
               <a:ext uri="{FF2B5EF4-FFF2-40B4-BE49-F238E27FC236}">
-                <a16:creationId xmlns:a16="http://schemas.microsoft.com/office/drawing/2014/main" id="{72C4C9F6-2082-005D-C7D2-EE5DC6C02EBA}"/>
+                <a16:creationId xmlns:a16="http://schemas.microsoft.com/office/drawing/2014/main" id="{78FABCB7-B861-1696-C479-DC0889C53CBD}"/>
               </a:ext>
             </a:extLst>
           </p:cNvPr>
@@ -7241,8 +7241,8 @@
         </p:nvSpPr>
         <p:spPr>
           <a:xfrm>
-            <a:off x="7506601" y="3628724"/>
-            <a:ext cx="731502" cy="285806"/>
+            <a:off x="7489184" y="3733399"/>
+            <a:ext cx="766335" cy="285806"/>
           </a:xfrm>
           <a:prstGeom prst="rect">
             <a:avLst/>
@@ -7278,7 +7278,7 @@
           <p:cNvPr id="84" name="theme_card">
             <a:extLst>
               <a:ext uri="{FF2B5EF4-FFF2-40B4-BE49-F238E27FC236}">
-                <a16:creationId xmlns:a16="http://schemas.microsoft.com/office/drawing/2014/main" id="{DBED94EA-E652-F291-7CA2-DBC6F1E70E08}"/>
+                <a16:creationId xmlns:a16="http://schemas.microsoft.com/office/drawing/2014/main" id="{B5241DB1-DBAD-EA67-09FD-33F8F200CD77}"/>
               </a:ext>
             </a:extLst>
           </p:cNvPr>
@@ -7287,8 +7287,8 @@
         </p:nvSpPr>
         <p:spPr>
           <a:xfrm>
-            <a:off x="8455812" y="2948338"/>
-            <a:ext cx="1010169" cy="872290"/>
+            <a:off x="8534187" y="3053013"/>
+            <a:ext cx="1079835" cy="889735"/>
           </a:xfrm>
           <a:prstGeom prst="roundRect">
             <a:avLst/>
@@ -7339,7 +7339,7 @@
           <p:cNvPr id="85" name="theme_icon_dot">
             <a:extLst>
               <a:ext uri="{FF2B5EF4-FFF2-40B4-BE49-F238E27FC236}">
-                <a16:creationId xmlns:a16="http://schemas.microsoft.com/office/drawing/2014/main" id="{0A6765A4-653D-4D94-724F-C7FC511E4D7A}"/>
+                <a16:creationId xmlns:a16="http://schemas.microsoft.com/office/drawing/2014/main" id="{4B492044-748F-7343-C7B7-9755496DE90B}"/>
               </a:ext>
             </a:extLst>
           </p:cNvPr>
@@ -7348,7 +7348,7 @@
         </p:nvSpPr>
         <p:spPr>
           <a:xfrm>
-            <a:off x="8569020" y="3148965"/>
+            <a:off x="8656103" y="3253640"/>
             <a:ext cx="139334" cy="139566"/>
           </a:xfrm>
           <a:prstGeom prst="ellipse">
@@ -7393,7 +7393,7 @@
           <p:cNvPr id="86" name="theme_icon_label">
             <a:extLst>
               <a:ext uri="{FF2B5EF4-FFF2-40B4-BE49-F238E27FC236}">
-                <a16:creationId xmlns:a16="http://schemas.microsoft.com/office/drawing/2014/main" id="{FD8AA493-EA8D-EF0F-D39A-BC8DA32114EF}"/>
+                <a16:creationId xmlns:a16="http://schemas.microsoft.com/office/drawing/2014/main" id="{FDEDA045-B4DC-53C2-606D-96BC7B9D8293}"/>
               </a:ext>
             </a:extLst>
           </p:cNvPr>
@@ -7402,7 +7402,7 @@
         </p:nvSpPr>
         <p:spPr>
           <a:xfrm>
-            <a:off x="8569020" y="3154548"/>
+            <a:off x="8656103" y="3259222"/>
             <a:ext cx="139334" cy="285806"/>
           </a:xfrm>
           <a:prstGeom prst="rect">
@@ -7440,7 +7440,7 @@
           <p:cNvPr id="87" name="theme_title">
             <a:extLst>
               <a:ext uri="{FF2B5EF4-FFF2-40B4-BE49-F238E27FC236}">
-                <a16:creationId xmlns:a16="http://schemas.microsoft.com/office/drawing/2014/main" id="{DA1A2A2D-856D-62FA-6ACE-1CF580EECEFC}"/>
+                <a16:creationId xmlns:a16="http://schemas.microsoft.com/office/drawing/2014/main" id="{339967DC-886A-F29F-616D-B64741FED118}"/>
               </a:ext>
             </a:extLst>
           </p:cNvPr>
@@ -7449,8 +7449,8 @@
         </p:nvSpPr>
         <p:spPr>
           <a:xfrm>
-            <a:off x="8778021" y="3114073"/>
-            <a:ext cx="618293" cy="285806"/>
+            <a:off x="8899937" y="3218748"/>
+            <a:ext cx="592168" cy="285806"/>
           </a:xfrm>
           <a:prstGeom prst="rect">
             <a:avLst/>
@@ -7486,7 +7486,7 @@
           <p:cNvPr id="88" name="theme_line_0">
             <a:extLst>
               <a:ext uri="{FF2B5EF4-FFF2-40B4-BE49-F238E27FC236}">
-                <a16:creationId xmlns:a16="http://schemas.microsoft.com/office/drawing/2014/main" id="{F8A12BD6-C8D6-CE99-1BBD-9E746BB5A856}"/>
+                <a16:creationId xmlns:a16="http://schemas.microsoft.com/office/drawing/2014/main" id="{C72CCBC2-7DBA-EB44-C8FF-D162B178FE2E}"/>
               </a:ext>
             </a:extLst>
           </p:cNvPr>
@@ -7495,8 +7495,8 @@
         </p:nvSpPr>
         <p:spPr>
           <a:xfrm>
-            <a:off x="8629979" y="3454266"/>
-            <a:ext cx="731502" cy="285806"/>
+            <a:off x="8725770" y="3558941"/>
+            <a:ext cx="766335" cy="285806"/>
           </a:xfrm>
           <a:prstGeom prst="rect">
             <a:avLst/>
@@ -7532,7 +7532,7 @@
           <p:cNvPr id="89" name="theme_line_1">
             <a:extLst>
               <a:ext uri="{FF2B5EF4-FFF2-40B4-BE49-F238E27FC236}">
-                <a16:creationId xmlns:a16="http://schemas.microsoft.com/office/drawing/2014/main" id="{999DD06F-2559-CE9D-4F84-F186FA5E689C}"/>
+                <a16:creationId xmlns:a16="http://schemas.microsoft.com/office/drawing/2014/main" id="{B1C74A5B-468A-2E2C-B368-B89F4E7EFCE0}"/>
               </a:ext>
             </a:extLst>
           </p:cNvPr>
@@ -7541,8 +7541,8 @@
         </p:nvSpPr>
         <p:spPr>
           <a:xfrm>
-            <a:off x="8629979" y="3628724"/>
-            <a:ext cx="731502" cy="285806"/>
+            <a:off x="8725770" y="3733399"/>
+            <a:ext cx="766335" cy="285806"/>
           </a:xfrm>
           <a:prstGeom prst="rect">
             <a:avLst/>
@@ -7578,7 +7578,7 @@
           <p:cNvPr id="90" name="compose_card">
             <a:extLst>
               <a:ext uri="{FF2B5EF4-FFF2-40B4-BE49-F238E27FC236}">
-                <a16:creationId xmlns:a16="http://schemas.microsoft.com/office/drawing/2014/main" id="{2CBC28BC-A83A-97E9-1E22-BA353A61BE36}"/>
+                <a16:creationId xmlns:a16="http://schemas.microsoft.com/office/drawing/2014/main" id="{0AA228E3-1416-8FD4-B368-54EF31765415}"/>
               </a:ext>
             </a:extLst>
           </p:cNvPr>
@@ -7587,8 +7587,8 @@
         </p:nvSpPr>
         <p:spPr>
           <a:xfrm>
-            <a:off x="6209056" y="4047423"/>
-            <a:ext cx="1010169" cy="872289"/>
+            <a:off x="6061014" y="4047423"/>
+            <a:ext cx="1079836" cy="889735"/>
           </a:xfrm>
           <a:prstGeom prst="roundRect">
             <a:avLst/>
@@ -7639,7 +7639,7 @@
           <p:cNvPr id="91" name="compose_icon_dot">
             <a:extLst>
               <a:ext uri="{FF2B5EF4-FFF2-40B4-BE49-F238E27FC236}">
-                <a16:creationId xmlns:a16="http://schemas.microsoft.com/office/drawing/2014/main" id="{FA300DFC-019B-9465-801F-BD119ADB2B17}"/>
+                <a16:creationId xmlns:a16="http://schemas.microsoft.com/office/drawing/2014/main" id="{048C2BF9-ABC8-3E3D-7D92-447980C69535}"/>
               </a:ext>
             </a:extLst>
           </p:cNvPr>
@@ -7648,7 +7648,7 @@
         </p:nvSpPr>
         <p:spPr>
           <a:xfrm>
-            <a:off x="6322265" y="4248050"/>
+            <a:off x="6182931" y="4248050"/>
             <a:ext cx="139334" cy="139566"/>
           </a:xfrm>
           <a:prstGeom prst="ellipse">
@@ -7693,7 +7693,7 @@
           <p:cNvPr id="92" name="compose_icon_label">
             <a:extLst>
               <a:ext uri="{FF2B5EF4-FFF2-40B4-BE49-F238E27FC236}">
-                <a16:creationId xmlns:a16="http://schemas.microsoft.com/office/drawing/2014/main" id="{DB648192-C431-A2A4-6AEC-F482331D5638}"/>
+                <a16:creationId xmlns:a16="http://schemas.microsoft.com/office/drawing/2014/main" id="{7A0AA5C0-925A-796F-70BE-4267090234B1}"/>
               </a:ext>
             </a:extLst>
           </p:cNvPr>
@@ -7702,7 +7702,7 @@
         </p:nvSpPr>
         <p:spPr>
           <a:xfrm>
-            <a:off x="6322265" y="4253632"/>
+            <a:off x="6182931" y="4253632"/>
             <a:ext cx="139334" cy="285806"/>
           </a:xfrm>
           <a:prstGeom prst="rect">
@@ -7740,7 +7740,7 @@
           <p:cNvPr id="93" name="compose_title">
             <a:extLst>
               <a:ext uri="{FF2B5EF4-FFF2-40B4-BE49-F238E27FC236}">
-                <a16:creationId xmlns:a16="http://schemas.microsoft.com/office/drawing/2014/main" id="{5CBE7730-393C-91AB-8163-A553EE4FE3E2}"/>
+                <a16:creationId xmlns:a16="http://schemas.microsoft.com/office/drawing/2014/main" id="{A1CC0D6C-5674-5248-61DE-020B77F12816}"/>
               </a:ext>
             </a:extLst>
           </p:cNvPr>
@@ -7749,8 +7749,8 @@
         </p:nvSpPr>
         <p:spPr>
           <a:xfrm>
-            <a:off x="6531265" y="4213158"/>
-            <a:ext cx="618293" cy="285806"/>
+            <a:off x="6426765" y="4213158"/>
+            <a:ext cx="592168" cy="285806"/>
           </a:xfrm>
           <a:prstGeom prst="rect">
             <a:avLst/>
@@ -7786,7 +7786,7 @@
           <p:cNvPr id="94" name="compose_line_0">
             <a:extLst>
               <a:ext uri="{FF2B5EF4-FFF2-40B4-BE49-F238E27FC236}">
-                <a16:creationId xmlns:a16="http://schemas.microsoft.com/office/drawing/2014/main" id="{056568FA-E55C-0088-E005-AA04F44A5D09}"/>
+                <a16:creationId xmlns:a16="http://schemas.microsoft.com/office/drawing/2014/main" id="{51DFD3F1-EA8C-A38A-1158-404ED3DD5C36}"/>
               </a:ext>
             </a:extLst>
           </p:cNvPr>
@@ -7795,8 +7795,8 @@
         </p:nvSpPr>
         <p:spPr>
           <a:xfrm>
-            <a:off x="6383223" y="4553351"/>
-            <a:ext cx="731502" cy="285806"/>
+            <a:off x="6252598" y="4553351"/>
+            <a:ext cx="766335" cy="285806"/>
           </a:xfrm>
           <a:prstGeom prst="rect">
             <a:avLst/>
@@ -7832,7 +7832,7 @@
           <p:cNvPr id="95" name="compose_line_1">
             <a:extLst>
               <a:ext uri="{FF2B5EF4-FFF2-40B4-BE49-F238E27FC236}">
-                <a16:creationId xmlns:a16="http://schemas.microsoft.com/office/drawing/2014/main" id="{AC871981-23EB-2032-B13A-F39C6722FB93}"/>
+                <a16:creationId xmlns:a16="http://schemas.microsoft.com/office/drawing/2014/main" id="{797AB9E6-7A55-4CEA-3E4A-B436A6BE2FAD}"/>
               </a:ext>
             </a:extLst>
           </p:cNvPr>
@@ -7841,8 +7841,8 @@
         </p:nvSpPr>
         <p:spPr>
           <a:xfrm>
-            <a:off x="6383223" y="4727809"/>
-            <a:ext cx="731502" cy="285806"/>
+            <a:off x="6252598" y="4727809"/>
+            <a:ext cx="766335" cy="285806"/>
           </a:xfrm>
           <a:prstGeom prst="rect">
             <a:avLst/>
@@ -7878,7 +7878,7 @@
           <p:cNvPr id="96" name="objects_card">
             <a:extLst>
               <a:ext uri="{FF2B5EF4-FFF2-40B4-BE49-F238E27FC236}">
-                <a16:creationId xmlns:a16="http://schemas.microsoft.com/office/drawing/2014/main" id="{5654B933-88CF-8DA9-41FC-F8D1CF5667F9}"/>
+                <a16:creationId xmlns:a16="http://schemas.microsoft.com/office/drawing/2014/main" id="{6859F1C5-5368-C46C-0A09-67F9FD11CA6A}"/>
               </a:ext>
             </a:extLst>
           </p:cNvPr>
@@ -7887,8 +7887,8 @@
         </p:nvSpPr>
         <p:spPr>
           <a:xfrm>
-            <a:off x="7332434" y="4047423"/>
-            <a:ext cx="1010169" cy="872289"/>
+            <a:off x="7297600" y="4047423"/>
+            <a:ext cx="1079836" cy="889735"/>
           </a:xfrm>
           <a:prstGeom prst="roundRect">
             <a:avLst/>
@@ -7939,7 +7939,7 @@
           <p:cNvPr id="97" name="objects_icon_dot">
             <a:extLst>
               <a:ext uri="{FF2B5EF4-FFF2-40B4-BE49-F238E27FC236}">
-                <a16:creationId xmlns:a16="http://schemas.microsoft.com/office/drawing/2014/main" id="{E42CE8F3-2796-72BC-4CDE-E7C169203A31}"/>
+                <a16:creationId xmlns:a16="http://schemas.microsoft.com/office/drawing/2014/main" id="{D7ABCDA0-1C54-3C4F-633D-22231F76A57A}"/>
               </a:ext>
             </a:extLst>
           </p:cNvPr>
@@ -7948,8 +7948,8 @@
         </p:nvSpPr>
         <p:spPr>
           <a:xfrm>
-            <a:off x="7445642" y="4248050"/>
-            <a:ext cx="139334" cy="139566"/>
+            <a:off x="7419518" y="4248050"/>
+            <a:ext cx="139333" cy="139566"/>
           </a:xfrm>
           <a:prstGeom prst="ellipse">
             <a:avLst/>
@@ -7993,7 +7993,7 @@
           <p:cNvPr id="98" name="objects_icon_label">
             <a:extLst>
               <a:ext uri="{FF2B5EF4-FFF2-40B4-BE49-F238E27FC236}">
-                <a16:creationId xmlns:a16="http://schemas.microsoft.com/office/drawing/2014/main" id="{8DF0E87F-7D5F-3C08-BA66-5B17480D42BF}"/>
+                <a16:creationId xmlns:a16="http://schemas.microsoft.com/office/drawing/2014/main" id="{5C7F0183-33A4-50EF-CEE5-1B90E2F38E00}"/>
               </a:ext>
             </a:extLst>
           </p:cNvPr>
@@ -8002,7 +8002,7 @@
         </p:nvSpPr>
         <p:spPr>
           <a:xfrm>
-            <a:off x="7445642" y="4253632"/>
+            <a:off x="7419518" y="4253632"/>
             <a:ext cx="139334" cy="285806"/>
           </a:xfrm>
           <a:prstGeom prst="rect">
@@ -8040,7 +8040,7 @@
           <p:cNvPr id="99" name="objects_title">
             <a:extLst>
               <a:ext uri="{FF2B5EF4-FFF2-40B4-BE49-F238E27FC236}">
-                <a16:creationId xmlns:a16="http://schemas.microsoft.com/office/drawing/2014/main" id="{B1B33239-7D2B-CF3E-C063-6C5390EECC2E}"/>
+                <a16:creationId xmlns:a16="http://schemas.microsoft.com/office/drawing/2014/main" id="{7713DC7B-2A93-1327-DC19-13B88073BE2E}"/>
               </a:ext>
             </a:extLst>
           </p:cNvPr>
@@ -8049,8 +8049,8 @@
         </p:nvSpPr>
         <p:spPr>
           <a:xfrm>
-            <a:off x="7654643" y="4213158"/>
-            <a:ext cx="618293" cy="285806"/>
+            <a:off x="7663352" y="4213158"/>
+            <a:ext cx="592168" cy="285806"/>
           </a:xfrm>
           <a:prstGeom prst="rect">
             <a:avLst/>
@@ -8086,7 +8086,7 @@
           <p:cNvPr id="100" name="objects_line_0">
             <a:extLst>
               <a:ext uri="{FF2B5EF4-FFF2-40B4-BE49-F238E27FC236}">
-                <a16:creationId xmlns:a16="http://schemas.microsoft.com/office/drawing/2014/main" id="{54D557BD-5A89-DFF1-7DE6-6E1B8D0D98CB}"/>
+                <a16:creationId xmlns:a16="http://schemas.microsoft.com/office/drawing/2014/main" id="{C1C5665C-2F2B-6B4F-1307-06EC7D921C1A}"/>
               </a:ext>
             </a:extLst>
           </p:cNvPr>
@@ -8095,8 +8095,8 @@
         </p:nvSpPr>
         <p:spPr>
           <a:xfrm>
-            <a:off x="7506601" y="4553351"/>
-            <a:ext cx="731502" cy="285806"/>
+            <a:off x="7489184" y="4553351"/>
+            <a:ext cx="766335" cy="285806"/>
           </a:xfrm>
           <a:prstGeom prst="rect">
             <a:avLst/>
@@ -8132,7 +8132,7 @@
           <p:cNvPr id="101" name="objects_line_1">
             <a:extLst>
               <a:ext uri="{FF2B5EF4-FFF2-40B4-BE49-F238E27FC236}">
-                <a16:creationId xmlns:a16="http://schemas.microsoft.com/office/drawing/2014/main" id="{5583A870-FA42-5EF4-A6EC-556898E22AB9}"/>
+                <a16:creationId xmlns:a16="http://schemas.microsoft.com/office/drawing/2014/main" id="{4046ADB8-AD61-14E0-BA8F-5B4A97ADA2BA}"/>
               </a:ext>
             </a:extLst>
           </p:cNvPr>
@@ -8141,8 +8141,8 @@
         </p:nvSpPr>
         <p:spPr>
           <a:xfrm>
-            <a:off x="7506601" y="4727809"/>
-            <a:ext cx="731502" cy="285806"/>
+            <a:off x="7489184" y="4727809"/>
+            <a:ext cx="766335" cy="285806"/>
           </a:xfrm>
           <a:prstGeom prst="rect">
             <a:avLst/>
@@ -8178,7 +8178,7 @@
           <p:cNvPr id="102" name="decorate_card">
             <a:extLst>
               <a:ext uri="{FF2B5EF4-FFF2-40B4-BE49-F238E27FC236}">
-                <a16:creationId xmlns:a16="http://schemas.microsoft.com/office/drawing/2014/main" id="{E9837E25-0671-CD25-17A4-D8E769BDDC90}"/>
+                <a16:creationId xmlns:a16="http://schemas.microsoft.com/office/drawing/2014/main" id="{B7406077-1529-ACBE-EB4C-9766096DD24B}"/>
               </a:ext>
             </a:extLst>
           </p:cNvPr>
@@ -8187,8 +8187,8 @@
         </p:nvSpPr>
         <p:spPr>
           <a:xfrm>
-            <a:off x="8455812" y="4047423"/>
-            <a:ext cx="1010169" cy="872289"/>
+            <a:off x="8534187" y="4047423"/>
+            <a:ext cx="1079835" cy="889735"/>
           </a:xfrm>
           <a:prstGeom prst="roundRect">
             <a:avLst/>
@@ -8239,7 +8239,7 @@
           <p:cNvPr id="103" name="decorate_icon_dot">
             <a:extLst>
               <a:ext uri="{FF2B5EF4-FFF2-40B4-BE49-F238E27FC236}">
-                <a16:creationId xmlns:a16="http://schemas.microsoft.com/office/drawing/2014/main" id="{0249FE43-FDF7-63C0-EB7C-09FCA9A3B18A}"/>
+                <a16:creationId xmlns:a16="http://schemas.microsoft.com/office/drawing/2014/main" id="{B8FFC9CD-15B9-4E2B-298D-1CB4F028158C}"/>
               </a:ext>
             </a:extLst>
           </p:cNvPr>
@@ -8248,7 +8248,7 @@
         </p:nvSpPr>
         <p:spPr>
           <a:xfrm>
-            <a:off x="8569020" y="4248050"/>
+            <a:off x="8656103" y="4248050"/>
             <a:ext cx="139334" cy="139566"/>
           </a:xfrm>
           <a:prstGeom prst="ellipse">
@@ -8293,7 +8293,7 @@
           <p:cNvPr id="104" name="decorate_icon_label">
             <a:extLst>
               <a:ext uri="{FF2B5EF4-FFF2-40B4-BE49-F238E27FC236}">
-                <a16:creationId xmlns:a16="http://schemas.microsoft.com/office/drawing/2014/main" id="{C23B418A-7E47-CBAF-8429-DB25749FC62F}"/>
+                <a16:creationId xmlns:a16="http://schemas.microsoft.com/office/drawing/2014/main" id="{8F72E0E4-E0AA-1B9C-9B8D-653D642143B8}"/>
               </a:ext>
             </a:extLst>
           </p:cNvPr>
@@ -8302,7 +8302,7 @@
         </p:nvSpPr>
         <p:spPr>
           <a:xfrm>
-            <a:off x="8569020" y="4253632"/>
+            <a:off x="8656103" y="4253632"/>
             <a:ext cx="139334" cy="285806"/>
           </a:xfrm>
           <a:prstGeom prst="rect">
@@ -8340,7 +8340,7 @@
           <p:cNvPr id="105" name="decorate_title">
             <a:extLst>
               <a:ext uri="{FF2B5EF4-FFF2-40B4-BE49-F238E27FC236}">
-                <a16:creationId xmlns:a16="http://schemas.microsoft.com/office/drawing/2014/main" id="{12A236B7-6A3F-3621-08C7-43907B2F40EE}"/>
+                <a16:creationId xmlns:a16="http://schemas.microsoft.com/office/drawing/2014/main" id="{8E2249AF-7BD8-A307-B018-E737DAE83966}"/>
               </a:ext>
             </a:extLst>
           </p:cNvPr>
@@ -8349,8 +8349,8 @@
         </p:nvSpPr>
         <p:spPr>
           <a:xfrm>
-            <a:off x="8778021" y="4213158"/>
-            <a:ext cx="618293" cy="285806"/>
+            <a:off x="8899937" y="4213158"/>
+            <a:ext cx="592168" cy="285806"/>
           </a:xfrm>
           <a:prstGeom prst="rect">
             <a:avLst/>
@@ -8386,7 +8386,7 @@
           <p:cNvPr id="106" name="decorate_line_0">
             <a:extLst>
               <a:ext uri="{FF2B5EF4-FFF2-40B4-BE49-F238E27FC236}">
-                <a16:creationId xmlns:a16="http://schemas.microsoft.com/office/drawing/2014/main" id="{9DEBECD1-B202-CF8F-1BAC-82E0F0A7DF49}"/>
+                <a16:creationId xmlns:a16="http://schemas.microsoft.com/office/drawing/2014/main" id="{15815D48-3CC4-0897-DD21-280C9FC52FAE}"/>
               </a:ext>
             </a:extLst>
           </p:cNvPr>
@@ -8395,8 +8395,8 @@
         </p:nvSpPr>
         <p:spPr>
           <a:xfrm>
-            <a:off x="8629979" y="4553351"/>
-            <a:ext cx="731502" cy="285806"/>
+            <a:off x="8725770" y="4553351"/>
+            <a:ext cx="766335" cy="285806"/>
           </a:xfrm>
           <a:prstGeom prst="rect">
             <a:avLst/>
@@ -8432,7 +8432,7 @@
           <p:cNvPr id="107" name="decorate_line_1">
             <a:extLst>
               <a:ext uri="{FF2B5EF4-FFF2-40B4-BE49-F238E27FC236}">
-                <a16:creationId xmlns:a16="http://schemas.microsoft.com/office/drawing/2014/main" id="{73C4714C-8DE2-9E64-C9F8-C0BF3031D454}"/>
+                <a16:creationId xmlns:a16="http://schemas.microsoft.com/office/drawing/2014/main" id="{E67EF8EC-CB38-657C-4148-A89A56A49274}"/>
               </a:ext>
             </a:extLst>
           </p:cNvPr>
@@ -8441,8 +8441,8 @@
         </p:nvSpPr>
         <p:spPr>
           <a:xfrm>
-            <a:off x="8629979" y="4727809"/>
-            <a:ext cx="731502" cy="285806"/>
+            <a:off x="8725770" y="4727809"/>
+            <a:ext cx="766335" cy="285806"/>
           </a:xfrm>
           <a:prstGeom prst="rect">
             <a:avLst/>
@@ -8478,7 +8478,7 @@
           <p:cNvPr id="108" name="styled_ir_card">
             <a:extLst>
               <a:ext uri="{FF2B5EF4-FFF2-40B4-BE49-F238E27FC236}">
-                <a16:creationId xmlns:a16="http://schemas.microsoft.com/office/drawing/2014/main" id="{B5F533A2-1111-8081-E30F-B750D63F7FF8}"/>
+                <a16:creationId xmlns:a16="http://schemas.microsoft.com/office/drawing/2014/main" id="{710B73CC-0D39-F327-18F0-658D9EA488B7}"/>
               </a:ext>
             </a:extLst>
           </p:cNvPr>
@@ -8487,8 +8487,8 @@
         </p:nvSpPr>
         <p:spPr>
           <a:xfrm>
-            <a:off x="9971065" y="2036796"/>
-            <a:ext cx="1741671" cy="915904"/>
+            <a:off x="10075566" y="2076049"/>
+            <a:ext cx="1706837" cy="915904"/>
           </a:xfrm>
           <a:prstGeom prst="roundRect">
             <a:avLst/>
@@ -8539,7 +8539,7 @@
           <p:cNvPr id="109" name="styled_ir_icon_dot">
             <a:extLst>
               <a:ext uri="{FF2B5EF4-FFF2-40B4-BE49-F238E27FC236}">
-                <a16:creationId xmlns:a16="http://schemas.microsoft.com/office/drawing/2014/main" id="{1DFBB19D-A283-6121-ADA9-A39FA11ED9E7}"/>
+                <a16:creationId xmlns:a16="http://schemas.microsoft.com/office/drawing/2014/main" id="{41779A82-955E-2EB4-4B5E-E3C9ADD2A235}"/>
               </a:ext>
             </a:extLst>
           </p:cNvPr>
@@ -8548,8 +8548,8 @@
         </p:nvSpPr>
         <p:spPr>
           <a:xfrm>
-            <a:off x="10127815" y="2263591"/>
-            <a:ext cx="191584" cy="191904"/>
+            <a:off x="10249733" y="2302844"/>
+            <a:ext cx="191583" cy="191904"/>
           </a:xfrm>
           <a:prstGeom prst="ellipse">
             <a:avLst/>
@@ -8593,7 +8593,7 @@
           <p:cNvPr id="110" name="styled_ir_icon_label">
             <a:extLst>
               <a:ext uri="{FF2B5EF4-FFF2-40B4-BE49-F238E27FC236}">
-                <a16:creationId xmlns:a16="http://schemas.microsoft.com/office/drawing/2014/main" id="{A240514E-14B0-27A6-0CA1-410C1BBC5299}"/>
+                <a16:creationId xmlns:a16="http://schemas.microsoft.com/office/drawing/2014/main" id="{6B288165-010E-FFD7-81D5-6A6D497A3B37}"/>
               </a:ext>
             </a:extLst>
           </p:cNvPr>
@@ -8602,7 +8602,7 @@
         </p:nvSpPr>
         <p:spPr>
           <a:xfrm>
-            <a:off x="10127815" y="2271267"/>
+            <a:off x="10249733" y="2310520"/>
             <a:ext cx="191584" cy="285806"/>
           </a:xfrm>
           <a:prstGeom prst="rect">
@@ -8640,7 +8640,7 @@
           <p:cNvPr id="111" name="styled_ir_title">
             <a:extLst>
               <a:ext uri="{FF2B5EF4-FFF2-40B4-BE49-F238E27FC236}">
-                <a16:creationId xmlns:a16="http://schemas.microsoft.com/office/drawing/2014/main" id="{12FA0D02-9ECB-22CE-7783-8D9D720871AE}"/>
+                <a16:creationId xmlns:a16="http://schemas.microsoft.com/office/drawing/2014/main" id="{69E6C2AB-BA03-F293-4FE7-94C0DCF67B01}"/>
               </a:ext>
             </a:extLst>
           </p:cNvPr>
@@ -8649,8 +8649,8 @@
         </p:nvSpPr>
         <p:spPr>
           <a:xfrm>
-            <a:off x="10432607" y="2254868"/>
-            <a:ext cx="1210461" cy="285806"/>
+            <a:off x="10580650" y="2294121"/>
+            <a:ext cx="1079836" cy="285806"/>
           </a:xfrm>
           <a:prstGeom prst="rect">
             <a:avLst/>
@@ -8664,7 +8664,7 @@
           <a:lstStyle/>
           <a:p>
             <a:r>
-              <a:rPr lang="en-US" altLang="ko-KR" sz="1168" b="1">
+              <a:rPr lang="en-US" altLang="ko-KR" sz="1095" b="1">
                 <a:solidFill>
                   <a:srgbClr val="111827"/>
                 </a:solidFill>
@@ -8672,7 +8672,7 @@
               </a:rPr>
               <a:t>Styled Deck IR</a:t>
             </a:r>
-            <a:endParaRPr lang="ko-KR" altLang="en-US" sz="1168" b="1">
+            <a:endParaRPr lang="ko-KR" altLang="en-US" sz="1095" b="1">
               <a:solidFill>
                 <a:srgbClr val="111827"/>
               </a:solidFill>
@@ -8686,7 +8686,7 @@
           <p:cNvPr id="112" name="styled_ir_line_0">
             <a:extLst>
               <a:ext uri="{FF2B5EF4-FFF2-40B4-BE49-F238E27FC236}">
-                <a16:creationId xmlns:a16="http://schemas.microsoft.com/office/drawing/2014/main" id="{2C19E6FA-3DF9-C21D-0615-A4ACE232D888}"/>
+                <a16:creationId xmlns:a16="http://schemas.microsoft.com/office/drawing/2014/main" id="{47E6F79F-12AC-8329-7F30-7349957CA439}"/>
               </a:ext>
             </a:extLst>
           </p:cNvPr>
@@ -8695,8 +8695,8 @@
         </p:nvSpPr>
         <p:spPr>
           <a:xfrm>
-            <a:off x="10223607" y="2595061"/>
-            <a:ext cx="1384628" cy="285806"/>
+            <a:off x="10362941" y="2634314"/>
+            <a:ext cx="1297545" cy="285806"/>
           </a:xfrm>
           <a:prstGeom prst="rect">
             <a:avLst/>
@@ -8732,7 +8732,7 @@
           <p:cNvPr id="113" name="styled_ir_line_1">
             <a:extLst>
               <a:ext uri="{FF2B5EF4-FFF2-40B4-BE49-F238E27FC236}">
-                <a16:creationId xmlns:a16="http://schemas.microsoft.com/office/drawing/2014/main" id="{B3484CC4-B2D3-3B8B-94E9-2BAE74B61890}"/>
+                <a16:creationId xmlns:a16="http://schemas.microsoft.com/office/drawing/2014/main" id="{FFB00C68-D393-1383-CA88-C1087699D5B1}"/>
               </a:ext>
             </a:extLst>
           </p:cNvPr>
@@ -8741,8 +8741,8 @@
         </p:nvSpPr>
         <p:spPr>
           <a:xfrm>
-            <a:off x="10223607" y="2760796"/>
-            <a:ext cx="1384628" cy="285806"/>
+            <a:off x="10362941" y="2800049"/>
+            <a:ext cx="1297545" cy="285806"/>
           </a:xfrm>
           <a:prstGeom prst="rect">
             <a:avLst/>
@@ -8778,7 +8778,7 @@
           <p:cNvPr id="114" name="renderers_card">
             <a:extLst>
               <a:ext uri="{FF2B5EF4-FFF2-40B4-BE49-F238E27FC236}">
-                <a16:creationId xmlns:a16="http://schemas.microsoft.com/office/drawing/2014/main" id="{B798357B-D1F0-F668-8020-4BC4521E2D2A}"/>
+                <a16:creationId xmlns:a16="http://schemas.microsoft.com/office/drawing/2014/main" id="{5196DBDE-33B4-37A9-2013-F3510F84581D}"/>
               </a:ext>
             </a:extLst>
           </p:cNvPr>
@@ -8787,8 +8787,8 @@
         </p:nvSpPr>
         <p:spPr>
           <a:xfrm>
-            <a:off x="9971065" y="3401929"/>
-            <a:ext cx="1741671" cy="915904"/>
+            <a:off x="10075566" y="3401929"/>
+            <a:ext cx="1706837" cy="915904"/>
           </a:xfrm>
           <a:prstGeom prst="roundRect">
             <a:avLst/>
@@ -8839,7 +8839,7 @@
           <p:cNvPr id="115" name="renderers_icon_dot">
             <a:extLst>
               <a:ext uri="{FF2B5EF4-FFF2-40B4-BE49-F238E27FC236}">
-                <a16:creationId xmlns:a16="http://schemas.microsoft.com/office/drawing/2014/main" id="{1E597368-54E5-4F62-0200-CF69B47FAA1F}"/>
+                <a16:creationId xmlns:a16="http://schemas.microsoft.com/office/drawing/2014/main" id="{EA8C46E3-394B-464E-3AA3-3B6309541AD9}"/>
               </a:ext>
             </a:extLst>
           </p:cNvPr>
@@ -8848,8 +8848,8 @@
         </p:nvSpPr>
         <p:spPr>
           <a:xfrm>
-            <a:off x="10127815" y="3628724"/>
-            <a:ext cx="191584" cy="191904"/>
+            <a:off x="10249733" y="3628724"/>
+            <a:ext cx="191583" cy="191904"/>
           </a:xfrm>
           <a:prstGeom prst="ellipse">
             <a:avLst/>
@@ -8893,7 +8893,7 @@
           <p:cNvPr id="116" name="renderers_icon_label">
             <a:extLst>
               <a:ext uri="{FF2B5EF4-FFF2-40B4-BE49-F238E27FC236}">
-                <a16:creationId xmlns:a16="http://schemas.microsoft.com/office/drawing/2014/main" id="{8CF317E5-EF82-C39E-D23B-32D63C584844}"/>
+                <a16:creationId xmlns:a16="http://schemas.microsoft.com/office/drawing/2014/main" id="{E1E4F79A-DB90-AA54-D060-63A142327A1C}"/>
               </a:ext>
             </a:extLst>
           </p:cNvPr>
@@ -8902,7 +8902,7 @@
         </p:nvSpPr>
         <p:spPr>
           <a:xfrm>
-            <a:off x="10127815" y="3636401"/>
+            <a:off x="10249733" y="3636401"/>
             <a:ext cx="191584" cy="285806"/>
           </a:xfrm>
           <a:prstGeom prst="rect">
@@ -8940,7 +8940,7 @@
           <p:cNvPr id="117" name="renderers_title">
             <a:extLst>
               <a:ext uri="{FF2B5EF4-FFF2-40B4-BE49-F238E27FC236}">
-                <a16:creationId xmlns:a16="http://schemas.microsoft.com/office/drawing/2014/main" id="{164A5BBB-EA70-90B9-FA9B-C8A5F9CDD265}"/>
+                <a16:creationId xmlns:a16="http://schemas.microsoft.com/office/drawing/2014/main" id="{CEA48883-E954-65D9-7E65-55CD4F215E36}"/>
               </a:ext>
             </a:extLst>
           </p:cNvPr>
@@ -8949,8 +8949,8 @@
         </p:nvSpPr>
         <p:spPr>
           <a:xfrm>
-            <a:off x="10432607" y="3620001"/>
-            <a:ext cx="1210461" cy="285806"/>
+            <a:off x="10580650" y="3620001"/>
+            <a:ext cx="1079836" cy="285806"/>
           </a:xfrm>
           <a:prstGeom prst="rect">
             <a:avLst/>
@@ -8964,7 +8964,7 @@
           <a:lstStyle/>
           <a:p>
             <a:r>
-              <a:rPr lang="en-US" altLang="ko-KR" sz="1168" b="1">
+              <a:rPr lang="en-US" altLang="ko-KR" sz="1095" b="1">
                 <a:solidFill>
                   <a:srgbClr val="111827"/>
                 </a:solidFill>
@@ -8972,7 +8972,7 @@
               </a:rPr>
               <a:t>Renderers</a:t>
             </a:r>
-            <a:endParaRPr lang="ko-KR" altLang="en-US" sz="1168" b="1">
+            <a:endParaRPr lang="ko-KR" altLang="en-US" sz="1095" b="1">
               <a:solidFill>
                 <a:srgbClr val="111827"/>
               </a:solidFill>
@@ -8986,7 +8986,7 @@
           <p:cNvPr id="118" name="renderers_line_0">
             <a:extLst>
               <a:ext uri="{FF2B5EF4-FFF2-40B4-BE49-F238E27FC236}">
-                <a16:creationId xmlns:a16="http://schemas.microsoft.com/office/drawing/2014/main" id="{C725CB7C-AE93-988E-1BE9-8486881953CE}"/>
+                <a16:creationId xmlns:a16="http://schemas.microsoft.com/office/drawing/2014/main" id="{00CC0E90-D150-8657-8ED5-CA08C6002136}"/>
               </a:ext>
             </a:extLst>
           </p:cNvPr>
@@ -8995,8 +8995,8 @@
         </p:nvSpPr>
         <p:spPr>
           <a:xfrm>
-            <a:off x="10223607" y="3960194"/>
-            <a:ext cx="1384628" cy="285806"/>
+            <a:off x="10362941" y="3960194"/>
+            <a:ext cx="1297545" cy="285806"/>
           </a:xfrm>
           <a:prstGeom prst="rect">
             <a:avLst/>
@@ -9032,7 +9032,7 @@
           <p:cNvPr id="119" name="renderers_line_1">
             <a:extLst>
               <a:ext uri="{FF2B5EF4-FFF2-40B4-BE49-F238E27FC236}">
-                <a16:creationId xmlns:a16="http://schemas.microsoft.com/office/drawing/2014/main" id="{5A9C0846-86CF-53A3-2E05-6853C60DF5BA}"/>
+                <a16:creationId xmlns:a16="http://schemas.microsoft.com/office/drawing/2014/main" id="{6AC0FF05-619B-6619-7989-109A03571A02}"/>
               </a:ext>
             </a:extLst>
           </p:cNvPr>
@@ -9041,8 +9041,8 @@
         </p:nvSpPr>
         <p:spPr>
           <a:xfrm>
-            <a:off x="10223607" y="4125929"/>
-            <a:ext cx="1384628" cy="285806"/>
+            <a:off x="10362941" y="4125929"/>
+            <a:ext cx="1297545" cy="285806"/>
           </a:xfrm>
           <a:prstGeom prst="rect">
             <a:avLst/>
@@ -9078,7 +9078,7 @@
           <p:cNvPr id="120" name="visual_check">
             <a:extLst>
               <a:ext uri="{FF2B5EF4-FFF2-40B4-BE49-F238E27FC236}">
-                <a16:creationId xmlns:a16="http://schemas.microsoft.com/office/drawing/2014/main" id="{04CD1632-61D4-E307-5B5C-AC44676FF064}"/>
+                <a16:creationId xmlns:a16="http://schemas.microsoft.com/office/drawing/2014/main" id="{840FB578-A723-D350-8AD1-AE21929726A2}"/>
               </a:ext>
             </a:extLst>
           </p:cNvPr>
@@ -9087,8 +9087,8 @@
         </p:nvSpPr>
         <p:spPr>
           <a:xfrm>
-            <a:off x="9927523" y="4466122"/>
-            <a:ext cx="1828755" cy="523373"/>
+            <a:off x="10075566" y="4413785"/>
+            <a:ext cx="1706837" cy="523373"/>
           </a:xfrm>
           <a:prstGeom prst="roundRect">
             <a:avLst/>
@@ -9139,7 +9139,7 @@
           <p:cNvPr id="121" name="visual_check_stripe">
             <a:extLst>
               <a:ext uri="{FF2B5EF4-FFF2-40B4-BE49-F238E27FC236}">
-                <a16:creationId xmlns:a16="http://schemas.microsoft.com/office/drawing/2014/main" id="{14F87290-B6C6-B726-9E66-9A44B50EAE40}"/>
+                <a16:creationId xmlns:a16="http://schemas.microsoft.com/office/drawing/2014/main" id="{5047920E-BFBC-0296-5296-BD32E26230C7}"/>
               </a:ext>
             </a:extLst>
           </p:cNvPr>
@@ -9148,8 +9148,8 @@
         </p:nvSpPr>
         <p:spPr>
           <a:xfrm>
-            <a:off x="9927523" y="4553351"/>
-            <a:ext cx="56605" cy="348916"/>
+            <a:off x="10075566" y="4501014"/>
+            <a:ext cx="56604" cy="348916"/>
           </a:xfrm>
           <a:prstGeom prst="roundRect">
             <a:avLst/>
@@ -9193,7 +9193,7 @@
           <p:cNvPr id="122" name="visual_check_seal_icon_dot">
             <a:extLst>
               <a:ext uri="{FF2B5EF4-FFF2-40B4-BE49-F238E27FC236}">
-                <a16:creationId xmlns:a16="http://schemas.microsoft.com/office/drawing/2014/main" id="{D6482650-1FD1-DAF5-EA5C-E09820F06B38}"/>
+                <a16:creationId xmlns:a16="http://schemas.microsoft.com/office/drawing/2014/main" id="{A248D0CC-26F5-3570-CAD2-CC288B2784A9}"/>
               </a:ext>
             </a:extLst>
           </p:cNvPr>
@@ -9202,8 +9202,8 @@
         </p:nvSpPr>
         <p:spPr>
           <a:xfrm>
-            <a:off x="10023315" y="4579520"/>
-            <a:ext cx="296085" cy="296578"/>
+            <a:off x="10171357" y="4527182"/>
+            <a:ext cx="296085" cy="296579"/>
           </a:xfrm>
           <a:prstGeom prst="ellipse">
             <a:avLst/>
@@ -9247,7 +9247,7 @@
           <p:cNvPr id="123" name="visual_check_seal_icon_label">
             <a:extLst>
               <a:ext uri="{FF2B5EF4-FFF2-40B4-BE49-F238E27FC236}">
-                <a16:creationId xmlns:a16="http://schemas.microsoft.com/office/drawing/2014/main" id="{CF0A6E03-DA69-D3A4-5C2B-EEBBEB8C257C}"/>
+                <a16:creationId xmlns:a16="http://schemas.microsoft.com/office/drawing/2014/main" id="{F1DF1DF9-0631-FE37-1914-A843785C9B4E}"/>
               </a:ext>
             </a:extLst>
           </p:cNvPr>
@@ -9256,7 +9256,7 @@
         </p:nvSpPr>
         <p:spPr>
           <a:xfrm>
-            <a:off x="10023315" y="4591383"/>
+            <a:off x="10171357" y="4539045"/>
             <a:ext cx="296084" cy="285806"/>
           </a:xfrm>
           <a:prstGeom prst="rect">
@@ -9294,7 +9294,7 @@
           <p:cNvPr id="124" name="visual_check_label">
             <a:extLst>
               <a:ext uri="{FF2B5EF4-FFF2-40B4-BE49-F238E27FC236}">
-                <a16:creationId xmlns:a16="http://schemas.microsoft.com/office/drawing/2014/main" id="{5777028A-F86D-0A9C-BFA6-B9ADDB7D99C3}"/>
+                <a16:creationId xmlns:a16="http://schemas.microsoft.com/office/drawing/2014/main" id="{A15D3B39-7D57-DABC-EF09-60C9551F0C1E}"/>
               </a:ext>
             </a:extLst>
           </p:cNvPr>
@@ -9303,8 +9303,8 @@
         </p:nvSpPr>
         <p:spPr>
           <a:xfrm>
-            <a:off x="10415191" y="4570797"/>
-            <a:ext cx="1254003" cy="285806"/>
+            <a:off x="10571942" y="4518459"/>
+            <a:ext cx="1088544" cy="285806"/>
           </a:xfrm>
           <a:prstGeom prst="rect">
             <a:avLst/>
@@ -9340,7 +9340,7 @@
           <p:cNvPr id="125" name="visual_check_text">
             <a:extLst>
               <a:ext uri="{FF2B5EF4-FFF2-40B4-BE49-F238E27FC236}">
-                <a16:creationId xmlns:a16="http://schemas.microsoft.com/office/drawing/2014/main" id="{0EB08A58-0C1C-8B6E-14C7-99C1202DBD41}"/>
+                <a16:creationId xmlns:a16="http://schemas.microsoft.com/office/drawing/2014/main" id="{A6F57D7C-1A98-081B-B89E-1254D34B83D0}"/>
               </a:ext>
             </a:extLst>
           </p:cNvPr>
@@ -9349,8 +9349,8 @@
         </p:nvSpPr>
         <p:spPr>
           <a:xfrm>
-            <a:off x="10415191" y="4753978"/>
-            <a:ext cx="1254003" cy="285806"/>
+            <a:off x="10571942" y="4701640"/>
+            <a:ext cx="1088544" cy="285806"/>
           </a:xfrm>
           <a:prstGeom prst="rect">
             <a:avLst/>
@@ -9364,7 +9364,7 @@
           <a:lstStyle/>
           <a:p>
             <a:r>
-              <a:rPr lang="en-US" altLang="ko-KR" sz="1022" b="1">
+              <a:rPr lang="en-US" altLang="ko-KR" sz="980" b="1">
                 <a:solidFill>
                   <a:srgbClr val="881337"/>
                 </a:solidFill>
@@ -9372,7 +9372,7 @@
               </a:rPr>
               <a:t>visual validation</a:t>
             </a:r>
-            <a:endParaRPr lang="ko-KR" altLang="en-US" sz="1022" b="1">
+            <a:endParaRPr lang="ko-KR" altLang="en-US" sz="980" b="1">
               <a:solidFill>
                 <a:srgbClr val="881337"/>
               </a:solidFill>
@@ -9386,7 +9386,7 @@
           <p:cNvPr id="126" name="coherence_band">
             <a:extLst>
               <a:ext uri="{FF2B5EF4-FFF2-40B4-BE49-F238E27FC236}">
-                <a16:creationId xmlns:a16="http://schemas.microsoft.com/office/drawing/2014/main" id="{3FFFE465-6E3F-800F-FB8E-7ED84197131F}"/>
+                <a16:creationId xmlns:a16="http://schemas.microsoft.com/office/drawing/2014/main" id="{3F9B211E-DC85-6EEF-96F9-BBF8C24CA086}"/>
               </a:ext>
             </a:extLst>
           </p:cNvPr>
@@ -9447,7 +9447,7 @@
           <p:cNvPr id="127" name="coherence_title">
             <a:extLst>
               <a:ext uri="{FF2B5EF4-FFF2-40B4-BE49-F238E27FC236}">
-                <a16:creationId xmlns:a16="http://schemas.microsoft.com/office/drawing/2014/main" id="{1CC9F662-BEDA-C9BC-3F4B-887555821552}"/>
+                <a16:creationId xmlns:a16="http://schemas.microsoft.com/office/drawing/2014/main" id="{6F84F762-BB74-D678-A42F-DAC8F5D53AE7}"/>
               </a:ext>
             </a:extLst>
           </p:cNvPr>
@@ -9493,7 +9493,7 @@
           <p:cNvPr id="128" name="coherence_body">
             <a:extLst>
               <a:ext uri="{FF2B5EF4-FFF2-40B4-BE49-F238E27FC236}">
-                <a16:creationId xmlns:a16="http://schemas.microsoft.com/office/drawing/2014/main" id="{ED2EDA59-3D10-C8EB-8FE0-BF35D2F16703}"/>
+                <a16:creationId xmlns:a16="http://schemas.microsoft.com/office/drawing/2014/main" id="{722D8012-6476-6AD7-9A0D-D03130020566}"/>
               </a:ext>
             </a:extLst>
           </p:cNvPr>
@@ -9537,7 +9537,7 @@
     </p:spTree>
     <p:extLst>
       <p:ext uri="{BB962C8B-B14F-4D97-AF65-F5344CB8AC3E}">
-        <p14:creationId xmlns:p14="http://schemas.microsoft.com/office/powerpoint/2010/main" val="3382768005"/>
+        <p14:creationId xmlns:p14="http://schemas.microsoft.com/office/powerpoint/2010/main" val="3691472564"/>
       </p:ext>
     </p:extLst>
   </p:cSld>

</xml_diff>

<commit_message>
Refresh README slide previews
</commit_message>
<xml_diff>
--- a/docs/assets/readme-slides/mdpr-pipeline-teaser.pptx
+++ b/docs/assets/readme-slides/mdpr-pipeline-teaser.pptx
@@ -129,7 +129,7 @@
           <p:cNvPr id="2" name="제목 1">
             <a:extLst>
               <a:ext uri="{FF2B5EF4-FFF2-40B4-BE49-F238E27FC236}">
-                <a16:creationId xmlns:a16="http://schemas.microsoft.com/office/drawing/2014/main" id="{15A30246-0E6D-449F-9B3A-0C50B528A0AA}"/>
+                <a16:creationId xmlns:a16="http://schemas.microsoft.com/office/drawing/2014/main" id="{92893F1D-D62A-2D52-8AAD-B217B572C33E}"/>
               </a:ext>
             </a:extLst>
           </p:cNvPr>
@@ -166,7 +166,7 @@
           <p:cNvPr id="3" name="부제목 2">
             <a:extLst>
               <a:ext uri="{FF2B5EF4-FFF2-40B4-BE49-F238E27FC236}">
-                <a16:creationId xmlns:a16="http://schemas.microsoft.com/office/drawing/2014/main" id="{AF22FECA-46E4-2756-9589-AC2EEF9E484F}"/>
+                <a16:creationId xmlns:a16="http://schemas.microsoft.com/office/drawing/2014/main" id="{25F715BB-6E4D-6E5E-5098-CD28C11388DA}"/>
               </a:ext>
             </a:extLst>
           </p:cNvPr>
@@ -236,7 +236,7 @@
           <p:cNvPr id="4" name="날짜 개체 틀 3">
             <a:extLst>
               <a:ext uri="{FF2B5EF4-FFF2-40B4-BE49-F238E27FC236}">
-                <a16:creationId xmlns:a16="http://schemas.microsoft.com/office/drawing/2014/main" id="{416B1F31-CA79-9F61-2253-9F61253A3519}"/>
+                <a16:creationId xmlns:a16="http://schemas.microsoft.com/office/drawing/2014/main" id="{ED4FF38E-3BB0-CFFB-D3CB-F9F83B828832}"/>
               </a:ext>
             </a:extLst>
           </p:cNvPr>
@@ -252,7 +252,7 @@
           <a:bodyPr/>
           <a:lstStyle/>
           <a:p>
-            <a:fld id="{A63FB5EC-CF88-4035-A752-ACC250E0626A}" type="datetimeFigureOut">
+            <a:fld id="{E848CDE2-9FE7-40BA-9BF4-AE70776CEE5B}" type="datetimeFigureOut">
               <a:rPr lang="ko-KR" altLang="en-US" smtClean="0"/>
               <a:t>2026-06-20</a:t>
             </a:fld>
@@ -265,7 +265,7 @@
           <p:cNvPr id="5" name="바닥글 개체 틀 4">
             <a:extLst>
               <a:ext uri="{FF2B5EF4-FFF2-40B4-BE49-F238E27FC236}">
-                <a16:creationId xmlns:a16="http://schemas.microsoft.com/office/drawing/2014/main" id="{5E8C68ED-AD92-B13A-4673-0600DC7699D9}"/>
+                <a16:creationId xmlns:a16="http://schemas.microsoft.com/office/drawing/2014/main" id="{AFEF3268-E3D1-0FD8-5941-9D0DDE3BD804}"/>
               </a:ext>
             </a:extLst>
           </p:cNvPr>
@@ -290,7 +290,7 @@
           <p:cNvPr id="6" name="슬라이드 번호 개체 틀 5">
             <a:extLst>
               <a:ext uri="{FF2B5EF4-FFF2-40B4-BE49-F238E27FC236}">
-                <a16:creationId xmlns:a16="http://schemas.microsoft.com/office/drawing/2014/main" id="{06271CB9-E2BB-92E1-14BB-7EE0BD355B8A}"/>
+                <a16:creationId xmlns:a16="http://schemas.microsoft.com/office/drawing/2014/main" id="{F7996EE9-6398-596F-6085-3892B22E85FC}"/>
               </a:ext>
             </a:extLst>
           </p:cNvPr>
@@ -306,7 +306,7 @@
           <a:bodyPr/>
           <a:lstStyle/>
           <a:p>
-            <a:fld id="{FE9BD0AC-AD16-4498-B7AD-B58A3BA041BF}" type="slidenum">
+            <a:fld id="{DD9F5464-F4A4-4964-BECE-944A5E428E53}" type="slidenum">
               <a:rPr lang="ko-KR" altLang="en-US" smtClean="0"/>
               <a:t>‹#›</a:t>
             </a:fld>
@@ -317,7 +317,7 @@
     </p:spTree>
     <p:extLst>
       <p:ext uri="{BB962C8B-B14F-4D97-AF65-F5344CB8AC3E}">
-        <p14:creationId xmlns:p14="http://schemas.microsoft.com/office/powerpoint/2010/main" val="3827427534"/>
+        <p14:creationId xmlns:p14="http://schemas.microsoft.com/office/powerpoint/2010/main" val="3925959329"/>
       </p:ext>
     </p:extLst>
   </p:cSld>
@@ -349,7 +349,7 @@
           <p:cNvPr id="2" name="제목 1">
             <a:extLst>
               <a:ext uri="{FF2B5EF4-FFF2-40B4-BE49-F238E27FC236}">
-                <a16:creationId xmlns:a16="http://schemas.microsoft.com/office/drawing/2014/main" id="{F79C07E5-FC2E-86C9-A456-149F7D6E4E68}"/>
+                <a16:creationId xmlns:a16="http://schemas.microsoft.com/office/drawing/2014/main" id="{D0D73DCF-CABD-D76F-AC04-0B61028DB102}"/>
               </a:ext>
             </a:extLst>
           </p:cNvPr>
@@ -377,7 +377,7 @@
           <p:cNvPr id="3" name="세로 텍스트 개체 틀 2">
             <a:extLst>
               <a:ext uri="{FF2B5EF4-FFF2-40B4-BE49-F238E27FC236}">
-                <a16:creationId xmlns:a16="http://schemas.microsoft.com/office/drawing/2014/main" id="{EB98D82B-FB08-43AA-10E1-6F1DF21F23FC}"/>
+                <a16:creationId xmlns:a16="http://schemas.microsoft.com/office/drawing/2014/main" id="{A0B71E0D-7C4A-550A-C090-E35339E0CBA4}"/>
               </a:ext>
             </a:extLst>
           </p:cNvPr>
@@ -434,7 +434,7 @@
           <p:cNvPr id="4" name="날짜 개체 틀 3">
             <a:extLst>
               <a:ext uri="{FF2B5EF4-FFF2-40B4-BE49-F238E27FC236}">
-                <a16:creationId xmlns:a16="http://schemas.microsoft.com/office/drawing/2014/main" id="{43B822AA-8B28-581C-05E8-359B209A7DEC}"/>
+                <a16:creationId xmlns:a16="http://schemas.microsoft.com/office/drawing/2014/main" id="{7A4ABDD6-4631-E9FC-7DF8-85C4E75F58BC}"/>
               </a:ext>
             </a:extLst>
           </p:cNvPr>
@@ -450,7 +450,7 @@
           <a:bodyPr/>
           <a:lstStyle/>
           <a:p>
-            <a:fld id="{A63FB5EC-CF88-4035-A752-ACC250E0626A}" type="datetimeFigureOut">
+            <a:fld id="{E848CDE2-9FE7-40BA-9BF4-AE70776CEE5B}" type="datetimeFigureOut">
               <a:rPr lang="ko-KR" altLang="en-US" smtClean="0"/>
               <a:t>2026-06-20</a:t>
             </a:fld>
@@ -463,7 +463,7 @@
           <p:cNvPr id="5" name="바닥글 개체 틀 4">
             <a:extLst>
               <a:ext uri="{FF2B5EF4-FFF2-40B4-BE49-F238E27FC236}">
-                <a16:creationId xmlns:a16="http://schemas.microsoft.com/office/drawing/2014/main" id="{E332C1FC-3250-F78E-1F4A-37B2F52B7093}"/>
+                <a16:creationId xmlns:a16="http://schemas.microsoft.com/office/drawing/2014/main" id="{2E24DCB2-F9AA-669F-0CA6-1ACF99F93B80}"/>
               </a:ext>
             </a:extLst>
           </p:cNvPr>
@@ -488,7 +488,7 @@
           <p:cNvPr id="6" name="슬라이드 번호 개체 틀 5">
             <a:extLst>
               <a:ext uri="{FF2B5EF4-FFF2-40B4-BE49-F238E27FC236}">
-                <a16:creationId xmlns:a16="http://schemas.microsoft.com/office/drawing/2014/main" id="{176EBE82-1459-339B-8AB7-F3204EB6211C}"/>
+                <a16:creationId xmlns:a16="http://schemas.microsoft.com/office/drawing/2014/main" id="{371D045B-139D-6A5D-E287-1EAAA20A1E9B}"/>
               </a:ext>
             </a:extLst>
           </p:cNvPr>
@@ -504,7 +504,7 @@
           <a:bodyPr/>
           <a:lstStyle/>
           <a:p>
-            <a:fld id="{FE9BD0AC-AD16-4498-B7AD-B58A3BA041BF}" type="slidenum">
+            <a:fld id="{DD9F5464-F4A4-4964-BECE-944A5E428E53}" type="slidenum">
               <a:rPr lang="ko-KR" altLang="en-US" smtClean="0"/>
               <a:t>‹#›</a:t>
             </a:fld>
@@ -515,7 +515,7 @@
     </p:spTree>
     <p:extLst>
       <p:ext uri="{BB962C8B-B14F-4D97-AF65-F5344CB8AC3E}">
-        <p14:creationId xmlns:p14="http://schemas.microsoft.com/office/powerpoint/2010/main" val="1469090259"/>
+        <p14:creationId xmlns:p14="http://schemas.microsoft.com/office/powerpoint/2010/main" val="3838905520"/>
       </p:ext>
     </p:extLst>
   </p:cSld>
@@ -547,7 +547,7 @@
           <p:cNvPr id="2" name="세로 제목 1">
             <a:extLst>
               <a:ext uri="{FF2B5EF4-FFF2-40B4-BE49-F238E27FC236}">
-                <a16:creationId xmlns:a16="http://schemas.microsoft.com/office/drawing/2014/main" id="{ED01F664-A3A9-DB48-1FA6-4D9DC7E1E3E7}"/>
+                <a16:creationId xmlns:a16="http://schemas.microsoft.com/office/drawing/2014/main" id="{06568621-89D0-3402-DDEC-191AE0AEEEC9}"/>
               </a:ext>
             </a:extLst>
           </p:cNvPr>
@@ -580,7 +580,7 @@
           <p:cNvPr id="3" name="세로 텍스트 개체 틀 2">
             <a:extLst>
               <a:ext uri="{FF2B5EF4-FFF2-40B4-BE49-F238E27FC236}">
-                <a16:creationId xmlns:a16="http://schemas.microsoft.com/office/drawing/2014/main" id="{001DEA81-3A86-31AB-AFAC-BE39EF8E9A3D}"/>
+                <a16:creationId xmlns:a16="http://schemas.microsoft.com/office/drawing/2014/main" id="{EBCBF24B-B496-23B2-CD8A-9F124EEA316B}"/>
               </a:ext>
             </a:extLst>
           </p:cNvPr>
@@ -642,7 +642,7 @@
           <p:cNvPr id="4" name="날짜 개체 틀 3">
             <a:extLst>
               <a:ext uri="{FF2B5EF4-FFF2-40B4-BE49-F238E27FC236}">
-                <a16:creationId xmlns:a16="http://schemas.microsoft.com/office/drawing/2014/main" id="{F06C1E78-CC28-43FB-3894-1EE3043D3B7A}"/>
+                <a16:creationId xmlns:a16="http://schemas.microsoft.com/office/drawing/2014/main" id="{E2EEAE07-93A7-B33E-1627-05375328FCE4}"/>
               </a:ext>
             </a:extLst>
           </p:cNvPr>
@@ -658,7 +658,7 @@
           <a:bodyPr/>
           <a:lstStyle/>
           <a:p>
-            <a:fld id="{A63FB5EC-CF88-4035-A752-ACC250E0626A}" type="datetimeFigureOut">
+            <a:fld id="{E848CDE2-9FE7-40BA-9BF4-AE70776CEE5B}" type="datetimeFigureOut">
               <a:rPr lang="ko-KR" altLang="en-US" smtClean="0"/>
               <a:t>2026-06-20</a:t>
             </a:fld>
@@ -671,7 +671,7 @@
           <p:cNvPr id="5" name="바닥글 개체 틀 4">
             <a:extLst>
               <a:ext uri="{FF2B5EF4-FFF2-40B4-BE49-F238E27FC236}">
-                <a16:creationId xmlns:a16="http://schemas.microsoft.com/office/drawing/2014/main" id="{1FAF613B-D8EC-25B5-4AB7-6BC803DDF2BC}"/>
+                <a16:creationId xmlns:a16="http://schemas.microsoft.com/office/drawing/2014/main" id="{13BF5F0B-7D30-9D43-6856-A0E19FD09B3D}"/>
               </a:ext>
             </a:extLst>
           </p:cNvPr>
@@ -696,7 +696,7 @@
           <p:cNvPr id="6" name="슬라이드 번호 개체 틀 5">
             <a:extLst>
               <a:ext uri="{FF2B5EF4-FFF2-40B4-BE49-F238E27FC236}">
-                <a16:creationId xmlns:a16="http://schemas.microsoft.com/office/drawing/2014/main" id="{D83C513E-B149-F056-15E8-C26740BCAC9D}"/>
+                <a16:creationId xmlns:a16="http://schemas.microsoft.com/office/drawing/2014/main" id="{2E54466B-0E90-49B7-C4A6-430CA2DBC1E8}"/>
               </a:ext>
             </a:extLst>
           </p:cNvPr>
@@ -712,7 +712,7 @@
           <a:bodyPr/>
           <a:lstStyle/>
           <a:p>
-            <a:fld id="{FE9BD0AC-AD16-4498-B7AD-B58A3BA041BF}" type="slidenum">
+            <a:fld id="{DD9F5464-F4A4-4964-BECE-944A5E428E53}" type="slidenum">
               <a:rPr lang="ko-KR" altLang="en-US" smtClean="0"/>
               <a:t>‹#›</a:t>
             </a:fld>
@@ -723,7 +723,7 @@
     </p:spTree>
     <p:extLst>
       <p:ext uri="{BB962C8B-B14F-4D97-AF65-F5344CB8AC3E}">
-        <p14:creationId xmlns:p14="http://schemas.microsoft.com/office/powerpoint/2010/main" val="2026523762"/>
+        <p14:creationId xmlns:p14="http://schemas.microsoft.com/office/powerpoint/2010/main" val="141124760"/>
       </p:ext>
     </p:extLst>
   </p:cSld>
@@ -755,7 +755,7 @@
           <p:cNvPr id="2" name="제목 1">
             <a:extLst>
               <a:ext uri="{FF2B5EF4-FFF2-40B4-BE49-F238E27FC236}">
-                <a16:creationId xmlns:a16="http://schemas.microsoft.com/office/drawing/2014/main" id="{B88D2776-BC68-728A-5C2A-70240FD142A8}"/>
+                <a16:creationId xmlns:a16="http://schemas.microsoft.com/office/drawing/2014/main" id="{8551B20D-C01D-8E5E-A8B4-17B93AD5DD39}"/>
               </a:ext>
             </a:extLst>
           </p:cNvPr>
@@ -783,7 +783,7 @@
           <p:cNvPr id="3" name="내용 개체 틀 2">
             <a:extLst>
               <a:ext uri="{FF2B5EF4-FFF2-40B4-BE49-F238E27FC236}">
-                <a16:creationId xmlns:a16="http://schemas.microsoft.com/office/drawing/2014/main" id="{512AFB13-35B8-7D85-FE1E-D14FB7334703}"/>
+                <a16:creationId xmlns:a16="http://schemas.microsoft.com/office/drawing/2014/main" id="{4549529E-888E-E8DB-C04A-734F15A6D652}"/>
               </a:ext>
             </a:extLst>
           </p:cNvPr>
@@ -840,7 +840,7 @@
           <p:cNvPr id="4" name="날짜 개체 틀 3">
             <a:extLst>
               <a:ext uri="{FF2B5EF4-FFF2-40B4-BE49-F238E27FC236}">
-                <a16:creationId xmlns:a16="http://schemas.microsoft.com/office/drawing/2014/main" id="{5C3435F3-765F-A191-063A-AE4BC7F05C04}"/>
+                <a16:creationId xmlns:a16="http://schemas.microsoft.com/office/drawing/2014/main" id="{9950ECE2-CD58-337E-2BC3-B5BF25452EA9}"/>
               </a:ext>
             </a:extLst>
           </p:cNvPr>
@@ -856,7 +856,7 @@
           <a:bodyPr/>
           <a:lstStyle/>
           <a:p>
-            <a:fld id="{A63FB5EC-CF88-4035-A752-ACC250E0626A}" type="datetimeFigureOut">
+            <a:fld id="{E848CDE2-9FE7-40BA-9BF4-AE70776CEE5B}" type="datetimeFigureOut">
               <a:rPr lang="ko-KR" altLang="en-US" smtClean="0"/>
               <a:t>2026-06-20</a:t>
             </a:fld>
@@ -869,7 +869,7 @@
           <p:cNvPr id="5" name="바닥글 개체 틀 4">
             <a:extLst>
               <a:ext uri="{FF2B5EF4-FFF2-40B4-BE49-F238E27FC236}">
-                <a16:creationId xmlns:a16="http://schemas.microsoft.com/office/drawing/2014/main" id="{268C1387-2417-D030-D3CB-DE01F8538F87}"/>
+                <a16:creationId xmlns:a16="http://schemas.microsoft.com/office/drawing/2014/main" id="{07B19707-8934-3DC1-D053-B6119AE8A2B9}"/>
               </a:ext>
             </a:extLst>
           </p:cNvPr>
@@ -894,7 +894,7 @@
           <p:cNvPr id="6" name="슬라이드 번호 개체 틀 5">
             <a:extLst>
               <a:ext uri="{FF2B5EF4-FFF2-40B4-BE49-F238E27FC236}">
-                <a16:creationId xmlns:a16="http://schemas.microsoft.com/office/drawing/2014/main" id="{E18E1C98-4564-FF41-331D-ADD882B08195}"/>
+                <a16:creationId xmlns:a16="http://schemas.microsoft.com/office/drawing/2014/main" id="{944D9378-5B12-B57F-2F6C-689F8D068D4F}"/>
               </a:ext>
             </a:extLst>
           </p:cNvPr>
@@ -910,7 +910,7 @@
           <a:bodyPr/>
           <a:lstStyle/>
           <a:p>
-            <a:fld id="{FE9BD0AC-AD16-4498-B7AD-B58A3BA041BF}" type="slidenum">
+            <a:fld id="{DD9F5464-F4A4-4964-BECE-944A5E428E53}" type="slidenum">
               <a:rPr lang="ko-KR" altLang="en-US" smtClean="0"/>
               <a:t>‹#›</a:t>
             </a:fld>
@@ -921,7 +921,7 @@
     </p:spTree>
     <p:extLst>
       <p:ext uri="{BB962C8B-B14F-4D97-AF65-F5344CB8AC3E}">
-        <p14:creationId xmlns:p14="http://schemas.microsoft.com/office/powerpoint/2010/main" val="3499918860"/>
+        <p14:creationId xmlns:p14="http://schemas.microsoft.com/office/powerpoint/2010/main" val="478400442"/>
       </p:ext>
     </p:extLst>
   </p:cSld>
@@ -953,7 +953,7 @@
           <p:cNvPr id="2" name="제목 1">
             <a:extLst>
               <a:ext uri="{FF2B5EF4-FFF2-40B4-BE49-F238E27FC236}">
-                <a16:creationId xmlns:a16="http://schemas.microsoft.com/office/drawing/2014/main" id="{5184698F-18AB-3425-96E0-5BDF601E4CF0}"/>
+                <a16:creationId xmlns:a16="http://schemas.microsoft.com/office/drawing/2014/main" id="{65EEC037-F81F-9869-A587-EBD0F43A4A75}"/>
               </a:ext>
             </a:extLst>
           </p:cNvPr>
@@ -990,7 +990,7 @@
           <p:cNvPr id="3" name="텍스트 개체 틀 2">
             <a:extLst>
               <a:ext uri="{FF2B5EF4-FFF2-40B4-BE49-F238E27FC236}">
-                <a16:creationId xmlns:a16="http://schemas.microsoft.com/office/drawing/2014/main" id="{AFEFB3E4-FB01-1A7E-A225-F236DF241136}"/>
+                <a16:creationId xmlns:a16="http://schemas.microsoft.com/office/drawing/2014/main" id="{5DCD9FC9-A843-F02A-67FC-98E6753D310A}"/>
               </a:ext>
             </a:extLst>
           </p:cNvPr>
@@ -1115,7 +1115,7 @@
           <p:cNvPr id="4" name="날짜 개체 틀 3">
             <a:extLst>
               <a:ext uri="{FF2B5EF4-FFF2-40B4-BE49-F238E27FC236}">
-                <a16:creationId xmlns:a16="http://schemas.microsoft.com/office/drawing/2014/main" id="{CA5C1B1E-8E2D-F2BF-1EAD-7F56E7277ADC}"/>
+                <a16:creationId xmlns:a16="http://schemas.microsoft.com/office/drawing/2014/main" id="{7B56C9C2-7532-AEF3-102B-57EDB6E7E311}"/>
               </a:ext>
             </a:extLst>
           </p:cNvPr>
@@ -1131,7 +1131,7 @@
           <a:bodyPr/>
           <a:lstStyle/>
           <a:p>
-            <a:fld id="{A63FB5EC-CF88-4035-A752-ACC250E0626A}" type="datetimeFigureOut">
+            <a:fld id="{E848CDE2-9FE7-40BA-9BF4-AE70776CEE5B}" type="datetimeFigureOut">
               <a:rPr lang="ko-KR" altLang="en-US" smtClean="0"/>
               <a:t>2026-06-20</a:t>
             </a:fld>
@@ -1144,7 +1144,7 @@
           <p:cNvPr id="5" name="바닥글 개체 틀 4">
             <a:extLst>
               <a:ext uri="{FF2B5EF4-FFF2-40B4-BE49-F238E27FC236}">
-                <a16:creationId xmlns:a16="http://schemas.microsoft.com/office/drawing/2014/main" id="{454B87B4-8A9F-F60E-84C8-C9E7E2750096}"/>
+                <a16:creationId xmlns:a16="http://schemas.microsoft.com/office/drawing/2014/main" id="{D7A5E9DF-E6CA-6092-6573-25B5D0188A10}"/>
               </a:ext>
             </a:extLst>
           </p:cNvPr>
@@ -1169,7 +1169,7 @@
           <p:cNvPr id="6" name="슬라이드 번호 개체 틀 5">
             <a:extLst>
               <a:ext uri="{FF2B5EF4-FFF2-40B4-BE49-F238E27FC236}">
-                <a16:creationId xmlns:a16="http://schemas.microsoft.com/office/drawing/2014/main" id="{5AB70A2E-4204-29D2-F4F5-83DAD68AC59C}"/>
+                <a16:creationId xmlns:a16="http://schemas.microsoft.com/office/drawing/2014/main" id="{7416DAAB-3E34-57A9-1678-38994D24436A}"/>
               </a:ext>
             </a:extLst>
           </p:cNvPr>
@@ -1185,7 +1185,7 @@
           <a:bodyPr/>
           <a:lstStyle/>
           <a:p>
-            <a:fld id="{FE9BD0AC-AD16-4498-B7AD-B58A3BA041BF}" type="slidenum">
+            <a:fld id="{DD9F5464-F4A4-4964-BECE-944A5E428E53}" type="slidenum">
               <a:rPr lang="ko-KR" altLang="en-US" smtClean="0"/>
               <a:t>‹#›</a:t>
             </a:fld>
@@ -1196,7 +1196,7 @@
     </p:spTree>
     <p:extLst>
       <p:ext uri="{BB962C8B-B14F-4D97-AF65-F5344CB8AC3E}">
-        <p14:creationId xmlns:p14="http://schemas.microsoft.com/office/powerpoint/2010/main" val="4201571969"/>
+        <p14:creationId xmlns:p14="http://schemas.microsoft.com/office/powerpoint/2010/main" val="805985636"/>
       </p:ext>
     </p:extLst>
   </p:cSld>
@@ -1228,7 +1228,7 @@
           <p:cNvPr id="2" name="제목 1">
             <a:extLst>
               <a:ext uri="{FF2B5EF4-FFF2-40B4-BE49-F238E27FC236}">
-                <a16:creationId xmlns:a16="http://schemas.microsoft.com/office/drawing/2014/main" id="{7801D98D-AA22-4536-F635-827CC2688881}"/>
+                <a16:creationId xmlns:a16="http://schemas.microsoft.com/office/drawing/2014/main" id="{D6185F87-D208-331D-A6A5-813B935E457A}"/>
               </a:ext>
             </a:extLst>
           </p:cNvPr>
@@ -1256,7 +1256,7 @@
           <p:cNvPr id="3" name="내용 개체 틀 2">
             <a:extLst>
               <a:ext uri="{FF2B5EF4-FFF2-40B4-BE49-F238E27FC236}">
-                <a16:creationId xmlns:a16="http://schemas.microsoft.com/office/drawing/2014/main" id="{B57BC3E7-0E70-5D9D-2C3C-705FC5557879}"/>
+                <a16:creationId xmlns:a16="http://schemas.microsoft.com/office/drawing/2014/main" id="{FCBC5AAF-4CF5-00C0-641D-5AC7AD7E2F2B}"/>
               </a:ext>
             </a:extLst>
           </p:cNvPr>
@@ -1318,7 +1318,7 @@
           <p:cNvPr id="4" name="내용 개체 틀 3">
             <a:extLst>
               <a:ext uri="{FF2B5EF4-FFF2-40B4-BE49-F238E27FC236}">
-                <a16:creationId xmlns:a16="http://schemas.microsoft.com/office/drawing/2014/main" id="{4B367486-0AF0-5D65-AF99-55448FE406A0}"/>
+                <a16:creationId xmlns:a16="http://schemas.microsoft.com/office/drawing/2014/main" id="{8B247DD1-AA59-85A5-E3C5-5D0E931CB57E}"/>
               </a:ext>
             </a:extLst>
           </p:cNvPr>
@@ -1380,7 +1380,7 @@
           <p:cNvPr id="5" name="날짜 개체 틀 4">
             <a:extLst>
               <a:ext uri="{FF2B5EF4-FFF2-40B4-BE49-F238E27FC236}">
-                <a16:creationId xmlns:a16="http://schemas.microsoft.com/office/drawing/2014/main" id="{7B9A1818-C229-431F-1EBA-6D4BC55201D4}"/>
+                <a16:creationId xmlns:a16="http://schemas.microsoft.com/office/drawing/2014/main" id="{7FCA31BE-B2CE-FB4E-384E-5DB2EBA59724}"/>
               </a:ext>
             </a:extLst>
           </p:cNvPr>
@@ -1396,7 +1396,7 @@
           <a:bodyPr/>
           <a:lstStyle/>
           <a:p>
-            <a:fld id="{A63FB5EC-CF88-4035-A752-ACC250E0626A}" type="datetimeFigureOut">
+            <a:fld id="{E848CDE2-9FE7-40BA-9BF4-AE70776CEE5B}" type="datetimeFigureOut">
               <a:rPr lang="ko-KR" altLang="en-US" smtClean="0"/>
               <a:t>2026-06-20</a:t>
             </a:fld>
@@ -1409,7 +1409,7 @@
           <p:cNvPr id="6" name="바닥글 개체 틀 5">
             <a:extLst>
               <a:ext uri="{FF2B5EF4-FFF2-40B4-BE49-F238E27FC236}">
-                <a16:creationId xmlns:a16="http://schemas.microsoft.com/office/drawing/2014/main" id="{57A12F3B-3F33-D2CF-2B32-61AA7DFBBBA0}"/>
+                <a16:creationId xmlns:a16="http://schemas.microsoft.com/office/drawing/2014/main" id="{C14ECD95-C41B-6127-AEB8-F6A3D3B40F7D}"/>
               </a:ext>
             </a:extLst>
           </p:cNvPr>
@@ -1434,7 +1434,7 @@
           <p:cNvPr id="7" name="슬라이드 번호 개체 틀 6">
             <a:extLst>
               <a:ext uri="{FF2B5EF4-FFF2-40B4-BE49-F238E27FC236}">
-                <a16:creationId xmlns:a16="http://schemas.microsoft.com/office/drawing/2014/main" id="{CEFE1BF6-DED9-320A-5A25-E40A9823C881}"/>
+                <a16:creationId xmlns:a16="http://schemas.microsoft.com/office/drawing/2014/main" id="{8CF59585-BC3F-A5BF-70EB-52BEE42FB3D8}"/>
               </a:ext>
             </a:extLst>
           </p:cNvPr>
@@ -1450,7 +1450,7 @@
           <a:bodyPr/>
           <a:lstStyle/>
           <a:p>
-            <a:fld id="{FE9BD0AC-AD16-4498-B7AD-B58A3BA041BF}" type="slidenum">
+            <a:fld id="{DD9F5464-F4A4-4964-BECE-944A5E428E53}" type="slidenum">
               <a:rPr lang="ko-KR" altLang="en-US" smtClean="0"/>
               <a:t>‹#›</a:t>
             </a:fld>
@@ -1461,7 +1461,7 @@
     </p:spTree>
     <p:extLst>
       <p:ext uri="{BB962C8B-B14F-4D97-AF65-F5344CB8AC3E}">
-        <p14:creationId xmlns:p14="http://schemas.microsoft.com/office/powerpoint/2010/main" val="790113431"/>
+        <p14:creationId xmlns:p14="http://schemas.microsoft.com/office/powerpoint/2010/main" val="302624383"/>
       </p:ext>
     </p:extLst>
   </p:cSld>
@@ -1493,7 +1493,7 @@
           <p:cNvPr id="2" name="제목 1">
             <a:extLst>
               <a:ext uri="{FF2B5EF4-FFF2-40B4-BE49-F238E27FC236}">
-                <a16:creationId xmlns:a16="http://schemas.microsoft.com/office/drawing/2014/main" id="{2E255485-E140-E320-19C3-E8613EF2695E}"/>
+                <a16:creationId xmlns:a16="http://schemas.microsoft.com/office/drawing/2014/main" id="{7B4E4606-0361-95C4-2F67-BCCEE76CB08D}"/>
               </a:ext>
             </a:extLst>
           </p:cNvPr>
@@ -1526,7 +1526,7 @@
           <p:cNvPr id="3" name="텍스트 개체 틀 2">
             <a:extLst>
               <a:ext uri="{FF2B5EF4-FFF2-40B4-BE49-F238E27FC236}">
-                <a16:creationId xmlns:a16="http://schemas.microsoft.com/office/drawing/2014/main" id="{0D633DD1-AF81-8F4B-52A8-0BF8C465A9AC}"/>
+                <a16:creationId xmlns:a16="http://schemas.microsoft.com/office/drawing/2014/main" id="{569CAD88-F6C6-5AE7-C52D-6922147CC6B3}"/>
               </a:ext>
             </a:extLst>
           </p:cNvPr>
@@ -1597,7 +1597,7 @@
           <p:cNvPr id="4" name="내용 개체 틀 3">
             <a:extLst>
               <a:ext uri="{FF2B5EF4-FFF2-40B4-BE49-F238E27FC236}">
-                <a16:creationId xmlns:a16="http://schemas.microsoft.com/office/drawing/2014/main" id="{F26CF5B2-BA2F-0A78-BCBD-AB5F57C08AB9}"/>
+                <a16:creationId xmlns:a16="http://schemas.microsoft.com/office/drawing/2014/main" id="{D6AB9014-7B6F-2513-03B8-3279C6354C05}"/>
               </a:ext>
             </a:extLst>
           </p:cNvPr>
@@ -1659,7 +1659,7 @@
           <p:cNvPr id="5" name="텍스트 개체 틀 4">
             <a:extLst>
               <a:ext uri="{FF2B5EF4-FFF2-40B4-BE49-F238E27FC236}">
-                <a16:creationId xmlns:a16="http://schemas.microsoft.com/office/drawing/2014/main" id="{D5F982DE-DF20-1613-8078-FBFB275E711E}"/>
+                <a16:creationId xmlns:a16="http://schemas.microsoft.com/office/drawing/2014/main" id="{9B312FF5-A79C-75F3-4BD4-9EBF55B8B668}"/>
               </a:ext>
             </a:extLst>
           </p:cNvPr>
@@ -1730,7 +1730,7 @@
           <p:cNvPr id="6" name="내용 개체 틀 5">
             <a:extLst>
               <a:ext uri="{FF2B5EF4-FFF2-40B4-BE49-F238E27FC236}">
-                <a16:creationId xmlns:a16="http://schemas.microsoft.com/office/drawing/2014/main" id="{1CE62BB1-43C6-AC19-AD90-1FCFA8ECE930}"/>
+                <a16:creationId xmlns:a16="http://schemas.microsoft.com/office/drawing/2014/main" id="{AE47B5ED-B353-F558-1CAA-8456233A8C0E}"/>
               </a:ext>
             </a:extLst>
           </p:cNvPr>
@@ -1792,7 +1792,7 @@
           <p:cNvPr id="7" name="날짜 개체 틀 6">
             <a:extLst>
               <a:ext uri="{FF2B5EF4-FFF2-40B4-BE49-F238E27FC236}">
-                <a16:creationId xmlns:a16="http://schemas.microsoft.com/office/drawing/2014/main" id="{566CAD9C-8FB4-6C5C-208A-5FCE57E33A2C}"/>
+                <a16:creationId xmlns:a16="http://schemas.microsoft.com/office/drawing/2014/main" id="{3FC21CEE-75E4-43FC-23E4-E637FD25CAA7}"/>
               </a:ext>
             </a:extLst>
           </p:cNvPr>
@@ -1808,7 +1808,7 @@
           <a:bodyPr/>
           <a:lstStyle/>
           <a:p>
-            <a:fld id="{A63FB5EC-CF88-4035-A752-ACC250E0626A}" type="datetimeFigureOut">
+            <a:fld id="{E848CDE2-9FE7-40BA-9BF4-AE70776CEE5B}" type="datetimeFigureOut">
               <a:rPr lang="ko-KR" altLang="en-US" smtClean="0"/>
               <a:t>2026-06-20</a:t>
             </a:fld>
@@ -1821,7 +1821,7 @@
           <p:cNvPr id="8" name="바닥글 개체 틀 7">
             <a:extLst>
               <a:ext uri="{FF2B5EF4-FFF2-40B4-BE49-F238E27FC236}">
-                <a16:creationId xmlns:a16="http://schemas.microsoft.com/office/drawing/2014/main" id="{BCF37FC1-ECA5-5022-EBAC-0A8A0854A8F1}"/>
+                <a16:creationId xmlns:a16="http://schemas.microsoft.com/office/drawing/2014/main" id="{3C2ED05F-7A04-96B4-F8F0-82AC17DCB69A}"/>
               </a:ext>
             </a:extLst>
           </p:cNvPr>
@@ -1846,7 +1846,7 @@
           <p:cNvPr id="9" name="슬라이드 번호 개체 틀 8">
             <a:extLst>
               <a:ext uri="{FF2B5EF4-FFF2-40B4-BE49-F238E27FC236}">
-                <a16:creationId xmlns:a16="http://schemas.microsoft.com/office/drawing/2014/main" id="{9D7E44CB-288F-AFE4-F475-1B304C80FABE}"/>
+                <a16:creationId xmlns:a16="http://schemas.microsoft.com/office/drawing/2014/main" id="{8C5DDAF3-88E4-A720-79FA-35A8FD8D79FB}"/>
               </a:ext>
             </a:extLst>
           </p:cNvPr>
@@ -1862,7 +1862,7 @@
           <a:bodyPr/>
           <a:lstStyle/>
           <a:p>
-            <a:fld id="{FE9BD0AC-AD16-4498-B7AD-B58A3BA041BF}" type="slidenum">
+            <a:fld id="{DD9F5464-F4A4-4964-BECE-944A5E428E53}" type="slidenum">
               <a:rPr lang="ko-KR" altLang="en-US" smtClean="0"/>
               <a:t>‹#›</a:t>
             </a:fld>
@@ -1873,7 +1873,7 @@
     </p:spTree>
     <p:extLst>
       <p:ext uri="{BB962C8B-B14F-4D97-AF65-F5344CB8AC3E}">
-        <p14:creationId xmlns:p14="http://schemas.microsoft.com/office/powerpoint/2010/main" val="3071882999"/>
+        <p14:creationId xmlns:p14="http://schemas.microsoft.com/office/powerpoint/2010/main" val="3701057167"/>
       </p:ext>
     </p:extLst>
   </p:cSld>
@@ -1905,7 +1905,7 @@
           <p:cNvPr id="2" name="제목 1">
             <a:extLst>
               <a:ext uri="{FF2B5EF4-FFF2-40B4-BE49-F238E27FC236}">
-                <a16:creationId xmlns:a16="http://schemas.microsoft.com/office/drawing/2014/main" id="{B649E272-78F2-2B83-BEBF-E41E97B9597C}"/>
+                <a16:creationId xmlns:a16="http://schemas.microsoft.com/office/drawing/2014/main" id="{CA98716F-B681-4448-12BA-1B3C2E37EA4A}"/>
               </a:ext>
             </a:extLst>
           </p:cNvPr>
@@ -1933,7 +1933,7 @@
           <p:cNvPr id="3" name="날짜 개체 틀 2">
             <a:extLst>
               <a:ext uri="{FF2B5EF4-FFF2-40B4-BE49-F238E27FC236}">
-                <a16:creationId xmlns:a16="http://schemas.microsoft.com/office/drawing/2014/main" id="{CC8CA0BB-26F0-8C6D-2616-13AA54AFAB88}"/>
+                <a16:creationId xmlns:a16="http://schemas.microsoft.com/office/drawing/2014/main" id="{F3D10F43-F496-217F-0DF7-7013D7BF3186}"/>
               </a:ext>
             </a:extLst>
           </p:cNvPr>
@@ -1949,7 +1949,7 @@
           <a:bodyPr/>
           <a:lstStyle/>
           <a:p>
-            <a:fld id="{A63FB5EC-CF88-4035-A752-ACC250E0626A}" type="datetimeFigureOut">
+            <a:fld id="{E848CDE2-9FE7-40BA-9BF4-AE70776CEE5B}" type="datetimeFigureOut">
               <a:rPr lang="ko-KR" altLang="en-US" smtClean="0"/>
               <a:t>2026-06-20</a:t>
             </a:fld>
@@ -1962,7 +1962,7 @@
           <p:cNvPr id="4" name="바닥글 개체 틀 3">
             <a:extLst>
               <a:ext uri="{FF2B5EF4-FFF2-40B4-BE49-F238E27FC236}">
-                <a16:creationId xmlns:a16="http://schemas.microsoft.com/office/drawing/2014/main" id="{8F71F9C2-F25F-EB90-F7B1-9B3C99404B7A}"/>
+                <a16:creationId xmlns:a16="http://schemas.microsoft.com/office/drawing/2014/main" id="{5F093488-FBC4-17E6-A1A9-7ADA717DF3EE}"/>
               </a:ext>
             </a:extLst>
           </p:cNvPr>
@@ -1987,7 +1987,7 @@
           <p:cNvPr id="5" name="슬라이드 번호 개체 틀 4">
             <a:extLst>
               <a:ext uri="{FF2B5EF4-FFF2-40B4-BE49-F238E27FC236}">
-                <a16:creationId xmlns:a16="http://schemas.microsoft.com/office/drawing/2014/main" id="{58C0C6B3-3EC2-85F0-3EC4-5941C6A8207A}"/>
+                <a16:creationId xmlns:a16="http://schemas.microsoft.com/office/drawing/2014/main" id="{034E7F5E-DA6E-92B9-6F68-535A21DA53D8}"/>
               </a:ext>
             </a:extLst>
           </p:cNvPr>
@@ -2003,7 +2003,7 @@
           <a:bodyPr/>
           <a:lstStyle/>
           <a:p>
-            <a:fld id="{FE9BD0AC-AD16-4498-B7AD-B58A3BA041BF}" type="slidenum">
+            <a:fld id="{DD9F5464-F4A4-4964-BECE-944A5E428E53}" type="slidenum">
               <a:rPr lang="ko-KR" altLang="en-US" smtClean="0"/>
               <a:t>‹#›</a:t>
             </a:fld>
@@ -2014,7 +2014,7 @@
     </p:spTree>
     <p:extLst>
       <p:ext uri="{BB962C8B-B14F-4D97-AF65-F5344CB8AC3E}">
-        <p14:creationId xmlns:p14="http://schemas.microsoft.com/office/powerpoint/2010/main" val="1292972361"/>
+        <p14:creationId xmlns:p14="http://schemas.microsoft.com/office/powerpoint/2010/main" val="4042313397"/>
       </p:ext>
     </p:extLst>
   </p:cSld>
@@ -2046,7 +2046,7 @@
           <p:cNvPr id="2" name="날짜 개체 틀 1">
             <a:extLst>
               <a:ext uri="{FF2B5EF4-FFF2-40B4-BE49-F238E27FC236}">
-                <a16:creationId xmlns:a16="http://schemas.microsoft.com/office/drawing/2014/main" id="{38484E79-289E-9D57-B116-D49B45ADB1D9}"/>
+                <a16:creationId xmlns:a16="http://schemas.microsoft.com/office/drawing/2014/main" id="{608BC39E-1E64-4B67-9009-182F291161FE}"/>
               </a:ext>
             </a:extLst>
           </p:cNvPr>
@@ -2062,7 +2062,7 @@
           <a:bodyPr/>
           <a:lstStyle/>
           <a:p>
-            <a:fld id="{A63FB5EC-CF88-4035-A752-ACC250E0626A}" type="datetimeFigureOut">
+            <a:fld id="{E848CDE2-9FE7-40BA-9BF4-AE70776CEE5B}" type="datetimeFigureOut">
               <a:rPr lang="ko-KR" altLang="en-US" smtClean="0"/>
               <a:t>2026-06-20</a:t>
             </a:fld>
@@ -2075,7 +2075,7 @@
           <p:cNvPr id="3" name="바닥글 개체 틀 2">
             <a:extLst>
               <a:ext uri="{FF2B5EF4-FFF2-40B4-BE49-F238E27FC236}">
-                <a16:creationId xmlns:a16="http://schemas.microsoft.com/office/drawing/2014/main" id="{D067095C-997D-082B-96DA-700CCBE9672B}"/>
+                <a16:creationId xmlns:a16="http://schemas.microsoft.com/office/drawing/2014/main" id="{D72CF067-44F7-3C58-5345-6AF537B64443}"/>
               </a:ext>
             </a:extLst>
           </p:cNvPr>
@@ -2100,7 +2100,7 @@
           <p:cNvPr id="4" name="슬라이드 번호 개체 틀 3">
             <a:extLst>
               <a:ext uri="{FF2B5EF4-FFF2-40B4-BE49-F238E27FC236}">
-                <a16:creationId xmlns:a16="http://schemas.microsoft.com/office/drawing/2014/main" id="{670FD8FF-AEFC-B07E-AAE8-B959FBBA70B2}"/>
+                <a16:creationId xmlns:a16="http://schemas.microsoft.com/office/drawing/2014/main" id="{7939CD28-4D34-F693-AE6E-D29907763A46}"/>
               </a:ext>
             </a:extLst>
           </p:cNvPr>
@@ -2116,7 +2116,7 @@
           <a:bodyPr/>
           <a:lstStyle/>
           <a:p>
-            <a:fld id="{FE9BD0AC-AD16-4498-B7AD-B58A3BA041BF}" type="slidenum">
+            <a:fld id="{DD9F5464-F4A4-4964-BECE-944A5E428E53}" type="slidenum">
               <a:rPr lang="ko-KR" altLang="en-US" smtClean="0"/>
               <a:t>‹#›</a:t>
             </a:fld>
@@ -2127,7 +2127,7 @@
     </p:spTree>
     <p:extLst>
       <p:ext uri="{BB962C8B-B14F-4D97-AF65-F5344CB8AC3E}">
-        <p14:creationId xmlns:p14="http://schemas.microsoft.com/office/powerpoint/2010/main" val="2709282295"/>
+        <p14:creationId xmlns:p14="http://schemas.microsoft.com/office/powerpoint/2010/main" val="3170499741"/>
       </p:ext>
     </p:extLst>
   </p:cSld>
@@ -2159,7 +2159,7 @@
           <p:cNvPr id="2" name="제목 1">
             <a:extLst>
               <a:ext uri="{FF2B5EF4-FFF2-40B4-BE49-F238E27FC236}">
-                <a16:creationId xmlns:a16="http://schemas.microsoft.com/office/drawing/2014/main" id="{EE6297A1-35F5-DE8E-DD21-3D4CA9729511}"/>
+                <a16:creationId xmlns:a16="http://schemas.microsoft.com/office/drawing/2014/main" id="{25E09777-443C-BE23-FD3D-453756E5D8CB}"/>
               </a:ext>
             </a:extLst>
           </p:cNvPr>
@@ -2196,7 +2196,7 @@
           <p:cNvPr id="3" name="내용 개체 틀 2">
             <a:extLst>
               <a:ext uri="{FF2B5EF4-FFF2-40B4-BE49-F238E27FC236}">
-                <a16:creationId xmlns:a16="http://schemas.microsoft.com/office/drawing/2014/main" id="{A5B10768-D974-5682-569D-306BE94FEA1A}"/>
+                <a16:creationId xmlns:a16="http://schemas.microsoft.com/office/drawing/2014/main" id="{FF26679C-9EF9-0DAC-73FF-E87704FE4B4E}"/>
               </a:ext>
             </a:extLst>
           </p:cNvPr>
@@ -2286,7 +2286,7 @@
           <p:cNvPr id="4" name="텍스트 개체 틀 3">
             <a:extLst>
               <a:ext uri="{FF2B5EF4-FFF2-40B4-BE49-F238E27FC236}">
-                <a16:creationId xmlns:a16="http://schemas.microsoft.com/office/drawing/2014/main" id="{15A8D91C-5922-425A-90C7-FB9216F9C816}"/>
+                <a16:creationId xmlns:a16="http://schemas.microsoft.com/office/drawing/2014/main" id="{EC86C164-867B-FEF9-4C54-83AD45ADBEEE}"/>
               </a:ext>
             </a:extLst>
           </p:cNvPr>
@@ -2357,7 +2357,7 @@
           <p:cNvPr id="5" name="날짜 개체 틀 4">
             <a:extLst>
               <a:ext uri="{FF2B5EF4-FFF2-40B4-BE49-F238E27FC236}">
-                <a16:creationId xmlns:a16="http://schemas.microsoft.com/office/drawing/2014/main" id="{984769B0-3055-6673-F0C1-5F5D5D24AFAD}"/>
+                <a16:creationId xmlns:a16="http://schemas.microsoft.com/office/drawing/2014/main" id="{CCD49319-82C8-0EA9-A972-C5F634CF04B5}"/>
               </a:ext>
             </a:extLst>
           </p:cNvPr>
@@ -2373,7 +2373,7 @@
           <a:bodyPr/>
           <a:lstStyle/>
           <a:p>
-            <a:fld id="{A63FB5EC-CF88-4035-A752-ACC250E0626A}" type="datetimeFigureOut">
+            <a:fld id="{E848CDE2-9FE7-40BA-9BF4-AE70776CEE5B}" type="datetimeFigureOut">
               <a:rPr lang="ko-KR" altLang="en-US" smtClean="0"/>
               <a:t>2026-06-20</a:t>
             </a:fld>
@@ -2386,7 +2386,7 @@
           <p:cNvPr id="6" name="바닥글 개체 틀 5">
             <a:extLst>
               <a:ext uri="{FF2B5EF4-FFF2-40B4-BE49-F238E27FC236}">
-                <a16:creationId xmlns:a16="http://schemas.microsoft.com/office/drawing/2014/main" id="{F8BDC113-C5B6-00DA-6988-C89D5CD19FB7}"/>
+                <a16:creationId xmlns:a16="http://schemas.microsoft.com/office/drawing/2014/main" id="{51E4AAE1-20AC-B9A1-9D3C-5524FA1419CA}"/>
               </a:ext>
             </a:extLst>
           </p:cNvPr>
@@ -2411,7 +2411,7 @@
           <p:cNvPr id="7" name="슬라이드 번호 개체 틀 6">
             <a:extLst>
               <a:ext uri="{FF2B5EF4-FFF2-40B4-BE49-F238E27FC236}">
-                <a16:creationId xmlns:a16="http://schemas.microsoft.com/office/drawing/2014/main" id="{1F1C4F4A-1FF0-77DA-8B03-AEBE1CF54B1D}"/>
+                <a16:creationId xmlns:a16="http://schemas.microsoft.com/office/drawing/2014/main" id="{6D1B1B0A-BD4A-05A6-EEE4-900986EC1079}"/>
               </a:ext>
             </a:extLst>
           </p:cNvPr>
@@ -2427,7 +2427,7 @@
           <a:bodyPr/>
           <a:lstStyle/>
           <a:p>
-            <a:fld id="{FE9BD0AC-AD16-4498-B7AD-B58A3BA041BF}" type="slidenum">
+            <a:fld id="{DD9F5464-F4A4-4964-BECE-944A5E428E53}" type="slidenum">
               <a:rPr lang="ko-KR" altLang="en-US" smtClean="0"/>
               <a:t>‹#›</a:t>
             </a:fld>
@@ -2438,7 +2438,7 @@
     </p:spTree>
     <p:extLst>
       <p:ext uri="{BB962C8B-B14F-4D97-AF65-F5344CB8AC3E}">
-        <p14:creationId xmlns:p14="http://schemas.microsoft.com/office/powerpoint/2010/main" val="1809156513"/>
+        <p14:creationId xmlns:p14="http://schemas.microsoft.com/office/powerpoint/2010/main" val="1205516953"/>
       </p:ext>
     </p:extLst>
   </p:cSld>
@@ -2470,7 +2470,7 @@
           <p:cNvPr id="2" name="제목 1">
             <a:extLst>
               <a:ext uri="{FF2B5EF4-FFF2-40B4-BE49-F238E27FC236}">
-                <a16:creationId xmlns:a16="http://schemas.microsoft.com/office/drawing/2014/main" id="{EDEB0B9B-22C0-5642-5F96-CF8BB941605B}"/>
+                <a16:creationId xmlns:a16="http://schemas.microsoft.com/office/drawing/2014/main" id="{B106BA5A-292E-D494-6C9E-98A5137F7237}"/>
               </a:ext>
             </a:extLst>
           </p:cNvPr>
@@ -2507,7 +2507,7 @@
           <p:cNvPr id="3" name="그림 개체 틀 2">
             <a:extLst>
               <a:ext uri="{FF2B5EF4-FFF2-40B4-BE49-F238E27FC236}">
-                <a16:creationId xmlns:a16="http://schemas.microsoft.com/office/drawing/2014/main" id="{1CF96DA0-CE99-BA11-CED8-3C65AE79900F}"/>
+                <a16:creationId xmlns:a16="http://schemas.microsoft.com/office/drawing/2014/main" id="{BF3CB32D-2840-3BCC-12E7-A6738C20D009}"/>
               </a:ext>
             </a:extLst>
           </p:cNvPr>
@@ -2574,7 +2574,7 @@
           <p:cNvPr id="4" name="텍스트 개체 틀 3">
             <a:extLst>
               <a:ext uri="{FF2B5EF4-FFF2-40B4-BE49-F238E27FC236}">
-                <a16:creationId xmlns:a16="http://schemas.microsoft.com/office/drawing/2014/main" id="{5F821E12-CDB5-45C1-E45B-CBA6092C5219}"/>
+                <a16:creationId xmlns:a16="http://schemas.microsoft.com/office/drawing/2014/main" id="{6602DCE5-3313-EE42-A5B6-52C9527950B8}"/>
               </a:ext>
             </a:extLst>
           </p:cNvPr>
@@ -2645,7 +2645,7 @@
           <p:cNvPr id="5" name="날짜 개체 틀 4">
             <a:extLst>
               <a:ext uri="{FF2B5EF4-FFF2-40B4-BE49-F238E27FC236}">
-                <a16:creationId xmlns:a16="http://schemas.microsoft.com/office/drawing/2014/main" id="{F511C10F-D807-7335-170B-85FF52F24674}"/>
+                <a16:creationId xmlns:a16="http://schemas.microsoft.com/office/drawing/2014/main" id="{2E246E3E-282D-1404-2BBB-C60BEC7FE3B6}"/>
               </a:ext>
             </a:extLst>
           </p:cNvPr>
@@ -2661,7 +2661,7 @@
           <a:bodyPr/>
           <a:lstStyle/>
           <a:p>
-            <a:fld id="{A63FB5EC-CF88-4035-A752-ACC250E0626A}" type="datetimeFigureOut">
+            <a:fld id="{E848CDE2-9FE7-40BA-9BF4-AE70776CEE5B}" type="datetimeFigureOut">
               <a:rPr lang="ko-KR" altLang="en-US" smtClean="0"/>
               <a:t>2026-06-20</a:t>
             </a:fld>
@@ -2674,7 +2674,7 @@
           <p:cNvPr id="6" name="바닥글 개체 틀 5">
             <a:extLst>
               <a:ext uri="{FF2B5EF4-FFF2-40B4-BE49-F238E27FC236}">
-                <a16:creationId xmlns:a16="http://schemas.microsoft.com/office/drawing/2014/main" id="{C338F221-3BF3-BCDC-3DC5-7E082E84C715}"/>
+                <a16:creationId xmlns:a16="http://schemas.microsoft.com/office/drawing/2014/main" id="{1DBB5D62-A317-FB80-B961-992F88A892FC}"/>
               </a:ext>
             </a:extLst>
           </p:cNvPr>
@@ -2699,7 +2699,7 @@
           <p:cNvPr id="7" name="슬라이드 번호 개체 틀 6">
             <a:extLst>
               <a:ext uri="{FF2B5EF4-FFF2-40B4-BE49-F238E27FC236}">
-                <a16:creationId xmlns:a16="http://schemas.microsoft.com/office/drawing/2014/main" id="{63D78494-F116-A918-26DA-7F102F1AE673}"/>
+                <a16:creationId xmlns:a16="http://schemas.microsoft.com/office/drawing/2014/main" id="{3CEBE489-0505-933B-B8C9-0108DC0403D2}"/>
               </a:ext>
             </a:extLst>
           </p:cNvPr>
@@ -2715,7 +2715,7 @@
           <a:bodyPr/>
           <a:lstStyle/>
           <a:p>
-            <a:fld id="{FE9BD0AC-AD16-4498-B7AD-B58A3BA041BF}" type="slidenum">
+            <a:fld id="{DD9F5464-F4A4-4964-BECE-944A5E428E53}" type="slidenum">
               <a:rPr lang="ko-KR" altLang="en-US" smtClean="0"/>
               <a:t>‹#›</a:t>
             </a:fld>
@@ -2726,7 +2726,7 @@
     </p:spTree>
     <p:extLst>
       <p:ext uri="{BB962C8B-B14F-4D97-AF65-F5344CB8AC3E}">
-        <p14:creationId xmlns:p14="http://schemas.microsoft.com/office/powerpoint/2010/main" val="3190563830"/>
+        <p14:creationId xmlns:p14="http://schemas.microsoft.com/office/powerpoint/2010/main" val="3307314845"/>
       </p:ext>
     </p:extLst>
   </p:cSld>
@@ -2763,7 +2763,7 @@
           <p:cNvPr id="2" name="제목 개체 틀 1">
             <a:extLst>
               <a:ext uri="{FF2B5EF4-FFF2-40B4-BE49-F238E27FC236}">
-                <a16:creationId xmlns:a16="http://schemas.microsoft.com/office/drawing/2014/main" id="{01183E73-7F38-2E97-3029-B4E0EC818C8C}"/>
+                <a16:creationId xmlns:a16="http://schemas.microsoft.com/office/drawing/2014/main" id="{E04EE6ED-3B7F-E793-D94E-CE26A933E574}"/>
               </a:ext>
             </a:extLst>
           </p:cNvPr>
@@ -2801,7 +2801,7 @@
           <p:cNvPr id="3" name="텍스트 개체 틀 2">
             <a:extLst>
               <a:ext uri="{FF2B5EF4-FFF2-40B4-BE49-F238E27FC236}">
-                <a16:creationId xmlns:a16="http://schemas.microsoft.com/office/drawing/2014/main" id="{79D892E7-9763-76F4-90A6-02E6E2ABF407}"/>
+                <a16:creationId xmlns:a16="http://schemas.microsoft.com/office/drawing/2014/main" id="{1E7D42CD-9377-467C-2EE1-2A3E804CC26C}"/>
               </a:ext>
             </a:extLst>
           </p:cNvPr>
@@ -2868,7 +2868,7 @@
           <p:cNvPr id="4" name="날짜 개체 틀 3">
             <a:extLst>
               <a:ext uri="{FF2B5EF4-FFF2-40B4-BE49-F238E27FC236}">
-                <a16:creationId xmlns:a16="http://schemas.microsoft.com/office/drawing/2014/main" id="{617ED005-CED8-B543-EDDD-FDC148565AE5}"/>
+                <a16:creationId xmlns:a16="http://schemas.microsoft.com/office/drawing/2014/main" id="{29AE03BE-2968-610C-931B-A4FCAC02682D}"/>
               </a:ext>
             </a:extLst>
           </p:cNvPr>
@@ -2902,7 +2902,7 @@
             </a:lvl1pPr>
           </a:lstStyle>
           <a:p>
-            <a:fld id="{A63FB5EC-CF88-4035-A752-ACC250E0626A}" type="datetimeFigureOut">
+            <a:fld id="{E848CDE2-9FE7-40BA-9BF4-AE70776CEE5B}" type="datetimeFigureOut">
               <a:rPr lang="ko-KR" altLang="en-US" smtClean="0"/>
               <a:t>2026-06-20</a:t>
             </a:fld>
@@ -2915,7 +2915,7 @@
           <p:cNvPr id="5" name="바닥글 개체 틀 4">
             <a:extLst>
               <a:ext uri="{FF2B5EF4-FFF2-40B4-BE49-F238E27FC236}">
-                <a16:creationId xmlns:a16="http://schemas.microsoft.com/office/drawing/2014/main" id="{F72BDFCF-B4AF-DA01-109C-D8C7AD182495}"/>
+                <a16:creationId xmlns:a16="http://schemas.microsoft.com/office/drawing/2014/main" id="{375FA33C-1928-6F5D-DB1C-DFC2DA760B8E}"/>
               </a:ext>
             </a:extLst>
           </p:cNvPr>
@@ -2958,7 +2958,7 @@
           <p:cNvPr id="6" name="슬라이드 번호 개체 틀 5">
             <a:extLst>
               <a:ext uri="{FF2B5EF4-FFF2-40B4-BE49-F238E27FC236}">
-                <a16:creationId xmlns:a16="http://schemas.microsoft.com/office/drawing/2014/main" id="{AF63665B-B821-F6D3-DA43-1C52F3C8A113}"/>
+                <a16:creationId xmlns:a16="http://schemas.microsoft.com/office/drawing/2014/main" id="{5B8C61BB-8B76-3204-73FB-BA35C593F69F}"/>
               </a:ext>
             </a:extLst>
           </p:cNvPr>
@@ -2992,7 +2992,7 @@
             </a:lvl1pPr>
           </a:lstStyle>
           <a:p>
-            <a:fld id="{FE9BD0AC-AD16-4498-B7AD-B58A3BA041BF}" type="slidenum">
+            <a:fld id="{DD9F5464-F4A4-4964-BECE-944A5E428E53}" type="slidenum">
               <a:rPr lang="ko-KR" altLang="en-US" smtClean="0"/>
               <a:t>‹#›</a:t>
             </a:fld>
@@ -3003,7 +3003,7 @@
     </p:spTree>
     <p:extLst>
       <p:ext uri="{BB962C8B-B14F-4D97-AF65-F5344CB8AC3E}">
-        <p14:creationId xmlns:p14="http://schemas.microsoft.com/office/powerpoint/2010/main" val="3277023161"/>
+        <p14:creationId xmlns:p14="http://schemas.microsoft.com/office/powerpoint/2010/main" val="3698964218"/>
       </p:ext>
     </p:extLst>
   </p:cSld>
@@ -3326,7 +3326,7 @@
           <p:cNvPr id="2" name="z00_grid_top">
             <a:extLst>
               <a:ext uri="{FF2B5EF4-FFF2-40B4-BE49-F238E27FC236}">
-                <a16:creationId xmlns:a16="http://schemas.microsoft.com/office/drawing/2014/main" id="{7722F11C-4892-0F23-BB55-52003F5EFE7F}"/>
+                <a16:creationId xmlns:a16="http://schemas.microsoft.com/office/drawing/2014/main" id="{00475DBB-8F5F-C767-F1C1-5498618EDEED}"/>
               </a:ext>
             </a:extLst>
           </p:cNvPr>
@@ -3369,7 +3369,7 @@
           <p:cNvPr id="3" name="z00_grid_bottom">
             <a:extLst>
               <a:ext uri="{FF2B5EF4-FFF2-40B4-BE49-F238E27FC236}">
-                <a16:creationId xmlns:a16="http://schemas.microsoft.com/office/drawing/2014/main" id="{81507C64-5907-30A5-ACF7-ACAB4B9EA9F3}"/>
+                <a16:creationId xmlns:a16="http://schemas.microsoft.com/office/drawing/2014/main" id="{DF5256FD-F158-8128-5AAF-877400349DD7}"/>
               </a:ext>
             </a:extLst>
           </p:cNvPr>
@@ -3412,7 +3412,7 @@
           <p:cNvPr id="4" name="z00_grid_v_0">
             <a:extLst>
               <a:ext uri="{FF2B5EF4-FFF2-40B4-BE49-F238E27FC236}">
-                <a16:creationId xmlns:a16="http://schemas.microsoft.com/office/drawing/2014/main" id="{C903421C-E5B4-C411-DB6E-FECDB5FFE612}"/>
+                <a16:creationId xmlns:a16="http://schemas.microsoft.com/office/drawing/2014/main" id="{9CF67D0B-E5A9-A589-04DD-EC781B3F0632}"/>
               </a:ext>
             </a:extLst>
           </p:cNvPr>
@@ -3455,7 +3455,7 @@
           <p:cNvPr id="5" name="z00_grid_v_1">
             <a:extLst>
               <a:ext uri="{FF2B5EF4-FFF2-40B4-BE49-F238E27FC236}">
-                <a16:creationId xmlns:a16="http://schemas.microsoft.com/office/drawing/2014/main" id="{EDAC0E4F-45B2-E0D7-BAD2-11DCFD443B14}"/>
+                <a16:creationId xmlns:a16="http://schemas.microsoft.com/office/drawing/2014/main" id="{4FA74D82-9340-405E-3377-552D48906895}"/>
               </a:ext>
             </a:extLst>
           </p:cNvPr>
@@ -3498,7 +3498,7 @@
           <p:cNvPr id="6" name="z00_grid_v_2">
             <a:extLst>
               <a:ext uri="{FF2B5EF4-FFF2-40B4-BE49-F238E27FC236}">
-                <a16:creationId xmlns:a16="http://schemas.microsoft.com/office/drawing/2014/main" id="{98FB07C9-1198-B655-437B-D1D736A738D7}"/>
+                <a16:creationId xmlns:a16="http://schemas.microsoft.com/office/drawing/2014/main" id="{340D8C2D-8C88-AF82-FCD5-8E58DC051196}"/>
               </a:ext>
             </a:extLst>
           </p:cNvPr>
@@ -3541,7 +3541,7 @@
           <p:cNvPr id="7" name="header_title">
             <a:extLst>
               <a:ext uri="{FF2B5EF4-FFF2-40B4-BE49-F238E27FC236}">
-                <a16:creationId xmlns:a16="http://schemas.microsoft.com/office/drawing/2014/main" id="{8C6F9F3A-138F-8068-17E3-D6B3E55ABB84}"/>
+                <a16:creationId xmlns:a16="http://schemas.microsoft.com/office/drawing/2014/main" id="{0D4A10B1-B3BD-B38C-C03C-2883C4E3DF4C}"/>
               </a:ext>
             </a:extLst>
           </p:cNvPr>
@@ -3587,7 +3587,7 @@
           <p:cNvPr id="8" name="header_subtitle">
             <a:extLst>
               <a:ext uri="{FF2B5EF4-FFF2-40B4-BE49-F238E27FC236}">
-                <a16:creationId xmlns:a16="http://schemas.microsoft.com/office/drawing/2014/main" id="{1278923A-9C24-6C68-DB5B-652B7CCD90E9}"/>
+                <a16:creationId xmlns:a16="http://schemas.microsoft.com/office/drawing/2014/main" id="{80E9F703-909F-D112-6F49-896EE3710F28}"/>
               </a:ext>
             </a:extLst>
           </p:cNvPr>
@@ -3633,7 +3633,7 @@
           <p:cNvPr id="9" name="zone_content_panel">
             <a:extLst>
               <a:ext uri="{FF2B5EF4-FFF2-40B4-BE49-F238E27FC236}">
-                <a16:creationId xmlns:a16="http://schemas.microsoft.com/office/drawing/2014/main" id="{E238D4A7-6AE3-52FE-432A-9485760A29BD}"/>
+                <a16:creationId xmlns:a16="http://schemas.microsoft.com/office/drawing/2014/main" id="{A694FDBF-6D32-D106-82AB-11C33D6FEF7D}"/>
               </a:ext>
             </a:extLst>
           </p:cNvPr>
@@ -3694,7 +3694,7 @@
           <p:cNvPr id="10" name="zone_content_title">
             <a:extLst>
               <a:ext uri="{FF2B5EF4-FFF2-40B4-BE49-F238E27FC236}">
-                <a16:creationId xmlns:a16="http://schemas.microsoft.com/office/drawing/2014/main" id="{0C51956F-EAF5-6383-A9DC-4458C1905A75}"/>
+                <a16:creationId xmlns:a16="http://schemas.microsoft.com/office/drawing/2014/main" id="{FD63BC1D-B40D-3872-9BD8-70A71485108F}"/>
               </a:ext>
             </a:extLst>
           </p:cNvPr>
@@ -3740,7 +3740,7 @@
           <p:cNvPr id="11" name="zone_content_subtitle">
             <a:extLst>
               <a:ext uri="{FF2B5EF4-FFF2-40B4-BE49-F238E27FC236}">
-                <a16:creationId xmlns:a16="http://schemas.microsoft.com/office/drawing/2014/main" id="{9CAA5B4D-2EE0-0C96-AA29-DC08C026A178}"/>
+                <a16:creationId xmlns:a16="http://schemas.microsoft.com/office/drawing/2014/main" id="{5C263190-19F6-FD00-D421-F392ACC34972}"/>
               </a:ext>
             </a:extLst>
           </p:cNvPr>
@@ -3786,7 +3786,7 @@
           <p:cNvPr id="12" name="zone_reasoning_panel">
             <a:extLst>
               <a:ext uri="{FF2B5EF4-FFF2-40B4-BE49-F238E27FC236}">
-                <a16:creationId xmlns:a16="http://schemas.microsoft.com/office/drawing/2014/main" id="{F4A2EE2F-FBF2-CD9B-33E6-16FCB47DE534}"/>
+                <a16:creationId xmlns:a16="http://schemas.microsoft.com/office/drawing/2014/main" id="{CBACF3A7-A37B-CEE0-F0B6-237697977DEC}"/>
               </a:ext>
             </a:extLst>
           </p:cNvPr>
@@ -3847,7 +3847,7 @@
           <p:cNvPr id="13" name="zone_reasoning_title">
             <a:extLst>
               <a:ext uri="{FF2B5EF4-FFF2-40B4-BE49-F238E27FC236}">
-                <a16:creationId xmlns:a16="http://schemas.microsoft.com/office/drawing/2014/main" id="{485CAA72-4ADD-A2F3-D5F1-0FD150F3AB76}"/>
+                <a16:creationId xmlns:a16="http://schemas.microsoft.com/office/drawing/2014/main" id="{F7D9427E-7F6F-14EB-E9E5-47FE1ABCE86D}"/>
               </a:ext>
             </a:extLst>
           </p:cNvPr>
@@ -3893,7 +3893,7 @@
           <p:cNvPr id="14" name="zone_reasoning_subtitle">
             <a:extLst>
               <a:ext uri="{FF2B5EF4-FFF2-40B4-BE49-F238E27FC236}">
-                <a16:creationId xmlns:a16="http://schemas.microsoft.com/office/drawing/2014/main" id="{6CCEC35B-B323-7F5D-D4CE-0791B3E61F65}"/>
+                <a16:creationId xmlns:a16="http://schemas.microsoft.com/office/drawing/2014/main" id="{66C5D5E4-5852-CBF7-18E5-2A22BB20DF0C}"/>
               </a:ext>
             </a:extLst>
           </p:cNvPr>
@@ -3939,7 +3939,7 @@
           <p:cNvPr id="15" name="zone_rules_panel">
             <a:extLst>
               <a:ext uri="{FF2B5EF4-FFF2-40B4-BE49-F238E27FC236}">
-                <a16:creationId xmlns:a16="http://schemas.microsoft.com/office/drawing/2014/main" id="{F4E78355-AE73-436A-A680-A07337B4DEA4}"/>
+                <a16:creationId xmlns:a16="http://schemas.microsoft.com/office/drawing/2014/main" id="{3B17F8EB-CFAC-5805-47FF-9932054B5A99}"/>
               </a:ext>
             </a:extLst>
           </p:cNvPr>
@@ -4000,7 +4000,7 @@
           <p:cNvPr id="16" name="zone_rules_title">
             <a:extLst>
               <a:ext uri="{FF2B5EF4-FFF2-40B4-BE49-F238E27FC236}">
-                <a16:creationId xmlns:a16="http://schemas.microsoft.com/office/drawing/2014/main" id="{4E217526-C679-EE99-7AB0-1923C9482F3A}"/>
+                <a16:creationId xmlns:a16="http://schemas.microsoft.com/office/drawing/2014/main" id="{B16ACC0C-78DB-8D8E-0924-8E6F1057EDD2}"/>
               </a:ext>
             </a:extLst>
           </p:cNvPr>
@@ -4046,7 +4046,7 @@
           <p:cNvPr id="17" name="zone_rules_subtitle">
             <a:extLst>
               <a:ext uri="{FF2B5EF4-FFF2-40B4-BE49-F238E27FC236}">
-                <a16:creationId xmlns:a16="http://schemas.microsoft.com/office/drawing/2014/main" id="{3ECE5EB2-7B56-F577-FD36-EE7769739378}"/>
+                <a16:creationId xmlns:a16="http://schemas.microsoft.com/office/drawing/2014/main" id="{0F7AFC3A-9BE2-1F81-F4EF-A662E5DBD3D1}"/>
               </a:ext>
             </a:extLst>
           </p:cNvPr>
@@ -4092,7 +4092,7 @@
           <p:cNvPr id="18" name="zone_outputs_panel">
             <a:extLst>
               <a:ext uri="{FF2B5EF4-FFF2-40B4-BE49-F238E27FC236}">
-                <a16:creationId xmlns:a16="http://schemas.microsoft.com/office/drawing/2014/main" id="{AB39D39D-A08F-7470-0CD5-689B9E11EC29}"/>
+                <a16:creationId xmlns:a16="http://schemas.microsoft.com/office/drawing/2014/main" id="{D36EA134-7663-5B8D-3D0E-21B504F44DEE}"/>
               </a:ext>
             </a:extLst>
           </p:cNvPr>
@@ -4153,7 +4153,7 @@
           <p:cNvPr id="19" name="zone_outputs_title">
             <a:extLst>
               <a:ext uri="{FF2B5EF4-FFF2-40B4-BE49-F238E27FC236}">
-                <a16:creationId xmlns:a16="http://schemas.microsoft.com/office/drawing/2014/main" id="{E7E9B0E1-D152-C312-6A7A-D8A697DB9C0D}"/>
+                <a16:creationId xmlns:a16="http://schemas.microsoft.com/office/drawing/2014/main" id="{B8396C2A-3BCA-5659-AC42-6E7E5EA71741}"/>
               </a:ext>
             </a:extLst>
           </p:cNvPr>
@@ -4199,7 +4199,7 @@
           <p:cNvPr id="20" name="zone_outputs_subtitle">
             <a:extLst>
               <a:ext uri="{FF2B5EF4-FFF2-40B4-BE49-F238E27FC236}">
-                <a16:creationId xmlns:a16="http://schemas.microsoft.com/office/drawing/2014/main" id="{B89429F1-362C-1D44-A4B7-A7009245945F}"/>
+                <a16:creationId xmlns:a16="http://schemas.microsoft.com/office/drawing/2014/main" id="{FC191FE8-A0FA-897A-DCA3-712BB09219C4}"/>
               </a:ext>
             </a:extLst>
           </p:cNvPr>
@@ -4245,7 +4245,7 @@
           <p:cNvPr id="21" name="main_start_markdown">
             <a:extLst>
               <a:ext uri="{FF2B5EF4-FFF2-40B4-BE49-F238E27FC236}">
-                <a16:creationId xmlns:a16="http://schemas.microsoft.com/office/drawing/2014/main" id="{26A49D9C-7DF6-A1C5-4411-3921DBA0F21B}"/>
+                <a16:creationId xmlns:a16="http://schemas.microsoft.com/office/drawing/2014/main" id="{0A75AFE4-6342-31FA-1D8A-B11F44716402}"/>
               </a:ext>
             </a:extLst>
           </p:cNvPr>
@@ -4288,7 +4288,7 @@
           <p:cNvPr id="22" name="main_markdown_splitter">
             <a:extLst>
               <a:ext uri="{FF2B5EF4-FFF2-40B4-BE49-F238E27FC236}">
-                <a16:creationId xmlns:a16="http://schemas.microsoft.com/office/drawing/2014/main" id="{DA4482F0-294C-3E66-E138-D54E5C162A29}"/>
+                <a16:creationId xmlns:a16="http://schemas.microsoft.com/office/drawing/2014/main" id="{6039A92C-D677-6646-5506-51DA0D56E9C3}"/>
               </a:ext>
             </a:extLst>
           </p:cNvPr>
@@ -4331,7 +4331,7 @@
           <p:cNvPr id="23" name="main_splitter_ir_seg_1">
             <a:extLst>
               <a:ext uri="{FF2B5EF4-FFF2-40B4-BE49-F238E27FC236}">
-                <a16:creationId xmlns:a16="http://schemas.microsoft.com/office/drawing/2014/main" id="{E68131D9-6CAA-0B9D-3573-0BDE93ED67F4}"/>
+                <a16:creationId xmlns:a16="http://schemas.microsoft.com/office/drawing/2014/main" id="{0BCB1058-A20F-97A6-E48D-46BD6496D922}"/>
               </a:ext>
             </a:extLst>
           </p:cNvPr>
@@ -4374,7 +4374,7 @@
           <p:cNvPr id="24" name="main_splitter_ir_seg_2">
             <a:extLst>
               <a:ext uri="{FF2B5EF4-FFF2-40B4-BE49-F238E27FC236}">
-                <a16:creationId xmlns:a16="http://schemas.microsoft.com/office/drawing/2014/main" id="{972B8B13-DA58-DB33-B135-80B0FD37341C}"/>
+                <a16:creationId xmlns:a16="http://schemas.microsoft.com/office/drawing/2014/main" id="{E5173165-BFF1-D1C6-E75C-5F3D10B69874}"/>
               </a:ext>
             </a:extLst>
           </p:cNvPr>
@@ -4417,7 +4417,7 @@
           <p:cNvPr id="25" name="main_splitter_ir_seg_3">
             <a:extLst>
               <a:ext uri="{FF2B5EF4-FFF2-40B4-BE49-F238E27FC236}">
-                <a16:creationId xmlns:a16="http://schemas.microsoft.com/office/drawing/2014/main" id="{DE7E84EF-133B-A5F0-6306-CE81D0CCC327}"/>
+                <a16:creationId xmlns:a16="http://schemas.microsoft.com/office/drawing/2014/main" id="{1870CB06-6A8F-A25C-5330-3D93141F3F87}"/>
               </a:ext>
             </a:extLst>
           </p:cNvPr>
@@ -4460,7 +4460,7 @@
           <p:cNvPr id="26" name="hint_ir_reasoning">
             <a:extLst>
               <a:ext uri="{FF2B5EF4-FFF2-40B4-BE49-F238E27FC236}">
-                <a16:creationId xmlns:a16="http://schemas.microsoft.com/office/drawing/2014/main" id="{FDD78AAB-68FE-04D7-C1C5-7F62B6AB5BF4}"/>
+                <a16:creationId xmlns:a16="http://schemas.microsoft.com/office/drawing/2014/main" id="{B55C0045-491E-D79E-E4CA-F7346347A1FA}"/>
               </a:ext>
             </a:extLst>
           </p:cNvPr>
@@ -4504,7 +4504,7 @@
           <p:cNvPr id="27" name="main_ir_rules">
             <a:extLst>
               <a:ext uri="{FF2B5EF4-FFF2-40B4-BE49-F238E27FC236}">
-                <a16:creationId xmlns:a16="http://schemas.microsoft.com/office/drawing/2014/main" id="{6C30D4B0-D0CC-BA83-BF1F-E9A47CABA730}"/>
+                <a16:creationId xmlns:a16="http://schemas.microsoft.com/office/drawing/2014/main" id="{C6E3D79A-FC31-A0F1-B27B-90B94AAE47DA}"/>
               </a:ext>
             </a:extLst>
           </p:cNvPr>
@@ -4547,7 +4547,7 @@
           <p:cNvPr id="28" name="hint_reasoning_rules_seg_1">
             <a:extLst>
               <a:ext uri="{FF2B5EF4-FFF2-40B4-BE49-F238E27FC236}">
-                <a16:creationId xmlns:a16="http://schemas.microsoft.com/office/drawing/2014/main" id="{68CF229D-BEC2-E5DE-4F1B-30EE9D721292}"/>
+                <a16:creationId xmlns:a16="http://schemas.microsoft.com/office/drawing/2014/main" id="{77699F3C-377F-34FB-09B0-91FD3BB69F41}"/>
               </a:ext>
             </a:extLst>
           </p:cNvPr>
@@ -4591,7 +4591,7 @@
           <p:cNvPr id="29" name="hint_reasoning_rules_seg_2">
             <a:extLst>
               <a:ext uri="{FF2B5EF4-FFF2-40B4-BE49-F238E27FC236}">
-                <a16:creationId xmlns:a16="http://schemas.microsoft.com/office/drawing/2014/main" id="{20B3587C-4EE5-4597-1D4F-B61AB1D8A48E}"/>
+                <a16:creationId xmlns:a16="http://schemas.microsoft.com/office/drawing/2014/main" id="{8820E3D2-975D-5921-29D4-9E943063937E}"/>
               </a:ext>
             </a:extLst>
           </p:cNvPr>
@@ -4635,7 +4635,7 @@
           <p:cNvPr id="30" name="hint_reasoning_rules_seg_3">
             <a:extLst>
               <a:ext uri="{FF2B5EF4-FFF2-40B4-BE49-F238E27FC236}">
-                <a16:creationId xmlns:a16="http://schemas.microsoft.com/office/drawing/2014/main" id="{5E57C18A-0853-3D98-759A-41C482D99C1E}"/>
+                <a16:creationId xmlns:a16="http://schemas.microsoft.com/office/drawing/2014/main" id="{C77A6AE7-C66C-1BD8-D670-BD3B367CABFE}"/>
               </a:ext>
             </a:extLst>
           </p:cNvPr>
@@ -4679,7 +4679,7 @@
           <p:cNvPr id="31" name="rule_features_recipes">
             <a:extLst>
               <a:ext uri="{FF2B5EF4-FFF2-40B4-BE49-F238E27FC236}">
-                <a16:creationId xmlns:a16="http://schemas.microsoft.com/office/drawing/2014/main" id="{E1FB2039-2F79-4B7C-F723-7CC156EE6441}"/>
+                <a16:creationId xmlns:a16="http://schemas.microsoft.com/office/drawing/2014/main" id="{06A9AFB4-1C56-D29A-AA56-8C6B411EF5DB}"/>
               </a:ext>
             </a:extLst>
           </p:cNvPr>
@@ -4722,7 +4722,7 @@
           <p:cNvPr id="32" name="rule_recipes_theme">
             <a:extLst>
               <a:ext uri="{FF2B5EF4-FFF2-40B4-BE49-F238E27FC236}">
-                <a16:creationId xmlns:a16="http://schemas.microsoft.com/office/drawing/2014/main" id="{152B82B3-43CA-48FF-CD4C-40D34EC88D2B}"/>
+                <a16:creationId xmlns:a16="http://schemas.microsoft.com/office/drawing/2014/main" id="{E2D95235-70F7-D376-44ED-DABD9616DB95}"/>
               </a:ext>
             </a:extLst>
           </p:cNvPr>
@@ -4765,7 +4765,7 @@
           <p:cNvPr id="33" name="rule_features_compose">
             <a:extLst>
               <a:ext uri="{FF2B5EF4-FFF2-40B4-BE49-F238E27FC236}">
-                <a16:creationId xmlns:a16="http://schemas.microsoft.com/office/drawing/2014/main" id="{FB07F8C2-3ECB-153C-5C95-509750899E23}"/>
+                <a16:creationId xmlns:a16="http://schemas.microsoft.com/office/drawing/2014/main" id="{CFC060DD-5A4A-D7C0-584A-6FF4B1C6A701}"/>
               </a:ext>
             </a:extLst>
           </p:cNvPr>
@@ -4808,7 +4808,7 @@
           <p:cNvPr id="34" name="rule_recipes_objects">
             <a:extLst>
               <a:ext uri="{FF2B5EF4-FFF2-40B4-BE49-F238E27FC236}">
-                <a16:creationId xmlns:a16="http://schemas.microsoft.com/office/drawing/2014/main" id="{9CEFB7CA-A0D6-0425-ADC9-A680C5F375D9}"/>
+                <a16:creationId xmlns:a16="http://schemas.microsoft.com/office/drawing/2014/main" id="{F248C9AB-A8D9-387F-1A17-22B0407985B7}"/>
               </a:ext>
             </a:extLst>
           </p:cNvPr>
@@ -4851,7 +4851,7 @@
           <p:cNvPr id="35" name="rule_theme_decorate">
             <a:extLst>
               <a:ext uri="{FF2B5EF4-FFF2-40B4-BE49-F238E27FC236}">
-                <a16:creationId xmlns:a16="http://schemas.microsoft.com/office/drawing/2014/main" id="{CA3EA1C7-C922-F100-4C20-B39C6ADCE156}"/>
+                <a16:creationId xmlns:a16="http://schemas.microsoft.com/office/drawing/2014/main" id="{F3F90A5E-0981-4342-6F32-AF5C1AF76EAB}"/>
               </a:ext>
             </a:extLst>
           </p:cNvPr>
@@ -4894,7 +4894,7 @@
           <p:cNvPr id="36" name="rule_compose_objects">
             <a:extLst>
               <a:ext uri="{FF2B5EF4-FFF2-40B4-BE49-F238E27FC236}">
-                <a16:creationId xmlns:a16="http://schemas.microsoft.com/office/drawing/2014/main" id="{6B8486F3-499D-10BC-C4C3-A81DEB7942ED}"/>
+                <a16:creationId xmlns:a16="http://schemas.microsoft.com/office/drawing/2014/main" id="{FADC1D49-3ABE-63E0-4C8F-90B8E542D5F7}"/>
               </a:ext>
             </a:extLst>
           </p:cNvPr>
@@ -4937,7 +4937,7 @@
           <p:cNvPr id="37" name="rule_objects_decorate">
             <a:extLst>
               <a:ext uri="{FF2B5EF4-FFF2-40B4-BE49-F238E27FC236}">
-                <a16:creationId xmlns:a16="http://schemas.microsoft.com/office/drawing/2014/main" id="{571E6CC1-A8DB-8026-62BD-E0DB4F3EE398}"/>
+                <a16:creationId xmlns:a16="http://schemas.microsoft.com/office/drawing/2014/main" id="{104D19E9-4F4C-7276-C9AD-00AF9D018795}"/>
               </a:ext>
             </a:extLst>
           </p:cNvPr>
@@ -4980,7 +4980,7 @@
           <p:cNvPr id="38" name="main_rules_styled_ir">
             <a:extLst>
               <a:ext uri="{FF2B5EF4-FFF2-40B4-BE49-F238E27FC236}">
-                <a16:creationId xmlns:a16="http://schemas.microsoft.com/office/drawing/2014/main" id="{1D441198-26CC-D9F4-B018-D42FCA786F54}"/>
+                <a16:creationId xmlns:a16="http://schemas.microsoft.com/office/drawing/2014/main" id="{55BAD3EC-C119-D3FD-FBE7-50360CA66698}"/>
               </a:ext>
             </a:extLst>
           </p:cNvPr>
@@ -5023,7 +5023,7 @@
           <p:cNvPr id="39" name="main_styled_renderers">
             <a:extLst>
               <a:ext uri="{FF2B5EF4-FFF2-40B4-BE49-F238E27FC236}">
-                <a16:creationId xmlns:a16="http://schemas.microsoft.com/office/drawing/2014/main" id="{7765697B-F77B-F908-EBE3-8E4B27CC9827}"/>
+                <a16:creationId xmlns:a16="http://schemas.microsoft.com/office/drawing/2014/main" id="{E027DB1D-51AE-95F9-9A42-913EEB67E45C}"/>
               </a:ext>
             </a:extLst>
           </p:cNvPr>
@@ -5066,7 +5066,7 @@
           <p:cNvPr id="40" name="validation_loop">
             <a:extLst>
               <a:ext uri="{FF2B5EF4-FFF2-40B4-BE49-F238E27FC236}">
-                <a16:creationId xmlns:a16="http://schemas.microsoft.com/office/drawing/2014/main" id="{858378A6-F29A-79E1-AD48-98030ADA18E8}"/>
+                <a16:creationId xmlns:a16="http://schemas.microsoft.com/office/drawing/2014/main" id="{E41FEA22-15F0-2F31-98D8-01269F0DB5E9}"/>
               </a:ext>
             </a:extLst>
           </p:cNvPr>
@@ -5109,7 +5109,7 @@
           <p:cNvPr id="41" name="source_chip">
             <a:extLst>
               <a:ext uri="{FF2B5EF4-FFF2-40B4-BE49-F238E27FC236}">
-                <a16:creationId xmlns:a16="http://schemas.microsoft.com/office/drawing/2014/main" id="{D92CD025-D8D3-432B-9AD0-DC651A884602}"/>
+                <a16:creationId xmlns:a16="http://schemas.microsoft.com/office/drawing/2014/main" id="{77C50564-8F29-955A-3954-BE072141CD8C}"/>
               </a:ext>
             </a:extLst>
           </p:cNvPr>
@@ -5170,7 +5170,7 @@
           <p:cNvPr id="42" name="source_chip_text">
             <a:extLst>
               <a:ext uri="{FF2B5EF4-FFF2-40B4-BE49-F238E27FC236}">
-                <a16:creationId xmlns:a16="http://schemas.microsoft.com/office/drawing/2014/main" id="{819F1BE0-E948-E0AE-2A99-56CA87F6C5AC}"/>
+                <a16:creationId xmlns:a16="http://schemas.microsoft.com/office/drawing/2014/main" id="{56270CA3-2411-B33C-997D-E0954BE0C36B}"/>
               </a:ext>
             </a:extLst>
           </p:cNvPr>
@@ -5217,7 +5217,7 @@
           <p:cNvPr id="43" name="markdown_card">
             <a:extLst>
               <a:ext uri="{FF2B5EF4-FFF2-40B4-BE49-F238E27FC236}">
-                <a16:creationId xmlns:a16="http://schemas.microsoft.com/office/drawing/2014/main" id="{919D73DE-14E9-6038-072A-873A6371A81F}"/>
+                <a16:creationId xmlns:a16="http://schemas.microsoft.com/office/drawing/2014/main" id="{03C22E06-7E5F-083F-69CE-5F1A17BE0C66}"/>
               </a:ext>
             </a:extLst>
           </p:cNvPr>
@@ -5278,7 +5278,7 @@
           <p:cNvPr id="44" name="markdown_icon_dot">
             <a:extLst>
               <a:ext uri="{FF2B5EF4-FFF2-40B4-BE49-F238E27FC236}">
-                <a16:creationId xmlns:a16="http://schemas.microsoft.com/office/drawing/2014/main" id="{FB51F82D-A4D1-534B-D123-C5FF5A32B8EC}"/>
+                <a16:creationId xmlns:a16="http://schemas.microsoft.com/office/drawing/2014/main" id="{F00FFA6C-2640-0042-109D-FF506CD8CCD7}"/>
               </a:ext>
             </a:extLst>
           </p:cNvPr>
@@ -5332,7 +5332,7 @@
           <p:cNvPr id="45" name="markdown_icon_label">
             <a:extLst>
               <a:ext uri="{FF2B5EF4-FFF2-40B4-BE49-F238E27FC236}">
-                <a16:creationId xmlns:a16="http://schemas.microsoft.com/office/drawing/2014/main" id="{DDBEF82A-82CF-AE06-BCD5-BD9F00028D04}"/>
+                <a16:creationId xmlns:a16="http://schemas.microsoft.com/office/drawing/2014/main" id="{ED936A40-13F2-D21A-AE6D-BE7F0EC5941F}"/>
               </a:ext>
             </a:extLst>
           </p:cNvPr>
@@ -5341,8 +5341,8 @@
         </p:nvSpPr>
         <p:spPr>
           <a:xfrm>
-            <a:off x="1184336" y="2921123"/>
-            <a:ext cx="191584" cy="285806"/>
+            <a:off x="1184336" y="2913447"/>
+            <a:ext cx="191584" cy="276999"/>
           </a:xfrm>
           <a:prstGeom prst="rect">
             <a:avLst/>
@@ -5350,7 +5350,7 @@
           <a:noFill/>
         </p:spPr>
         <p:txBody>
-          <a:bodyPr vert="horz" wrap="square" lIns="8708" tIns="4361" rIns="8708" bIns="4361" rtlCol="0" anchor="ctr">
+          <a:bodyPr vert="horz" wrap="square" lIns="0" tIns="0" rIns="0" bIns="0" rtlCol="0" anchor="ctr">
             <a:noAutofit/>
           </a:bodyPr>
           <a:lstStyle/>
@@ -5379,7 +5379,7 @@
           <p:cNvPr id="46" name="markdown_title">
             <a:extLst>
               <a:ext uri="{FF2B5EF4-FFF2-40B4-BE49-F238E27FC236}">
-                <a16:creationId xmlns:a16="http://schemas.microsoft.com/office/drawing/2014/main" id="{274FB7A1-A2B1-A7AF-5913-6BE4DF835EF1}"/>
+                <a16:creationId xmlns:a16="http://schemas.microsoft.com/office/drawing/2014/main" id="{B88FDB95-15E5-EABE-EA1C-B7CB0A8BCA86}"/>
               </a:ext>
             </a:extLst>
           </p:cNvPr>
@@ -5425,7 +5425,7 @@
           <p:cNvPr id="47" name="markdown_line_0">
             <a:extLst>
               <a:ext uri="{FF2B5EF4-FFF2-40B4-BE49-F238E27FC236}">
-                <a16:creationId xmlns:a16="http://schemas.microsoft.com/office/drawing/2014/main" id="{F59EB15F-9B76-7167-4DCF-B5E501C61670}"/>
+                <a16:creationId xmlns:a16="http://schemas.microsoft.com/office/drawing/2014/main" id="{7A27354E-2EFD-BC32-CB52-9111EF3D054A}"/>
               </a:ext>
             </a:extLst>
           </p:cNvPr>
@@ -5471,7 +5471,7 @@
           <p:cNvPr id="48" name="markdown_line_1">
             <a:extLst>
               <a:ext uri="{FF2B5EF4-FFF2-40B4-BE49-F238E27FC236}">
-                <a16:creationId xmlns:a16="http://schemas.microsoft.com/office/drawing/2014/main" id="{C5544588-6744-8F7E-96C3-FB12CC530D83}"/>
+                <a16:creationId xmlns:a16="http://schemas.microsoft.com/office/drawing/2014/main" id="{54DCCA3F-C33C-5350-2E1D-A58D3EB0B794}"/>
               </a:ext>
             </a:extLst>
           </p:cNvPr>
@@ -5517,7 +5517,7 @@
           <p:cNvPr id="49" name="splitter_card">
             <a:extLst>
               <a:ext uri="{FF2B5EF4-FFF2-40B4-BE49-F238E27FC236}">
-                <a16:creationId xmlns:a16="http://schemas.microsoft.com/office/drawing/2014/main" id="{FB29592F-CE9B-893A-F91B-52C85E2C77FA}"/>
+                <a16:creationId xmlns:a16="http://schemas.microsoft.com/office/drawing/2014/main" id="{7734659F-E9E8-299A-4776-AEEB07A113CB}"/>
               </a:ext>
             </a:extLst>
           </p:cNvPr>
@@ -5578,7 +5578,7 @@
           <p:cNvPr id="50" name="splitter_icon_dot">
             <a:extLst>
               <a:ext uri="{FF2B5EF4-FFF2-40B4-BE49-F238E27FC236}">
-                <a16:creationId xmlns:a16="http://schemas.microsoft.com/office/drawing/2014/main" id="{9A7C96D9-7FFA-3D10-B975-D7031646E617}"/>
+                <a16:creationId xmlns:a16="http://schemas.microsoft.com/office/drawing/2014/main" id="{7C19050A-58D3-9B6A-F3C6-B23610D2F2EF}"/>
               </a:ext>
             </a:extLst>
           </p:cNvPr>
@@ -5632,7 +5632,7 @@
           <p:cNvPr id="51" name="splitter_icon_label">
             <a:extLst>
               <a:ext uri="{FF2B5EF4-FFF2-40B4-BE49-F238E27FC236}">
-                <a16:creationId xmlns:a16="http://schemas.microsoft.com/office/drawing/2014/main" id="{687B4862-0C82-F0B3-EA74-5CC797A05C8E}"/>
+                <a16:creationId xmlns:a16="http://schemas.microsoft.com/office/drawing/2014/main" id="{564C25E1-5F34-3A11-9ECD-BBF4828485F2}"/>
               </a:ext>
             </a:extLst>
           </p:cNvPr>
@@ -5641,8 +5641,8 @@
         </p:nvSpPr>
         <p:spPr>
           <a:xfrm>
-            <a:off x="1184336" y="4142328"/>
-            <a:ext cx="191584" cy="285806"/>
+            <a:off x="1184336" y="4134652"/>
+            <a:ext cx="191584" cy="276999"/>
           </a:xfrm>
           <a:prstGeom prst="rect">
             <a:avLst/>
@@ -5650,7 +5650,7 @@
           <a:noFill/>
         </p:spPr>
         <p:txBody>
-          <a:bodyPr vert="horz" wrap="square" lIns="8708" tIns="4361" rIns="8708" bIns="4361" rtlCol="0" anchor="ctr">
+          <a:bodyPr vert="horz" wrap="square" lIns="0" tIns="0" rIns="0" bIns="0" rtlCol="0" anchor="ctr">
             <a:noAutofit/>
           </a:bodyPr>
           <a:lstStyle/>
@@ -5679,7 +5679,7 @@
           <p:cNvPr id="52" name="splitter_title">
             <a:extLst>
               <a:ext uri="{FF2B5EF4-FFF2-40B4-BE49-F238E27FC236}">
-                <a16:creationId xmlns:a16="http://schemas.microsoft.com/office/drawing/2014/main" id="{F8262AD8-C222-6AF9-1230-75020BEC3B5E}"/>
+                <a16:creationId xmlns:a16="http://schemas.microsoft.com/office/drawing/2014/main" id="{1F6908D0-CCB5-0C70-0F1A-C294DCAB46F6}"/>
               </a:ext>
             </a:extLst>
           </p:cNvPr>
@@ -5725,7 +5725,7 @@
           <p:cNvPr id="53" name="splitter_line_0">
             <a:extLst>
               <a:ext uri="{FF2B5EF4-FFF2-40B4-BE49-F238E27FC236}">
-                <a16:creationId xmlns:a16="http://schemas.microsoft.com/office/drawing/2014/main" id="{215FCEC1-468B-E7C4-1BBD-FE4ED15312FC}"/>
+                <a16:creationId xmlns:a16="http://schemas.microsoft.com/office/drawing/2014/main" id="{5564F389-089F-803F-8030-F74B1B5822E9}"/>
               </a:ext>
             </a:extLst>
           </p:cNvPr>
@@ -5771,7 +5771,7 @@
           <p:cNvPr id="54" name="splitter_line_1">
             <a:extLst>
               <a:ext uri="{FF2B5EF4-FFF2-40B4-BE49-F238E27FC236}">
-                <a16:creationId xmlns:a16="http://schemas.microsoft.com/office/drawing/2014/main" id="{CC883366-7924-EEB5-2510-1060C4976F88}"/>
+                <a16:creationId xmlns:a16="http://schemas.microsoft.com/office/drawing/2014/main" id="{EFD63F27-2A05-A9CD-D8E9-AD97B8F50760}"/>
               </a:ext>
             </a:extLst>
           </p:cNvPr>
@@ -5817,7 +5817,7 @@
           <p:cNvPr id="55" name="ir_core_card">
             <a:extLst>
               <a:ext uri="{FF2B5EF4-FFF2-40B4-BE49-F238E27FC236}">
-                <a16:creationId xmlns:a16="http://schemas.microsoft.com/office/drawing/2014/main" id="{76FC1939-B799-878C-3435-4A9D460CA9A9}"/>
+                <a16:creationId xmlns:a16="http://schemas.microsoft.com/office/drawing/2014/main" id="{70F9E6F7-9F34-5C5D-46B8-BFC59C4D38D3}"/>
               </a:ext>
             </a:extLst>
           </p:cNvPr>
@@ -5878,7 +5878,7 @@
           <p:cNvPr id="56" name="ir_core_icon_dot">
             <a:extLst>
               <a:ext uri="{FF2B5EF4-FFF2-40B4-BE49-F238E27FC236}">
-                <a16:creationId xmlns:a16="http://schemas.microsoft.com/office/drawing/2014/main" id="{58466E76-7884-C3C6-ED83-3BDBF45519AD}"/>
+                <a16:creationId xmlns:a16="http://schemas.microsoft.com/office/drawing/2014/main" id="{90071460-A1C1-FC3C-3202-3665C5123E3B}"/>
               </a:ext>
             </a:extLst>
           </p:cNvPr>
@@ -5932,7 +5932,7 @@
           <p:cNvPr id="57" name="ir_core_icon_label">
             <a:extLst>
               <a:ext uri="{FF2B5EF4-FFF2-40B4-BE49-F238E27FC236}">
-                <a16:creationId xmlns:a16="http://schemas.microsoft.com/office/drawing/2014/main" id="{5E896E8D-CD80-9244-F6F1-FF6DC4B94927}"/>
+                <a16:creationId xmlns:a16="http://schemas.microsoft.com/office/drawing/2014/main" id="{83681781-CCC4-E137-7927-0D90A09F0B77}"/>
               </a:ext>
             </a:extLst>
           </p:cNvPr>
@@ -5941,8 +5941,8 @@
         </p:nvSpPr>
         <p:spPr>
           <a:xfrm>
-            <a:off x="3831676" y="2310520"/>
-            <a:ext cx="191584" cy="285806"/>
+            <a:off x="3831676" y="2302844"/>
+            <a:ext cx="191584" cy="276999"/>
           </a:xfrm>
           <a:prstGeom prst="rect">
             <a:avLst/>
@@ -5950,7 +5950,7 @@
           <a:noFill/>
         </p:spPr>
         <p:txBody>
-          <a:bodyPr vert="horz" wrap="square" lIns="8708" tIns="4361" rIns="8708" bIns="4361" rtlCol="0" anchor="ctr">
+          <a:bodyPr vert="horz" wrap="square" lIns="0" tIns="0" rIns="0" bIns="0" rtlCol="0" anchor="ctr">
             <a:noAutofit/>
           </a:bodyPr>
           <a:lstStyle/>
@@ -5979,7 +5979,7 @@
           <p:cNvPr id="58" name="ir_core_title">
             <a:extLst>
               <a:ext uri="{FF2B5EF4-FFF2-40B4-BE49-F238E27FC236}">
-                <a16:creationId xmlns:a16="http://schemas.microsoft.com/office/drawing/2014/main" id="{82F687E8-E358-F176-AA71-E206B05005C4}"/>
+                <a16:creationId xmlns:a16="http://schemas.microsoft.com/office/drawing/2014/main" id="{C5AC8BF6-A66C-8E54-D9BE-5969E358E6C5}"/>
               </a:ext>
             </a:extLst>
           </p:cNvPr>
@@ -6025,7 +6025,7 @@
           <p:cNvPr id="59" name="ir_core_line_0">
             <a:extLst>
               <a:ext uri="{FF2B5EF4-FFF2-40B4-BE49-F238E27FC236}">
-                <a16:creationId xmlns:a16="http://schemas.microsoft.com/office/drawing/2014/main" id="{13CF376B-1605-7CE2-DD60-E8B51A6FB5CD}"/>
+                <a16:creationId xmlns:a16="http://schemas.microsoft.com/office/drawing/2014/main" id="{15E6B9D2-9606-278A-3B68-EB3247D6F199}"/>
               </a:ext>
             </a:extLst>
           </p:cNvPr>
@@ -6071,7 +6071,7 @@
           <p:cNvPr id="60" name="ir_core_line_1">
             <a:extLst>
               <a:ext uri="{FF2B5EF4-FFF2-40B4-BE49-F238E27FC236}">
-                <a16:creationId xmlns:a16="http://schemas.microsoft.com/office/drawing/2014/main" id="{1CEC2F10-4B09-4E7E-C7A5-76157FE764B7}"/>
+                <a16:creationId xmlns:a16="http://schemas.microsoft.com/office/drawing/2014/main" id="{C6A4E2FC-49EE-ACB8-FEB7-AE25BCD276B7}"/>
               </a:ext>
             </a:extLst>
           </p:cNvPr>
@@ -6117,7 +6117,7 @@
           <p:cNvPr id="61" name="reasoning_card">
             <a:extLst>
               <a:ext uri="{FF2B5EF4-FFF2-40B4-BE49-F238E27FC236}">
-                <a16:creationId xmlns:a16="http://schemas.microsoft.com/office/drawing/2014/main" id="{BF305F44-1B15-F0CD-BC4D-A25A66EA88C4}"/>
+                <a16:creationId xmlns:a16="http://schemas.microsoft.com/office/drawing/2014/main" id="{3FB809A1-95C4-5DE9-34EA-1A5D4D723D96}"/>
               </a:ext>
             </a:extLst>
           </p:cNvPr>
@@ -6178,7 +6178,7 @@
           <p:cNvPr id="62" name="reasoning_icon_dot">
             <a:extLst>
               <a:ext uri="{FF2B5EF4-FFF2-40B4-BE49-F238E27FC236}">
-                <a16:creationId xmlns:a16="http://schemas.microsoft.com/office/drawing/2014/main" id="{A2241C7B-433F-44F0-0E02-41491790943A}"/>
+                <a16:creationId xmlns:a16="http://schemas.microsoft.com/office/drawing/2014/main" id="{A12270CD-B82A-BC15-A003-D5E3EB9537EF}"/>
               </a:ext>
             </a:extLst>
           </p:cNvPr>
@@ -6232,7 +6232,7 @@
           <p:cNvPr id="63" name="reasoning_icon_label">
             <a:extLst>
               <a:ext uri="{FF2B5EF4-FFF2-40B4-BE49-F238E27FC236}">
-                <a16:creationId xmlns:a16="http://schemas.microsoft.com/office/drawing/2014/main" id="{39668B04-52AE-F4E6-700B-A361F3A9415F}"/>
+                <a16:creationId xmlns:a16="http://schemas.microsoft.com/office/drawing/2014/main" id="{85BCE0BA-276D-9392-B831-1E200BCADD54}"/>
               </a:ext>
             </a:extLst>
           </p:cNvPr>
@@ -6241,8 +6241,8 @@
         </p:nvSpPr>
         <p:spPr>
           <a:xfrm>
-            <a:off x="3831676" y="3723629"/>
-            <a:ext cx="191584" cy="285806"/>
+            <a:off x="3831676" y="3715953"/>
+            <a:ext cx="191584" cy="276999"/>
           </a:xfrm>
           <a:prstGeom prst="rect">
             <a:avLst/>
@@ -6250,7 +6250,7 @@
           <a:noFill/>
         </p:spPr>
         <p:txBody>
-          <a:bodyPr vert="horz" wrap="square" lIns="8708" tIns="4361" rIns="8708" bIns="4361" rtlCol="0" anchor="ctr">
+          <a:bodyPr vert="horz" wrap="square" lIns="0" tIns="0" rIns="0" bIns="0" rtlCol="0" anchor="ctr">
             <a:noAutofit/>
           </a:bodyPr>
           <a:lstStyle/>
@@ -6279,7 +6279,7 @@
           <p:cNvPr id="64" name="reasoning_title">
             <a:extLst>
               <a:ext uri="{FF2B5EF4-FFF2-40B4-BE49-F238E27FC236}">
-                <a16:creationId xmlns:a16="http://schemas.microsoft.com/office/drawing/2014/main" id="{265DB8B5-85FF-0FA9-B92E-3AA9EAD31757}"/>
+                <a16:creationId xmlns:a16="http://schemas.microsoft.com/office/drawing/2014/main" id="{79A58FB8-56C6-B61D-9657-5A8B6E27BBD1}"/>
               </a:ext>
             </a:extLst>
           </p:cNvPr>
@@ -6325,7 +6325,7 @@
           <p:cNvPr id="65" name="reasoning_line_0">
             <a:extLst>
               <a:ext uri="{FF2B5EF4-FFF2-40B4-BE49-F238E27FC236}">
-                <a16:creationId xmlns:a16="http://schemas.microsoft.com/office/drawing/2014/main" id="{3DBABB2E-4751-D7A9-C022-0625847658E6}"/>
+                <a16:creationId xmlns:a16="http://schemas.microsoft.com/office/drawing/2014/main" id="{DC0D488D-2A0C-76B1-E365-304CC14C531E}"/>
               </a:ext>
             </a:extLst>
           </p:cNvPr>
@@ -6371,7 +6371,7 @@
           <p:cNvPr id="66" name="reasoning_guard">
             <a:extLst>
               <a:ext uri="{FF2B5EF4-FFF2-40B4-BE49-F238E27FC236}">
-                <a16:creationId xmlns:a16="http://schemas.microsoft.com/office/drawing/2014/main" id="{6322EA6A-C933-7CF6-6708-AAB3446F9D59}"/>
+                <a16:creationId xmlns:a16="http://schemas.microsoft.com/office/drawing/2014/main" id="{E50A6533-CDFF-8B05-1025-9D1FAFEDA61B}"/>
               </a:ext>
             </a:extLst>
           </p:cNvPr>
@@ -6432,7 +6432,7 @@
           <p:cNvPr id="67" name="reasoning_guard_text">
             <a:extLst>
               <a:ext uri="{FF2B5EF4-FFF2-40B4-BE49-F238E27FC236}">
-                <a16:creationId xmlns:a16="http://schemas.microsoft.com/office/drawing/2014/main" id="{0CFE2C52-02DB-CC9C-4C9A-08EB9B96B87F}"/>
+                <a16:creationId xmlns:a16="http://schemas.microsoft.com/office/drawing/2014/main" id="{F3D0DC19-9A7D-2613-AD8E-7AD2A126FA62}"/>
               </a:ext>
             </a:extLst>
           </p:cNvPr>
@@ -6479,7 +6479,7 @@
           <p:cNvPr id="68" name="reasoning_limit">
             <a:extLst>
               <a:ext uri="{FF2B5EF4-FFF2-40B4-BE49-F238E27FC236}">
-                <a16:creationId xmlns:a16="http://schemas.microsoft.com/office/drawing/2014/main" id="{C7A18C9D-80E6-FA0D-0C29-2BA1AA242F81}"/>
+                <a16:creationId xmlns:a16="http://schemas.microsoft.com/office/drawing/2014/main" id="{0F29E3DA-9D15-7231-D321-81E3EC844108}"/>
               </a:ext>
             </a:extLst>
           </p:cNvPr>
@@ -6525,7 +6525,7 @@
           <p:cNvPr id="69" name="rule_engine_card">
             <a:extLst>
               <a:ext uri="{FF2B5EF4-FFF2-40B4-BE49-F238E27FC236}">
-                <a16:creationId xmlns:a16="http://schemas.microsoft.com/office/drawing/2014/main" id="{F40B79DC-8184-388F-7DC4-5B4E69D4A1E9}"/>
+                <a16:creationId xmlns:a16="http://schemas.microsoft.com/office/drawing/2014/main" id="{273180A8-B68D-1930-EE12-3E5BC755A335}"/>
               </a:ext>
             </a:extLst>
           </p:cNvPr>
@@ -6586,7 +6586,7 @@
           <p:cNvPr id="70" name="rule_engine_title">
             <a:extLst>
               <a:ext uri="{FF2B5EF4-FFF2-40B4-BE49-F238E27FC236}">
-                <a16:creationId xmlns:a16="http://schemas.microsoft.com/office/drawing/2014/main" id="{0203DD24-A6D4-95A6-9BE4-02A5B7C0385B}"/>
+                <a16:creationId xmlns:a16="http://schemas.microsoft.com/office/drawing/2014/main" id="{6862EAA2-C372-6D23-FFA3-0B0D128D0454}"/>
               </a:ext>
             </a:extLst>
           </p:cNvPr>
@@ -6632,7 +6632,7 @@
           <p:cNvPr id="71" name="rule_engine_body">
             <a:extLst>
               <a:ext uri="{FF2B5EF4-FFF2-40B4-BE49-F238E27FC236}">
-                <a16:creationId xmlns:a16="http://schemas.microsoft.com/office/drawing/2014/main" id="{59FBF9B6-C76C-E668-42F8-95B7B95C3F69}"/>
+                <a16:creationId xmlns:a16="http://schemas.microsoft.com/office/drawing/2014/main" id="{C7A9C912-3721-0F67-4685-9E301D15268B}"/>
               </a:ext>
             </a:extLst>
           </p:cNvPr>
@@ -6678,7 +6678,7 @@
           <p:cNvPr id="72" name="features_card">
             <a:extLst>
               <a:ext uri="{FF2B5EF4-FFF2-40B4-BE49-F238E27FC236}">
-                <a16:creationId xmlns:a16="http://schemas.microsoft.com/office/drawing/2014/main" id="{506C96CA-20DB-0A91-FD37-60D8791185E3}"/>
+                <a16:creationId xmlns:a16="http://schemas.microsoft.com/office/drawing/2014/main" id="{3CFF6BBC-910F-D36E-A7CE-30F360F195E4}"/>
               </a:ext>
             </a:extLst>
           </p:cNvPr>
@@ -6739,7 +6739,7 @@
           <p:cNvPr id="73" name="features_icon_dot">
             <a:extLst>
               <a:ext uri="{FF2B5EF4-FFF2-40B4-BE49-F238E27FC236}">
-                <a16:creationId xmlns:a16="http://schemas.microsoft.com/office/drawing/2014/main" id="{28CCB6FA-A87E-5903-4DCD-2958D518011D}"/>
+                <a16:creationId xmlns:a16="http://schemas.microsoft.com/office/drawing/2014/main" id="{E84F0029-2F0E-8951-0230-DDF375C876FC}"/>
               </a:ext>
             </a:extLst>
           </p:cNvPr>
@@ -6793,7 +6793,7 @@
           <p:cNvPr id="74" name="features_icon_label">
             <a:extLst>
               <a:ext uri="{FF2B5EF4-FFF2-40B4-BE49-F238E27FC236}">
-                <a16:creationId xmlns:a16="http://schemas.microsoft.com/office/drawing/2014/main" id="{6D49A6E7-F439-F3F4-BF36-A7D9DEA2D0C4}"/>
+                <a16:creationId xmlns:a16="http://schemas.microsoft.com/office/drawing/2014/main" id="{14D91F07-0746-F7BB-4438-0753470E442D}"/>
               </a:ext>
             </a:extLst>
           </p:cNvPr>
@@ -6802,8 +6802,8 @@
         </p:nvSpPr>
         <p:spPr>
           <a:xfrm>
-            <a:off x="6182931" y="3259222"/>
-            <a:ext cx="139334" cy="285806"/>
+            <a:off x="6182931" y="3253640"/>
+            <a:ext cx="139334" cy="276999"/>
           </a:xfrm>
           <a:prstGeom prst="rect">
             <a:avLst/>
@@ -6811,7 +6811,7 @@
           <a:noFill/>
         </p:spPr>
         <p:txBody>
-          <a:bodyPr vert="horz" wrap="square" lIns="8708" tIns="4361" rIns="8708" bIns="4361" rtlCol="0" anchor="ctr">
+          <a:bodyPr vert="horz" wrap="square" lIns="0" tIns="0" rIns="0" bIns="0" rtlCol="0" anchor="ctr">
             <a:noAutofit/>
           </a:bodyPr>
           <a:lstStyle/>
@@ -6840,7 +6840,7 @@
           <p:cNvPr id="75" name="features_title">
             <a:extLst>
               <a:ext uri="{FF2B5EF4-FFF2-40B4-BE49-F238E27FC236}">
-                <a16:creationId xmlns:a16="http://schemas.microsoft.com/office/drawing/2014/main" id="{D38F9349-E920-CF0F-2A74-681855C317DE}"/>
+                <a16:creationId xmlns:a16="http://schemas.microsoft.com/office/drawing/2014/main" id="{F58938FC-7981-1E84-78F1-5B7E94AAAF85}"/>
               </a:ext>
             </a:extLst>
           </p:cNvPr>
@@ -6886,7 +6886,7 @@
           <p:cNvPr id="76" name="features_line_0">
             <a:extLst>
               <a:ext uri="{FF2B5EF4-FFF2-40B4-BE49-F238E27FC236}">
-                <a16:creationId xmlns:a16="http://schemas.microsoft.com/office/drawing/2014/main" id="{1F50CE6C-1A48-1D2C-50CD-84794C383489}"/>
+                <a16:creationId xmlns:a16="http://schemas.microsoft.com/office/drawing/2014/main" id="{C8A30813-1313-8F94-4B65-4DC38DC07C3C}"/>
               </a:ext>
             </a:extLst>
           </p:cNvPr>
@@ -6932,7 +6932,7 @@
           <p:cNvPr id="77" name="features_line_1">
             <a:extLst>
               <a:ext uri="{FF2B5EF4-FFF2-40B4-BE49-F238E27FC236}">
-                <a16:creationId xmlns:a16="http://schemas.microsoft.com/office/drawing/2014/main" id="{D3EDCC3D-35A8-38F1-F6F8-DF99C21E9D92}"/>
+                <a16:creationId xmlns:a16="http://schemas.microsoft.com/office/drawing/2014/main" id="{0908CAA1-6F1A-EA4D-2CAD-31221A1C59B9}"/>
               </a:ext>
             </a:extLst>
           </p:cNvPr>
@@ -6978,7 +6978,7 @@
           <p:cNvPr id="78" name="recipes_card">
             <a:extLst>
               <a:ext uri="{FF2B5EF4-FFF2-40B4-BE49-F238E27FC236}">
-                <a16:creationId xmlns:a16="http://schemas.microsoft.com/office/drawing/2014/main" id="{D3A5E7EE-A62D-FE6F-B17C-613D9AD62F67}"/>
+                <a16:creationId xmlns:a16="http://schemas.microsoft.com/office/drawing/2014/main" id="{122BAEF6-7867-AE40-D9C6-BB23891C2C9D}"/>
               </a:ext>
             </a:extLst>
           </p:cNvPr>
@@ -7039,7 +7039,7 @@
           <p:cNvPr id="79" name="recipes_icon_dot">
             <a:extLst>
               <a:ext uri="{FF2B5EF4-FFF2-40B4-BE49-F238E27FC236}">
-                <a16:creationId xmlns:a16="http://schemas.microsoft.com/office/drawing/2014/main" id="{5A9E6E92-AD97-5BE4-3AB7-16042FA22163}"/>
+                <a16:creationId xmlns:a16="http://schemas.microsoft.com/office/drawing/2014/main" id="{4FFDA542-5B7E-7984-95EB-4B95F1B91F52}"/>
               </a:ext>
             </a:extLst>
           </p:cNvPr>
@@ -7093,7 +7093,7 @@
           <p:cNvPr id="80" name="recipes_icon_label">
             <a:extLst>
               <a:ext uri="{FF2B5EF4-FFF2-40B4-BE49-F238E27FC236}">
-                <a16:creationId xmlns:a16="http://schemas.microsoft.com/office/drawing/2014/main" id="{3150AD95-D9AC-9342-DEE2-E4E1288AEEAF}"/>
+                <a16:creationId xmlns:a16="http://schemas.microsoft.com/office/drawing/2014/main" id="{2757096F-D32E-B74C-1669-765F7E56906F}"/>
               </a:ext>
             </a:extLst>
           </p:cNvPr>
@@ -7102,8 +7102,8 @@
         </p:nvSpPr>
         <p:spPr>
           <a:xfrm>
-            <a:off x="7419518" y="3259222"/>
-            <a:ext cx="139334" cy="285806"/>
+            <a:off x="7419518" y="3253640"/>
+            <a:ext cx="139334" cy="276999"/>
           </a:xfrm>
           <a:prstGeom prst="rect">
             <a:avLst/>
@@ -7111,7 +7111,7 @@
           <a:noFill/>
         </p:spPr>
         <p:txBody>
-          <a:bodyPr vert="horz" wrap="square" lIns="8708" tIns="4361" rIns="8708" bIns="4361" rtlCol="0" anchor="ctr">
+          <a:bodyPr vert="horz" wrap="square" lIns="0" tIns="0" rIns="0" bIns="0" rtlCol="0" anchor="ctr">
             <a:noAutofit/>
           </a:bodyPr>
           <a:lstStyle/>
@@ -7140,7 +7140,7 @@
           <p:cNvPr id="81" name="recipes_title">
             <a:extLst>
               <a:ext uri="{FF2B5EF4-FFF2-40B4-BE49-F238E27FC236}">
-                <a16:creationId xmlns:a16="http://schemas.microsoft.com/office/drawing/2014/main" id="{A6BD999C-711B-5F89-27B9-5824DB57685D}"/>
+                <a16:creationId xmlns:a16="http://schemas.microsoft.com/office/drawing/2014/main" id="{DDBE973A-76E9-7EC7-B6AD-C77225E0DEF2}"/>
               </a:ext>
             </a:extLst>
           </p:cNvPr>
@@ -7186,7 +7186,7 @@
           <p:cNvPr id="82" name="recipes_line_0">
             <a:extLst>
               <a:ext uri="{FF2B5EF4-FFF2-40B4-BE49-F238E27FC236}">
-                <a16:creationId xmlns:a16="http://schemas.microsoft.com/office/drawing/2014/main" id="{B8D370F3-0086-4F15-C738-87CDAB5AF620}"/>
+                <a16:creationId xmlns:a16="http://schemas.microsoft.com/office/drawing/2014/main" id="{B6D272D8-DA28-DE92-8598-9EEE8E4D9830}"/>
               </a:ext>
             </a:extLst>
           </p:cNvPr>
@@ -7232,7 +7232,7 @@
           <p:cNvPr id="83" name="recipes_line_1">
             <a:extLst>
               <a:ext uri="{FF2B5EF4-FFF2-40B4-BE49-F238E27FC236}">
-                <a16:creationId xmlns:a16="http://schemas.microsoft.com/office/drawing/2014/main" id="{78FABCB7-B861-1696-C479-DC0889C53CBD}"/>
+                <a16:creationId xmlns:a16="http://schemas.microsoft.com/office/drawing/2014/main" id="{A56F806F-9CAA-6E5C-80D4-AD3D5170F2EC}"/>
               </a:ext>
             </a:extLst>
           </p:cNvPr>
@@ -7278,7 +7278,7 @@
           <p:cNvPr id="84" name="theme_card">
             <a:extLst>
               <a:ext uri="{FF2B5EF4-FFF2-40B4-BE49-F238E27FC236}">
-                <a16:creationId xmlns:a16="http://schemas.microsoft.com/office/drawing/2014/main" id="{B5241DB1-DBAD-EA67-09FD-33F8F200CD77}"/>
+                <a16:creationId xmlns:a16="http://schemas.microsoft.com/office/drawing/2014/main" id="{83384489-1934-A62D-B8C3-3CE1DBFEE3B8}"/>
               </a:ext>
             </a:extLst>
           </p:cNvPr>
@@ -7339,7 +7339,7 @@
           <p:cNvPr id="85" name="theme_icon_dot">
             <a:extLst>
               <a:ext uri="{FF2B5EF4-FFF2-40B4-BE49-F238E27FC236}">
-                <a16:creationId xmlns:a16="http://schemas.microsoft.com/office/drawing/2014/main" id="{4B492044-748F-7343-C7B7-9755496DE90B}"/>
+                <a16:creationId xmlns:a16="http://schemas.microsoft.com/office/drawing/2014/main" id="{E827282C-7A95-BD7F-541F-0C88271D421C}"/>
               </a:ext>
             </a:extLst>
           </p:cNvPr>
@@ -7393,7 +7393,7 @@
           <p:cNvPr id="86" name="theme_icon_label">
             <a:extLst>
               <a:ext uri="{FF2B5EF4-FFF2-40B4-BE49-F238E27FC236}">
-                <a16:creationId xmlns:a16="http://schemas.microsoft.com/office/drawing/2014/main" id="{FDEDA045-B4DC-53C2-606D-96BC7B9D8293}"/>
+                <a16:creationId xmlns:a16="http://schemas.microsoft.com/office/drawing/2014/main" id="{03EFA2C8-2747-6554-304F-2764C2F2EE78}"/>
               </a:ext>
             </a:extLst>
           </p:cNvPr>
@@ -7402,8 +7402,8 @@
         </p:nvSpPr>
         <p:spPr>
           <a:xfrm>
-            <a:off x="8656103" y="3259222"/>
-            <a:ext cx="139334" cy="285806"/>
+            <a:off x="8656103" y="3253640"/>
+            <a:ext cx="139334" cy="276999"/>
           </a:xfrm>
           <a:prstGeom prst="rect">
             <a:avLst/>
@@ -7411,7 +7411,7 @@
           <a:noFill/>
         </p:spPr>
         <p:txBody>
-          <a:bodyPr vert="horz" wrap="square" lIns="8708" tIns="4361" rIns="8708" bIns="4361" rtlCol="0" anchor="ctr">
+          <a:bodyPr vert="horz" wrap="square" lIns="0" tIns="0" rIns="0" bIns="0" rtlCol="0" anchor="ctr">
             <a:noAutofit/>
           </a:bodyPr>
           <a:lstStyle/>
@@ -7440,7 +7440,7 @@
           <p:cNvPr id="87" name="theme_title">
             <a:extLst>
               <a:ext uri="{FF2B5EF4-FFF2-40B4-BE49-F238E27FC236}">
-                <a16:creationId xmlns:a16="http://schemas.microsoft.com/office/drawing/2014/main" id="{339967DC-886A-F29F-616D-B64741FED118}"/>
+                <a16:creationId xmlns:a16="http://schemas.microsoft.com/office/drawing/2014/main" id="{9D3A0B1B-A2CD-0965-50C2-7A955AD9EE04}"/>
               </a:ext>
             </a:extLst>
           </p:cNvPr>
@@ -7486,7 +7486,7 @@
           <p:cNvPr id="88" name="theme_line_0">
             <a:extLst>
               <a:ext uri="{FF2B5EF4-FFF2-40B4-BE49-F238E27FC236}">
-                <a16:creationId xmlns:a16="http://schemas.microsoft.com/office/drawing/2014/main" id="{C72CCBC2-7DBA-EB44-C8FF-D162B178FE2E}"/>
+                <a16:creationId xmlns:a16="http://schemas.microsoft.com/office/drawing/2014/main" id="{1F55D626-7E96-B3D1-D53E-8A479784A083}"/>
               </a:ext>
             </a:extLst>
           </p:cNvPr>
@@ -7532,7 +7532,7 @@
           <p:cNvPr id="89" name="theme_line_1">
             <a:extLst>
               <a:ext uri="{FF2B5EF4-FFF2-40B4-BE49-F238E27FC236}">
-                <a16:creationId xmlns:a16="http://schemas.microsoft.com/office/drawing/2014/main" id="{B1C74A5B-468A-2E2C-B368-B89F4E7EFCE0}"/>
+                <a16:creationId xmlns:a16="http://schemas.microsoft.com/office/drawing/2014/main" id="{066B3888-22C8-1ED7-0B54-0F6D5D12739C}"/>
               </a:ext>
             </a:extLst>
           </p:cNvPr>
@@ -7578,7 +7578,7 @@
           <p:cNvPr id="90" name="compose_card">
             <a:extLst>
               <a:ext uri="{FF2B5EF4-FFF2-40B4-BE49-F238E27FC236}">
-                <a16:creationId xmlns:a16="http://schemas.microsoft.com/office/drawing/2014/main" id="{0AA228E3-1416-8FD4-B368-54EF31765415}"/>
+                <a16:creationId xmlns:a16="http://schemas.microsoft.com/office/drawing/2014/main" id="{1532EF8C-5338-352A-3A96-3AEC55173267}"/>
               </a:ext>
             </a:extLst>
           </p:cNvPr>
@@ -7639,7 +7639,7 @@
           <p:cNvPr id="91" name="compose_icon_dot">
             <a:extLst>
               <a:ext uri="{FF2B5EF4-FFF2-40B4-BE49-F238E27FC236}">
-                <a16:creationId xmlns:a16="http://schemas.microsoft.com/office/drawing/2014/main" id="{048C2BF9-ABC8-3E3D-7D92-447980C69535}"/>
+                <a16:creationId xmlns:a16="http://schemas.microsoft.com/office/drawing/2014/main" id="{C533A7A4-22E0-B143-B1F2-4DE3E4E759AC}"/>
               </a:ext>
             </a:extLst>
           </p:cNvPr>
@@ -7693,7 +7693,7 @@
           <p:cNvPr id="92" name="compose_icon_label">
             <a:extLst>
               <a:ext uri="{FF2B5EF4-FFF2-40B4-BE49-F238E27FC236}">
-                <a16:creationId xmlns:a16="http://schemas.microsoft.com/office/drawing/2014/main" id="{7A0AA5C0-925A-796F-70BE-4267090234B1}"/>
+                <a16:creationId xmlns:a16="http://schemas.microsoft.com/office/drawing/2014/main" id="{A9ACCB32-8FE4-B6E1-A1A3-E4986636E2C4}"/>
               </a:ext>
             </a:extLst>
           </p:cNvPr>
@@ -7702,8 +7702,8 @@
         </p:nvSpPr>
         <p:spPr>
           <a:xfrm>
-            <a:off x="6182931" y="4253632"/>
-            <a:ext cx="139334" cy="285806"/>
+            <a:off x="6182931" y="4248050"/>
+            <a:ext cx="139334" cy="276999"/>
           </a:xfrm>
           <a:prstGeom prst="rect">
             <a:avLst/>
@@ -7711,7 +7711,7 @@
           <a:noFill/>
         </p:spPr>
         <p:txBody>
-          <a:bodyPr vert="horz" wrap="square" lIns="8708" tIns="4361" rIns="8708" bIns="4361" rtlCol="0" anchor="ctr">
+          <a:bodyPr vert="horz" wrap="square" lIns="0" tIns="0" rIns="0" bIns="0" rtlCol="0" anchor="ctr">
             <a:noAutofit/>
           </a:bodyPr>
           <a:lstStyle/>
@@ -7740,7 +7740,7 @@
           <p:cNvPr id="93" name="compose_title">
             <a:extLst>
               <a:ext uri="{FF2B5EF4-FFF2-40B4-BE49-F238E27FC236}">
-                <a16:creationId xmlns:a16="http://schemas.microsoft.com/office/drawing/2014/main" id="{A1CC0D6C-5674-5248-61DE-020B77F12816}"/>
+                <a16:creationId xmlns:a16="http://schemas.microsoft.com/office/drawing/2014/main" id="{7BF7B3DF-B7DB-F4E0-B2C9-51CAD5CB820F}"/>
               </a:ext>
             </a:extLst>
           </p:cNvPr>
@@ -7786,7 +7786,7 @@
           <p:cNvPr id="94" name="compose_line_0">
             <a:extLst>
               <a:ext uri="{FF2B5EF4-FFF2-40B4-BE49-F238E27FC236}">
-                <a16:creationId xmlns:a16="http://schemas.microsoft.com/office/drawing/2014/main" id="{51DFD3F1-EA8C-A38A-1158-404ED3DD5C36}"/>
+                <a16:creationId xmlns:a16="http://schemas.microsoft.com/office/drawing/2014/main" id="{CBD228A3-61C9-D875-B1FA-56BDC6D36107}"/>
               </a:ext>
             </a:extLst>
           </p:cNvPr>
@@ -7832,7 +7832,7 @@
           <p:cNvPr id="95" name="compose_line_1">
             <a:extLst>
               <a:ext uri="{FF2B5EF4-FFF2-40B4-BE49-F238E27FC236}">
-                <a16:creationId xmlns:a16="http://schemas.microsoft.com/office/drawing/2014/main" id="{797AB9E6-7A55-4CEA-3E4A-B436A6BE2FAD}"/>
+                <a16:creationId xmlns:a16="http://schemas.microsoft.com/office/drawing/2014/main" id="{9EDE2B91-A226-C5E9-7ADF-9793AAABC607}"/>
               </a:ext>
             </a:extLst>
           </p:cNvPr>
@@ -7878,7 +7878,7 @@
           <p:cNvPr id="96" name="objects_card">
             <a:extLst>
               <a:ext uri="{FF2B5EF4-FFF2-40B4-BE49-F238E27FC236}">
-                <a16:creationId xmlns:a16="http://schemas.microsoft.com/office/drawing/2014/main" id="{6859F1C5-5368-C46C-0A09-67F9FD11CA6A}"/>
+                <a16:creationId xmlns:a16="http://schemas.microsoft.com/office/drawing/2014/main" id="{80815EDE-3E37-AC9B-06C0-4A50B557C6A2}"/>
               </a:ext>
             </a:extLst>
           </p:cNvPr>
@@ -7939,7 +7939,7 @@
           <p:cNvPr id="97" name="objects_icon_dot">
             <a:extLst>
               <a:ext uri="{FF2B5EF4-FFF2-40B4-BE49-F238E27FC236}">
-                <a16:creationId xmlns:a16="http://schemas.microsoft.com/office/drawing/2014/main" id="{D7ABCDA0-1C54-3C4F-633D-22231F76A57A}"/>
+                <a16:creationId xmlns:a16="http://schemas.microsoft.com/office/drawing/2014/main" id="{1DC8CA0A-D531-0B82-D564-EBFA008142FD}"/>
               </a:ext>
             </a:extLst>
           </p:cNvPr>
@@ -7993,7 +7993,7 @@
           <p:cNvPr id="98" name="objects_icon_label">
             <a:extLst>
               <a:ext uri="{FF2B5EF4-FFF2-40B4-BE49-F238E27FC236}">
-                <a16:creationId xmlns:a16="http://schemas.microsoft.com/office/drawing/2014/main" id="{5C7F0183-33A4-50EF-CEE5-1B90E2F38E00}"/>
+                <a16:creationId xmlns:a16="http://schemas.microsoft.com/office/drawing/2014/main" id="{E46BF31D-C82F-FA74-8A39-D6DD5576A313}"/>
               </a:ext>
             </a:extLst>
           </p:cNvPr>
@@ -8002,8 +8002,8 @@
         </p:nvSpPr>
         <p:spPr>
           <a:xfrm>
-            <a:off x="7419518" y="4253632"/>
-            <a:ext cx="139334" cy="285806"/>
+            <a:off x="7419518" y="4248050"/>
+            <a:ext cx="139334" cy="276999"/>
           </a:xfrm>
           <a:prstGeom prst="rect">
             <a:avLst/>
@@ -8011,7 +8011,7 @@
           <a:noFill/>
         </p:spPr>
         <p:txBody>
-          <a:bodyPr vert="horz" wrap="square" lIns="8708" tIns="4361" rIns="8708" bIns="4361" rtlCol="0" anchor="ctr">
+          <a:bodyPr vert="horz" wrap="square" lIns="0" tIns="0" rIns="0" bIns="0" rtlCol="0" anchor="ctr">
             <a:noAutofit/>
           </a:bodyPr>
           <a:lstStyle/>
@@ -8040,7 +8040,7 @@
           <p:cNvPr id="99" name="objects_title">
             <a:extLst>
               <a:ext uri="{FF2B5EF4-FFF2-40B4-BE49-F238E27FC236}">
-                <a16:creationId xmlns:a16="http://schemas.microsoft.com/office/drawing/2014/main" id="{7713DC7B-2A93-1327-DC19-13B88073BE2E}"/>
+                <a16:creationId xmlns:a16="http://schemas.microsoft.com/office/drawing/2014/main" id="{AB8D5128-912B-9FF7-DEC9-AF66953FB8BC}"/>
               </a:ext>
             </a:extLst>
           </p:cNvPr>
@@ -8086,7 +8086,7 @@
           <p:cNvPr id="100" name="objects_line_0">
             <a:extLst>
               <a:ext uri="{FF2B5EF4-FFF2-40B4-BE49-F238E27FC236}">
-                <a16:creationId xmlns:a16="http://schemas.microsoft.com/office/drawing/2014/main" id="{C1C5665C-2F2B-6B4F-1307-06EC7D921C1A}"/>
+                <a16:creationId xmlns:a16="http://schemas.microsoft.com/office/drawing/2014/main" id="{57B1B6EA-5C38-5DAE-138A-E7CEFBF93F73}"/>
               </a:ext>
             </a:extLst>
           </p:cNvPr>
@@ -8132,7 +8132,7 @@
           <p:cNvPr id="101" name="objects_line_1">
             <a:extLst>
               <a:ext uri="{FF2B5EF4-FFF2-40B4-BE49-F238E27FC236}">
-                <a16:creationId xmlns:a16="http://schemas.microsoft.com/office/drawing/2014/main" id="{4046ADB8-AD61-14E0-BA8F-5B4A97ADA2BA}"/>
+                <a16:creationId xmlns:a16="http://schemas.microsoft.com/office/drawing/2014/main" id="{65B80D0F-346F-C392-9BE8-D852419A15FB}"/>
               </a:ext>
             </a:extLst>
           </p:cNvPr>
@@ -8178,7 +8178,7 @@
           <p:cNvPr id="102" name="decorate_card">
             <a:extLst>
               <a:ext uri="{FF2B5EF4-FFF2-40B4-BE49-F238E27FC236}">
-                <a16:creationId xmlns:a16="http://schemas.microsoft.com/office/drawing/2014/main" id="{B7406077-1529-ACBE-EB4C-9766096DD24B}"/>
+                <a16:creationId xmlns:a16="http://schemas.microsoft.com/office/drawing/2014/main" id="{D857AE9B-AEEC-5700-0B37-DDEE669836DE}"/>
               </a:ext>
             </a:extLst>
           </p:cNvPr>
@@ -8239,7 +8239,7 @@
           <p:cNvPr id="103" name="decorate_icon_dot">
             <a:extLst>
               <a:ext uri="{FF2B5EF4-FFF2-40B4-BE49-F238E27FC236}">
-                <a16:creationId xmlns:a16="http://schemas.microsoft.com/office/drawing/2014/main" id="{B8FFC9CD-15B9-4E2B-298D-1CB4F028158C}"/>
+                <a16:creationId xmlns:a16="http://schemas.microsoft.com/office/drawing/2014/main" id="{BC9C2629-05AF-4FF8-29DB-DB25C494CE23}"/>
               </a:ext>
             </a:extLst>
           </p:cNvPr>
@@ -8293,7 +8293,7 @@
           <p:cNvPr id="104" name="decorate_icon_label">
             <a:extLst>
               <a:ext uri="{FF2B5EF4-FFF2-40B4-BE49-F238E27FC236}">
-                <a16:creationId xmlns:a16="http://schemas.microsoft.com/office/drawing/2014/main" id="{8F72E0E4-E0AA-1B9C-9B8D-653D642143B8}"/>
+                <a16:creationId xmlns:a16="http://schemas.microsoft.com/office/drawing/2014/main" id="{3FBE5824-65E5-EB80-0D30-6CA816676CD5}"/>
               </a:ext>
             </a:extLst>
           </p:cNvPr>
@@ -8302,8 +8302,8 @@
         </p:nvSpPr>
         <p:spPr>
           <a:xfrm>
-            <a:off x="8656103" y="4253632"/>
-            <a:ext cx="139334" cy="285806"/>
+            <a:off x="8656103" y="4248050"/>
+            <a:ext cx="139334" cy="276999"/>
           </a:xfrm>
           <a:prstGeom prst="rect">
             <a:avLst/>
@@ -8311,7 +8311,7 @@
           <a:noFill/>
         </p:spPr>
         <p:txBody>
-          <a:bodyPr vert="horz" wrap="square" lIns="8708" tIns="4361" rIns="8708" bIns="4361" rtlCol="0" anchor="ctr">
+          <a:bodyPr vert="horz" wrap="square" lIns="0" tIns="0" rIns="0" bIns="0" rtlCol="0" anchor="ctr">
             <a:noAutofit/>
           </a:bodyPr>
           <a:lstStyle/>
@@ -8340,7 +8340,7 @@
           <p:cNvPr id="105" name="decorate_title">
             <a:extLst>
               <a:ext uri="{FF2B5EF4-FFF2-40B4-BE49-F238E27FC236}">
-                <a16:creationId xmlns:a16="http://schemas.microsoft.com/office/drawing/2014/main" id="{8E2249AF-7BD8-A307-B018-E737DAE83966}"/>
+                <a16:creationId xmlns:a16="http://schemas.microsoft.com/office/drawing/2014/main" id="{5EBB57A0-7AB0-D92E-2C55-C5E2D7DD9C9B}"/>
               </a:ext>
             </a:extLst>
           </p:cNvPr>
@@ -8386,7 +8386,7 @@
           <p:cNvPr id="106" name="decorate_line_0">
             <a:extLst>
               <a:ext uri="{FF2B5EF4-FFF2-40B4-BE49-F238E27FC236}">
-                <a16:creationId xmlns:a16="http://schemas.microsoft.com/office/drawing/2014/main" id="{15815D48-3CC4-0897-DD21-280C9FC52FAE}"/>
+                <a16:creationId xmlns:a16="http://schemas.microsoft.com/office/drawing/2014/main" id="{902EBA3C-AB2C-8D61-290D-F6857311A4FB}"/>
               </a:ext>
             </a:extLst>
           </p:cNvPr>
@@ -8432,7 +8432,7 @@
           <p:cNvPr id="107" name="decorate_line_1">
             <a:extLst>
               <a:ext uri="{FF2B5EF4-FFF2-40B4-BE49-F238E27FC236}">
-                <a16:creationId xmlns:a16="http://schemas.microsoft.com/office/drawing/2014/main" id="{E67EF8EC-CB38-657C-4148-A89A56A49274}"/>
+                <a16:creationId xmlns:a16="http://schemas.microsoft.com/office/drawing/2014/main" id="{29022C19-13CC-B752-A812-F6F5B1640C59}"/>
               </a:ext>
             </a:extLst>
           </p:cNvPr>
@@ -8478,7 +8478,7 @@
           <p:cNvPr id="108" name="styled_ir_card">
             <a:extLst>
               <a:ext uri="{FF2B5EF4-FFF2-40B4-BE49-F238E27FC236}">
-                <a16:creationId xmlns:a16="http://schemas.microsoft.com/office/drawing/2014/main" id="{710B73CC-0D39-F327-18F0-658D9EA488B7}"/>
+                <a16:creationId xmlns:a16="http://schemas.microsoft.com/office/drawing/2014/main" id="{871C1E24-761F-B031-DDFA-2FCD05EFE4F5}"/>
               </a:ext>
             </a:extLst>
           </p:cNvPr>
@@ -8539,7 +8539,7 @@
           <p:cNvPr id="109" name="styled_ir_icon_dot">
             <a:extLst>
               <a:ext uri="{FF2B5EF4-FFF2-40B4-BE49-F238E27FC236}">
-                <a16:creationId xmlns:a16="http://schemas.microsoft.com/office/drawing/2014/main" id="{41779A82-955E-2EB4-4B5E-E3C9ADD2A235}"/>
+                <a16:creationId xmlns:a16="http://schemas.microsoft.com/office/drawing/2014/main" id="{3FC7DF7B-92B9-92FD-6A03-3526534E329F}"/>
               </a:ext>
             </a:extLst>
           </p:cNvPr>
@@ -8593,7 +8593,7 @@
           <p:cNvPr id="110" name="styled_ir_icon_label">
             <a:extLst>
               <a:ext uri="{FF2B5EF4-FFF2-40B4-BE49-F238E27FC236}">
-                <a16:creationId xmlns:a16="http://schemas.microsoft.com/office/drawing/2014/main" id="{6B288165-010E-FFD7-81D5-6A6D497A3B37}"/>
+                <a16:creationId xmlns:a16="http://schemas.microsoft.com/office/drawing/2014/main" id="{B9C70234-CA61-A979-1C5F-B455230868AF}"/>
               </a:ext>
             </a:extLst>
           </p:cNvPr>
@@ -8602,8 +8602,8 @@
         </p:nvSpPr>
         <p:spPr>
           <a:xfrm>
-            <a:off x="10249733" y="2310520"/>
-            <a:ext cx="191584" cy="285806"/>
+            <a:off x="10249733" y="2302844"/>
+            <a:ext cx="191584" cy="276999"/>
           </a:xfrm>
           <a:prstGeom prst="rect">
             <a:avLst/>
@@ -8611,7 +8611,7 @@
           <a:noFill/>
         </p:spPr>
         <p:txBody>
-          <a:bodyPr vert="horz" wrap="square" lIns="8708" tIns="4361" rIns="8708" bIns="4361" rtlCol="0" anchor="ctr">
+          <a:bodyPr vert="horz" wrap="square" lIns="0" tIns="0" rIns="0" bIns="0" rtlCol="0" anchor="ctr">
             <a:noAutofit/>
           </a:bodyPr>
           <a:lstStyle/>
@@ -8640,7 +8640,7 @@
           <p:cNvPr id="111" name="styled_ir_title">
             <a:extLst>
               <a:ext uri="{FF2B5EF4-FFF2-40B4-BE49-F238E27FC236}">
-                <a16:creationId xmlns:a16="http://schemas.microsoft.com/office/drawing/2014/main" id="{69E6C2AB-BA03-F293-4FE7-94C0DCF67B01}"/>
+                <a16:creationId xmlns:a16="http://schemas.microsoft.com/office/drawing/2014/main" id="{E2DCB50C-F0D4-9CEA-654F-AEA71F20817C}"/>
               </a:ext>
             </a:extLst>
           </p:cNvPr>
@@ -8686,7 +8686,7 @@
           <p:cNvPr id="112" name="styled_ir_line_0">
             <a:extLst>
               <a:ext uri="{FF2B5EF4-FFF2-40B4-BE49-F238E27FC236}">
-                <a16:creationId xmlns:a16="http://schemas.microsoft.com/office/drawing/2014/main" id="{47E6F79F-12AC-8329-7F30-7349957CA439}"/>
+                <a16:creationId xmlns:a16="http://schemas.microsoft.com/office/drawing/2014/main" id="{C11DB605-AC1B-A409-C7AC-0110C74B9035}"/>
               </a:ext>
             </a:extLst>
           </p:cNvPr>
@@ -8732,7 +8732,7 @@
           <p:cNvPr id="113" name="styled_ir_line_1">
             <a:extLst>
               <a:ext uri="{FF2B5EF4-FFF2-40B4-BE49-F238E27FC236}">
-                <a16:creationId xmlns:a16="http://schemas.microsoft.com/office/drawing/2014/main" id="{FFB00C68-D393-1383-CA88-C1087699D5B1}"/>
+                <a16:creationId xmlns:a16="http://schemas.microsoft.com/office/drawing/2014/main" id="{4CE727F9-D98B-462C-5417-A83368A79511}"/>
               </a:ext>
             </a:extLst>
           </p:cNvPr>
@@ -8778,7 +8778,7 @@
           <p:cNvPr id="114" name="renderers_card">
             <a:extLst>
               <a:ext uri="{FF2B5EF4-FFF2-40B4-BE49-F238E27FC236}">
-                <a16:creationId xmlns:a16="http://schemas.microsoft.com/office/drawing/2014/main" id="{5196DBDE-33B4-37A9-2013-F3510F84581D}"/>
+                <a16:creationId xmlns:a16="http://schemas.microsoft.com/office/drawing/2014/main" id="{6E44DC85-3482-592A-DEB7-99D7C8B5F354}"/>
               </a:ext>
             </a:extLst>
           </p:cNvPr>
@@ -8839,7 +8839,7 @@
           <p:cNvPr id="115" name="renderers_icon_dot">
             <a:extLst>
               <a:ext uri="{FF2B5EF4-FFF2-40B4-BE49-F238E27FC236}">
-                <a16:creationId xmlns:a16="http://schemas.microsoft.com/office/drawing/2014/main" id="{EA8C46E3-394B-464E-3AA3-3B6309541AD9}"/>
+                <a16:creationId xmlns:a16="http://schemas.microsoft.com/office/drawing/2014/main" id="{8A60E043-CF22-8F16-E36B-676FC78359B4}"/>
               </a:ext>
             </a:extLst>
           </p:cNvPr>
@@ -8893,7 +8893,7 @@
           <p:cNvPr id="116" name="renderers_icon_label">
             <a:extLst>
               <a:ext uri="{FF2B5EF4-FFF2-40B4-BE49-F238E27FC236}">
-                <a16:creationId xmlns:a16="http://schemas.microsoft.com/office/drawing/2014/main" id="{E1E4F79A-DB90-AA54-D060-63A142327A1C}"/>
+                <a16:creationId xmlns:a16="http://schemas.microsoft.com/office/drawing/2014/main" id="{B9285215-215D-541C-E860-C67EB286D81C}"/>
               </a:ext>
             </a:extLst>
           </p:cNvPr>
@@ -8902,8 +8902,8 @@
         </p:nvSpPr>
         <p:spPr>
           <a:xfrm>
-            <a:off x="10249733" y="3636401"/>
-            <a:ext cx="191584" cy="285806"/>
+            <a:off x="10249733" y="3628724"/>
+            <a:ext cx="191584" cy="276999"/>
           </a:xfrm>
           <a:prstGeom prst="rect">
             <a:avLst/>
@@ -8911,7 +8911,7 @@
           <a:noFill/>
         </p:spPr>
         <p:txBody>
-          <a:bodyPr vert="horz" wrap="square" lIns="8708" tIns="4361" rIns="8708" bIns="4361" rtlCol="0" anchor="ctr">
+          <a:bodyPr vert="horz" wrap="square" lIns="0" tIns="0" rIns="0" bIns="0" rtlCol="0" anchor="ctr">
             <a:noAutofit/>
           </a:bodyPr>
           <a:lstStyle/>
@@ -8940,7 +8940,7 @@
           <p:cNvPr id="117" name="renderers_title">
             <a:extLst>
               <a:ext uri="{FF2B5EF4-FFF2-40B4-BE49-F238E27FC236}">
-                <a16:creationId xmlns:a16="http://schemas.microsoft.com/office/drawing/2014/main" id="{CEA48883-E954-65D9-7E65-55CD4F215E36}"/>
+                <a16:creationId xmlns:a16="http://schemas.microsoft.com/office/drawing/2014/main" id="{5DECB5AD-6D73-E6EC-A119-679E946B93D5}"/>
               </a:ext>
             </a:extLst>
           </p:cNvPr>
@@ -8986,7 +8986,7 @@
           <p:cNvPr id="118" name="renderers_line_0">
             <a:extLst>
               <a:ext uri="{FF2B5EF4-FFF2-40B4-BE49-F238E27FC236}">
-                <a16:creationId xmlns:a16="http://schemas.microsoft.com/office/drawing/2014/main" id="{00CC0E90-D150-8657-8ED5-CA08C6002136}"/>
+                <a16:creationId xmlns:a16="http://schemas.microsoft.com/office/drawing/2014/main" id="{975C6949-DE0E-7AFD-DF5C-259277393EA2}"/>
               </a:ext>
             </a:extLst>
           </p:cNvPr>
@@ -9032,7 +9032,7 @@
           <p:cNvPr id="119" name="renderers_line_1">
             <a:extLst>
               <a:ext uri="{FF2B5EF4-FFF2-40B4-BE49-F238E27FC236}">
-                <a16:creationId xmlns:a16="http://schemas.microsoft.com/office/drawing/2014/main" id="{6AC0FF05-619B-6619-7989-109A03571A02}"/>
+                <a16:creationId xmlns:a16="http://schemas.microsoft.com/office/drawing/2014/main" id="{B7D070F6-BDD2-0C0B-7B26-FEDD2316A022}"/>
               </a:ext>
             </a:extLst>
           </p:cNvPr>
@@ -9078,7 +9078,7 @@
           <p:cNvPr id="120" name="visual_check">
             <a:extLst>
               <a:ext uri="{FF2B5EF4-FFF2-40B4-BE49-F238E27FC236}">
-                <a16:creationId xmlns:a16="http://schemas.microsoft.com/office/drawing/2014/main" id="{840FB578-A723-D350-8AD1-AE21929726A2}"/>
+                <a16:creationId xmlns:a16="http://schemas.microsoft.com/office/drawing/2014/main" id="{95A6FD8E-ADC4-3949-DFA0-87C2D44DEA12}"/>
               </a:ext>
             </a:extLst>
           </p:cNvPr>
@@ -9139,7 +9139,7 @@
           <p:cNvPr id="121" name="visual_check_stripe">
             <a:extLst>
               <a:ext uri="{FF2B5EF4-FFF2-40B4-BE49-F238E27FC236}">
-                <a16:creationId xmlns:a16="http://schemas.microsoft.com/office/drawing/2014/main" id="{5047920E-BFBC-0296-5296-BD32E26230C7}"/>
+                <a16:creationId xmlns:a16="http://schemas.microsoft.com/office/drawing/2014/main" id="{097CCDCF-378C-0CA9-2949-1C496127ACE4}"/>
               </a:ext>
             </a:extLst>
           </p:cNvPr>
@@ -9193,7 +9193,7 @@
           <p:cNvPr id="122" name="visual_check_seal_icon_dot">
             <a:extLst>
               <a:ext uri="{FF2B5EF4-FFF2-40B4-BE49-F238E27FC236}">
-                <a16:creationId xmlns:a16="http://schemas.microsoft.com/office/drawing/2014/main" id="{A248D0CC-26F5-3570-CAD2-CC288B2784A9}"/>
+                <a16:creationId xmlns:a16="http://schemas.microsoft.com/office/drawing/2014/main" id="{657E9615-91C6-FEA4-99EA-C53B0456E016}"/>
               </a:ext>
             </a:extLst>
           </p:cNvPr>
@@ -9247,7 +9247,7 @@
           <p:cNvPr id="123" name="visual_check_seal_icon_label">
             <a:extLst>
               <a:ext uri="{FF2B5EF4-FFF2-40B4-BE49-F238E27FC236}">
-                <a16:creationId xmlns:a16="http://schemas.microsoft.com/office/drawing/2014/main" id="{F1DF1DF9-0631-FE37-1914-A843785C9B4E}"/>
+                <a16:creationId xmlns:a16="http://schemas.microsoft.com/office/drawing/2014/main" id="{DE08D624-1C53-CC79-DB6D-1BC6B1EC3C01}"/>
               </a:ext>
             </a:extLst>
           </p:cNvPr>
@@ -9256,8 +9256,8 @@
         </p:nvSpPr>
         <p:spPr>
           <a:xfrm>
-            <a:off x="10171357" y="4539045"/>
-            <a:ext cx="296084" cy="285806"/>
+            <a:off x="10171357" y="4527182"/>
+            <a:ext cx="296084" cy="276999"/>
           </a:xfrm>
           <a:prstGeom prst="rect">
             <a:avLst/>
@@ -9265,14 +9265,14 @@
           <a:noFill/>
         </p:spPr>
         <p:txBody>
-          <a:bodyPr vert="horz" wrap="square" lIns="8708" tIns="4361" rIns="8708" bIns="4361" rtlCol="0" anchor="ctr">
+          <a:bodyPr vert="horz" wrap="square" lIns="0" tIns="0" rIns="0" bIns="0" rtlCol="0" anchor="ctr">
             <a:noAutofit/>
           </a:bodyPr>
           <a:lstStyle/>
           <a:p>
             <a:pPr algn="ctr"/>
             <a:r>
-              <a:rPr lang="en-US" altLang="ko-KR" sz="980" b="1">
+              <a:rPr lang="en-US" altLang="ko-KR" sz="1117" b="1">
                 <a:solidFill>
                   <a:srgbClr val="FFFFFF"/>
                 </a:solidFill>
@@ -9280,7 +9280,7 @@
               </a:rPr>
               <a:t>V</a:t>
             </a:r>
-            <a:endParaRPr lang="ko-KR" altLang="en-US" sz="980" b="1">
+            <a:endParaRPr lang="ko-KR" altLang="en-US" sz="1117" b="1">
               <a:solidFill>
                 <a:srgbClr val="FFFFFF"/>
               </a:solidFill>
@@ -9294,7 +9294,7 @@
           <p:cNvPr id="124" name="visual_check_label">
             <a:extLst>
               <a:ext uri="{FF2B5EF4-FFF2-40B4-BE49-F238E27FC236}">
-                <a16:creationId xmlns:a16="http://schemas.microsoft.com/office/drawing/2014/main" id="{A15D3B39-7D57-DABC-EF09-60C9551F0C1E}"/>
+                <a16:creationId xmlns:a16="http://schemas.microsoft.com/office/drawing/2014/main" id="{E52BC9B7-D3B7-029C-3B86-582806DC241B}"/>
               </a:ext>
             </a:extLst>
           </p:cNvPr>
@@ -9340,7 +9340,7 @@
           <p:cNvPr id="125" name="visual_check_text">
             <a:extLst>
               <a:ext uri="{FF2B5EF4-FFF2-40B4-BE49-F238E27FC236}">
-                <a16:creationId xmlns:a16="http://schemas.microsoft.com/office/drawing/2014/main" id="{A6F57D7C-1A98-081B-B89E-1254D34B83D0}"/>
+                <a16:creationId xmlns:a16="http://schemas.microsoft.com/office/drawing/2014/main" id="{680BFD89-CAA3-E148-F1D0-D1018E875FF3}"/>
               </a:ext>
             </a:extLst>
           </p:cNvPr>
@@ -9386,7 +9386,7 @@
           <p:cNvPr id="126" name="coherence_band">
             <a:extLst>
               <a:ext uri="{FF2B5EF4-FFF2-40B4-BE49-F238E27FC236}">
-                <a16:creationId xmlns:a16="http://schemas.microsoft.com/office/drawing/2014/main" id="{3F9B211E-DC85-6EEF-96F9-BBF8C24CA086}"/>
+                <a16:creationId xmlns:a16="http://schemas.microsoft.com/office/drawing/2014/main" id="{1A3E2925-AF46-22A9-EB48-CA7A3936F814}"/>
               </a:ext>
             </a:extLst>
           </p:cNvPr>
@@ -9447,7 +9447,7 @@
           <p:cNvPr id="127" name="coherence_title">
             <a:extLst>
               <a:ext uri="{FF2B5EF4-FFF2-40B4-BE49-F238E27FC236}">
-                <a16:creationId xmlns:a16="http://schemas.microsoft.com/office/drawing/2014/main" id="{6F84F762-BB74-D678-A42F-DAC8F5D53AE7}"/>
+                <a16:creationId xmlns:a16="http://schemas.microsoft.com/office/drawing/2014/main" id="{45A6F1FB-6A15-F7A8-96EE-AE18898D94A3}"/>
               </a:ext>
             </a:extLst>
           </p:cNvPr>
@@ -9493,7 +9493,7 @@
           <p:cNvPr id="128" name="coherence_body">
             <a:extLst>
               <a:ext uri="{FF2B5EF4-FFF2-40B4-BE49-F238E27FC236}">
-                <a16:creationId xmlns:a16="http://schemas.microsoft.com/office/drawing/2014/main" id="{722D8012-6476-6AD7-9A0D-D03130020566}"/>
+                <a16:creationId xmlns:a16="http://schemas.microsoft.com/office/drawing/2014/main" id="{47F1A056-6BE6-923E-1AFD-D40470B3FEE7}"/>
               </a:ext>
             </a:extLst>
           </p:cNvPr>
@@ -9537,7 +9537,7 @@
     </p:spTree>
     <p:extLst>
       <p:ext uri="{BB962C8B-B14F-4D97-AF65-F5344CB8AC3E}">
-        <p14:creationId xmlns:p14="http://schemas.microsoft.com/office/powerpoint/2010/main" val="3691472564"/>
+        <p14:creationId xmlns:p14="http://schemas.microsoft.com/office/powerpoint/2010/main" val="674851706"/>
       </p:ext>
     </p:extLst>
   </p:cSld>

</xml_diff>

<commit_message>
Add separated theme style and color contract
</commit_message>
<xml_diff>
--- a/docs/assets/readme-slides/mdpr-pipeline-teaser.pptx
+++ b/docs/assets/readme-slides/mdpr-pipeline-teaser.pptx
@@ -129,7 +129,7 @@
           <p:cNvPr id="2" name="제목 1">
             <a:extLst>
               <a:ext uri="{FF2B5EF4-FFF2-40B4-BE49-F238E27FC236}">
-                <a16:creationId xmlns:a16="http://schemas.microsoft.com/office/drawing/2014/main" id="{92893F1D-D62A-2D52-8AAD-B217B572C33E}"/>
+                <a16:creationId xmlns:a16="http://schemas.microsoft.com/office/drawing/2014/main" id="{A37B26F0-640E-9B99-F478-25F62266F957}"/>
               </a:ext>
             </a:extLst>
           </p:cNvPr>
@@ -166,7 +166,7 @@
           <p:cNvPr id="3" name="부제목 2">
             <a:extLst>
               <a:ext uri="{FF2B5EF4-FFF2-40B4-BE49-F238E27FC236}">
-                <a16:creationId xmlns:a16="http://schemas.microsoft.com/office/drawing/2014/main" id="{25F715BB-6E4D-6E5E-5098-CD28C11388DA}"/>
+                <a16:creationId xmlns:a16="http://schemas.microsoft.com/office/drawing/2014/main" id="{B24F44A9-8E5B-F129-F2E7-600BAE6E0CB6}"/>
               </a:ext>
             </a:extLst>
           </p:cNvPr>
@@ -236,7 +236,7 @@
           <p:cNvPr id="4" name="날짜 개체 틀 3">
             <a:extLst>
               <a:ext uri="{FF2B5EF4-FFF2-40B4-BE49-F238E27FC236}">
-                <a16:creationId xmlns:a16="http://schemas.microsoft.com/office/drawing/2014/main" id="{ED4FF38E-3BB0-CFFB-D3CB-F9F83B828832}"/>
+                <a16:creationId xmlns:a16="http://schemas.microsoft.com/office/drawing/2014/main" id="{92A111FB-D244-E7B4-7760-B0A6C49FF3B3}"/>
               </a:ext>
             </a:extLst>
           </p:cNvPr>
@@ -252,7 +252,7 @@
           <a:bodyPr/>
           <a:lstStyle/>
           <a:p>
-            <a:fld id="{E848CDE2-9FE7-40BA-9BF4-AE70776CEE5B}" type="datetimeFigureOut">
+            <a:fld id="{C7A2DD86-A6D0-4D7F-9460-517EC008A1FC}" type="datetimeFigureOut">
               <a:rPr lang="ko-KR" altLang="en-US" smtClean="0"/>
               <a:t>2026-06-20</a:t>
             </a:fld>
@@ -265,7 +265,7 @@
           <p:cNvPr id="5" name="바닥글 개체 틀 4">
             <a:extLst>
               <a:ext uri="{FF2B5EF4-FFF2-40B4-BE49-F238E27FC236}">
-                <a16:creationId xmlns:a16="http://schemas.microsoft.com/office/drawing/2014/main" id="{AFEF3268-E3D1-0FD8-5941-9D0DDE3BD804}"/>
+                <a16:creationId xmlns:a16="http://schemas.microsoft.com/office/drawing/2014/main" id="{6723B46A-EBAE-54DD-6F68-254F94AC3092}"/>
               </a:ext>
             </a:extLst>
           </p:cNvPr>
@@ -290,7 +290,7 @@
           <p:cNvPr id="6" name="슬라이드 번호 개체 틀 5">
             <a:extLst>
               <a:ext uri="{FF2B5EF4-FFF2-40B4-BE49-F238E27FC236}">
-                <a16:creationId xmlns:a16="http://schemas.microsoft.com/office/drawing/2014/main" id="{F7996EE9-6398-596F-6085-3892B22E85FC}"/>
+                <a16:creationId xmlns:a16="http://schemas.microsoft.com/office/drawing/2014/main" id="{E0FD0168-1224-86F7-3D96-B4B70230EE54}"/>
               </a:ext>
             </a:extLst>
           </p:cNvPr>
@@ -306,7 +306,7 @@
           <a:bodyPr/>
           <a:lstStyle/>
           <a:p>
-            <a:fld id="{DD9F5464-F4A4-4964-BECE-944A5E428E53}" type="slidenum">
+            <a:fld id="{FCE527D7-AC3E-4C2A-A377-10FA5A63B0EC}" type="slidenum">
               <a:rPr lang="ko-KR" altLang="en-US" smtClean="0"/>
               <a:t>‹#›</a:t>
             </a:fld>
@@ -317,7 +317,7 @@
     </p:spTree>
     <p:extLst>
       <p:ext uri="{BB962C8B-B14F-4D97-AF65-F5344CB8AC3E}">
-        <p14:creationId xmlns:p14="http://schemas.microsoft.com/office/powerpoint/2010/main" val="3925959329"/>
+        <p14:creationId xmlns:p14="http://schemas.microsoft.com/office/powerpoint/2010/main" val="1093937482"/>
       </p:ext>
     </p:extLst>
   </p:cSld>
@@ -349,7 +349,7 @@
           <p:cNvPr id="2" name="제목 1">
             <a:extLst>
               <a:ext uri="{FF2B5EF4-FFF2-40B4-BE49-F238E27FC236}">
-                <a16:creationId xmlns:a16="http://schemas.microsoft.com/office/drawing/2014/main" id="{D0D73DCF-CABD-D76F-AC04-0B61028DB102}"/>
+                <a16:creationId xmlns:a16="http://schemas.microsoft.com/office/drawing/2014/main" id="{31C1646D-B61D-E64E-40BF-4D86CF2C6073}"/>
               </a:ext>
             </a:extLst>
           </p:cNvPr>
@@ -377,7 +377,7 @@
           <p:cNvPr id="3" name="세로 텍스트 개체 틀 2">
             <a:extLst>
               <a:ext uri="{FF2B5EF4-FFF2-40B4-BE49-F238E27FC236}">
-                <a16:creationId xmlns:a16="http://schemas.microsoft.com/office/drawing/2014/main" id="{A0B71E0D-7C4A-550A-C090-E35339E0CBA4}"/>
+                <a16:creationId xmlns:a16="http://schemas.microsoft.com/office/drawing/2014/main" id="{8A58F64B-C56E-6819-91AC-0F6C8DABAF78}"/>
               </a:ext>
             </a:extLst>
           </p:cNvPr>
@@ -434,7 +434,7 @@
           <p:cNvPr id="4" name="날짜 개체 틀 3">
             <a:extLst>
               <a:ext uri="{FF2B5EF4-FFF2-40B4-BE49-F238E27FC236}">
-                <a16:creationId xmlns:a16="http://schemas.microsoft.com/office/drawing/2014/main" id="{7A4ABDD6-4631-E9FC-7DF8-85C4E75F58BC}"/>
+                <a16:creationId xmlns:a16="http://schemas.microsoft.com/office/drawing/2014/main" id="{A03B0F8E-1CCA-0D60-351D-C1A0953B5E55}"/>
               </a:ext>
             </a:extLst>
           </p:cNvPr>
@@ -450,7 +450,7 @@
           <a:bodyPr/>
           <a:lstStyle/>
           <a:p>
-            <a:fld id="{E848CDE2-9FE7-40BA-9BF4-AE70776CEE5B}" type="datetimeFigureOut">
+            <a:fld id="{C7A2DD86-A6D0-4D7F-9460-517EC008A1FC}" type="datetimeFigureOut">
               <a:rPr lang="ko-KR" altLang="en-US" smtClean="0"/>
               <a:t>2026-06-20</a:t>
             </a:fld>
@@ -463,7 +463,7 @@
           <p:cNvPr id="5" name="바닥글 개체 틀 4">
             <a:extLst>
               <a:ext uri="{FF2B5EF4-FFF2-40B4-BE49-F238E27FC236}">
-                <a16:creationId xmlns:a16="http://schemas.microsoft.com/office/drawing/2014/main" id="{2E24DCB2-F9AA-669F-0CA6-1ACF99F93B80}"/>
+                <a16:creationId xmlns:a16="http://schemas.microsoft.com/office/drawing/2014/main" id="{668A4EE0-D67F-476D-4B42-A0602C20B927}"/>
               </a:ext>
             </a:extLst>
           </p:cNvPr>
@@ -488,7 +488,7 @@
           <p:cNvPr id="6" name="슬라이드 번호 개체 틀 5">
             <a:extLst>
               <a:ext uri="{FF2B5EF4-FFF2-40B4-BE49-F238E27FC236}">
-                <a16:creationId xmlns:a16="http://schemas.microsoft.com/office/drawing/2014/main" id="{371D045B-139D-6A5D-E287-1EAAA20A1E9B}"/>
+                <a16:creationId xmlns:a16="http://schemas.microsoft.com/office/drawing/2014/main" id="{0009D8CA-218D-C879-A6C8-2D74C62F0DB2}"/>
               </a:ext>
             </a:extLst>
           </p:cNvPr>
@@ -504,7 +504,7 @@
           <a:bodyPr/>
           <a:lstStyle/>
           <a:p>
-            <a:fld id="{DD9F5464-F4A4-4964-BECE-944A5E428E53}" type="slidenum">
+            <a:fld id="{FCE527D7-AC3E-4C2A-A377-10FA5A63B0EC}" type="slidenum">
               <a:rPr lang="ko-KR" altLang="en-US" smtClean="0"/>
               <a:t>‹#›</a:t>
             </a:fld>
@@ -515,7 +515,7 @@
     </p:spTree>
     <p:extLst>
       <p:ext uri="{BB962C8B-B14F-4D97-AF65-F5344CB8AC3E}">
-        <p14:creationId xmlns:p14="http://schemas.microsoft.com/office/powerpoint/2010/main" val="3838905520"/>
+        <p14:creationId xmlns:p14="http://schemas.microsoft.com/office/powerpoint/2010/main" val="1761592475"/>
       </p:ext>
     </p:extLst>
   </p:cSld>
@@ -547,7 +547,7 @@
           <p:cNvPr id="2" name="세로 제목 1">
             <a:extLst>
               <a:ext uri="{FF2B5EF4-FFF2-40B4-BE49-F238E27FC236}">
-                <a16:creationId xmlns:a16="http://schemas.microsoft.com/office/drawing/2014/main" id="{06568621-89D0-3402-DDEC-191AE0AEEEC9}"/>
+                <a16:creationId xmlns:a16="http://schemas.microsoft.com/office/drawing/2014/main" id="{48277972-F2E5-4BE4-396B-75C6C99A4D0E}"/>
               </a:ext>
             </a:extLst>
           </p:cNvPr>
@@ -580,7 +580,7 @@
           <p:cNvPr id="3" name="세로 텍스트 개체 틀 2">
             <a:extLst>
               <a:ext uri="{FF2B5EF4-FFF2-40B4-BE49-F238E27FC236}">
-                <a16:creationId xmlns:a16="http://schemas.microsoft.com/office/drawing/2014/main" id="{EBCBF24B-B496-23B2-CD8A-9F124EEA316B}"/>
+                <a16:creationId xmlns:a16="http://schemas.microsoft.com/office/drawing/2014/main" id="{7E6AD225-7C14-28D5-A1C6-B53423470DC1}"/>
               </a:ext>
             </a:extLst>
           </p:cNvPr>
@@ -642,7 +642,7 @@
           <p:cNvPr id="4" name="날짜 개체 틀 3">
             <a:extLst>
               <a:ext uri="{FF2B5EF4-FFF2-40B4-BE49-F238E27FC236}">
-                <a16:creationId xmlns:a16="http://schemas.microsoft.com/office/drawing/2014/main" id="{E2EEAE07-93A7-B33E-1627-05375328FCE4}"/>
+                <a16:creationId xmlns:a16="http://schemas.microsoft.com/office/drawing/2014/main" id="{05490A60-DEC3-8F51-474F-059AC6FB6539}"/>
               </a:ext>
             </a:extLst>
           </p:cNvPr>
@@ -658,7 +658,7 @@
           <a:bodyPr/>
           <a:lstStyle/>
           <a:p>
-            <a:fld id="{E848CDE2-9FE7-40BA-9BF4-AE70776CEE5B}" type="datetimeFigureOut">
+            <a:fld id="{C7A2DD86-A6D0-4D7F-9460-517EC008A1FC}" type="datetimeFigureOut">
               <a:rPr lang="ko-KR" altLang="en-US" smtClean="0"/>
               <a:t>2026-06-20</a:t>
             </a:fld>
@@ -671,7 +671,7 @@
           <p:cNvPr id="5" name="바닥글 개체 틀 4">
             <a:extLst>
               <a:ext uri="{FF2B5EF4-FFF2-40B4-BE49-F238E27FC236}">
-                <a16:creationId xmlns:a16="http://schemas.microsoft.com/office/drawing/2014/main" id="{13BF5F0B-7D30-9D43-6856-A0E19FD09B3D}"/>
+                <a16:creationId xmlns:a16="http://schemas.microsoft.com/office/drawing/2014/main" id="{725D49ED-8A2A-477D-2516-8F2058A4EACD}"/>
               </a:ext>
             </a:extLst>
           </p:cNvPr>
@@ -696,7 +696,7 @@
           <p:cNvPr id="6" name="슬라이드 번호 개체 틀 5">
             <a:extLst>
               <a:ext uri="{FF2B5EF4-FFF2-40B4-BE49-F238E27FC236}">
-                <a16:creationId xmlns:a16="http://schemas.microsoft.com/office/drawing/2014/main" id="{2E54466B-0E90-49B7-C4A6-430CA2DBC1E8}"/>
+                <a16:creationId xmlns:a16="http://schemas.microsoft.com/office/drawing/2014/main" id="{AB6155DC-AA56-A0C0-0E14-616BA34FC6B0}"/>
               </a:ext>
             </a:extLst>
           </p:cNvPr>
@@ -712,7 +712,7 @@
           <a:bodyPr/>
           <a:lstStyle/>
           <a:p>
-            <a:fld id="{DD9F5464-F4A4-4964-BECE-944A5E428E53}" type="slidenum">
+            <a:fld id="{FCE527D7-AC3E-4C2A-A377-10FA5A63B0EC}" type="slidenum">
               <a:rPr lang="ko-KR" altLang="en-US" smtClean="0"/>
               <a:t>‹#›</a:t>
             </a:fld>
@@ -723,7 +723,7 @@
     </p:spTree>
     <p:extLst>
       <p:ext uri="{BB962C8B-B14F-4D97-AF65-F5344CB8AC3E}">
-        <p14:creationId xmlns:p14="http://schemas.microsoft.com/office/powerpoint/2010/main" val="141124760"/>
+        <p14:creationId xmlns:p14="http://schemas.microsoft.com/office/powerpoint/2010/main" val="1908232628"/>
       </p:ext>
     </p:extLst>
   </p:cSld>
@@ -755,7 +755,7 @@
           <p:cNvPr id="2" name="제목 1">
             <a:extLst>
               <a:ext uri="{FF2B5EF4-FFF2-40B4-BE49-F238E27FC236}">
-                <a16:creationId xmlns:a16="http://schemas.microsoft.com/office/drawing/2014/main" id="{8551B20D-C01D-8E5E-A8B4-17B93AD5DD39}"/>
+                <a16:creationId xmlns:a16="http://schemas.microsoft.com/office/drawing/2014/main" id="{24780910-8EFD-4BED-4844-965BC711B15F}"/>
               </a:ext>
             </a:extLst>
           </p:cNvPr>
@@ -783,7 +783,7 @@
           <p:cNvPr id="3" name="내용 개체 틀 2">
             <a:extLst>
               <a:ext uri="{FF2B5EF4-FFF2-40B4-BE49-F238E27FC236}">
-                <a16:creationId xmlns:a16="http://schemas.microsoft.com/office/drawing/2014/main" id="{4549529E-888E-E8DB-C04A-734F15A6D652}"/>
+                <a16:creationId xmlns:a16="http://schemas.microsoft.com/office/drawing/2014/main" id="{3FAADF5F-5570-F73B-9477-C0224A5E6350}"/>
               </a:ext>
             </a:extLst>
           </p:cNvPr>
@@ -840,7 +840,7 @@
           <p:cNvPr id="4" name="날짜 개체 틀 3">
             <a:extLst>
               <a:ext uri="{FF2B5EF4-FFF2-40B4-BE49-F238E27FC236}">
-                <a16:creationId xmlns:a16="http://schemas.microsoft.com/office/drawing/2014/main" id="{9950ECE2-CD58-337E-2BC3-B5BF25452EA9}"/>
+                <a16:creationId xmlns:a16="http://schemas.microsoft.com/office/drawing/2014/main" id="{4D1E49B2-5255-58FA-F8D7-40E5F33564F5}"/>
               </a:ext>
             </a:extLst>
           </p:cNvPr>
@@ -856,7 +856,7 @@
           <a:bodyPr/>
           <a:lstStyle/>
           <a:p>
-            <a:fld id="{E848CDE2-9FE7-40BA-9BF4-AE70776CEE5B}" type="datetimeFigureOut">
+            <a:fld id="{C7A2DD86-A6D0-4D7F-9460-517EC008A1FC}" type="datetimeFigureOut">
               <a:rPr lang="ko-KR" altLang="en-US" smtClean="0"/>
               <a:t>2026-06-20</a:t>
             </a:fld>
@@ -869,7 +869,7 @@
           <p:cNvPr id="5" name="바닥글 개체 틀 4">
             <a:extLst>
               <a:ext uri="{FF2B5EF4-FFF2-40B4-BE49-F238E27FC236}">
-                <a16:creationId xmlns:a16="http://schemas.microsoft.com/office/drawing/2014/main" id="{07B19707-8934-3DC1-D053-B6119AE8A2B9}"/>
+                <a16:creationId xmlns:a16="http://schemas.microsoft.com/office/drawing/2014/main" id="{4740E1C8-D394-CBAD-0FB4-346F821D039E}"/>
               </a:ext>
             </a:extLst>
           </p:cNvPr>
@@ -894,7 +894,7 @@
           <p:cNvPr id="6" name="슬라이드 번호 개체 틀 5">
             <a:extLst>
               <a:ext uri="{FF2B5EF4-FFF2-40B4-BE49-F238E27FC236}">
-                <a16:creationId xmlns:a16="http://schemas.microsoft.com/office/drawing/2014/main" id="{944D9378-5B12-B57F-2F6C-689F8D068D4F}"/>
+                <a16:creationId xmlns:a16="http://schemas.microsoft.com/office/drawing/2014/main" id="{81E73AAD-BCF3-BCD1-74AB-16075BF9F176}"/>
               </a:ext>
             </a:extLst>
           </p:cNvPr>
@@ -910,7 +910,7 @@
           <a:bodyPr/>
           <a:lstStyle/>
           <a:p>
-            <a:fld id="{DD9F5464-F4A4-4964-BECE-944A5E428E53}" type="slidenum">
+            <a:fld id="{FCE527D7-AC3E-4C2A-A377-10FA5A63B0EC}" type="slidenum">
               <a:rPr lang="ko-KR" altLang="en-US" smtClean="0"/>
               <a:t>‹#›</a:t>
             </a:fld>
@@ -921,7 +921,7 @@
     </p:spTree>
     <p:extLst>
       <p:ext uri="{BB962C8B-B14F-4D97-AF65-F5344CB8AC3E}">
-        <p14:creationId xmlns:p14="http://schemas.microsoft.com/office/powerpoint/2010/main" val="478400442"/>
+        <p14:creationId xmlns:p14="http://schemas.microsoft.com/office/powerpoint/2010/main" val="2577444905"/>
       </p:ext>
     </p:extLst>
   </p:cSld>
@@ -953,7 +953,7 @@
           <p:cNvPr id="2" name="제목 1">
             <a:extLst>
               <a:ext uri="{FF2B5EF4-FFF2-40B4-BE49-F238E27FC236}">
-                <a16:creationId xmlns:a16="http://schemas.microsoft.com/office/drawing/2014/main" id="{65EEC037-F81F-9869-A587-EBD0F43A4A75}"/>
+                <a16:creationId xmlns:a16="http://schemas.microsoft.com/office/drawing/2014/main" id="{36CD94B5-872B-93ED-8736-805390ED88FF}"/>
               </a:ext>
             </a:extLst>
           </p:cNvPr>
@@ -990,7 +990,7 @@
           <p:cNvPr id="3" name="텍스트 개체 틀 2">
             <a:extLst>
               <a:ext uri="{FF2B5EF4-FFF2-40B4-BE49-F238E27FC236}">
-                <a16:creationId xmlns:a16="http://schemas.microsoft.com/office/drawing/2014/main" id="{5DCD9FC9-A843-F02A-67FC-98E6753D310A}"/>
+                <a16:creationId xmlns:a16="http://schemas.microsoft.com/office/drawing/2014/main" id="{26F5E376-FF77-01C0-2F08-78ABA6B79044}"/>
               </a:ext>
             </a:extLst>
           </p:cNvPr>
@@ -1115,7 +1115,7 @@
           <p:cNvPr id="4" name="날짜 개체 틀 3">
             <a:extLst>
               <a:ext uri="{FF2B5EF4-FFF2-40B4-BE49-F238E27FC236}">
-                <a16:creationId xmlns:a16="http://schemas.microsoft.com/office/drawing/2014/main" id="{7B56C9C2-7532-AEF3-102B-57EDB6E7E311}"/>
+                <a16:creationId xmlns:a16="http://schemas.microsoft.com/office/drawing/2014/main" id="{77927F08-6AAB-7E71-7DE6-B10A42125B70}"/>
               </a:ext>
             </a:extLst>
           </p:cNvPr>
@@ -1131,7 +1131,7 @@
           <a:bodyPr/>
           <a:lstStyle/>
           <a:p>
-            <a:fld id="{E848CDE2-9FE7-40BA-9BF4-AE70776CEE5B}" type="datetimeFigureOut">
+            <a:fld id="{C7A2DD86-A6D0-4D7F-9460-517EC008A1FC}" type="datetimeFigureOut">
               <a:rPr lang="ko-KR" altLang="en-US" smtClean="0"/>
               <a:t>2026-06-20</a:t>
             </a:fld>
@@ -1144,7 +1144,7 @@
           <p:cNvPr id="5" name="바닥글 개체 틀 4">
             <a:extLst>
               <a:ext uri="{FF2B5EF4-FFF2-40B4-BE49-F238E27FC236}">
-                <a16:creationId xmlns:a16="http://schemas.microsoft.com/office/drawing/2014/main" id="{D7A5E9DF-E6CA-6092-6573-25B5D0188A10}"/>
+                <a16:creationId xmlns:a16="http://schemas.microsoft.com/office/drawing/2014/main" id="{E0F69016-7221-B8E1-31C0-36EB0BEB58C4}"/>
               </a:ext>
             </a:extLst>
           </p:cNvPr>
@@ -1169,7 +1169,7 @@
           <p:cNvPr id="6" name="슬라이드 번호 개체 틀 5">
             <a:extLst>
               <a:ext uri="{FF2B5EF4-FFF2-40B4-BE49-F238E27FC236}">
-                <a16:creationId xmlns:a16="http://schemas.microsoft.com/office/drawing/2014/main" id="{7416DAAB-3E34-57A9-1678-38994D24436A}"/>
+                <a16:creationId xmlns:a16="http://schemas.microsoft.com/office/drawing/2014/main" id="{FBABEDF7-3663-DA8C-AA3F-454670072850}"/>
               </a:ext>
             </a:extLst>
           </p:cNvPr>
@@ -1185,7 +1185,7 @@
           <a:bodyPr/>
           <a:lstStyle/>
           <a:p>
-            <a:fld id="{DD9F5464-F4A4-4964-BECE-944A5E428E53}" type="slidenum">
+            <a:fld id="{FCE527D7-AC3E-4C2A-A377-10FA5A63B0EC}" type="slidenum">
               <a:rPr lang="ko-KR" altLang="en-US" smtClean="0"/>
               <a:t>‹#›</a:t>
             </a:fld>
@@ -1196,7 +1196,7 @@
     </p:spTree>
     <p:extLst>
       <p:ext uri="{BB962C8B-B14F-4D97-AF65-F5344CB8AC3E}">
-        <p14:creationId xmlns:p14="http://schemas.microsoft.com/office/powerpoint/2010/main" val="805985636"/>
+        <p14:creationId xmlns:p14="http://schemas.microsoft.com/office/powerpoint/2010/main" val="61224077"/>
       </p:ext>
     </p:extLst>
   </p:cSld>
@@ -1228,7 +1228,7 @@
           <p:cNvPr id="2" name="제목 1">
             <a:extLst>
               <a:ext uri="{FF2B5EF4-FFF2-40B4-BE49-F238E27FC236}">
-                <a16:creationId xmlns:a16="http://schemas.microsoft.com/office/drawing/2014/main" id="{D6185F87-D208-331D-A6A5-813B935E457A}"/>
+                <a16:creationId xmlns:a16="http://schemas.microsoft.com/office/drawing/2014/main" id="{259636A2-74F7-3345-1466-12FA07F12835}"/>
               </a:ext>
             </a:extLst>
           </p:cNvPr>
@@ -1256,7 +1256,7 @@
           <p:cNvPr id="3" name="내용 개체 틀 2">
             <a:extLst>
               <a:ext uri="{FF2B5EF4-FFF2-40B4-BE49-F238E27FC236}">
-                <a16:creationId xmlns:a16="http://schemas.microsoft.com/office/drawing/2014/main" id="{FCBC5AAF-4CF5-00C0-641D-5AC7AD7E2F2B}"/>
+                <a16:creationId xmlns:a16="http://schemas.microsoft.com/office/drawing/2014/main" id="{D3FC9E59-317C-EC31-2C7E-197136B0A27F}"/>
               </a:ext>
             </a:extLst>
           </p:cNvPr>
@@ -1318,7 +1318,7 @@
           <p:cNvPr id="4" name="내용 개체 틀 3">
             <a:extLst>
               <a:ext uri="{FF2B5EF4-FFF2-40B4-BE49-F238E27FC236}">
-                <a16:creationId xmlns:a16="http://schemas.microsoft.com/office/drawing/2014/main" id="{8B247DD1-AA59-85A5-E3C5-5D0E931CB57E}"/>
+                <a16:creationId xmlns:a16="http://schemas.microsoft.com/office/drawing/2014/main" id="{64927319-1CFB-6769-0401-3CA60A5235A8}"/>
               </a:ext>
             </a:extLst>
           </p:cNvPr>
@@ -1380,7 +1380,7 @@
           <p:cNvPr id="5" name="날짜 개체 틀 4">
             <a:extLst>
               <a:ext uri="{FF2B5EF4-FFF2-40B4-BE49-F238E27FC236}">
-                <a16:creationId xmlns:a16="http://schemas.microsoft.com/office/drawing/2014/main" id="{7FCA31BE-B2CE-FB4E-384E-5DB2EBA59724}"/>
+                <a16:creationId xmlns:a16="http://schemas.microsoft.com/office/drawing/2014/main" id="{BF822E8A-9987-D62C-DB3A-74E4F7CFC30E}"/>
               </a:ext>
             </a:extLst>
           </p:cNvPr>
@@ -1396,7 +1396,7 @@
           <a:bodyPr/>
           <a:lstStyle/>
           <a:p>
-            <a:fld id="{E848CDE2-9FE7-40BA-9BF4-AE70776CEE5B}" type="datetimeFigureOut">
+            <a:fld id="{C7A2DD86-A6D0-4D7F-9460-517EC008A1FC}" type="datetimeFigureOut">
               <a:rPr lang="ko-KR" altLang="en-US" smtClean="0"/>
               <a:t>2026-06-20</a:t>
             </a:fld>
@@ -1409,7 +1409,7 @@
           <p:cNvPr id="6" name="바닥글 개체 틀 5">
             <a:extLst>
               <a:ext uri="{FF2B5EF4-FFF2-40B4-BE49-F238E27FC236}">
-                <a16:creationId xmlns:a16="http://schemas.microsoft.com/office/drawing/2014/main" id="{C14ECD95-C41B-6127-AEB8-F6A3D3B40F7D}"/>
+                <a16:creationId xmlns:a16="http://schemas.microsoft.com/office/drawing/2014/main" id="{28B3B2FF-3CB5-7073-CB40-EC801130FF8B}"/>
               </a:ext>
             </a:extLst>
           </p:cNvPr>
@@ -1434,7 +1434,7 @@
           <p:cNvPr id="7" name="슬라이드 번호 개체 틀 6">
             <a:extLst>
               <a:ext uri="{FF2B5EF4-FFF2-40B4-BE49-F238E27FC236}">
-                <a16:creationId xmlns:a16="http://schemas.microsoft.com/office/drawing/2014/main" id="{8CF59585-BC3F-A5BF-70EB-52BEE42FB3D8}"/>
+                <a16:creationId xmlns:a16="http://schemas.microsoft.com/office/drawing/2014/main" id="{81D9144A-3B4B-DDA8-666B-FCC81D47C3D5}"/>
               </a:ext>
             </a:extLst>
           </p:cNvPr>
@@ -1450,7 +1450,7 @@
           <a:bodyPr/>
           <a:lstStyle/>
           <a:p>
-            <a:fld id="{DD9F5464-F4A4-4964-BECE-944A5E428E53}" type="slidenum">
+            <a:fld id="{FCE527D7-AC3E-4C2A-A377-10FA5A63B0EC}" type="slidenum">
               <a:rPr lang="ko-KR" altLang="en-US" smtClean="0"/>
               <a:t>‹#›</a:t>
             </a:fld>
@@ -1461,7 +1461,7 @@
     </p:spTree>
     <p:extLst>
       <p:ext uri="{BB962C8B-B14F-4D97-AF65-F5344CB8AC3E}">
-        <p14:creationId xmlns:p14="http://schemas.microsoft.com/office/powerpoint/2010/main" val="302624383"/>
+        <p14:creationId xmlns:p14="http://schemas.microsoft.com/office/powerpoint/2010/main" val="493004599"/>
       </p:ext>
     </p:extLst>
   </p:cSld>
@@ -1493,7 +1493,7 @@
           <p:cNvPr id="2" name="제목 1">
             <a:extLst>
               <a:ext uri="{FF2B5EF4-FFF2-40B4-BE49-F238E27FC236}">
-                <a16:creationId xmlns:a16="http://schemas.microsoft.com/office/drawing/2014/main" id="{7B4E4606-0361-95C4-2F67-BCCEE76CB08D}"/>
+                <a16:creationId xmlns:a16="http://schemas.microsoft.com/office/drawing/2014/main" id="{783C95EE-4AC3-1789-1C07-AB94C077E526}"/>
               </a:ext>
             </a:extLst>
           </p:cNvPr>
@@ -1526,7 +1526,7 @@
           <p:cNvPr id="3" name="텍스트 개체 틀 2">
             <a:extLst>
               <a:ext uri="{FF2B5EF4-FFF2-40B4-BE49-F238E27FC236}">
-                <a16:creationId xmlns:a16="http://schemas.microsoft.com/office/drawing/2014/main" id="{569CAD88-F6C6-5AE7-C52D-6922147CC6B3}"/>
+                <a16:creationId xmlns:a16="http://schemas.microsoft.com/office/drawing/2014/main" id="{E362E9F6-3854-5CFB-3F39-F6C93E2D8073}"/>
               </a:ext>
             </a:extLst>
           </p:cNvPr>
@@ -1597,7 +1597,7 @@
           <p:cNvPr id="4" name="내용 개체 틀 3">
             <a:extLst>
               <a:ext uri="{FF2B5EF4-FFF2-40B4-BE49-F238E27FC236}">
-                <a16:creationId xmlns:a16="http://schemas.microsoft.com/office/drawing/2014/main" id="{D6AB9014-7B6F-2513-03B8-3279C6354C05}"/>
+                <a16:creationId xmlns:a16="http://schemas.microsoft.com/office/drawing/2014/main" id="{F6B547F6-D420-0E1D-2730-FD58B13669BF}"/>
               </a:ext>
             </a:extLst>
           </p:cNvPr>
@@ -1659,7 +1659,7 @@
           <p:cNvPr id="5" name="텍스트 개체 틀 4">
             <a:extLst>
               <a:ext uri="{FF2B5EF4-FFF2-40B4-BE49-F238E27FC236}">
-                <a16:creationId xmlns:a16="http://schemas.microsoft.com/office/drawing/2014/main" id="{9B312FF5-A79C-75F3-4BD4-9EBF55B8B668}"/>
+                <a16:creationId xmlns:a16="http://schemas.microsoft.com/office/drawing/2014/main" id="{3F67708D-781A-05B3-950D-BA6BE370F70A}"/>
               </a:ext>
             </a:extLst>
           </p:cNvPr>
@@ -1730,7 +1730,7 @@
           <p:cNvPr id="6" name="내용 개체 틀 5">
             <a:extLst>
               <a:ext uri="{FF2B5EF4-FFF2-40B4-BE49-F238E27FC236}">
-                <a16:creationId xmlns:a16="http://schemas.microsoft.com/office/drawing/2014/main" id="{AE47B5ED-B353-F558-1CAA-8456233A8C0E}"/>
+                <a16:creationId xmlns:a16="http://schemas.microsoft.com/office/drawing/2014/main" id="{315A6460-D23A-8EB0-6643-57AA472AAF8C}"/>
               </a:ext>
             </a:extLst>
           </p:cNvPr>
@@ -1792,7 +1792,7 @@
           <p:cNvPr id="7" name="날짜 개체 틀 6">
             <a:extLst>
               <a:ext uri="{FF2B5EF4-FFF2-40B4-BE49-F238E27FC236}">
-                <a16:creationId xmlns:a16="http://schemas.microsoft.com/office/drawing/2014/main" id="{3FC21CEE-75E4-43FC-23E4-E637FD25CAA7}"/>
+                <a16:creationId xmlns:a16="http://schemas.microsoft.com/office/drawing/2014/main" id="{216BCF9B-18C6-B400-0188-E7AB1EC9F8B5}"/>
               </a:ext>
             </a:extLst>
           </p:cNvPr>
@@ -1808,7 +1808,7 @@
           <a:bodyPr/>
           <a:lstStyle/>
           <a:p>
-            <a:fld id="{E848CDE2-9FE7-40BA-9BF4-AE70776CEE5B}" type="datetimeFigureOut">
+            <a:fld id="{C7A2DD86-A6D0-4D7F-9460-517EC008A1FC}" type="datetimeFigureOut">
               <a:rPr lang="ko-KR" altLang="en-US" smtClean="0"/>
               <a:t>2026-06-20</a:t>
             </a:fld>
@@ -1821,7 +1821,7 @@
           <p:cNvPr id="8" name="바닥글 개체 틀 7">
             <a:extLst>
               <a:ext uri="{FF2B5EF4-FFF2-40B4-BE49-F238E27FC236}">
-                <a16:creationId xmlns:a16="http://schemas.microsoft.com/office/drawing/2014/main" id="{3C2ED05F-7A04-96B4-F8F0-82AC17DCB69A}"/>
+                <a16:creationId xmlns:a16="http://schemas.microsoft.com/office/drawing/2014/main" id="{F48EE727-1F5E-B705-905C-8BEBFDD3DB8D}"/>
               </a:ext>
             </a:extLst>
           </p:cNvPr>
@@ -1846,7 +1846,7 @@
           <p:cNvPr id="9" name="슬라이드 번호 개체 틀 8">
             <a:extLst>
               <a:ext uri="{FF2B5EF4-FFF2-40B4-BE49-F238E27FC236}">
-                <a16:creationId xmlns:a16="http://schemas.microsoft.com/office/drawing/2014/main" id="{8C5DDAF3-88E4-A720-79FA-35A8FD8D79FB}"/>
+                <a16:creationId xmlns:a16="http://schemas.microsoft.com/office/drawing/2014/main" id="{928C4C5E-007C-5EF0-F18A-EAFF851DC4EB}"/>
               </a:ext>
             </a:extLst>
           </p:cNvPr>
@@ -1862,7 +1862,7 @@
           <a:bodyPr/>
           <a:lstStyle/>
           <a:p>
-            <a:fld id="{DD9F5464-F4A4-4964-BECE-944A5E428E53}" type="slidenum">
+            <a:fld id="{FCE527D7-AC3E-4C2A-A377-10FA5A63B0EC}" type="slidenum">
               <a:rPr lang="ko-KR" altLang="en-US" smtClean="0"/>
               <a:t>‹#›</a:t>
             </a:fld>
@@ -1873,7 +1873,7 @@
     </p:spTree>
     <p:extLst>
       <p:ext uri="{BB962C8B-B14F-4D97-AF65-F5344CB8AC3E}">
-        <p14:creationId xmlns:p14="http://schemas.microsoft.com/office/powerpoint/2010/main" val="3701057167"/>
+        <p14:creationId xmlns:p14="http://schemas.microsoft.com/office/powerpoint/2010/main" val="738334856"/>
       </p:ext>
     </p:extLst>
   </p:cSld>
@@ -1905,7 +1905,7 @@
           <p:cNvPr id="2" name="제목 1">
             <a:extLst>
               <a:ext uri="{FF2B5EF4-FFF2-40B4-BE49-F238E27FC236}">
-                <a16:creationId xmlns:a16="http://schemas.microsoft.com/office/drawing/2014/main" id="{CA98716F-B681-4448-12BA-1B3C2E37EA4A}"/>
+                <a16:creationId xmlns:a16="http://schemas.microsoft.com/office/drawing/2014/main" id="{0602FFFF-F315-33D8-F4CC-6CA1035C7909}"/>
               </a:ext>
             </a:extLst>
           </p:cNvPr>
@@ -1933,7 +1933,7 @@
           <p:cNvPr id="3" name="날짜 개체 틀 2">
             <a:extLst>
               <a:ext uri="{FF2B5EF4-FFF2-40B4-BE49-F238E27FC236}">
-                <a16:creationId xmlns:a16="http://schemas.microsoft.com/office/drawing/2014/main" id="{F3D10F43-F496-217F-0DF7-7013D7BF3186}"/>
+                <a16:creationId xmlns:a16="http://schemas.microsoft.com/office/drawing/2014/main" id="{7AEFD362-6802-641B-305D-0B7DDD916D24}"/>
               </a:ext>
             </a:extLst>
           </p:cNvPr>
@@ -1949,7 +1949,7 @@
           <a:bodyPr/>
           <a:lstStyle/>
           <a:p>
-            <a:fld id="{E848CDE2-9FE7-40BA-9BF4-AE70776CEE5B}" type="datetimeFigureOut">
+            <a:fld id="{C7A2DD86-A6D0-4D7F-9460-517EC008A1FC}" type="datetimeFigureOut">
               <a:rPr lang="ko-KR" altLang="en-US" smtClean="0"/>
               <a:t>2026-06-20</a:t>
             </a:fld>
@@ -1962,7 +1962,7 @@
           <p:cNvPr id="4" name="바닥글 개체 틀 3">
             <a:extLst>
               <a:ext uri="{FF2B5EF4-FFF2-40B4-BE49-F238E27FC236}">
-                <a16:creationId xmlns:a16="http://schemas.microsoft.com/office/drawing/2014/main" id="{5F093488-FBC4-17E6-A1A9-7ADA717DF3EE}"/>
+                <a16:creationId xmlns:a16="http://schemas.microsoft.com/office/drawing/2014/main" id="{86321183-CC82-E047-78E0-EE249C3CE405}"/>
               </a:ext>
             </a:extLst>
           </p:cNvPr>
@@ -1987,7 +1987,7 @@
           <p:cNvPr id="5" name="슬라이드 번호 개체 틀 4">
             <a:extLst>
               <a:ext uri="{FF2B5EF4-FFF2-40B4-BE49-F238E27FC236}">
-                <a16:creationId xmlns:a16="http://schemas.microsoft.com/office/drawing/2014/main" id="{034E7F5E-DA6E-92B9-6F68-535A21DA53D8}"/>
+                <a16:creationId xmlns:a16="http://schemas.microsoft.com/office/drawing/2014/main" id="{3B6778E2-3C22-D6E3-0D41-0BCE441FC32C}"/>
               </a:ext>
             </a:extLst>
           </p:cNvPr>
@@ -2003,7 +2003,7 @@
           <a:bodyPr/>
           <a:lstStyle/>
           <a:p>
-            <a:fld id="{DD9F5464-F4A4-4964-BECE-944A5E428E53}" type="slidenum">
+            <a:fld id="{FCE527D7-AC3E-4C2A-A377-10FA5A63B0EC}" type="slidenum">
               <a:rPr lang="ko-KR" altLang="en-US" smtClean="0"/>
               <a:t>‹#›</a:t>
             </a:fld>
@@ -2014,7 +2014,7 @@
     </p:spTree>
     <p:extLst>
       <p:ext uri="{BB962C8B-B14F-4D97-AF65-F5344CB8AC3E}">
-        <p14:creationId xmlns:p14="http://schemas.microsoft.com/office/powerpoint/2010/main" val="4042313397"/>
+        <p14:creationId xmlns:p14="http://schemas.microsoft.com/office/powerpoint/2010/main" val="2282776537"/>
       </p:ext>
     </p:extLst>
   </p:cSld>
@@ -2046,7 +2046,7 @@
           <p:cNvPr id="2" name="날짜 개체 틀 1">
             <a:extLst>
               <a:ext uri="{FF2B5EF4-FFF2-40B4-BE49-F238E27FC236}">
-                <a16:creationId xmlns:a16="http://schemas.microsoft.com/office/drawing/2014/main" id="{608BC39E-1E64-4B67-9009-182F291161FE}"/>
+                <a16:creationId xmlns:a16="http://schemas.microsoft.com/office/drawing/2014/main" id="{B3F24C52-FD90-7FA0-5B37-249F5E44CEB2}"/>
               </a:ext>
             </a:extLst>
           </p:cNvPr>
@@ -2062,7 +2062,7 @@
           <a:bodyPr/>
           <a:lstStyle/>
           <a:p>
-            <a:fld id="{E848CDE2-9FE7-40BA-9BF4-AE70776CEE5B}" type="datetimeFigureOut">
+            <a:fld id="{C7A2DD86-A6D0-4D7F-9460-517EC008A1FC}" type="datetimeFigureOut">
               <a:rPr lang="ko-KR" altLang="en-US" smtClean="0"/>
               <a:t>2026-06-20</a:t>
             </a:fld>
@@ -2075,7 +2075,7 @@
           <p:cNvPr id="3" name="바닥글 개체 틀 2">
             <a:extLst>
               <a:ext uri="{FF2B5EF4-FFF2-40B4-BE49-F238E27FC236}">
-                <a16:creationId xmlns:a16="http://schemas.microsoft.com/office/drawing/2014/main" id="{D72CF067-44F7-3C58-5345-6AF537B64443}"/>
+                <a16:creationId xmlns:a16="http://schemas.microsoft.com/office/drawing/2014/main" id="{99FC91CF-2140-A15E-0D22-FEB262C48385}"/>
               </a:ext>
             </a:extLst>
           </p:cNvPr>
@@ -2100,7 +2100,7 @@
           <p:cNvPr id="4" name="슬라이드 번호 개체 틀 3">
             <a:extLst>
               <a:ext uri="{FF2B5EF4-FFF2-40B4-BE49-F238E27FC236}">
-                <a16:creationId xmlns:a16="http://schemas.microsoft.com/office/drawing/2014/main" id="{7939CD28-4D34-F693-AE6E-D29907763A46}"/>
+                <a16:creationId xmlns:a16="http://schemas.microsoft.com/office/drawing/2014/main" id="{35A378C8-4675-A6CD-4D62-C2F684F37488}"/>
               </a:ext>
             </a:extLst>
           </p:cNvPr>
@@ -2116,7 +2116,7 @@
           <a:bodyPr/>
           <a:lstStyle/>
           <a:p>
-            <a:fld id="{DD9F5464-F4A4-4964-BECE-944A5E428E53}" type="slidenum">
+            <a:fld id="{FCE527D7-AC3E-4C2A-A377-10FA5A63B0EC}" type="slidenum">
               <a:rPr lang="ko-KR" altLang="en-US" smtClean="0"/>
               <a:t>‹#›</a:t>
             </a:fld>
@@ -2127,7 +2127,7 @@
     </p:spTree>
     <p:extLst>
       <p:ext uri="{BB962C8B-B14F-4D97-AF65-F5344CB8AC3E}">
-        <p14:creationId xmlns:p14="http://schemas.microsoft.com/office/powerpoint/2010/main" val="3170499741"/>
+        <p14:creationId xmlns:p14="http://schemas.microsoft.com/office/powerpoint/2010/main" val="630287698"/>
       </p:ext>
     </p:extLst>
   </p:cSld>
@@ -2159,7 +2159,7 @@
           <p:cNvPr id="2" name="제목 1">
             <a:extLst>
               <a:ext uri="{FF2B5EF4-FFF2-40B4-BE49-F238E27FC236}">
-                <a16:creationId xmlns:a16="http://schemas.microsoft.com/office/drawing/2014/main" id="{25E09777-443C-BE23-FD3D-453756E5D8CB}"/>
+                <a16:creationId xmlns:a16="http://schemas.microsoft.com/office/drawing/2014/main" id="{0449B2F0-0B17-FA76-CD3F-2166E47CA782}"/>
               </a:ext>
             </a:extLst>
           </p:cNvPr>
@@ -2196,7 +2196,7 @@
           <p:cNvPr id="3" name="내용 개체 틀 2">
             <a:extLst>
               <a:ext uri="{FF2B5EF4-FFF2-40B4-BE49-F238E27FC236}">
-                <a16:creationId xmlns:a16="http://schemas.microsoft.com/office/drawing/2014/main" id="{FF26679C-9EF9-0DAC-73FF-E87704FE4B4E}"/>
+                <a16:creationId xmlns:a16="http://schemas.microsoft.com/office/drawing/2014/main" id="{605648D6-19C2-5C90-EFD4-9DA4F57821F3}"/>
               </a:ext>
             </a:extLst>
           </p:cNvPr>
@@ -2286,7 +2286,7 @@
           <p:cNvPr id="4" name="텍스트 개체 틀 3">
             <a:extLst>
               <a:ext uri="{FF2B5EF4-FFF2-40B4-BE49-F238E27FC236}">
-                <a16:creationId xmlns:a16="http://schemas.microsoft.com/office/drawing/2014/main" id="{EC86C164-867B-FEF9-4C54-83AD45ADBEEE}"/>
+                <a16:creationId xmlns:a16="http://schemas.microsoft.com/office/drawing/2014/main" id="{D7202582-513D-5C88-626C-BA8200A9170B}"/>
               </a:ext>
             </a:extLst>
           </p:cNvPr>
@@ -2357,7 +2357,7 @@
           <p:cNvPr id="5" name="날짜 개체 틀 4">
             <a:extLst>
               <a:ext uri="{FF2B5EF4-FFF2-40B4-BE49-F238E27FC236}">
-                <a16:creationId xmlns:a16="http://schemas.microsoft.com/office/drawing/2014/main" id="{CCD49319-82C8-0EA9-A972-C5F634CF04B5}"/>
+                <a16:creationId xmlns:a16="http://schemas.microsoft.com/office/drawing/2014/main" id="{E87D2C64-2914-63C8-9246-0E25E41483E9}"/>
               </a:ext>
             </a:extLst>
           </p:cNvPr>
@@ -2373,7 +2373,7 @@
           <a:bodyPr/>
           <a:lstStyle/>
           <a:p>
-            <a:fld id="{E848CDE2-9FE7-40BA-9BF4-AE70776CEE5B}" type="datetimeFigureOut">
+            <a:fld id="{C7A2DD86-A6D0-4D7F-9460-517EC008A1FC}" type="datetimeFigureOut">
               <a:rPr lang="ko-KR" altLang="en-US" smtClean="0"/>
               <a:t>2026-06-20</a:t>
             </a:fld>
@@ -2386,7 +2386,7 @@
           <p:cNvPr id="6" name="바닥글 개체 틀 5">
             <a:extLst>
               <a:ext uri="{FF2B5EF4-FFF2-40B4-BE49-F238E27FC236}">
-                <a16:creationId xmlns:a16="http://schemas.microsoft.com/office/drawing/2014/main" id="{51E4AAE1-20AC-B9A1-9D3C-5524FA1419CA}"/>
+                <a16:creationId xmlns:a16="http://schemas.microsoft.com/office/drawing/2014/main" id="{AD2064E1-6D91-1DA3-D17D-A53B8C352A20}"/>
               </a:ext>
             </a:extLst>
           </p:cNvPr>
@@ -2411,7 +2411,7 @@
           <p:cNvPr id="7" name="슬라이드 번호 개체 틀 6">
             <a:extLst>
               <a:ext uri="{FF2B5EF4-FFF2-40B4-BE49-F238E27FC236}">
-                <a16:creationId xmlns:a16="http://schemas.microsoft.com/office/drawing/2014/main" id="{6D1B1B0A-BD4A-05A6-EEE4-900986EC1079}"/>
+                <a16:creationId xmlns:a16="http://schemas.microsoft.com/office/drawing/2014/main" id="{BFD6E679-D03D-637F-C8D0-A798653FE569}"/>
               </a:ext>
             </a:extLst>
           </p:cNvPr>
@@ -2427,7 +2427,7 @@
           <a:bodyPr/>
           <a:lstStyle/>
           <a:p>
-            <a:fld id="{DD9F5464-F4A4-4964-BECE-944A5E428E53}" type="slidenum">
+            <a:fld id="{FCE527D7-AC3E-4C2A-A377-10FA5A63B0EC}" type="slidenum">
               <a:rPr lang="ko-KR" altLang="en-US" smtClean="0"/>
               <a:t>‹#›</a:t>
             </a:fld>
@@ -2438,7 +2438,7 @@
     </p:spTree>
     <p:extLst>
       <p:ext uri="{BB962C8B-B14F-4D97-AF65-F5344CB8AC3E}">
-        <p14:creationId xmlns:p14="http://schemas.microsoft.com/office/powerpoint/2010/main" val="1205516953"/>
+        <p14:creationId xmlns:p14="http://schemas.microsoft.com/office/powerpoint/2010/main" val="2595109787"/>
       </p:ext>
     </p:extLst>
   </p:cSld>
@@ -2470,7 +2470,7 @@
           <p:cNvPr id="2" name="제목 1">
             <a:extLst>
               <a:ext uri="{FF2B5EF4-FFF2-40B4-BE49-F238E27FC236}">
-                <a16:creationId xmlns:a16="http://schemas.microsoft.com/office/drawing/2014/main" id="{B106BA5A-292E-D494-6C9E-98A5137F7237}"/>
+                <a16:creationId xmlns:a16="http://schemas.microsoft.com/office/drawing/2014/main" id="{D495988F-C569-76E7-1A40-6DAB13E279B8}"/>
               </a:ext>
             </a:extLst>
           </p:cNvPr>
@@ -2507,7 +2507,7 @@
           <p:cNvPr id="3" name="그림 개체 틀 2">
             <a:extLst>
               <a:ext uri="{FF2B5EF4-FFF2-40B4-BE49-F238E27FC236}">
-                <a16:creationId xmlns:a16="http://schemas.microsoft.com/office/drawing/2014/main" id="{BF3CB32D-2840-3BCC-12E7-A6738C20D009}"/>
+                <a16:creationId xmlns:a16="http://schemas.microsoft.com/office/drawing/2014/main" id="{35E4056D-3211-B208-9FB4-3F6EFCE5EC0A}"/>
               </a:ext>
             </a:extLst>
           </p:cNvPr>
@@ -2574,7 +2574,7 @@
           <p:cNvPr id="4" name="텍스트 개체 틀 3">
             <a:extLst>
               <a:ext uri="{FF2B5EF4-FFF2-40B4-BE49-F238E27FC236}">
-                <a16:creationId xmlns:a16="http://schemas.microsoft.com/office/drawing/2014/main" id="{6602DCE5-3313-EE42-A5B6-52C9527950B8}"/>
+                <a16:creationId xmlns:a16="http://schemas.microsoft.com/office/drawing/2014/main" id="{D968AE31-E146-1C7E-61FF-309BE58E9781}"/>
               </a:ext>
             </a:extLst>
           </p:cNvPr>
@@ -2645,7 +2645,7 @@
           <p:cNvPr id="5" name="날짜 개체 틀 4">
             <a:extLst>
               <a:ext uri="{FF2B5EF4-FFF2-40B4-BE49-F238E27FC236}">
-                <a16:creationId xmlns:a16="http://schemas.microsoft.com/office/drawing/2014/main" id="{2E246E3E-282D-1404-2BBB-C60BEC7FE3B6}"/>
+                <a16:creationId xmlns:a16="http://schemas.microsoft.com/office/drawing/2014/main" id="{637F5C53-8233-88AB-94DA-3F36426BB37F}"/>
               </a:ext>
             </a:extLst>
           </p:cNvPr>
@@ -2661,7 +2661,7 @@
           <a:bodyPr/>
           <a:lstStyle/>
           <a:p>
-            <a:fld id="{E848CDE2-9FE7-40BA-9BF4-AE70776CEE5B}" type="datetimeFigureOut">
+            <a:fld id="{C7A2DD86-A6D0-4D7F-9460-517EC008A1FC}" type="datetimeFigureOut">
               <a:rPr lang="ko-KR" altLang="en-US" smtClean="0"/>
               <a:t>2026-06-20</a:t>
             </a:fld>
@@ -2674,7 +2674,7 @@
           <p:cNvPr id="6" name="바닥글 개체 틀 5">
             <a:extLst>
               <a:ext uri="{FF2B5EF4-FFF2-40B4-BE49-F238E27FC236}">
-                <a16:creationId xmlns:a16="http://schemas.microsoft.com/office/drawing/2014/main" id="{1DBB5D62-A317-FB80-B961-992F88A892FC}"/>
+                <a16:creationId xmlns:a16="http://schemas.microsoft.com/office/drawing/2014/main" id="{70D677E0-F05C-3246-7C17-ADAC3FFAFD35}"/>
               </a:ext>
             </a:extLst>
           </p:cNvPr>
@@ -2699,7 +2699,7 @@
           <p:cNvPr id="7" name="슬라이드 번호 개체 틀 6">
             <a:extLst>
               <a:ext uri="{FF2B5EF4-FFF2-40B4-BE49-F238E27FC236}">
-                <a16:creationId xmlns:a16="http://schemas.microsoft.com/office/drawing/2014/main" id="{3CEBE489-0505-933B-B8C9-0108DC0403D2}"/>
+                <a16:creationId xmlns:a16="http://schemas.microsoft.com/office/drawing/2014/main" id="{7B44CE93-A8EB-4AE8-EDB2-C01FC784DAB2}"/>
               </a:ext>
             </a:extLst>
           </p:cNvPr>
@@ -2715,7 +2715,7 @@
           <a:bodyPr/>
           <a:lstStyle/>
           <a:p>
-            <a:fld id="{DD9F5464-F4A4-4964-BECE-944A5E428E53}" type="slidenum">
+            <a:fld id="{FCE527D7-AC3E-4C2A-A377-10FA5A63B0EC}" type="slidenum">
               <a:rPr lang="ko-KR" altLang="en-US" smtClean="0"/>
               <a:t>‹#›</a:t>
             </a:fld>
@@ -2726,7 +2726,7 @@
     </p:spTree>
     <p:extLst>
       <p:ext uri="{BB962C8B-B14F-4D97-AF65-F5344CB8AC3E}">
-        <p14:creationId xmlns:p14="http://schemas.microsoft.com/office/powerpoint/2010/main" val="3307314845"/>
+        <p14:creationId xmlns:p14="http://schemas.microsoft.com/office/powerpoint/2010/main" val="2179983072"/>
       </p:ext>
     </p:extLst>
   </p:cSld>
@@ -2763,7 +2763,7 @@
           <p:cNvPr id="2" name="제목 개체 틀 1">
             <a:extLst>
               <a:ext uri="{FF2B5EF4-FFF2-40B4-BE49-F238E27FC236}">
-                <a16:creationId xmlns:a16="http://schemas.microsoft.com/office/drawing/2014/main" id="{E04EE6ED-3B7F-E793-D94E-CE26A933E574}"/>
+                <a16:creationId xmlns:a16="http://schemas.microsoft.com/office/drawing/2014/main" id="{F21EBD62-315F-C814-8EDC-6F994CB0B734}"/>
               </a:ext>
             </a:extLst>
           </p:cNvPr>
@@ -2801,7 +2801,7 @@
           <p:cNvPr id="3" name="텍스트 개체 틀 2">
             <a:extLst>
               <a:ext uri="{FF2B5EF4-FFF2-40B4-BE49-F238E27FC236}">
-                <a16:creationId xmlns:a16="http://schemas.microsoft.com/office/drawing/2014/main" id="{1E7D42CD-9377-467C-2EE1-2A3E804CC26C}"/>
+                <a16:creationId xmlns:a16="http://schemas.microsoft.com/office/drawing/2014/main" id="{98F1E854-C3D2-469A-9399-FFDB1B718E3F}"/>
               </a:ext>
             </a:extLst>
           </p:cNvPr>
@@ -2868,7 +2868,7 @@
           <p:cNvPr id="4" name="날짜 개체 틀 3">
             <a:extLst>
               <a:ext uri="{FF2B5EF4-FFF2-40B4-BE49-F238E27FC236}">
-                <a16:creationId xmlns:a16="http://schemas.microsoft.com/office/drawing/2014/main" id="{29AE03BE-2968-610C-931B-A4FCAC02682D}"/>
+                <a16:creationId xmlns:a16="http://schemas.microsoft.com/office/drawing/2014/main" id="{E21CF47B-8AF6-0612-5315-559C5674103F}"/>
               </a:ext>
             </a:extLst>
           </p:cNvPr>
@@ -2902,7 +2902,7 @@
             </a:lvl1pPr>
           </a:lstStyle>
           <a:p>
-            <a:fld id="{E848CDE2-9FE7-40BA-9BF4-AE70776CEE5B}" type="datetimeFigureOut">
+            <a:fld id="{C7A2DD86-A6D0-4D7F-9460-517EC008A1FC}" type="datetimeFigureOut">
               <a:rPr lang="ko-KR" altLang="en-US" smtClean="0"/>
               <a:t>2026-06-20</a:t>
             </a:fld>
@@ -2915,7 +2915,7 @@
           <p:cNvPr id="5" name="바닥글 개체 틀 4">
             <a:extLst>
               <a:ext uri="{FF2B5EF4-FFF2-40B4-BE49-F238E27FC236}">
-                <a16:creationId xmlns:a16="http://schemas.microsoft.com/office/drawing/2014/main" id="{375FA33C-1928-6F5D-DB1C-DFC2DA760B8E}"/>
+                <a16:creationId xmlns:a16="http://schemas.microsoft.com/office/drawing/2014/main" id="{4A289A9F-D007-4844-FE76-CC496EB5E998}"/>
               </a:ext>
             </a:extLst>
           </p:cNvPr>
@@ -2958,7 +2958,7 @@
           <p:cNvPr id="6" name="슬라이드 번호 개체 틀 5">
             <a:extLst>
               <a:ext uri="{FF2B5EF4-FFF2-40B4-BE49-F238E27FC236}">
-                <a16:creationId xmlns:a16="http://schemas.microsoft.com/office/drawing/2014/main" id="{5B8C61BB-8B76-3204-73FB-BA35C593F69F}"/>
+                <a16:creationId xmlns:a16="http://schemas.microsoft.com/office/drawing/2014/main" id="{8DB4F75F-98D5-671E-B8D2-02A98EA6252F}"/>
               </a:ext>
             </a:extLst>
           </p:cNvPr>
@@ -2992,7 +2992,7 @@
             </a:lvl1pPr>
           </a:lstStyle>
           <a:p>
-            <a:fld id="{DD9F5464-F4A4-4964-BECE-944A5E428E53}" type="slidenum">
+            <a:fld id="{FCE527D7-AC3E-4C2A-A377-10FA5A63B0EC}" type="slidenum">
               <a:rPr lang="ko-KR" altLang="en-US" smtClean="0"/>
               <a:t>‹#›</a:t>
             </a:fld>
@@ -3003,7 +3003,7 @@
     </p:spTree>
     <p:extLst>
       <p:ext uri="{BB962C8B-B14F-4D97-AF65-F5344CB8AC3E}">
-        <p14:creationId xmlns:p14="http://schemas.microsoft.com/office/powerpoint/2010/main" val="3698964218"/>
+        <p14:creationId xmlns:p14="http://schemas.microsoft.com/office/powerpoint/2010/main" val="1183363630"/>
       </p:ext>
     </p:extLst>
   </p:cSld>
@@ -3326,7 +3326,7 @@
           <p:cNvPr id="2" name="z00_grid_top">
             <a:extLst>
               <a:ext uri="{FF2B5EF4-FFF2-40B4-BE49-F238E27FC236}">
-                <a16:creationId xmlns:a16="http://schemas.microsoft.com/office/drawing/2014/main" id="{00475DBB-8F5F-C767-F1C1-5498618EDEED}"/>
+                <a16:creationId xmlns:a16="http://schemas.microsoft.com/office/drawing/2014/main" id="{54103CB4-1F7D-1488-C315-9001ABFEEDB1}"/>
               </a:ext>
             </a:extLst>
           </p:cNvPr>
@@ -3369,7 +3369,7 @@
           <p:cNvPr id="3" name="z00_grid_bottom">
             <a:extLst>
               <a:ext uri="{FF2B5EF4-FFF2-40B4-BE49-F238E27FC236}">
-                <a16:creationId xmlns:a16="http://schemas.microsoft.com/office/drawing/2014/main" id="{DF5256FD-F158-8128-5AAF-877400349DD7}"/>
+                <a16:creationId xmlns:a16="http://schemas.microsoft.com/office/drawing/2014/main" id="{976757FB-F7A7-7C75-F441-550C6C174258}"/>
               </a:ext>
             </a:extLst>
           </p:cNvPr>
@@ -3412,7 +3412,7 @@
           <p:cNvPr id="4" name="z00_grid_v_0">
             <a:extLst>
               <a:ext uri="{FF2B5EF4-FFF2-40B4-BE49-F238E27FC236}">
-                <a16:creationId xmlns:a16="http://schemas.microsoft.com/office/drawing/2014/main" id="{9CF67D0B-E5A9-A589-04DD-EC781B3F0632}"/>
+                <a16:creationId xmlns:a16="http://schemas.microsoft.com/office/drawing/2014/main" id="{84F1C7E9-613C-8E59-3689-CC7AF91E0959}"/>
               </a:ext>
             </a:extLst>
           </p:cNvPr>
@@ -3455,7 +3455,7 @@
           <p:cNvPr id="5" name="z00_grid_v_1">
             <a:extLst>
               <a:ext uri="{FF2B5EF4-FFF2-40B4-BE49-F238E27FC236}">
-                <a16:creationId xmlns:a16="http://schemas.microsoft.com/office/drawing/2014/main" id="{4FA74D82-9340-405E-3377-552D48906895}"/>
+                <a16:creationId xmlns:a16="http://schemas.microsoft.com/office/drawing/2014/main" id="{09A9CB6A-86C3-4BF5-6362-64AD612FBADA}"/>
               </a:ext>
             </a:extLst>
           </p:cNvPr>
@@ -3498,7 +3498,7 @@
           <p:cNvPr id="6" name="z00_grid_v_2">
             <a:extLst>
               <a:ext uri="{FF2B5EF4-FFF2-40B4-BE49-F238E27FC236}">
-                <a16:creationId xmlns:a16="http://schemas.microsoft.com/office/drawing/2014/main" id="{340D8C2D-8C88-AF82-FCD5-8E58DC051196}"/>
+                <a16:creationId xmlns:a16="http://schemas.microsoft.com/office/drawing/2014/main" id="{D32B3094-48FE-7636-64BF-F965D56F4889}"/>
               </a:ext>
             </a:extLst>
           </p:cNvPr>
@@ -3541,7 +3541,7 @@
           <p:cNvPr id="7" name="header_title">
             <a:extLst>
               <a:ext uri="{FF2B5EF4-FFF2-40B4-BE49-F238E27FC236}">
-                <a16:creationId xmlns:a16="http://schemas.microsoft.com/office/drawing/2014/main" id="{0D4A10B1-B3BD-B38C-C03C-2883C4E3DF4C}"/>
+                <a16:creationId xmlns:a16="http://schemas.microsoft.com/office/drawing/2014/main" id="{D36508D1-A028-B71B-F85B-241A3DE2B6FF}"/>
               </a:ext>
             </a:extLst>
           </p:cNvPr>
@@ -3587,7 +3587,7 @@
           <p:cNvPr id="8" name="header_subtitle">
             <a:extLst>
               <a:ext uri="{FF2B5EF4-FFF2-40B4-BE49-F238E27FC236}">
-                <a16:creationId xmlns:a16="http://schemas.microsoft.com/office/drawing/2014/main" id="{80E9F703-909F-D112-6F49-896EE3710F28}"/>
+                <a16:creationId xmlns:a16="http://schemas.microsoft.com/office/drawing/2014/main" id="{8A7A8773-5025-E21A-B0A0-AE6F28CF6803}"/>
               </a:ext>
             </a:extLst>
           </p:cNvPr>
@@ -3633,7 +3633,7 @@
           <p:cNvPr id="9" name="zone_content_panel">
             <a:extLst>
               <a:ext uri="{FF2B5EF4-FFF2-40B4-BE49-F238E27FC236}">
-                <a16:creationId xmlns:a16="http://schemas.microsoft.com/office/drawing/2014/main" id="{A694FDBF-6D32-D106-82AB-11C33D6FEF7D}"/>
+                <a16:creationId xmlns:a16="http://schemas.microsoft.com/office/drawing/2014/main" id="{A5ABF89C-616D-8BE4-F8D5-9081F329B142}"/>
               </a:ext>
             </a:extLst>
           </p:cNvPr>
@@ -3694,7 +3694,7 @@
           <p:cNvPr id="10" name="zone_content_title">
             <a:extLst>
               <a:ext uri="{FF2B5EF4-FFF2-40B4-BE49-F238E27FC236}">
-                <a16:creationId xmlns:a16="http://schemas.microsoft.com/office/drawing/2014/main" id="{FD63BC1D-B40D-3872-9BD8-70A71485108F}"/>
+                <a16:creationId xmlns:a16="http://schemas.microsoft.com/office/drawing/2014/main" id="{76ACBE98-9D74-F96E-FBB7-D693D73FA15F}"/>
               </a:ext>
             </a:extLst>
           </p:cNvPr>
@@ -3740,7 +3740,7 @@
           <p:cNvPr id="11" name="zone_content_subtitle">
             <a:extLst>
               <a:ext uri="{FF2B5EF4-FFF2-40B4-BE49-F238E27FC236}">
-                <a16:creationId xmlns:a16="http://schemas.microsoft.com/office/drawing/2014/main" id="{5C263190-19F6-FD00-D421-F392ACC34972}"/>
+                <a16:creationId xmlns:a16="http://schemas.microsoft.com/office/drawing/2014/main" id="{16F65B18-67B0-3457-53E2-FB4D6DAD11EE}"/>
               </a:ext>
             </a:extLst>
           </p:cNvPr>
@@ -3786,7 +3786,7 @@
           <p:cNvPr id="12" name="zone_reasoning_panel">
             <a:extLst>
               <a:ext uri="{FF2B5EF4-FFF2-40B4-BE49-F238E27FC236}">
-                <a16:creationId xmlns:a16="http://schemas.microsoft.com/office/drawing/2014/main" id="{CBACF3A7-A37B-CEE0-F0B6-237697977DEC}"/>
+                <a16:creationId xmlns:a16="http://schemas.microsoft.com/office/drawing/2014/main" id="{128B5867-FC85-F3FA-41E7-B69131F4E153}"/>
               </a:ext>
             </a:extLst>
           </p:cNvPr>
@@ -3847,7 +3847,7 @@
           <p:cNvPr id="13" name="zone_reasoning_title">
             <a:extLst>
               <a:ext uri="{FF2B5EF4-FFF2-40B4-BE49-F238E27FC236}">
-                <a16:creationId xmlns:a16="http://schemas.microsoft.com/office/drawing/2014/main" id="{F7D9427E-7F6F-14EB-E9E5-47FE1ABCE86D}"/>
+                <a16:creationId xmlns:a16="http://schemas.microsoft.com/office/drawing/2014/main" id="{A8B1091A-DD66-FCAB-1975-4F2199A6EC90}"/>
               </a:ext>
             </a:extLst>
           </p:cNvPr>
@@ -3893,7 +3893,7 @@
           <p:cNvPr id="14" name="zone_reasoning_subtitle">
             <a:extLst>
               <a:ext uri="{FF2B5EF4-FFF2-40B4-BE49-F238E27FC236}">
-                <a16:creationId xmlns:a16="http://schemas.microsoft.com/office/drawing/2014/main" id="{66C5D5E4-5852-CBF7-18E5-2A22BB20DF0C}"/>
+                <a16:creationId xmlns:a16="http://schemas.microsoft.com/office/drawing/2014/main" id="{D79D12BD-817A-05E4-3907-77BCD3286116}"/>
               </a:ext>
             </a:extLst>
           </p:cNvPr>
@@ -3939,7 +3939,7 @@
           <p:cNvPr id="15" name="zone_rules_panel">
             <a:extLst>
               <a:ext uri="{FF2B5EF4-FFF2-40B4-BE49-F238E27FC236}">
-                <a16:creationId xmlns:a16="http://schemas.microsoft.com/office/drawing/2014/main" id="{3B17F8EB-CFAC-5805-47FF-9932054B5A99}"/>
+                <a16:creationId xmlns:a16="http://schemas.microsoft.com/office/drawing/2014/main" id="{4660DD83-1533-8400-D021-0D02CC9D0F56}"/>
               </a:ext>
             </a:extLst>
           </p:cNvPr>
@@ -4000,7 +4000,7 @@
           <p:cNvPr id="16" name="zone_rules_title">
             <a:extLst>
               <a:ext uri="{FF2B5EF4-FFF2-40B4-BE49-F238E27FC236}">
-                <a16:creationId xmlns:a16="http://schemas.microsoft.com/office/drawing/2014/main" id="{B16ACC0C-78DB-8D8E-0924-8E6F1057EDD2}"/>
+                <a16:creationId xmlns:a16="http://schemas.microsoft.com/office/drawing/2014/main" id="{1B592876-AA67-1867-D43E-08FEFE55A467}"/>
               </a:ext>
             </a:extLst>
           </p:cNvPr>
@@ -4046,7 +4046,7 @@
           <p:cNvPr id="17" name="zone_rules_subtitle">
             <a:extLst>
               <a:ext uri="{FF2B5EF4-FFF2-40B4-BE49-F238E27FC236}">
-                <a16:creationId xmlns:a16="http://schemas.microsoft.com/office/drawing/2014/main" id="{0F7AFC3A-9BE2-1F81-F4EF-A662E5DBD3D1}"/>
+                <a16:creationId xmlns:a16="http://schemas.microsoft.com/office/drawing/2014/main" id="{D7B798C3-B541-DE69-7FFF-E6E971913CDA}"/>
               </a:ext>
             </a:extLst>
           </p:cNvPr>
@@ -4092,7 +4092,7 @@
           <p:cNvPr id="18" name="zone_outputs_panel">
             <a:extLst>
               <a:ext uri="{FF2B5EF4-FFF2-40B4-BE49-F238E27FC236}">
-                <a16:creationId xmlns:a16="http://schemas.microsoft.com/office/drawing/2014/main" id="{D36EA134-7663-5B8D-3D0E-21B504F44DEE}"/>
+                <a16:creationId xmlns:a16="http://schemas.microsoft.com/office/drawing/2014/main" id="{ED146A82-5F13-E856-1EE1-AE219436F66F}"/>
               </a:ext>
             </a:extLst>
           </p:cNvPr>
@@ -4153,7 +4153,7 @@
           <p:cNvPr id="19" name="zone_outputs_title">
             <a:extLst>
               <a:ext uri="{FF2B5EF4-FFF2-40B4-BE49-F238E27FC236}">
-                <a16:creationId xmlns:a16="http://schemas.microsoft.com/office/drawing/2014/main" id="{B8396C2A-3BCA-5659-AC42-6E7E5EA71741}"/>
+                <a16:creationId xmlns:a16="http://schemas.microsoft.com/office/drawing/2014/main" id="{249453AB-35BF-F9AD-ED3A-5219F69D9403}"/>
               </a:ext>
             </a:extLst>
           </p:cNvPr>
@@ -4199,7 +4199,7 @@
           <p:cNvPr id="20" name="zone_outputs_subtitle">
             <a:extLst>
               <a:ext uri="{FF2B5EF4-FFF2-40B4-BE49-F238E27FC236}">
-                <a16:creationId xmlns:a16="http://schemas.microsoft.com/office/drawing/2014/main" id="{FC191FE8-A0FA-897A-DCA3-712BB09219C4}"/>
+                <a16:creationId xmlns:a16="http://schemas.microsoft.com/office/drawing/2014/main" id="{C3D5FA31-F040-A975-EAE4-69FF04B9FFC3}"/>
               </a:ext>
             </a:extLst>
           </p:cNvPr>
@@ -4245,7 +4245,7 @@
           <p:cNvPr id="21" name="main_start_markdown">
             <a:extLst>
               <a:ext uri="{FF2B5EF4-FFF2-40B4-BE49-F238E27FC236}">
-                <a16:creationId xmlns:a16="http://schemas.microsoft.com/office/drawing/2014/main" id="{0A75AFE4-6342-31FA-1D8A-B11F44716402}"/>
+                <a16:creationId xmlns:a16="http://schemas.microsoft.com/office/drawing/2014/main" id="{1A011C61-D85D-8DD5-B22B-02873B640FBA}"/>
               </a:ext>
             </a:extLst>
           </p:cNvPr>
@@ -4288,7 +4288,7 @@
           <p:cNvPr id="22" name="main_markdown_splitter">
             <a:extLst>
               <a:ext uri="{FF2B5EF4-FFF2-40B4-BE49-F238E27FC236}">
-                <a16:creationId xmlns:a16="http://schemas.microsoft.com/office/drawing/2014/main" id="{6039A92C-D677-6646-5506-51DA0D56E9C3}"/>
+                <a16:creationId xmlns:a16="http://schemas.microsoft.com/office/drawing/2014/main" id="{DC1D39C0-F881-7E9F-E10E-04B8226693A9}"/>
               </a:ext>
             </a:extLst>
           </p:cNvPr>
@@ -4331,7 +4331,7 @@
           <p:cNvPr id="23" name="main_splitter_ir_seg_1">
             <a:extLst>
               <a:ext uri="{FF2B5EF4-FFF2-40B4-BE49-F238E27FC236}">
-                <a16:creationId xmlns:a16="http://schemas.microsoft.com/office/drawing/2014/main" id="{0BCB1058-A20F-97A6-E48D-46BD6496D922}"/>
+                <a16:creationId xmlns:a16="http://schemas.microsoft.com/office/drawing/2014/main" id="{4349E39C-AA12-9996-71CE-D7EDF00A4128}"/>
               </a:ext>
             </a:extLst>
           </p:cNvPr>
@@ -4374,7 +4374,7 @@
           <p:cNvPr id="24" name="main_splitter_ir_seg_2">
             <a:extLst>
               <a:ext uri="{FF2B5EF4-FFF2-40B4-BE49-F238E27FC236}">
-                <a16:creationId xmlns:a16="http://schemas.microsoft.com/office/drawing/2014/main" id="{E5173165-BFF1-D1C6-E75C-5F3D10B69874}"/>
+                <a16:creationId xmlns:a16="http://schemas.microsoft.com/office/drawing/2014/main" id="{2E050902-2316-CFEE-7887-D543DB947467}"/>
               </a:ext>
             </a:extLst>
           </p:cNvPr>
@@ -4417,7 +4417,7 @@
           <p:cNvPr id="25" name="main_splitter_ir_seg_3">
             <a:extLst>
               <a:ext uri="{FF2B5EF4-FFF2-40B4-BE49-F238E27FC236}">
-                <a16:creationId xmlns:a16="http://schemas.microsoft.com/office/drawing/2014/main" id="{1870CB06-6A8F-A25C-5330-3D93141F3F87}"/>
+                <a16:creationId xmlns:a16="http://schemas.microsoft.com/office/drawing/2014/main" id="{8B26B471-AF31-6DCA-B33D-7D8CEF3C5208}"/>
               </a:ext>
             </a:extLst>
           </p:cNvPr>
@@ -4460,7 +4460,7 @@
           <p:cNvPr id="26" name="hint_ir_reasoning">
             <a:extLst>
               <a:ext uri="{FF2B5EF4-FFF2-40B4-BE49-F238E27FC236}">
-                <a16:creationId xmlns:a16="http://schemas.microsoft.com/office/drawing/2014/main" id="{B55C0045-491E-D79E-E4CA-F7346347A1FA}"/>
+                <a16:creationId xmlns:a16="http://schemas.microsoft.com/office/drawing/2014/main" id="{733D694C-C0B1-DDA5-185C-078303850C63}"/>
               </a:ext>
             </a:extLst>
           </p:cNvPr>
@@ -4504,7 +4504,7 @@
           <p:cNvPr id="27" name="main_ir_rules">
             <a:extLst>
               <a:ext uri="{FF2B5EF4-FFF2-40B4-BE49-F238E27FC236}">
-                <a16:creationId xmlns:a16="http://schemas.microsoft.com/office/drawing/2014/main" id="{C6E3D79A-FC31-A0F1-B27B-90B94AAE47DA}"/>
+                <a16:creationId xmlns:a16="http://schemas.microsoft.com/office/drawing/2014/main" id="{01C37751-0B8E-65D7-69C9-810F18BC4004}"/>
               </a:ext>
             </a:extLst>
           </p:cNvPr>
@@ -4547,7 +4547,7 @@
           <p:cNvPr id="28" name="hint_reasoning_rules_seg_1">
             <a:extLst>
               <a:ext uri="{FF2B5EF4-FFF2-40B4-BE49-F238E27FC236}">
-                <a16:creationId xmlns:a16="http://schemas.microsoft.com/office/drawing/2014/main" id="{77699F3C-377F-34FB-09B0-91FD3BB69F41}"/>
+                <a16:creationId xmlns:a16="http://schemas.microsoft.com/office/drawing/2014/main" id="{F386C96A-C79E-5B02-7ED0-0D311DB77751}"/>
               </a:ext>
             </a:extLst>
           </p:cNvPr>
@@ -4591,7 +4591,7 @@
           <p:cNvPr id="29" name="hint_reasoning_rules_seg_2">
             <a:extLst>
               <a:ext uri="{FF2B5EF4-FFF2-40B4-BE49-F238E27FC236}">
-                <a16:creationId xmlns:a16="http://schemas.microsoft.com/office/drawing/2014/main" id="{8820E3D2-975D-5921-29D4-9E943063937E}"/>
+                <a16:creationId xmlns:a16="http://schemas.microsoft.com/office/drawing/2014/main" id="{3A709624-902B-4B52-AFFB-7885D2EAC28E}"/>
               </a:ext>
             </a:extLst>
           </p:cNvPr>
@@ -4635,7 +4635,7 @@
           <p:cNvPr id="30" name="hint_reasoning_rules_seg_3">
             <a:extLst>
               <a:ext uri="{FF2B5EF4-FFF2-40B4-BE49-F238E27FC236}">
-                <a16:creationId xmlns:a16="http://schemas.microsoft.com/office/drawing/2014/main" id="{C77A6AE7-C66C-1BD8-D670-BD3B367CABFE}"/>
+                <a16:creationId xmlns:a16="http://schemas.microsoft.com/office/drawing/2014/main" id="{2C0010AD-A453-8455-9EAF-D9DCC1DBD218}"/>
               </a:ext>
             </a:extLst>
           </p:cNvPr>
@@ -4679,7 +4679,7 @@
           <p:cNvPr id="31" name="rule_features_recipes">
             <a:extLst>
               <a:ext uri="{FF2B5EF4-FFF2-40B4-BE49-F238E27FC236}">
-                <a16:creationId xmlns:a16="http://schemas.microsoft.com/office/drawing/2014/main" id="{06A9AFB4-1C56-D29A-AA56-8C6B411EF5DB}"/>
+                <a16:creationId xmlns:a16="http://schemas.microsoft.com/office/drawing/2014/main" id="{659B8906-8C5A-2BB6-3E46-9C5813ACD291}"/>
               </a:ext>
             </a:extLst>
           </p:cNvPr>
@@ -4722,7 +4722,7 @@
           <p:cNvPr id="32" name="rule_recipes_theme">
             <a:extLst>
               <a:ext uri="{FF2B5EF4-FFF2-40B4-BE49-F238E27FC236}">
-                <a16:creationId xmlns:a16="http://schemas.microsoft.com/office/drawing/2014/main" id="{E2D95235-70F7-D376-44ED-DABD9616DB95}"/>
+                <a16:creationId xmlns:a16="http://schemas.microsoft.com/office/drawing/2014/main" id="{1EC8B5FE-F885-089B-01B1-6B97D44C7E66}"/>
               </a:ext>
             </a:extLst>
           </p:cNvPr>
@@ -4765,7 +4765,7 @@
           <p:cNvPr id="33" name="rule_features_compose">
             <a:extLst>
               <a:ext uri="{FF2B5EF4-FFF2-40B4-BE49-F238E27FC236}">
-                <a16:creationId xmlns:a16="http://schemas.microsoft.com/office/drawing/2014/main" id="{CFC060DD-5A4A-D7C0-584A-6FF4B1C6A701}"/>
+                <a16:creationId xmlns:a16="http://schemas.microsoft.com/office/drawing/2014/main" id="{471AF0AE-211F-251E-C9DF-23F5C2C8421B}"/>
               </a:ext>
             </a:extLst>
           </p:cNvPr>
@@ -4808,7 +4808,7 @@
           <p:cNvPr id="34" name="rule_recipes_objects">
             <a:extLst>
               <a:ext uri="{FF2B5EF4-FFF2-40B4-BE49-F238E27FC236}">
-                <a16:creationId xmlns:a16="http://schemas.microsoft.com/office/drawing/2014/main" id="{F248C9AB-A8D9-387F-1A17-22B0407985B7}"/>
+                <a16:creationId xmlns:a16="http://schemas.microsoft.com/office/drawing/2014/main" id="{DC729138-BDF9-5B61-A754-8A03F9BBA363}"/>
               </a:ext>
             </a:extLst>
           </p:cNvPr>
@@ -4851,7 +4851,7 @@
           <p:cNvPr id="35" name="rule_theme_decorate">
             <a:extLst>
               <a:ext uri="{FF2B5EF4-FFF2-40B4-BE49-F238E27FC236}">
-                <a16:creationId xmlns:a16="http://schemas.microsoft.com/office/drawing/2014/main" id="{F3F90A5E-0981-4342-6F32-AF5C1AF76EAB}"/>
+                <a16:creationId xmlns:a16="http://schemas.microsoft.com/office/drawing/2014/main" id="{3BC0AC1C-0A22-923D-BBCA-6D8B63442E35}"/>
               </a:ext>
             </a:extLst>
           </p:cNvPr>
@@ -4894,7 +4894,7 @@
           <p:cNvPr id="36" name="rule_compose_objects">
             <a:extLst>
               <a:ext uri="{FF2B5EF4-FFF2-40B4-BE49-F238E27FC236}">
-                <a16:creationId xmlns:a16="http://schemas.microsoft.com/office/drawing/2014/main" id="{FADC1D49-3ABE-63E0-4C8F-90B8E542D5F7}"/>
+                <a16:creationId xmlns:a16="http://schemas.microsoft.com/office/drawing/2014/main" id="{DD921C2F-FFBB-F54D-6DA4-E75E34CD41C4}"/>
               </a:ext>
             </a:extLst>
           </p:cNvPr>
@@ -4937,7 +4937,7 @@
           <p:cNvPr id="37" name="rule_objects_decorate">
             <a:extLst>
               <a:ext uri="{FF2B5EF4-FFF2-40B4-BE49-F238E27FC236}">
-                <a16:creationId xmlns:a16="http://schemas.microsoft.com/office/drawing/2014/main" id="{104D19E9-4F4C-7276-C9AD-00AF9D018795}"/>
+                <a16:creationId xmlns:a16="http://schemas.microsoft.com/office/drawing/2014/main" id="{2C3BA8C9-0487-5384-FCE8-F6AA455AF856}"/>
               </a:ext>
             </a:extLst>
           </p:cNvPr>
@@ -4980,7 +4980,7 @@
           <p:cNvPr id="38" name="main_rules_styled_ir">
             <a:extLst>
               <a:ext uri="{FF2B5EF4-FFF2-40B4-BE49-F238E27FC236}">
-                <a16:creationId xmlns:a16="http://schemas.microsoft.com/office/drawing/2014/main" id="{55BAD3EC-C119-D3FD-FBE7-50360CA66698}"/>
+                <a16:creationId xmlns:a16="http://schemas.microsoft.com/office/drawing/2014/main" id="{79DACCD7-6FF9-B5ED-A909-D2420147FC70}"/>
               </a:ext>
             </a:extLst>
           </p:cNvPr>
@@ -5023,7 +5023,7 @@
           <p:cNvPr id="39" name="main_styled_renderers">
             <a:extLst>
               <a:ext uri="{FF2B5EF4-FFF2-40B4-BE49-F238E27FC236}">
-                <a16:creationId xmlns:a16="http://schemas.microsoft.com/office/drawing/2014/main" id="{E027DB1D-51AE-95F9-9A42-913EEB67E45C}"/>
+                <a16:creationId xmlns:a16="http://schemas.microsoft.com/office/drawing/2014/main" id="{EBD95183-F6C7-57C1-DD98-7F741A8A8B19}"/>
               </a:ext>
             </a:extLst>
           </p:cNvPr>
@@ -5066,7 +5066,7 @@
           <p:cNvPr id="40" name="validation_loop">
             <a:extLst>
               <a:ext uri="{FF2B5EF4-FFF2-40B4-BE49-F238E27FC236}">
-                <a16:creationId xmlns:a16="http://schemas.microsoft.com/office/drawing/2014/main" id="{E41FEA22-15F0-2F31-98D8-01269F0DB5E9}"/>
+                <a16:creationId xmlns:a16="http://schemas.microsoft.com/office/drawing/2014/main" id="{339D8669-6201-F50D-1D78-1F022B7E259F}"/>
               </a:ext>
             </a:extLst>
           </p:cNvPr>
@@ -5109,7 +5109,7 @@
           <p:cNvPr id="41" name="source_chip">
             <a:extLst>
               <a:ext uri="{FF2B5EF4-FFF2-40B4-BE49-F238E27FC236}">
-                <a16:creationId xmlns:a16="http://schemas.microsoft.com/office/drawing/2014/main" id="{77C50564-8F29-955A-3954-BE072141CD8C}"/>
+                <a16:creationId xmlns:a16="http://schemas.microsoft.com/office/drawing/2014/main" id="{1F87E298-BF1A-B085-6451-D8DFA15590E2}"/>
               </a:ext>
             </a:extLst>
           </p:cNvPr>
@@ -5170,7 +5170,7 @@
           <p:cNvPr id="42" name="source_chip_text">
             <a:extLst>
               <a:ext uri="{FF2B5EF4-FFF2-40B4-BE49-F238E27FC236}">
-                <a16:creationId xmlns:a16="http://schemas.microsoft.com/office/drawing/2014/main" id="{56270CA3-2411-B33C-997D-E0954BE0C36B}"/>
+                <a16:creationId xmlns:a16="http://schemas.microsoft.com/office/drawing/2014/main" id="{03CCB476-00A1-768B-1BAE-0426998558AB}"/>
               </a:ext>
             </a:extLst>
           </p:cNvPr>
@@ -5217,7 +5217,7 @@
           <p:cNvPr id="43" name="markdown_card">
             <a:extLst>
               <a:ext uri="{FF2B5EF4-FFF2-40B4-BE49-F238E27FC236}">
-                <a16:creationId xmlns:a16="http://schemas.microsoft.com/office/drawing/2014/main" id="{03C22E06-7E5F-083F-69CE-5F1A17BE0C66}"/>
+                <a16:creationId xmlns:a16="http://schemas.microsoft.com/office/drawing/2014/main" id="{53419BC8-D05D-5387-A8F1-512442784D22}"/>
               </a:ext>
             </a:extLst>
           </p:cNvPr>
@@ -5278,7 +5278,7 @@
           <p:cNvPr id="44" name="markdown_icon_dot">
             <a:extLst>
               <a:ext uri="{FF2B5EF4-FFF2-40B4-BE49-F238E27FC236}">
-                <a16:creationId xmlns:a16="http://schemas.microsoft.com/office/drawing/2014/main" id="{F00FFA6C-2640-0042-109D-FF506CD8CCD7}"/>
+                <a16:creationId xmlns:a16="http://schemas.microsoft.com/office/drawing/2014/main" id="{ADF07689-1447-22BF-25D2-D6E2E45CC2E7}"/>
               </a:ext>
             </a:extLst>
           </p:cNvPr>
@@ -5332,7 +5332,7 @@
           <p:cNvPr id="45" name="markdown_icon_label">
             <a:extLst>
               <a:ext uri="{FF2B5EF4-FFF2-40B4-BE49-F238E27FC236}">
-                <a16:creationId xmlns:a16="http://schemas.microsoft.com/office/drawing/2014/main" id="{ED936A40-13F2-D21A-AE6D-BE7F0EC5941F}"/>
+                <a16:creationId xmlns:a16="http://schemas.microsoft.com/office/drawing/2014/main" id="{7E84E566-A6CA-DD9C-51D4-D0BFD1001FC5}"/>
               </a:ext>
             </a:extLst>
           </p:cNvPr>
@@ -5379,7 +5379,7 @@
           <p:cNvPr id="46" name="markdown_title">
             <a:extLst>
               <a:ext uri="{FF2B5EF4-FFF2-40B4-BE49-F238E27FC236}">
-                <a16:creationId xmlns:a16="http://schemas.microsoft.com/office/drawing/2014/main" id="{B88FDB95-15E5-EABE-EA1C-B7CB0A8BCA86}"/>
+                <a16:creationId xmlns:a16="http://schemas.microsoft.com/office/drawing/2014/main" id="{55223CE8-30FD-1EFB-B5D7-487D779C9E98}"/>
               </a:ext>
             </a:extLst>
           </p:cNvPr>
@@ -5425,7 +5425,7 @@
           <p:cNvPr id="47" name="markdown_line_0">
             <a:extLst>
               <a:ext uri="{FF2B5EF4-FFF2-40B4-BE49-F238E27FC236}">
-                <a16:creationId xmlns:a16="http://schemas.microsoft.com/office/drawing/2014/main" id="{7A27354E-2EFD-BC32-CB52-9111EF3D054A}"/>
+                <a16:creationId xmlns:a16="http://schemas.microsoft.com/office/drawing/2014/main" id="{6FD56F65-5460-BFC7-CCF7-0DBCF6040887}"/>
               </a:ext>
             </a:extLst>
           </p:cNvPr>
@@ -5471,7 +5471,7 @@
           <p:cNvPr id="48" name="markdown_line_1">
             <a:extLst>
               <a:ext uri="{FF2B5EF4-FFF2-40B4-BE49-F238E27FC236}">
-                <a16:creationId xmlns:a16="http://schemas.microsoft.com/office/drawing/2014/main" id="{54DCCA3F-C33C-5350-2E1D-A58D3EB0B794}"/>
+                <a16:creationId xmlns:a16="http://schemas.microsoft.com/office/drawing/2014/main" id="{9BD9F5DE-ABDC-4128-FEEC-5075F553FE89}"/>
               </a:ext>
             </a:extLst>
           </p:cNvPr>
@@ -5517,7 +5517,7 @@
           <p:cNvPr id="49" name="splitter_card">
             <a:extLst>
               <a:ext uri="{FF2B5EF4-FFF2-40B4-BE49-F238E27FC236}">
-                <a16:creationId xmlns:a16="http://schemas.microsoft.com/office/drawing/2014/main" id="{7734659F-E9E8-299A-4776-AEEB07A113CB}"/>
+                <a16:creationId xmlns:a16="http://schemas.microsoft.com/office/drawing/2014/main" id="{6E30F664-A884-FFFE-13F1-DA71943C21C1}"/>
               </a:ext>
             </a:extLst>
           </p:cNvPr>
@@ -5578,7 +5578,7 @@
           <p:cNvPr id="50" name="splitter_icon_dot">
             <a:extLst>
               <a:ext uri="{FF2B5EF4-FFF2-40B4-BE49-F238E27FC236}">
-                <a16:creationId xmlns:a16="http://schemas.microsoft.com/office/drawing/2014/main" id="{7C19050A-58D3-9B6A-F3C6-B23610D2F2EF}"/>
+                <a16:creationId xmlns:a16="http://schemas.microsoft.com/office/drawing/2014/main" id="{8F8299AA-D5CF-97C2-4343-8B4950235101}"/>
               </a:ext>
             </a:extLst>
           </p:cNvPr>
@@ -5632,7 +5632,7 @@
           <p:cNvPr id="51" name="splitter_icon_label">
             <a:extLst>
               <a:ext uri="{FF2B5EF4-FFF2-40B4-BE49-F238E27FC236}">
-                <a16:creationId xmlns:a16="http://schemas.microsoft.com/office/drawing/2014/main" id="{564C25E1-5F34-3A11-9ECD-BBF4828485F2}"/>
+                <a16:creationId xmlns:a16="http://schemas.microsoft.com/office/drawing/2014/main" id="{5D345BF1-9C1D-B62E-693E-D71A6ACB0AD3}"/>
               </a:ext>
             </a:extLst>
           </p:cNvPr>
@@ -5679,7 +5679,7 @@
           <p:cNvPr id="52" name="splitter_title">
             <a:extLst>
               <a:ext uri="{FF2B5EF4-FFF2-40B4-BE49-F238E27FC236}">
-                <a16:creationId xmlns:a16="http://schemas.microsoft.com/office/drawing/2014/main" id="{1F6908D0-CCB5-0C70-0F1A-C294DCAB46F6}"/>
+                <a16:creationId xmlns:a16="http://schemas.microsoft.com/office/drawing/2014/main" id="{8517CF6C-9484-9D40-27A9-A27F3E341C3A}"/>
               </a:ext>
             </a:extLst>
           </p:cNvPr>
@@ -5725,7 +5725,7 @@
           <p:cNvPr id="53" name="splitter_line_0">
             <a:extLst>
               <a:ext uri="{FF2B5EF4-FFF2-40B4-BE49-F238E27FC236}">
-                <a16:creationId xmlns:a16="http://schemas.microsoft.com/office/drawing/2014/main" id="{5564F389-089F-803F-8030-F74B1B5822E9}"/>
+                <a16:creationId xmlns:a16="http://schemas.microsoft.com/office/drawing/2014/main" id="{B978DCBF-5491-DB81-3719-7ADBFA73E45C}"/>
               </a:ext>
             </a:extLst>
           </p:cNvPr>
@@ -5771,7 +5771,7 @@
           <p:cNvPr id="54" name="splitter_line_1">
             <a:extLst>
               <a:ext uri="{FF2B5EF4-FFF2-40B4-BE49-F238E27FC236}">
-                <a16:creationId xmlns:a16="http://schemas.microsoft.com/office/drawing/2014/main" id="{EFD63F27-2A05-A9CD-D8E9-AD97B8F50760}"/>
+                <a16:creationId xmlns:a16="http://schemas.microsoft.com/office/drawing/2014/main" id="{991D64B9-5766-060C-AEBC-80D840716FC2}"/>
               </a:ext>
             </a:extLst>
           </p:cNvPr>
@@ -5817,7 +5817,7 @@
           <p:cNvPr id="55" name="ir_core_card">
             <a:extLst>
               <a:ext uri="{FF2B5EF4-FFF2-40B4-BE49-F238E27FC236}">
-                <a16:creationId xmlns:a16="http://schemas.microsoft.com/office/drawing/2014/main" id="{70F9E6F7-9F34-5C5D-46B8-BFC59C4D38D3}"/>
+                <a16:creationId xmlns:a16="http://schemas.microsoft.com/office/drawing/2014/main" id="{938C562C-1E87-EE57-3032-51BE976AAE01}"/>
               </a:ext>
             </a:extLst>
           </p:cNvPr>
@@ -5878,7 +5878,7 @@
           <p:cNvPr id="56" name="ir_core_icon_dot">
             <a:extLst>
               <a:ext uri="{FF2B5EF4-FFF2-40B4-BE49-F238E27FC236}">
-                <a16:creationId xmlns:a16="http://schemas.microsoft.com/office/drawing/2014/main" id="{90071460-A1C1-FC3C-3202-3665C5123E3B}"/>
+                <a16:creationId xmlns:a16="http://schemas.microsoft.com/office/drawing/2014/main" id="{12CD192A-215A-6DCC-A3FD-D039BDF9ED14}"/>
               </a:ext>
             </a:extLst>
           </p:cNvPr>
@@ -5932,7 +5932,7 @@
           <p:cNvPr id="57" name="ir_core_icon_label">
             <a:extLst>
               <a:ext uri="{FF2B5EF4-FFF2-40B4-BE49-F238E27FC236}">
-                <a16:creationId xmlns:a16="http://schemas.microsoft.com/office/drawing/2014/main" id="{83681781-CCC4-E137-7927-0D90A09F0B77}"/>
+                <a16:creationId xmlns:a16="http://schemas.microsoft.com/office/drawing/2014/main" id="{990EFA94-FF04-9C99-095E-25499882EA2E}"/>
               </a:ext>
             </a:extLst>
           </p:cNvPr>
@@ -5979,7 +5979,7 @@
           <p:cNvPr id="58" name="ir_core_title">
             <a:extLst>
               <a:ext uri="{FF2B5EF4-FFF2-40B4-BE49-F238E27FC236}">
-                <a16:creationId xmlns:a16="http://schemas.microsoft.com/office/drawing/2014/main" id="{C5AC8BF6-A66C-8E54-D9BE-5969E358E6C5}"/>
+                <a16:creationId xmlns:a16="http://schemas.microsoft.com/office/drawing/2014/main" id="{6317F0EE-287D-CD63-7007-C3837ED01ABD}"/>
               </a:ext>
             </a:extLst>
           </p:cNvPr>
@@ -6025,7 +6025,7 @@
           <p:cNvPr id="59" name="ir_core_line_0">
             <a:extLst>
               <a:ext uri="{FF2B5EF4-FFF2-40B4-BE49-F238E27FC236}">
-                <a16:creationId xmlns:a16="http://schemas.microsoft.com/office/drawing/2014/main" id="{15E6B9D2-9606-278A-3B68-EB3247D6F199}"/>
+                <a16:creationId xmlns:a16="http://schemas.microsoft.com/office/drawing/2014/main" id="{533DCB95-FA31-8B52-5B01-AF82BA237758}"/>
               </a:ext>
             </a:extLst>
           </p:cNvPr>
@@ -6071,7 +6071,7 @@
           <p:cNvPr id="60" name="ir_core_line_1">
             <a:extLst>
               <a:ext uri="{FF2B5EF4-FFF2-40B4-BE49-F238E27FC236}">
-                <a16:creationId xmlns:a16="http://schemas.microsoft.com/office/drawing/2014/main" id="{C6A4E2FC-49EE-ACB8-FEB7-AE25BCD276B7}"/>
+                <a16:creationId xmlns:a16="http://schemas.microsoft.com/office/drawing/2014/main" id="{3DC8834C-EA10-763C-1475-0B39362734E8}"/>
               </a:ext>
             </a:extLst>
           </p:cNvPr>
@@ -6117,7 +6117,7 @@
           <p:cNvPr id="61" name="reasoning_card">
             <a:extLst>
               <a:ext uri="{FF2B5EF4-FFF2-40B4-BE49-F238E27FC236}">
-                <a16:creationId xmlns:a16="http://schemas.microsoft.com/office/drawing/2014/main" id="{3FB809A1-95C4-5DE9-34EA-1A5D4D723D96}"/>
+                <a16:creationId xmlns:a16="http://schemas.microsoft.com/office/drawing/2014/main" id="{7CFAB46E-3058-05E6-1952-BA7397015429}"/>
               </a:ext>
             </a:extLst>
           </p:cNvPr>
@@ -6178,7 +6178,7 @@
           <p:cNvPr id="62" name="reasoning_icon_dot">
             <a:extLst>
               <a:ext uri="{FF2B5EF4-FFF2-40B4-BE49-F238E27FC236}">
-                <a16:creationId xmlns:a16="http://schemas.microsoft.com/office/drawing/2014/main" id="{A12270CD-B82A-BC15-A003-D5E3EB9537EF}"/>
+                <a16:creationId xmlns:a16="http://schemas.microsoft.com/office/drawing/2014/main" id="{E0BC856B-E1E5-828E-BAE0-43426FDB022F}"/>
               </a:ext>
             </a:extLst>
           </p:cNvPr>
@@ -6232,7 +6232,7 @@
           <p:cNvPr id="63" name="reasoning_icon_label">
             <a:extLst>
               <a:ext uri="{FF2B5EF4-FFF2-40B4-BE49-F238E27FC236}">
-                <a16:creationId xmlns:a16="http://schemas.microsoft.com/office/drawing/2014/main" id="{85BCE0BA-276D-9392-B831-1E200BCADD54}"/>
+                <a16:creationId xmlns:a16="http://schemas.microsoft.com/office/drawing/2014/main" id="{EC0D3B44-2886-B359-B2F3-85C50746D13E}"/>
               </a:ext>
             </a:extLst>
           </p:cNvPr>
@@ -6279,7 +6279,7 @@
           <p:cNvPr id="64" name="reasoning_title">
             <a:extLst>
               <a:ext uri="{FF2B5EF4-FFF2-40B4-BE49-F238E27FC236}">
-                <a16:creationId xmlns:a16="http://schemas.microsoft.com/office/drawing/2014/main" id="{79A58FB8-56C6-B61D-9657-5A8B6E27BBD1}"/>
+                <a16:creationId xmlns:a16="http://schemas.microsoft.com/office/drawing/2014/main" id="{2D57FABE-16B2-1E3B-2635-E0E32D2B940F}"/>
               </a:ext>
             </a:extLst>
           </p:cNvPr>
@@ -6325,7 +6325,7 @@
           <p:cNvPr id="65" name="reasoning_line_0">
             <a:extLst>
               <a:ext uri="{FF2B5EF4-FFF2-40B4-BE49-F238E27FC236}">
-                <a16:creationId xmlns:a16="http://schemas.microsoft.com/office/drawing/2014/main" id="{DC0D488D-2A0C-76B1-E365-304CC14C531E}"/>
+                <a16:creationId xmlns:a16="http://schemas.microsoft.com/office/drawing/2014/main" id="{EDA2DA6B-8F0E-25A3-B81A-37C57BBC06AF}"/>
               </a:ext>
             </a:extLst>
           </p:cNvPr>
@@ -6371,7 +6371,7 @@
           <p:cNvPr id="66" name="reasoning_guard">
             <a:extLst>
               <a:ext uri="{FF2B5EF4-FFF2-40B4-BE49-F238E27FC236}">
-                <a16:creationId xmlns:a16="http://schemas.microsoft.com/office/drawing/2014/main" id="{E50A6533-CDFF-8B05-1025-9D1FAFEDA61B}"/>
+                <a16:creationId xmlns:a16="http://schemas.microsoft.com/office/drawing/2014/main" id="{0776E943-6B06-1F98-4860-A1357F67F9D7}"/>
               </a:ext>
             </a:extLst>
           </p:cNvPr>
@@ -6432,7 +6432,7 @@
           <p:cNvPr id="67" name="reasoning_guard_text">
             <a:extLst>
               <a:ext uri="{FF2B5EF4-FFF2-40B4-BE49-F238E27FC236}">
-                <a16:creationId xmlns:a16="http://schemas.microsoft.com/office/drawing/2014/main" id="{F3D0DC19-9A7D-2613-AD8E-7AD2A126FA62}"/>
+                <a16:creationId xmlns:a16="http://schemas.microsoft.com/office/drawing/2014/main" id="{43A91A9A-BAA7-CE9C-F8E6-B0837B49D9C2}"/>
               </a:ext>
             </a:extLst>
           </p:cNvPr>
@@ -6479,7 +6479,7 @@
           <p:cNvPr id="68" name="reasoning_limit">
             <a:extLst>
               <a:ext uri="{FF2B5EF4-FFF2-40B4-BE49-F238E27FC236}">
-                <a16:creationId xmlns:a16="http://schemas.microsoft.com/office/drawing/2014/main" id="{0F29E3DA-9D15-7231-D321-81E3EC844108}"/>
+                <a16:creationId xmlns:a16="http://schemas.microsoft.com/office/drawing/2014/main" id="{5557A5EF-F500-CF7E-AF7A-813EB264E286}"/>
               </a:ext>
             </a:extLst>
           </p:cNvPr>
@@ -6525,7 +6525,7 @@
           <p:cNvPr id="69" name="rule_engine_card">
             <a:extLst>
               <a:ext uri="{FF2B5EF4-FFF2-40B4-BE49-F238E27FC236}">
-                <a16:creationId xmlns:a16="http://schemas.microsoft.com/office/drawing/2014/main" id="{273180A8-B68D-1930-EE12-3E5BC755A335}"/>
+                <a16:creationId xmlns:a16="http://schemas.microsoft.com/office/drawing/2014/main" id="{0FAE2522-2E30-6A29-7C31-5CAE1883B608}"/>
               </a:ext>
             </a:extLst>
           </p:cNvPr>
@@ -6586,7 +6586,7 @@
           <p:cNvPr id="70" name="rule_engine_title">
             <a:extLst>
               <a:ext uri="{FF2B5EF4-FFF2-40B4-BE49-F238E27FC236}">
-                <a16:creationId xmlns:a16="http://schemas.microsoft.com/office/drawing/2014/main" id="{6862EAA2-C372-6D23-FFA3-0B0D128D0454}"/>
+                <a16:creationId xmlns:a16="http://schemas.microsoft.com/office/drawing/2014/main" id="{CA7A1896-88F0-C948-8601-A81DDE7CF547}"/>
               </a:ext>
             </a:extLst>
           </p:cNvPr>
@@ -6632,7 +6632,7 @@
           <p:cNvPr id="71" name="rule_engine_body">
             <a:extLst>
               <a:ext uri="{FF2B5EF4-FFF2-40B4-BE49-F238E27FC236}">
-                <a16:creationId xmlns:a16="http://schemas.microsoft.com/office/drawing/2014/main" id="{C7A9C912-3721-0F67-4685-9E301D15268B}"/>
+                <a16:creationId xmlns:a16="http://schemas.microsoft.com/office/drawing/2014/main" id="{3A0B975F-FD5A-1869-A989-9F29E9C1970F}"/>
               </a:ext>
             </a:extLst>
           </p:cNvPr>
@@ -6678,7 +6678,7 @@
           <p:cNvPr id="72" name="features_card">
             <a:extLst>
               <a:ext uri="{FF2B5EF4-FFF2-40B4-BE49-F238E27FC236}">
-                <a16:creationId xmlns:a16="http://schemas.microsoft.com/office/drawing/2014/main" id="{3CFF6BBC-910F-D36E-A7CE-30F360F195E4}"/>
+                <a16:creationId xmlns:a16="http://schemas.microsoft.com/office/drawing/2014/main" id="{5044963E-2023-AB4A-2A66-20380EEB9466}"/>
               </a:ext>
             </a:extLst>
           </p:cNvPr>
@@ -6739,7 +6739,7 @@
           <p:cNvPr id="73" name="features_icon_dot">
             <a:extLst>
               <a:ext uri="{FF2B5EF4-FFF2-40B4-BE49-F238E27FC236}">
-                <a16:creationId xmlns:a16="http://schemas.microsoft.com/office/drawing/2014/main" id="{E84F0029-2F0E-8951-0230-DDF375C876FC}"/>
+                <a16:creationId xmlns:a16="http://schemas.microsoft.com/office/drawing/2014/main" id="{6034F9BC-76F6-7829-0F62-1E44DC38D173}"/>
               </a:ext>
             </a:extLst>
           </p:cNvPr>
@@ -6793,7 +6793,7 @@
           <p:cNvPr id="74" name="features_icon_label">
             <a:extLst>
               <a:ext uri="{FF2B5EF4-FFF2-40B4-BE49-F238E27FC236}">
-                <a16:creationId xmlns:a16="http://schemas.microsoft.com/office/drawing/2014/main" id="{14D91F07-0746-F7BB-4438-0753470E442D}"/>
+                <a16:creationId xmlns:a16="http://schemas.microsoft.com/office/drawing/2014/main" id="{A4931AE5-65D2-ED50-A225-90CB7FD51542}"/>
               </a:ext>
             </a:extLst>
           </p:cNvPr>
@@ -6840,7 +6840,7 @@
           <p:cNvPr id="75" name="features_title">
             <a:extLst>
               <a:ext uri="{FF2B5EF4-FFF2-40B4-BE49-F238E27FC236}">
-                <a16:creationId xmlns:a16="http://schemas.microsoft.com/office/drawing/2014/main" id="{F58938FC-7981-1E84-78F1-5B7E94AAAF85}"/>
+                <a16:creationId xmlns:a16="http://schemas.microsoft.com/office/drawing/2014/main" id="{FDF0E03F-ED45-4969-8AAF-A803BFFDAF21}"/>
               </a:ext>
             </a:extLst>
           </p:cNvPr>
@@ -6886,7 +6886,7 @@
           <p:cNvPr id="76" name="features_line_0">
             <a:extLst>
               <a:ext uri="{FF2B5EF4-FFF2-40B4-BE49-F238E27FC236}">
-                <a16:creationId xmlns:a16="http://schemas.microsoft.com/office/drawing/2014/main" id="{C8A30813-1313-8F94-4B65-4DC38DC07C3C}"/>
+                <a16:creationId xmlns:a16="http://schemas.microsoft.com/office/drawing/2014/main" id="{B539948D-B4E1-A0D8-9821-A811EADADBEB}"/>
               </a:ext>
             </a:extLst>
           </p:cNvPr>
@@ -6932,7 +6932,7 @@
           <p:cNvPr id="77" name="features_line_1">
             <a:extLst>
               <a:ext uri="{FF2B5EF4-FFF2-40B4-BE49-F238E27FC236}">
-                <a16:creationId xmlns:a16="http://schemas.microsoft.com/office/drawing/2014/main" id="{0908CAA1-6F1A-EA4D-2CAD-31221A1C59B9}"/>
+                <a16:creationId xmlns:a16="http://schemas.microsoft.com/office/drawing/2014/main" id="{20B7B708-1E69-3EEF-7355-3259C85CC305}"/>
               </a:ext>
             </a:extLst>
           </p:cNvPr>
@@ -6978,7 +6978,7 @@
           <p:cNvPr id="78" name="recipes_card">
             <a:extLst>
               <a:ext uri="{FF2B5EF4-FFF2-40B4-BE49-F238E27FC236}">
-                <a16:creationId xmlns:a16="http://schemas.microsoft.com/office/drawing/2014/main" id="{122BAEF6-7867-AE40-D9C6-BB23891C2C9D}"/>
+                <a16:creationId xmlns:a16="http://schemas.microsoft.com/office/drawing/2014/main" id="{895E0EA3-3652-7C5F-33BA-4A33ADF07977}"/>
               </a:ext>
             </a:extLst>
           </p:cNvPr>
@@ -7039,7 +7039,7 @@
           <p:cNvPr id="79" name="recipes_icon_dot">
             <a:extLst>
               <a:ext uri="{FF2B5EF4-FFF2-40B4-BE49-F238E27FC236}">
-                <a16:creationId xmlns:a16="http://schemas.microsoft.com/office/drawing/2014/main" id="{4FFDA542-5B7E-7984-95EB-4B95F1B91F52}"/>
+                <a16:creationId xmlns:a16="http://schemas.microsoft.com/office/drawing/2014/main" id="{3B29158A-9D3A-1C10-542B-4FFAAA8C7B9D}"/>
               </a:ext>
             </a:extLst>
           </p:cNvPr>
@@ -7093,7 +7093,7 @@
           <p:cNvPr id="80" name="recipes_icon_label">
             <a:extLst>
               <a:ext uri="{FF2B5EF4-FFF2-40B4-BE49-F238E27FC236}">
-                <a16:creationId xmlns:a16="http://schemas.microsoft.com/office/drawing/2014/main" id="{2757096F-D32E-B74C-1669-765F7E56906F}"/>
+                <a16:creationId xmlns:a16="http://schemas.microsoft.com/office/drawing/2014/main" id="{D6614EFE-66AD-98D9-6F57-97FEFDAF50CA}"/>
               </a:ext>
             </a:extLst>
           </p:cNvPr>
@@ -7140,7 +7140,7 @@
           <p:cNvPr id="81" name="recipes_title">
             <a:extLst>
               <a:ext uri="{FF2B5EF4-FFF2-40B4-BE49-F238E27FC236}">
-                <a16:creationId xmlns:a16="http://schemas.microsoft.com/office/drawing/2014/main" id="{DDBE973A-76E9-7EC7-B6AD-C77225E0DEF2}"/>
+                <a16:creationId xmlns:a16="http://schemas.microsoft.com/office/drawing/2014/main" id="{A04A8D6B-04EC-6D95-BE9D-0EE322BA8B75}"/>
               </a:ext>
             </a:extLst>
           </p:cNvPr>
@@ -7186,7 +7186,7 @@
           <p:cNvPr id="82" name="recipes_line_0">
             <a:extLst>
               <a:ext uri="{FF2B5EF4-FFF2-40B4-BE49-F238E27FC236}">
-                <a16:creationId xmlns:a16="http://schemas.microsoft.com/office/drawing/2014/main" id="{B6D272D8-DA28-DE92-8598-9EEE8E4D9830}"/>
+                <a16:creationId xmlns:a16="http://schemas.microsoft.com/office/drawing/2014/main" id="{6E8DB9B4-81F9-1E65-D9A6-F5B9040D2FFC}"/>
               </a:ext>
             </a:extLst>
           </p:cNvPr>
@@ -7232,7 +7232,7 @@
           <p:cNvPr id="83" name="recipes_line_1">
             <a:extLst>
               <a:ext uri="{FF2B5EF4-FFF2-40B4-BE49-F238E27FC236}">
-                <a16:creationId xmlns:a16="http://schemas.microsoft.com/office/drawing/2014/main" id="{A56F806F-9CAA-6E5C-80D4-AD3D5170F2EC}"/>
+                <a16:creationId xmlns:a16="http://schemas.microsoft.com/office/drawing/2014/main" id="{02A3FC23-8BEF-2FAD-7AC6-7410D529A457}"/>
               </a:ext>
             </a:extLst>
           </p:cNvPr>
@@ -7278,7 +7278,7 @@
           <p:cNvPr id="84" name="theme_card">
             <a:extLst>
               <a:ext uri="{FF2B5EF4-FFF2-40B4-BE49-F238E27FC236}">
-                <a16:creationId xmlns:a16="http://schemas.microsoft.com/office/drawing/2014/main" id="{83384489-1934-A62D-B8C3-3CE1DBFEE3B8}"/>
+                <a16:creationId xmlns:a16="http://schemas.microsoft.com/office/drawing/2014/main" id="{3277B260-336D-1B8B-244F-9A2D9ED0AD45}"/>
               </a:ext>
             </a:extLst>
           </p:cNvPr>
@@ -7339,7 +7339,7 @@
           <p:cNvPr id="85" name="theme_icon_dot">
             <a:extLst>
               <a:ext uri="{FF2B5EF4-FFF2-40B4-BE49-F238E27FC236}">
-                <a16:creationId xmlns:a16="http://schemas.microsoft.com/office/drawing/2014/main" id="{E827282C-7A95-BD7F-541F-0C88271D421C}"/>
+                <a16:creationId xmlns:a16="http://schemas.microsoft.com/office/drawing/2014/main" id="{C769E464-2E6C-93EF-3D3B-0B9EDF50A8D4}"/>
               </a:ext>
             </a:extLst>
           </p:cNvPr>
@@ -7393,7 +7393,7 @@
           <p:cNvPr id="86" name="theme_icon_label">
             <a:extLst>
               <a:ext uri="{FF2B5EF4-FFF2-40B4-BE49-F238E27FC236}">
-                <a16:creationId xmlns:a16="http://schemas.microsoft.com/office/drawing/2014/main" id="{03EFA2C8-2747-6554-304F-2764C2F2EE78}"/>
+                <a16:creationId xmlns:a16="http://schemas.microsoft.com/office/drawing/2014/main" id="{6F0F8C5F-2FB6-81A7-F61C-5517F6CD3B1F}"/>
               </a:ext>
             </a:extLst>
           </p:cNvPr>
@@ -7440,7 +7440,7 @@
           <p:cNvPr id="87" name="theme_title">
             <a:extLst>
               <a:ext uri="{FF2B5EF4-FFF2-40B4-BE49-F238E27FC236}">
-                <a16:creationId xmlns:a16="http://schemas.microsoft.com/office/drawing/2014/main" id="{9D3A0B1B-A2CD-0965-50C2-7A955AD9EE04}"/>
+                <a16:creationId xmlns:a16="http://schemas.microsoft.com/office/drawing/2014/main" id="{14616B5C-C269-FF99-650E-3C35FFC5994E}"/>
               </a:ext>
             </a:extLst>
           </p:cNvPr>
@@ -7486,7 +7486,7 @@
           <p:cNvPr id="88" name="theme_line_0">
             <a:extLst>
               <a:ext uri="{FF2B5EF4-FFF2-40B4-BE49-F238E27FC236}">
-                <a16:creationId xmlns:a16="http://schemas.microsoft.com/office/drawing/2014/main" id="{1F55D626-7E96-B3D1-D53E-8A479784A083}"/>
+                <a16:creationId xmlns:a16="http://schemas.microsoft.com/office/drawing/2014/main" id="{8C7E63E5-7413-A24D-2E13-80197B83881B}"/>
               </a:ext>
             </a:extLst>
           </p:cNvPr>
@@ -7532,7 +7532,7 @@
           <p:cNvPr id="89" name="theme_line_1">
             <a:extLst>
               <a:ext uri="{FF2B5EF4-FFF2-40B4-BE49-F238E27FC236}">
-                <a16:creationId xmlns:a16="http://schemas.microsoft.com/office/drawing/2014/main" id="{066B3888-22C8-1ED7-0B54-0F6D5D12739C}"/>
+                <a16:creationId xmlns:a16="http://schemas.microsoft.com/office/drawing/2014/main" id="{35A30D1C-D538-B55A-EF88-3EBAD717B75B}"/>
               </a:ext>
             </a:extLst>
           </p:cNvPr>
@@ -7578,7 +7578,7 @@
           <p:cNvPr id="90" name="compose_card">
             <a:extLst>
               <a:ext uri="{FF2B5EF4-FFF2-40B4-BE49-F238E27FC236}">
-                <a16:creationId xmlns:a16="http://schemas.microsoft.com/office/drawing/2014/main" id="{1532EF8C-5338-352A-3A96-3AEC55173267}"/>
+                <a16:creationId xmlns:a16="http://schemas.microsoft.com/office/drawing/2014/main" id="{E1E56A42-7D5D-92E9-9D6C-8E0BF7D80E05}"/>
               </a:ext>
             </a:extLst>
           </p:cNvPr>
@@ -7639,7 +7639,7 @@
           <p:cNvPr id="91" name="compose_icon_dot">
             <a:extLst>
               <a:ext uri="{FF2B5EF4-FFF2-40B4-BE49-F238E27FC236}">
-                <a16:creationId xmlns:a16="http://schemas.microsoft.com/office/drawing/2014/main" id="{C533A7A4-22E0-B143-B1F2-4DE3E4E759AC}"/>
+                <a16:creationId xmlns:a16="http://schemas.microsoft.com/office/drawing/2014/main" id="{E9CE3CE9-AD71-8B9C-BB46-15B250EF4700}"/>
               </a:ext>
             </a:extLst>
           </p:cNvPr>
@@ -7693,7 +7693,7 @@
           <p:cNvPr id="92" name="compose_icon_label">
             <a:extLst>
               <a:ext uri="{FF2B5EF4-FFF2-40B4-BE49-F238E27FC236}">
-                <a16:creationId xmlns:a16="http://schemas.microsoft.com/office/drawing/2014/main" id="{A9ACCB32-8FE4-B6E1-A1A3-E4986636E2C4}"/>
+                <a16:creationId xmlns:a16="http://schemas.microsoft.com/office/drawing/2014/main" id="{DBCC12D4-2A7F-33E0-8BC6-A0AA56758991}"/>
               </a:ext>
             </a:extLst>
           </p:cNvPr>
@@ -7740,7 +7740,7 @@
           <p:cNvPr id="93" name="compose_title">
             <a:extLst>
               <a:ext uri="{FF2B5EF4-FFF2-40B4-BE49-F238E27FC236}">
-                <a16:creationId xmlns:a16="http://schemas.microsoft.com/office/drawing/2014/main" id="{7BF7B3DF-B7DB-F4E0-B2C9-51CAD5CB820F}"/>
+                <a16:creationId xmlns:a16="http://schemas.microsoft.com/office/drawing/2014/main" id="{6268DA5F-7730-4C3B-F3E5-4375ED140AD1}"/>
               </a:ext>
             </a:extLst>
           </p:cNvPr>
@@ -7786,7 +7786,7 @@
           <p:cNvPr id="94" name="compose_line_0">
             <a:extLst>
               <a:ext uri="{FF2B5EF4-FFF2-40B4-BE49-F238E27FC236}">
-                <a16:creationId xmlns:a16="http://schemas.microsoft.com/office/drawing/2014/main" id="{CBD228A3-61C9-D875-B1FA-56BDC6D36107}"/>
+                <a16:creationId xmlns:a16="http://schemas.microsoft.com/office/drawing/2014/main" id="{A22FB8B8-A106-5469-1933-3055CB1DECFD}"/>
               </a:ext>
             </a:extLst>
           </p:cNvPr>
@@ -7832,7 +7832,7 @@
           <p:cNvPr id="95" name="compose_line_1">
             <a:extLst>
               <a:ext uri="{FF2B5EF4-FFF2-40B4-BE49-F238E27FC236}">
-                <a16:creationId xmlns:a16="http://schemas.microsoft.com/office/drawing/2014/main" id="{9EDE2B91-A226-C5E9-7ADF-9793AAABC607}"/>
+                <a16:creationId xmlns:a16="http://schemas.microsoft.com/office/drawing/2014/main" id="{08D7433E-8CA7-C6E6-BB0A-0F50DEBACBAD}"/>
               </a:ext>
             </a:extLst>
           </p:cNvPr>
@@ -7878,7 +7878,7 @@
           <p:cNvPr id="96" name="objects_card">
             <a:extLst>
               <a:ext uri="{FF2B5EF4-FFF2-40B4-BE49-F238E27FC236}">
-                <a16:creationId xmlns:a16="http://schemas.microsoft.com/office/drawing/2014/main" id="{80815EDE-3E37-AC9B-06C0-4A50B557C6A2}"/>
+                <a16:creationId xmlns:a16="http://schemas.microsoft.com/office/drawing/2014/main" id="{3E4FA430-9DA1-7FBD-A70A-7DA14846319C}"/>
               </a:ext>
             </a:extLst>
           </p:cNvPr>
@@ -7939,7 +7939,7 @@
           <p:cNvPr id="97" name="objects_icon_dot">
             <a:extLst>
               <a:ext uri="{FF2B5EF4-FFF2-40B4-BE49-F238E27FC236}">
-                <a16:creationId xmlns:a16="http://schemas.microsoft.com/office/drawing/2014/main" id="{1DC8CA0A-D531-0B82-D564-EBFA008142FD}"/>
+                <a16:creationId xmlns:a16="http://schemas.microsoft.com/office/drawing/2014/main" id="{3A1E67F6-743C-917C-F7B4-1C2D786B12BB}"/>
               </a:ext>
             </a:extLst>
           </p:cNvPr>
@@ -7993,7 +7993,7 @@
           <p:cNvPr id="98" name="objects_icon_label">
             <a:extLst>
               <a:ext uri="{FF2B5EF4-FFF2-40B4-BE49-F238E27FC236}">
-                <a16:creationId xmlns:a16="http://schemas.microsoft.com/office/drawing/2014/main" id="{E46BF31D-C82F-FA74-8A39-D6DD5576A313}"/>
+                <a16:creationId xmlns:a16="http://schemas.microsoft.com/office/drawing/2014/main" id="{CC038929-F9CF-9770-38F0-B4A79EB1CAD1}"/>
               </a:ext>
             </a:extLst>
           </p:cNvPr>
@@ -8040,7 +8040,7 @@
           <p:cNvPr id="99" name="objects_title">
             <a:extLst>
               <a:ext uri="{FF2B5EF4-FFF2-40B4-BE49-F238E27FC236}">
-                <a16:creationId xmlns:a16="http://schemas.microsoft.com/office/drawing/2014/main" id="{AB8D5128-912B-9FF7-DEC9-AF66953FB8BC}"/>
+                <a16:creationId xmlns:a16="http://schemas.microsoft.com/office/drawing/2014/main" id="{9B96C8C5-A9E7-50D9-A857-6BB3E297F68F}"/>
               </a:ext>
             </a:extLst>
           </p:cNvPr>
@@ -8086,7 +8086,7 @@
           <p:cNvPr id="100" name="objects_line_0">
             <a:extLst>
               <a:ext uri="{FF2B5EF4-FFF2-40B4-BE49-F238E27FC236}">
-                <a16:creationId xmlns:a16="http://schemas.microsoft.com/office/drawing/2014/main" id="{57B1B6EA-5C38-5DAE-138A-E7CEFBF93F73}"/>
+                <a16:creationId xmlns:a16="http://schemas.microsoft.com/office/drawing/2014/main" id="{5B562D2E-1EF5-6BA2-9C44-FA763B225895}"/>
               </a:ext>
             </a:extLst>
           </p:cNvPr>
@@ -8132,7 +8132,7 @@
           <p:cNvPr id="101" name="objects_line_1">
             <a:extLst>
               <a:ext uri="{FF2B5EF4-FFF2-40B4-BE49-F238E27FC236}">
-                <a16:creationId xmlns:a16="http://schemas.microsoft.com/office/drawing/2014/main" id="{65B80D0F-346F-C392-9BE8-D852419A15FB}"/>
+                <a16:creationId xmlns:a16="http://schemas.microsoft.com/office/drawing/2014/main" id="{D1EA289C-36C2-26CF-A24B-FC606EC4D5B3}"/>
               </a:ext>
             </a:extLst>
           </p:cNvPr>
@@ -8178,7 +8178,7 @@
           <p:cNvPr id="102" name="decorate_card">
             <a:extLst>
               <a:ext uri="{FF2B5EF4-FFF2-40B4-BE49-F238E27FC236}">
-                <a16:creationId xmlns:a16="http://schemas.microsoft.com/office/drawing/2014/main" id="{D857AE9B-AEEC-5700-0B37-DDEE669836DE}"/>
+                <a16:creationId xmlns:a16="http://schemas.microsoft.com/office/drawing/2014/main" id="{26A791FC-7090-DD16-4855-CD5A55665347}"/>
               </a:ext>
             </a:extLst>
           </p:cNvPr>
@@ -8239,7 +8239,7 @@
           <p:cNvPr id="103" name="decorate_icon_dot">
             <a:extLst>
               <a:ext uri="{FF2B5EF4-FFF2-40B4-BE49-F238E27FC236}">
-                <a16:creationId xmlns:a16="http://schemas.microsoft.com/office/drawing/2014/main" id="{BC9C2629-05AF-4FF8-29DB-DB25C494CE23}"/>
+                <a16:creationId xmlns:a16="http://schemas.microsoft.com/office/drawing/2014/main" id="{A11223F8-CA01-23EE-E493-9C191549A792}"/>
               </a:ext>
             </a:extLst>
           </p:cNvPr>
@@ -8293,7 +8293,7 @@
           <p:cNvPr id="104" name="decorate_icon_label">
             <a:extLst>
               <a:ext uri="{FF2B5EF4-FFF2-40B4-BE49-F238E27FC236}">
-                <a16:creationId xmlns:a16="http://schemas.microsoft.com/office/drawing/2014/main" id="{3FBE5824-65E5-EB80-0D30-6CA816676CD5}"/>
+                <a16:creationId xmlns:a16="http://schemas.microsoft.com/office/drawing/2014/main" id="{5B71BE62-4417-7787-39A6-75DAC6E0499D}"/>
               </a:ext>
             </a:extLst>
           </p:cNvPr>
@@ -8340,7 +8340,7 @@
           <p:cNvPr id="105" name="decorate_title">
             <a:extLst>
               <a:ext uri="{FF2B5EF4-FFF2-40B4-BE49-F238E27FC236}">
-                <a16:creationId xmlns:a16="http://schemas.microsoft.com/office/drawing/2014/main" id="{5EBB57A0-7AB0-D92E-2C55-C5E2D7DD9C9B}"/>
+                <a16:creationId xmlns:a16="http://schemas.microsoft.com/office/drawing/2014/main" id="{DCFE48A8-2CA7-F180-A3BA-30D696B8F832}"/>
               </a:ext>
             </a:extLst>
           </p:cNvPr>
@@ -8386,7 +8386,7 @@
           <p:cNvPr id="106" name="decorate_line_0">
             <a:extLst>
               <a:ext uri="{FF2B5EF4-FFF2-40B4-BE49-F238E27FC236}">
-                <a16:creationId xmlns:a16="http://schemas.microsoft.com/office/drawing/2014/main" id="{902EBA3C-AB2C-8D61-290D-F6857311A4FB}"/>
+                <a16:creationId xmlns:a16="http://schemas.microsoft.com/office/drawing/2014/main" id="{232B4E13-23E7-72FD-E6E4-8CB0ED4192D8}"/>
               </a:ext>
             </a:extLst>
           </p:cNvPr>
@@ -8432,7 +8432,7 @@
           <p:cNvPr id="107" name="decorate_line_1">
             <a:extLst>
               <a:ext uri="{FF2B5EF4-FFF2-40B4-BE49-F238E27FC236}">
-                <a16:creationId xmlns:a16="http://schemas.microsoft.com/office/drawing/2014/main" id="{29022C19-13CC-B752-A812-F6F5B1640C59}"/>
+                <a16:creationId xmlns:a16="http://schemas.microsoft.com/office/drawing/2014/main" id="{BD97F9A4-E4BC-EDF3-41A3-FF70769634DD}"/>
               </a:ext>
             </a:extLst>
           </p:cNvPr>
@@ -8478,7 +8478,7 @@
           <p:cNvPr id="108" name="styled_ir_card">
             <a:extLst>
               <a:ext uri="{FF2B5EF4-FFF2-40B4-BE49-F238E27FC236}">
-                <a16:creationId xmlns:a16="http://schemas.microsoft.com/office/drawing/2014/main" id="{871C1E24-761F-B031-DDFA-2FCD05EFE4F5}"/>
+                <a16:creationId xmlns:a16="http://schemas.microsoft.com/office/drawing/2014/main" id="{A6280E5B-FF1E-9060-4978-58312EB59736}"/>
               </a:ext>
             </a:extLst>
           </p:cNvPr>
@@ -8539,7 +8539,7 @@
           <p:cNvPr id="109" name="styled_ir_icon_dot">
             <a:extLst>
               <a:ext uri="{FF2B5EF4-FFF2-40B4-BE49-F238E27FC236}">
-                <a16:creationId xmlns:a16="http://schemas.microsoft.com/office/drawing/2014/main" id="{3FC7DF7B-92B9-92FD-6A03-3526534E329F}"/>
+                <a16:creationId xmlns:a16="http://schemas.microsoft.com/office/drawing/2014/main" id="{6E6E374A-9AB8-8696-7D08-CB2A87C71FA7}"/>
               </a:ext>
             </a:extLst>
           </p:cNvPr>
@@ -8593,7 +8593,7 @@
           <p:cNvPr id="110" name="styled_ir_icon_label">
             <a:extLst>
               <a:ext uri="{FF2B5EF4-FFF2-40B4-BE49-F238E27FC236}">
-                <a16:creationId xmlns:a16="http://schemas.microsoft.com/office/drawing/2014/main" id="{B9C70234-CA61-A979-1C5F-B455230868AF}"/>
+                <a16:creationId xmlns:a16="http://schemas.microsoft.com/office/drawing/2014/main" id="{DF7AC879-3269-4084-25CF-7A554E4C04FA}"/>
               </a:ext>
             </a:extLst>
           </p:cNvPr>
@@ -8640,7 +8640,7 @@
           <p:cNvPr id="111" name="styled_ir_title">
             <a:extLst>
               <a:ext uri="{FF2B5EF4-FFF2-40B4-BE49-F238E27FC236}">
-                <a16:creationId xmlns:a16="http://schemas.microsoft.com/office/drawing/2014/main" id="{E2DCB50C-F0D4-9CEA-654F-AEA71F20817C}"/>
+                <a16:creationId xmlns:a16="http://schemas.microsoft.com/office/drawing/2014/main" id="{8F5E8600-A2B7-BAD8-905A-5A0174C6A98A}"/>
               </a:ext>
             </a:extLst>
           </p:cNvPr>
@@ -8686,7 +8686,7 @@
           <p:cNvPr id="112" name="styled_ir_line_0">
             <a:extLst>
               <a:ext uri="{FF2B5EF4-FFF2-40B4-BE49-F238E27FC236}">
-                <a16:creationId xmlns:a16="http://schemas.microsoft.com/office/drawing/2014/main" id="{C11DB605-AC1B-A409-C7AC-0110C74B9035}"/>
+                <a16:creationId xmlns:a16="http://schemas.microsoft.com/office/drawing/2014/main" id="{D14903F1-A695-A668-F0BA-95E27B4DCB4E}"/>
               </a:ext>
             </a:extLst>
           </p:cNvPr>
@@ -8732,7 +8732,7 @@
           <p:cNvPr id="113" name="styled_ir_line_1">
             <a:extLst>
               <a:ext uri="{FF2B5EF4-FFF2-40B4-BE49-F238E27FC236}">
-                <a16:creationId xmlns:a16="http://schemas.microsoft.com/office/drawing/2014/main" id="{4CE727F9-D98B-462C-5417-A83368A79511}"/>
+                <a16:creationId xmlns:a16="http://schemas.microsoft.com/office/drawing/2014/main" id="{ADAEA09B-5DF2-0CFD-22A8-863EBA11150D}"/>
               </a:ext>
             </a:extLst>
           </p:cNvPr>
@@ -8778,7 +8778,7 @@
           <p:cNvPr id="114" name="renderers_card">
             <a:extLst>
               <a:ext uri="{FF2B5EF4-FFF2-40B4-BE49-F238E27FC236}">
-                <a16:creationId xmlns:a16="http://schemas.microsoft.com/office/drawing/2014/main" id="{6E44DC85-3482-592A-DEB7-99D7C8B5F354}"/>
+                <a16:creationId xmlns:a16="http://schemas.microsoft.com/office/drawing/2014/main" id="{024392AB-265A-B785-8225-138753CF44DF}"/>
               </a:ext>
             </a:extLst>
           </p:cNvPr>
@@ -8839,7 +8839,7 @@
           <p:cNvPr id="115" name="renderers_icon_dot">
             <a:extLst>
               <a:ext uri="{FF2B5EF4-FFF2-40B4-BE49-F238E27FC236}">
-                <a16:creationId xmlns:a16="http://schemas.microsoft.com/office/drawing/2014/main" id="{8A60E043-CF22-8F16-E36B-676FC78359B4}"/>
+                <a16:creationId xmlns:a16="http://schemas.microsoft.com/office/drawing/2014/main" id="{F5693D85-6DF5-0F42-CFE0-7445BAB7C00C}"/>
               </a:ext>
             </a:extLst>
           </p:cNvPr>
@@ -8893,7 +8893,7 @@
           <p:cNvPr id="116" name="renderers_icon_label">
             <a:extLst>
               <a:ext uri="{FF2B5EF4-FFF2-40B4-BE49-F238E27FC236}">
-                <a16:creationId xmlns:a16="http://schemas.microsoft.com/office/drawing/2014/main" id="{B9285215-215D-541C-E860-C67EB286D81C}"/>
+                <a16:creationId xmlns:a16="http://schemas.microsoft.com/office/drawing/2014/main" id="{37C89C3C-AF47-AB74-6A7D-16C0493287E6}"/>
               </a:ext>
             </a:extLst>
           </p:cNvPr>
@@ -8940,7 +8940,7 @@
           <p:cNvPr id="117" name="renderers_title">
             <a:extLst>
               <a:ext uri="{FF2B5EF4-FFF2-40B4-BE49-F238E27FC236}">
-                <a16:creationId xmlns:a16="http://schemas.microsoft.com/office/drawing/2014/main" id="{5DECB5AD-6D73-E6EC-A119-679E946B93D5}"/>
+                <a16:creationId xmlns:a16="http://schemas.microsoft.com/office/drawing/2014/main" id="{18CB787D-80DF-E9E8-EDE0-E1FC31940340}"/>
               </a:ext>
             </a:extLst>
           </p:cNvPr>
@@ -8986,7 +8986,7 @@
           <p:cNvPr id="118" name="renderers_line_0">
             <a:extLst>
               <a:ext uri="{FF2B5EF4-FFF2-40B4-BE49-F238E27FC236}">
-                <a16:creationId xmlns:a16="http://schemas.microsoft.com/office/drawing/2014/main" id="{975C6949-DE0E-7AFD-DF5C-259277393EA2}"/>
+                <a16:creationId xmlns:a16="http://schemas.microsoft.com/office/drawing/2014/main" id="{0DE32F25-CEFE-2858-F137-BBD006378CC1}"/>
               </a:ext>
             </a:extLst>
           </p:cNvPr>
@@ -9032,7 +9032,7 @@
           <p:cNvPr id="119" name="renderers_line_1">
             <a:extLst>
               <a:ext uri="{FF2B5EF4-FFF2-40B4-BE49-F238E27FC236}">
-                <a16:creationId xmlns:a16="http://schemas.microsoft.com/office/drawing/2014/main" id="{B7D070F6-BDD2-0C0B-7B26-FEDD2316A022}"/>
+                <a16:creationId xmlns:a16="http://schemas.microsoft.com/office/drawing/2014/main" id="{5630865F-9C74-BA52-2FAF-EF723A661C8D}"/>
               </a:ext>
             </a:extLst>
           </p:cNvPr>
@@ -9078,7 +9078,7 @@
           <p:cNvPr id="120" name="visual_check">
             <a:extLst>
               <a:ext uri="{FF2B5EF4-FFF2-40B4-BE49-F238E27FC236}">
-                <a16:creationId xmlns:a16="http://schemas.microsoft.com/office/drawing/2014/main" id="{95A6FD8E-ADC4-3949-DFA0-87C2D44DEA12}"/>
+                <a16:creationId xmlns:a16="http://schemas.microsoft.com/office/drawing/2014/main" id="{36EE31EB-5B4A-1AD8-E9E9-CBD79381D4C5}"/>
               </a:ext>
             </a:extLst>
           </p:cNvPr>
@@ -9139,7 +9139,7 @@
           <p:cNvPr id="121" name="visual_check_stripe">
             <a:extLst>
               <a:ext uri="{FF2B5EF4-FFF2-40B4-BE49-F238E27FC236}">
-                <a16:creationId xmlns:a16="http://schemas.microsoft.com/office/drawing/2014/main" id="{097CCDCF-378C-0CA9-2949-1C496127ACE4}"/>
+                <a16:creationId xmlns:a16="http://schemas.microsoft.com/office/drawing/2014/main" id="{E2307F09-9BE4-D5A9-458C-07376C19C10A}"/>
               </a:ext>
             </a:extLst>
           </p:cNvPr>
@@ -9193,7 +9193,7 @@
           <p:cNvPr id="122" name="visual_check_seal_icon_dot">
             <a:extLst>
               <a:ext uri="{FF2B5EF4-FFF2-40B4-BE49-F238E27FC236}">
-                <a16:creationId xmlns:a16="http://schemas.microsoft.com/office/drawing/2014/main" id="{657E9615-91C6-FEA4-99EA-C53B0456E016}"/>
+                <a16:creationId xmlns:a16="http://schemas.microsoft.com/office/drawing/2014/main" id="{FA17DA71-7CBE-7570-4ACD-F4F5E91F22FA}"/>
               </a:ext>
             </a:extLst>
           </p:cNvPr>
@@ -9247,7 +9247,7 @@
           <p:cNvPr id="123" name="visual_check_seal_icon_label">
             <a:extLst>
               <a:ext uri="{FF2B5EF4-FFF2-40B4-BE49-F238E27FC236}">
-                <a16:creationId xmlns:a16="http://schemas.microsoft.com/office/drawing/2014/main" id="{DE08D624-1C53-CC79-DB6D-1BC6B1EC3C01}"/>
+                <a16:creationId xmlns:a16="http://schemas.microsoft.com/office/drawing/2014/main" id="{6C1FD18F-E57A-80BF-9178-8BDE0EEF8D38}"/>
               </a:ext>
             </a:extLst>
           </p:cNvPr>
@@ -9294,7 +9294,7 @@
           <p:cNvPr id="124" name="visual_check_label">
             <a:extLst>
               <a:ext uri="{FF2B5EF4-FFF2-40B4-BE49-F238E27FC236}">
-                <a16:creationId xmlns:a16="http://schemas.microsoft.com/office/drawing/2014/main" id="{E52BC9B7-D3B7-029C-3B86-582806DC241B}"/>
+                <a16:creationId xmlns:a16="http://schemas.microsoft.com/office/drawing/2014/main" id="{247B1101-7985-049E-CB9E-4ADBB8BCB651}"/>
               </a:ext>
             </a:extLst>
           </p:cNvPr>
@@ -9340,7 +9340,7 @@
           <p:cNvPr id="125" name="visual_check_text">
             <a:extLst>
               <a:ext uri="{FF2B5EF4-FFF2-40B4-BE49-F238E27FC236}">
-                <a16:creationId xmlns:a16="http://schemas.microsoft.com/office/drawing/2014/main" id="{680BFD89-CAA3-E148-F1D0-D1018E875FF3}"/>
+                <a16:creationId xmlns:a16="http://schemas.microsoft.com/office/drawing/2014/main" id="{977C6730-2F46-BDAC-2830-0EE989AC323E}"/>
               </a:ext>
             </a:extLst>
           </p:cNvPr>
@@ -9386,7 +9386,7 @@
           <p:cNvPr id="126" name="coherence_band">
             <a:extLst>
               <a:ext uri="{FF2B5EF4-FFF2-40B4-BE49-F238E27FC236}">
-                <a16:creationId xmlns:a16="http://schemas.microsoft.com/office/drawing/2014/main" id="{1A3E2925-AF46-22A9-EB48-CA7A3936F814}"/>
+                <a16:creationId xmlns:a16="http://schemas.microsoft.com/office/drawing/2014/main" id="{EA76D1BA-D2DD-A97E-9BA3-05A99824DD3A}"/>
               </a:ext>
             </a:extLst>
           </p:cNvPr>
@@ -9447,7 +9447,7 @@
           <p:cNvPr id="127" name="coherence_title">
             <a:extLst>
               <a:ext uri="{FF2B5EF4-FFF2-40B4-BE49-F238E27FC236}">
-                <a16:creationId xmlns:a16="http://schemas.microsoft.com/office/drawing/2014/main" id="{45A6F1FB-6A15-F7A8-96EE-AE18898D94A3}"/>
+                <a16:creationId xmlns:a16="http://schemas.microsoft.com/office/drawing/2014/main" id="{F6E0F5C1-9344-7B30-C252-DD37FBF86B89}"/>
               </a:ext>
             </a:extLst>
           </p:cNvPr>
@@ -9493,7 +9493,7 @@
           <p:cNvPr id="128" name="coherence_body">
             <a:extLst>
               <a:ext uri="{FF2B5EF4-FFF2-40B4-BE49-F238E27FC236}">
-                <a16:creationId xmlns:a16="http://schemas.microsoft.com/office/drawing/2014/main" id="{47F1A056-6BE6-923E-1AFD-D40470B3FEE7}"/>
+                <a16:creationId xmlns:a16="http://schemas.microsoft.com/office/drawing/2014/main" id="{B386E233-751A-B073-B1BE-51EBF5D0E416}"/>
               </a:ext>
             </a:extLst>
           </p:cNvPr>
@@ -9537,7 +9537,7 @@
     </p:spTree>
     <p:extLst>
       <p:ext uri="{BB962C8B-B14F-4D97-AF65-F5344CB8AC3E}">
-        <p14:creationId xmlns:p14="http://schemas.microsoft.com/office/powerpoint/2010/main" val="674851706"/>
+        <p14:creationId xmlns:p14="http://schemas.microsoft.com/office/powerpoint/2010/main" val="1339269845"/>
       </p:ext>
     </p:extLst>
   </p:cSld>

</xml_diff>

<commit_message>
Add theme style presets and visual validation
</commit_message>
<xml_diff>
--- a/docs/assets/readme-slides/mdpr-pipeline-teaser.pptx
+++ b/docs/assets/readme-slides/mdpr-pipeline-teaser.pptx
@@ -129,7 +129,7 @@
           <p:cNvPr id="2" name="제목 1">
             <a:extLst>
               <a:ext uri="{FF2B5EF4-FFF2-40B4-BE49-F238E27FC236}">
-                <a16:creationId xmlns:a16="http://schemas.microsoft.com/office/drawing/2014/main" id="{A37B26F0-640E-9B99-F478-25F62266F957}"/>
+                <a16:creationId xmlns:a16="http://schemas.microsoft.com/office/drawing/2014/main" id="{40D8F000-BB2C-5AF4-0EEF-964FCF5DA86E}"/>
               </a:ext>
             </a:extLst>
           </p:cNvPr>
@@ -166,7 +166,7 @@
           <p:cNvPr id="3" name="부제목 2">
             <a:extLst>
               <a:ext uri="{FF2B5EF4-FFF2-40B4-BE49-F238E27FC236}">
-                <a16:creationId xmlns:a16="http://schemas.microsoft.com/office/drawing/2014/main" id="{B24F44A9-8E5B-F129-F2E7-600BAE6E0CB6}"/>
+                <a16:creationId xmlns:a16="http://schemas.microsoft.com/office/drawing/2014/main" id="{E72CB708-CF46-4ACC-54A6-4AF9B6F00881}"/>
               </a:ext>
             </a:extLst>
           </p:cNvPr>
@@ -236,7 +236,7 @@
           <p:cNvPr id="4" name="날짜 개체 틀 3">
             <a:extLst>
               <a:ext uri="{FF2B5EF4-FFF2-40B4-BE49-F238E27FC236}">
-                <a16:creationId xmlns:a16="http://schemas.microsoft.com/office/drawing/2014/main" id="{92A111FB-D244-E7B4-7760-B0A6C49FF3B3}"/>
+                <a16:creationId xmlns:a16="http://schemas.microsoft.com/office/drawing/2014/main" id="{E6669347-0A9D-AF7B-8A12-40A08A9FE1FA}"/>
               </a:ext>
             </a:extLst>
           </p:cNvPr>
@@ -252,7 +252,7 @@
           <a:bodyPr/>
           <a:lstStyle/>
           <a:p>
-            <a:fld id="{C7A2DD86-A6D0-4D7F-9460-517EC008A1FC}" type="datetimeFigureOut">
+            <a:fld id="{4EDDC4F2-F7BA-451D-AD65-B44D4A0691CB}" type="datetimeFigureOut">
               <a:rPr lang="ko-KR" altLang="en-US" smtClean="0"/>
               <a:t>2026-06-20</a:t>
             </a:fld>
@@ -265,7 +265,7 @@
           <p:cNvPr id="5" name="바닥글 개체 틀 4">
             <a:extLst>
               <a:ext uri="{FF2B5EF4-FFF2-40B4-BE49-F238E27FC236}">
-                <a16:creationId xmlns:a16="http://schemas.microsoft.com/office/drawing/2014/main" id="{6723B46A-EBAE-54DD-6F68-254F94AC3092}"/>
+                <a16:creationId xmlns:a16="http://schemas.microsoft.com/office/drawing/2014/main" id="{11AAD211-596F-2AD6-4C10-714D580E0622}"/>
               </a:ext>
             </a:extLst>
           </p:cNvPr>
@@ -290,7 +290,7 @@
           <p:cNvPr id="6" name="슬라이드 번호 개체 틀 5">
             <a:extLst>
               <a:ext uri="{FF2B5EF4-FFF2-40B4-BE49-F238E27FC236}">
-                <a16:creationId xmlns:a16="http://schemas.microsoft.com/office/drawing/2014/main" id="{E0FD0168-1224-86F7-3D96-B4B70230EE54}"/>
+                <a16:creationId xmlns:a16="http://schemas.microsoft.com/office/drawing/2014/main" id="{D7518E4D-A3EC-6A35-FB5E-DE6C5903FE9A}"/>
               </a:ext>
             </a:extLst>
           </p:cNvPr>
@@ -306,7 +306,7 @@
           <a:bodyPr/>
           <a:lstStyle/>
           <a:p>
-            <a:fld id="{FCE527D7-AC3E-4C2A-A377-10FA5A63B0EC}" type="slidenum">
+            <a:fld id="{A36E63EA-5A2B-431F-BF5E-3184E73FCB0D}" type="slidenum">
               <a:rPr lang="ko-KR" altLang="en-US" smtClean="0"/>
               <a:t>‹#›</a:t>
             </a:fld>
@@ -317,7 +317,7 @@
     </p:spTree>
     <p:extLst>
       <p:ext uri="{BB962C8B-B14F-4D97-AF65-F5344CB8AC3E}">
-        <p14:creationId xmlns:p14="http://schemas.microsoft.com/office/powerpoint/2010/main" val="1093937482"/>
+        <p14:creationId xmlns:p14="http://schemas.microsoft.com/office/powerpoint/2010/main" val="1205908244"/>
       </p:ext>
     </p:extLst>
   </p:cSld>
@@ -349,7 +349,7 @@
           <p:cNvPr id="2" name="제목 1">
             <a:extLst>
               <a:ext uri="{FF2B5EF4-FFF2-40B4-BE49-F238E27FC236}">
-                <a16:creationId xmlns:a16="http://schemas.microsoft.com/office/drawing/2014/main" id="{31C1646D-B61D-E64E-40BF-4D86CF2C6073}"/>
+                <a16:creationId xmlns:a16="http://schemas.microsoft.com/office/drawing/2014/main" id="{A2E99A70-4AE8-3D2B-4254-93A3AFC0D62F}"/>
               </a:ext>
             </a:extLst>
           </p:cNvPr>
@@ -377,7 +377,7 @@
           <p:cNvPr id="3" name="세로 텍스트 개체 틀 2">
             <a:extLst>
               <a:ext uri="{FF2B5EF4-FFF2-40B4-BE49-F238E27FC236}">
-                <a16:creationId xmlns:a16="http://schemas.microsoft.com/office/drawing/2014/main" id="{8A58F64B-C56E-6819-91AC-0F6C8DABAF78}"/>
+                <a16:creationId xmlns:a16="http://schemas.microsoft.com/office/drawing/2014/main" id="{535650EF-01AA-483B-38AE-29FBDEF3A87B}"/>
               </a:ext>
             </a:extLst>
           </p:cNvPr>
@@ -434,7 +434,7 @@
           <p:cNvPr id="4" name="날짜 개체 틀 3">
             <a:extLst>
               <a:ext uri="{FF2B5EF4-FFF2-40B4-BE49-F238E27FC236}">
-                <a16:creationId xmlns:a16="http://schemas.microsoft.com/office/drawing/2014/main" id="{A03B0F8E-1CCA-0D60-351D-C1A0953B5E55}"/>
+                <a16:creationId xmlns:a16="http://schemas.microsoft.com/office/drawing/2014/main" id="{BB7B3E54-932B-8652-5E49-8E44CFD2A5FB}"/>
               </a:ext>
             </a:extLst>
           </p:cNvPr>
@@ -450,7 +450,7 @@
           <a:bodyPr/>
           <a:lstStyle/>
           <a:p>
-            <a:fld id="{C7A2DD86-A6D0-4D7F-9460-517EC008A1FC}" type="datetimeFigureOut">
+            <a:fld id="{4EDDC4F2-F7BA-451D-AD65-B44D4A0691CB}" type="datetimeFigureOut">
               <a:rPr lang="ko-KR" altLang="en-US" smtClean="0"/>
               <a:t>2026-06-20</a:t>
             </a:fld>
@@ -463,7 +463,7 @@
           <p:cNvPr id="5" name="바닥글 개체 틀 4">
             <a:extLst>
               <a:ext uri="{FF2B5EF4-FFF2-40B4-BE49-F238E27FC236}">
-                <a16:creationId xmlns:a16="http://schemas.microsoft.com/office/drawing/2014/main" id="{668A4EE0-D67F-476D-4B42-A0602C20B927}"/>
+                <a16:creationId xmlns:a16="http://schemas.microsoft.com/office/drawing/2014/main" id="{6651A640-8773-0663-10E2-FD89EA4720A5}"/>
               </a:ext>
             </a:extLst>
           </p:cNvPr>
@@ -488,7 +488,7 @@
           <p:cNvPr id="6" name="슬라이드 번호 개체 틀 5">
             <a:extLst>
               <a:ext uri="{FF2B5EF4-FFF2-40B4-BE49-F238E27FC236}">
-                <a16:creationId xmlns:a16="http://schemas.microsoft.com/office/drawing/2014/main" id="{0009D8CA-218D-C879-A6C8-2D74C62F0DB2}"/>
+                <a16:creationId xmlns:a16="http://schemas.microsoft.com/office/drawing/2014/main" id="{DD642E7D-EC45-4851-C2AC-72C9F7FF7C2E}"/>
               </a:ext>
             </a:extLst>
           </p:cNvPr>
@@ -504,7 +504,7 @@
           <a:bodyPr/>
           <a:lstStyle/>
           <a:p>
-            <a:fld id="{FCE527D7-AC3E-4C2A-A377-10FA5A63B0EC}" type="slidenum">
+            <a:fld id="{A36E63EA-5A2B-431F-BF5E-3184E73FCB0D}" type="slidenum">
               <a:rPr lang="ko-KR" altLang="en-US" smtClean="0"/>
               <a:t>‹#›</a:t>
             </a:fld>
@@ -515,7 +515,7 @@
     </p:spTree>
     <p:extLst>
       <p:ext uri="{BB962C8B-B14F-4D97-AF65-F5344CB8AC3E}">
-        <p14:creationId xmlns:p14="http://schemas.microsoft.com/office/powerpoint/2010/main" val="1761592475"/>
+        <p14:creationId xmlns:p14="http://schemas.microsoft.com/office/powerpoint/2010/main" val="1170634376"/>
       </p:ext>
     </p:extLst>
   </p:cSld>
@@ -547,7 +547,7 @@
           <p:cNvPr id="2" name="세로 제목 1">
             <a:extLst>
               <a:ext uri="{FF2B5EF4-FFF2-40B4-BE49-F238E27FC236}">
-                <a16:creationId xmlns:a16="http://schemas.microsoft.com/office/drawing/2014/main" id="{48277972-F2E5-4BE4-396B-75C6C99A4D0E}"/>
+                <a16:creationId xmlns:a16="http://schemas.microsoft.com/office/drawing/2014/main" id="{671D8CD4-889A-93BC-D094-E87C5C757FE8}"/>
               </a:ext>
             </a:extLst>
           </p:cNvPr>
@@ -580,7 +580,7 @@
           <p:cNvPr id="3" name="세로 텍스트 개체 틀 2">
             <a:extLst>
               <a:ext uri="{FF2B5EF4-FFF2-40B4-BE49-F238E27FC236}">
-                <a16:creationId xmlns:a16="http://schemas.microsoft.com/office/drawing/2014/main" id="{7E6AD225-7C14-28D5-A1C6-B53423470DC1}"/>
+                <a16:creationId xmlns:a16="http://schemas.microsoft.com/office/drawing/2014/main" id="{06154821-FEA5-E299-D6AA-EB72BEBDF802}"/>
               </a:ext>
             </a:extLst>
           </p:cNvPr>
@@ -642,7 +642,7 @@
           <p:cNvPr id="4" name="날짜 개체 틀 3">
             <a:extLst>
               <a:ext uri="{FF2B5EF4-FFF2-40B4-BE49-F238E27FC236}">
-                <a16:creationId xmlns:a16="http://schemas.microsoft.com/office/drawing/2014/main" id="{05490A60-DEC3-8F51-474F-059AC6FB6539}"/>
+                <a16:creationId xmlns:a16="http://schemas.microsoft.com/office/drawing/2014/main" id="{CABE9AD4-AE7E-96A4-A488-11D95BCCA5A9}"/>
               </a:ext>
             </a:extLst>
           </p:cNvPr>
@@ -658,7 +658,7 @@
           <a:bodyPr/>
           <a:lstStyle/>
           <a:p>
-            <a:fld id="{C7A2DD86-A6D0-4D7F-9460-517EC008A1FC}" type="datetimeFigureOut">
+            <a:fld id="{4EDDC4F2-F7BA-451D-AD65-B44D4A0691CB}" type="datetimeFigureOut">
               <a:rPr lang="ko-KR" altLang="en-US" smtClean="0"/>
               <a:t>2026-06-20</a:t>
             </a:fld>
@@ -671,7 +671,7 @@
           <p:cNvPr id="5" name="바닥글 개체 틀 4">
             <a:extLst>
               <a:ext uri="{FF2B5EF4-FFF2-40B4-BE49-F238E27FC236}">
-                <a16:creationId xmlns:a16="http://schemas.microsoft.com/office/drawing/2014/main" id="{725D49ED-8A2A-477D-2516-8F2058A4EACD}"/>
+                <a16:creationId xmlns:a16="http://schemas.microsoft.com/office/drawing/2014/main" id="{EF211E44-0F12-1285-7C64-90E819431AAC}"/>
               </a:ext>
             </a:extLst>
           </p:cNvPr>
@@ -696,7 +696,7 @@
           <p:cNvPr id="6" name="슬라이드 번호 개체 틀 5">
             <a:extLst>
               <a:ext uri="{FF2B5EF4-FFF2-40B4-BE49-F238E27FC236}">
-                <a16:creationId xmlns:a16="http://schemas.microsoft.com/office/drawing/2014/main" id="{AB6155DC-AA56-A0C0-0E14-616BA34FC6B0}"/>
+                <a16:creationId xmlns:a16="http://schemas.microsoft.com/office/drawing/2014/main" id="{9BC67932-4803-C110-8D95-B2C6240486A5}"/>
               </a:ext>
             </a:extLst>
           </p:cNvPr>
@@ -712,7 +712,7 @@
           <a:bodyPr/>
           <a:lstStyle/>
           <a:p>
-            <a:fld id="{FCE527D7-AC3E-4C2A-A377-10FA5A63B0EC}" type="slidenum">
+            <a:fld id="{A36E63EA-5A2B-431F-BF5E-3184E73FCB0D}" type="slidenum">
               <a:rPr lang="ko-KR" altLang="en-US" smtClean="0"/>
               <a:t>‹#›</a:t>
             </a:fld>
@@ -723,7 +723,7 @@
     </p:spTree>
     <p:extLst>
       <p:ext uri="{BB962C8B-B14F-4D97-AF65-F5344CB8AC3E}">
-        <p14:creationId xmlns:p14="http://schemas.microsoft.com/office/powerpoint/2010/main" val="1908232628"/>
+        <p14:creationId xmlns:p14="http://schemas.microsoft.com/office/powerpoint/2010/main" val="2883822501"/>
       </p:ext>
     </p:extLst>
   </p:cSld>
@@ -755,7 +755,7 @@
           <p:cNvPr id="2" name="제목 1">
             <a:extLst>
               <a:ext uri="{FF2B5EF4-FFF2-40B4-BE49-F238E27FC236}">
-                <a16:creationId xmlns:a16="http://schemas.microsoft.com/office/drawing/2014/main" id="{24780910-8EFD-4BED-4844-965BC711B15F}"/>
+                <a16:creationId xmlns:a16="http://schemas.microsoft.com/office/drawing/2014/main" id="{9FA3B6CA-AF08-29B5-241D-A1547E16D4C7}"/>
               </a:ext>
             </a:extLst>
           </p:cNvPr>
@@ -783,7 +783,7 @@
           <p:cNvPr id="3" name="내용 개체 틀 2">
             <a:extLst>
               <a:ext uri="{FF2B5EF4-FFF2-40B4-BE49-F238E27FC236}">
-                <a16:creationId xmlns:a16="http://schemas.microsoft.com/office/drawing/2014/main" id="{3FAADF5F-5570-F73B-9477-C0224A5E6350}"/>
+                <a16:creationId xmlns:a16="http://schemas.microsoft.com/office/drawing/2014/main" id="{3681D43E-F433-4130-CB62-875F286D559A}"/>
               </a:ext>
             </a:extLst>
           </p:cNvPr>
@@ -840,7 +840,7 @@
           <p:cNvPr id="4" name="날짜 개체 틀 3">
             <a:extLst>
               <a:ext uri="{FF2B5EF4-FFF2-40B4-BE49-F238E27FC236}">
-                <a16:creationId xmlns:a16="http://schemas.microsoft.com/office/drawing/2014/main" id="{4D1E49B2-5255-58FA-F8D7-40E5F33564F5}"/>
+                <a16:creationId xmlns:a16="http://schemas.microsoft.com/office/drawing/2014/main" id="{DC481173-8F50-613F-524B-FCD4CFB08052}"/>
               </a:ext>
             </a:extLst>
           </p:cNvPr>
@@ -856,7 +856,7 @@
           <a:bodyPr/>
           <a:lstStyle/>
           <a:p>
-            <a:fld id="{C7A2DD86-A6D0-4D7F-9460-517EC008A1FC}" type="datetimeFigureOut">
+            <a:fld id="{4EDDC4F2-F7BA-451D-AD65-B44D4A0691CB}" type="datetimeFigureOut">
               <a:rPr lang="ko-KR" altLang="en-US" smtClean="0"/>
               <a:t>2026-06-20</a:t>
             </a:fld>
@@ -869,7 +869,7 @@
           <p:cNvPr id="5" name="바닥글 개체 틀 4">
             <a:extLst>
               <a:ext uri="{FF2B5EF4-FFF2-40B4-BE49-F238E27FC236}">
-                <a16:creationId xmlns:a16="http://schemas.microsoft.com/office/drawing/2014/main" id="{4740E1C8-D394-CBAD-0FB4-346F821D039E}"/>
+                <a16:creationId xmlns:a16="http://schemas.microsoft.com/office/drawing/2014/main" id="{7E2D2AF0-7E55-380C-EB36-E1220522F574}"/>
               </a:ext>
             </a:extLst>
           </p:cNvPr>
@@ -894,7 +894,7 @@
           <p:cNvPr id="6" name="슬라이드 번호 개체 틀 5">
             <a:extLst>
               <a:ext uri="{FF2B5EF4-FFF2-40B4-BE49-F238E27FC236}">
-                <a16:creationId xmlns:a16="http://schemas.microsoft.com/office/drawing/2014/main" id="{81E73AAD-BCF3-BCD1-74AB-16075BF9F176}"/>
+                <a16:creationId xmlns:a16="http://schemas.microsoft.com/office/drawing/2014/main" id="{9CCA412B-B9B5-14F1-91BC-7558650D3C6F}"/>
               </a:ext>
             </a:extLst>
           </p:cNvPr>
@@ -910,7 +910,7 @@
           <a:bodyPr/>
           <a:lstStyle/>
           <a:p>
-            <a:fld id="{FCE527D7-AC3E-4C2A-A377-10FA5A63B0EC}" type="slidenum">
+            <a:fld id="{A36E63EA-5A2B-431F-BF5E-3184E73FCB0D}" type="slidenum">
               <a:rPr lang="ko-KR" altLang="en-US" smtClean="0"/>
               <a:t>‹#›</a:t>
             </a:fld>
@@ -921,7 +921,7 @@
     </p:spTree>
     <p:extLst>
       <p:ext uri="{BB962C8B-B14F-4D97-AF65-F5344CB8AC3E}">
-        <p14:creationId xmlns:p14="http://schemas.microsoft.com/office/powerpoint/2010/main" val="2577444905"/>
+        <p14:creationId xmlns:p14="http://schemas.microsoft.com/office/powerpoint/2010/main" val="3252414932"/>
       </p:ext>
     </p:extLst>
   </p:cSld>
@@ -953,7 +953,7 @@
           <p:cNvPr id="2" name="제목 1">
             <a:extLst>
               <a:ext uri="{FF2B5EF4-FFF2-40B4-BE49-F238E27FC236}">
-                <a16:creationId xmlns:a16="http://schemas.microsoft.com/office/drawing/2014/main" id="{36CD94B5-872B-93ED-8736-805390ED88FF}"/>
+                <a16:creationId xmlns:a16="http://schemas.microsoft.com/office/drawing/2014/main" id="{D147401A-862E-3E04-F9EA-0B0BCA24F015}"/>
               </a:ext>
             </a:extLst>
           </p:cNvPr>
@@ -990,7 +990,7 @@
           <p:cNvPr id="3" name="텍스트 개체 틀 2">
             <a:extLst>
               <a:ext uri="{FF2B5EF4-FFF2-40B4-BE49-F238E27FC236}">
-                <a16:creationId xmlns:a16="http://schemas.microsoft.com/office/drawing/2014/main" id="{26F5E376-FF77-01C0-2F08-78ABA6B79044}"/>
+                <a16:creationId xmlns:a16="http://schemas.microsoft.com/office/drawing/2014/main" id="{A842F0B8-1D76-A5C6-C958-F6F3C498A9F8}"/>
               </a:ext>
             </a:extLst>
           </p:cNvPr>
@@ -1115,7 +1115,7 @@
           <p:cNvPr id="4" name="날짜 개체 틀 3">
             <a:extLst>
               <a:ext uri="{FF2B5EF4-FFF2-40B4-BE49-F238E27FC236}">
-                <a16:creationId xmlns:a16="http://schemas.microsoft.com/office/drawing/2014/main" id="{77927F08-6AAB-7E71-7DE6-B10A42125B70}"/>
+                <a16:creationId xmlns:a16="http://schemas.microsoft.com/office/drawing/2014/main" id="{8B38B0DC-FBBC-2598-F26C-9797CF52DC2E}"/>
               </a:ext>
             </a:extLst>
           </p:cNvPr>
@@ -1131,7 +1131,7 @@
           <a:bodyPr/>
           <a:lstStyle/>
           <a:p>
-            <a:fld id="{C7A2DD86-A6D0-4D7F-9460-517EC008A1FC}" type="datetimeFigureOut">
+            <a:fld id="{4EDDC4F2-F7BA-451D-AD65-B44D4A0691CB}" type="datetimeFigureOut">
               <a:rPr lang="ko-KR" altLang="en-US" smtClean="0"/>
               <a:t>2026-06-20</a:t>
             </a:fld>
@@ -1144,7 +1144,7 @@
           <p:cNvPr id="5" name="바닥글 개체 틀 4">
             <a:extLst>
               <a:ext uri="{FF2B5EF4-FFF2-40B4-BE49-F238E27FC236}">
-                <a16:creationId xmlns:a16="http://schemas.microsoft.com/office/drawing/2014/main" id="{E0F69016-7221-B8E1-31C0-36EB0BEB58C4}"/>
+                <a16:creationId xmlns:a16="http://schemas.microsoft.com/office/drawing/2014/main" id="{FCC0AC2D-DCC2-4690-41ED-42E2BECCA5C5}"/>
               </a:ext>
             </a:extLst>
           </p:cNvPr>
@@ -1169,7 +1169,7 @@
           <p:cNvPr id="6" name="슬라이드 번호 개체 틀 5">
             <a:extLst>
               <a:ext uri="{FF2B5EF4-FFF2-40B4-BE49-F238E27FC236}">
-                <a16:creationId xmlns:a16="http://schemas.microsoft.com/office/drawing/2014/main" id="{FBABEDF7-3663-DA8C-AA3F-454670072850}"/>
+                <a16:creationId xmlns:a16="http://schemas.microsoft.com/office/drawing/2014/main" id="{54FC350D-605D-5F21-3A01-BE7C7CCC24EB}"/>
               </a:ext>
             </a:extLst>
           </p:cNvPr>
@@ -1185,7 +1185,7 @@
           <a:bodyPr/>
           <a:lstStyle/>
           <a:p>
-            <a:fld id="{FCE527D7-AC3E-4C2A-A377-10FA5A63B0EC}" type="slidenum">
+            <a:fld id="{A36E63EA-5A2B-431F-BF5E-3184E73FCB0D}" type="slidenum">
               <a:rPr lang="ko-KR" altLang="en-US" smtClean="0"/>
               <a:t>‹#›</a:t>
             </a:fld>
@@ -1196,7 +1196,7 @@
     </p:spTree>
     <p:extLst>
       <p:ext uri="{BB962C8B-B14F-4D97-AF65-F5344CB8AC3E}">
-        <p14:creationId xmlns:p14="http://schemas.microsoft.com/office/powerpoint/2010/main" val="61224077"/>
+        <p14:creationId xmlns:p14="http://schemas.microsoft.com/office/powerpoint/2010/main" val="238210886"/>
       </p:ext>
     </p:extLst>
   </p:cSld>
@@ -1228,7 +1228,7 @@
           <p:cNvPr id="2" name="제목 1">
             <a:extLst>
               <a:ext uri="{FF2B5EF4-FFF2-40B4-BE49-F238E27FC236}">
-                <a16:creationId xmlns:a16="http://schemas.microsoft.com/office/drawing/2014/main" id="{259636A2-74F7-3345-1466-12FA07F12835}"/>
+                <a16:creationId xmlns:a16="http://schemas.microsoft.com/office/drawing/2014/main" id="{8B9E2A8F-30A9-BF2E-502A-5304804A9107}"/>
               </a:ext>
             </a:extLst>
           </p:cNvPr>
@@ -1256,7 +1256,7 @@
           <p:cNvPr id="3" name="내용 개체 틀 2">
             <a:extLst>
               <a:ext uri="{FF2B5EF4-FFF2-40B4-BE49-F238E27FC236}">
-                <a16:creationId xmlns:a16="http://schemas.microsoft.com/office/drawing/2014/main" id="{D3FC9E59-317C-EC31-2C7E-197136B0A27F}"/>
+                <a16:creationId xmlns:a16="http://schemas.microsoft.com/office/drawing/2014/main" id="{D408BA57-5393-BC2F-9BDA-1455D8BFD362}"/>
               </a:ext>
             </a:extLst>
           </p:cNvPr>
@@ -1318,7 +1318,7 @@
           <p:cNvPr id="4" name="내용 개체 틀 3">
             <a:extLst>
               <a:ext uri="{FF2B5EF4-FFF2-40B4-BE49-F238E27FC236}">
-                <a16:creationId xmlns:a16="http://schemas.microsoft.com/office/drawing/2014/main" id="{64927319-1CFB-6769-0401-3CA60A5235A8}"/>
+                <a16:creationId xmlns:a16="http://schemas.microsoft.com/office/drawing/2014/main" id="{FB300CF0-3CC8-237B-1B23-0668B81BCD1B}"/>
               </a:ext>
             </a:extLst>
           </p:cNvPr>
@@ -1380,7 +1380,7 @@
           <p:cNvPr id="5" name="날짜 개체 틀 4">
             <a:extLst>
               <a:ext uri="{FF2B5EF4-FFF2-40B4-BE49-F238E27FC236}">
-                <a16:creationId xmlns:a16="http://schemas.microsoft.com/office/drawing/2014/main" id="{BF822E8A-9987-D62C-DB3A-74E4F7CFC30E}"/>
+                <a16:creationId xmlns:a16="http://schemas.microsoft.com/office/drawing/2014/main" id="{7B3654A6-2423-14AB-7A34-AA78FA17B3B6}"/>
               </a:ext>
             </a:extLst>
           </p:cNvPr>
@@ -1396,7 +1396,7 @@
           <a:bodyPr/>
           <a:lstStyle/>
           <a:p>
-            <a:fld id="{C7A2DD86-A6D0-4D7F-9460-517EC008A1FC}" type="datetimeFigureOut">
+            <a:fld id="{4EDDC4F2-F7BA-451D-AD65-B44D4A0691CB}" type="datetimeFigureOut">
               <a:rPr lang="ko-KR" altLang="en-US" smtClean="0"/>
               <a:t>2026-06-20</a:t>
             </a:fld>
@@ -1409,7 +1409,7 @@
           <p:cNvPr id="6" name="바닥글 개체 틀 5">
             <a:extLst>
               <a:ext uri="{FF2B5EF4-FFF2-40B4-BE49-F238E27FC236}">
-                <a16:creationId xmlns:a16="http://schemas.microsoft.com/office/drawing/2014/main" id="{28B3B2FF-3CB5-7073-CB40-EC801130FF8B}"/>
+                <a16:creationId xmlns:a16="http://schemas.microsoft.com/office/drawing/2014/main" id="{14742C08-A86F-12C4-FABC-7FFEDE9E0E1E}"/>
               </a:ext>
             </a:extLst>
           </p:cNvPr>
@@ -1434,7 +1434,7 @@
           <p:cNvPr id="7" name="슬라이드 번호 개체 틀 6">
             <a:extLst>
               <a:ext uri="{FF2B5EF4-FFF2-40B4-BE49-F238E27FC236}">
-                <a16:creationId xmlns:a16="http://schemas.microsoft.com/office/drawing/2014/main" id="{81D9144A-3B4B-DDA8-666B-FCC81D47C3D5}"/>
+                <a16:creationId xmlns:a16="http://schemas.microsoft.com/office/drawing/2014/main" id="{2273C72F-D2BA-A44F-CAEA-1EE9A7441A9C}"/>
               </a:ext>
             </a:extLst>
           </p:cNvPr>
@@ -1450,7 +1450,7 @@
           <a:bodyPr/>
           <a:lstStyle/>
           <a:p>
-            <a:fld id="{FCE527D7-AC3E-4C2A-A377-10FA5A63B0EC}" type="slidenum">
+            <a:fld id="{A36E63EA-5A2B-431F-BF5E-3184E73FCB0D}" type="slidenum">
               <a:rPr lang="ko-KR" altLang="en-US" smtClean="0"/>
               <a:t>‹#›</a:t>
             </a:fld>
@@ -1461,7 +1461,7 @@
     </p:spTree>
     <p:extLst>
       <p:ext uri="{BB962C8B-B14F-4D97-AF65-F5344CB8AC3E}">
-        <p14:creationId xmlns:p14="http://schemas.microsoft.com/office/powerpoint/2010/main" val="493004599"/>
+        <p14:creationId xmlns:p14="http://schemas.microsoft.com/office/powerpoint/2010/main" val="1453668919"/>
       </p:ext>
     </p:extLst>
   </p:cSld>
@@ -1493,7 +1493,7 @@
           <p:cNvPr id="2" name="제목 1">
             <a:extLst>
               <a:ext uri="{FF2B5EF4-FFF2-40B4-BE49-F238E27FC236}">
-                <a16:creationId xmlns:a16="http://schemas.microsoft.com/office/drawing/2014/main" id="{783C95EE-4AC3-1789-1C07-AB94C077E526}"/>
+                <a16:creationId xmlns:a16="http://schemas.microsoft.com/office/drawing/2014/main" id="{A459F278-07E9-04B3-0A2B-2E451A66E657}"/>
               </a:ext>
             </a:extLst>
           </p:cNvPr>
@@ -1526,7 +1526,7 @@
           <p:cNvPr id="3" name="텍스트 개체 틀 2">
             <a:extLst>
               <a:ext uri="{FF2B5EF4-FFF2-40B4-BE49-F238E27FC236}">
-                <a16:creationId xmlns:a16="http://schemas.microsoft.com/office/drawing/2014/main" id="{E362E9F6-3854-5CFB-3F39-F6C93E2D8073}"/>
+                <a16:creationId xmlns:a16="http://schemas.microsoft.com/office/drawing/2014/main" id="{7EE2BF31-9FD8-0D7F-94EE-A02E6BEE812A}"/>
               </a:ext>
             </a:extLst>
           </p:cNvPr>
@@ -1597,7 +1597,7 @@
           <p:cNvPr id="4" name="내용 개체 틀 3">
             <a:extLst>
               <a:ext uri="{FF2B5EF4-FFF2-40B4-BE49-F238E27FC236}">
-                <a16:creationId xmlns:a16="http://schemas.microsoft.com/office/drawing/2014/main" id="{F6B547F6-D420-0E1D-2730-FD58B13669BF}"/>
+                <a16:creationId xmlns:a16="http://schemas.microsoft.com/office/drawing/2014/main" id="{D78D00AA-845D-988A-2E15-5B30CC039911}"/>
               </a:ext>
             </a:extLst>
           </p:cNvPr>
@@ -1659,7 +1659,7 @@
           <p:cNvPr id="5" name="텍스트 개체 틀 4">
             <a:extLst>
               <a:ext uri="{FF2B5EF4-FFF2-40B4-BE49-F238E27FC236}">
-                <a16:creationId xmlns:a16="http://schemas.microsoft.com/office/drawing/2014/main" id="{3F67708D-781A-05B3-950D-BA6BE370F70A}"/>
+                <a16:creationId xmlns:a16="http://schemas.microsoft.com/office/drawing/2014/main" id="{E312F72C-2A51-2B04-12CF-F617211D1DE7}"/>
               </a:ext>
             </a:extLst>
           </p:cNvPr>
@@ -1730,7 +1730,7 @@
           <p:cNvPr id="6" name="내용 개체 틀 5">
             <a:extLst>
               <a:ext uri="{FF2B5EF4-FFF2-40B4-BE49-F238E27FC236}">
-                <a16:creationId xmlns:a16="http://schemas.microsoft.com/office/drawing/2014/main" id="{315A6460-D23A-8EB0-6643-57AA472AAF8C}"/>
+                <a16:creationId xmlns:a16="http://schemas.microsoft.com/office/drawing/2014/main" id="{04183D2B-B9C0-6FA6-7BEC-57C7CFBB3B52}"/>
               </a:ext>
             </a:extLst>
           </p:cNvPr>
@@ -1792,7 +1792,7 @@
           <p:cNvPr id="7" name="날짜 개체 틀 6">
             <a:extLst>
               <a:ext uri="{FF2B5EF4-FFF2-40B4-BE49-F238E27FC236}">
-                <a16:creationId xmlns:a16="http://schemas.microsoft.com/office/drawing/2014/main" id="{216BCF9B-18C6-B400-0188-E7AB1EC9F8B5}"/>
+                <a16:creationId xmlns:a16="http://schemas.microsoft.com/office/drawing/2014/main" id="{A278BA29-BAAD-AB0F-EFCD-EF7910F238B6}"/>
               </a:ext>
             </a:extLst>
           </p:cNvPr>
@@ -1808,7 +1808,7 @@
           <a:bodyPr/>
           <a:lstStyle/>
           <a:p>
-            <a:fld id="{C7A2DD86-A6D0-4D7F-9460-517EC008A1FC}" type="datetimeFigureOut">
+            <a:fld id="{4EDDC4F2-F7BA-451D-AD65-B44D4A0691CB}" type="datetimeFigureOut">
               <a:rPr lang="ko-KR" altLang="en-US" smtClean="0"/>
               <a:t>2026-06-20</a:t>
             </a:fld>
@@ -1821,7 +1821,7 @@
           <p:cNvPr id="8" name="바닥글 개체 틀 7">
             <a:extLst>
               <a:ext uri="{FF2B5EF4-FFF2-40B4-BE49-F238E27FC236}">
-                <a16:creationId xmlns:a16="http://schemas.microsoft.com/office/drawing/2014/main" id="{F48EE727-1F5E-B705-905C-8BEBFDD3DB8D}"/>
+                <a16:creationId xmlns:a16="http://schemas.microsoft.com/office/drawing/2014/main" id="{BD84B081-E185-028F-698E-D65ACA44EE65}"/>
               </a:ext>
             </a:extLst>
           </p:cNvPr>
@@ -1846,7 +1846,7 @@
           <p:cNvPr id="9" name="슬라이드 번호 개체 틀 8">
             <a:extLst>
               <a:ext uri="{FF2B5EF4-FFF2-40B4-BE49-F238E27FC236}">
-                <a16:creationId xmlns:a16="http://schemas.microsoft.com/office/drawing/2014/main" id="{928C4C5E-007C-5EF0-F18A-EAFF851DC4EB}"/>
+                <a16:creationId xmlns:a16="http://schemas.microsoft.com/office/drawing/2014/main" id="{C845E1CA-4BB2-75C2-BAFB-D137E3274846}"/>
               </a:ext>
             </a:extLst>
           </p:cNvPr>
@@ -1862,7 +1862,7 @@
           <a:bodyPr/>
           <a:lstStyle/>
           <a:p>
-            <a:fld id="{FCE527D7-AC3E-4C2A-A377-10FA5A63B0EC}" type="slidenum">
+            <a:fld id="{A36E63EA-5A2B-431F-BF5E-3184E73FCB0D}" type="slidenum">
               <a:rPr lang="ko-KR" altLang="en-US" smtClean="0"/>
               <a:t>‹#›</a:t>
             </a:fld>
@@ -1873,7 +1873,7 @@
     </p:spTree>
     <p:extLst>
       <p:ext uri="{BB962C8B-B14F-4D97-AF65-F5344CB8AC3E}">
-        <p14:creationId xmlns:p14="http://schemas.microsoft.com/office/powerpoint/2010/main" val="738334856"/>
+        <p14:creationId xmlns:p14="http://schemas.microsoft.com/office/powerpoint/2010/main" val="1515704153"/>
       </p:ext>
     </p:extLst>
   </p:cSld>
@@ -1905,7 +1905,7 @@
           <p:cNvPr id="2" name="제목 1">
             <a:extLst>
               <a:ext uri="{FF2B5EF4-FFF2-40B4-BE49-F238E27FC236}">
-                <a16:creationId xmlns:a16="http://schemas.microsoft.com/office/drawing/2014/main" id="{0602FFFF-F315-33D8-F4CC-6CA1035C7909}"/>
+                <a16:creationId xmlns:a16="http://schemas.microsoft.com/office/drawing/2014/main" id="{D926C6CF-45C6-1B87-DCE9-C28454CD3B2B}"/>
               </a:ext>
             </a:extLst>
           </p:cNvPr>
@@ -1933,7 +1933,7 @@
           <p:cNvPr id="3" name="날짜 개체 틀 2">
             <a:extLst>
               <a:ext uri="{FF2B5EF4-FFF2-40B4-BE49-F238E27FC236}">
-                <a16:creationId xmlns:a16="http://schemas.microsoft.com/office/drawing/2014/main" id="{7AEFD362-6802-641B-305D-0B7DDD916D24}"/>
+                <a16:creationId xmlns:a16="http://schemas.microsoft.com/office/drawing/2014/main" id="{6C5380D6-5713-9D86-7946-6A4151D73670}"/>
               </a:ext>
             </a:extLst>
           </p:cNvPr>
@@ -1949,7 +1949,7 @@
           <a:bodyPr/>
           <a:lstStyle/>
           <a:p>
-            <a:fld id="{C7A2DD86-A6D0-4D7F-9460-517EC008A1FC}" type="datetimeFigureOut">
+            <a:fld id="{4EDDC4F2-F7BA-451D-AD65-B44D4A0691CB}" type="datetimeFigureOut">
               <a:rPr lang="ko-KR" altLang="en-US" smtClean="0"/>
               <a:t>2026-06-20</a:t>
             </a:fld>
@@ -1962,7 +1962,7 @@
           <p:cNvPr id="4" name="바닥글 개체 틀 3">
             <a:extLst>
               <a:ext uri="{FF2B5EF4-FFF2-40B4-BE49-F238E27FC236}">
-                <a16:creationId xmlns:a16="http://schemas.microsoft.com/office/drawing/2014/main" id="{86321183-CC82-E047-78E0-EE249C3CE405}"/>
+                <a16:creationId xmlns:a16="http://schemas.microsoft.com/office/drawing/2014/main" id="{8A4BA29F-605A-0760-261D-381DF9D4FA17}"/>
               </a:ext>
             </a:extLst>
           </p:cNvPr>
@@ -1987,7 +1987,7 @@
           <p:cNvPr id="5" name="슬라이드 번호 개체 틀 4">
             <a:extLst>
               <a:ext uri="{FF2B5EF4-FFF2-40B4-BE49-F238E27FC236}">
-                <a16:creationId xmlns:a16="http://schemas.microsoft.com/office/drawing/2014/main" id="{3B6778E2-3C22-D6E3-0D41-0BCE441FC32C}"/>
+                <a16:creationId xmlns:a16="http://schemas.microsoft.com/office/drawing/2014/main" id="{3AFA2730-F0B7-CD21-A8BD-79A5EA5A5961}"/>
               </a:ext>
             </a:extLst>
           </p:cNvPr>
@@ -2003,7 +2003,7 @@
           <a:bodyPr/>
           <a:lstStyle/>
           <a:p>
-            <a:fld id="{FCE527D7-AC3E-4C2A-A377-10FA5A63B0EC}" type="slidenum">
+            <a:fld id="{A36E63EA-5A2B-431F-BF5E-3184E73FCB0D}" type="slidenum">
               <a:rPr lang="ko-KR" altLang="en-US" smtClean="0"/>
               <a:t>‹#›</a:t>
             </a:fld>
@@ -2014,7 +2014,7 @@
     </p:spTree>
     <p:extLst>
       <p:ext uri="{BB962C8B-B14F-4D97-AF65-F5344CB8AC3E}">
-        <p14:creationId xmlns:p14="http://schemas.microsoft.com/office/powerpoint/2010/main" val="2282776537"/>
+        <p14:creationId xmlns:p14="http://schemas.microsoft.com/office/powerpoint/2010/main" val="2778200295"/>
       </p:ext>
     </p:extLst>
   </p:cSld>
@@ -2046,7 +2046,7 @@
           <p:cNvPr id="2" name="날짜 개체 틀 1">
             <a:extLst>
               <a:ext uri="{FF2B5EF4-FFF2-40B4-BE49-F238E27FC236}">
-                <a16:creationId xmlns:a16="http://schemas.microsoft.com/office/drawing/2014/main" id="{B3F24C52-FD90-7FA0-5B37-249F5E44CEB2}"/>
+                <a16:creationId xmlns:a16="http://schemas.microsoft.com/office/drawing/2014/main" id="{EE318CA7-0149-E025-899F-201036D0001A}"/>
               </a:ext>
             </a:extLst>
           </p:cNvPr>
@@ -2062,7 +2062,7 @@
           <a:bodyPr/>
           <a:lstStyle/>
           <a:p>
-            <a:fld id="{C7A2DD86-A6D0-4D7F-9460-517EC008A1FC}" type="datetimeFigureOut">
+            <a:fld id="{4EDDC4F2-F7BA-451D-AD65-B44D4A0691CB}" type="datetimeFigureOut">
               <a:rPr lang="ko-KR" altLang="en-US" smtClean="0"/>
               <a:t>2026-06-20</a:t>
             </a:fld>
@@ -2075,7 +2075,7 @@
           <p:cNvPr id="3" name="바닥글 개체 틀 2">
             <a:extLst>
               <a:ext uri="{FF2B5EF4-FFF2-40B4-BE49-F238E27FC236}">
-                <a16:creationId xmlns:a16="http://schemas.microsoft.com/office/drawing/2014/main" id="{99FC91CF-2140-A15E-0D22-FEB262C48385}"/>
+                <a16:creationId xmlns:a16="http://schemas.microsoft.com/office/drawing/2014/main" id="{08345A3A-DD72-3C75-EED8-75B84FD429FA}"/>
               </a:ext>
             </a:extLst>
           </p:cNvPr>
@@ -2100,7 +2100,7 @@
           <p:cNvPr id="4" name="슬라이드 번호 개체 틀 3">
             <a:extLst>
               <a:ext uri="{FF2B5EF4-FFF2-40B4-BE49-F238E27FC236}">
-                <a16:creationId xmlns:a16="http://schemas.microsoft.com/office/drawing/2014/main" id="{35A378C8-4675-A6CD-4D62-C2F684F37488}"/>
+                <a16:creationId xmlns:a16="http://schemas.microsoft.com/office/drawing/2014/main" id="{03105AAE-2DEF-92FE-8772-E941873B57E1}"/>
               </a:ext>
             </a:extLst>
           </p:cNvPr>
@@ -2116,7 +2116,7 @@
           <a:bodyPr/>
           <a:lstStyle/>
           <a:p>
-            <a:fld id="{FCE527D7-AC3E-4C2A-A377-10FA5A63B0EC}" type="slidenum">
+            <a:fld id="{A36E63EA-5A2B-431F-BF5E-3184E73FCB0D}" type="slidenum">
               <a:rPr lang="ko-KR" altLang="en-US" smtClean="0"/>
               <a:t>‹#›</a:t>
             </a:fld>
@@ -2127,7 +2127,7 @@
     </p:spTree>
     <p:extLst>
       <p:ext uri="{BB962C8B-B14F-4D97-AF65-F5344CB8AC3E}">
-        <p14:creationId xmlns:p14="http://schemas.microsoft.com/office/powerpoint/2010/main" val="630287698"/>
+        <p14:creationId xmlns:p14="http://schemas.microsoft.com/office/powerpoint/2010/main" val="2524690840"/>
       </p:ext>
     </p:extLst>
   </p:cSld>
@@ -2159,7 +2159,7 @@
           <p:cNvPr id="2" name="제목 1">
             <a:extLst>
               <a:ext uri="{FF2B5EF4-FFF2-40B4-BE49-F238E27FC236}">
-                <a16:creationId xmlns:a16="http://schemas.microsoft.com/office/drawing/2014/main" id="{0449B2F0-0B17-FA76-CD3F-2166E47CA782}"/>
+                <a16:creationId xmlns:a16="http://schemas.microsoft.com/office/drawing/2014/main" id="{7A886FE6-26E0-7DD3-483E-DA79F7855728}"/>
               </a:ext>
             </a:extLst>
           </p:cNvPr>
@@ -2196,7 +2196,7 @@
           <p:cNvPr id="3" name="내용 개체 틀 2">
             <a:extLst>
               <a:ext uri="{FF2B5EF4-FFF2-40B4-BE49-F238E27FC236}">
-                <a16:creationId xmlns:a16="http://schemas.microsoft.com/office/drawing/2014/main" id="{605648D6-19C2-5C90-EFD4-9DA4F57821F3}"/>
+                <a16:creationId xmlns:a16="http://schemas.microsoft.com/office/drawing/2014/main" id="{14CCC68F-6AE8-AB5F-9008-4CB5C4E62F49}"/>
               </a:ext>
             </a:extLst>
           </p:cNvPr>
@@ -2286,7 +2286,7 @@
           <p:cNvPr id="4" name="텍스트 개체 틀 3">
             <a:extLst>
               <a:ext uri="{FF2B5EF4-FFF2-40B4-BE49-F238E27FC236}">
-                <a16:creationId xmlns:a16="http://schemas.microsoft.com/office/drawing/2014/main" id="{D7202582-513D-5C88-626C-BA8200A9170B}"/>
+                <a16:creationId xmlns:a16="http://schemas.microsoft.com/office/drawing/2014/main" id="{24F4DD3D-B5BB-142D-099E-650F275DD6A9}"/>
               </a:ext>
             </a:extLst>
           </p:cNvPr>
@@ -2357,7 +2357,7 @@
           <p:cNvPr id="5" name="날짜 개체 틀 4">
             <a:extLst>
               <a:ext uri="{FF2B5EF4-FFF2-40B4-BE49-F238E27FC236}">
-                <a16:creationId xmlns:a16="http://schemas.microsoft.com/office/drawing/2014/main" id="{E87D2C64-2914-63C8-9246-0E25E41483E9}"/>
+                <a16:creationId xmlns:a16="http://schemas.microsoft.com/office/drawing/2014/main" id="{7F387B83-2C5A-80A3-C1A4-C58249FCED4A}"/>
               </a:ext>
             </a:extLst>
           </p:cNvPr>
@@ -2373,7 +2373,7 @@
           <a:bodyPr/>
           <a:lstStyle/>
           <a:p>
-            <a:fld id="{C7A2DD86-A6D0-4D7F-9460-517EC008A1FC}" type="datetimeFigureOut">
+            <a:fld id="{4EDDC4F2-F7BA-451D-AD65-B44D4A0691CB}" type="datetimeFigureOut">
               <a:rPr lang="ko-KR" altLang="en-US" smtClean="0"/>
               <a:t>2026-06-20</a:t>
             </a:fld>
@@ -2386,7 +2386,7 @@
           <p:cNvPr id="6" name="바닥글 개체 틀 5">
             <a:extLst>
               <a:ext uri="{FF2B5EF4-FFF2-40B4-BE49-F238E27FC236}">
-                <a16:creationId xmlns:a16="http://schemas.microsoft.com/office/drawing/2014/main" id="{AD2064E1-6D91-1DA3-D17D-A53B8C352A20}"/>
+                <a16:creationId xmlns:a16="http://schemas.microsoft.com/office/drawing/2014/main" id="{6DAB2AC0-16F7-70F5-6786-9066B8E078C2}"/>
               </a:ext>
             </a:extLst>
           </p:cNvPr>
@@ -2411,7 +2411,7 @@
           <p:cNvPr id="7" name="슬라이드 번호 개체 틀 6">
             <a:extLst>
               <a:ext uri="{FF2B5EF4-FFF2-40B4-BE49-F238E27FC236}">
-                <a16:creationId xmlns:a16="http://schemas.microsoft.com/office/drawing/2014/main" id="{BFD6E679-D03D-637F-C8D0-A798653FE569}"/>
+                <a16:creationId xmlns:a16="http://schemas.microsoft.com/office/drawing/2014/main" id="{41A48463-C170-CC84-F3BF-A9FBD02DA261}"/>
               </a:ext>
             </a:extLst>
           </p:cNvPr>
@@ -2427,7 +2427,7 @@
           <a:bodyPr/>
           <a:lstStyle/>
           <a:p>
-            <a:fld id="{FCE527D7-AC3E-4C2A-A377-10FA5A63B0EC}" type="slidenum">
+            <a:fld id="{A36E63EA-5A2B-431F-BF5E-3184E73FCB0D}" type="slidenum">
               <a:rPr lang="ko-KR" altLang="en-US" smtClean="0"/>
               <a:t>‹#›</a:t>
             </a:fld>
@@ -2438,7 +2438,7 @@
     </p:spTree>
     <p:extLst>
       <p:ext uri="{BB962C8B-B14F-4D97-AF65-F5344CB8AC3E}">
-        <p14:creationId xmlns:p14="http://schemas.microsoft.com/office/powerpoint/2010/main" val="2595109787"/>
+        <p14:creationId xmlns:p14="http://schemas.microsoft.com/office/powerpoint/2010/main" val="620806793"/>
       </p:ext>
     </p:extLst>
   </p:cSld>
@@ -2470,7 +2470,7 @@
           <p:cNvPr id="2" name="제목 1">
             <a:extLst>
               <a:ext uri="{FF2B5EF4-FFF2-40B4-BE49-F238E27FC236}">
-                <a16:creationId xmlns:a16="http://schemas.microsoft.com/office/drawing/2014/main" id="{D495988F-C569-76E7-1A40-6DAB13E279B8}"/>
+                <a16:creationId xmlns:a16="http://schemas.microsoft.com/office/drawing/2014/main" id="{2B45A392-D8F7-D638-0A79-276B0680E6DB}"/>
               </a:ext>
             </a:extLst>
           </p:cNvPr>
@@ -2507,7 +2507,7 @@
           <p:cNvPr id="3" name="그림 개체 틀 2">
             <a:extLst>
               <a:ext uri="{FF2B5EF4-FFF2-40B4-BE49-F238E27FC236}">
-                <a16:creationId xmlns:a16="http://schemas.microsoft.com/office/drawing/2014/main" id="{35E4056D-3211-B208-9FB4-3F6EFCE5EC0A}"/>
+                <a16:creationId xmlns:a16="http://schemas.microsoft.com/office/drawing/2014/main" id="{A7DCD1B5-E5AD-21A4-CAD5-F4C761963597}"/>
               </a:ext>
             </a:extLst>
           </p:cNvPr>
@@ -2574,7 +2574,7 @@
           <p:cNvPr id="4" name="텍스트 개체 틀 3">
             <a:extLst>
               <a:ext uri="{FF2B5EF4-FFF2-40B4-BE49-F238E27FC236}">
-                <a16:creationId xmlns:a16="http://schemas.microsoft.com/office/drawing/2014/main" id="{D968AE31-E146-1C7E-61FF-309BE58E9781}"/>
+                <a16:creationId xmlns:a16="http://schemas.microsoft.com/office/drawing/2014/main" id="{5D7FCA1F-4461-4E41-C9EA-45427E86EC59}"/>
               </a:ext>
             </a:extLst>
           </p:cNvPr>
@@ -2645,7 +2645,7 @@
           <p:cNvPr id="5" name="날짜 개체 틀 4">
             <a:extLst>
               <a:ext uri="{FF2B5EF4-FFF2-40B4-BE49-F238E27FC236}">
-                <a16:creationId xmlns:a16="http://schemas.microsoft.com/office/drawing/2014/main" id="{637F5C53-8233-88AB-94DA-3F36426BB37F}"/>
+                <a16:creationId xmlns:a16="http://schemas.microsoft.com/office/drawing/2014/main" id="{B08A715F-ECA3-7205-08F0-99EEB9DF18AC}"/>
               </a:ext>
             </a:extLst>
           </p:cNvPr>
@@ -2661,7 +2661,7 @@
           <a:bodyPr/>
           <a:lstStyle/>
           <a:p>
-            <a:fld id="{C7A2DD86-A6D0-4D7F-9460-517EC008A1FC}" type="datetimeFigureOut">
+            <a:fld id="{4EDDC4F2-F7BA-451D-AD65-B44D4A0691CB}" type="datetimeFigureOut">
               <a:rPr lang="ko-KR" altLang="en-US" smtClean="0"/>
               <a:t>2026-06-20</a:t>
             </a:fld>
@@ -2674,7 +2674,7 @@
           <p:cNvPr id="6" name="바닥글 개체 틀 5">
             <a:extLst>
               <a:ext uri="{FF2B5EF4-FFF2-40B4-BE49-F238E27FC236}">
-                <a16:creationId xmlns:a16="http://schemas.microsoft.com/office/drawing/2014/main" id="{70D677E0-F05C-3246-7C17-ADAC3FFAFD35}"/>
+                <a16:creationId xmlns:a16="http://schemas.microsoft.com/office/drawing/2014/main" id="{CB8DE82C-3EE2-DCF9-F80C-D3B696BAEFCB}"/>
               </a:ext>
             </a:extLst>
           </p:cNvPr>
@@ -2699,7 +2699,7 @@
           <p:cNvPr id="7" name="슬라이드 번호 개체 틀 6">
             <a:extLst>
               <a:ext uri="{FF2B5EF4-FFF2-40B4-BE49-F238E27FC236}">
-                <a16:creationId xmlns:a16="http://schemas.microsoft.com/office/drawing/2014/main" id="{7B44CE93-A8EB-4AE8-EDB2-C01FC784DAB2}"/>
+                <a16:creationId xmlns:a16="http://schemas.microsoft.com/office/drawing/2014/main" id="{2482DE60-FA84-C95B-73AA-4D962B3B283A}"/>
               </a:ext>
             </a:extLst>
           </p:cNvPr>
@@ -2715,7 +2715,7 @@
           <a:bodyPr/>
           <a:lstStyle/>
           <a:p>
-            <a:fld id="{FCE527D7-AC3E-4C2A-A377-10FA5A63B0EC}" type="slidenum">
+            <a:fld id="{A36E63EA-5A2B-431F-BF5E-3184E73FCB0D}" type="slidenum">
               <a:rPr lang="ko-KR" altLang="en-US" smtClean="0"/>
               <a:t>‹#›</a:t>
             </a:fld>
@@ -2726,7 +2726,7 @@
     </p:spTree>
     <p:extLst>
       <p:ext uri="{BB962C8B-B14F-4D97-AF65-F5344CB8AC3E}">
-        <p14:creationId xmlns:p14="http://schemas.microsoft.com/office/powerpoint/2010/main" val="2179983072"/>
+        <p14:creationId xmlns:p14="http://schemas.microsoft.com/office/powerpoint/2010/main" val="2412212217"/>
       </p:ext>
     </p:extLst>
   </p:cSld>
@@ -2763,7 +2763,7 @@
           <p:cNvPr id="2" name="제목 개체 틀 1">
             <a:extLst>
               <a:ext uri="{FF2B5EF4-FFF2-40B4-BE49-F238E27FC236}">
-                <a16:creationId xmlns:a16="http://schemas.microsoft.com/office/drawing/2014/main" id="{F21EBD62-315F-C814-8EDC-6F994CB0B734}"/>
+                <a16:creationId xmlns:a16="http://schemas.microsoft.com/office/drawing/2014/main" id="{94020524-9A6A-93A4-3A68-396B50135762}"/>
               </a:ext>
             </a:extLst>
           </p:cNvPr>
@@ -2801,7 +2801,7 @@
           <p:cNvPr id="3" name="텍스트 개체 틀 2">
             <a:extLst>
               <a:ext uri="{FF2B5EF4-FFF2-40B4-BE49-F238E27FC236}">
-                <a16:creationId xmlns:a16="http://schemas.microsoft.com/office/drawing/2014/main" id="{98F1E854-C3D2-469A-9399-FFDB1B718E3F}"/>
+                <a16:creationId xmlns:a16="http://schemas.microsoft.com/office/drawing/2014/main" id="{85AB9161-B742-5DC8-DFDD-AD7378577796}"/>
               </a:ext>
             </a:extLst>
           </p:cNvPr>
@@ -2868,7 +2868,7 @@
           <p:cNvPr id="4" name="날짜 개체 틀 3">
             <a:extLst>
               <a:ext uri="{FF2B5EF4-FFF2-40B4-BE49-F238E27FC236}">
-                <a16:creationId xmlns:a16="http://schemas.microsoft.com/office/drawing/2014/main" id="{E21CF47B-8AF6-0612-5315-559C5674103F}"/>
+                <a16:creationId xmlns:a16="http://schemas.microsoft.com/office/drawing/2014/main" id="{F7B4E9E1-BF57-7B6D-7475-363EA253E2E8}"/>
               </a:ext>
             </a:extLst>
           </p:cNvPr>
@@ -2902,7 +2902,7 @@
             </a:lvl1pPr>
           </a:lstStyle>
           <a:p>
-            <a:fld id="{C7A2DD86-A6D0-4D7F-9460-517EC008A1FC}" type="datetimeFigureOut">
+            <a:fld id="{4EDDC4F2-F7BA-451D-AD65-B44D4A0691CB}" type="datetimeFigureOut">
               <a:rPr lang="ko-KR" altLang="en-US" smtClean="0"/>
               <a:t>2026-06-20</a:t>
             </a:fld>
@@ -2915,7 +2915,7 @@
           <p:cNvPr id="5" name="바닥글 개체 틀 4">
             <a:extLst>
               <a:ext uri="{FF2B5EF4-FFF2-40B4-BE49-F238E27FC236}">
-                <a16:creationId xmlns:a16="http://schemas.microsoft.com/office/drawing/2014/main" id="{4A289A9F-D007-4844-FE76-CC496EB5E998}"/>
+                <a16:creationId xmlns:a16="http://schemas.microsoft.com/office/drawing/2014/main" id="{D24513F7-FA78-6767-CE7F-EAA4726BF0FB}"/>
               </a:ext>
             </a:extLst>
           </p:cNvPr>
@@ -2958,7 +2958,7 @@
           <p:cNvPr id="6" name="슬라이드 번호 개체 틀 5">
             <a:extLst>
               <a:ext uri="{FF2B5EF4-FFF2-40B4-BE49-F238E27FC236}">
-                <a16:creationId xmlns:a16="http://schemas.microsoft.com/office/drawing/2014/main" id="{8DB4F75F-98D5-671E-B8D2-02A98EA6252F}"/>
+                <a16:creationId xmlns:a16="http://schemas.microsoft.com/office/drawing/2014/main" id="{BBC2EEC4-B8ED-969F-533F-A4C54549DA10}"/>
               </a:ext>
             </a:extLst>
           </p:cNvPr>
@@ -2992,7 +2992,7 @@
             </a:lvl1pPr>
           </a:lstStyle>
           <a:p>
-            <a:fld id="{FCE527D7-AC3E-4C2A-A377-10FA5A63B0EC}" type="slidenum">
+            <a:fld id="{A36E63EA-5A2B-431F-BF5E-3184E73FCB0D}" type="slidenum">
               <a:rPr lang="ko-KR" altLang="en-US" smtClean="0"/>
               <a:t>‹#›</a:t>
             </a:fld>
@@ -3003,7 +3003,7 @@
     </p:spTree>
     <p:extLst>
       <p:ext uri="{BB962C8B-B14F-4D97-AF65-F5344CB8AC3E}">
-        <p14:creationId xmlns:p14="http://schemas.microsoft.com/office/powerpoint/2010/main" val="1183363630"/>
+        <p14:creationId xmlns:p14="http://schemas.microsoft.com/office/powerpoint/2010/main" val="2103855178"/>
       </p:ext>
     </p:extLst>
   </p:cSld>
@@ -3326,7 +3326,7 @@
           <p:cNvPr id="2" name="z00_grid_top">
             <a:extLst>
               <a:ext uri="{FF2B5EF4-FFF2-40B4-BE49-F238E27FC236}">
-                <a16:creationId xmlns:a16="http://schemas.microsoft.com/office/drawing/2014/main" id="{54103CB4-1F7D-1488-C315-9001ABFEEDB1}"/>
+                <a16:creationId xmlns:a16="http://schemas.microsoft.com/office/drawing/2014/main" id="{F75B49F6-10AF-3B2B-18DA-60CE6A2D9597}"/>
               </a:ext>
             </a:extLst>
           </p:cNvPr>
@@ -3369,7 +3369,7 @@
           <p:cNvPr id="3" name="z00_grid_bottom">
             <a:extLst>
               <a:ext uri="{FF2B5EF4-FFF2-40B4-BE49-F238E27FC236}">
-                <a16:creationId xmlns:a16="http://schemas.microsoft.com/office/drawing/2014/main" id="{976757FB-F7A7-7C75-F441-550C6C174258}"/>
+                <a16:creationId xmlns:a16="http://schemas.microsoft.com/office/drawing/2014/main" id="{F9BDCD24-E878-1E6D-57D2-79FE5A1FA100}"/>
               </a:ext>
             </a:extLst>
           </p:cNvPr>
@@ -3412,7 +3412,7 @@
           <p:cNvPr id="4" name="z00_grid_v_0">
             <a:extLst>
               <a:ext uri="{FF2B5EF4-FFF2-40B4-BE49-F238E27FC236}">
-                <a16:creationId xmlns:a16="http://schemas.microsoft.com/office/drawing/2014/main" id="{84F1C7E9-613C-8E59-3689-CC7AF91E0959}"/>
+                <a16:creationId xmlns:a16="http://schemas.microsoft.com/office/drawing/2014/main" id="{61B5C174-25B8-F190-EB19-EFD692BD20D6}"/>
               </a:ext>
             </a:extLst>
           </p:cNvPr>
@@ -3421,7 +3421,7 @@
         </p:nvCxnSpPr>
         <p:spPr>
           <a:xfrm>
-            <a:off x="3309174" y="1099085"/>
+            <a:off x="3330945" y="1099085"/>
             <a:ext cx="0" cy="4317833"/>
           </a:xfrm>
           <a:prstGeom prst="line">
@@ -3455,7 +3455,7 @@
           <p:cNvPr id="5" name="z00_grid_v_1">
             <a:extLst>
               <a:ext uri="{FF2B5EF4-FFF2-40B4-BE49-F238E27FC236}">
-                <a16:creationId xmlns:a16="http://schemas.microsoft.com/office/drawing/2014/main" id="{09A9CB6A-86C3-4BF5-6362-64AD612FBADA}"/>
+                <a16:creationId xmlns:a16="http://schemas.microsoft.com/office/drawing/2014/main" id="{FEE66A0B-6F04-7E0C-7C5A-12D4488FFFEB}"/>
               </a:ext>
             </a:extLst>
           </p:cNvPr>
@@ -3464,7 +3464,7 @@
         </p:nvCxnSpPr>
         <p:spPr>
           <a:xfrm>
-            <a:off x="6008764" y="1099085"/>
+            <a:off x="5838951" y="1099085"/>
             <a:ext cx="0" cy="4317833"/>
           </a:xfrm>
           <a:prstGeom prst="line">
@@ -3498,7 +3498,7 @@
           <p:cNvPr id="6" name="z00_grid_v_2">
             <a:extLst>
               <a:ext uri="{FF2B5EF4-FFF2-40B4-BE49-F238E27FC236}">
-                <a16:creationId xmlns:a16="http://schemas.microsoft.com/office/drawing/2014/main" id="{D32B3094-48FE-7636-64BF-F965D56F4889}"/>
+                <a16:creationId xmlns:a16="http://schemas.microsoft.com/office/drawing/2014/main" id="{0160707E-DE34-4B2D-B853-45DA71B465C8}"/>
               </a:ext>
             </a:extLst>
           </p:cNvPr>
@@ -3507,7 +3507,7 @@
         </p:nvCxnSpPr>
         <p:spPr>
           <a:xfrm>
-            <a:off x="9614022" y="1099085"/>
+            <a:off x="9857856" y="1099085"/>
             <a:ext cx="0" cy="4317833"/>
           </a:xfrm>
           <a:prstGeom prst="line">
@@ -3541,7 +3541,7 @@
           <p:cNvPr id="7" name="header_title">
             <a:extLst>
               <a:ext uri="{FF2B5EF4-FFF2-40B4-BE49-F238E27FC236}">
-                <a16:creationId xmlns:a16="http://schemas.microsoft.com/office/drawing/2014/main" id="{D36508D1-A028-B71B-F85B-241A3DE2B6FF}"/>
+                <a16:creationId xmlns:a16="http://schemas.microsoft.com/office/drawing/2014/main" id="{DCF8E862-B97B-32F4-B276-03D57F8BF580}"/>
               </a:ext>
             </a:extLst>
           </p:cNvPr>
@@ -3551,7 +3551,7 @@
         <p:spPr>
           <a:xfrm>
             <a:off x="592168" y="401253"/>
-            <a:ext cx="7140850" cy="285806"/>
+            <a:ext cx="7140850" cy="294615"/>
           </a:xfrm>
           <a:prstGeom prst="rect">
             <a:avLst/>
@@ -3559,7 +3559,7 @@
           <a:noFill/>
         </p:spPr>
         <p:txBody>
-          <a:bodyPr vert="horz" wrap="square" lIns="8708" tIns="4361" rIns="8708" bIns="4361" rtlCol="0" anchor="ctr">
+          <a:bodyPr vert="horz" wrap="square" lIns="8708" tIns="8723" rIns="8708" bIns="8723" rtlCol="0" anchor="ctr">
             <a:noAutofit/>
           </a:bodyPr>
           <a:lstStyle/>
@@ -3587,7 +3587,7 @@
           <p:cNvPr id="8" name="header_subtitle">
             <a:extLst>
               <a:ext uri="{FF2B5EF4-FFF2-40B4-BE49-F238E27FC236}">
-                <a16:creationId xmlns:a16="http://schemas.microsoft.com/office/drawing/2014/main" id="{8A7A8773-5025-E21A-B0A0-AE6F28CF6803}"/>
+                <a16:creationId xmlns:a16="http://schemas.microsoft.com/office/drawing/2014/main" id="{D638691B-1148-E7AA-5E6A-4CFD96768B0C}"/>
               </a:ext>
             </a:extLst>
           </p:cNvPr>
@@ -3597,7 +3597,7 @@
         <p:spPr>
           <a:xfrm>
             <a:off x="592168" y="785061"/>
-            <a:ext cx="10188774" cy="285806"/>
+            <a:ext cx="10188774" cy="294615"/>
           </a:xfrm>
           <a:prstGeom prst="rect">
             <a:avLst/>
@@ -3605,7 +3605,7 @@
           <a:noFill/>
         </p:spPr>
         <p:txBody>
-          <a:bodyPr vert="horz" wrap="square" lIns="8708" tIns="4361" rIns="8708" bIns="4361" rtlCol="0" anchor="ctr">
+          <a:bodyPr vert="horz" wrap="square" lIns="8708" tIns="8723" rIns="8708" bIns="8723" rtlCol="0" anchor="ctr">
             <a:noAutofit/>
           </a:bodyPr>
           <a:lstStyle/>
@@ -3633,7 +3633,7 @@
           <p:cNvPr id="9" name="zone_content_panel">
             <a:extLst>
               <a:ext uri="{FF2B5EF4-FFF2-40B4-BE49-F238E27FC236}">
-                <a16:creationId xmlns:a16="http://schemas.microsoft.com/office/drawing/2014/main" id="{A5ABF89C-616D-8BE4-F8D5-9081F329B142}"/>
+                <a16:creationId xmlns:a16="http://schemas.microsoft.com/office/drawing/2014/main" id="{66E62231-A030-65D6-0646-4923E69855D1}"/>
               </a:ext>
             </a:extLst>
           </p:cNvPr>
@@ -3646,7 +3646,9 @@
             <a:ext cx="2438339" cy="3750845"/>
           </a:xfrm>
           <a:prstGeom prst="roundRect">
-            <a:avLst/>
+            <a:avLst>
+              <a:gd name="adj" fmla="val 5714"/>
+            </a:avLst>
           </a:prstGeom>
           <a:solidFill>
             <a:srgbClr val="EEF4EF"/>
@@ -3694,7 +3696,7 @@
           <p:cNvPr id="10" name="zone_content_title">
             <a:extLst>
               <a:ext uri="{FF2B5EF4-FFF2-40B4-BE49-F238E27FC236}">
-                <a16:creationId xmlns:a16="http://schemas.microsoft.com/office/drawing/2014/main" id="{76ACBE98-9D74-F96E-FBB7-D693D73FA15F}"/>
+                <a16:creationId xmlns:a16="http://schemas.microsoft.com/office/drawing/2014/main" id="{B2649A5D-0348-B0A5-D9E5-A989D5E8F5F8}"/>
               </a:ext>
             </a:extLst>
           </p:cNvPr>
@@ -3703,8 +3705,8 @@
         </p:nvSpPr>
         <p:spPr>
           <a:xfrm>
-            <a:off x="975336" y="1526507"/>
-            <a:ext cx="2055171" cy="285806"/>
+            <a:off x="992752" y="1517784"/>
+            <a:ext cx="2020338" cy="276999"/>
           </a:xfrm>
           <a:prstGeom prst="rect">
             <a:avLst/>
@@ -3712,7 +3714,7 @@
           <a:noFill/>
         </p:spPr>
         <p:txBody>
-          <a:bodyPr vert="horz" wrap="square" lIns="8708" tIns="4361" rIns="8708" bIns="4361" rtlCol="0" anchor="t">
+          <a:bodyPr vert="horz" wrap="square" lIns="0" tIns="0" rIns="0" bIns="0" rtlCol="0" anchor="ctr">
             <a:noAutofit/>
           </a:bodyPr>
           <a:lstStyle/>
@@ -3740,7 +3742,7 @@
           <p:cNvPr id="11" name="zone_content_subtitle">
             <a:extLst>
               <a:ext uri="{FF2B5EF4-FFF2-40B4-BE49-F238E27FC236}">
-                <a16:creationId xmlns:a16="http://schemas.microsoft.com/office/drawing/2014/main" id="{16F65B18-67B0-3457-53E2-FB4D6DAD11EE}"/>
+                <a16:creationId xmlns:a16="http://schemas.microsoft.com/office/drawing/2014/main" id="{CB1A33F0-A039-6F33-3C24-057505DC2DE0}"/>
               </a:ext>
             </a:extLst>
           </p:cNvPr>
@@ -3749,8 +3751,8 @@
         </p:nvSpPr>
         <p:spPr>
           <a:xfrm>
-            <a:off x="975336" y="1831808"/>
-            <a:ext cx="2055171" cy="285806"/>
+            <a:off x="992752" y="1814362"/>
+            <a:ext cx="2020338" cy="276999"/>
           </a:xfrm>
           <a:prstGeom prst="rect">
             <a:avLst/>
@@ -3758,7 +3760,7 @@
           <a:noFill/>
         </p:spPr>
         <p:txBody>
-          <a:bodyPr vert="horz" wrap="square" lIns="8708" tIns="4361" rIns="8708" bIns="4361" rtlCol="0" anchor="t">
+          <a:bodyPr vert="horz" wrap="square" lIns="0" tIns="0" rIns="0" bIns="0" rtlCol="0" anchor="ctr">
             <a:noAutofit/>
           </a:bodyPr>
           <a:lstStyle/>
@@ -3786,7 +3788,7 @@
           <p:cNvPr id="12" name="zone_reasoning_panel">
             <a:extLst>
               <a:ext uri="{FF2B5EF4-FFF2-40B4-BE49-F238E27FC236}">
-                <a16:creationId xmlns:a16="http://schemas.microsoft.com/office/drawing/2014/main" id="{128B5867-FC85-F3FA-41E7-B69131F4E153}"/>
+                <a16:creationId xmlns:a16="http://schemas.microsoft.com/office/drawing/2014/main" id="{2CB6DF17-9DBC-A3F5-CC17-0C0F529578B2}"/>
               </a:ext>
             </a:extLst>
           </p:cNvPr>
@@ -3799,7 +3801,9 @@
             <a:ext cx="2351255" cy="3750845"/>
           </a:xfrm>
           <a:prstGeom prst="roundRect">
-            <a:avLst/>
+            <a:avLst>
+              <a:gd name="adj" fmla="val 5926"/>
+            </a:avLst>
           </a:prstGeom>
           <a:solidFill>
             <a:srgbClr val="FFF3DE"/>
@@ -3847,7 +3851,7 @@
           <p:cNvPr id="13" name="zone_reasoning_title">
             <a:extLst>
               <a:ext uri="{FF2B5EF4-FFF2-40B4-BE49-F238E27FC236}">
-                <a16:creationId xmlns:a16="http://schemas.microsoft.com/office/drawing/2014/main" id="{A8B1091A-DD66-FCAB-1975-4F2199A6EC90}"/>
+                <a16:creationId xmlns:a16="http://schemas.microsoft.com/office/drawing/2014/main" id="{238A5CEE-B549-27DD-935E-AFDE2111F6DD}"/>
               </a:ext>
             </a:extLst>
           </p:cNvPr>
@@ -3856,8 +3860,8 @@
         </p:nvSpPr>
         <p:spPr>
           <a:xfrm>
-            <a:off x="3631383" y="1526507"/>
-            <a:ext cx="1968088" cy="285806"/>
+            <a:off x="3648800" y="1517784"/>
+            <a:ext cx="1933254" cy="276999"/>
           </a:xfrm>
           <a:prstGeom prst="rect">
             <a:avLst/>
@@ -3865,7 +3869,7 @@
           <a:noFill/>
         </p:spPr>
         <p:txBody>
-          <a:bodyPr vert="horz" wrap="square" lIns="8708" tIns="4361" rIns="8708" bIns="4361" rtlCol="0" anchor="t">
+          <a:bodyPr vert="horz" wrap="square" lIns="0" tIns="0" rIns="0" bIns="0" rtlCol="0" anchor="ctr">
             <a:noAutofit/>
           </a:bodyPr>
           <a:lstStyle/>
@@ -3893,7 +3897,7 @@
           <p:cNvPr id="14" name="zone_reasoning_subtitle">
             <a:extLst>
               <a:ext uri="{FF2B5EF4-FFF2-40B4-BE49-F238E27FC236}">
-                <a16:creationId xmlns:a16="http://schemas.microsoft.com/office/drawing/2014/main" id="{D79D12BD-817A-05E4-3907-77BCD3286116}"/>
+                <a16:creationId xmlns:a16="http://schemas.microsoft.com/office/drawing/2014/main" id="{7FB4E32E-F3F5-8D9A-E61B-127FC6EC41EC}"/>
               </a:ext>
             </a:extLst>
           </p:cNvPr>
@@ -3902,8 +3906,8 @@
         </p:nvSpPr>
         <p:spPr>
           <a:xfrm>
-            <a:off x="3631383" y="1831808"/>
-            <a:ext cx="1968088" cy="285806"/>
+            <a:off x="3648800" y="1814362"/>
+            <a:ext cx="1933254" cy="276999"/>
           </a:xfrm>
           <a:prstGeom prst="rect">
             <a:avLst/>
@@ -3911,7 +3915,7 @@
           <a:noFill/>
         </p:spPr>
         <p:txBody>
-          <a:bodyPr vert="horz" wrap="square" lIns="8708" tIns="4361" rIns="8708" bIns="4361" rtlCol="0" anchor="t">
+          <a:bodyPr vert="horz" wrap="square" lIns="0" tIns="0" rIns="0" bIns="0" rtlCol="0" anchor="ctr">
             <a:noAutofit/>
           </a:bodyPr>
           <a:lstStyle/>
@@ -3939,7 +3943,7 @@
           <p:cNvPr id="15" name="zone_rules_panel">
             <a:extLst>
               <a:ext uri="{FF2B5EF4-FFF2-40B4-BE49-F238E27FC236}">
-                <a16:creationId xmlns:a16="http://schemas.microsoft.com/office/drawing/2014/main" id="{4660DD83-1533-8400-D021-0D02CC9D0F56}"/>
+                <a16:creationId xmlns:a16="http://schemas.microsoft.com/office/drawing/2014/main" id="{D63A546A-ABC7-6EC9-0B35-E83274EE4C60}"/>
               </a:ext>
             </a:extLst>
           </p:cNvPr>
@@ -3952,7 +3956,9 @@
             <a:ext cx="3901343" cy="3750845"/>
           </a:xfrm>
           <a:prstGeom prst="roundRect">
-            <a:avLst/>
+            <a:avLst>
+              <a:gd name="adj" fmla="val 3715"/>
+            </a:avLst>
           </a:prstGeom>
           <a:solidFill>
             <a:srgbClr val="EAF7F3"/>
@@ -4000,7 +4006,7 @@
           <p:cNvPr id="16" name="zone_rules_title">
             <a:extLst>
               <a:ext uri="{FF2B5EF4-FFF2-40B4-BE49-F238E27FC236}">
-                <a16:creationId xmlns:a16="http://schemas.microsoft.com/office/drawing/2014/main" id="{1B592876-AA67-1867-D43E-08FEFE55A467}"/>
+                <a16:creationId xmlns:a16="http://schemas.microsoft.com/office/drawing/2014/main" id="{CF148F85-4B6E-454E-7CC7-1DFFBBF1FA45}"/>
               </a:ext>
             </a:extLst>
           </p:cNvPr>
@@ -4009,8 +4015,8 @@
         </p:nvSpPr>
         <p:spPr>
           <a:xfrm>
-            <a:off x="6078431" y="1526507"/>
-            <a:ext cx="3518175" cy="285806"/>
+            <a:off x="6095848" y="1517784"/>
+            <a:ext cx="3483342" cy="276999"/>
           </a:xfrm>
           <a:prstGeom prst="rect">
             <a:avLst/>
@@ -4018,7 +4024,7 @@
           <a:noFill/>
         </p:spPr>
         <p:txBody>
-          <a:bodyPr vert="horz" wrap="square" lIns="8708" tIns="4361" rIns="8708" bIns="4361" rtlCol="0" anchor="t">
+          <a:bodyPr vert="horz" wrap="square" lIns="0" tIns="0" rIns="0" bIns="0" rtlCol="0" anchor="ctr">
             <a:noAutofit/>
           </a:bodyPr>
           <a:lstStyle/>
@@ -4046,7 +4052,7 @@
           <p:cNvPr id="17" name="zone_rules_subtitle">
             <a:extLst>
               <a:ext uri="{FF2B5EF4-FFF2-40B4-BE49-F238E27FC236}">
-                <a16:creationId xmlns:a16="http://schemas.microsoft.com/office/drawing/2014/main" id="{D7B798C3-B541-DE69-7FFF-E6E971913CDA}"/>
+                <a16:creationId xmlns:a16="http://schemas.microsoft.com/office/drawing/2014/main" id="{E721F6BD-4A6D-DBAF-1E75-EABC7B8ADF4F}"/>
               </a:ext>
             </a:extLst>
           </p:cNvPr>
@@ -4055,8 +4061,8 @@
         </p:nvSpPr>
         <p:spPr>
           <a:xfrm>
-            <a:off x="6078431" y="1831808"/>
-            <a:ext cx="3518175" cy="285806"/>
+            <a:off x="6095848" y="1814362"/>
+            <a:ext cx="3483342" cy="276999"/>
           </a:xfrm>
           <a:prstGeom prst="rect">
             <a:avLst/>
@@ -4064,7 +4070,7 @@
           <a:noFill/>
         </p:spPr>
         <p:txBody>
-          <a:bodyPr vert="horz" wrap="square" lIns="8708" tIns="4361" rIns="8708" bIns="4361" rtlCol="0" anchor="t">
+          <a:bodyPr vert="horz" wrap="square" lIns="0" tIns="0" rIns="0" bIns="0" rtlCol="0" anchor="ctr">
             <a:noAutofit/>
           </a:bodyPr>
           <a:lstStyle/>
@@ -4092,7 +4098,7 @@
           <p:cNvPr id="18" name="zone_outputs_panel">
             <a:extLst>
               <a:ext uri="{FF2B5EF4-FFF2-40B4-BE49-F238E27FC236}">
-                <a16:creationId xmlns:a16="http://schemas.microsoft.com/office/drawing/2014/main" id="{ED146A82-5F13-E856-1EE1-AE219436F66F}"/>
+                <a16:creationId xmlns:a16="http://schemas.microsoft.com/office/drawing/2014/main" id="{2DC85142-C869-6F44-8736-246D0E4EDF3D}"/>
               </a:ext>
             </a:extLst>
           </p:cNvPr>
@@ -4105,7 +4111,9 @@
             <a:ext cx="2002922" cy="3750845"/>
           </a:xfrm>
           <a:prstGeom prst="roundRect">
-            <a:avLst/>
+            <a:avLst>
+              <a:gd name="adj" fmla="val 6957"/>
+            </a:avLst>
           </a:prstGeom>
           <a:solidFill>
             <a:srgbClr val="F1F0FA"/>
@@ -4153,7 +4161,7 @@
           <p:cNvPr id="19" name="zone_outputs_title">
             <a:extLst>
               <a:ext uri="{FF2B5EF4-FFF2-40B4-BE49-F238E27FC236}">
-                <a16:creationId xmlns:a16="http://schemas.microsoft.com/office/drawing/2014/main" id="{249453AB-35BF-F9AD-ED3A-5219F69D9403}"/>
+                <a16:creationId xmlns:a16="http://schemas.microsoft.com/office/drawing/2014/main" id="{D83E7750-B70A-5217-BF87-6AF9830A03E2}"/>
               </a:ext>
             </a:extLst>
           </p:cNvPr>
@@ -4162,8 +4170,8 @@
         </p:nvSpPr>
         <p:spPr>
           <a:xfrm>
-            <a:off x="10119107" y="1526507"/>
-            <a:ext cx="1619754" cy="285806"/>
+            <a:off x="10136524" y="1517784"/>
+            <a:ext cx="1584920" cy="276999"/>
           </a:xfrm>
           <a:prstGeom prst="rect">
             <a:avLst/>
@@ -4171,7 +4179,7 @@
           <a:noFill/>
         </p:spPr>
         <p:txBody>
-          <a:bodyPr vert="horz" wrap="square" lIns="8708" tIns="4361" rIns="8708" bIns="4361" rtlCol="0" anchor="t">
+          <a:bodyPr vert="horz" wrap="square" lIns="0" tIns="0" rIns="0" bIns="0" rtlCol="0" anchor="ctr">
             <a:noAutofit/>
           </a:bodyPr>
           <a:lstStyle/>
@@ -4199,7 +4207,7 @@
           <p:cNvPr id="20" name="zone_outputs_subtitle">
             <a:extLst>
               <a:ext uri="{FF2B5EF4-FFF2-40B4-BE49-F238E27FC236}">
-                <a16:creationId xmlns:a16="http://schemas.microsoft.com/office/drawing/2014/main" id="{C3D5FA31-F040-A975-EAE4-69FF04B9FFC3}"/>
+                <a16:creationId xmlns:a16="http://schemas.microsoft.com/office/drawing/2014/main" id="{0919E7C8-EEFB-AE76-D8CC-086896B40897}"/>
               </a:ext>
             </a:extLst>
           </p:cNvPr>
@@ -4208,8 +4216,8 @@
         </p:nvSpPr>
         <p:spPr>
           <a:xfrm>
-            <a:off x="10119107" y="1831808"/>
-            <a:ext cx="1619754" cy="285806"/>
+            <a:off x="10136524" y="1814362"/>
+            <a:ext cx="1584920" cy="276999"/>
           </a:xfrm>
           <a:prstGeom prst="rect">
             <a:avLst/>
@@ -4217,7 +4225,7 @@
           <a:noFill/>
         </p:spPr>
         <p:txBody>
-          <a:bodyPr vert="horz" wrap="square" lIns="8708" tIns="4361" rIns="8708" bIns="4361" rtlCol="0" anchor="t">
+          <a:bodyPr vert="horz" wrap="square" lIns="0" tIns="0" rIns="0" bIns="0" rtlCol="0" anchor="ctr">
             <a:noAutofit/>
           </a:bodyPr>
           <a:lstStyle/>
@@ -4245,7 +4253,7 @@
           <p:cNvPr id="21" name="main_start_markdown">
             <a:extLst>
               <a:ext uri="{FF2B5EF4-FFF2-40B4-BE49-F238E27FC236}">
-                <a16:creationId xmlns:a16="http://schemas.microsoft.com/office/drawing/2014/main" id="{1A011C61-D85D-8DD5-B22B-02873B640FBA}"/>
+                <a16:creationId xmlns:a16="http://schemas.microsoft.com/office/drawing/2014/main" id="{E39CC62B-810F-C353-6BA8-F5A7B3EB54C9}"/>
               </a:ext>
             </a:extLst>
           </p:cNvPr>
@@ -4288,7 +4296,7 @@
           <p:cNvPr id="22" name="main_markdown_splitter">
             <a:extLst>
               <a:ext uri="{FF2B5EF4-FFF2-40B4-BE49-F238E27FC236}">
-                <a16:creationId xmlns:a16="http://schemas.microsoft.com/office/drawing/2014/main" id="{DC1D39C0-F881-7E9F-E10E-04B8226693A9}"/>
+                <a16:creationId xmlns:a16="http://schemas.microsoft.com/office/drawing/2014/main" id="{CE6F8A24-861F-B6EE-CC87-C588C90BC630}"/>
               </a:ext>
             </a:extLst>
           </p:cNvPr>
@@ -4331,7 +4339,7 @@
           <p:cNvPr id="23" name="main_splitter_ir_seg_1">
             <a:extLst>
               <a:ext uri="{FF2B5EF4-FFF2-40B4-BE49-F238E27FC236}">
-                <a16:creationId xmlns:a16="http://schemas.microsoft.com/office/drawing/2014/main" id="{4349E39C-AA12-9996-71CE-D7EDF00A4128}"/>
+                <a16:creationId xmlns:a16="http://schemas.microsoft.com/office/drawing/2014/main" id="{1EF0B746-72DD-A554-E0FF-E8DFC4FA865E}"/>
               </a:ext>
             </a:extLst>
           </p:cNvPr>
@@ -4374,7 +4382,7 @@
           <p:cNvPr id="24" name="main_splitter_ir_seg_2">
             <a:extLst>
               <a:ext uri="{FF2B5EF4-FFF2-40B4-BE49-F238E27FC236}">
-                <a16:creationId xmlns:a16="http://schemas.microsoft.com/office/drawing/2014/main" id="{2E050902-2316-CFEE-7887-D543DB947467}"/>
+                <a16:creationId xmlns:a16="http://schemas.microsoft.com/office/drawing/2014/main" id="{09ADF139-3E78-C746-23E8-6A2CA697D214}"/>
               </a:ext>
             </a:extLst>
           </p:cNvPr>
@@ -4417,7 +4425,7 @@
           <p:cNvPr id="25" name="main_splitter_ir_seg_3">
             <a:extLst>
               <a:ext uri="{FF2B5EF4-FFF2-40B4-BE49-F238E27FC236}">
-                <a16:creationId xmlns:a16="http://schemas.microsoft.com/office/drawing/2014/main" id="{8B26B471-AF31-6DCA-B33D-7D8CEF3C5208}"/>
+                <a16:creationId xmlns:a16="http://schemas.microsoft.com/office/drawing/2014/main" id="{92A6280F-01A8-9979-CB0B-D834456D2179}"/>
               </a:ext>
             </a:extLst>
           </p:cNvPr>
@@ -4460,7 +4468,7 @@
           <p:cNvPr id="26" name="hint_ir_reasoning">
             <a:extLst>
               <a:ext uri="{FF2B5EF4-FFF2-40B4-BE49-F238E27FC236}">
-                <a16:creationId xmlns:a16="http://schemas.microsoft.com/office/drawing/2014/main" id="{733D694C-C0B1-DDA5-185C-078303850C63}"/>
+                <a16:creationId xmlns:a16="http://schemas.microsoft.com/office/drawing/2014/main" id="{AE04FE2C-6968-9D24-10D9-69E5D15302C4}"/>
               </a:ext>
             </a:extLst>
           </p:cNvPr>
@@ -4504,7 +4512,7 @@
           <p:cNvPr id="27" name="main_ir_rules">
             <a:extLst>
               <a:ext uri="{FF2B5EF4-FFF2-40B4-BE49-F238E27FC236}">
-                <a16:creationId xmlns:a16="http://schemas.microsoft.com/office/drawing/2014/main" id="{01C37751-0B8E-65D7-69C9-810F18BC4004}"/>
+                <a16:creationId xmlns:a16="http://schemas.microsoft.com/office/drawing/2014/main" id="{A38F09B0-184D-3EF7-C18F-9094A30132DE}"/>
               </a:ext>
             </a:extLst>
           </p:cNvPr>
@@ -4547,7 +4555,7 @@
           <p:cNvPr id="28" name="hint_reasoning_rules_seg_1">
             <a:extLst>
               <a:ext uri="{FF2B5EF4-FFF2-40B4-BE49-F238E27FC236}">
-                <a16:creationId xmlns:a16="http://schemas.microsoft.com/office/drawing/2014/main" id="{F386C96A-C79E-5B02-7ED0-0D311DB77751}"/>
+                <a16:creationId xmlns:a16="http://schemas.microsoft.com/office/drawing/2014/main" id="{56DF37D7-0F47-6911-D62E-204B90E7392F}"/>
               </a:ext>
             </a:extLst>
           </p:cNvPr>
@@ -4591,7 +4599,7 @@
           <p:cNvPr id="29" name="hint_reasoning_rules_seg_2">
             <a:extLst>
               <a:ext uri="{FF2B5EF4-FFF2-40B4-BE49-F238E27FC236}">
-                <a16:creationId xmlns:a16="http://schemas.microsoft.com/office/drawing/2014/main" id="{3A709624-902B-4B52-AFFB-7885D2EAC28E}"/>
+                <a16:creationId xmlns:a16="http://schemas.microsoft.com/office/drawing/2014/main" id="{7D1F3C84-DB59-D616-DA28-B284A1A2AB9E}"/>
               </a:ext>
             </a:extLst>
           </p:cNvPr>
@@ -4635,7 +4643,7 @@
           <p:cNvPr id="30" name="hint_reasoning_rules_seg_3">
             <a:extLst>
               <a:ext uri="{FF2B5EF4-FFF2-40B4-BE49-F238E27FC236}">
-                <a16:creationId xmlns:a16="http://schemas.microsoft.com/office/drawing/2014/main" id="{2C0010AD-A453-8455-9EAF-D9DCC1DBD218}"/>
+                <a16:creationId xmlns:a16="http://schemas.microsoft.com/office/drawing/2014/main" id="{538A58D9-B8A5-8A8E-74FF-ABA7F342F5DF}"/>
               </a:ext>
             </a:extLst>
           </p:cNvPr>
@@ -4679,7 +4687,7 @@
           <p:cNvPr id="31" name="rule_features_recipes">
             <a:extLst>
               <a:ext uri="{FF2B5EF4-FFF2-40B4-BE49-F238E27FC236}">
-                <a16:creationId xmlns:a16="http://schemas.microsoft.com/office/drawing/2014/main" id="{659B8906-8C5A-2BB6-3E46-9C5813ACD291}"/>
+                <a16:creationId xmlns:a16="http://schemas.microsoft.com/office/drawing/2014/main" id="{6C992AF4-E9EE-028A-494A-1621A62592B0}"/>
               </a:ext>
             </a:extLst>
           </p:cNvPr>
@@ -4722,7 +4730,7 @@
           <p:cNvPr id="32" name="rule_recipes_theme">
             <a:extLst>
               <a:ext uri="{FF2B5EF4-FFF2-40B4-BE49-F238E27FC236}">
-                <a16:creationId xmlns:a16="http://schemas.microsoft.com/office/drawing/2014/main" id="{1EC8B5FE-F885-089B-01B1-6B97D44C7E66}"/>
+                <a16:creationId xmlns:a16="http://schemas.microsoft.com/office/drawing/2014/main" id="{7E7FACC4-6FAA-03FB-6B12-312825192465}"/>
               </a:ext>
             </a:extLst>
           </p:cNvPr>
@@ -4765,7 +4773,7 @@
           <p:cNvPr id="33" name="rule_features_compose">
             <a:extLst>
               <a:ext uri="{FF2B5EF4-FFF2-40B4-BE49-F238E27FC236}">
-                <a16:creationId xmlns:a16="http://schemas.microsoft.com/office/drawing/2014/main" id="{471AF0AE-211F-251E-C9DF-23F5C2C8421B}"/>
+                <a16:creationId xmlns:a16="http://schemas.microsoft.com/office/drawing/2014/main" id="{6BCD6DC8-8381-B201-BCD1-B282866BF9A1}"/>
               </a:ext>
             </a:extLst>
           </p:cNvPr>
@@ -4808,7 +4816,7 @@
           <p:cNvPr id="34" name="rule_recipes_objects">
             <a:extLst>
               <a:ext uri="{FF2B5EF4-FFF2-40B4-BE49-F238E27FC236}">
-                <a16:creationId xmlns:a16="http://schemas.microsoft.com/office/drawing/2014/main" id="{DC729138-BDF9-5B61-A754-8A03F9BBA363}"/>
+                <a16:creationId xmlns:a16="http://schemas.microsoft.com/office/drawing/2014/main" id="{320524C9-9E7E-428D-019E-837FCF3EF404}"/>
               </a:ext>
             </a:extLst>
           </p:cNvPr>
@@ -4851,7 +4859,7 @@
           <p:cNvPr id="35" name="rule_theme_decorate">
             <a:extLst>
               <a:ext uri="{FF2B5EF4-FFF2-40B4-BE49-F238E27FC236}">
-                <a16:creationId xmlns:a16="http://schemas.microsoft.com/office/drawing/2014/main" id="{3BC0AC1C-0A22-923D-BBCA-6D8B63442E35}"/>
+                <a16:creationId xmlns:a16="http://schemas.microsoft.com/office/drawing/2014/main" id="{B6B5F24D-ECF9-E6FB-0EC9-6AE321F5E88D}"/>
               </a:ext>
             </a:extLst>
           </p:cNvPr>
@@ -4894,7 +4902,7 @@
           <p:cNvPr id="36" name="rule_compose_objects">
             <a:extLst>
               <a:ext uri="{FF2B5EF4-FFF2-40B4-BE49-F238E27FC236}">
-                <a16:creationId xmlns:a16="http://schemas.microsoft.com/office/drawing/2014/main" id="{DD921C2F-FFBB-F54D-6DA4-E75E34CD41C4}"/>
+                <a16:creationId xmlns:a16="http://schemas.microsoft.com/office/drawing/2014/main" id="{697C7654-9E93-3756-4D2F-9A6AF7EC5604}"/>
               </a:ext>
             </a:extLst>
           </p:cNvPr>
@@ -4937,7 +4945,7 @@
           <p:cNvPr id="37" name="rule_objects_decorate">
             <a:extLst>
               <a:ext uri="{FF2B5EF4-FFF2-40B4-BE49-F238E27FC236}">
-                <a16:creationId xmlns:a16="http://schemas.microsoft.com/office/drawing/2014/main" id="{2C3BA8C9-0487-5384-FCE8-F6AA455AF856}"/>
+                <a16:creationId xmlns:a16="http://schemas.microsoft.com/office/drawing/2014/main" id="{500090C7-31CC-59A3-4DF7-2CC8D7B9C7A1}"/>
               </a:ext>
             </a:extLst>
           </p:cNvPr>
@@ -4980,7 +4988,7 @@
           <p:cNvPr id="38" name="main_rules_styled_ir">
             <a:extLst>
               <a:ext uri="{FF2B5EF4-FFF2-40B4-BE49-F238E27FC236}">
-                <a16:creationId xmlns:a16="http://schemas.microsoft.com/office/drawing/2014/main" id="{79DACCD7-6FF9-B5ED-A909-D2420147FC70}"/>
+                <a16:creationId xmlns:a16="http://schemas.microsoft.com/office/drawing/2014/main" id="{AF524331-AE28-1C1A-52F6-5BD27FD9AA48}"/>
               </a:ext>
             </a:extLst>
           </p:cNvPr>
@@ -5023,7 +5031,7 @@
           <p:cNvPr id="39" name="main_styled_renderers">
             <a:extLst>
               <a:ext uri="{FF2B5EF4-FFF2-40B4-BE49-F238E27FC236}">
-                <a16:creationId xmlns:a16="http://schemas.microsoft.com/office/drawing/2014/main" id="{EBD95183-F6C7-57C1-DD98-7F741A8A8B19}"/>
+                <a16:creationId xmlns:a16="http://schemas.microsoft.com/office/drawing/2014/main" id="{6782BB55-F63B-1B1D-34B8-C2A0EDAFC1B6}"/>
               </a:ext>
             </a:extLst>
           </p:cNvPr>
@@ -5066,7 +5074,7 @@
           <p:cNvPr id="40" name="validation_loop">
             <a:extLst>
               <a:ext uri="{FF2B5EF4-FFF2-40B4-BE49-F238E27FC236}">
-                <a16:creationId xmlns:a16="http://schemas.microsoft.com/office/drawing/2014/main" id="{339D8669-6201-F50D-1D78-1F022B7E259F}"/>
+                <a16:creationId xmlns:a16="http://schemas.microsoft.com/office/drawing/2014/main" id="{AAE622E1-BF74-62EC-EEFA-10A971C35613}"/>
               </a:ext>
             </a:extLst>
           </p:cNvPr>
@@ -5109,7 +5117,7 @@
           <p:cNvPr id="41" name="source_chip">
             <a:extLst>
               <a:ext uri="{FF2B5EF4-FFF2-40B4-BE49-F238E27FC236}">
-                <a16:creationId xmlns:a16="http://schemas.microsoft.com/office/drawing/2014/main" id="{1F87E298-BF1A-B085-6451-D8DFA15590E2}"/>
+                <a16:creationId xmlns:a16="http://schemas.microsoft.com/office/drawing/2014/main" id="{74DC4082-745C-0AD2-1FD8-BFE48FF0CD42}"/>
               </a:ext>
             </a:extLst>
           </p:cNvPr>
@@ -5122,7 +5130,9 @@
             <a:ext cx="696669" cy="314024"/>
           </a:xfrm>
           <a:prstGeom prst="roundRect">
-            <a:avLst/>
+            <a:avLst>
+              <a:gd name="adj" fmla="val 44370"/>
+            </a:avLst>
           </a:prstGeom>
           <a:solidFill>
             <a:srgbClr val="EEF4EF"/>
@@ -5170,7 +5180,7 @@
           <p:cNvPr id="42" name="source_chip_text">
             <a:extLst>
               <a:ext uri="{FF2B5EF4-FFF2-40B4-BE49-F238E27FC236}">
-                <a16:creationId xmlns:a16="http://schemas.microsoft.com/office/drawing/2014/main" id="{03CCB476-00A1-768B-1BAE-0426998558AB}"/>
+                <a16:creationId xmlns:a16="http://schemas.microsoft.com/office/drawing/2014/main" id="{D99FEC8B-035D-430D-5F4B-56EB468ECBEC}"/>
               </a:ext>
             </a:extLst>
           </p:cNvPr>
@@ -5179,8 +5189,8 @@
         </p:nvSpPr>
         <p:spPr>
           <a:xfrm>
-            <a:off x="1724254" y="2198170"/>
-            <a:ext cx="557335" cy="285806"/>
+            <a:off x="1724254" y="2163278"/>
+            <a:ext cx="557335" cy="276999"/>
           </a:xfrm>
           <a:prstGeom prst="rect">
             <a:avLst/>
@@ -5188,7 +5198,7 @@
           <a:noFill/>
         </p:spPr>
         <p:txBody>
-          <a:bodyPr vert="horz" wrap="square" lIns="8708" tIns="4361" rIns="8708" bIns="4361" rtlCol="0" anchor="ctr">
+          <a:bodyPr vert="horz" wrap="square" lIns="0" tIns="0" rIns="0" bIns="0" rtlCol="0" anchor="ctr">
             <a:noAutofit/>
           </a:bodyPr>
           <a:lstStyle/>
@@ -5217,7 +5227,7 @@
           <p:cNvPr id="43" name="markdown_card">
             <a:extLst>
               <a:ext uri="{FF2B5EF4-FFF2-40B4-BE49-F238E27FC236}">
-                <a16:creationId xmlns:a16="http://schemas.microsoft.com/office/drawing/2014/main" id="{53419BC8-D05D-5387-A8F1-512442784D22}"/>
+                <a16:creationId xmlns:a16="http://schemas.microsoft.com/office/drawing/2014/main" id="{596BF581-ED5C-051A-6180-3A9020CC1B5D}"/>
               </a:ext>
             </a:extLst>
           </p:cNvPr>
@@ -5230,7 +5240,9 @@
             <a:ext cx="1985505" cy="942072"/>
           </a:xfrm>
           <a:prstGeom prst="roundRect">
-            <a:avLst/>
+            <a:avLst>
+              <a:gd name="adj" fmla="val 14790"/>
+            </a:avLst>
           </a:prstGeom>
           <a:solidFill>
             <a:srgbClr val="FFFDF8"/>
@@ -5278,7 +5290,7 @@
           <p:cNvPr id="44" name="markdown_icon_dot">
             <a:extLst>
               <a:ext uri="{FF2B5EF4-FFF2-40B4-BE49-F238E27FC236}">
-                <a16:creationId xmlns:a16="http://schemas.microsoft.com/office/drawing/2014/main" id="{ADF07689-1447-22BF-25D2-D6E2E45CC2E7}"/>
+                <a16:creationId xmlns:a16="http://schemas.microsoft.com/office/drawing/2014/main" id="{E3CADD30-7DFA-0C52-0A57-FCB1F4D8BC13}"/>
               </a:ext>
             </a:extLst>
           </p:cNvPr>
@@ -5287,8 +5299,8 @@
         </p:nvSpPr>
         <p:spPr>
           <a:xfrm>
-            <a:off x="1184336" y="2913447"/>
-            <a:ext cx="191584" cy="191903"/>
+            <a:off x="1179982" y="2909085"/>
+            <a:ext cx="217709" cy="218073"/>
           </a:xfrm>
           <a:prstGeom prst="ellipse">
             <a:avLst/>
@@ -5332,7 +5344,7 @@
           <p:cNvPr id="45" name="markdown_icon_label">
             <a:extLst>
               <a:ext uri="{FF2B5EF4-FFF2-40B4-BE49-F238E27FC236}">
-                <a16:creationId xmlns:a16="http://schemas.microsoft.com/office/drawing/2014/main" id="{7E84E566-A6CA-DD9C-51D4-D0BFD1001FC5}"/>
+                <a16:creationId xmlns:a16="http://schemas.microsoft.com/office/drawing/2014/main" id="{9E11529A-B93D-8B54-FB5D-7FABDE08CDCA}"/>
               </a:ext>
             </a:extLst>
           </p:cNvPr>
@@ -5341,8 +5353,8 @@
         </p:nvSpPr>
         <p:spPr>
           <a:xfrm>
-            <a:off x="1184336" y="2913447"/>
-            <a:ext cx="191584" cy="276999"/>
+            <a:off x="1179982" y="2909085"/>
+            <a:ext cx="217709" cy="276999"/>
           </a:xfrm>
           <a:prstGeom prst="rect">
             <a:avLst/>
@@ -5379,7 +5391,7 @@
           <p:cNvPr id="46" name="markdown_title">
             <a:extLst>
               <a:ext uri="{FF2B5EF4-FFF2-40B4-BE49-F238E27FC236}">
-                <a16:creationId xmlns:a16="http://schemas.microsoft.com/office/drawing/2014/main" id="{55223CE8-30FD-1EFB-B5D7-487D779C9E98}"/>
+                <a16:creationId xmlns:a16="http://schemas.microsoft.com/office/drawing/2014/main" id="{99AC761A-7418-3A87-2E7A-560435C2A6AB}"/>
               </a:ext>
             </a:extLst>
           </p:cNvPr>
@@ -5389,7 +5401,7 @@
         <p:spPr>
           <a:xfrm>
             <a:off x="1515254" y="2904724"/>
-            <a:ext cx="1358503" cy="285806"/>
+            <a:ext cx="1358503" cy="276999"/>
           </a:xfrm>
           <a:prstGeom prst="rect">
             <a:avLst/>
@@ -5397,7 +5409,7 @@
           <a:noFill/>
         </p:spPr>
         <p:txBody>
-          <a:bodyPr vert="horz" wrap="square" lIns="8708" tIns="4361" rIns="8708" bIns="4361" rtlCol="0" anchor="ctr">
+          <a:bodyPr vert="horz" wrap="square" lIns="0" tIns="0" rIns="0" bIns="0" rtlCol="0" anchor="ctr">
             <a:noAutofit/>
           </a:bodyPr>
           <a:lstStyle/>
@@ -5425,7 +5437,7 @@
           <p:cNvPr id="47" name="markdown_line_0">
             <a:extLst>
               <a:ext uri="{FF2B5EF4-FFF2-40B4-BE49-F238E27FC236}">
-                <a16:creationId xmlns:a16="http://schemas.microsoft.com/office/drawing/2014/main" id="{6FD56F65-5460-BFC7-CCF7-0DBCF6040887}"/>
+                <a16:creationId xmlns:a16="http://schemas.microsoft.com/office/drawing/2014/main" id="{12142459-4DCD-19F9-3DE8-F08E44D1107A}"/>
               </a:ext>
             </a:extLst>
           </p:cNvPr>
@@ -5435,7 +5447,7 @@
         <p:spPr>
           <a:xfrm>
             <a:off x="1297545" y="3244917"/>
-            <a:ext cx="1576212" cy="285806"/>
+            <a:ext cx="1576212" cy="294615"/>
           </a:xfrm>
           <a:prstGeom prst="rect">
             <a:avLst/>
@@ -5443,7 +5455,7 @@
           <a:noFill/>
         </p:spPr>
         <p:txBody>
-          <a:bodyPr vert="horz" wrap="square" lIns="8708" tIns="4361" rIns="8708" bIns="4361" rtlCol="0" anchor="t">
+          <a:bodyPr vert="horz" wrap="square" lIns="8708" tIns="8723" rIns="8708" bIns="8723" rtlCol="0" anchor="t">
             <a:noAutofit/>
           </a:bodyPr>
           <a:lstStyle/>
@@ -5471,7 +5483,7 @@
           <p:cNvPr id="48" name="markdown_line_1">
             <a:extLst>
               <a:ext uri="{FF2B5EF4-FFF2-40B4-BE49-F238E27FC236}">
-                <a16:creationId xmlns:a16="http://schemas.microsoft.com/office/drawing/2014/main" id="{9BD9F5DE-ABDC-4128-FEEC-5075F553FE89}"/>
+                <a16:creationId xmlns:a16="http://schemas.microsoft.com/office/drawing/2014/main" id="{15736425-DF3F-BCA0-2493-3D8BAE917A70}"/>
               </a:ext>
             </a:extLst>
           </p:cNvPr>
@@ -5481,7 +5493,7 @@
         <p:spPr>
           <a:xfrm>
             <a:off x="1297545" y="3410652"/>
-            <a:ext cx="1576212" cy="285806"/>
+            <a:ext cx="1576212" cy="294615"/>
           </a:xfrm>
           <a:prstGeom prst="rect">
             <a:avLst/>
@@ -5489,7 +5501,7 @@
           <a:noFill/>
         </p:spPr>
         <p:txBody>
-          <a:bodyPr vert="horz" wrap="square" lIns="8708" tIns="4361" rIns="8708" bIns="4361" rtlCol="0" anchor="t">
+          <a:bodyPr vert="horz" wrap="square" lIns="8708" tIns="8723" rIns="8708" bIns="8723" rtlCol="0" anchor="t">
             <a:noAutofit/>
           </a:bodyPr>
           <a:lstStyle/>
@@ -5517,7 +5529,7 @@
           <p:cNvPr id="49" name="splitter_card">
             <a:extLst>
               <a:ext uri="{FF2B5EF4-FFF2-40B4-BE49-F238E27FC236}">
-                <a16:creationId xmlns:a16="http://schemas.microsoft.com/office/drawing/2014/main" id="{6E30F664-A884-FFFE-13F1-DA71943C21C1}"/>
+                <a16:creationId xmlns:a16="http://schemas.microsoft.com/office/drawing/2014/main" id="{B98235E8-314D-B2CA-A3F6-7FAB318E7792}"/>
               </a:ext>
             </a:extLst>
           </p:cNvPr>
@@ -5530,7 +5542,9 @@
             <a:ext cx="1985505" cy="976964"/>
           </a:xfrm>
           <a:prstGeom prst="roundRect">
-            <a:avLst/>
+            <a:avLst>
+              <a:gd name="adj" fmla="val 14262"/>
+            </a:avLst>
           </a:prstGeom>
           <a:solidFill>
             <a:srgbClr val="FFFDF8"/>
@@ -5578,7 +5592,7 @@
           <p:cNvPr id="50" name="splitter_icon_dot">
             <a:extLst>
               <a:ext uri="{FF2B5EF4-FFF2-40B4-BE49-F238E27FC236}">
-                <a16:creationId xmlns:a16="http://schemas.microsoft.com/office/drawing/2014/main" id="{8F8299AA-D5CF-97C2-4343-8B4950235101}"/>
+                <a16:creationId xmlns:a16="http://schemas.microsoft.com/office/drawing/2014/main" id="{3279EC3A-2EAE-8B28-70BC-A9DCB33F235A}"/>
               </a:ext>
             </a:extLst>
           </p:cNvPr>
@@ -5587,8 +5601,8 @@
         </p:nvSpPr>
         <p:spPr>
           <a:xfrm>
-            <a:off x="1184336" y="4134652"/>
-            <a:ext cx="191584" cy="191904"/>
+            <a:off x="1179982" y="4130291"/>
+            <a:ext cx="217709" cy="218072"/>
           </a:xfrm>
           <a:prstGeom prst="ellipse">
             <a:avLst/>
@@ -5632,7 +5646,7 @@
           <p:cNvPr id="51" name="splitter_icon_label">
             <a:extLst>
               <a:ext uri="{FF2B5EF4-FFF2-40B4-BE49-F238E27FC236}">
-                <a16:creationId xmlns:a16="http://schemas.microsoft.com/office/drawing/2014/main" id="{5D345BF1-9C1D-B62E-693E-D71A6ACB0AD3}"/>
+                <a16:creationId xmlns:a16="http://schemas.microsoft.com/office/drawing/2014/main" id="{0F69E6A1-DF24-5C2F-1465-D1F4C64A8773}"/>
               </a:ext>
             </a:extLst>
           </p:cNvPr>
@@ -5641,8 +5655,8 @@
         </p:nvSpPr>
         <p:spPr>
           <a:xfrm>
-            <a:off x="1184336" y="4134652"/>
-            <a:ext cx="191584" cy="276999"/>
+            <a:off x="1179982" y="4130291"/>
+            <a:ext cx="217709" cy="276999"/>
           </a:xfrm>
           <a:prstGeom prst="rect">
             <a:avLst/>
@@ -5679,7 +5693,7 @@
           <p:cNvPr id="52" name="splitter_title">
             <a:extLst>
               <a:ext uri="{FF2B5EF4-FFF2-40B4-BE49-F238E27FC236}">
-                <a16:creationId xmlns:a16="http://schemas.microsoft.com/office/drawing/2014/main" id="{8517CF6C-9484-9D40-27A9-A27F3E341C3A}"/>
+                <a16:creationId xmlns:a16="http://schemas.microsoft.com/office/drawing/2014/main" id="{5875C5CD-48E9-A69A-7856-F246E33288FA}"/>
               </a:ext>
             </a:extLst>
           </p:cNvPr>
@@ -5689,7 +5703,7 @@
         <p:spPr>
           <a:xfrm>
             <a:off x="1515254" y="4125929"/>
-            <a:ext cx="1358503" cy="285806"/>
+            <a:ext cx="1358503" cy="276999"/>
           </a:xfrm>
           <a:prstGeom prst="rect">
             <a:avLst/>
@@ -5697,7 +5711,7 @@
           <a:noFill/>
         </p:spPr>
         <p:txBody>
-          <a:bodyPr vert="horz" wrap="square" lIns="8708" tIns="4361" rIns="8708" bIns="4361" rtlCol="0" anchor="ctr">
+          <a:bodyPr vert="horz" wrap="square" lIns="0" tIns="0" rIns="0" bIns="0" rtlCol="0" anchor="ctr">
             <a:noAutofit/>
           </a:bodyPr>
           <a:lstStyle/>
@@ -5725,7 +5739,7 @@
           <p:cNvPr id="53" name="splitter_line_0">
             <a:extLst>
               <a:ext uri="{FF2B5EF4-FFF2-40B4-BE49-F238E27FC236}">
-                <a16:creationId xmlns:a16="http://schemas.microsoft.com/office/drawing/2014/main" id="{B978DCBF-5491-DB81-3719-7ADBFA73E45C}"/>
+                <a16:creationId xmlns:a16="http://schemas.microsoft.com/office/drawing/2014/main" id="{EF86A5A3-E263-D2E7-6F34-040B0F6979FC}"/>
               </a:ext>
             </a:extLst>
           </p:cNvPr>
@@ -5735,7 +5749,7 @@
         <p:spPr>
           <a:xfrm>
             <a:off x="1297545" y="4466122"/>
-            <a:ext cx="1576212" cy="285806"/>
+            <a:ext cx="1576212" cy="294615"/>
           </a:xfrm>
           <a:prstGeom prst="rect">
             <a:avLst/>
@@ -5743,7 +5757,7 @@
           <a:noFill/>
         </p:spPr>
         <p:txBody>
-          <a:bodyPr vert="horz" wrap="square" lIns="8708" tIns="4361" rIns="8708" bIns="4361" rtlCol="0" anchor="t">
+          <a:bodyPr vert="horz" wrap="square" lIns="8708" tIns="8723" rIns="8708" bIns="8723" rtlCol="0" anchor="t">
             <a:noAutofit/>
           </a:bodyPr>
           <a:lstStyle/>
@@ -5771,7 +5785,7 @@
           <p:cNvPr id="54" name="splitter_line_1">
             <a:extLst>
               <a:ext uri="{FF2B5EF4-FFF2-40B4-BE49-F238E27FC236}">
-                <a16:creationId xmlns:a16="http://schemas.microsoft.com/office/drawing/2014/main" id="{991D64B9-5766-060C-AEBC-80D840716FC2}"/>
+                <a16:creationId xmlns:a16="http://schemas.microsoft.com/office/drawing/2014/main" id="{EF42F72A-CF9C-FA0D-0E10-13F9113EFF8C}"/>
               </a:ext>
             </a:extLst>
           </p:cNvPr>
@@ -5781,7 +5795,7 @@
         <p:spPr>
           <a:xfrm>
             <a:off x="1297545" y="4631857"/>
-            <a:ext cx="1576212" cy="285806"/>
+            <a:ext cx="1576212" cy="294615"/>
           </a:xfrm>
           <a:prstGeom prst="rect">
             <a:avLst/>
@@ -5789,7 +5803,7 @@
           <a:noFill/>
         </p:spPr>
         <p:txBody>
-          <a:bodyPr vert="horz" wrap="square" lIns="8708" tIns="4361" rIns="8708" bIns="4361" rtlCol="0" anchor="t">
+          <a:bodyPr vert="horz" wrap="square" lIns="8708" tIns="8723" rIns="8708" bIns="8723" rtlCol="0" anchor="t">
             <a:noAutofit/>
           </a:bodyPr>
           <a:lstStyle/>
@@ -5817,7 +5831,7 @@
           <p:cNvPr id="55" name="ir_core_card">
             <a:extLst>
               <a:ext uri="{FF2B5EF4-FFF2-40B4-BE49-F238E27FC236}">
-                <a16:creationId xmlns:a16="http://schemas.microsoft.com/office/drawing/2014/main" id="{938C562C-1E87-EE57-3032-51BE976AAE01}"/>
+                <a16:creationId xmlns:a16="http://schemas.microsoft.com/office/drawing/2014/main" id="{B71B8F5F-B69A-FE9D-B27D-803E6A1A4245}"/>
               </a:ext>
             </a:extLst>
           </p:cNvPr>
@@ -5830,7 +5844,9 @@
             <a:ext cx="1915838" cy="915904"/>
           </a:xfrm>
           <a:prstGeom prst="roundRect">
-            <a:avLst/>
+            <a:avLst>
+              <a:gd name="adj" fmla="val 15213"/>
+            </a:avLst>
           </a:prstGeom>
           <a:solidFill>
             <a:srgbClr val="FFFFFF"/>
@@ -5878,7 +5894,7 @@
           <p:cNvPr id="56" name="ir_core_icon_dot">
             <a:extLst>
               <a:ext uri="{FF2B5EF4-FFF2-40B4-BE49-F238E27FC236}">
-                <a16:creationId xmlns:a16="http://schemas.microsoft.com/office/drawing/2014/main" id="{12CD192A-215A-6DCC-A3FD-D039BDF9ED14}"/>
+                <a16:creationId xmlns:a16="http://schemas.microsoft.com/office/drawing/2014/main" id="{3E8BEF65-9BFB-094F-3215-A5B5FD043520}"/>
               </a:ext>
             </a:extLst>
           </p:cNvPr>
@@ -5887,8 +5903,8 @@
         </p:nvSpPr>
         <p:spPr>
           <a:xfrm>
-            <a:off x="3831676" y="2302844"/>
-            <a:ext cx="191583" cy="191904"/>
+            <a:off x="3827321" y="2298483"/>
+            <a:ext cx="217709" cy="218072"/>
           </a:xfrm>
           <a:prstGeom prst="ellipse">
             <a:avLst/>
@@ -5932,7 +5948,7 @@
           <p:cNvPr id="57" name="ir_core_icon_label">
             <a:extLst>
               <a:ext uri="{FF2B5EF4-FFF2-40B4-BE49-F238E27FC236}">
-                <a16:creationId xmlns:a16="http://schemas.microsoft.com/office/drawing/2014/main" id="{990EFA94-FF04-9C99-095E-25499882EA2E}"/>
+                <a16:creationId xmlns:a16="http://schemas.microsoft.com/office/drawing/2014/main" id="{DA4735E6-3DFE-64F0-6A26-ABFF11C638B5}"/>
               </a:ext>
             </a:extLst>
           </p:cNvPr>
@@ -5941,8 +5957,8 @@
         </p:nvSpPr>
         <p:spPr>
           <a:xfrm>
-            <a:off x="3831676" y="2302844"/>
-            <a:ext cx="191584" cy="276999"/>
+            <a:off x="3827321" y="2298483"/>
+            <a:ext cx="217709" cy="276999"/>
           </a:xfrm>
           <a:prstGeom prst="rect">
             <a:avLst/>
@@ -5979,7 +5995,7 @@
           <p:cNvPr id="58" name="ir_core_title">
             <a:extLst>
               <a:ext uri="{FF2B5EF4-FFF2-40B4-BE49-F238E27FC236}">
-                <a16:creationId xmlns:a16="http://schemas.microsoft.com/office/drawing/2014/main" id="{6317F0EE-287D-CD63-7007-C3837ED01ABD}"/>
+                <a16:creationId xmlns:a16="http://schemas.microsoft.com/office/drawing/2014/main" id="{5CB7C43F-6F0E-A1C3-A2BE-B537D52888AF}"/>
               </a:ext>
             </a:extLst>
           </p:cNvPr>
@@ -5989,7 +6005,7 @@
         <p:spPr>
           <a:xfrm>
             <a:off x="4162593" y="2294121"/>
-            <a:ext cx="1288836" cy="285806"/>
+            <a:ext cx="1288836" cy="276999"/>
           </a:xfrm>
           <a:prstGeom prst="rect">
             <a:avLst/>
@@ -5997,7 +6013,7 @@
           <a:noFill/>
         </p:spPr>
         <p:txBody>
-          <a:bodyPr vert="horz" wrap="square" lIns="8708" tIns="4361" rIns="8708" bIns="4361" rtlCol="0" anchor="ctr">
+          <a:bodyPr vert="horz" wrap="square" lIns="0" tIns="0" rIns="0" bIns="0" rtlCol="0" anchor="ctr">
             <a:noAutofit/>
           </a:bodyPr>
           <a:lstStyle/>
@@ -6025,7 +6041,7 @@
           <p:cNvPr id="59" name="ir_core_line_0">
             <a:extLst>
               <a:ext uri="{FF2B5EF4-FFF2-40B4-BE49-F238E27FC236}">
-                <a16:creationId xmlns:a16="http://schemas.microsoft.com/office/drawing/2014/main" id="{533DCB95-FA31-8B52-5B01-AF82BA237758}"/>
+                <a16:creationId xmlns:a16="http://schemas.microsoft.com/office/drawing/2014/main" id="{9048BC93-1F17-559F-3270-8D688C40CE69}"/>
               </a:ext>
             </a:extLst>
           </p:cNvPr>
@@ -6035,7 +6051,7 @@
         <p:spPr>
           <a:xfrm>
             <a:off x="3944884" y="2634314"/>
-            <a:ext cx="1506545" cy="285806"/>
+            <a:ext cx="1506545" cy="294615"/>
           </a:xfrm>
           <a:prstGeom prst="rect">
             <a:avLst/>
@@ -6043,7 +6059,7 @@
           <a:noFill/>
         </p:spPr>
         <p:txBody>
-          <a:bodyPr vert="horz" wrap="square" lIns="8708" tIns="4361" rIns="8708" bIns="4361" rtlCol="0" anchor="t">
+          <a:bodyPr vert="horz" wrap="square" lIns="8708" tIns="8723" rIns="8708" bIns="8723" rtlCol="0" anchor="t">
             <a:noAutofit/>
           </a:bodyPr>
           <a:lstStyle/>
@@ -6071,7 +6087,7 @@
           <p:cNvPr id="60" name="ir_core_line_1">
             <a:extLst>
               <a:ext uri="{FF2B5EF4-FFF2-40B4-BE49-F238E27FC236}">
-                <a16:creationId xmlns:a16="http://schemas.microsoft.com/office/drawing/2014/main" id="{3DC8834C-EA10-763C-1475-0B39362734E8}"/>
+                <a16:creationId xmlns:a16="http://schemas.microsoft.com/office/drawing/2014/main" id="{312B7E56-DC2E-9B22-C907-29198E77264A}"/>
               </a:ext>
             </a:extLst>
           </p:cNvPr>
@@ -6081,7 +6097,7 @@
         <p:spPr>
           <a:xfrm>
             <a:off x="3944884" y="2800049"/>
-            <a:ext cx="1506545" cy="285806"/>
+            <a:ext cx="1506545" cy="294615"/>
           </a:xfrm>
           <a:prstGeom prst="rect">
             <a:avLst/>
@@ -6089,7 +6105,7 @@
           <a:noFill/>
         </p:spPr>
         <p:txBody>
-          <a:bodyPr vert="horz" wrap="square" lIns="8708" tIns="4361" rIns="8708" bIns="4361" rtlCol="0" anchor="t">
+          <a:bodyPr vert="horz" wrap="square" lIns="8708" tIns="8723" rIns="8708" bIns="8723" rtlCol="0" anchor="t">
             <a:noAutofit/>
           </a:bodyPr>
           <a:lstStyle/>
@@ -6117,7 +6133,7 @@
           <p:cNvPr id="61" name="reasoning_card">
             <a:extLst>
               <a:ext uri="{FF2B5EF4-FFF2-40B4-BE49-F238E27FC236}">
-                <a16:creationId xmlns:a16="http://schemas.microsoft.com/office/drawing/2014/main" id="{7CFAB46E-3058-05E6-1952-BA7397015429}"/>
+                <a16:creationId xmlns:a16="http://schemas.microsoft.com/office/drawing/2014/main" id="{66EA7FF0-BABF-58D0-4789-D1C4B47B5881}"/>
               </a:ext>
             </a:extLst>
           </p:cNvPr>
@@ -6130,7 +6146,9 @@
             <a:ext cx="1915838" cy="1395663"/>
           </a:xfrm>
           <a:prstGeom prst="roundRect">
-            <a:avLst/>
+            <a:avLst>
+              <a:gd name="adj" fmla="val 9983"/>
+            </a:avLst>
           </a:prstGeom>
           <a:solidFill>
             <a:srgbClr val="FFFFFF"/>
@@ -6178,7 +6196,7 @@
           <p:cNvPr id="62" name="reasoning_icon_dot">
             <a:extLst>
               <a:ext uri="{FF2B5EF4-FFF2-40B4-BE49-F238E27FC236}">
-                <a16:creationId xmlns:a16="http://schemas.microsoft.com/office/drawing/2014/main" id="{E0BC856B-E1E5-828E-BAE0-43426FDB022F}"/>
+                <a16:creationId xmlns:a16="http://schemas.microsoft.com/office/drawing/2014/main" id="{C55BD113-44E4-1596-E1F3-D2AC7669713A}"/>
               </a:ext>
             </a:extLst>
           </p:cNvPr>
@@ -6187,8 +6205,8 @@
         </p:nvSpPr>
         <p:spPr>
           <a:xfrm>
-            <a:off x="3831676" y="3715953"/>
-            <a:ext cx="191583" cy="191904"/>
+            <a:off x="3827321" y="3711592"/>
+            <a:ext cx="217709" cy="218072"/>
           </a:xfrm>
           <a:prstGeom prst="ellipse">
             <a:avLst/>
@@ -6232,7 +6250,7 @@
           <p:cNvPr id="63" name="reasoning_icon_label">
             <a:extLst>
               <a:ext uri="{FF2B5EF4-FFF2-40B4-BE49-F238E27FC236}">
-                <a16:creationId xmlns:a16="http://schemas.microsoft.com/office/drawing/2014/main" id="{EC0D3B44-2886-B359-B2F3-85C50746D13E}"/>
+                <a16:creationId xmlns:a16="http://schemas.microsoft.com/office/drawing/2014/main" id="{462FCB43-4374-71CB-D3BE-A8C16749BC0A}"/>
               </a:ext>
             </a:extLst>
           </p:cNvPr>
@@ -6241,8 +6259,8 @@
         </p:nvSpPr>
         <p:spPr>
           <a:xfrm>
-            <a:off x="3831676" y="3715953"/>
-            <a:ext cx="191584" cy="276999"/>
+            <a:off x="3827321" y="3711592"/>
+            <a:ext cx="217709" cy="276999"/>
           </a:xfrm>
           <a:prstGeom prst="rect">
             <a:avLst/>
@@ -6279,7 +6297,7 @@
           <p:cNvPr id="64" name="reasoning_title">
             <a:extLst>
               <a:ext uri="{FF2B5EF4-FFF2-40B4-BE49-F238E27FC236}">
-                <a16:creationId xmlns:a16="http://schemas.microsoft.com/office/drawing/2014/main" id="{2D57FABE-16B2-1E3B-2635-E0E32D2B940F}"/>
+                <a16:creationId xmlns:a16="http://schemas.microsoft.com/office/drawing/2014/main" id="{AACC2751-9CE7-F91A-338E-509C15AD2E09}"/>
               </a:ext>
             </a:extLst>
           </p:cNvPr>
@@ -6289,7 +6307,7 @@
         <p:spPr>
           <a:xfrm>
             <a:off x="4162593" y="3707230"/>
-            <a:ext cx="1288836" cy="285806"/>
+            <a:ext cx="1288836" cy="276999"/>
           </a:xfrm>
           <a:prstGeom prst="rect">
             <a:avLst/>
@@ -6297,7 +6315,7 @@
           <a:noFill/>
         </p:spPr>
         <p:txBody>
-          <a:bodyPr vert="horz" wrap="square" lIns="8708" tIns="4361" rIns="8708" bIns="4361" rtlCol="0" anchor="ctr">
+          <a:bodyPr vert="horz" wrap="square" lIns="0" tIns="0" rIns="0" bIns="0" rtlCol="0" anchor="ctr">
             <a:noAutofit/>
           </a:bodyPr>
           <a:lstStyle/>
@@ -6325,7 +6343,7 @@
           <p:cNvPr id="65" name="reasoning_line_0">
             <a:extLst>
               <a:ext uri="{FF2B5EF4-FFF2-40B4-BE49-F238E27FC236}">
-                <a16:creationId xmlns:a16="http://schemas.microsoft.com/office/drawing/2014/main" id="{EDA2DA6B-8F0E-25A3-B81A-37C57BBC06AF}"/>
+                <a16:creationId xmlns:a16="http://schemas.microsoft.com/office/drawing/2014/main" id="{886DDD49-759F-2086-9E89-58EC1A32DB35}"/>
               </a:ext>
             </a:extLst>
           </p:cNvPr>
@@ -6335,7 +6353,7 @@
         <p:spPr>
           <a:xfrm>
             <a:off x="3944884" y="4047423"/>
-            <a:ext cx="1506545" cy="285806"/>
+            <a:ext cx="1506545" cy="294615"/>
           </a:xfrm>
           <a:prstGeom prst="rect">
             <a:avLst/>
@@ -6343,7 +6361,7 @@
           <a:noFill/>
         </p:spPr>
         <p:txBody>
-          <a:bodyPr vert="horz" wrap="square" lIns="8708" tIns="4361" rIns="8708" bIns="4361" rtlCol="0" anchor="t">
+          <a:bodyPr vert="horz" wrap="square" lIns="8708" tIns="8723" rIns="8708" bIns="8723" rtlCol="0" anchor="t">
             <a:noAutofit/>
           </a:bodyPr>
           <a:lstStyle/>
@@ -6371,7 +6389,7 @@
           <p:cNvPr id="66" name="reasoning_guard">
             <a:extLst>
               <a:ext uri="{FF2B5EF4-FFF2-40B4-BE49-F238E27FC236}">
-                <a16:creationId xmlns:a16="http://schemas.microsoft.com/office/drawing/2014/main" id="{0776E943-6B06-1F98-4860-A1357F67F9D7}"/>
+                <a16:creationId xmlns:a16="http://schemas.microsoft.com/office/drawing/2014/main" id="{FE0F55FF-6710-C229-0CDC-D85D6085FF60}"/>
               </a:ext>
             </a:extLst>
           </p:cNvPr>
@@ -6384,7 +6402,9 @@
             <a:ext cx="1428171" cy="314024"/>
           </a:xfrm>
           <a:prstGeom prst="roundRect">
-            <a:avLst/>
+            <a:avLst>
+              <a:gd name="adj" fmla="val 44370"/>
+            </a:avLst>
           </a:prstGeom>
           <a:solidFill>
             <a:srgbClr val="FFF7E6"/>
@@ -6432,7 +6452,7 @@
           <p:cNvPr id="67" name="reasoning_guard_text">
             <a:extLst>
               <a:ext uri="{FF2B5EF4-FFF2-40B4-BE49-F238E27FC236}">
-                <a16:creationId xmlns:a16="http://schemas.microsoft.com/office/drawing/2014/main" id="{43A91A9A-BAA7-CE9C-F8E6-B0837B49D9C2}"/>
+                <a16:creationId xmlns:a16="http://schemas.microsoft.com/office/drawing/2014/main" id="{2CE1C936-6962-D134-C863-1ABC61F9AA6F}"/>
               </a:ext>
             </a:extLst>
           </p:cNvPr>
@@ -6441,8 +6461,8 @@
         </p:nvSpPr>
         <p:spPr>
           <a:xfrm>
-            <a:off x="3971009" y="4344002"/>
-            <a:ext cx="1288836" cy="285806"/>
+            <a:off x="3971009" y="4309110"/>
+            <a:ext cx="1288836" cy="276999"/>
           </a:xfrm>
           <a:prstGeom prst="rect">
             <a:avLst/>
@@ -6450,7 +6470,7 @@
           <a:noFill/>
         </p:spPr>
         <p:txBody>
-          <a:bodyPr vert="horz" wrap="square" lIns="8708" tIns="4361" rIns="8708" bIns="4361" rtlCol="0" anchor="ctr">
+          <a:bodyPr vert="horz" wrap="square" lIns="0" tIns="0" rIns="0" bIns="0" rtlCol="0" anchor="ctr">
             <a:noAutofit/>
           </a:bodyPr>
           <a:lstStyle/>
@@ -6479,7 +6499,7 @@
           <p:cNvPr id="68" name="reasoning_limit">
             <a:extLst>
               <a:ext uri="{FF2B5EF4-FFF2-40B4-BE49-F238E27FC236}">
-                <a16:creationId xmlns:a16="http://schemas.microsoft.com/office/drawing/2014/main" id="{5557A5EF-F500-CF7E-AF7A-813EB264E286}"/>
+                <a16:creationId xmlns:a16="http://schemas.microsoft.com/office/drawing/2014/main" id="{8B722ED0-5B2A-00AB-87C3-E56656BE0C5C}"/>
               </a:ext>
             </a:extLst>
           </p:cNvPr>
@@ -6489,7 +6509,7 @@
         <p:spPr>
           <a:xfrm>
             <a:off x="3875217" y="4570797"/>
-            <a:ext cx="1480420" cy="285806"/>
+            <a:ext cx="1480420" cy="294615"/>
           </a:xfrm>
           <a:prstGeom prst="rect">
             <a:avLst/>
@@ -6497,7 +6517,7 @@
           <a:noFill/>
         </p:spPr>
         <p:txBody>
-          <a:bodyPr vert="horz" wrap="square" lIns="8708" tIns="4361" rIns="8708" bIns="4361" rtlCol="0" anchor="ctr">
+          <a:bodyPr vert="horz" wrap="square" lIns="8708" tIns="8723" rIns="8708" bIns="8723" rtlCol="0" anchor="ctr">
             <a:noAutofit/>
           </a:bodyPr>
           <a:lstStyle/>
@@ -6525,7 +6545,7 @@
           <p:cNvPr id="69" name="rule_engine_card">
             <a:extLst>
               <a:ext uri="{FF2B5EF4-FFF2-40B4-BE49-F238E27FC236}">
-                <a16:creationId xmlns:a16="http://schemas.microsoft.com/office/drawing/2014/main" id="{0FAE2522-2E30-6A29-7C31-5CAE1883B608}"/>
+                <a16:creationId xmlns:a16="http://schemas.microsoft.com/office/drawing/2014/main" id="{086C6A70-C45D-6B00-D5BD-E7AD215BB1ED}"/>
               </a:ext>
             </a:extLst>
           </p:cNvPr>
@@ -6538,7 +6558,9 @@
             <a:ext cx="3222091" cy="697832"/>
           </a:xfrm>
           <a:prstGeom prst="roundRect">
-            <a:avLst/>
+            <a:avLst>
+              <a:gd name="adj" fmla="val 19967"/>
+            </a:avLst>
           </a:prstGeom>
           <a:solidFill>
             <a:srgbClr val="DCFCE7"/>
@@ -6586,7 +6608,7 @@
           <p:cNvPr id="70" name="rule_engine_title">
             <a:extLst>
               <a:ext uri="{FF2B5EF4-FFF2-40B4-BE49-F238E27FC236}">
-                <a16:creationId xmlns:a16="http://schemas.microsoft.com/office/drawing/2014/main" id="{CA7A1896-88F0-C948-8601-A81DDE7CF547}"/>
+                <a16:creationId xmlns:a16="http://schemas.microsoft.com/office/drawing/2014/main" id="{9BA67C1C-2C12-3A76-EA97-ADC8A94AFA59}"/>
               </a:ext>
             </a:extLst>
           </p:cNvPr>
@@ -6596,7 +6618,7 @@
         <p:spPr>
           <a:xfrm>
             <a:off x="6487723" y="2307206"/>
-            <a:ext cx="2699590" cy="285806"/>
+            <a:ext cx="2699590" cy="294615"/>
           </a:xfrm>
           <a:prstGeom prst="rect">
             <a:avLst/>
@@ -6604,7 +6626,7 @@
           <a:noFill/>
         </p:spPr>
         <p:txBody>
-          <a:bodyPr vert="horz" wrap="square" lIns="8708" tIns="4361" rIns="8708" bIns="4361" rtlCol="0" anchor="ctr">
+          <a:bodyPr vert="horz" wrap="square" lIns="8708" tIns="8723" rIns="8708" bIns="8723" rtlCol="0" anchor="ctr">
             <a:noAutofit/>
           </a:bodyPr>
           <a:lstStyle/>
@@ -6632,7 +6654,7 @@
           <p:cNvPr id="71" name="rule_engine_body">
             <a:extLst>
               <a:ext uri="{FF2B5EF4-FFF2-40B4-BE49-F238E27FC236}">
-                <a16:creationId xmlns:a16="http://schemas.microsoft.com/office/drawing/2014/main" id="{3A0B975F-FD5A-1869-A989-9F29E9C1970F}"/>
+                <a16:creationId xmlns:a16="http://schemas.microsoft.com/office/drawing/2014/main" id="{EDF2928A-EB1F-5DEC-3A6E-E6EC4AFD4114}"/>
               </a:ext>
             </a:extLst>
           </p:cNvPr>
@@ -6642,7 +6664,7 @@
         <p:spPr>
           <a:xfrm>
             <a:off x="6487723" y="2577615"/>
-            <a:ext cx="2699590" cy="285806"/>
+            <a:ext cx="2699590" cy="294615"/>
           </a:xfrm>
           <a:prstGeom prst="rect">
             <a:avLst/>
@@ -6650,7 +6672,7 @@
           <a:noFill/>
         </p:spPr>
         <p:txBody>
-          <a:bodyPr vert="horz" wrap="square" lIns="8708" tIns="4361" rIns="8708" bIns="4361" rtlCol="0" anchor="ctr">
+          <a:bodyPr vert="horz" wrap="square" lIns="8708" tIns="8723" rIns="8708" bIns="8723" rtlCol="0" anchor="ctr">
             <a:noAutofit/>
           </a:bodyPr>
           <a:lstStyle/>
@@ -6678,7 +6700,7 @@
           <p:cNvPr id="72" name="features_card">
             <a:extLst>
               <a:ext uri="{FF2B5EF4-FFF2-40B4-BE49-F238E27FC236}">
-                <a16:creationId xmlns:a16="http://schemas.microsoft.com/office/drawing/2014/main" id="{5044963E-2023-AB4A-2A66-20380EEB9466}"/>
+                <a16:creationId xmlns:a16="http://schemas.microsoft.com/office/drawing/2014/main" id="{69CDCB23-4125-3009-1F7B-AE288D714E40}"/>
               </a:ext>
             </a:extLst>
           </p:cNvPr>
@@ -6691,7 +6713,9 @@
             <a:ext cx="1079836" cy="889735"/>
           </a:xfrm>
           <a:prstGeom prst="roundRect">
-            <a:avLst/>
+            <a:avLst>
+              <a:gd name="adj" fmla="val 15660"/>
+            </a:avLst>
           </a:prstGeom>
           <a:solidFill>
             <a:srgbClr val="F8FAFC"/>
@@ -6739,7 +6763,7 @@
           <p:cNvPr id="73" name="features_icon_dot">
             <a:extLst>
               <a:ext uri="{FF2B5EF4-FFF2-40B4-BE49-F238E27FC236}">
-                <a16:creationId xmlns:a16="http://schemas.microsoft.com/office/drawing/2014/main" id="{6034F9BC-76F6-7829-0F62-1E44DC38D173}"/>
+                <a16:creationId xmlns:a16="http://schemas.microsoft.com/office/drawing/2014/main" id="{D3BC89BB-2868-B14E-60CD-5C9C9B8ADD33}"/>
               </a:ext>
             </a:extLst>
           </p:cNvPr>
@@ -6749,7 +6773,7 @@
         <p:spPr>
           <a:xfrm>
             <a:off x="6182931" y="3253640"/>
-            <a:ext cx="139334" cy="139566"/>
+            <a:ext cx="156751" cy="157012"/>
           </a:xfrm>
           <a:prstGeom prst="ellipse">
             <a:avLst/>
@@ -6793,7 +6817,7 @@
           <p:cNvPr id="74" name="features_icon_label">
             <a:extLst>
               <a:ext uri="{FF2B5EF4-FFF2-40B4-BE49-F238E27FC236}">
-                <a16:creationId xmlns:a16="http://schemas.microsoft.com/office/drawing/2014/main" id="{A4931AE5-65D2-ED50-A225-90CB7FD51542}"/>
+                <a16:creationId xmlns:a16="http://schemas.microsoft.com/office/drawing/2014/main" id="{3393217C-DB37-CF1D-A493-CEA29CA2B23A}"/>
               </a:ext>
             </a:extLst>
           </p:cNvPr>
@@ -6803,7 +6827,7 @@
         <p:spPr>
           <a:xfrm>
             <a:off x="6182931" y="3253640"/>
-            <a:ext cx="139334" cy="276999"/>
+            <a:ext cx="156750" cy="276999"/>
           </a:xfrm>
           <a:prstGeom prst="rect">
             <a:avLst/>
@@ -6840,7 +6864,7 @@
           <p:cNvPr id="75" name="features_title">
             <a:extLst>
               <a:ext uri="{FF2B5EF4-FFF2-40B4-BE49-F238E27FC236}">
-                <a16:creationId xmlns:a16="http://schemas.microsoft.com/office/drawing/2014/main" id="{FDF0E03F-ED45-4969-8AAF-A803BFFDAF21}"/>
+                <a16:creationId xmlns:a16="http://schemas.microsoft.com/office/drawing/2014/main" id="{228EEAF0-5FDA-0A00-9A85-FAD3DC419DB8}"/>
               </a:ext>
             </a:extLst>
           </p:cNvPr>
@@ -6849,8 +6873,8 @@
         </p:nvSpPr>
         <p:spPr>
           <a:xfrm>
-            <a:off x="6426765" y="3218748"/>
-            <a:ext cx="592168" cy="285806"/>
+            <a:off x="6452890" y="3218748"/>
+            <a:ext cx="566043" cy="276999"/>
           </a:xfrm>
           <a:prstGeom prst="rect">
             <a:avLst/>
@@ -6858,7 +6882,7 @@
           <a:noFill/>
         </p:spPr>
         <p:txBody>
-          <a:bodyPr vert="horz" wrap="square" lIns="8708" tIns="4361" rIns="8708" bIns="4361" rtlCol="0" anchor="ctr">
+          <a:bodyPr vert="horz" wrap="square" lIns="0" tIns="0" rIns="0" bIns="0" rtlCol="0" anchor="ctr">
             <a:noAutofit/>
           </a:bodyPr>
           <a:lstStyle/>
@@ -6886,7 +6910,7 @@
           <p:cNvPr id="76" name="features_line_0">
             <a:extLst>
               <a:ext uri="{FF2B5EF4-FFF2-40B4-BE49-F238E27FC236}">
-                <a16:creationId xmlns:a16="http://schemas.microsoft.com/office/drawing/2014/main" id="{B539948D-B4E1-A0D8-9821-A811EADADBEB}"/>
+                <a16:creationId xmlns:a16="http://schemas.microsoft.com/office/drawing/2014/main" id="{9F732D61-2E38-D08C-BA5F-3A63534AE8E0}"/>
               </a:ext>
             </a:extLst>
           </p:cNvPr>
@@ -6895,8 +6919,8 @@
         </p:nvSpPr>
         <p:spPr>
           <a:xfrm>
-            <a:off x="6252598" y="3558941"/>
-            <a:ext cx="766335" cy="285806"/>
+            <a:off x="6261306" y="3558941"/>
+            <a:ext cx="757627" cy="294615"/>
           </a:xfrm>
           <a:prstGeom prst="rect">
             <a:avLst/>
@@ -6904,7 +6928,7 @@
           <a:noFill/>
         </p:spPr>
         <p:txBody>
-          <a:bodyPr vert="horz" wrap="square" lIns="8708" tIns="4361" rIns="8708" bIns="4361" rtlCol="0" anchor="t">
+          <a:bodyPr vert="horz" wrap="square" lIns="8708" tIns="8723" rIns="8708" bIns="8723" rtlCol="0" anchor="t">
             <a:noAutofit/>
           </a:bodyPr>
           <a:lstStyle/>
@@ -6932,7 +6956,7 @@
           <p:cNvPr id="77" name="features_line_1">
             <a:extLst>
               <a:ext uri="{FF2B5EF4-FFF2-40B4-BE49-F238E27FC236}">
-                <a16:creationId xmlns:a16="http://schemas.microsoft.com/office/drawing/2014/main" id="{20B7B708-1E69-3EEF-7355-3259C85CC305}"/>
+                <a16:creationId xmlns:a16="http://schemas.microsoft.com/office/drawing/2014/main" id="{1F52701B-5D07-DF51-6AF4-954644192479}"/>
               </a:ext>
             </a:extLst>
           </p:cNvPr>
@@ -6941,8 +6965,8 @@
         </p:nvSpPr>
         <p:spPr>
           <a:xfrm>
-            <a:off x="6252598" y="3733399"/>
-            <a:ext cx="766335" cy="285806"/>
+            <a:off x="6261306" y="3733399"/>
+            <a:ext cx="757627" cy="294615"/>
           </a:xfrm>
           <a:prstGeom prst="rect">
             <a:avLst/>
@@ -6950,7 +6974,7 @@
           <a:noFill/>
         </p:spPr>
         <p:txBody>
-          <a:bodyPr vert="horz" wrap="square" lIns="8708" tIns="4361" rIns="8708" bIns="4361" rtlCol="0" anchor="t">
+          <a:bodyPr vert="horz" wrap="square" lIns="8708" tIns="8723" rIns="8708" bIns="8723" rtlCol="0" anchor="t">
             <a:noAutofit/>
           </a:bodyPr>
           <a:lstStyle/>
@@ -6978,7 +7002,7 @@
           <p:cNvPr id="78" name="recipes_card">
             <a:extLst>
               <a:ext uri="{FF2B5EF4-FFF2-40B4-BE49-F238E27FC236}">
-                <a16:creationId xmlns:a16="http://schemas.microsoft.com/office/drawing/2014/main" id="{895E0EA3-3652-7C5F-33BA-4A33ADF07977}"/>
+                <a16:creationId xmlns:a16="http://schemas.microsoft.com/office/drawing/2014/main" id="{D2DA1030-908A-EC05-09B9-80AD68500334}"/>
               </a:ext>
             </a:extLst>
           </p:cNvPr>
@@ -6991,7 +7015,9 @@
             <a:ext cx="1079836" cy="889735"/>
           </a:xfrm>
           <a:prstGeom prst="roundRect">
-            <a:avLst/>
+            <a:avLst>
+              <a:gd name="adj" fmla="val 15660"/>
+            </a:avLst>
           </a:prstGeom>
           <a:solidFill>
             <a:srgbClr val="F8FAFC"/>
@@ -7039,7 +7065,7 @@
           <p:cNvPr id="79" name="recipes_icon_dot">
             <a:extLst>
               <a:ext uri="{FF2B5EF4-FFF2-40B4-BE49-F238E27FC236}">
-                <a16:creationId xmlns:a16="http://schemas.microsoft.com/office/drawing/2014/main" id="{3B29158A-9D3A-1C10-542B-4FFAAA8C7B9D}"/>
+                <a16:creationId xmlns:a16="http://schemas.microsoft.com/office/drawing/2014/main" id="{A5986A28-3205-E76B-87C8-309991B1F90B}"/>
               </a:ext>
             </a:extLst>
           </p:cNvPr>
@@ -7049,7 +7075,7 @@
         <p:spPr>
           <a:xfrm>
             <a:off x="7419518" y="3253640"/>
-            <a:ext cx="139333" cy="139566"/>
+            <a:ext cx="156750" cy="157012"/>
           </a:xfrm>
           <a:prstGeom prst="ellipse">
             <a:avLst/>
@@ -7093,7 +7119,7 @@
           <p:cNvPr id="80" name="recipes_icon_label">
             <a:extLst>
               <a:ext uri="{FF2B5EF4-FFF2-40B4-BE49-F238E27FC236}">
-                <a16:creationId xmlns:a16="http://schemas.microsoft.com/office/drawing/2014/main" id="{D6614EFE-66AD-98D9-6F57-97FEFDAF50CA}"/>
+                <a16:creationId xmlns:a16="http://schemas.microsoft.com/office/drawing/2014/main" id="{DE17B9C6-82F9-3354-A9B0-E9F15BF6D0B8}"/>
               </a:ext>
             </a:extLst>
           </p:cNvPr>
@@ -7103,7 +7129,7 @@
         <p:spPr>
           <a:xfrm>
             <a:off x="7419518" y="3253640"/>
-            <a:ext cx="139334" cy="276999"/>
+            <a:ext cx="156750" cy="276999"/>
           </a:xfrm>
           <a:prstGeom prst="rect">
             <a:avLst/>
@@ -7140,7 +7166,7 @@
           <p:cNvPr id="81" name="recipes_title">
             <a:extLst>
               <a:ext uri="{FF2B5EF4-FFF2-40B4-BE49-F238E27FC236}">
-                <a16:creationId xmlns:a16="http://schemas.microsoft.com/office/drawing/2014/main" id="{A04A8D6B-04EC-6D95-BE9D-0EE322BA8B75}"/>
+                <a16:creationId xmlns:a16="http://schemas.microsoft.com/office/drawing/2014/main" id="{E9036F68-A58B-57CF-1B28-B2E1AF65A53B}"/>
               </a:ext>
             </a:extLst>
           </p:cNvPr>
@@ -7149,8 +7175,8 @@
         </p:nvSpPr>
         <p:spPr>
           <a:xfrm>
-            <a:off x="7663352" y="3218748"/>
-            <a:ext cx="592168" cy="285806"/>
+            <a:off x="7689476" y="3218748"/>
+            <a:ext cx="566043" cy="276999"/>
           </a:xfrm>
           <a:prstGeom prst="rect">
             <a:avLst/>
@@ -7158,7 +7184,7 @@
           <a:noFill/>
         </p:spPr>
         <p:txBody>
-          <a:bodyPr vert="horz" wrap="square" lIns="8708" tIns="4361" rIns="8708" bIns="4361" rtlCol="0" anchor="ctr">
+          <a:bodyPr vert="horz" wrap="square" lIns="0" tIns="0" rIns="0" bIns="0" rtlCol="0" anchor="ctr">
             <a:noAutofit/>
           </a:bodyPr>
           <a:lstStyle/>
@@ -7186,7 +7212,7 @@
           <p:cNvPr id="82" name="recipes_line_0">
             <a:extLst>
               <a:ext uri="{FF2B5EF4-FFF2-40B4-BE49-F238E27FC236}">
-                <a16:creationId xmlns:a16="http://schemas.microsoft.com/office/drawing/2014/main" id="{6E8DB9B4-81F9-1E65-D9A6-F5B9040D2FFC}"/>
+                <a16:creationId xmlns:a16="http://schemas.microsoft.com/office/drawing/2014/main" id="{C86B3465-3C29-515F-2937-4B13C15D8BA8}"/>
               </a:ext>
             </a:extLst>
           </p:cNvPr>
@@ -7195,8 +7221,8 @@
         </p:nvSpPr>
         <p:spPr>
           <a:xfrm>
-            <a:off x="7489184" y="3558941"/>
-            <a:ext cx="766335" cy="285806"/>
+            <a:off x="7497893" y="3558941"/>
+            <a:ext cx="757627" cy="294615"/>
           </a:xfrm>
           <a:prstGeom prst="rect">
             <a:avLst/>
@@ -7204,7 +7230,7 @@
           <a:noFill/>
         </p:spPr>
         <p:txBody>
-          <a:bodyPr vert="horz" wrap="square" lIns="8708" tIns="4361" rIns="8708" bIns="4361" rtlCol="0" anchor="t">
+          <a:bodyPr vert="horz" wrap="square" lIns="8708" tIns="8723" rIns="8708" bIns="8723" rtlCol="0" anchor="t">
             <a:noAutofit/>
           </a:bodyPr>
           <a:lstStyle/>
@@ -7232,7 +7258,7 @@
           <p:cNvPr id="83" name="recipes_line_1">
             <a:extLst>
               <a:ext uri="{FF2B5EF4-FFF2-40B4-BE49-F238E27FC236}">
-                <a16:creationId xmlns:a16="http://schemas.microsoft.com/office/drawing/2014/main" id="{02A3FC23-8BEF-2FAD-7AC6-7410D529A457}"/>
+                <a16:creationId xmlns:a16="http://schemas.microsoft.com/office/drawing/2014/main" id="{B9151A42-783A-3DD3-2B14-C8625D7BCF14}"/>
               </a:ext>
             </a:extLst>
           </p:cNvPr>
@@ -7241,8 +7267,8 @@
         </p:nvSpPr>
         <p:spPr>
           <a:xfrm>
-            <a:off x="7489184" y="3733399"/>
-            <a:ext cx="766335" cy="285806"/>
+            <a:off x="7497893" y="3733399"/>
+            <a:ext cx="757627" cy="294615"/>
           </a:xfrm>
           <a:prstGeom prst="rect">
             <a:avLst/>
@@ -7250,7 +7276,7 @@
           <a:noFill/>
         </p:spPr>
         <p:txBody>
-          <a:bodyPr vert="horz" wrap="square" lIns="8708" tIns="4361" rIns="8708" bIns="4361" rtlCol="0" anchor="t">
+          <a:bodyPr vert="horz" wrap="square" lIns="8708" tIns="8723" rIns="8708" bIns="8723" rtlCol="0" anchor="t">
             <a:noAutofit/>
           </a:bodyPr>
           <a:lstStyle/>
@@ -7278,7 +7304,7 @@
           <p:cNvPr id="84" name="theme_card">
             <a:extLst>
               <a:ext uri="{FF2B5EF4-FFF2-40B4-BE49-F238E27FC236}">
-                <a16:creationId xmlns:a16="http://schemas.microsoft.com/office/drawing/2014/main" id="{3277B260-336D-1B8B-244F-9A2D9ED0AD45}"/>
+                <a16:creationId xmlns:a16="http://schemas.microsoft.com/office/drawing/2014/main" id="{041BC948-2B8A-DCF4-36A1-7243F636D089}"/>
               </a:ext>
             </a:extLst>
           </p:cNvPr>
@@ -7291,7 +7317,9 @@
             <a:ext cx="1079835" cy="889735"/>
           </a:xfrm>
           <a:prstGeom prst="roundRect">
-            <a:avLst/>
+            <a:avLst>
+              <a:gd name="adj" fmla="val 15660"/>
+            </a:avLst>
           </a:prstGeom>
           <a:solidFill>
             <a:srgbClr val="F8FAFC"/>
@@ -7339,7 +7367,7 @@
           <p:cNvPr id="85" name="theme_icon_dot">
             <a:extLst>
               <a:ext uri="{FF2B5EF4-FFF2-40B4-BE49-F238E27FC236}">
-                <a16:creationId xmlns:a16="http://schemas.microsoft.com/office/drawing/2014/main" id="{C769E464-2E6C-93EF-3D3B-0B9EDF50A8D4}"/>
+                <a16:creationId xmlns:a16="http://schemas.microsoft.com/office/drawing/2014/main" id="{C272F0E8-00F2-B8B7-A005-3D8798A9F866}"/>
               </a:ext>
             </a:extLst>
           </p:cNvPr>
@@ -7349,7 +7377,7 @@
         <p:spPr>
           <a:xfrm>
             <a:off x="8656103" y="3253640"/>
-            <a:ext cx="139334" cy="139566"/>
+            <a:ext cx="156751" cy="157012"/>
           </a:xfrm>
           <a:prstGeom prst="ellipse">
             <a:avLst/>
@@ -7393,7 +7421,7 @@
           <p:cNvPr id="86" name="theme_icon_label">
             <a:extLst>
               <a:ext uri="{FF2B5EF4-FFF2-40B4-BE49-F238E27FC236}">
-                <a16:creationId xmlns:a16="http://schemas.microsoft.com/office/drawing/2014/main" id="{6F0F8C5F-2FB6-81A7-F61C-5517F6CD3B1F}"/>
+                <a16:creationId xmlns:a16="http://schemas.microsoft.com/office/drawing/2014/main" id="{FF8400D9-68DF-0874-6FAD-491CCBB89ABA}"/>
               </a:ext>
             </a:extLst>
           </p:cNvPr>
@@ -7403,7 +7431,7 @@
         <p:spPr>
           <a:xfrm>
             <a:off x="8656103" y="3253640"/>
-            <a:ext cx="139334" cy="276999"/>
+            <a:ext cx="156750" cy="276999"/>
           </a:xfrm>
           <a:prstGeom prst="rect">
             <a:avLst/>
@@ -7440,7 +7468,7 @@
           <p:cNvPr id="87" name="theme_title">
             <a:extLst>
               <a:ext uri="{FF2B5EF4-FFF2-40B4-BE49-F238E27FC236}">
-                <a16:creationId xmlns:a16="http://schemas.microsoft.com/office/drawing/2014/main" id="{14616B5C-C269-FF99-650E-3C35FFC5994E}"/>
+                <a16:creationId xmlns:a16="http://schemas.microsoft.com/office/drawing/2014/main" id="{088884F8-695F-D1A4-7CCB-66F89DEFBCF7}"/>
               </a:ext>
             </a:extLst>
           </p:cNvPr>
@@ -7449,8 +7477,8 @@
         </p:nvSpPr>
         <p:spPr>
           <a:xfrm>
-            <a:off x="8899937" y="3218748"/>
-            <a:ext cx="592168" cy="285806"/>
+            <a:off x="8926063" y="3218748"/>
+            <a:ext cx="566043" cy="276999"/>
           </a:xfrm>
           <a:prstGeom prst="rect">
             <a:avLst/>
@@ -7458,7 +7486,7 @@
           <a:noFill/>
         </p:spPr>
         <p:txBody>
-          <a:bodyPr vert="horz" wrap="square" lIns="8708" tIns="4361" rIns="8708" bIns="4361" rtlCol="0" anchor="ctr">
+          <a:bodyPr vert="horz" wrap="square" lIns="0" tIns="0" rIns="0" bIns="0" rtlCol="0" anchor="ctr">
             <a:noAutofit/>
           </a:bodyPr>
           <a:lstStyle/>
@@ -7486,7 +7514,7 @@
           <p:cNvPr id="88" name="theme_line_0">
             <a:extLst>
               <a:ext uri="{FF2B5EF4-FFF2-40B4-BE49-F238E27FC236}">
-                <a16:creationId xmlns:a16="http://schemas.microsoft.com/office/drawing/2014/main" id="{8C7E63E5-7413-A24D-2E13-80197B83881B}"/>
+                <a16:creationId xmlns:a16="http://schemas.microsoft.com/office/drawing/2014/main" id="{55C6FB5A-47F3-B599-E123-0D9A61287FB8}"/>
               </a:ext>
             </a:extLst>
           </p:cNvPr>
@@ -7495,8 +7523,8 @@
         </p:nvSpPr>
         <p:spPr>
           <a:xfrm>
-            <a:off x="8725770" y="3558941"/>
-            <a:ext cx="766335" cy="285806"/>
+            <a:off x="8734478" y="3558941"/>
+            <a:ext cx="757627" cy="294615"/>
           </a:xfrm>
           <a:prstGeom prst="rect">
             <a:avLst/>
@@ -7504,7 +7532,7 @@
           <a:noFill/>
         </p:spPr>
         <p:txBody>
-          <a:bodyPr vert="horz" wrap="square" lIns="8708" tIns="4361" rIns="8708" bIns="4361" rtlCol="0" anchor="t">
+          <a:bodyPr vert="horz" wrap="square" lIns="8708" tIns="8723" rIns="8708" bIns="8723" rtlCol="0" anchor="t">
             <a:noAutofit/>
           </a:bodyPr>
           <a:lstStyle/>
@@ -7532,7 +7560,7 @@
           <p:cNvPr id="89" name="theme_line_1">
             <a:extLst>
               <a:ext uri="{FF2B5EF4-FFF2-40B4-BE49-F238E27FC236}">
-                <a16:creationId xmlns:a16="http://schemas.microsoft.com/office/drawing/2014/main" id="{35A30D1C-D538-B55A-EF88-3EBAD717B75B}"/>
+                <a16:creationId xmlns:a16="http://schemas.microsoft.com/office/drawing/2014/main" id="{F7AA71BA-A11C-7F64-0351-D8458516E896}"/>
               </a:ext>
             </a:extLst>
           </p:cNvPr>
@@ -7541,8 +7569,8 @@
         </p:nvSpPr>
         <p:spPr>
           <a:xfrm>
-            <a:off x="8725770" y="3733399"/>
-            <a:ext cx="766335" cy="285806"/>
+            <a:off x="8734478" y="3733399"/>
+            <a:ext cx="757627" cy="294615"/>
           </a:xfrm>
           <a:prstGeom prst="rect">
             <a:avLst/>
@@ -7550,7 +7578,7 @@
           <a:noFill/>
         </p:spPr>
         <p:txBody>
-          <a:bodyPr vert="horz" wrap="square" lIns="8708" tIns="4361" rIns="8708" bIns="4361" rtlCol="0" anchor="t">
+          <a:bodyPr vert="horz" wrap="square" lIns="8708" tIns="8723" rIns="8708" bIns="8723" rtlCol="0" anchor="t">
             <a:noAutofit/>
           </a:bodyPr>
           <a:lstStyle/>
@@ -7578,7 +7606,7 @@
           <p:cNvPr id="90" name="compose_card">
             <a:extLst>
               <a:ext uri="{FF2B5EF4-FFF2-40B4-BE49-F238E27FC236}">
-                <a16:creationId xmlns:a16="http://schemas.microsoft.com/office/drawing/2014/main" id="{E1E56A42-7D5D-92E9-9D6C-8E0BF7D80E05}"/>
+                <a16:creationId xmlns:a16="http://schemas.microsoft.com/office/drawing/2014/main" id="{DD9B547F-FB92-FCA6-FCBB-B9F07149E06C}"/>
               </a:ext>
             </a:extLst>
           </p:cNvPr>
@@ -7591,7 +7619,9 @@
             <a:ext cx="1079836" cy="889735"/>
           </a:xfrm>
           <a:prstGeom prst="roundRect">
-            <a:avLst/>
+            <a:avLst>
+              <a:gd name="adj" fmla="val 15660"/>
+            </a:avLst>
           </a:prstGeom>
           <a:solidFill>
             <a:srgbClr val="F8FAFC"/>
@@ -7639,7 +7669,7 @@
           <p:cNvPr id="91" name="compose_icon_dot">
             <a:extLst>
               <a:ext uri="{FF2B5EF4-FFF2-40B4-BE49-F238E27FC236}">
-                <a16:creationId xmlns:a16="http://schemas.microsoft.com/office/drawing/2014/main" id="{E9CE3CE9-AD71-8B9C-BB46-15B250EF4700}"/>
+                <a16:creationId xmlns:a16="http://schemas.microsoft.com/office/drawing/2014/main" id="{3B405590-4B6D-379B-F2FE-D56DB92A7AA7}"/>
               </a:ext>
             </a:extLst>
           </p:cNvPr>
@@ -7649,7 +7679,7 @@
         <p:spPr>
           <a:xfrm>
             <a:off x="6182931" y="4248050"/>
-            <a:ext cx="139334" cy="139566"/>
+            <a:ext cx="156751" cy="157012"/>
           </a:xfrm>
           <a:prstGeom prst="ellipse">
             <a:avLst/>
@@ -7693,7 +7723,7 @@
           <p:cNvPr id="92" name="compose_icon_label">
             <a:extLst>
               <a:ext uri="{FF2B5EF4-FFF2-40B4-BE49-F238E27FC236}">
-                <a16:creationId xmlns:a16="http://schemas.microsoft.com/office/drawing/2014/main" id="{DBCC12D4-2A7F-33E0-8BC6-A0AA56758991}"/>
+                <a16:creationId xmlns:a16="http://schemas.microsoft.com/office/drawing/2014/main" id="{C229D5CE-E174-3AD5-68C6-A8BCB5CC82A7}"/>
               </a:ext>
             </a:extLst>
           </p:cNvPr>
@@ -7703,7 +7733,7 @@
         <p:spPr>
           <a:xfrm>
             <a:off x="6182931" y="4248050"/>
-            <a:ext cx="139334" cy="276999"/>
+            <a:ext cx="156750" cy="276999"/>
           </a:xfrm>
           <a:prstGeom prst="rect">
             <a:avLst/>
@@ -7740,7 +7770,7 @@
           <p:cNvPr id="93" name="compose_title">
             <a:extLst>
               <a:ext uri="{FF2B5EF4-FFF2-40B4-BE49-F238E27FC236}">
-                <a16:creationId xmlns:a16="http://schemas.microsoft.com/office/drawing/2014/main" id="{6268DA5F-7730-4C3B-F3E5-4375ED140AD1}"/>
+                <a16:creationId xmlns:a16="http://schemas.microsoft.com/office/drawing/2014/main" id="{2743A83D-9416-0E7E-F890-55A0BB19EC00}"/>
               </a:ext>
             </a:extLst>
           </p:cNvPr>
@@ -7749,8 +7779,8 @@
         </p:nvSpPr>
         <p:spPr>
           <a:xfrm>
-            <a:off x="6426765" y="4213158"/>
-            <a:ext cx="592168" cy="285806"/>
+            <a:off x="6452890" y="4213158"/>
+            <a:ext cx="566043" cy="276999"/>
           </a:xfrm>
           <a:prstGeom prst="rect">
             <a:avLst/>
@@ -7758,7 +7788,7 @@
           <a:noFill/>
         </p:spPr>
         <p:txBody>
-          <a:bodyPr vert="horz" wrap="square" lIns="8708" tIns="4361" rIns="8708" bIns="4361" rtlCol="0" anchor="ctr">
+          <a:bodyPr vert="horz" wrap="square" lIns="0" tIns="0" rIns="0" bIns="0" rtlCol="0" anchor="ctr">
             <a:noAutofit/>
           </a:bodyPr>
           <a:lstStyle/>
@@ -7786,7 +7816,7 @@
           <p:cNvPr id="94" name="compose_line_0">
             <a:extLst>
               <a:ext uri="{FF2B5EF4-FFF2-40B4-BE49-F238E27FC236}">
-                <a16:creationId xmlns:a16="http://schemas.microsoft.com/office/drawing/2014/main" id="{A22FB8B8-A106-5469-1933-3055CB1DECFD}"/>
+                <a16:creationId xmlns:a16="http://schemas.microsoft.com/office/drawing/2014/main" id="{B4291D40-F271-4843-A272-1BC8E9113991}"/>
               </a:ext>
             </a:extLst>
           </p:cNvPr>
@@ -7795,8 +7825,8 @@
         </p:nvSpPr>
         <p:spPr>
           <a:xfrm>
-            <a:off x="6252598" y="4553351"/>
-            <a:ext cx="766335" cy="285806"/>
+            <a:off x="6261306" y="4553351"/>
+            <a:ext cx="757627" cy="294615"/>
           </a:xfrm>
           <a:prstGeom prst="rect">
             <a:avLst/>
@@ -7804,7 +7834,7 @@
           <a:noFill/>
         </p:spPr>
         <p:txBody>
-          <a:bodyPr vert="horz" wrap="square" lIns="8708" tIns="4361" rIns="8708" bIns="4361" rtlCol="0" anchor="t">
+          <a:bodyPr vert="horz" wrap="square" lIns="8708" tIns="8723" rIns="8708" bIns="8723" rtlCol="0" anchor="t">
             <a:noAutofit/>
           </a:bodyPr>
           <a:lstStyle/>
@@ -7832,7 +7862,7 @@
           <p:cNvPr id="95" name="compose_line_1">
             <a:extLst>
               <a:ext uri="{FF2B5EF4-FFF2-40B4-BE49-F238E27FC236}">
-                <a16:creationId xmlns:a16="http://schemas.microsoft.com/office/drawing/2014/main" id="{08D7433E-8CA7-C6E6-BB0A-0F50DEBACBAD}"/>
+                <a16:creationId xmlns:a16="http://schemas.microsoft.com/office/drawing/2014/main" id="{22459BDA-8F2E-4981-A792-F093F5342CE0}"/>
               </a:ext>
             </a:extLst>
           </p:cNvPr>
@@ -7841,8 +7871,8 @@
         </p:nvSpPr>
         <p:spPr>
           <a:xfrm>
-            <a:off x="6252598" y="4727809"/>
-            <a:ext cx="766335" cy="285806"/>
+            <a:off x="6261306" y="4727809"/>
+            <a:ext cx="757627" cy="294615"/>
           </a:xfrm>
           <a:prstGeom prst="rect">
             <a:avLst/>
@@ -7850,7 +7880,7 @@
           <a:noFill/>
         </p:spPr>
         <p:txBody>
-          <a:bodyPr vert="horz" wrap="square" lIns="8708" tIns="4361" rIns="8708" bIns="4361" rtlCol="0" anchor="t">
+          <a:bodyPr vert="horz" wrap="square" lIns="8708" tIns="8723" rIns="8708" bIns="8723" rtlCol="0" anchor="t">
             <a:noAutofit/>
           </a:bodyPr>
           <a:lstStyle/>
@@ -7878,7 +7908,7 @@
           <p:cNvPr id="96" name="objects_card">
             <a:extLst>
               <a:ext uri="{FF2B5EF4-FFF2-40B4-BE49-F238E27FC236}">
-                <a16:creationId xmlns:a16="http://schemas.microsoft.com/office/drawing/2014/main" id="{3E4FA430-9DA1-7FBD-A70A-7DA14846319C}"/>
+                <a16:creationId xmlns:a16="http://schemas.microsoft.com/office/drawing/2014/main" id="{C35B82D5-E390-A8CE-C465-0CF3D9052CC5}"/>
               </a:ext>
             </a:extLst>
           </p:cNvPr>
@@ -7891,7 +7921,9 @@
             <a:ext cx="1079836" cy="889735"/>
           </a:xfrm>
           <a:prstGeom prst="roundRect">
-            <a:avLst/>
+            <a:avLst>
+              <a:gd name="adj" fmla="val 15660"/>
+            </a:avLst>
           </a:prstGeom>
           <a:solidFill>
             <a:srgbClr val="F8FAFC"/>
@@ -7939,7 +7971,7 @@
           <p:cNvPr id="97" name="objects_icon_dot">
             <a:extLst>
               <a:ext uri="{FF2B5EF4-FFF2-40B4-BE49-F238E27FC236}">
-                <a16:creationId xmlns:a16="http://schemas.microsoft.com/office/drawing/2014/main" id="{3A1E67F6-743C-917C-F7B4-1C2D786B12BB}"/>
+                <a16:creationId xmlns:a16="http://schemas.microsoft.com/office/drawing/2014/main" id="{13EF4495-E5C4-96E2-7909-EE76B2712D01}"/>
               </a:ext>
             </a:extLst>
           </p:cNvPr>
@@ -7949,7 +7981,7 @@
         <p:spPr>
           <a:xfrm>
             <a:off x="7419518" y="4248050"/>
-            <a:ext cx="139333" cy="139566"/>
+            <a:ext cx="156750" cy="157012"/>
           </a:xfrm>
           <a:prstGeom prst="ellipse">
             <a:avLst/>
@@ -7993,7 +8025,7 @@
           <p:cNvPr id="98" name="objects_icon_label">
             <a:extLst>
               <a:ext uri="{FF2B5EF4-FFF2-40B4-BE49-F238E27FC236}">
-                <a16:creationId xmlns:a16="http://schemas.microsoft.com/office/drawing/2014/main" id="{CC038929-F9CF-9770-38F0-B4A79EB1CAD1}"/>
+                <a16:creationId xmlns:a16="http://schemas.microsoft.com/office/drawing/2014/main" id="{94C1E04D-C64F-1B4A-45CB-908FBFD8835B}"/>
               </a:ext>
             </a:extLst>
           </p:cNvPr>
@@ -8003,7 +8035,7 @@
         <p:spPr>
           <a:xfrm>
             <a:off x="7419518" y="4248050"/>
-            <a:ext cx="139334" cy="276999"/>
+            <a:ext cx="156750" cy="276999"/>
           </a:xfrm>
           <a:prstGeom prst="rect">
             <a:avLst/>
@@ -8040,7 +8072,7 @@
           <p:cNvPr id="99" name="objects_title">
             <a:extLst>
               <a:ext uri="{FF2B5EF4-FFF2-40B4-BE49-F238E27FC236}">
-                <a16:creationId xmlns:a16="http://schemas.microsoft.com/office/drawing/2014/main" id="{9B96C8C5-A9E7-50D9-A857-6BB3E297F68F}"/>
+                <a16:creationId xmlns:a16="http://schemas.microsoft.com/office/drawing/2014/main" id="{0EF296BA-EB7E-550F-3A54-81A09B5263B3}"/>
               </a:ext>
             </a:extLst>
           </p:cNvPr>
@@ -8049,8 +8081,8 @@
         </p:nvSpPr>
         <p:spPr>
           <a:xfrm>
-            <a:off x="7663352" y="4213158"/>
-            <a:ext cx="592168" cy="285806"/>
+            <a:off x="7689476" y="4213158"/>
+            <a:ext cx="566043" cy="276999"/>
           </a:xfrm>
           <a:prstGeom prst="rect">
             <a:avLst/>
@@ -8058,7 +8090,7 @@
           <a:noFill/>
         </p:spPr>
         <p:txBody>
-          <a:bodyPr vert="horz" wrap="square" lIns="8708" tIns="4361" rIns="8708" bIns="4361" rtlCol="0" anchor="ctr">
+          <a:bodyPr vert="horz" wrap="square" lIns="0" tIns="0" rIns="0" bIns="0" rtlCol="0" anchor="ctr">
             <a:noAutofit/>
           </a:bodyPr>
           <a:lstStyle/>
@@ -8086,7 +8118,7 @@
           <p:cNvPr id="100" name="objects_line_0">
             <a:extLst>
               <a:ext uri="{FF2B5EF4-FFF2-40B4-BE49-F238E27FC236}">
-                <a16:creationId xmlns:a16="http://schemas.microsoft.com/office/drawing/2014/main" id="{5B562D2E-1EF5-6BA2-9C44-FA763B225895}"/>
+                <a16:creationId xmlns:a16="http://schemas.microsoft.com/office/drawing/2014/main" id="{8BB7F4C2-292A-3D52-EB04-5ABEB3D3F52D}"/>
               </a:ext>
             </a:extLst>
           </p:cNvPr>
@@ -8095,8 +8127,8 @@
         </p:nvSpPr>
         <p:spPr>
           <a:xfrm>
-            <a:off x="7489184" y="4553351"/>
-            <a:ext cx="766335" cy="285806"/>
+            <a:off x="7497893" y="4553351"/>
+            <a:ext cx="757627" cy="294615"/>
           </a:xfrm>
           <a:prstGeom prst="rect">
             <a:avLst/>
@@ -8104,7 +8136,7 @@
           <a:noFill/>
         </p:spPr>
         <p:txBody>
-          <a:bodyPr vert="horz" wrap="square" lIns="8708" tIns="4361" rIns="8708" bIns="4361" rtlCol="0" anchor="t">
+          <a:bodyPr vert="horz" wrap="square" lIns="8708" tIns="8723" rIns="8708" bIns="8723" rtlCol="0" anchor="t">
             <a:noAutofit/>
           </a:bodyPr>
           <a:lstStyle/>
@@ -8132,7 +8164,7 @@
           <p:cNvPr id="101" name="objects_line_1">
             <a:extLst>
               <a:ext uri="{FF2B5EF4-FFF2-40B4-BE49-F238E27FC236}">
-                <a16:creationId xmlns:a16="http://schemas.microsoft.com/office/drawing/2014/main" id="{D1EA289C-36C2-26CF-A24B-FC606EC4D5B3}"/>
+                <a16:creationId xmlns:a16="http://schemas.microsoft.com/office/drawing/2014/main" id="{3EEC70B0-32B4-BC84-36F1-148E5D83244C}"/>
               </a:ext>
             </a:extLst>
           </p:cNvPr>
@@ -8141,8 +8173,8 @@
         </p:nvSpPr>
         <p:spPr>
           <a:xfrm>
-            <a:off x="7489184" y="4727809"/>
-            <a:ext cx="766335" cy="285806"/>
+            <a:off x="7497893" y="4727809"/>
+            <a:ext cx="757627" cy="294615"/>
           </a:xfrm>
           <a:prstGeom prst="rect">
             <a:avLst/>
@@ -8150,7 +8182,7 @@
           <a:noFill/>
         </p:spPr>
         <p:txBody>
-          <a:bodyPr vert="horz" wrap="square" lIns="8708" tIns="4361" rIns="8708" bIns="4361" rtlCol="0" anchor="t">
+          <a:bodyPr vert="horz" wrap="square" lIns="8708" tIns="8723" rIns="8708" bIns="8723" rtlCol="0" anchor="t">
             <a:noAutofit/>
           </a:bodyPr>
           <a:lstStyle/>
@@ -8178,7 +8210,7 @@
           <p:cNvPr id="102" name="decorate_card">
             <a:extLst>
               <a:ext uri="{FF2B5EF4-FFF2-40B4-BE49-F238E27FC236}">
-                <a16:creationId xmlns:a16="http://schemas.microsoft.com/office/drawing/2014/main" id="{26A791FC-7090-DD16-4855-CD5A55665347}"/>
+                <a16:creationId xmlns:a16="http://schemas.microsoft.com/office/drawing/2014/main" id="{4B35F939-CE91-5AA5-283E-D5942F8835A8}"/>
               </a:ext>
             </a:extLst>
           </p:cNvPr>
@@ -8191,7 +8223,9 @@
             <a:ext cx="1079835" cy="889735"/>
           </a:xfrm>
           <a:prstGeom prst="roundRect">
-            <a:avLst/>
+            <a:avLst>
+              <a:gd name="adj" fmla="val 15660"/>
+            </a:avLst>
           </a:prstGeom>
           <a:solidFill>
             <a:srgbClr val="F8FAFC"/>
@@ -8239,7 +8273,7 @@
           <p:cNvPr id="103" name="decorate_icon_dot">
             <a:extLst>
               <a:ext uri="{FF2B5EF4-FFF2-40B4-BE49-F238E27FC236}">
-                <a16:creationId xmlns:a16="http://schemas.microsoft.com/office/drawing/2014/main" id="{A11223F8-CA01-23EE-E493-9C191549A792}"/>
+                <a16:creationId xmlns:a16="http://schemas.microsoft.com/office/drawing/2014/main" id="{73E826F0-AE8C-45E8-C421-3F9B8CE8DFB0}"/>
               </a:ext>
             </a:extLst>
           </p:cNvPr>
@@ -8249,7 +8283,7 @@
         <p:spPr>
           <a:xfrm>
             <a:off x="8656103" y="4248050"/>
-            <a:ext cx="139334" cy="139566"/>
+            <a:ext cx="156751" cy="157012"/>
           </a:xfrm>
           <a:prstGeom prst="ellipse">
             <a:avLst/>
@@ -8293,7 +8327,7 @@
           <p:cNvPr id="104" name="decorate_icon_label">
             <a:extLst>
               <a:ext uri="{FF2B5EF4-FFF2-40B4-BE49-F238E27FC236}">
-                <a16:creationId xmlns:a16="http://schemas.microsoft.com/office/drawing/2014/main" id="{5B71BE62-4417-7787-39A6-75DAC6E0499D}"/>
+                <a16:creationId xmlns:a16="http://schemas.microsoft.com/office/drawing/2014/main" id="{F4F324B2-7DF9-B5B9-8E37-2992D701B4A7}"/>
               </a:ext>
             </a:extLst>
           </p:cNvPr>
@@ -8303,7 +8337,7 @@
         <p:spPr>
           <a:xfrm>
             <a:off x="8656103" y="4248050"/>
-            <a:ext cx="139334" cy="276999"/>
+            <a:ext cx="156750" cy="276999"/>
           </a:xfrm>
           <a:prstGeom prst="rect">
             <a:avLst/>
@@ -8340,7 +8374,7 @@
           <p:cNvPr id="105" name="decorate_title">
             <a:extLst>
               <a:ext uri="{FF2B5EF4-FFF2-40B4-BE49-F238E27FC236}">
-                <a16:creationId xmlns:a16="http://schemas.microsoft.com/office/drawing/2014/main" id="{DCFE48A8-2CA7-F180-A3BA-30D696B8F832}"/>
+                <a16:creationId xmlns:a16="http://schemas.microsoft.com/office/drawing/2014/main" id="{143F92D6-5A13-0F0A-8ACE-C359D532BAB8}"/>
               </a:ext>
             </a:extLst>
           </p:cNvPr>
@@ -8349,8 +8383,8 @@
         </p:nvSpPr>
         <p:spPr>
           <a:xfrm>
-            <a:off x="8899937" y="4213158"/>
-            <a:ext cx="592168" cy="285806"/>
+            <a:off x="8926063" y="4213158"/>
+            <a:ext cx="566043" cy="276999"/>
           </a:xfrm>
           <a:prstGeom prst="rect">
             <a:avLst/>
@@ -8358,7 +8392,7 @@
           <a:noFill/>
         </p:spPr>
         <p:txBody>
-          <a:bodyPr vert="horz" wrap="square" lIns="8708" tIns="4361" rIns="8708" bIns="4361" rtlCol="0" anchor="ctr">
+          <a:bodyPr vert="horz" wrap="square" lIns="0" tIns="0" rIns="0" bIns="0" rtlCol="0" anchor="ctr">
             <a:noAutofit/>
           </a:bodyPr>
           <a:lstStyle/>
@@ -8386,7 +8420,7 @@
           <p:cNvPr id="106" name="decorate_line_0">
             <a:extLst>
               <a:ext uri="{FF2B5EF4-FFF2-40B4-BE49-F238E27FC236}">
-                <a16:creationId xmlns:a16="http://schemas.microsoft.com/office/drawing/2014/main" id="{232B4E13-23E7-72FD-E6E4-8CB0ED4192D8}"/>
+                <a16:creationId xmlns:a16="http://schemas.microsoft.com/office/drawing/2014/main" id="{69D95B68-5019-26D4-B448-2C5C2C91154E}"/>
               </a:ext>
             </a:extLst>
           </p:cNvPr>
@@ -8395,8 +8429,8 @@
         </p:nvSpPr>
         <p:spPr>
           <a:xfrm>
-            <a:off x="8725770" y="4553351"/>
-            <a:ext cx="766335" cy="285806"/>
+            <a:off x="8734478" y="4553351"/>
+            <a:ext cx="757627" cy="294615"/>
           </a:xfrm>
           <a:prstGeom prst="rect">
             <a:avLst/>
@@ -8404,7 +8438,7 @@
           <a:noFill/>
         </p:spPr>
         <p:txBody>
-          <a:bodyPr vert="horz" wrap="square" lIns="8708" tIns="4361" rIns="8708" bIns="4361" rtlCol="0" anchor="t">
+          <a:bodyPr vert="horz" wrap="square" lIns="8708" tIns="8723" rIns="8708" bIns="8723" rtlCol="0" anchor="t">
             <a:noAutofit/>
           </a:bodyPr>
           <a:lstStyle/>
@@ -8432,7 +8466,7 @@
           <p:cNvPr id="107" name="decorate_line_1">
             <a:extLst>
               <a:ext uri="{FF2B5EF4-FFF2-40B4-BE49-F238E27FC236}">
-                <a16:creationId xmlns:a16="http://schemas.microsoft.com/office/drawing/2014/main" id="{BD97F9A4-E4BC-EDF3-41A3-FF70769634DD}"/>
+                <a16:creationId xmlns:a16="http://schemas.microsoft.com/office/drawing/2014/main" id="{70F97C1D-0BC1-29CB-2847-9680F6B288E1}"/>
               </a:ext>
             </a:extLst>
           </p:cNvPr>
@@ -8441,8 +8475,8 @@
         </p:nvSpPr>
         <p:spPr>
           <a:xfrm>
-            <a:off x="8725770" y="4727809"/>
-            <a:ext cx="766335" cy="285806"/>
+            <a:off x="8734478" y="4727809"/>
+            <a:ext cx="757627" cy="294615"/>
           </a:xfrm>
           <a:prstGeom prst="rect">
             <a:avLst/>
@@ -8450,7 +8484,7 @@
           <a:noFill/>
         </p:spPr>
         <p:txBody>
-          <a:bodyPr vert="horz" wrap="square" lIns="8708" tIns="4361" rIns="8708" bIns="4361" rtlCol="0" anchor="t">
+          <a:bodyPr vert="horz" wrap="square" lIns="8708" tIns="8723" rIns="8708" bIns="8723" rtlCol="0" anchor="t">
             <a:noAutofit/>
           </a:bodyPr>
           <a:lstStyle/>
@@ -8478,7 +8512,7 @@
           <p:cNvPr id="108" name="styled_ir_card">
             <a:extLst>
               <a:ext uri="{FF2B5EF4-FFF2-40B4-BE49-F238E27FC236}">
-                <a16:creationId xmlns:a16="http://schemas.microsoft.com/office/drawing/2014/main" id="{A6280E5B-FF1E-9060-4978-58312EB59736}"/>
+                <a16:creationId xmlns:a16="http://schemas.microsoft.com/office/drawing/2014/main" id="{B9BE7568-CF90-7ADD-31AE-A944D2C42457}"/>
               </a:ext>
             </a:extLst>
           </p:cNvPr>
@@ -8491,7 +8525,9 @@
             <a:ext cx="1706837" cy="915904"/>
           </a:xfrm>
           <a:prstGeom prst="roundRect">
-            <a:avLst/>
+            <a:avLst>
+              <a:gd name="adj" fmla="val 15213"/>
+            </a:avLst>
           </a:prstGeom>
           <a:solidFill>
             <a:srgbClr val="FFFDF8"/>
@@ -8539,7 +8575,7 @@
           <p:cNvPr id="109" name="styled_ir_icon_dot">
             <a:extLst>
               <a:ext uri="{FF2B5EF4-FFF2-40B4-BE49-F238E27FC236}">
-                <a16:creationId xmlns:a16="http://schemas.microsoft.com/office/drawing/2014/main" id="{6E6E374A-9AB8-8696-7D08-CB2A87C71FA7}"/>
+                <a16:creationId xmlns:a16="http://schemas.microsoft.com/office/drawing/2014/main" id="{4F7D190B-7410-AC3A-BDAF-7B19A69BEB77}"/>
               </a:ext>
             </a:extLst>
           </p:cNvPr>
@@ -8548,8 +8584,8 @@
         </p:nvSpPr>
         <p:spPr>
           <a:xfrm>
-            <a:off x="10249733" y="2302844"/>
-            <a:ext cx="191583" cy="191904"/>
+            <a:off x="10245379" y="2298483"/>
+            <a:ext cx="217709" cy="218072"/>
           </a:xfrm>
           <a:prstGeom prst="ellipse">
             <a:avLst/>
@@ -8593,7 +8629,7 @@
           <p:cNvPr id="110" name="styled_ir_icon_label">
             <a:extLst>
               <a:ext uri="{FF2B5EF4-FFF2-40B4-BE49-F238E27FC236}">
-                <a16:creationId xmlns:a16="http://schemas.microsoft.com/office/drawing/2014/main" id="{DF7AC879-3269-4084-25CF-7A554E4C04FA}"/>
+                <a16:creationId xmlns:a16="http://schemas.microsoft.com/office/drawing/2014/main" id="{E07CB734-B9E2-614B-7EE5-474708C953C8}"/>
               </a:ext>
             </a:extLst>
           </p:cNvPr>
@@ -8602,8 +8638,8 @@
         </p:nvSpPr>
         <p:spPr>
           <a:xfrm>
-            <a:off x="10249733" y="2302844"/>
-            <a:ext cx="191584" cy="276999"/>
+            <a:off x="10245379" y="2298483"/>
+            <a:ext cx="217709" cy="276999"/>
           </a:xfrm>
           <a:prstGeom prst="rect">
             <a:avLst/>
@@ -8640,7 +8676,7 @@
           <p:cNvPr id="111" name="styled_ir_title">
             <a:extLst>
               <a:ext uri="{FF2B5EF4-FFF2-40B4-BE49-F238E27FC236}">
-                <a16:creationId xmlns:a16="http://schemas.microsoft.com/office/drawing/2014/main" id="{8F5E8600-A2B7-BAD8-905A-5A0174C6A98A}"/>
+                <a16:creationId xmlns:a16="http://schemas.microsoft.com/office/drawing/2014/main" id="{BC5942FC-6543-C287-8EB9-98B3410F5050}"/>
               </a:ext>
             </a:extLst>
           </p:cNvPr>
@@ -8650,7 +8686,7 @@
         <p:spPr>
           <a:xfrm>
             <a:off x="10580650" y="2294121"/>
-            <a:ext cx="1079836" cy="285806"/>
+            <a:ext cx="1079836" cy="276999"/>
           </a:xfrm>
           <a:prstGeom prst="rect">
             <a:avLst/>
@@ -8658,7 +8694,7 @@
           <a:noFill/>
         </p:spPr>
         <p:txBody>
-          <a:bodyPr vert="horz" wrap="square" lIns="8708" tIns="4361" rIns="8708" bIns="4361" rtlCol="0" anchor="ctr">
+          <a:bodyPr vert="horz" wrap="square" lIns="0" tIns="0" rIns="0" bIns="0" rtlCol="0" anchor="ctr">
             <a:noAutofit/>
           </a:bodyPr>
           <a:lstStyle/>
@@ -8686,7 +8722,7 @@
           <p:cNvPr id="112" name="styled_ir_line_0">
             <a:extLst>
               <a:ext uri="{FF2B5EF4-FFF2-40B4-BE49-F238E27FC236}">
-                <a16:creationId xmlns:a16="http://schemas.microsoft.com/office/drawing/2014/main" id="{D14903F1-A695-A668-F0BA-95E27B4DCB4E}"/>
+                <a16:creationId xmlns:a16="http://schemas.microsoft.com/office/drawing/2014/main" id="{AD08EED1-F99F-0565-7495-4C0EB2E49DFB}"/>
               </a:ext>
             </a:extLst>
           </p:cNvPr>
@@ -8696,7 +8732,7 @@
         <p:spPr>
           <a:xfrm>
             <a:off x="10362941" y="2634314"/>
-            <a:ext cx="1297545" cy="285806"/>
+            <a:ext cx="1297545" cy="294615"/>
           </a:xfrm>
           <a:prstGeom prst="rect">
             <a:avLst/>
@@ -8704,7 +8740,7 @@
           <a:noFill/>
         </p:spPr>
         <p:txBody>
-          <a:bodyPr vert="horz" wrap="square" lIns="8708" tIns="4361" rIns="8708" bIns="4361" rtlCol="0" anchor="t">
+          <a:bodyPr vert="horz" wrap="square" lIns="8708" tIns="8723" rIns="8708" bIns="8723" rtlCol="0" anchor="t">
             <a:noAutofit/>
           </a:bodyPr>
           <a:lstStyle/>
@@ -8732,7 +8768,7 @@
           <p:cNvPr id="113" name="styled_ir_line_1">
             <a:extLst>
               <a:ext uri="{FF2B5EF4-FFF2-40B4-BE49-F238E27FC236}">
-                <a16:creationId xmlns:a16="http://schemas.microsoft.com/office/drawing/2014/main" id="{ADAEA09B-5DF2-0CFD-22A8-863EBA11150D}"/>
+                <a16:creationId xmlns:a16="http://schemas.microsoft.com/office/drawing/2014/main" id="{F9BB74B1-FA3F-B8A4-1A78-2FCB4A321900}"/>
               </a:ext>
             </a:extLst>
           </p:cNvPr>
@@ -8742,7 +8778,7 @@
         <p:spPr>
           <a:xfrm>
             <a:off x="10362941" y="2800049"/>
-            <a:ext cx="1297545" cy="285806"/>
+            <a:ext cx="1297545" cy="294615"/>
           </a:xfrm>
           <a:prstGeom prst="rect">
             <a:avLst/>
@@ -8750,7 +8786,7 @@
           <a:noFill/>
         </p:spPr>
         <p:txBody>
-          <a:bodyPr vert="horz" wrap="square" lIns="8708" tIns="4361" rIns="8708" bIns="4361" rtlCol="0" anchor="t">
+          <a:bodyPr vert="horz" wrap="square" lIns="8708" tIns="8723" rIns="8708" bIns="8723" rtlCol="0" anchor="t">
             <a:noAutofit/>
           </a:bodyPr>
           <a:lstStyle/>
@@ -8778,7 +8814,7 @@
           <p:cNvPr id="114" name="renderers_card">
             <a:extLst>
               <a:ext uri="{FF2B5EF4-FFF2-40B4-BE49-F238E27FC236}">
-                <a16:creationId xmlns:a16="http://schemas.microsoft.com/office/drawing/2014/main" id="{024392AB-265A-B785-8225-138753CF44DF}"/>
+                <a16:creationId xmlns:a16="http://schemas.microsoft.com/office/drawing/2014/main" id="{294C9146-C360-5B6F-0D8B-A44115769DFD}"/>
               </a:ext>
             </a:extLst>
           </p:cNvPr>
@@ -8791,7 +8827,9 @@
             <a:ext cx="1706837" cy="915904"/>
           </a:xfrm>
           <a:prstGeom prst="roundRect">
-            <a:avLst/>
+            <a:avLst>
+              <a:gd name="adj" fmla="val 15213"/>
+            </a:avLst>
           </a:prstGeom>
           <a:solidFill>
             <a:srgbClr val="FFFDF8"/>
@@ -8839,7 +8877,7 @@
           <p:cNvPr id="115" name="renderers_icon_dot">
             <a:extLst>
               <a:ext uri="{FF2B5EF4-FFF2-40B4-BE49-F238E27FC236}">
-                <a16:creationId xmlns:a16="http://schemas.microsoft.com/office/drawing/2014/main" id="{F5693D85-6DF5-0F42-CFE0-7445BAB7C00C}"/>
+                <a16:creationId xmlns:a16="http://schemas.microsoft.com/office/drawing/2014/main" id="{6A65750B-94E3-211A-995B-96CC83EB51C3}"/>
               </a:ext>
             </a:extLst>
           </p:cNvPr>
@@ -8848,8 +8886,8 @@
         </p:nvSpPr>
         <p:spPr>
           <a:xfrm>
-            <a:off x="10249733" y="3628724"/>
-            <a:ext cx="191583" cy="191904"/>
+            <a:off x="10245379" y="3624363"/>
+            <a:ext cx="217709" cy="218072"/>
           </a:xfrm>
           <a:prstGeom prst="ellipse">
             <a:avLst/>
@@ -8893,7 +8931,7 @@
           <p:cNvPr id="116" name="renderers_icon_label">
             <a:extLst>
               <a:ext uri="{FF2B5EF4-FFF2-40B4-BE49-F238E27FC236}">
-                <a16:creationId xmlns:a16="http://schemas.microsoft.com/office/drawing/2014/main" id="{37C89C3C-AF47-AB74-6A7D-16C0493287E6}"/>
+                <a16:creationId xmlns:a16="http://schemas.microsoft.com/office/drawing/2014/main" id="{1A1E07D3-040C-3A47-C37E-BF3DCD3C6783}"/>
               </a:ext>
             </a:extLst>
           </p:cNvPr>
@@ -8902,8 +8940,8 @@
         </p:nvSpPr>
         <p:spPr>
           <a:xfrm>
-            <a:off x="10249733" y="3628724"/>
-            <a:ext cx="191584" cy="276999"/>
+            <a:off x="10245379" y="3624363"/>
+            <a:ext cx="217709" cy="276999"/>
           </a:xfrm>
           <a:prstGeom prst="rect">
             <a:avLst/>
@@ -8940,7 +8978,7 @@
           <p:cNvPr id="117" name="renderers_title">
             <a:extLst>
               <a:ext uri="{FF2B5EF4-FFF2-40B4-BE49-F238E27FC236}">
-                <a16:creationId xmlns:a16="http://schemas.microsoft.com/office/drawing/2014/main" id="{18CB787D-80DF-E9E8-EDE0-E1FC31940340}"/>
+                <a16:creationId xmlns:a16="http://schemas.microsoft.com/office/drawing/2014/main" id="{56DAA560-0D03-7480-8C8E-63B26131A137}"/>
               </a:ext>
             </a:extLst>
           </p:cNvPr>
@@ -8950,7 +8988,7 @@
         <p:spPr>
           <a:xfrm>
             <a:off x="10580650" y="3620001"/>
-            <a:ext cx="1079836" cy="285806"/>
+            <a:ext cx="1079836" cy="276999"/>
           </a:xfrm>
           <a:prstGeom prst="rect">
             <a:avLst/>
@@ -8958,7 +8996,7 @@
           <a:noFill/>
         </p:spPr>
         <p:txBody>
-          <a:bodyPr vert="horz" wrap="square" lIns="8708" tIns="4361" rIns="8708" bIns="4361" rtlCol="0" anchor="ctr">
+          <a:bodyPr vert="horz" wrap="square" lIns="0" tIns="0" rIns="0" bIns="0" rtlCol="0" anchor="ctr">
             <a:noAutofit/>
           </a:bodyPr>
           <a:lstStyle/>
@@ -8986,7 +9024,7 @@
           <p:cNvPr id="118" name="renderers_line_0">
             <a:extLst>
               <a:ext uri="{FF2B5EF4-FFF2-40B4-BE49-F238E27FC236}">
-                <a16:creationId xmlns:a16="http://schemas.microsoft.com/office/drawing/2014/main" id="{0DE32F25-CEFE-2858-F137-BBD006378CC1}"/>
+                <a16:creationId xmlns:a16="http://schemas.microsoft.com/office/drawing/2014/main" id="{64558167-61E3-754C-E07D-503A6BED3214}"/>
               </a:ext>
             </a:extLst>
           </p:cNvPr>
@@ -8996,7 +9034,7 @@
         <p:spPr>
           <a:xfrm>
             <a:off x="10362941" y="3960194"/>
-            <a:ext cx="1297545" cy="285806"/>
+            <a:ext cx="1297545" cy="294615"/>
           </a:xfrm>
           <a:prstGeom prst="rect">
             <a:avLst/>
@@ -9004,7 +9042,7 @@
           <a:noFill/>
         </p:spPr>
         <p:txBody>
-          <a:bodyPr vert="horz" wrap="square" lIns="8708" tIns="4361" rIns="8708" bIns="4361" rtlCol="0" anchor="t">
+          <a:bodyPr vert="horz" wrap="square" lIns="8708" tIns="8723" rIns="8708" bIns="8723" rtlCol="0" anchor="t">
             <a:noAutofit/>
           </a:bodyPr>
           <a:lstStyle/>
@@ -9032,7 +9070,7 @@
           <p:cNvPr id="119" name="renderers_line_1">
             <a:extLst>
               <a:ext uri="{FF2B5EF4-FFF2-40B4-BE49-F238E27FC236}">
-                <a16:creationId xmlns:a16="http://schemas.microsoft.com/office/drawing/2014/main" id="{5630865F-9C74-BA52-2FAF-EF723A661C8D}"/>
+                <a16:creationId xmlns:a16="http://schemas.microsoft.com/office/drawing/2014/main" id="{E8A59122-E35F-2BFB-66D7-93310D7D2F77}"/>
               </a:ext>
             </a:extLst>
           </p:cNvPr>
@@ -9042,7 +9080,7 @@
         <p:spPr>
           <a:xfrm>
             <a:off x="10362941" y="4125929"/>
-            <a:ext cx="1297545" cy="285806"/>
+            <a:ext cx="1297545" cy="294615"/>
           </a:xfrm>
           <a:prstGeom prst="rect">
             <a:avLst/>
@@ -9050,7 +9088,7 @@
           <a:noFill/>
         </p:spPr>
         <p:txBody>
-          <a:bodyPr vert="horz" wrap="square" lIns="8708" tIns="4361" rIns="8708" bIns="4361" rtlCol="0" anchor="t">
+          <a:bodyPr vert="horz" wrap="square" lIns="8708" tIns="8723" rIns="8708" bIns="8723" rtlCol="0" anchor="t">
             <a:noAutofit/>
           </a:bodyPr>
           <a:lstStyle/>
@@ -9078,7 +9116,7 @@
           <p:cNvPr id="120" name="visual_check">
             <a:extLst>
               <a:ext uri="{FF2B5EF4-FFF2-40B4-BE49-F238E27FC236}">
-                <a16:creationId xmlns:a16="http://schemas.microsoft.com/office/drawing/2014/main" id="{36EE31EB-5B4A-1AD8-E9E9-CBD79381D4C5}"/>
+                <a16:creationId xmlns:a16="http://schemas.microsoft.com/office/drawing/2014/main" id="{306E91B8-59BC-C6A9-8B7D-CB3BD96F69B9}"/>
               </a:ext>
             </a:extLst>
           </p:cNvPr>
@@ -9091,7 +9129,9 @@
             <a:ext cx="1706837" cy="523373"/>
           </a:xfrm>
           <a:prstGeom prst="roundRect">
-            <a:avLst/>
+            <a:avLst>
+              <a:gd name="adj" fmla="val 26622"/>
+            </a:avLst>
           </a:prstGeom>
           <a:solidFill>
             <a:srgbClr val="FFF1F2"/>
@@ -9139,7 +9179,7 @@
           <p:cNvPr id="121" name="visual_check_stripe">
             <a:extLst>
               <a:ext uri="{FF2B5EF4-FFF2-40B4-BE49-F238E27FC236}">
-                <a16:creationId xmlns:a16="http://schemas.microsoft.com/office/drawing/2014/main" id="{E2307F09-9BE4-D5A9-458C-07376C19C10A}"/>
+                <a16:creationId xmlns:a16="http://schemas.microsoft.com/office/drawing/2014/main" id="{3459D173-64FE-E155-76F7-E160B57C2C9B}"/>
               </a:ext>
             </a:extLst>
           </p:cNvPr>
@@ -9193,7 +9233,7 @@
           <p:cNvPr id="122" name="visual_check_seal_icon_dot">
             <a:extLst>
               <a:ext uri="{FF2B5EF4-FFF2-40B4-BE49-F238E27FC236}">
-                <a16:creationId xmlns:a16="http://schemas.microsoft.com/office/drawing/2014/main" id="{FA17DA71-7CBE-7570-4ACD-F4F5E91F22FA}"/>
+                <a16:creationId xmlns:a16="http://schemas.microsoft.com/office/drawing/2014/main" id="{42E5384E-514D-BDD2-EE73-A6ECBEAF1907}"/>
               </a:ext>
             </a:extLst>
           </p:cNvPr>
@@ -9247,7 +9287,7 @@
           <p:cNvPr id="123" name="visual_check_seal_icon_label">
             <a:extLst>
               <a:ext uri="{FF2B5EF4-FFF2-40B4-BE49-F238E27FC236}">
-                <a16:creationId xmlns:a16="http://schemas.microsoft.com/office/drawing/2014/main" id="{6C1FD18F-E57A-80BF-9178-8BDE0EEF8D38}"/>
+                <a16:creationId xmlns:a16="http://schemas.microsoft.com/office/drawing/2014/main" id="{8991D3DF-C7CB-3DA1-633C-2773F898A950}"/>
               </a:ext>
             </a:extLst>
           </p:cNvPr>
@@ -9272,7 +9312,7 @@
           <a:p>
             <a:pPr algn="ctr"/>
             <a:r>
-              <a:rPr lang="en-US" altLang="ko-KR" sz="1117" b="1">
+              <a:rPr lang="en-US" altLang="ko-KR" sz="980" b="1">
                 <a:solidFill>
                   <a:srgbClr val="FFFFFF"/>
                 </a:solidFill>
@@ -9280,7 +9320,7 @@
               </a:rPr>
               <a:t>V</a:t>
             </a:r>
-            <a:endParaRPr lang="ko-KR" altLang="en-US" sz="1117" b="1">
+            <a:endParaRPr lang="ko-KR" altLang="en-US" sz="980" b="1">
               <a:solidFill>
                 <a:srgbClr val="FFFFFF"/>
               </a:solidFill>
@@ -9294,7 +9334,7 @@
           <p:cNvPr id="124" name="visual_check_label">
             <a:extLst>
               <a:ext uri="{FF2B5EF4-FFF2-40B4-BE49-F238E27FC236}">
-                <a16:creationId xmlns:a16="http://schemas.microsoft.com/office/drawing/2014/main" id="{247B1101-7985-049E-CB9E-4ADBB8BCB651}"/>
+                <a16:creationId xmlns:a16="http://schemas.microsoft.com/office/drawing/2014/main" id="{33E38136-0D7C-8CF2-A849-4D5A8BD8300E}"/>
               </a:ext>
             </a:extLst>
           </p:cNvPr>
@@ -9304,7 +9344,7 @@
         <p:spPr>
           <a:xfrm>
             <a:off x="10571942" y="4518459"/>
-            <a:ext cx="1088544" cy="285806"/>
+            <a:ext cx="1088544" cy="294615"/>
           </a:xfrm>
           <a:prstGeom prst="rect">
             <a:avLst/>
@@ -9312,7 +9352,7 @@
           <a:noFill/>
         </p:spPr>
         <p:txBody>
-          <a:bodyPr vert="horz" wrap="square" lIns="8708" tIns="4361" rIns="8708" bIns="4361" rtlCol="0" anchor="ctr">
+          <a:bodyPr vert="horz" wrap="square" lIns="8708" tIns="8723" rIns="8708" bIns="8723" rtlCol="0" anchor="ctr">
             <a:noAutofit/>
           </a:bodyPr>
           <a:lstStyle/>
@@ -9340,7 +9380,7 @@
           <p:cNvPr id="125" name="visual_check_text">
             <a:extLst>
               <a:ext uri="{FF2B5EF4-FFF2-40B4-BE49-F238E27FC236}">
-                <a16:creationId xmlns:a16="http://schemas.microsoft.com/office/drawing/2014/main" id="{977C6730-2F46-BDAC-2830-0EE989AC323E}"/>
+                <a16:creationId xmlns:a16="http://schemas.microsoft.com/office/drawing/2014/main" id="{82BBCBA4-4C27-36BB-3898-CAAE9BECC515}"/>
               </a:ext>
             </a:extLst>
           </p:cNvPr>
@@ -9350,7 +9390,7 @@
         <p:spPr>
           <a:xfrm>
             <a:off x="10571942" y="4701640"/>
-            <a:ext cx="1088544" cy="285806"/>
+            <a:ext cx="1088544" cy="294615"/>
           </a:xfrm>
           <a:prstGeom prst="rect">
             <a:avLst/>
@@ -9358,7 +9398,7 @@
           <a:noFill/>
         </p:spPr>
         <p:txBody>
-          <a:bodyPr vert="horz" wrap="square" lIns="8708" tIns="4361" rIns="8708" bIns="4361" rtlCol="0" anchor="ctr">
+          <a:bodyPr vert="horz" wrap="square" lIns="8708" tIns="8723" rIns="8708" bIns="8723" rtlCol="0" anchor="ctr">
             <a:noAutofit/>
           </a:bodyPr>
           <a:lstStyle/>
@@ -9386,7 +9426,7 @@
           <p:cNvPr id="126" name="coherence_band">
             <a:extLst>
               <a:ext uri="{FF2B5EF4-FFF2-40B4-BE49-F238E27FC236}">
-                <a16:creationId xmlns:a16="http://schemas.microsoft.com/office/drawing/2014/main" id="{EA76D1BA-D2DD-A97E-9BA3-05A99824DD3A}"/>
+                <a16:creationId xmlns:a16="http://schemas.microsoft.com/office/drawing/2014/main" id="{47357692-B2F3-75F2-52B1-20D5BA34A17D}"/>
               </a:ext>
             </a:extLst>
           </p:cNvPr>
@@ -9399,7 +9439,9 @@
             <a:ext cx="10624192" cy="628049"/>
           </a:xfrm>
           <a:prstGeom prst="roundRect">
-            <a:avLst/>
+            <a:avLst>
+              <a:gd name="adj" fmla="val 22185"/>
+            </a:avLst>
           </a:prstGeom>
           <a:solidFill>
             <a:srgbClr val="FFFDF8"/>
@@ -9447,7 +9489,7 @@
           <p:cNvPr id="127" name="coherence_title">
             <a:extLst>
               <a:ext uri="{FF2B5EF4-FFF2-40B4-BE49-F238E27FC236}">
-                <a16:creationId xmlns:a16="http://schemas.microsoft.com/office/drawing/2014/main" id="{F6E0F5C1-9344-7B30-C252-DD37FBF86B89}"/>
+                <a16:creationId xmlns:a16="http://schemas.microsoft.com/office/drawing/2014/main" id="{B2CE74F5-488F-3B5E-754E-A9D20A91FD08}"/>
               </a:ext>
             </a:extLst>
           </p:cNvPr>
@@ -9457,7 +9499,7 @@
         <p:spPr>
           <a:xfrm>
             <a:off x="1062419" y="5617544"/>
-            <a:ext cx="1611045" cy="285806"/>
+            <a:ext cx="1611045" cy="294615"/>
           </a:xfrm>
           <a:prstGeom prst="rect">
             <a:avLst/>
@@ -9465,7 +9507,7 @@
           <a:noFill/>
         </p:spPr>
         <p:txBody>
-          <a:bodyPr vert="horz" wrap="square" lIns="8708" tIns="4361" rIns="8708" bIns="4361" rtlCol="0" anchor="ctr">
+          <a:bodyPr vert="horz" wrap="square" lIns="8708" tIns="8723" rIns="8708" bIns="8723" rtlCol="0" anchor="ctr">
             <a:noAutofit/>
           </a:bodyPr>
           <a:lstStyle/>
@@ -9493,7 +9535,7 @@
           <p:cNvPr id="128" name="coherence_body">
             <a:extLst>
               <a:ext uri="{FF2B5EF4-FFF2-40B4-BE49-F238E27FC236}">
-                <a16:creationId xmlns:a16="http://schemas.microsoft.com/office/drawing/2014/main" id="{B386E233-751A-B073-B1BE-51EBF5D0E416}"/>
+                <a16:creationId xmlns:a16="http://schemas.microsoft.com/office/drawing/2014/main" id="{76F4B85E-F56A-9522-7AF5-16B257689B41}"/>
               </a:ext>
             </a:extLst>
           </p:cNvPr>
@@ -9503,7 +9545,7 @@
         <p:spPr>
           <a:xfrm>
             <a:off x="2830215" y="5591375"/>
-            <a:ext cx="8272936" cy="285806"/>
+            <a:ext cx="8272936" cy="294615"/>
           </a:xfrm>
           <a:prstGeom prst="rect">
             <a:avLst/>
@@ -9511,7 +9553,7 @@
           <a:noFill/>
         </p:spPr>
         <p:txBody>
-          <a:bodyPr vert="horz" wrap="square" lIns="8708" tIns="4361" rIns="8708" bIns="4361" rtlCol="0" anchor="ctr">
+          <a:bodyPr vert="horz" wrap="square" lIns="8708" tIns="8723" rIns="8708" bIns="8723" rtlCol="0" anchor="ctr">
             <a:noAutofit/>
           </a:bodyPr>
           <a:lstStyle/>
@@ -9537,7 +9579,7 @@
     </p:spTree>
     <p:extLst>
       <p:ext uri="{BB962C8B-B14F-4D97-AF65-F5344CB8AC3E}">
-        <p14:creationId xmlns:p14="http://schemas.microsoft.com/office/powerpoint/2010/main" val="1339269845"/>
+        <p14:creationId xmlns:p14="http://schemas.microsoft.com/office/powerpoint/2010/main" val="2434112564"/>
       </p:ext>
     </p:extLst>
   </p:cSld>

</xml_diff>

<commit_message>
Synchronize README pipeline preview assets
</commit_message>
<xml_diff>
--- a/docs/assets/readme-slides/mdpr-pipeline-teaser.pptx
+++ b/docs/assets/readme-slides/mdpr-pipeline-teaser.pptx
@@ -129,7 +129,7 @@
           <p:cNvPr id="2" name="제목 1">
             <a:extLst>
               <a:ext uri="{FF2B5EF4-FFF2-40B4-BE49-F238E27FC236}">
-                <a16:creationId xmlns:a16="http://schemas.microsoft.com/office/drawing/2014/main" id="{40D8F000-BB2C-5AF4-0EEF-964FCF5DA86E}"/>
+                <a16:creationId xmlns:a16="http://schemas.microsoft.com/office/drawing/2014/main" id="{00247C0A-ABB1-950B-42E6-08ADFA7D9353}"/>
               </a:ext>
             </a:extLst>
           </p:cNvPr>
@@ -166,7 +166,7 @@
           <p:cNvPr id="3" name="부제목 2">
             <a:extLst>
               <a:ext uri="{FF2B5EF4-FFF2-40B4-BE49-F238E27FC236}">
-                <a16:creationId xmlns:a16="http://schemas.microsoft.com/office/drawing/2014/main" id="{E72CB708-CF46-4ACC-54A6-4AF9B6F00881}"/>
+                <a16:creationId xmlns:a16="http://schemas.microsoft.com/office/drawing/2014/main" id="{E8821273-C2D0-F987-F270-8104638A2311}"/>
               </a:ext>
             </a:extLst>
           </p:cNvPr>
@@ -236,7 +236,7 @@
           <p:cNvPr id="4" name="날짜 개체 틀 3">
             <a:extLst>
               <a:ext uri="{FF2B5EF4-FFF2-40B4-BE49-F238E27FC236}">
-                <a16:creationId xmlns:a16="http://schemas.microsoft.com/office/drawing/2014/main" id="{E6669347-0A9D-AF7B-8A12-40A08A9FE1FA}"/>
+                <a16:creationId xmlns:a16="http://schemas.microsoft.com/office/drawing/2014/main" id="{2C7C5B21-0431-CCAB-95C2-B9424D0CAB34}"/>
               </a:ext>
             </a:extLst>
           </p:cNvPr>
@@ -252,7 +252,7 @@
           <a:bodyPr/>
           <a:lstStyle/>
           <a:p>
-            <a:fld id="{4EDDC4F2-F7BA-451D-AD65-B44D4A0691CB}" type="datetimeFigureOut">
+            <a:fld id="{F692C54F-6661-431E-BC7A-3BF7D7121E25}" type="datetimeFigureOut">
               <a:rPr lang="ko-KR" altLang="en-US" smtClean="0"/>
               <a:t>2026-06-20</a:t>
             </a:fld>
@@ -265,7 +265,7 @@
           <p:cNvPr id="5" name="바닥글 개체 틀 4">
             <a:extLst>
               <a:ext uri="{FF2B5EF4-FFF2-40B4-BE49-F238E27FC236}">
-                <a16:creationId xmlns:a16="http://schemas.microsoft.com/office/drawing/2014/main" id="{11AAD211-596F-2AD6-4C10-714D580E0622}"/>
+                <a16:creationId xmlns:a16="http://schemas.microsoft.com/office/drawing/2014/main" id="{6CCEE2AE-E1A6-5934-FB39-CB515FF3E804}"/>
               </a:ext>
             </a:extLst>
           </p:cNvPr>
@@ -290,7 +290,7 @@
           <p:cNvPr id="6" name="슬라이드 번호 개체 틀 5">
             <a:extLst>
               <a:ext uri="{FF2B5EF4-FFF2-40B4-BE49-F238E27FC236}">
-                <a16:creationId xmlns:a16="http://schemas.microsoft.com/office/drawing/2014/main" id="{D7518E4D-A3EC-6A35-FB5E-DE6C5903FE9A}"/>
+                <a16:creationId xmlns:a16="http://schemas.microsoft.com/office/drawing/2014/main" id="{C3788ABA-81A9-21E5-174C-96A0BBCC76E2}"/>
               </a:ext>
             </a:extLst>
           </p:cNvPr>
@@ -306,7 +306,7 @@
           <a:bodyPr/>
           <a:lstStyle/>
           <a:p>
-            <a:fld id="{A36E63EA-5A2B-431F-BF5E-3184E73FCB0D}" type="slidenum">
+            <a:fld id="{82B1D940-9C20-4F30-B670-23B802C5312A}" type="slidenum">
               <a:rPr lang="ko-KR" altLang="en-US" smtClean="0"/>
               <a:t>‹#›</a:t>
             </a:fld>
@@ -317,7 +317,7 @@
     </p:spTree>
     <p:extLst>
       <p:ext uri="{BB962C8B-B14F-4D97-AF65-F5344CB8AC3E}">
-        <p14:creationId xmlns:p14="http://schemas.microsoft.com/office/powerpoint/2010/main" val="1205908244"/>
+        <p14:creationId xmlns:p14="http://schemas.microsoft.com/office/powerpoint/2010/main" val="2000666784"/>
       </p:ext>
     </p:extLst>
   </p:cSld>
@@ -349,7 +349,7 @@
           <p:cNvPr id="2" name="제목 1">
             <a:extLst>
               <a:ext uri="{FF2B5EF4-FFF2-40B4-BE49-F238E27FC236}">
-                <a16:creationId xmlns:a16="http://schemas.microsoft.com/office/drawing/2014/main" id="{A2E99A70-4AE8-3D2B-4254-93A3AFC0D62F}"/>
+                <a16:creationId xmlns:a16="http://schemas.microsoft.com/office/drawing/2014/main" id="{5BB50C85-A2BF-A8CB-1538-9A3EDD419206}"/>
               </a:ext>
             </a:extLst>
           </p:cNvPr>
@@ -377,7 +377,7 @@
           <p:cNvPr id="3" name="세로 텍스트 개체 틀 2">
             <a:extLst>
               <a:ext uri="{FF2B5EF4-FFF2-40B4-BE49-F238E27FC236}">
-                <a16:creationId xmlns:a16="http://schemas.microsoft.com/office/drawing/2014/main" id="{535650EF-01AA-483B-38AE-29FBDEF3A87B}"/>
+                <a16:creationId xmlns:a16="http://schemas.microsoft.com/office/drawing/2014/main" id="{1E13DB6D-760E-036E-7729-DFBA556BE757}"/>
               </a:ext>
             </a:extLst>
           </p:cNvPr>
@@ -434,7 +434,7 @@
           <p:cNvPr id="4" name="날짜 개체 틀 3">
             <a:extLst>
               <a:ext uri="{FF2B5EF4-FFF2-40B4-BE49-F238E27FC236}">
-                <a16:creationId xmlns:a16="http://schemas.microsoft.com/office/drawing/2014/main" id="{BB7B3E54-932B-8652-5E49-8E44CFD2A5FB}"/>
+                <a16:creationId xmlns:a16="http://schemas.microsoft.com/office/drawing/2014/main" id="{641CD6FC-2582-DEDC-7D17-EDF7ADBB38D2}"/>
               </a:ext>
             </a:extLst>
           </p:cNvPr>
@@ -450,7 +450,7 @@
           <a:bodyPr/>
           <a:lstStyle/>
           <a:p>
-            <a:fld id="{4EDDC4F2-F7BA-451D-AD65-B44D4A0691CB}" type="datetimeFigureOut">
+            <a:fld id="{F692C54F-6661-431E-BC7A-3BF7D7121E25}" type="datetimeFigureOut">
               <a:rPr lang="ko-KR" altLang="en-US" smtClean="0"/>
               <a:t>2026-06-20</a:t>
             </a:fld>
@@ -463,7 +463,7 @@
           <p:cNvPr id="5" name="바닥글 개체 틀 4">
             <a:extLst>
               <a:ext uri="{FF2B5EF4-FFF2-40B4-BE49-F238E27FC236}">
-                <a16:creationId xmlns:a16="http://schemas.microsoft.com/office/drawing/2014/main" id="{6651A640-8773-0663-10E2-FD89EA4720A5}"/>
+                <a16:creationId xmlns:a16="http://schemas.microsoft.com/office/drawing/2014/main" id="{0501D7D7-8DE9-5F01-D36C-4288670186D4}"/>
               </a:ext>
             </a:extLst>
           </p:cNvPr>
@@ -488,7 +488,7 @@
           <p:cNvPr id="6" name="슬라이드 번호 개체 틀 5">
             <a:extLst>
               <a:ext uri="{FF2B5EF4-FFF2-40B4-BE49-F238E27FC236}">
-                <a16:creationId xmlns:a16="http://schemas.microsoft.com/office/drawing/2014/main" id="{DD642E7D-EC45-4851-C2AC-72C9F7FF7C2E}"/>
+                <a16:creationId xmlns:a16="http://schemas.microsoft.com/office/drawing/2014/main" id="{B40177E8-75A2-F4F6-2F68-6B439F5E68BE}"/>
               </a:ext>
             </a:extLst>
           </p:cNvPr>
@@ -504,7 +504,7 @@
           <a:bodyPr/>
           <a:lstStyle/>
           <a:p>
-            <a:fld id="{A36E63EA-5A2B-431F-BF5E-3184E73FCB0D}" type="slidenum">
+            <a:fld id="{82B1D940-9C20-4F30-B670-23B802C5312A}" type="slidenum">
               <a:rPr lang="ko-KR" altLang="en-US" smtClean="0"/>
               <a:t>‹#›</a:t>
             </a:fld>
@@ -515,7 +515,7 @@
     </p:spTree>
     <p:extLst>
       <p:ext uri="{BB962C8B-B14F-4D97-AF65-F5344CB8AC3E}">
-        <p14:creationId xmlns:p14="http://schemas.microsoft.com/office/powerpoint/2010/main" val="1170634376"/>
+        <p14:creationId xmlns:p14="http://schemas.microsoft.com/office/powerpoint/2010/main" val="1933831378"/>
       </p:ext>
     </p:extLst>
   </p:cSld>
@@ -547,7 +547,7 @@
           <p:cNvPr id="2" name="세로 제목 1">
             <a:extLst>
               <a:ext uri="{FF2B5EF4-FFF2-40B4-BE49-F238E27FC236}">
-                <a16:creationId xmlns:a16="http://schemas.microsoft.com/office/drawing/2014/main" id="{671D8CD4-889A-93BC-D094-E87C5C757FE8}"/>
+                <a16:creationId xmlns:a16="http://schemas.microsoft.com/office/drawing/2014/main" id="{EB7CBF25-E64E-77D2-5501-B8A79EE8329F}"/>
               </a:ext>
             </a:extLst>
           </p:cNvPr>
@@ -580,7 +580,7 @@
           <p:cNvPr id="3" name="세로 텍스트 개체 틀 2">
             <a:extLst>
               <a:ext uri="{FF2B5EF4-FFF2-40B4-BE49-F238E27FC236}">
-                <a16:creationId xmlns:a16="http://schemas.microsoft.com/office/drawing/2014/main" id="{06154821-FEA5-E299-D6AA-EB72BEBDF802}"/>
+                <a16:creationId xmlns:a16="http://schemas.microsoft.com/office/drawing/2014/main" id="{BFC3D04B-DB1A-CB2F-037B-06BBEDC7AB22}"/>
               </a:ext>
             </a:extLst>
           </p:cNvPr>
@@ -642,7 +642,7 @@
           <p:cNvPr id="4" name="날짜 개체 틀 3">
             <a:extLst>
               <a:ext uri="{FF2B5EF4-FFF2-40B4-BE49-F238E27FC236}">
-                <a16:creationId xmlns:a16="http://schemas.microsoft.com/office/drawing/2014/main" id="{CABE9AD4-AE7E-96A4-A488-11D95BCCA5A9}"/>
+                <a16:creationId xmlns:a16="http://schemas.microsoft.com/office/drawing/2014/main" id="{350CF92A-37CD-2F94-9A9A-C8268487C253}"/>
               </a:ext>
             </a:extLst>
           </p:cNvPr>
@@ -658,7 +658,7 @@
           <a:bodyPr/>
           <a:lstStyle/>
           <a:p>
-            <a:fld id="{4EDDC4F2-F7BA-451D-AD65-B44D4A0691CB}" type="datetimeFigureOut">
+            <a:fld id="{F692C54F-6661-431E-BC7A-3BF7D7121E25}" type="datetimeFigureOut">
               <a:rPr lang="ko-KR" altLang="en-US" smtClean="0"/>
               <a:t>2026-06-20</a:t>
             </a:fld>
@@ -671,7 +671,7 @@
           <p:cNvPr id="5" name="바닥글 개체 틀 4">
             <a:extLst>
               <a:ext uri="{FF2B5EF4-FFF2-40B4-BE49-F238E27FC236}">
-                <a16:creationId xmlns:a16="http://schemas.microsoft.com/office/drawing/2014/main" id="{EF211E44-0F12-1285-7C64-90E819431AAC}"/>
+                <a16:creationId xmlns:a16="http://schemas.microsoft.com/office/drawing/2014/main" id="{AFB326B2-3BB4-2F97-D89E-806ED4A9712F}"/>
               </a:ext>
             </a:extLst>
           </p:cNvPr>
@@ -696,7 +696,7 @@
           <p:cNvPr id="6" name="슬라이드 번호 개체 틀 5">
             <a:extLst>
               <a:ext uri="{FF2B5EF4-FFF2-40B4-BE49-F238E27FC236}">
-                <a16:creationId xmlns:a16="http://schemas.microsoft.com/office/drawing/2014/main" id="{9BC67932-4803-C110-8D95-B2C6240486A5}"/>
+                <a16:creationId xmlns:a16="http://schemas.microsoft.com/office/drawing/2014/main" id="{8E4D6A42-1870-5E71-AAB8-2A09C85B535B}"/>
               </a:ext>
             </a:extLst>
           </p:cNvPr>
@@ -712,7 +712,7 @@
           <a:bodyPr/>
           <a:lstStyle/>
           <a:p>
-            <a:fld id="{A36E63EA-5A2B-431F-BF5E-3184E73FCB0D}" type="slidenum">
+            <a:fld id="{82B1D940-9C20-4F30-B670-23B802C5312A}" type="slidenum">
               <a:rPr lang="ko-KR" altLang="en-US" smtClean="0"/>
               <a:t>‹#›</a:t>
             </a:fld>
@@ -723,7 +723,7 @@
     </p:spTree>
     <p:extLst>
       <p:ext uri="{BB962C8B-B14F-4D97-AF65-F5344CB8AC3E}">
-        <p14:creationId xmlns:p14="http://schemas.microsoft.com/office/powerpoint/2010/main" val="2883822501"/>
+        <p14:creationId xmlns:p14="http://schemas.microsoft.com/office/powerpoint/2010/main" val="283394697"/>
       </p:ext>
     </p:extLst>
   </p:cSld>
@@ -755,7 +755,7 @@
           <p:cNvPr id="2" name="제목 1">
             <a:extLst>
               <a:ext uri="{FF2B5EF4-FFF2-40B4-BE49-F238E27FC236}">
-                <a16:creationId xmlns:a16="http://schemas.microsoft.com/office/drawing/2014/main" id="{9FA3B6CA-AF08-29B5-241D-A1547E16D4C7}"/>
+                <a16:creationId xmlns:a16="http://schemas.microsoft.com/office/drawing/2014/main" id="{969EDCC4-2859-13BE-1198-9713099DBEA5}"/>
               </a:ext>
             </a:extLst>
           </p:cNvPr>
@@ -783,7 +783,7 @@
           <p:cNvPr id="3" name="내용 개체 틀 2">
             <a:extLst>
               <a:ext uri="{FF2B5EF4-FFF2-40B4-BE49-F238E27FC236}">
-                <a16:creationId xmlns:a16="http://schemas.microsoft.com/office/drawing/2014/main" id="{3681D43E-F433-4130-CB62-875F286D559A}"/>
+                <a16:creationId xmlns:a16="http://schemas.microsoft.com/office/drawing/2014/main" id="{F83CB3FD-74F5-81FA-1BB8-FC8A56F6C6D7}"/>
               </a:ext>
             </a:extLst>
           </p:cNvPr>
@@ -840,7 +840,7 @@
           <p:cNvPr id="4" name="날짜 개체 틀 3">
             <a:extLst>
               <a:ext uri="{FF2B5EF4-FFF2-40B4-BE49-F238E27FC236}">
-                <a16:creationId xmlns:a16="http://schemas.microsoft.com/office/drawing/2014/main" id="{DC481173-8F50-613F-524B-FCD4CFB08052}"/>
+                <a16:creationId xmlns:a16="http://schemas.microsoft.com/office/drawing/2014/main" id="{25955552-5611-9A0D-00A5-355C97437F43}"/>
               </a:ext>
             </a:extLst>
           </p:cNvPr>
@@ -856,7 +856,7 @@
           <a:bodyPr/>
           <a:lstStyle/>
           <a:p>
-            <a:fld id="{4EDDC4F2-F7BA-451D-AD65-B44D4A0691CB}" type="datetimeFigureOut">
+            <a:fld id="{F692C54F-6661-431E-BC7A-3BF7D7121E25}" type="datetimeFigureOut">
               <a:rPr lang="ko-KR" altLang="en-US" smtClean="0"/>
               <a:t>2026-06-20</a:t>
             </a:fld>
@@ -869,7 +869,7 @@
           <p:cNvPr id="5" name="바닥글 개체 틀 4">
             <a:extLst>
               <a:ext uri="{FF2B5EF4-FFF2-40B4-BE49-F238E27FC236}">
-                <a16:creationId xmlns:a16="http://schemas.microsoft.com/office/drawing/2014/main" id="{7E2D2AF0-7E55-380C-EB36-E1220522F574}"/>
+                <a16:creationId xmlns:a16="http://schemas.microsoft.com/office/drawing/2014/main" id="{4DFF7FAA-50A0-8AAD-33C1-3E22F0BBB7B2}"/>
               </a:ext>
             </a:extLst>
           </p:cNvPr>
@@ -894,7 +894,7 @@
           <p:cNvPr id="6" name="슬라이드 번호 개체 틀 5">
             <a:extLst>
               <a:ext uri="{FF2B5EF4-FFF2-40B4-BE49-F238E27FC236}">
-                <a16:creationId xmlns:a16="http://schemas.microsoft.com/office/drawing/2014/main" id="{9CCA412B-B9B5-14F1-91BC-7558650D3C6F}"/>
+                <a16:creationId xmlns:a16="http://schemas.microsoft.com/office/drawing/2014/main" id="{A23F2B0A-FCDD-D762-3665-5CA6CEC04BFD}"/>
               </a:ext>
             </a:extLst>
           </p:cNvPr>
@@ -910,7 +910,7 @@
           <a:bodyPr/>
           <a:lstStyle/>
           <a:p>
-            <a:fld id="{A36E63EA-5A2B-431F-BF5E-3184E73FCB0D}" type="slidenum">
+            <a:fld id="{82B1D940-9C20-4F30-B670-23B802C5312A}" type="slidenum">
               <a:rPr lang="ko-KR" altLang="en-US" smtClean="0"/>
               <a:t>‹#›</a:t>
             </a:fld>
@@ -921,7 +921,7 @@
     </p:spTree>
     <p:extLst>
       <p:ext uri="{BB962C8B-B14F-4D97-AF65-F5344CB8AC3E}">
-        <p14:creationId xmlns:p14="http://schemas.microsoft.com/office/powerpoint/2010/main" val="3252414932"/>
+        <p14:creationId xmlns:p14="http://schemas.microsoft.com/office/powerpoint/2010/main" val="2128940428"/>
       </p:ext>
     </p:extLst>
   </p:cSld>
@@ -953,7 +953,7 @@
           <p:cNvPr id="2" name="제목 1">
             <a:extLst>
               <a:ext uri="{FF2B5EF4-FFF2-40B4-BE49-F238E27FC236}">
-                <a16:creationId xmlns:a16="http://schemas.microsoft.com/office/drawing/2014/main" id="{D147401A-862E-3E04-F9EA-0B0BCA24F015}"/>
+                <a16:creationId xmlns:a16="http://schemas.microsoft.com/office/drawing/2014/main" id="{E5C804A5-7D09-B3A0-96C9-9C12029D9289}"/>
               </a:ext>
             </a:extLst>
           </p:cNvPr>
@@ -990,7 +990,7 @@
           <p:cNvPr id="3" name="텍스트 개체 틀 2">
             <a:extLst>
               <a:ext uri="{FF2B5EF4-FFF2-40B4-BE49-F238E27FC236}">
-                <a16:creationId xmlns:a16="http://schemas.microsoft.com/office/drawing/2014/main" id="{A842F0B8-1D76-A5C6-C958-F6F3C498A9F8}"/>
+                <a16:creationId xmlns:a16="http://schemas.microsoft.com/office/drawing/2014/main" id="{98788F86-8C7F-C66F-0E52-4CBDB29AC694}"/>
               </a:ext>
             </a:extLst>
           </p:cNvPr>
@@ -1115,7 +1115,7 @@
           <p:cNvPr id="4" name="날짜 개체 틀 3">
             <a:extLst>
               <a:ext uri="{FF2B5EF4-FFF2-40B4-BE49-F238E27FC236}">
-                <a16:creationId xmlns:a16="http://schemas.microsoft.com/office/drawing/2014/main" id="{8B38B0DC-FBBC-2598-F26C-9797CF52DC2E}"/>
+                <a16:creationId xmlns:a16="http://schemas.microsoft.com/office/drawing/2014/main" id="{4407F00C-D2D9-1064-6805-FFFCBE16F9D4}"/>
               </a:ext>
             </a:extLst>
           </p:cNvPr>
@@ -1131,7 +1131,7 @@
           <a:bodyPr/>
           <a:lstStyle/>
           <a:p>
-            <a:fld id="{4EDDC4F2-F7BA-451D-AD65-B44D4A0691CB}" type="datetimeFigureOut">
+            <a:fld id="{F692C54F-6661-431E-BC7A-3BF7D7121E25}" type="datetimeFigureOut">
               <a:rPr lang="ko-KR" altLang="en-US" smtClean="0"/>
               <a:t>2026-06-20</a:t>
             </a:fld>
@@ -1144,7 +1144,7 @@
           <p:cNvPr id="5" name="바닥글 개체 틀 4">
             <a:extLst>
               <a:ext uri="{FF2B5EF4-FFF2-40B4-BE49-F238E27FC236}">
-                <a16:creationId xmlns:a16="http://schemas.microsoft.com/office/drawing/2014/main" id="{FCC0AC2D-DCC2-4690-41ED-42E2BECCA5C5}"/>
+                <a16:creationId xmlns:a16="http://schemas.microsoft.com/office/drawing/2014/main" id="{D691F6A3-57B8-45B3-890C-AF552E9DBFB9}"/>
               </a:ext>
             </a:extLst>
           </p:cNvPr>
@@ -1169,7 +1169,7 @@
           <p:cNvPr id="6" name="슬라이드 번호 개체 틀 5">
             <a:extLst>
               <a:ext uri="{FF2B5EF4-FFF2-40B4-BE49-F238E27FC236}">
-                <a16:creationId xmlns:a16="http://schemas.microsoft.com/office/drawing/2014/main" id="{54FC350D-605D-5F21-3A01-BE7C7CCC24EB}"/>
+                <a16:creationId xmlns:a16="http://schemas.microsoft.com/office/drawing/2014/main" id="{CBAE08DD-08F9-BB56-0489-474916F17D4E}"/>
               </a:ext>
             </a:extLst>
           </p:cNvPr>
@@ -1185,7 +1185,7 @@
           <a:bodyPr/>
           <a:lstStyle/>
           <a:p>
-            <a:fld id="{A36E63EA-5A2B-431F-BF5E-3184E73FCB0D}" type="slidenum">
+            <a:fld id="{82B1D940-9C20-4F30-B670-23B802C5312A}" type="slidenum">
               <a:rPr lang="ko-KR" altLang="en-US" smtClean="0"/>
               <a:t>‹#›</a:t>
             </a:fld>
@@ -1196,7 +1196,7 @@
     </p:spTree>
     <p:extLst>
       <p:ext uri="{BB962C8B-B14F-4D97-AF65-F5344CB8AC3E}">
-        <p14:creationId xmlns:p14="http://schemas.microsoft.com/office/powerpoint/2010/main" val="238210886"/>
+        <p14:creationId xmlns:p14="http://schemas.microsoft.com/office/powerpoint/2010/main" val="1422526037"/>
       </p:ext>
     </p:extLst>
   </p:cSld>
@@ -1228,7 +1228,7 @@
           <p:cNvPr id="2" name="제목 1">
             <a:extLst>
               <a:ext uri="{FF2B5EF4-FFF2-40B4-BE49-F238E27FC236}">
-                <a16:creationId xmlns:a16="http://schemas.microsoft.com/office/drawing/2014/main" id="{8B9E2A8F-30A9-BF2E-502A-5304804A9107}"/>
+                <a16:creationId xmlns:a16="http://schemas.microsoft.com/office/drawing/2014/main" id="{EAE5823B-D404-576B-541B-613C48EA3AA6}"/>
               </a:ext>
             </a:extLst>
           </p:cNvPr>
@@ -1256,7 +1256,7 @@
           <p:cNvPr id="3" name="내용 개체 틀 2">
             <a:extLst>
               <a:ext uri="{FF2B5EF4-FFF2-40B4-BE49-F238E27FC236}">
-                <a16:creationId xmlns:a16="http://schemas.microsoft.com/office/drawing/2014/main" id="{D408BA57-5393-BC2F-9BDA-1455D8BFD362}"/>
+                <a16:creationId xmlns:a16="http://schemas.microsoft.com/office/drawing/2014/main" id="{BE503001-3748-DE1E-1A9B-41D5711AAE63}"/>
               </a:ext>
             </a:extLst>
           </p:cNvPr>
@@ -1318,7 +1318,7 @@
           <p:cNvPr id="4" name="내용 개체 틀 3">
             <a:extLst>
               <a:ext uri="{FF2B5EF4-FFF2-40B4-BE49-F238E27FC236}">
-                <a16:creationId xmlns:a16="http://schemas.microsoft.com/office/drawing/2014/main" id="{FB300CF0-3CC8-237B-1B23-0668B81BCD1B}"/>
+                <a16:creationId xmlns:a16="http://schemas.microsoft.com/office/drawing/2014/main" id="{9129C331-D470-11CE-B219-E2ED74F9F08F}"/>
               </a:ext>
             </a:extLst>
           </p:cNvPr>
@@ -1380,7 +1380,7 @@
           <p:cNvPr id="5" name="날짜 개체 틀 4">
             <a:extLst>
               <a:ext uri="{FF2B5EF4-FFF2-40B4-BE49-F238E27FC236}">
-                <a16:creationId xmlns:a16="http://schemas.microsoft.com/office/drawing/2014/main" id="{7B3654A6-2423-14AB-7A34-AA78FA17B3B6}"/>
+                <a16:creationId xmlns:a16="http://schemas.microsoft.com/office/drawing/2014/main" id="{C9CB8C97-48C9-4C01-5ABC-5E2BB6705159}"/>
               </a:ext>
             </a:extLst>
           </p:cNvPr>
@@ -1396,7 +1396,7 @@
           <a:bodyPr/>
           <a:lstStyle/>
           <a:p>
-            <a:fld id="{4EDDC4F2-F7BA-451D-AD65-B44D4A0691CB}" type="datetimeFigureOut">
+            <a:fld id="{F692C54F-6661-431E-BC7A-3BF7D7121E25}" type="datetimeFigureOut">
               <a:rPr lang="ko-KR" altLang="en-US" smtClean="0"/>
               <a:t>2026-06-20</a:t>
             </a:fld>
@@ -1409,7 +1409,7 @@
           <p:cNvPr id="6" name="바닥글 개체 틀 5">
             <a:extLst>
               <a:ext uri="{FF2B5EF4-FFF2-40B4-BE49-F238E27FC236}">
-                <a16:creationId xmlns:a16="http://schemas.microsoft.com/office/drawing/2014/main" id="{14742C08-A86F-12C4-FABC-7FFEDE9E0E1E}"/>
+                <a16:creationId xmlns:a16="http://schemas.microsoft.com/office/drawing/2014/main" id="{132358E4-FEA2-AB29-74E4-5E1E90D0DCFF}"/>
               </a:ext>
             </a:extLst>
           </p:cNvPr>
@@ -1434,7 +1434,7 @@
           <p:cNvPr id="7" name="슬라이드 번호 개체 틀 6">
             <a:extLst>
               <a:ext uri="{FF2B5EF4-FFF2-40B4-BE49-F238E27FC236}">
-                <a16:creationId xmlns:a16="http://schemas.microsoft.com/office/drawing/2014/main" id="{2273C72F-D2BA-A44F-CAEA-1EE9A7441A9C}"/>
+                <a16:creationId xmlns:a16="http://schemas.microsoft.com/office/drawing/2014/main" id="{8C4C4F40-4C31-B6E1-29DD-944C799E8204}"/>
               </a:ext>
             </a:extLst>
           </p:cNvPr>
@@ -1450,7 +1450,7 @@
           <a:bodyPr/>
           <a:lstStyle/>
           <a:p>
-            <a:fld id="{A36E63EA-5A2B-431F-BF5E-3184E73FCB0D}" type="slidenum">
+            <a:fld id="{82B1D940-9C20-4F30-B670-23B802C5312A}" type="slidenum">
               <a:rPr lang="ko-KR" altLang="en-US" smtClean="0"/>
               <a:t>‹#›</a:t>
             </a:fld>
@@ -1461,7 +1461,7 @@
     </p:spTree>
     <p:extLst>
       <p:ext uri="{BB962C8B-B14F-4D97-AF65-F5344CB8AC3E}">
-        <p14:creationId xmlns:p14="http://schemas.microsoft.com/office/powerpoint/2010/main" val="1453668919"/>
+        <p14:creationId xmlns:p14="http://schemas.microsoft.com/office/powerpoint/2010/main" val="53683349"/>
       </p:ext>
     </p:extLst>
   </p:cSld>
@@ -1493,7 +1493,7 @@
           <p:cNvPr id="2" name="제목 1">
             <a:extLst>
               <a:ext uri="{FF2B5EF4-FFF2-40B4-BE49-F238E27FC236}">
-                <a16:creationId xmlns:a16="http://schemas.microsoft.com/office/drawing/2014/main" id="{A459F278-07E9-04B3-0A2B-2E451A66E657}"/>
+                <a16:creationId xmlns:a16="http://schemas.microsoft.com/office/drawing/2014/main" id="{0F69BCB7-D590-D0DA-D8B6-4ACCE12B9BC9}"/>
               </a:ext>
             </a:extLst>
           </p:cNvPr>
@@ -1526,7 +1526,7 @@
           <p:cNvPr id="3" name="텍스트 개체 틀 2">
             <a:extLst>
               <a:ext uri="{FF2B5EF4-FFF2-40B4-BE49-F238E27FC236}">
-                <a16:creationId xmlns:a16="http://schemas.microsoft.com/office/drawing/2014/main" id="{7EE2BF31-9FD8-0D7F-94EE-A02E6BEE812A}"/>
+                <a16:creationId xmlns:a16="http://schemas.microsoft.com/office/drawing/2014/main" id="{52F6E358-5272-D42D-5101-2DCBD11C7E61}"/>
               </a:ext>
             </a:extLst>
           </p:cNvPr>
@@ -1597,7 +1597,7 @@
           <p:cNvPr id="4" name="내용 개체 틀 3">
             <a:extLst>
               <a:ext uri="{FF2B5EF4-FFF2-40B4-BE49-F238E27FC236}">
-                <a16:creationId xmlns:a16="http://schemas.microsoft.com/office/drawing/2014/main" id="{D78D00AA-845D-988A-2E15-5B30CC039911}"/>
+                <a16:creationId xmlns:a16="http://schemas.microsoft.com/office/drawing/2014/main" id="{7EF7B7A8-C3DD-28FF-A45F-4D8892EC2359}"/>
               </a:ext>
             </a:extLst>
           </p:cNvPr>
@@ -1659,7 +1659,7 @@
           <p:cNvPr id="5" name="텍스트 개체 틀 4">
             <a:extLst>
               <a:ext uri="{FF2B5EF4-FFF2-40B4-BE49-F238E27FC236}">
-                <a16:creationId xmlns:a16="http://schemas.microsoft.com/office/drawing/2014/main" id="{E312F72C-2A51-2B04-12CF-F617211D1DE7}"/>
+                <a16:creationId xmlns:a16="http://schemas.microsoft.com/office/drawing/2014/main" id="{5A6CD881-CA7F-517F-67E2-863C2C8CEA7D}"/>
               </a:ext>
             </a:extLst>
           </p:cNvPr>
@@ -1730,7 +1730,7 @@
           <p:cNvPr id="6" name="내용 개체 틀 5">
             <a:extLst>
               <a:ext uri="{FF2B5EF4-FFF2-40B4-BE49-F238E27FC236}">
-                <a16:creationId xmlns:a16="http://schemas.microsoft.com/office/drawing/2014/main" id="{04183D2B-B9C0-6FA6-7BEC-57C7CFBB3B52}"/>
+                <a16:creationId xmlns:a16="http://schemas.microsoft.com/office/drawing/2014/main" id="{D9020877-F7F3-92A0-57FC-9276853981F3}"/>
               </a:ext>
             </a:extLst>
           </p:cNvPr>
@@ -1792,7 +1792,7 @@
           <p:cNvPr id="7" name="날짜 개체 틀 6">
             <a:extLst>
               <a:ext uri="{FF2B5EF4-FFF2-40B4-BE49-F238E27FC236}">
-                <a16:creationId xmlns:a16="http://schemas.microsoft.com/office/drawing/2014/main" id="{A278BA29-BAAD-AB0F-EFCD-EF7910F238B6}"/>
+                <a16:creationId xmlns:a16="http://schemas.microsoft.com/office/drawing/2014/main" id="{EF801746-45AA-4FCC-AB65-828AF14ECEED}"/>
               </a:ext>
             </a:extLst>
           </p:cNvPr>
@@ -1808,7 +1808,7 @@
           <a:bodyPr/>
           <a:lstStyle/>
           <a:p>
-            <a:fld id="{4EDDC4F2-F7BA-451D-AD65-B44D4A0691CB}" type="datetimeFigureOut">
+            <a:fld id="{F692C54F-6661-431E-BC7A-3BF7D7121E25}" type="datetimeFigureOut">
               <a:rPr lang="ko-KR" altLang="en-US" smtClean="0"/>
               <a:t>2026-06-20</a:t>
             </a:fld>
@@ -1821,7 +1821,7 @@
           <p:cNvPr id="8" name="바닥글 개체 틀 7">
             <a:extLst>
               <a:ext uri="{FF2B5EF4-FFF2-40B4-BE49-F238E27FC236}">
-                <a16:creationId xmlns:a16="http://schemas.microsoft.com/office/drawing/2014/main" id="{BD84B081-E185-028F-698E-D65ACA44EE65}"/>
+                <a16:creationId xmlns:a16="http://schemas.microsoft.com/office/drawing/2014/main" id="{57015B39-5CEE-419F-B090-473D39C3A608}"/>
               </a:ext>
             </a:extLst>
           </p:cNvPr>
@@ -1846,7 +1846,7 @@
           <p:cNvPr id="9" name="슬라이드 번호 개체 틀 8">
             <a:extLst>
               <a:ext uri="{FF2B5EF4-FFF2-40B4-BE49-F238E27FC236}">
-                <a16:creationId xmlns:a16="http://schemas.microsoft.com/office/drawing/2014/main" id="{C845E1CA-4BB2-75C2-BAFB-D137E3274846}"/>
+                <a16:creationId xmlns:a16="http://schemas.microsoft.com/office/drawing/2014/main" id="{1ACA02B4-0BA8-6B39-A2DF-B08CB82ED5B6}"/>
               </a:ext>
             </a:extLst>
           </p:cNvPr>
@@ -1862,7 +1862,7 @@
           <a:bodyPr/>
           <a:lstStyle/>
           <a:p>
-            <a:fld id="{A36E63EA-5A2B-431F-BF5E-3184E73FCB0D}" type="slidenum">
+            <a:fld id="{82B1D940-9C20-4F30-B670-23B802C5312A}" type="slidenum">
               <a:rPr lang="ko-KR" altLang="en-US" smtClean="0"/>
               <a:t>‹#›</a:t>
             </a:fld>
@@ -1873,7 +1873,7 @@
     </p:spTree>
     <p:extLst>
       <p:ext uri="{BB962C8B-B14F-4D97-AF65-F5344CB8AC3E}">
-        <p14:creationId xmlns:p14="http://schemas.microsoft.com/office/powerpoint/2010/main" val="1515704153"/>
+        <p14:creationId xmlns:p14="http://schemas.microsoft.com/office/powerpoint/2010/main" val="343214365"/>
       </p:ext>
     </p:extLst>
   </p:cSld>
@@ -1905,7 +1905,7 @@
           <p:cNvPr id="2" name="제목 1">
             <a:extLst>
               <a:ext uri="{FF2B5EF4-FFF2-40B4-BE49-F238E27FC236}">
-                <a16:creationId xmlns:a16="http://schemas.microsoft.com/office/drawing/2014/main" id="{D926C6CF-45C6-1B87-DCE9-C28454CD3B2B}"/>
+                <a16:creationId xmlns:a16="http://schemas.microsoft.com/office/drawing/2014/main" id="{4A9E0B72-4E1A-F4F0-2805-EEFC449986A1}"/>
               </a:ext>
             </a:extLst>
           </p:cNvPr>
@@ -1933,7 +1933,7 @@
           <p:cNvPr id="3" name="날짜 개체 틀 2">
             <a:extLst>
               <a:ext uri="{FF2B5EF4-FFF2-40B4-BE49-F238E27FC236}">
-                <a16:creationId xmlns:a16="http://schemas.microsoft.com/office/drawing/2014/main" id="{6C5380D6-5713-9D86-7946-6A4151D73670}"/>
+                <a16:creationId xmlns:a16="http://schemas.microsoft.com/office/drawing/2014/main" id="{73C9A622-80DA-2227-EC7A-EF5F6C6678DE}"/>
               </a:ext>
             </a:extLst>
           </p:cNvPr>
@@ -1949,7 +1949,7 @@
           <a:bodyPr/>
           <a:lstStyle/>
           <a:p>
-            <a:fld id="{4EDDC4F2-F7BA-451D-AD65-B44D4A0691CB}" type="datetimeFigureOut">
+            <a:fld id="{F692C54F-6661-431E-BC7A-3BF7D7121E25}" type="datetimeFigureOut">
               <a:rPr lang="ko-KR" altLang="en-US" smtClean="0"/>
               <a:t>2026-06-20</a:t>
             </a:fld>
@@ -1962,7 +1962,7 @@
           <p:cNvPr id="4" name="바닥글 개체 틀 3">
             <a:extLst>
               <a:ext uri="{FF2B5EF4-FFF2-40B4-BE49-F238E27FC236}">
-                <a16:creationId xmlns:a16="http://schemas.microsoft.com/office/drawing/2014/main" id="{8A4BA29F-605A-0760-261D-381DF9D4FA17}"/>
+                <a16:creationId xmlns:a16="http://schemas.microsoft.com/office/drawing/2014/main" id="{5093F602-21BA-D1A3-B91C-8FC58565C99E}"/>
               </a:ext>
             </a:extLst>
           </p:cNvPr>
@@ -1987,7 +1987,7 @@
           <p:cNvPr id="5" name="슬라이드 번호 개체 틀 4">
             <a:extLst>
               <a:ext uri="{FF2B5EF4-FFF2-40B4-BE49-F238E27FC236}">
-                <a16:creationId xmlns:a16="http://schemas.microsoft.com/office/drawing/2014/main" id="{3AFA2730-F0B7-CD21-A8BD-79A5EA5A5961}"/>
+                <a16:creationId xmlns:a16="http://schemas.microsoft.com/office/drawing/2014/main" id="{9899F506-B1BC-70A2-74E2-CF46E519F8CE}"/>
               </a:ext>
             </a:extLst>
           </p:cNvPr>
@@ -2003,7 +2003,7 @@
           <a:bodyPr/>
           <a:lstStyle/>
           <a:p>
-            <a:fld id="{A36E63EA-5A2B-431F-BF5E-3184E73FCB0D}" type="slidenum">
+            <a:fld id="{82B1D940-9C20-4F30-B670-23B802C5312A}" type="slidenum">
               <a:rPr lang="ko-KR" altLang="en-US" smtClean="0"/>
               <a:t>‹#›</a:t>
             </a:fld>
@@ -2014,7 +2014,7 @@
     </p:spTree>
     <p:extLst>
       <p:ext uri="{BB962C8B-B14F-4D97-AF65-F5344CB8AC3E}">
-        <p14:creationId xmlns:p14="http://schemas.microsoft.com/office/powerpoint/2010/main" val="2778200295"/>
+        <p14:creationId xmlns:p14="http://schemas.microsoft.com/office/powerpoint/2010/main" val="1904036162"/>
       </p:ext>
     </p:extLst>
   </p:cSld>
@@ -2046,7 +2046,7 @@
           <p:cNvPr id="2" name="날짜 개체 틀 1">
             <a:extLst>
               <a:ext uri="{FF2B5EF4-FFF2-40B4-BE49-F238E27FC236}">
-                <a16:creationId xmlns:a16="http://schemas.microsoft.com/office/drawing/2014/main" id="{EE318CA7-0149-E025-899F-201036D0001A}"/>
+                <a16:creationId xmlns:a16="http://schemas.microsoft.com/office/drawing/2014/main" id="{D495CB06-EA22-8EC9-9AF9-F3C953929061}"/>
               </a:ext>
             </a:extLst>
           </p:cNvPr>
@@ -2062,7 +2062,7 @@
           <a:bodyPr/>
           <a:lstStyle/>
           <a:p>
-            <a:fld id="{4EDDC4F2-F7BA-451D-AD65-B44D4A0691CB}" type="datetimeFigureOut">
+            <a:fld id="{F692C54F-6661-431E-BC7A-3BF7D7121E25}" type="datetimeFigureOut">
               <a:rPr lang="ko-KR" altLang="en-US" smtClean="0"/>
               <a:t>2026-06-20</a:t>
             </a:fld>
@@ -2075,7 +2075,7 @@
           <p:cNvPr id="3" name="바닥글 개체 틀 2">
             <a:extLst>
               <a:ext uri="{FF2B5EF4-FFF2-40B4-BE49-F238E27FC236}">
-                <a16:creationId xmlns:a16="http://schemas.microsoft.com/office/drawing/2014/main" id="{08345A3A-DD72-3C75-EED8-75B84FD429FA}"/>
+                <a16:creationId xmlns:a16="http://schemas.microsoft.com/office/drawing/2014/main" id="{D277CFBC-50F9-52A8-8450-0B7450C90EE8}"/>
               </a:ext>
             </a:extLst>
           </p:cNvPr>
@@ -2100,7 +2100,7 @@
           <p:cNvPr id="4" name="슬라이드 번호 개체 틀 3">
             <a:extLst>
               <a:ext uri="{FF2B5EF4-FFF2-40B4-BE49-F238E27FC236}">
-                <a16:creationId xmlns:a16="http://schemas.microsoft.com/office/drawing/2014/main" id="{03105AAE-2DEF-92FE-8772-E941873B57E1}"/>
+                <a16:creationId xmlns:a16="http://schemas.microsoft.com/office/drawing/2014/main" id="{52EEBE57-8F33-A404-F5B1-ADDCA399E682}"/>
               </a:ext>
             </a:extLst>
           </p:cNvPr>
@@ -2116,7 +2116,7 @@
           <a:bodyPr/>
           <a:lstStyle/>
           <a:p>
-            <a:fld id="{A36E63EA-5A2B-431F-BF5E-3184E73FCB0D}" type="slidenum">
+            <a:fld id="{82B1D940-9C20-4F30-B670-23B802C5312A}" type="slidenum">
               <a:rPr lang="ko-KR" altLang="en-US" smtClean="0"/>
               <a:t>‹#›</a:t>
             </a:fld>
@@ -2127,7 +2127,7 @@
     </p:spTree>
     <p:extLst>
       <p:ext uri="{BB962C8B-B14F-4D97-AF65-F5344CB8AC3E}">
-        <p14:creationId xmlns:p14="http://schemas.microsoft.com/office/powerpoint/2010/main" val="2524690840"/>
+        <p14:creationId xmlns:p14="http://schemas.microsoft.com/office/powerpoint/2010/main" val="535441016"/>
       </p:ext>
     </p:extLst>
   </p:cSld>
@@ -2159,7 +2159,7 @@
           <p:cNvPr id="2" name="제목 1">
             <a:extLst>
               <a:ext uri="{FF2B5EF4-FFF2-40B4-BE49-F238E27FC236}">
-                <a16:creationId xmlns:a16="http://schemas.microsoft.com/office/drawing/2014/main" id="{7A886FE6-26E0-7DD3-483E-DA79F7855728}"/>
+                <a16:creationId xmlns:a16="http://schemas.microsoft.com/office/drawing/2014/main" id="{852CDCE3-4475-8D84-0349-06383CE22EA3}"/>
               </a:ext>
             </a:extLst>
           </p:cNvPr>
@@ -2196,7 +2196,7 @@
           <p:cNvPr id="3" name="내용 개체 틀 2">
             <a:extLst>
               <a:ext uri="{FF2B5EF4-FFF2-40B4-BE49-F238E27FC236}">
-                <a16:creationId xmlns:a16="http://schemas.microsoft.com/office/drawing/2014/main" id="{14CCC68F-6AE8-AB5F-9008-4CB5C4E62F49}"/>
+                <a16:creationId xmlns:a16="http://schemas.microsoft.com/office/drawing/2014/main" id="{D4D7438D-F9DD-B442-ACD0-3554CF8DBCD0}"/>
               </a:ext>
             </a:extLst>
           </p:cNvPr>
@@ -2286,7 +2286,7 @@
           <p:cNvPr id="4" name="텍스트 개체 틀 3">
             <a:extLst>
               <a:ext uri="{FF2B5EF4-FFF2-40B4-BE49-F238E27FC236}">
-                <a16:creationId xmlns:a16="http://schemas.microsoft.com/office/drawing/2014/main" id="{24F4DD3D-B5BB-142D-099E-650F275DD6A9}"/>
+                <a16:creationId xmlns:a16="http://schemas.microsoft.com/office/drawing/2014/main" id="{D139E9FB-DD1F-1F04-22DA-E87ED590DEE5}"/>
               </a:ext>
             </a:extLst>
           </p:cNvPr>
@@ -2357,7 +2357,7 @@
           <p:cNvPr id="5" name="날짜 개체 틀 4">
             <a:extLst>
               <a:ext uri="{FF2B5EF4-FFF2-40B4-BE49-F238E27FC236}">
-                <a16:creationId xmlns:a16="http://schemas.microsoft.com/office/drawing/2014/main" id="{7F387B83-2C5A-80A3-C1A4-C58249FCED4A}"/>
+                <a16:creationId xmlns:a16="http://schemas.microsoft.com/office/drawing/2014/main" id="{71CEA759-F284-3369-9BB3-2252BE1ADAEB}"/>
               </a:ext>
             </a:extLst>
           </p:cNvPr>
@@ -2373,7 +2373,7 @@
           <a:bodyPr/>
           <a:lstStyle/>
           <a:p>
-            <a:fld id="{4EDDC4F2-F7BA-451D-AD65-B44D4A0691CB}" type="datetimeFigureOut">
+            <a:fld id="{F692C54F-6661-431E-BC7A-3BF7D7121E25}" type="datetimeFigureOut">
               <a:rPr lang="ko-KR" altLang="en-US" smtClean="0"/>
               <a:t>2026-06-20</a:t>
             </a:fld>
@@ -2386,7 +2386,7 @@
           <p:cNvPr id="6" name="바닥글 개체 틀 5">
             <a:extLst>
               <a:ext uri="{FF2B5EF4-FFF2-40B4-BE49-F238E27FC236}">
-                <a16:creationId xmlns:a16="http://schemas.microsoft.com/office/drawing/2014/main" id="{6DAB2AC0-16F7-70F5-6786-9066B8E078C2}"/>
+                <a16:creationId xmlns:a16="http://schemas.microsoft.com/office/drawing/2014/main" id="{D760AF63-5AD6-2767-4409-D529813B93B7}"/>
               </a:ext>
             </a:extLst>
           </p:cNvPr>
@@ -2411,7 +2411,7 @@
           <p:cNvPr id="7" name="슬라이드 번호 개체 틀 6">
             <a:extLst>
               <a:ext uri="{FF2B5EF4-FFF2-40B4-BE49-F238E27FC236}">
-                <a16:creationId xmlns:a16="http://schemas.microsoft.com/office/drawing/2014/main" id="{41A48463-C170-CC84-F3BF-A9FBD02DA261}"/>
+                <a16:creationId xmlns:a16="http://schemas.microsoft.com/office/drawing/2014/main" id="{716D35CB-B116-7291-D13F-6F9EA03565B1}"/>
               </a:ext>
             </a:extLst>
           </p:cNvPr>
@@ -2427,7 +2427,7 @@
           <a:bodyPr/>
           <a:lstStyle/>
           <a:p>
-            <a:fld id="{A36E63EA-5A2B-431F-BF5E-3184E73FCB0D}" type="slidenum">
+            <a:fld id="{82B1D940-9C20-4F30-B670-23B802C5312A}" type="slidenum">
               <a:rPr lang="ko-KR" altLang="en-US" smtClean="0"/>
               <a:t>‹#›</a:t>
             </a:fld>
@@ -2438,7 +2438,7 @@
     </p:spTree>
     <p:extLst>
       <p:ext uri="{BB962C8B-B14F-4D97-AF65-F5344CB8AC3E}">
-        <p14:creationId xmlns:p14="http://schemas.microsoft.com/office/powerpoint/2010/main" val="620806793"/>
+        <p14:creationId xmlns:p14="http://schemas.microsoft.com/office/powerpoint/2010/main" val="2608029936"/>
       </p:ext>
     </p:extLst>
   </p:cSld>
@@ -2470,7 +2470,7 @@
           <p:cNvPr id="2" name="제목 1">
             <a:extLst>
               <a:ext uri="{FF2B5EF4-FFF2-40B4-BE49-F238E27FC236}">
-                <a16:creationId xmlns:a16="http://schemas.microsoft.com/office/drawing/2014/main" id="{2B45A392-D8F7-D638-0A79-276B0680E6DB}"/>
+                <a16:creationId xmlns:a16="http://schemas.microsoft.com/office/drawing/2014/main" id="{B4ECC30B-E423-0A03-4677-B7AA37BB29E1}"/>
               </a:ext>
             </a:extLst>
           </p:cNvPr>
@@ -2507,7 +2507,7 @@
           <p:cNvPr id="3" name="그림 개체 틀 2">
             <a:extLst>
               <a:ext uri="{FF2B5EF4-FFF2-40B4-BE49-F238E27FC236}">
-                <a16:creationId xmlns:a16="http://schemas.microsoft.com/office/drawing/2014/main" id="{A7DCD1B5-E5AD-21A4-CAD5-F4C761963597}"/>
+                <a16:creationId xmlns:a16="http://schemas.microsoft.com/office/drawing/2014/main" id="{3FA49F30-D2D2-1962-976F-D0986379B972}"/>
               </a:ext>
             </a:extLst>
           </p:cNvPr>
@@ -2574,7 +2574,7 @@
           <p:cNvPr id="4" name="텍스트 개체 틀 3">
             <a:extLst>
               <a:ext uri="{FF2B5EF4-FFF2-40B4-BE49-F238E27FC236}">
-                <a16:creationId xmlns:a16="http://schemas.microsoft.com/office/drawing/2014/main" id="{5D7FCA1F-4461-4E41-C9EA-45427E86EC59}"/>
+                <a16:creationId xmlns:a16="http://schemas.microsoft.com/office/drawing/2014/main" id="{AC1B723E-283B-C94A-76D2-7B1774CEA3A5}"/>
               </a:ext>
             </a:extLst>
           </p:cNvPr>
@@ -2645,7 +2645,7 @@
           <p:cNvPr id="5" name="날짜 개체 틀 4">
             <a:extLst>
               <a:ext uri="{FF2B5EF4-FFF2-40B4-BE49-F238E27FC236}">
-                <a16:creationId xmlns:a16="http://schemas.microsoft.com/office/drawing/2014/main" id="{B08A715F-ECA3-7205-08F0-99EEB9DF18AC}"/>
+                <a16:creationId xmlns:a16="http://schemas.microsoft.com/office/drawing/2014/main" id="{6917B21C-68FB-F02F-B86C-5EECDE8F1897}"/>
               </a:ext>
             </a:extLst>
           </p:cNvPr>
@@ -2661,7 +2661,7 @@
           <a:bodyPr/>
           <a:lstStyle/>
           <a:p>
-            <a:fld id="{4EDDC4F2-F7BA-451D-AD65-B44D4A0691CB}" type="datetimeFigureOut">
+            <a:fld id="{F692C54F-6661-431E-BC7A-3BF7D7121E25}" type="datetimeFigureOut">
               <a:rPr lang="ko-KR" altLang="en-US" smtClean="0"/>
               <a:t>2026-06-20</a:t>
             </a:fld>
@@ -2674,7 +2674,7 @@
           <p:cNvPr id="6" name="바닥글 개체 틀 5">
             <a:extLst>
               <a:ext uri="{FF2B5EF4-FFF2-40B4-BE49-F238E27FC236}">
-                <a16:creationId xmlns:a16="http://schemas.microsoft.com/office/drawing/2014/main" id="{CB8DE82C-3EE2-DCF9-F80C-D3B696BAEFCB}"/>
+                <a16:creationId xmlns:a16="http://schemas.microsoft.com/office/drawing/2014/main" id="{94AB013D-D2B0-81C0-686E-B4F012395B07}"/>
               </a:ext>
             </a:extLst>
           </p:cNvPr>
@@ -2699,7 +2699,7 @@
           <p:cNvPr id="7" name="슬라이드 번호 개체 틀 6">
             <a:extLst>
               <a:ext uri="{FF2B5EF4-FFF2-40B4-BE49-F238E27FC236}">
-                <a16:creationId xmlns:a16="http://schemas.microsoft.com/office/drawing/2014/main" id="{2482DE60-FA84-C95B-73AA-4D962B3B283A}"/>
+                <a16:creationId xmlns:a16="http://schemas.microsoft.com/office/drawing/2014/main" id="{26720161-1A85-1747-3CC3-712577F04AFB}"/>
               </a:ext>
             </a:extLst>
           </p:cNvPr>
@@ -2715,7 +2715,7 @@
           <a:bodyPr/>
           <a:lstStyle/>
           <a:p>
-            <a:fld id="{A36E63EA-5A2B-431F-BF5E-3184E73FCB0D}" type="slidenum">
+            <a:fld id="{82B1D940-9C20-4F30-B670-23B802C5312A}" type="slidenum">
               <a:rPr lang="ko-KR" altLang="en-US" smtClean="0"/>
               <a:t>‹#›</a:t>
             </a:fld>
@@ -2726,7 +2726,7 @@
     </p:spTree>
     <p:extLst>
       <p:ext uri="{BB962C8B-B14F-4D97-AF65-F5344CB8AC3E}">
-        <p14:creationId xmlns:p14="http://schemas.microsoft.com/office/powerpoint/2010/main" val="2412212217"/>
+        <p14:creationId xmlns:p14="http://schemas.microsoft.com/office/powerpoint/2010/main" val="768098765"/>
       </p:ext>
     </p:extLst>
   </p:cSld>
@@ -2763,7 +2763,7 @@
           <p:cNvPr id="2" name="제목 개체 틀 1">
             <a:extLst>
               <a:ext uri="{FF2B5EF4-FFF2-40B4-BE49-F238E27FC236}">
-                <a16:creationId xmlns:a16="http://schemas.microsoft.com/office/drawing/2014/main" id="{94020524-9A6A-93A4-3A68-396B50135762}"/>
+                <a16:creationId xmlns:a16="http://schemas.microsoft.com/office/drawing/2014/main" id="{DB6582A7-BBBB-3981-E552-23B92201E013}"/>
               </a:ext>
             </a:extLst>
           </p:cNvPr>
@@ -2801,7 +2801,7 @@
           <p:cNvPr id="3" name="텍스트 개체 틀 2">
             <a:extLst>
               <a:ext uri="{FF2B5EF4-FFF2-40B4-BE49-F238E27FC236}">
-                <a16:creationId xmlns:a16="http://schemas.microsoft.com/office/drawing/2014/main" id="{85AB9161-B742-5DC8-DFDD-AD7378577796}"/>
+                <a16:creationId xmlns:a16="http://schemas.microsoft.com/office/drawing/2014/main" id="{6121E714-F00C-F5B3-12D8-9C7968748E41}"/>
               </a:ext>
             </a:extLst>
           </p:cNvPr>
@@ -2868,7 +2868,7 @@
           <p:cNvPr id="4" name="날짜 개체 틀 3">
             <a:extLst>
               <a:ext uri="{FF2B5EF4-FFF2-40B4-BE49-F238E27FC236}">
-                <a16:creationId xmlns:a16="http://schemas.microsoft.com/office/drawing/2014/main" id="{F7B4E9E1-BF57-7B6D-7475-363EA253E2E8}"/>
+                <a16:creationId xmlns:a16="http://schemas.microsoft.com/office/drawing/2014/main" id="{726850D6-FDF0-6A78-3D9C-9295C6E9587F}"/>
               </a:ext>
             </a:extLst>
           </p:cNvPr>
@@ -2902,7 +2902,7 @@
             </a:lvl1pPr>
           </a:lstStyle>
           <a:p>
-            <a:fld id="{4EDDC4F2-F7BA-451D-AD65-B44D4A0691CB}" type="datetimeFigureOut">
+            <a:fld id="{F692C54F-6661-431E-BC7A-3BF7D7121E25}" type="datetimeFigureOut">
               <a:rPr lang="ko-KR" altLang="en-US" smtClean="0"/>
               <a:t>2026-06-20</a:t>
             </a:fld>
@@ -2915,7 +2915,7 @@
           <p:cNvPr id="5" name="바닥글 개체 틀 4">
             <a:extLst>
               <a:ext uri="{FF2B5EF4-FFF2-40B4-BE49-F238E27FC236}">
-                <a16:creationId xmlns:a16="http://schemas.microsoft.com/office/drawing/2014/main" id="{D24513F7-FA78-6767-CE7F-EAA4726BF0FB}"/>
+                <a16:creationId xmlns:a16="http://schemas.microsoft.com/office/drawing/2014/main" id="{A00971DC-82FE-1484-0BC3-0A923B5EA895}"/>
               </a:ext>
             </a:extLst>
           </p:cNvPr>
@@ -2958,7 +2958,7 @@
           <p:cNvPr id="6" name="슬라이드 번호 개체 틀 5">
             <a:extLst>
               <a:ext uri="{FF2B5EF4-FFF2-40B4-BE49-F238E27FC236}">
-                <a16:creationId xmlns:a16="http://schemas.microsoft.com/office/drawing/2014/main" id="{BBC2EEC4-B8ED-969F-533F-A4C54549DA10}"/>
+                <a16:creationId xmlns:a16="http://schemas.microsoft.com/office/drawing/2014/main" id="{D143E963-3311-5AC1-36A3-0E36EBE638C0}"/>
               </a:ext>
             </a:extLst>
           </p:cNvPr>
@@ -2992,7 +2992,7 @@
             </a:lvl1pPr>
           </a:lstStyle>
           <a:p>
-            <a:fld id="{A36E63EA-5A2B-431F-BF5E-3184E73FCB0D}" type="slidenum">
+            <a:fld id="{82B1D940-9C20-4F30-B670-23B802C5312A}" type="slidenum">
               <a:rPr lang="ko-KR" altLang="en-US" smtClean="0"/>
               <a:t>‹#›</a:t>
             </a:fld>
@@ -3003,7 +3003,7 @@
     </p:spTree>
     <p:extLst>
       <p:ext uri="{BB962C8B-B14F-4D97-AF65-F5344CB8AC3E}">
-        <p14:creationId xmlns:p14="http://schemas.microsoft.com/office/powerpoint/2010/main" val="2103855178"/>
+        <p14:creationId xmlns:p14="http://schemas.microsoft.com/office/powerpoint/2010/main" val="985503933"/>
       </p:ext>
     </p:extLst>
   </p:cSld>
@@ -3326,7 +3326,7 @@
           <p:cNvPr id="2" name="z00_grid_top">
             <a:extLst>
               <a:ext uri="{FF2B5EF4-FFF2-40B4-BE49-F238E27FC236}">
-                <a16:creationId xmlns:a16="http://schemas.microsoft.com/office/drawing/2014/main" id="{F75B49F6-10AF-3B2B-18DA-60CE6A2D9597}"/>
+                <a16:creationId xmlns:a16="http://schemas.microsoft.com/office/drawing/2014/main" id="{A660290B-30C0-8A36-19E7-E962F0EBA989}"/>
               </a:ext>
             </a:extLst>
           </p:cNvPr>
@@ -3369,7 +3369,7 @@
           <p:cNvPr id="3" name="z00_grid_bottom">
             <a:extLst>
               <a:ext uri="{FF2B5EF4-FFF2-40B4-BE49-F238E27FC236}">
-                <a16:creationId xmlns:a16="http://schemas.microsoft.com/office/drawing/2014/main" id="{F9BDCD24-E878-1E6D-57D2-79FE5A1FA100}"/>
+                <a16:creationId xmlns:a16="http://schemas.microsoft.com/office/drawing/2014/main" id="{64109907-C32D-E4BC-2381-D8171DD30B71}"/>
               </a:ext>
             </a:extLst>
           </p:cNvPr>
@@ -3378,7 +3378,7 @@
         </p:nvCxnSpPr>
         <p:spPr>
           <a:xfrm>
-            <a:off x="627001" y="5416918"/>
+            <a:off x="627001" y="5198845"/>
             <a:ext cx="10937693" cy="0"/>
           </a:xfrm>
           <a:prstGeom prst="line">
@@ -3412,7 +3412,7 @@
           <p:cNvPr id="4" name="z00_grid_v_0">
             <a:extLst>
               <a:ext uri="{FF2B5EF4-FFF2-40B4-BE49-F238E27FC236}">
-                <a16:creationId xmlns:a16="http://schemas.microsoft.com/office/drawing/2014/main" id="{61B5C174-25B8-F190-EB19-EFD692BD20D6}"/>
+                <a16:creationId xmlns:a16="http://schemas.microsoft.com/office/drawing/2014/main" id="{DA177854-B0ED-9332-5758-EE4F67D86052}"/>
               </a:ext>
             </a:extLst>
           </p:cNvPr>
@@ -3455,7 +3455,7 @@
           <p:cNvPr id="5" name="z00_grid_v_1">
             <a:extLst>
               <a:ext uri="{FF2B5EF4-FFF2-40B4-BE49-F238E27FC236}">
-                <a16:creationId xmlns:a16="http://schemas.microsoft.com/office/drawing/2014/main" id="{FEE66A0B-6F04-7E0C-7C5A-12D4488FFFEB}"/>
+                <a16:creationId xmlns:a16="http://schemas.microsoft.com/office/drawing/2014/main" id="{A330C8A4-C503-112A-79A8-E4DB5C85BAB4}"/>
               </a:ext>
             </a:extLst>
           </p:cNvPr>
@@ -3498,7 +3498,7 @@
           <p:cNvPr id="6" name="z00_grid_v_2">
             <a:extLst>
               <a:ext uri="{FF2B5EF4-FFF2-40B4-BE49-F238E27FC236}">
-                <a16:creationId xmlns:a16="http://schemas.microsoft.com/office/drawing/2014/main" id="{0160707E-DE34-4B2D-B853-45DA71B465C8}"/>
+                <a16:creationId xmlns:a16="http://schemas.microsoft.com/office/drawing/2014/main" id="{C2470649-2299-DFE7-4F09-7B97B17AA53A}"/>
               </a:ext>
             </a:extLst>
           </p:cNvPr>
@@ -3541,7 +3541,7 @@
           <p:cNvPr id="7" name="header_title">
             <a:extLst>
               <a:ext uri="{FF2B5EF4-FFF2-40B4-BE49-F238E27FC236}">
-                <a16:creationId xmlns:a16="http://schemas.microsoft.com/office/drawing/2014/main" id="{DCF8E862-B97B-32F4-B276-03D57F8BF580}"/>
+                <a16:creationId xmlns:a16="http://schemas.microsoft.com/office/drawing/2014/main" id="{5008FEC9-3015-5942-A7B3-C82701AF7DF1}"/>
               </a:ext>
             </a:extLst>
           </p:cNvPr>
@@ -3587,7 +3587,7 @@
           <p:cNvPr id="8" name="header_subtitle">
             <a:extLst>
               <a:ext uri="{FF2B5EF4-FFF2-40B4-BE49-F238E27FC236}">
-                <a16:creationId xmlns:a16="http://schemas.microsoft.com/office/drawing/2014/main" id="{D638691B-1148-E7AA-5E6A-4CFD96768B0C}"/>
+                <a16:creationId xmlns:a16="http://schemas.microsoft.com/office/drawing/2014/main" id="{9686F127-99CB-76B6-1222-3F668C00212E}"/>
               </a:ext>
             </a:extLst>
           </p:cNvPr>
@@ -3633,7 +3633,7 @@
           <p:cNvPr id="9" name="zone_content_panel">
             <a:extLst>
               <a:ext uri="{FF2B5EF4-FFF2-40B4-BE49-F238E27FC236}">
-                <a16:creationId xmlns:a16="http://schemas.microsoft.com/office/drawing/2014/main" id="{66E62231-A030-65D6-0646-4923E69855D1}"/>
+                <a16:creationId xmlns:a16="http://schemas.microsoft.com/office/drawing/2014/main" id="{8701C48E-3146-43E2-4200-AE6C680816C1}"/>
               </a:ext>
             </a:extLst>
           </p:cNvPr>
@@ -3696,7 +3696,7 @@
           <p:cNvPr id="10" name="zone_content_title">
             <a:extLst>
               <a:ext uri="{FF2B5EF4-FFF2-40B4-BE49-F238E27FC236}">
-                <a16:creationId xmlns:a16="http://schemas.microsoft.com/office/drawing/2014/main" id="{B2649A5D-0348-B0A5-D9E5-A989D5E8F5F8}"/>
+                <a16:creationId xmlns:a16="http://schemas.microsoft.com/office/drawing/2014/main" id="{8046DF84-E49C-BE9C-5F59-55C30C73206B}"/>
               </a:ext>
             </a:extLst>
           </p:cNvPr>
@@ -3742,7 +3742,7 @@
           <p:cNvPr id="11" name="zone_content_subtitle">
             <a:extLst>
               <a:ext uri="{FF2B5EF4-FFF2-40B4-BE49-F238E27FC236}">
-                <a16:creationId xmlns:a16="http://schemas.microsoft.com/office/drawing/2014/main" id="{CB1A33F0-A039-6F33-3C24-057505DC2DE0}"/>
+                <a16:creationId xmlns:a16="http://schemas.microsoft.com/office/drawing/2014/main" id="{00153960-FD76-F84B-4C30-FAD2167591FF}"/>
               </a:ext>
             </a:extLst>
           </p:cNvPr>
@@ -3788,7 +3788,7 @@
           <p:cNvPr id="12" name="zone_reasoning_panel">
             <a:extLst>
               <a:ext uri="{FF2B5EF4-FFF2-40B4-BE49-F238E27FC236}">
-                <a16:creationId xmlns:a16="http://schemas.microsoft.com/office/drawing/2014/main" id="{2CB6DF17-9DBC-A3F5-CC17-0C0F529578B2}"/>
+                <a16:creationId xmlns:a16="http://schemas.microsoft.com/office/drawing/2014/main" id="{4133A8CD-24BC-DF50-6755-FFDF95716961}"/>
               </a:ext>
             </a:extLst>
           </p:cNvPr>
@@ -3851,7 +3851,7 @@
           <p:cNvPr id="13" name="zone_reasoning_title">
             <a:extLst>
               <a:ext uri="{FF2B5EF4-FFF2-40B4-BE49-F238E27FC236}">
-                <a16:creationId xmlns:a16="http://schemas.microsoft.com/office/drawing/2014/main" id="{238A5CEE-B549-27DD-935E-AFDE2111F6DD}"/>
+                <a16:creationId xmlns:a16="http://schemas.microsoft.com/office/drawing/2014/main" id="{1A047CD1-9A0A-801B-7C3F-FFE00B1EB224}"/>
               </a:ext>
             </a:extLst>
           </p:cNvPr>
@@ -3897,7 +3897,7 @@
           <p:cNvPr id="14" name="zone_reasoning_subtitle">
             <a:extLst>
               <a:ext uri="{FF2B5EF4-FFF2-40B4-BE49-F238E27FC236}">
-                <a16:creationId xmlns:a16="http://schemas.microsoft.com/office/drawing/2014/main" id="{7FB4E32E-F3F5-8D9A-E61B-127FC6EC41EC}"/>
+                <a16:creationId xmlns:a16="http://schemas.microsoft.com/office/drawing/2014/main" id="{2A6B040F-AB79-910C-E95B-66C8C030467E}"/>
               </a:ext>
             </a:extLst>
           </p:cNvPr>
@@ -3943,7 +3943,7 @@
           <p:cNvPr id="15" name="zone_rules_panel">
             <a:extLst>
               <a:ext uri="{FF2B5EF4-FFF2-40B4-BE49-F238E27FC236}">
-                <a16:creationId xmlns:a16="http://schemas.microsoft.com/office/drawing/2014/main" id="{D63A546A-ABC7-6EC9-0B35-E83274EE4C60}"/>
+                <a16:creationId xmlns:a16="http://schemas.microsoft.com/office/drawing/2014/main" id="{BE82D27A-06B0-A68F-3AEF-B2DA1519F901}"/>
               </a:ext>
             </a:extLst>
           </p:cNvPr>
@@ -4006,7 +4006,7 @@
           <p:cNvPr id="16" name="zone_rules_title">
             <a:extLst>
               <a:ext uri="{FF2B5EF4-FFF2-40B4-BE49-F238E27FC236}">
-                <a16:creationId xmlns:a16="http://schemas.microsoft.com/office/drawing/2014/main" id="{CF148F85-4B6E-454E-7CC7-1DFFBBF1FA45}"/>
+                <a16:creationId xmlns:a16="http://schemas.microsoft.com/office/drawing/2014/main" id="{8654588F-B68D-8B34-F51A-859988029AF7}"/>
               </a:ext>
             </a:extLst>
           </p:cNvPr>
@@ -4052,7 +4052,7 @@
           <p:cNvPr id="17" name="zone_rules_subtitle">
             <a:extLst>
               <a:ext uri="{FF2B5EF4-FFF2-40B4-BE49-F238E27FC236}">
-                <a16:creationId xmlns:a16="http://schemas.microsoft.com/office/drawing/2014/main" id="{E721F6BD-4A6D-DBAF-1E75-EABC7B8ADF4F}"/>
+                <a16:creationId xmlns:a16="http://schemas.microsoft.com/office/drawing/2014/main" id="{BB4C89CE-32FB-A66F-FBE3-A0566526E80C}"/>
               </a:ext>
             </a:extLst>
           </p:cNvPr>
@@ -4098,7 +4098,7 @@
           <p:cNvPr id="18" name="zone_outputs_panel">
             <a:extLst>
               <a:ext uri="{FF2B5EF4-FFF2-40B4-BE49-F238E27FC236}">
-                <a16:creationId xmlns:a16="http://schemas.microsoft.com/office/drawing/2014/main" id="{2DC85142-C869-6F44-8736-246D0E4EDF3D}"/>
+                <a16:creationId xmlns:a16="http://schemas.microsoft.com/office/drawing/2014/main" id="{9EFD3DF1-A328-B9F4-C93E-EA5A53EA45F5}"/>
               </a:ext>
             </a:extLst>
           </p:cNvPr>
@@ -4161,7 +4161,7 @@
           <p:cNvPr id="19" name="zone_outputs_title">
             <a:extLst>
               <a:ext uri="{FF2B5EF4-FFF2-40B4-BE49-F238E27FC236}">
-                <a16:creationId xmlns:a16="http://schemas.microsoft.com/office/drawing/2014/main" id="{D83E7750-B70A-5217-BF87-6AF9830A03E2}"/>
+                <a16:creationId xmlns:a16="http://schemas.microsoft.com/office/drawing/2014/main" id="{9C350D2D-5DB1-D52D-FCD8-9010905B480D}"/>
               </a:ext>
             </a:extLst>
           </p:cNvPr>
@@ -4207,7 +4207,7 @@
           <p:cNvPr id="20" name="zone_outputs_subtitle">
             <a:extLst>
               <a:ext uri="{FF2B5EF4-FFF2-40B4-BE49-F238E27FC236}">
-                <a16:creationId xmlns:a16="http://schemas.microsoft.com/office/drawing/2014/main" id="{0919E7C8-EEFB-AE76-D8CC-086896B40897}"/>
+                <a16:creationId xmlns:a16="http://schemas.microsoft.com/office/drawing/2014/main" id="{A2594A10-E5B1-464B-A8B9-8E3E3B3243F3}"/>
               </a:ext>
             </a:extLst>
           </p:cNvPr>
@@ -4253,7 +4253,7 @@
           <p:cNvPr id="21" name="main_start_markdown">
             <a:extLst>
               <a:ext uri="{FF2B5EF4-FFF2-40B4-BE49-F238E27FC236}">
-                <a16:creationId xmlns:a16="http://schemas.microsoft.com/office/drawing/2014/main" id="{E39CC62B-810F-C353-6BA8-F5A7B3EB54C9}"/>
+                <a16:creationId xmlns:a16="http://schemas.microsoft.com/office/drawing/2014/main" id="{E1A80C1E-EBBB-EB73-86C8-F166AAFF01AB}"/>
               </a:ext>
             </a:extLst>
           </p:cNvPr>
@@ -4296,7 +4296,7 @@
           <p:cNvPr id="22" name="main_markdown_splitter">
             <a:extLst>
               <a:ext uri="{FF2B5EF4-FFF2-40B4-BE49-F238E27FC236}">
-                <a16:creationId xmlns:a16="http://schemas.microsoft.com/office/drawing/2014/main" id="{CE6F8A24-861F-B6EE-CC87-C588C90BC630}"/>
+                <a16:creationId xmlns:a16="http://schemas.microsoft.com/office/drawing/2014/main" id="{FB61F44F-BDBF-6450-D1BD-2CE85EE2FFA6}"/>
               </a:ext>
             </a:extLst>
           </p:cNvPr>
@@ -4339,7 +4339,7 @@
           <p:cNvPr id="23" name="main_splitter_ir_seg_1">
             <a:extLst>
               <a:ext uri="{FF2B5EF4-FFF2-40B4-BE49-F238E27FC236}">
-                <a16:creationId xmlns:a16="http://schemas.microsoft.com/office/drawing/2014/main" id="{1EF0B746-72DD-A554-E0FF-E8DFC4FA865E}"/>
+                <a16:creationId xmlns:a16="http://schemas.microsoft.com/office/drawing/2014/main" id="{717F0BBE-1EAC-2B10-A415-30209424FE8C}"/>
               </a:ext>
             </a:extLst>
           </p:cNvPr>
@@ -4382,7 +4382,7 @@
           <p:cNvPr id="24" name="main_splitter_ir_seg_2">
             <a:extLst>
               <a:ext uri="{FF2B5EF4-FFF2-40B4-BE49-F238E27FC236}">
-                <a16:creationId xmlns:a16="http://schemas.microsoft.com/office/drawing/2014/main" id="{09ADF139-3E78-C746-23E8-6A2CA697D214}"/>
+                <a16:creationId xmlns:a16="http://schemas.microsoft.com/office/drawing/2014/main" id="{2F0CA61E-7C9B-3163-652C-1F33093BB7DE}"/>
               </a:ext>
             </a:extLst>
           </p:cNvPr>
@@ -4425,7 +4425,7 @@
           <p:cNvPr id="25" name="main_splitter_ir_seg_3">
             <a:extLst>
               <a:ext uri="{FF2B5EF4-FFF2-40B4-BE49-F238E27FC236}">
-                <a16:creationId xmlns:a16="http://schemas.microsoft.com/office/drawing/2014/main" id="{92A6280F-01A8-9979-CB0B-D834456D2179}"/>
+                <a16:creationId xmlns:a16="http://schemas.microsoft.com/office/drawing/2014/main" id="{8A25E509-6B0E-DAA2-9D31-D744A19E15D7}"/>
               </a:ext>
             </a:extLst>
           </p:cNvPr>
@@ -4468,7 +4468,7 @@
           <p:cNvPr id="26" name="hint_ir_reasoning">
             <a:extLst>
               <a:ext uri="{FF2B5EF4-FFF2-40B4-BE49-F238E27FC236}">
-                <a16:creationId xmlns:a16="http://schemas.microsoft.com/office/drawing/2014/main" id="{AE04FE2C-6968-9D24-10D9-69E5D15302C4}"/>
+                <a16:creationId xmlns:a16="http://schemas.microsoft.com/office/drawing/2014/main" id="{97B53CD9-F178-92A7-B1DF-E7D0E0DFD863}"/>
               </a:ext>
             </a:extLst>
           </p:cNvPr>
@@ -4512,7 +4512,7 @@
           <p:cNvPr id="27" name="main_ir_rules">
             <a:extLst>
               <a:ext uri="{FF2B5EF4-FFF2-40B4-BE49-F238E27FC236}">
-                <a16:creationId xmlns:a16="http://schemas.microsoft.com/office/drawing/2014/main" id="{A38F09B0-184D-3EF7-C18F-9094A30132DE}"/>
+                <a16:creationId xmlns:a16="http://schemas.microsoft.com/office/drawing/2014/main" id="{5785DF1C-1044-0421-A626-B24FD4E9C2EF}"/>
               </a:ext>
             </a:extLst>
           </p:cNvPr>
@@ -4555,7 +4555,7 @@
           <p:cNvPr id="28" name="hint_reasoning_rules_seg_1">
             <a:extLst>
               <a:ext uri="{FF2B5EF4-FFF2-40B4-BE49-F238E27FC236}">
-                <a16:creationId xmlns:a16="http://schemas.microsoft.com/office/drawing/2014/main" id="{56DF37D7-0F47-6911-D62E-204B90E7392F}"/>
+                <a16:creationId xmlns:a16="http://schemas.microsoft.com/office/drawing/2014/main" id="{FE1A6641-14A3-C6EF-F9B2-D4065F11325B}"/>
               </a:ext>
             </a:extLst>
           </p:cNvPr>
@@ -4599,7 +4599,7 @@
           <p:cNvPr id="29" name="hint_reasoning_rules_seg_2">
             <a:extLst>
               <a:ext uri="{FF2B5EF4-FFF2-40B4-BE49-F238E27FC236}">
-                <a16:creationId xmlns:a16="http://schemas.microsoft.com/office/drawing/2014/main" id="{7D1F3C84-DB59-D616-DA28-B284A1A2AB9E}"/>
+                <a16:creationId xmlns:a16="http://schemas.microsoft.com/office/drawing/2014/main" id="{08C74972-6B73-2BAF-E83D-B1D64847544D}"/>
               </a:ext>
             </a:extLst>
           </p:cNvPr>
@@ -4643,7 +4643,7 @@
           <p:cNvPr id="30" name="hint_reasoning_rules_seg_3">
             <a:extLst>
               <a:ext uri="{FF2B5EF4-FFF2-40B4-BE49-F238E27FC236}">
-                <a16:creationId xmlns:a16="http://schemas.microsoft.com/office/drawing/2014/main" id="{538A58D9-B8A5-8A8E-74FF-ABA7F342F5DF}"/>
+                <a16:creationId xmlns:a16="http://schemas.microsoft.com/office/drawing/2014/main" id="{2351F645-7423-B524-3B60-C0F3ECB91D26}"/>
               </a:ext>
             </a:extLst>
           </p:cNvPr>
@@ -4687,7 +4687,7 @@
           <p:cNvPr id="31" name="rule_features_recipes">
             <a:extLst>
               <a:ext uri="{FF2B5EF4-FFF2-40B4-BE49-F238E27FC236}">
-                <a16:creationId xmlns:a16="http://schemas.microsoft.com/office/drawing/2014/main" id="{6C992AF4-E9EE-028A-494A-1621A62592B0}"/>
+                <a16:creationId xmlns:a16="http://schemas.microsoft.com/office/drawing/2014/main" id="{044F9AAC-152A-EE69-227E-EF6A05FED803}"/>
               </a:ext>
             </a:extLst>
           </p:cNvPr>
@@ -4730,7 +4730,7 @@
           <p:cNvPr id="32" name="rule_recipes_theme">
             <a:extLst>
               <a:ext uri="{FF2B5EF4-FFF2-40B4-BE49-F238E27FC236}">
-                <a16:creationId xmlns:a16="http://schemas.microsoft.com/office/drawing/2014/main" id="{7E7FACC4-6FAA-03FB-6B12-312825192465}"/>
+                <a16:creationId xmlns:a16="http://schemas.microsoft.com/office/drawing/2014/main" id="{B5BED09F-BA4A-8A4C-5486-00A16257456E}"/>
               </a:ext>
             </a:extLst>
           </p:cNvPr>
@@ -4773,7 +4773,7 @@
           <p:cNvPr id="33" name="rule_features_compose">
             <a:extLst>
               <a:ext uri="{FF2B5EF4-FFF2-40B4-BE49-F238E27FC236}">
-                <a16:creationId xmlns:a16="http://schemas.microsoft.com/office/drawing/2014/main" id="{6BCD6DC8-8381-B201-BCD1-B282866BF9A1}"/>
+                <a16:creationId xmlns:a16="http://schemas.microsoft.com/office/drawing/2014/main" id="{2302E3E3-D7CF-F171-C71F-DBF93EF89BC4}"/>
               </a:ext>
             </a:extLst>
           </p:cNvPr>
@@ -4816,7 +4816,7 @@
           <p:cNvPr id="34" name="rule_recipes_objects">
             <a:extLst>
               <a:ext uri="{FF2B5EF4-FFF2-40B4-BE49-F238E27FC236}">
-                <a16:creationId xmlns:a16="http://schemas.microsoft.com/office/drawing/2014/main" id="{320524C9-9E7E-428D-019E-837FCF3EF404}"/>
+                <a16:creationId xmlns:a16="http://schemas.microsoft.com/office/drawing/2014/main" id="{41EC4169-BB44-33E3-5D19-75CEBB952FEC}"/>
               </a:ext>
             </a:extLst>
           </p:cNvPr>
@@ -4859,7 +4859,7 @@
           <p:cNvPr id="35" name="rule_theme_decorate">
             <a:extLst>
               <a:ext uri="{FF2B5EF4-FFF2-40B4-BE49-F238E27FC236}">
-                <a16:creationId xmlns:a16="http://schemas.microsoft.com/office/drawing/2014/main" id="{B6B5F24D-ECF9-E6FB-0EC9-6AE321F5E88D}"/>
+                <a16:creationId xmlns:a16="http://schemas.microsoft.com/office/drawing/2014/main" id="{3B9F5337-C389-0482-C3AD-7F2566A7891A}"/>
               </a:ext>
             </a:extLst>
           </p:cNvPr>
@@ -4902,7 +4902,7 @@
           <p:cNvPr id="36" name="rule_compose_objects">
             <a:extLst>
               <a:ext uri="{FF2B5EF4-FFF2-40B4-BE49-F238E27FC236}">
-                <a16:creationId xmlns:a16="http://schemas.microsoft.com/office/drawing/2014/main" id="{697C7654-9E93-3756-4D2F-9A6AF7EC5604}"/>
+                <a16:creationId xmlns:a16="http://schemas.microsoft.com/office/drawing/2014/main" id="{49768874-B3E7-8C0B-B1EC-D0BC7626D892}"/>
               </a:ext>
             </a:extLst>
           </p:cNvPr>
@@ -4945,7 +4945,7 @@
           <p:cNvPr id="37" name="rule_objects_decorate">
             <a:extLst>
               <a:ext uri="{FF2B5EF4-FFF2-40B4-BE49-F238E27FC236}">
-                <a16:creationId xmlns:a16="http://schemas.microsoft.com/office/drawing/2014/main" id="{500090C7-31CC-59A3-4DF7-2CC8D7B9C7A1}"/>
+                <a16:creationId xmlns:a16="http://schemas.microsoft.com/office/drawing/2014/main" id="{57374FF1-6740-4131-FC03-9E1E4C79792F}"/>
               </a:ext>
             </a:extLst>
           </p:cNvPr>
@@ -4988,7 +4988,7 @@
           <p:cNvPr id="38" name="main_rules_styled_ir">
             <a:extLst>
               <a:ext uri="{FF2B5EF4-FFF2-40B4-BE49-F238E27FC236}">
-                <a16:creationId xmlns:a16="http://schemas.microsoft.com/office/drawing/2014/main" id="{AF524331-AE28-1C1A-52F6-5BD27FD9AA48}"/>
+                <a16:creationId xmlns:a16="http://schemas.microsoft.com/office/drawing/2014/main" id="{B5374004-C327-1687-04D9-78DD68DB6B45}"/>
               </a:ext>
             </a:extLst>
           </p:cNvPr>
@@ -5031,7 +5031,7 @@
           <p:cNvPr id="39" name="main_styled_renderers">
             <a:extLst>
               <a:ext uri="{FF2B5EF4-FFF2-40B4-BE49-F238E27FC236}">
-                <a16:creationId xmlns:a16="http://schemas.microsoft.com/office/drawing/2014/main" id="{6782BB55-F63B-1B1D-34B8-C2A0EDAFC1B6}"/>
+                <a16:creationId xmlns:a16="http://schemas.microsoft.com/office/drawing/2014/main" id="{EC960FB9-923F-D8CF-A349-168069EF8565}"/>
               </a:ext>
             </a:extLst>
           </p:cNvPr>
@@ -5074,7 +5074,7 @@
           <p:cNvPr id="40" name="validation_loop">
             <a:extLst>
               <a:ext uri="{FF2B5EF4-FFF2-40B4-BE49-F238E27FC236}">
-                <a16:creationId xmlns:a16="http://schemas.microsoft.com/office/drawing/2014/main" id="{AAE622E1-BF74-62EC-EEFA-10A971C35613}"/>
+                <a16:creationId xmlns:a16="http://schemas.microsoft.com/office/drawing/2014/main" id="{DADEB3B6-A038-8BEF-63B1-F916BEEEAD54}"/>
               </a:ext>
             </a:extLst>
           </p:cNvPr>
@@ -5117,7 +5117,7 @@
           <p:cNvPr id="41" name="source_chip">
             <a:extLst>
               <a:ext uri="{FF2B5EF4-FFF2-40B4-BE49-F238E27FC236}">
-                <a16:creationId xmlns:a16="http://schemas.microsoft.com/office/drawing/2014/main" id="{74DC4082-745C-0AD2-1FD8-BFE48FF0CD42}"/>
+                <a16:creationId xmlns:a16="http://schemas.microsoft.com/office/drawing/2014/main" id="{9116F10B-841F-D3B8-1EB0-A7163BCDF6B6}"/>
               </a:ext>
             </a:extLst>
           </p:cNvPr>
@@ -5180,7 +5180,7 @@
           <p:cNvPr id="42" name="source_chip_text">
             <a:extLst>
               <a:ext uri="{FF2B5EF4-FFF2-40B4-BE49-F238E27FC236}">
-                <a16:creationId xmlns:a16="http://schemas.microsoft.com/office/drawing/2014/main" id="{D99FEC8B-035D-430D-5F4B-56EB468ECBEC}"/>
+                <a16:creationId xmlns:a16="http://schemas.microsoft.com/office/drawing/2014/main" id="{CF56DA16-1B05-3490-9832-E61E01166085}"/>
               </a:ext>
             </a:extLst>
           </p:cNvPr>
@@ -5227,7 +5227,7 @@
           <p:cNvPr id="43" name="markdown_card">
             <a:extLst>
               <a:ext uri="{FF2B5EF4-FFF2-40B4-BE49-F238E27FC236}">
-                <a16:creationId xmlns:a16="http://schemas.microsoft.com/office/drawing/2014/main" id="{596BF581-ED5C-051A-6180-3A9020CC1B5D}"/>
+                <a16:creationId xmlns:a16="http://schemas.microsoft.com/office/drawing/2014/main" id="{4EBAAEAB-279D-A16D-420E-BF0E3AD5CD4B}"/>
               </a:ext>
             </a:extLst>
           </p:cNvPr>
@@ -5290,7 +5290,7 @@
           <p:cNvPr id="44" name="markdown_icon_dot">
             <a:extLst>
               <a:ext uri="{FF2B5EF4-FFF2-40B4-BE49-F238E27FC236}">
-                <a16:creationId xmlns:a16="http://schemas.microsoft.com/office/drawing/2014/main" id="{E3CADD30-7DFA-0C52-0A57-FCB1F4D8BC13}"/>
+                <a16:creationId xmlns:a16="http://schemas.microsoft.com/office/drawing/2014/main" id="{453B4358-9E5D-4631-552D-B2040F5E403C}"/>
               </a:ext>
             </a:extLst>
           </p:cNvPr>
@@ -5344,7 +5344,7 @@
           <p:cNvPr id="45" name="markdown_icon_label">
             <a:extLst>
               <a:ext uri="{FF2B5EF4-FFF2-40B4-BE49-F238E27FC236}">
-                <a16:creationId xmlns:a16="http://schemas.microsoft.com/office/drawing/2014/main" id="{9E11529A-B93D-8B54-FB5D-7FABDE08CDCA}"/>
+                <a16:creationId xmlns:a16="http://schemas.microsoft.com/office/drawing/2014/main" id="{CE0E59D0-FABE-32CE-4B96-331526B5BD7D}"/>
               </a:ext>
             </a:extLst>
           </p:cNvPr>
@@ -5391,7 +5391,7 @@
           <p:cNvPr id="46" name="markdown_title">
             <a:extLst>
               <a:ext uri="{FF2B5EF4-FFF2-40B4-BE49-F238E27FC236}">
-                <a16:creationId xmlns:a16="http://schemas.microsoft.com/office/drawing/2014/main" id="{99AC761A-7418-3A87-2E7A-560435C2A6AB}"/>
+                <a16:creationId xmlns:a16="http://schemas.microsoft.com/office/drawing/2014/main" id="{7F4D7B5E-5164-E2FA-2B11-373AF467FB05}"/>
               </a:ext>
             </a:extLst>
           </p:cNvPr>
@@ -5437,7 +5437,7 @@
           <p:cNvPr id="47" name="markdown_line_0">
             <a:extLst>
               <a:ext uri="{FF2B5EF4-FFF2-40B4-BE49-F238E27FC236}">
-                <a16:creationId xmlns:a16="http://schemas.microsoft.com/office/drawing/2014/main" id="{12142459-4DCD-19F9-3DE8-F08E44D1107A}"/>
+                <a16:creationId xmlns:a16="http://schemas.microsoft.com/office/drawing/2014/main" id="{F90527D7-EEF6-EBA6-6A4E-653247DEEB04}"/>
               </a:ext>
             </a:extLst>
           </p:cNvPr>
@@ -5483,7 +5483,7 @@
           <p:cNvPr id="48" name="markdown_line_1">
             <a:extLst>
               <a:ext uri="{FF2B5EF4-FFF2-40B4-BE49-F238E27FC236}">
-                <a16:creationId xmlns:a16="http://schemas.microsoft.com/office/drawing/2014/main" id="{15736425-DF3F-BCA0-2493-3D8BAE917A70}"/>
+                <a16:creationId xmlns:a16="http://schemas.microsoft.com/office/drawing/2014/main" id="{1B516A6B-2C75-6906-3AD2-D95AEC2991D7}"/>
               </a:ext>
             </a:extLst>
           </p:cNvPr>
@@ -5529,7 +5529,7 @@
           <p:cNvPr id="49" name="splitter_card">
             <a:extLst>
               <a:ext uri="{FF2B5EF4-FFF2-40B4-BE49-F238E27FC236}">
-                <a16:creationId xmlns:a16="http://schemas.microsoft.com/office/drawing/2014/main" id="{B98235E8-314D-B2CA-A3F6-7FAB318E7792}"/>
+                <a16:creationId xmlns:a16="http://schemas.microsoft.com/office/drawing/2014/main" id="{7A4C40FB-13A4-BF96-CB00-095E834ACF12}"/>
               </a:ext>
             </a:extLst>
           </p:cNvPr>
@@ -5592,7 +5592,7 @@
           <p:cNvPr id="50" name="splitter_icon_dot">
             <a:extLst>
               <a:ext uri="{FF2B5EF4-FFF2-40B4-BE49-F238E27FC236}">
-                <a16:creationId xmlns:a16="http://schemas.microsoft.com/office/drawing/2014/main" id="{3279EC3A-2EAE-8B28-70BC-A9DCB33F235A}"/>
+                <a16:creationId xmlns:a16="http://schemas.microsoft.com/office/drawing/2014/main" id="{E32C15BE-7E99-6A5C-B2BE-F807026AAD66}"/>
               </a:ext>
             </a:extLst>
           </p:cNvPr>
@@ -5646,7 +5646,7 @@
           <p:cNvPr id="51" name="splitter_icon_label">
             <a:extLst>
               <a:ext uri="{FF2B5EF4-FFF2-40B4-BE49-F238E27FC236}">
-                <a16:creationId xmlns:a16="http://schemas.microsoft.com/office/drawing/2014/main" id="{0F69E6A1-DF24-5C2F-1465-D1F4C64A8773}"/>
+                <a16:creationId xmlns:a16="http://schemas.microsoft.com/office/drawing/2014/main" id="{3409DAD2-581F-AE6E-C237-CE707025F100}"/>
               </a:ext>
             </a:extLst>
           </p:cNvPr>
@@ -5693,7 +5693,7 @@
           <p:cNvPr id="52" name="splitter_title">
             <a:extLst>
               <a:ext uri="{FF2B5EF4-FFF2-40B4-BE49-F238E27FC236}">
-                <a16:creationId xmlns:a16="http://schemas.microsoft.com/office/drawing/2014/main" id="{5875C5CD-48E9-A69A-7856-F246E33288FA}"/>
+                <a16:creationId xmlns:a16="http://schemas.microsoft.com/office/drawing/2014/main" id="{9BED16AE-7893-7E3F-59AB-F75C4D949633}"/>
               </a:ext>
             </a:extLst>
           </p:cNvPr>
@@ -5739,7 +5739,7 @@
           <p:cNvPr id="53" name="splitter_line_0">
             <a:extLst>
               <a:ext uri="{FF2B5EF4-FFF2-40B4-BE49-F238E27FC236}">
-                <a16:creationId xmlns:a16="http://schemas.microsoft.com/office/drawing/2014/main" id="{EF86A5A3-E263-D2E7-6F34-040B0F6979FC}"/>
+                <a16:creationId xmlns:a16="http://schemas.microsoft.com/office/drawing/2014/main" id="{C9968620-0E81-4F8B-3DC8-A52A15D50C88}"/>
               </a:ext>
             </a:extLst>
           </p:cNvPr>
@@ -5785,7 +5785,7 @@
           <p:cNvPr id="54" name="splitter_line_1">
             <a:extLst>
               <a:ext uri="{FF2B5EF4-FFF2-40B4-BE49-F238E27FC236}">
-                <a16:creationId xmlns:a16="http://schemas.microsoft.com/office/drawing/2014/main" id="{EF42F72A-CF9C-FA0D-0E10-13F9113EFF8C}"/>
+                <a16:creationId xmlns:a16="http://schemas.microsoft.com/office/drawing/2014/main" id="{C6F5656D-5726-00EE-A96E-7C84551C8100}"/>
               </a:ext>
             </a:extLst>
           </p:cNvPr>
@@ -5831,7 +5831,7 @@
           <p:cNvPr id="55" name="ir_core_card">
             <a:extLst>
               <a:ext uri="{FF2B5EF4-FFF2-40B4-BE49-F238E27FC236}">
-                <a16:creationId xmlns:a16="http://schemas.microsoft.com/office/drawing/2014/main" id="{B71B8F5F-B69A-FE9D-B27D-803E6A1A4245}"/>
+                <a16:creationId xmlns:a16="http://schemas.microsoft.com/office/drawing/2014/main" id="{22C8A9C6-35AA-4C67-462E-23EA7295E6B9}"/>
               </a:ext>
             </a:extLst>
           </p:cNvPr>
@@ -5894,7 +5894,7 @@
           <p:cNvPr id="56" name="ir_core_icon_dot">
             <a:extLst>
               <a:ext uri="{FF2B5EF4-FFF2-40B4-BE49-F238E27FC236}">
-                <a16:creationId xmlns:a16="http://schemas.microsoft.com/office/drawing/2014/main" id="{3E8BEF65-9BFB-094F-3215-A5B5FD043520}"/>
+                <a16:creationId xmlns:a16="http://schemas.microsoft.com/office/drawing/2014/main" id="{043C01C4-71DE-1FDC-9FBD-90FCED5430D8}"/>
               </a:ext>
             </a:extLst>
           </p:cNvPr>
@@ -5948,7 +5948,7 @@
           <p:cNvPr id="57" name="ir_core_icon_label">
             <a:extLst>
               <a:ext uri="{FF2B5EF4-FFF2-40B4-BE49-F238E27FC236}">
-                <a16:creationId xmlns:a16="http://schemas.microsoft.com/office/drawing/2014/main" id="{DA4735E6-3DFE-64F0-6A26-ABFF11C638B5}"/>
+                <a16:creationId xmlns:a16="http://schemas.microsoft.com/office/drawing/2014/main" id="{FD7EC292-4196-720F-1ACC-D51862E022CC}"/>
               </a:ext>
             </a:extLst>
           </p:cNvPr>
@@ -5995,7 +5995,7 @@
           <p:cNvPr id="58" name="ir_core_title">
             <a:extLst>
               <a:ext uri="{FF2B5EF4-FFF2-40B4-BE49-F238E27FC236}">
-                <a16:creationId xmlns:a16="http://schemas.microsoft.com/office/drawing/2014/main" id="{5CB7C43F-6F0E-A1C3-A2BE-B537D52888AF}"/>
+                <a16:creationId xmlns:a16="http://schemas.microsoft.com/office/drawing/2014/main" id="{4304F4CC-5CCA-B1F9-AE3B-7D25C0616A2A}"/>
               </a:ext>
             </a:extLst>
           </p:cNvPr>
@@ -6041,7 +6041,7 @@
           <p:cNvPr id="59" name="ir_core_line_0">
             <a:extLst>
               <a:ext uri="{FF2B5EF4-FFF2-40B4-BE49-F238E27FC236}">
-                <a16:creationId xmlns:a16="http://schemas.microsoft.com/office/drawing/2014/main" id="{9048BC93-1F17-559F-3270-8D688C40CE69}"/>
+                <a16:creationId xmlns:a16="http://schemas.microsoft.com/office/drawing/2014/main" id="{08336F79-7FEA-1757-0313-B79654E20245}"/>
               </a:ext>
             </a:extLst>
           </p:cNvPr>
@@ -6087,7 +6087,7 @@
           <p:cNvPr id="60" name="ir_core_line_1">
             <a:extLst>
               <a:ext uri="{FF2B5EF4-FFF2-40B4-BE49-F238E27FC236}">
-                <a16:creationId xmlns:a16="http://schemas.microsoft.com/office/drawing/2014/main" id="{312B7E56-DC2E-9B22-C907-29198E77264A}"/>
+                <a16:creationId xmlns:a16="http://schemas.microsoft.com/office/drawing/2014/main" id="{E6909066-0370-A1E1-A80D-8B6DEAF2F144}"/>
               </a:ext>
             </a:extLst>
           </p:cNvPr>
@@ -6133,7 +6133,7 @@
           <p:cNvPr id="61" name="reasoning_card">
             <a:extLst>
               <a:ext uri="{FF2B5EF4-FFF2-40B4-BE49-F238E27FC236}">
-                <a16:creationId xmlns:a16="http://schemas.microsoft.com/office/drawing/2014/main" id="{66EA7FF0-BABF-58D0-4789-D1C4B47B5881}"/>
+                <a16:creationId xmlns:a16="http://schemas.microsoft.com/office/drawing/2014/main" id="{EB542D2E-BBE8-FBD0-19F0-9232A2834750}"/>
               </a:ext>
             </a:extLst>
           </p:cNvPr>
@@ -6196,7 +6196,7 @@
           <p:cNvPr id="62" name="reasoning_icon_dot">
             <a:extLst>
               <a:ext uri="{FF2B5EF4-FFF2-40B4-BE49-F238E27FC236}">
-                <a16:creationId xmlns:a16="http://schemas.microsoft.com/office/drawing/2014/main" id="{C55BD113-44E4-1596-E1F3-D2AC7669713A}"/>
+                <a16:creationId xmlns:a16="http://schemas.microsoft.com/office/drawing/2014/main" id="{4155189A-8451-158B-B803-CC9C53DCE62E}"/>
               </a:ext>
             </a:extLst>
           </p:cNvPr>
@@ -6250,7 +6250,7 @@
           <p:cNvPr id="63" name="reasoning_icon_label">
             <a:extLst>
               <a:ext uri="{FF2B5EF4-FFF2-40B4-BE49-F238E27FC236}">
-                <a16:creationId xmlns:a16="http://schemas.microsoft.com/office/drawing/2014/main" id="{462FCB43-4374-71CB-D3BE-A8C16749BC0A}"/>
+                <a16:creationId xmlns:a16="http://schemas.microsoft.com/office/drawing/2014/main" id="{AC40A99D-C386-455A-F18A-932EA7DB781C}"/>
               </a:ext>
             </a:extLst>
           </p:cNvPr>
@@ -6297,7 +6297,7 @@
           <p:cNvPr id="64" name="reasoning_title">
             <a:extLst>
               <a:ext uri="{FF2B5EF4-FFF2-40B4-BE49-F238E27FC236}">
-                <a16:creationId xmlns:a16="http://schemas.microsoft.com/office/drawing/2014/main" id="{AACC2751-9CE7-F91A-338E-509C15AD2E09}"/>
+                <a16:creationId xmlns:a16="http://schemas.microsoft.com/office/drawing/2014/main" id="{762AD650-FEEC-E3AF-8D91-A853692B33C5}"/>
               </a:ext>
             </a:extLst>
           </p:cNvPr>
@@ -6343,7 +6343,7 @@
           <p:cNvPr id="65" name="reasoning_line_0">
             <a:extLst>
               <a:ext uri="{FF2B5EF4-FFF2-40B4-BE49-F238E27FC236}">
-                <a16:creationId xmlns:a16="http://schemas.microsoft.com/office/drawing/2014/main" id="{886DDD49-759F-2086-9E89-58EC1A32DB35}"/>
+                <a16:creationId xmlns:a16="http://schemas.microsoft.com/office/drawing/2014/main" id="{7BD0EE6C-EEAB-DF78-106B-4C19C2A39720}"/>
               </a:ext>
             </a:extLst>
           </p:cNvPr>
@@ -6389,7 +6389,7 @@
           <p:cNvPr id="66" name="reasoning_guard">
             <a:extLst>
               <a:ext uri="{FF2B5EF4-FFF2-40B4-BE49-F238E27FC236}">
-                <a16:creationId xmlns:a16="http://schemas.microsoft.com/office/drawing/2014/main" id="{FE0F55FF-6710-C229-0CDC-D85D6085FF60}"/>
+                <a16:creationId xmlns:a16="http://schemas.microsoft.com/office/drawing/2014/main" id="{E2752FC1-5FB4-4436-61DE-3E5EFBF12C74}"/>
               </a:ext>
             </a:extLst>
           </p:cNvPr>
@@ -6452,7 +6452,7 @@
           <p:cNvPr id="67" name="reasoning_guard_text">
             <a:extLst>
               <a:ext uri="{FF2B5EF4-FFF2-40B4-BE49-F238E27FC236}">
-                <a16:creationId xmlns:a16="http://schemas.microsoft.com/office/drawing/2014/main" id="{2CE1C936-6962-D134-C863-1ABC61F9AA6F}"/>
+                <a16:creationId xmlns:a16="http://schemas.microsoft.com/office/drawing/2014/main" id="{7A145B97-A592-438D-EA50-4E1007AD33C7}"/>
               </a:ext>
             </a:extLst>
           </p:cNvPr>
@@ -6499,7 +6499,7 @@
           <p:cNvPr id="68" name="reasoning_limit">
             <a:extLst>
               <a:ext uri="{FF2B5EF4-FFF2-40B4-BE49-F238E27FC236}">
-                <a16:creationId xmlns:a16="http://schemas.microsoft.com/office/drawing/2014/main" id="{8B722ED0-5B2A-00AB-87C3-E56656BE0C5C}"/>
+                <a16:creationId xmlns:a16="http://schemas.microsoft.com/office/drawing/2014/main" id="{72C67807-9F89-1D40-787E-77BC6BA0DF0D}"/>
               </a:ext>
             </a:extLst>
           </p:cNvPr>
@@ -6545,7 +6545,7 @@
           <p:cNvPr id="69" name="rule_engine_card">
             <a:extLst>
               <a:ext uri="{FF2B5EF4-FFF2-40B4-BE49-F238E27FC236}">
-                <a16:creationId xmlns:a16="http://schemas.microsoft.com/office/drawing/2014/main" id="{086C6A70-C45D-6B00-D5BD-E7AD215BB1ED}"/>
+                <a16:creationId xmlns:a16="http://schemas.microsoft.com/office/drawing/2014/main" id="{7A55AADD-04A1-DF54-7AC1-594CE5F81029}"/>
               </a:ext>
             </a:extLst>
           </p:cNvPr>
@@ -6608,7 +6608,7 @@
           <p:cNvPr id="70" name="rule_engine_title">
             <a:extLst>
               <a:ext uri="{FF2B5EF4-FFF2-40B4-BE49-F238E27FC236}">
-                <a16:creationId xmlns:a16="http://schemas.microsoft.com/office/drawing/2014/main" id="{9BA67C1C-2C12-3A76-EA97-ADC8A94AFA59}"/>
+                <a16:creationId xmlns:a16="http://schemas.microsoft.com/office/drawing/2014/main" id="{A4073E71-181F-BC83-55CB-215B9E5A05DD}"/>
               </a:ext>
             </a:extLst>
           </p:cNvPr>
@@ -6654,7 +6654,7 @@
           <p:cNvPr id="71" name="rule_engine_body">
             <a:extLst>
               <a:ext uri="{FF2B5EF4-FFF2-40B4-BE49-F238E27FC236}">
-                <a16:creationId xmlns:a16="http://schemas.microsoft.com/office/drawing/2014/main" id="{EDF2928A-EB1F-5DEC-3A6E-E6EC4AFD4114}"/>
+                <a16:creationId xmlns:a16="http://schemas.microsoft.com/office/drawing/2014/main" id="{3DF5B3B6-B1A6-147F-F192-F472D7B1CB91}"/>
               </a:ext>
             </a:extLst>
           </p:cNvPr>
@@ -6700,7 +6700,7 @@
           <p:cNvPr id="72" name="features_card">
             <a:extLst>
               <a:ext uri="{FF2B5EF4-FFF2-40B4-BE49-F238E27FC236}">
-                <a16:creationId xmlns:a16="http://schemas.microsoft.com/office/drawing/2014/main" id="{69CDCB23-4125-3009-1F7B-AE288D714E40}"/>
+                <a16:creationId xmlns:a16="http://schemas.microsoft.com/office/drawing/2014/main" id="{D2FE586E-3515-9BEC-5D50-B8529511F640}"/>
               </a:ext>
             </a:extLst>
           </p:cNvPr>
@@ -6763,7 +6763,7 @@
           <p:cNvPr id="73" name="features_icon_dot">
             <a:extLst>
               <a:ext uri="{FF2B5EF4-FFF2-40B4-BE49-F238E27FC236}">
-                <a16:creationId xmlns:a16="http://schemas.microsoft.com/office/drawing/2014/main" id="{D3BC89BB-2868-B14E-60CD-5C9C9B8ADD33}"/>
+                <a16:creationId xmlns:a16="http://schemas.microsoft.com/office/drawing/2014/main" id="{ED5F13BB-3FF2-9529-FB67-D8DCAE26D9A6}"/>
               </a:ext>
             </a:extLst>
           </p:cNvPr>
@@ -6817,7 +6817,7 @@
           <p:cNvPr id="74" name="features_icon_label">
             <a:extLst>
               <a:ext uri="{FF2B5EF4-FFF2-40B4-BE49-F238E27FC236}">
-                <a16:creationId xmlns:a16="http://schemas.microsoft.com/office/drawing/2014/main" id="{3393217C-DB37-CF1D-A493-CEA29CA2B23A}"/>
+                <a16:creationId xmlns:a16="http://schemas.microsoft.com/office/drawing/2014/main" id="{8D22C6B1-ECBB-272B-C4AE-71D7FE6ED5D2}"/>
               </a:ext>
             </a:extLst>
           </p:cNvPr>
@@ -6864,7 +6864,7 @@
           <p:cNvPr id="75" name="features_title">
             <a:extLst>
               <a:ext uri="{FF2B5EF4-FFF2-40B4-BE49-F238E27FC236}">
-                <a16:creationId xmlns:a16="http://schemas.microsoft.com/office/drawing/2014/main" id="{228EEAF0-5FDA-0A00-9A85-FAD3DC419DB8}"/>
+                <a16:creationId xmlns:a16="http://schemas.microsoft.com/office/drawing/2014/main" id="{E2B08FFA-CABA-7317-6F88-CD9BDBF1F3F1}"/>
               </a:ext>
             </a:extLst>
           </p:cNvPr>
@@ -6910,7 +6910,7 @@
           <p:cNvPr id="76" name="features_line_0">
             <a:extLst>
               <a:ext uri="{FF2B5EF4-FFF2-40B4-BE49-F238E27FC236}">
-                <a16:creationId xmlns:a16="http://schemas.microsoft.com/office/drawing/2014/main" id="{9F732D61-2E38-D08C-BA5F-3A63534AE8E0}"/>
+                <a16:creationId xmlns:a16="http://schemas.microsoft.com/office/drawing/2014/main" id="{DD21B1F4-E5B7-1C31-CD95-4A2CFAC7E715}"/>
               </a:ext>
             </a:extLst>
           </p:cNvPr>
@@ -6956,7 +6956,7 @@
           <p:cNvPr id="77" name="features_line_1">
             <a:extLst>
               <a:ext uri="{FF2B5EF4-FFF2-40B4-BE49-F238E27FC236}">
-                <a16:creationId xmlns:a16="http://schemas.microsoft.com/office/drawing/2014/main" id="{1F52701B-5D07-DF51-6AF4-954644192479}"/>
+                <a16:creationId xmlns:a16="http://schemas.microsoft.com/office/drawing/2014/main" id="{38A0C5AE-15DD-C81D-E8A0-80581A18BD0C}"/>
               </a:ext>
             </a:extLst>
           </p:cNvPr>
@@ -7002,7 +7002,7 @@
           <p:cNvPr id="78" name="recipes_card">
             <a:extLst>
               <a:ext uri="{FF2B5EF4-FFF2-40B4-BE49-F238E27FC236}">
-                <a16:creationId xmlns:a16="http://schemas.microsoft.com/office/drawing/2014/main" id="{D2DA1030-908A-EC05-09B9-80AD68500334}"/>
+                <a16:creationId xmlns:a16="http://schemas.microsoft.com/office/drawing/2014/main" id="{2C1A8885-F3D9-DF7E-7FC6-746F4DBE5480}"/>
               </a:ext>
             </a:extLst>
           </p:cNvPr>
@@ -7065,7 +7065,7 @@
           <p:cNvPr id="79" name="recipes_icon_dot">
             <a:extLst>
               <a:ext uri="{FF2B5EF4-FFF2-40B4-BE49-F238E27FC236}">
-                <a16:creationId xmlns:a16="http://schemas.microsoft.com/office/drawing/2014/main" id="{A5986A28-3205-E76B-87C8-309991B1F90B}"/>
+                <a16:creationId xmlns:a16="http://schemas.microsoft.com/office/drawing/2014/main" id="{2E261521-C3EE-14AD-435E-C2982DDA4F44}"/>
               </a:ext>
             </a:extLst>
           </p:cNvPr>
@@ -7119,7 +7119,7 @@
           <p:cNvPr id="80" name="recipes_icon_label">
             <a:extLst>
               <a:ext uri="{FF2B5EF4-FFF2-40B4-BE49-F238E27FC236}">
-                <a16:creationId xmlns:a16="http://schemas.microsoft.com/office/drawing/2014/main" id="{DE17B9C6-82F9-3354-A9B0-E9F15BF6D0B8}"/>
+                <a16:creationId xmlns:a16="http://schemas.microsoft.com/office/drawing/2014/main" id="{87331D25-0A0E-1DF2-4160-CB32BE4D3330}"/>
               </a:ext>
             </a:extLst>
           </p:cNvPr>
@@ -7166,7 +7166,7 @@
           <p:cNvPr id="81" name="recipes_title">
             <a:extLst>
               <a:ext uri="{FF2B5EF4-FFF2-40B4-BE49-F238E27FC236}">
-                <a16:creationId xmlns:a16="http://schemas.microsoft.com/office/drawing/2014/main" id="{E9036F68-A58B-57CF-1B28-B2E1AF65A53B}"/>
+                <a16:creationId xmlns:a16="http://schemas.microsoft.com/office/drawing/2014/main" id="{89D3A795-0AEA-5A0A-6D04-E1B22717100F}"/>
               </a:ext>
             </a:extLst>
           </p:cNvPr>
@@ -7212,7 +7212,7 @@
           <p:cNvPr id="82" name="recipes_line_0">
             <a:extLst>
               <a:ext uri="{FF2B5EF4-FFF2-40B4-BE49-F238E27FC236}">
-                <a16:creationId xmlns:a16="http://schemas.microsoft.com/office/drawing/2014/main" id="{C86B3465-3C29-515F-2937-4B13C15D8BA8}"/>
+                <a16:creationId xmlns:a16="http://schemas.microsoft.com/office/drawing/2014/main" id="{DA809DF5-3BC9-5B4C-556F-2F642E01F06B}"/>
               </a:ext>
             </a:extLst>
           </p:cNvPr>
@@ -7258,7 +7258,7 @@
           <p:cNvPr id="83" name="recipes_line_1">
             <a:extLst>
               <a:ext uri="{FF2B5EF4-FFF2-40B4-BE49-F238E27FC236}">
-                <a16:creationId xmlns:a16="http://schemas.microsoft.com/office/drawing/2014/main" id="{B9151A42-783A-3DD3-2B14-C8625D7BCF14}"/>
+                <a16:creationId xmlns:a16="http://schemas.microsoft.com/office/drawing/2014/main" id="{1A56BBD8-A5EA-6AD9-C735-E8AF40830128}"/>
               </a:ext>
             </a:extLst>
           </p:cNvPr>
@@ -7304,7 +7304,7 @@
           <p:cNvPr id="84" name="theme_card">
             <a:extLst>
               <a:ext uri="{FF2B5EF4-FFF2-40B4-BE49-F238E27FC236}">
-                <a16:creationId xmlns:a16="http://schemas.microsoft.com/office/drawing/2014/main" id="{041BC948-2B8A-DCF4-36A1-7243F636D089}"/>
+                <a16:creationId xmlns:a16="http://schemas.microsoft.com/office/drawing/2014/main" id="{D5FD3998-2483-1020-6A30-525DF0AC78A7}"/>
               </a:ext>
             </a:extLst>
           </p:cNvPr>
@@ -7367,7 +7367,7 @@
           <p:cNvPr id="85" name="theme_icon_dot">
             <a:extLst>
               <a:ext uri="{FF2B5EF4-FFF2-40B4-BE49-F238E27FC236}">
-                <a16:creationId xmlns:a16="http://schemas.microsoft.com/office/drawing/2014/main" id="{C272F0E8-00F2-B8B7-A005-3D8798A9F866}"/>
+                <a16:creationId xmlns:a16="http://schemas.microsoft.com/office/drawing/2014/main" id="{92BC1A27-BEF7-11A6-4A3B-C010565B75AF}"/>
               </a:ext>
             </a:extLst>
           </p:cNvPr>
@@ -7421,7 +7421,7 @@
           <p:cNvPr id="86" name="theme_icon_label">
             <a:extLst>
               <a:ext uri="{FF2B5EF4-FFF2-40B4-BE49-F238E27FC236}">
-                <a16:creationId xmlns:a16="http://schemas.microsoft.com/office/drawing/2014/main" id="{FF8400D9-68DF-0874-6FAD-491CCBB89ABA}"/>
+                <a16:creationId xmlns:a16="http://schemas.microsoft.com/office/drawing/2014/main" id="{14740B9F-31FF-AA3B-E8E6-F5F40AF6E1B2}"/>
               </a:ext>
             </a:extLst>
           </p:cNvPr>
@@ -7468,7 +7468,7 @@
           <p:cNvPr id="87" name="theme_title">
             <a:extLst>
               <a:ext uri="{FF2B5EF4-FFF2-40B4-BE49-F238E27FC236}">
-                <a16:creationId xmlns:a16="http://schemas.microsoft.com/office/drawing/2014/main" id="{088884F8-695F-D1A4-7CCB-66F89DEFBCF7}"/>
+                <a16:creationId xmlns:a16="http://schemas.microsoft.com/office/drawing/2014/main" id="{3359B3EE-1933-F31F-9F4D-4381564088E9}"/>
               </a:ext>
             </a:extLst>
           </p:cNvPr>
@@ -7514,7 +7514,7 @@
           <p:cNvPr id="88" name="theme_line_0">
             <a:extLst>
               <a:ext uri="{FF2B5EF4-FFF2-40B4-BE49-F238E27FC236}">
-                <a16:creationId xmlns:a16="http://schemas.microsoft.com/office/drawing/2014/main" id="{55C6FB5A-47F3-B599-E123-0D9A61287FB8}"/>
+                <a16:creationId xmlns:a16="http://schemas.microsoft.com/office/drawing/2014/main" id="{A3321937-10F4-ACC3-6284-66325A55E422}"/>
               </a:ext>
             </a:extLst>
           </p:cNvPr>
@@ -7560,7 +7560,7 @@
           <p:cNvPr id="89" name="theme_line_1">
             <a:extLst>
               <a:ext uri="{FF2B5EF4-FFF2-40B4-BE49-F238E27FC236}">
-                <a16:creationId xmlns:a16="http://schemas.microsoft.com/office/drawing/2014/main" id="{F7AA71BA-A11C-7F64-0351-D8458516E896}"/>
+                <a16:creationId xmlns:a16="http://schemas.microsoft.com/office/drawing/2014/main" id="{6884D6B4-9AFC-B1C9-ABCF-1D1E6E3DE098}"/>
               </a:ext>
             </a:extLst>
           </p:cNvPr>
@@ -7606,7 +7606,7 @@
           <p:cNvPr id="90" name="compose_card">
             <a:extLst>
               <a:ext uri="{FF2B5EF4-FFF2-40B4-BE49-F238E27FC236}">
-                <a16:creationId xmlns:a16="http://schemas.microsoft.com/office/drawing/2014/main" id="{DD9B547F-FB92-FCA6-FCBB-B9F07149E06C}"/>
+                <a16:creationId xmlns:a16="http://schemas.microsoft.com/office/drawing/2014/main" id="{EB3117D9-910A-4A3E-1507-32DDC0C89C2E}"/>
               </a:ext>
             </a:extLst>
           </p:cNvPr>
@@ -7669,7 +7669,7 @@
           <p:cNvPr id="91" name="compose_icon_dot">
             <a:extLst>
               <a:ext uri="{FF2B5EF4-FFF2-40B4-BE49-F238E27FC236}">
-                <a16:creationId xmlns:a16="http://schemas.microsoft.com/office/drawing/2014/main" id="{3B405590-4B6D-379B-F2FE-D56DB92A7AA7}"/>
+                <a16:creationId xmlns:a16="http://schemas.microsoft.com/office/drawing/2014/main" id="{0F43866D-D4D0-3174-A471-9F3ACF5EC52B}"/>
               </a:ext>
             </a:extLst>
           </p:cNvPr>
@@ -7723,7 +7723,7 @@
           <p:cNvPr id="92" name="compose_icon_label">
             <a:extLst>
               <a:ext uri="{FF2B5EF4-FFF2-40B4-BE49-F238E27FC236}">
-                <a16:creationId xmlns:a16="http://schemas.microsoft.com/office/drawing/2014/main" id="{C229D5CE-E174-3AD5-68C6-A8BCB5CC82A7}"/>
+                <a16:creationId xmlns:a16="http://schemas.microsoft.com/office/drawing/2014/main" id="{C5F9937C-A86C-B58D-AE59-E5DB42E19029}"/>
               </a:ext>
             </a:extLst>
           </p:cNvPr>
@@ -7770,7 +7770,7 @@
           <p:cNvPr id="93" name="compose_title">
             <a:extLst>
               <a:ext uri="{FF2B5EF4-FFF2-40B4-BE49-F238E27FC236}">
-                <a16:creationId xmlns:a16="http://schemas.microsoft.com/office/drawing/2014/main" id="{2743A83D-9416-0E7E-F890-55A0BB19EC00}"/>
+                <a16:creationId xmlns:a16="http://schemas.microsoft.com/office/drawing/2014/main" id="{34FA863E-D013-C41A-4AA0-ED7320DE86C0}"/>
               </a:ext>
             </a:extLst>
           </p:cNvPr>
@@ -7816,7 +7816,7 @@
           <p:cNvPr id="94" name="compose_line_0">
             <a:extLst>
               <a:ext uri="{FF2B5EF4-FFF2-40B4-BE49-F238E27FC236}">
-                <a16:creationId xmlns:a16="http://schemas.microsoft.com/office/drawing/2014/main" id="{B4291D40-F271-4843-A272-1BC8E9113991}"/>
+                <a16:creationId xmlns:a16="http://schemas.microsoft.com/office/drawing/2014/main" id="{C8AEFCE5-5E25-083A-56CE-F9DD84742D2C}"/>
               </a:ext>
             </a:extLst>
           </p:cNvPr>
@@ -7862,7 +7862,7 @@
           <p:cNvPr id="95" name="compose_line_1">
             <a:extLst>
               <a:ext uri="{FF2B5EF4-FFF2-40B4-BE49-F238E27FC236}">
-                <a16:creationId xmlns:a16="http://schemas.microsoft.com/office/drawing/2014/main" id="{22459BDA-8F2E-4981-A792-F093F5342CE0}"/>
+                <a16:creationId xmlns:a16="http://schemas.microsoft.com/office/drawing/2014/main" id="{E8456249-5C0C-E6ED-D875-CD93E2E1021A}"/>
               </a:ext>
             </a:extLst>
           </p:cNvPr>
@@ -7908,7 +7908,7 @@
           <p:cNvPr id="96" name="objects_card">
             <a:extLst>
               <a:ext uri="{FF2B5EF4-FFF2-40B4-BE49-F238E27FC236}">
-                <a16:creationId xmlns:a16="http://schemas.microsoft.com/office/drawing/2014/main" id="{C35B82D5-E390-A8CE-C465-0CF3D9052CC5}"/>
+                <a16:creationId xmlns:a16="http://schemas.microsoft.com/office/drawing/2014/main" id="{D50CE41E-E365-0E93-9C03-A64B580154DC}"/>
               </a:ext>
             </a:extLst>
           </p:cNvPr>
@@ -7971,7 +7971,7 @@
           <p:cNvPr id="97" name="objects_icon_dot">
             <a:extLst>
               <a:ext uri="{FF2B5EF4-FFF2-40B4-BE49-F238E27FC236}">
-                <a16:creationId xmlns:a16="http://schemas.microsoft.com/office/drawing/2014/main" id="{13EF4495-E5C4-96E2-7909-EE76B2712D01}"/>
+                <a16:creationId xmlns:a16="http://schemas.microsoft.com/office/drawing/2014/main" id="{0163D77D-FF68-27B6-9C0B-949E96828F29}"/>
               </a:ext>
             </a:extLst>
           </p:cNvPr>
@@ -8025,7 +8025,7 @@
           <p:cNvPr id="98" name="objects_icon_label">
             <a:extLst>
               <a:ext uri="{FF2B5EF4-FFF2-40B4-BE49-F238E27FC236}">
-                <a16:creationId xmlns:a16="http://schemas.microsoft.com/office/drawing/2014/main" id="{94C1E04D-C64F-1B4A-45CB-908FBFD8835B}"/>
+                <a16:creationId xmlns:a16="http://schemas.microsoft.com/office/drawing/2014/main" id="{9B5255BC-3EB4-50B8-B5B2-1CD14BB055B3}"/>
               </a:ext>
             </a:extLst>
           </p:cNvPr>
@@ -8072,7 +8072,7 @@
           <p:cNvPr id="99" name="objects_title">
             <a:extLst>
               <a:ext uri="{FF2B5EF4-FFF2-40B4-BE49-F238E27FC236}">
-                <a16:creationId xmlns:a16="http://schemas.microsoft.com/office/drawing/2014/main" id="{0EF296BA-EB7E-550F-3A54-81A09B5263B3}"/>
+                <a16:creationId xmlns:a16="http://schemas.microsoft.com/office/drawing/2014/main" id="{C38E2131-E56A-4456-E106-5DE476601408}"/>
               </a:ext>
             </a:extLst>
           </p:cNvPr>
@@ -8118,7 +8118,7 @@
           <p:cNvPr id="100" name="objects_line_0">
             <a:extLst>
               <a:ext uri="{FF2B5EF4-FFF2-40B4-BE49-F238E27FC236}">
-                <a16:creationId xmlns:a16="http://schemas.microsoft.com/office/drawing/2014/main" id="{8BB7F4C2-292A-3D52-EB04-5ABEB3D3F52D}"/>
+                <a16:creationId xmlns:a16="http://schemas.microsoft.com/office/drawing/2014/main" id="{D53533DE-29E7-C995-DB89-7ADD393C9F20}"/>
               </a:ext>
             </a:extLst>
           </p:cNvPr>
@@ -8164,7 +8164,7 @@
           <p:cNvPr id="101" name="objects_line_1">
             <a:extLst>
               <a:ext uri="{FF2B5EF4-FFF2-40B4-BE49-F238E27FC236}">
-                <a16:creationId xmlns:a16="http://schemas.microsoft.com/office/drawing/2014/main" id="{3EEC70B0-32B4-BC84-36F1-148E5D83244C}"/>
+                <a16:creationId xmlns:a16="http://schemas.microsoft.com/office/drawing/2014/main" id="{376EC4D3-7A06-DD20-E3F5-5921092D1CF4}"/>
               </a:ext>
             </a:extLst>
           </p:cNvPr>
@@ -8210,7 +8210,7 @@
           <p:cNvPr id="102" name="decorate_card">
             <a:extLst>
               <a:ext uri="{FF2B5EF4-FFF2-40B4-BE49-F238E27FC236}">
-                <a16:creationId xmlns:a16="http://schemas.microsoft.com/office/drawing/2014/main" id="{4B35F939-CE91-5AA5-283E-D5942F8835A8}"/>
+                <a16:creationId xmlns:a16="http://schemas.microsoft.com/office/drawing/2014/main" id="{9339DAD8-6E0B-1B63-5612-41B3FFF56946}"/>
               </a:ext>
             </a:extLst>
           </p:cNvPr>
@@ -8273,7 +8273,7 @@
           <p:cNvPr id="103" name="decorate_icon_dot">
             <a:extLst>
               <a:ext uri="{FF2B5EF4-FFF2-40B4-BE49-F238E27FC236}">
-                <a16:creationId xmlns:a16="http://schemas.microsoft.com/office/drawing/2014/main" id="{73E826F0-AE8C-45E8-C421-3F9B8CE8DFB0}"/>
+                <a16:creationId xmlns:a16="http://schemas.microsoft.com/office/drawing/2014/main" id="{58A2D062-4D8D-23B9-5851-9099799A8EE6}"/>
               </a:ext>
             </a:extLst>
           </p:cNvPr>
@@ -8327,7 +8327,7 @@
           <p:cNvPr id="104" name="decorate_icon_label">
             <a:extLst>
               <a:ext uri="{FF2B5EF4-FFF2-40B4-BE49-F238E27FC236}">
-                <a16:creationId xmlns:a16="http://schemas.microsoft.com/office/drawing/2014/main" id="{F4F324B2-7DF9-B5B9-8E37-2992D701B4A7}"/>
+                <a16:creationId xmlns:a16="http://schemas.microsoft.com/office/drawing/2014/main" id="{DB339CE0-84E4-2DEB-2985-363FADA0ED5E}"/>
               </a:ext>
             </a:extLst>
           </p:cNvPr>
@@ -8374,7 +8374,7 @@
           <p:cNvPr id="105" name="decorate_title">
             <a:extLst>
               <a:ext uri="{FF2B5EF4-FFF2-40B4-BE49-F238E27FC236}">
-                <a16:creationId xmlns:a16="http://schemas.microsoft.com/office/drawing/2014/main" id="{143F92D6-5A13-0F0A-8ACE-C359D532BAB8}"/>
+                <a16:creationId xmlns:a16="http://schemas.microsoft.com/office/drawing/2014/main" id="{EFA4A154-53F6-6570-4CFB-FAEFFD6BA946}"/>
               </a:ext>
             </a:extLst>
           </p:cNvPr>
@@ -8420,7 +8420,7 @@
           <p:cNvPr id="106" name="decorate_line_0">
             <a:extLst>
               <a:ext uri="{FF2B5EF4-FFF2-40B4-BE49-F238E27FC236}">
-                <a16:creationId xmlns:a16="http://schemas.microsoft.com/office/drawing/2014/main" id="{69D95B68-5019-26D4-B448-2C5C2C91154E}"/>
+                <a16:creationId xmlns:a16="http://schemas.microsoft.com/office/drawing/2014/main" id="{D11E3191-2ED4-B90C-F2D0-E295F06530D5}"/>
               </a:ext>
             </a:extLst>
           </p:cNvPr>
@@ -8466,7 +8466,7 @@
           <p:cNvPr id="107" name="decorate_line_1">
             <a:extLst>
               <a:ext uri="{FF2B5EF4-FFF2-40B4-BE49-F238E27FC236}">
-                <a16:creationId xmlns:a16="http://schemas.microsoft.com/office/drawing/2014/main" id="{70F97C1D-0BC1-29CB-2847-9680F6B288E1}"/>
+                <a16:creationId xmlns:a16="http://schemas.microsoft.com/office/drawing/2014/main" id="{8BB72713-9476-0A63-0074-3170BE18E52D}"/>
               </a:ext>
             </a:extLst>
           </p:cNvPr>
@@ -8512,7 +8512,7 @@
           <p:cNvPr id="108" name="styled_ir_card">
             <a:extLst>
               <a:ext uri="{FF2B5EF4-FFF2-40B4-BE49-F238E27FC236}">
-                <a16:creationId xmlns:a16="http://schemas.microsoft.com/office/drawing/2014/main" id="{B9BE7568-CF90-7ADD-31AE-A944D2C42457}"/>
+                <a16:creationId xmlns:a16="http://schemas.microsoft.com/office/drawing/2014/main" id="{4EA41151-365B-8D8E-94B3-1F0EF15A132C}"/>
               </a:ext>
             </a:extLst>
           </p:cNvPr>
@@ -8575,7 +8575,7 @@
           <p:cNvPr id="109" name="styled_ir_icon_dot">
             <a:extLst>
               <a:ext uri="{FF2B5EF4-FFF2-40B4-BE49-F238E27FC236}">
-                <a16:creationId xmlns:a16="http://schemas.microsoft.com/office/drawing/2014/main" id="{4F7D190B-7410-AC3A-BDAF-7B19A69BEB77}"/>
+                <a16:creationId xmlns:a16="http://schemas.microsoft.com/office/drawing/2014/main" id="{7EE0593D-68F8-2007-30DE-F9BEF2EBCFEB}"/>
               </a:ext>
             </a:extLst>
           </p:cNvPr>
@@ -8629,7 +8629,7 @@
           <p:cNvPr id="110" name="styled_ir_icon_label">
             <a:extLst>
               <a:ext uri="{FF2B5EF4-FFF2-40B4-BE49-F238E27FC236}">
-                <a16:creationId xmlns:a16="http://schemas.microsoft.com/office/drawing/2014/main" id="{E07CB734-B9E2-614B-7EE5-474708C953C8}"/>
+                <a16:creationId xmlns:a16="http://schemas.microsoft.com/office/drawing/2014/main" id="{87A4EB4E-CDEB-23F0-A941-E619A3BE402E}"/>
               </a:ext>
             </a:extLst>
           </p:cNvPr>
@@ -8676,7 +8676,7 @@
           <p:cNvPr id="111" name="styled_ir_title">
             <a:extLst>
               <a:ext uri="{FF2B5EF4-FFF2-40B4-BE49-F238E27FC236}">
-                <a16:creationId xmlns:a16="http://schemas.microsoft.com/office/drawing/2014/main" id="{BC5942FC-6543-C287-8EB9-98B3410F5050}"/>
+                <a16:creationId xmlns:a16="http://schemas.microsoft.com/office/drawing/2014/main" id="{5F36CD8E-0640-6457-1C2C-E79D78CCF618}"/>
               </a:ext>
             </a:extLst>
           </p:cNvPr>
@@ -8722,7 +8722,7 @@
           <p:cNvPr id="112" name="styled_ir_line_0">
             <a:extLst>
               <a:ext uri="{FF2B5EF4-FFF2-40B4-BE49-F238E27FC236}">
-                <a16:creationId xmlns:a16="http://schemas.microsoft.com/office/drawing/2014/main" id="{AD08EED1-F99F-0565-7495-4C0EB2E49DFB}"/>
+                <a16:creationId xmlns:a16="http://schemas.microsoft.com/office/drawing/2014/main" id="{C459E636-709B-8B04-95CC-242B2CBE57D0}"/>
               </a:ext>
             </a:extLst>
           </p:cNvPr>
@@ -8768,7 +8768,7 @@
           <p:cNvPr id="113" name="styled_ir_line_1">
             <a:extLst>
               <a:ext uri="{FF2B5EF4-FFF2-40B4-BE49-F238E27FC236}">
-                <a16:creationId xmlns:a16="http://schemas.microsoft.com/office/drawing/2014/main" id="{F9BB74B1-FA3F-B8A4-1A78-2FCB4A321900}"/>
+                <a16:creationId xmlns:a16="http://schemas.microsoft.com/office/drawing/2014/main" id="{9B0C0B14-DDDB-C88A-7850-F6B54914460A}"/>
               </a:ext>
             </a:extLst>
           </p:cNvPr>
@@ -8814,7 +8814,7 @@
           <p:cNvPr id="114" name="renderers_card">
             <a:extLst>
               <a:ext uri="{FF2B5EF4-FFF2-40B4-BE49-F238E27FC236}">
-                <a16:creationId xmlns:a16="http://schemas.microsoft.com/office/drawing/2014/main" id="{294C9146-C360-5B6F-0D8B-A44115769DFD}"/>
+                <a16:creationId xmlns:a16="http://schemas.microsoft.com/office/drawing/2014/main" id="{C8719EBB-35A2-ECCC-065E-B6477B6B9F9D}"/>
               </a:ext>
             </a:extLst>
           </p:cNvPr>
@@ -8877,7 +8877,7 @@
           <p:cNvPr id="115" name="renderers_icon_dot">
             <a:extLst>
               <a:ext uri="{FF2B5EF4-FFF2-40B4-BE49-F238E27FC236}">
-                <a16:creationId xmlns:a16="http://schemas.microsoft.com/office/drawing/2014/main" id="{6A65750B-94E3-211A-995B-96CC83EB51C3}"/>
+                <a16:creationId xmlns:a16="http://schemas.microsoft.com/office/drawing/2014/main" id="{7C626CB0-D247-293C-2853-3F4F4C6221AE}"/>
               </a:ext>
             </a:extLst>
           </p:cNvPr>
@@ -8931,7 +8931,7 @@
           <p:cNvPr id="116" name="renderers_icon_label">
             <a:extLst>
               <a:ext uri="{FF2B5EF4-FFF2-40B4-BE49-F238E27FC236}">
-                <a16:creationId xmlns:a16="http://schemas.microsoft.com/office/drawing/2014/main" id="{1A1E07D3-040C-3A47-C37E-BF3DCD3C6783}"/>
+                <a16:creationId xmlns:a16="http://schemas.microsoft.com/office/drawing/2014/main" id="{94467FDB-D801-C1A1-D034-8E02D3B6E082}"/>
               </a:ext>
             </a:extLst>
           </p:cNvPr>
@@ -8978,7 +8978,7 @@
           <p:cNvPr id="117" name="renderers_title">
             <a:extLst>
               <a:ext uri="{FF2B5EF4-FFF2-40B4-BE49-F238E27FC236}">
-                <a16:creationId xmlns:a16="http://schemas.microsoft.com/office/drawing/2014/main" id="{56DAA560-0D03-7480-8C8E-63B26131A137}"/>
+                <a16:creationId xmlns:a16="http://schemas.microsoft.com/office/drawing/2014/main" id="{859ACF0A-E906-849C-01F0-CADA0F0CB109}"/>
               </a:ext>
             </a:extLst>
           </p:cNvPr>
@@ -9024,7 +9024,7 @@
           <p:cNvPr id="118" name="renderers_line_0">
             <a:extLst>
               <a:ext uri="{FF2B5EF4-FFF2-40B4-BE49-F238E27FC236}">
-                <a16:creationId xmlns:a16="http://schemas.microsoft.com/office/drawing/2014/main" id="{64558167-61E3-754C-E07D-503A6BED3214}"/>
+                <a16:creationId xmlns:a16="http://schemas.microsoft.com/office/drawing/2014/main" id="{4DD0A973-FEF0-B8C7-2326-073459C178F8}"/>
               </a:ext>
             </a:extLst>
           </p:cNvPr>
@@ -9070,7 +9070,7 @@
           <p:cNvPr id="119" name="renderers_line_1">
             <a:extLst>
               <a:ext uri="{FF2B5EF4-FFF2-40B4-BE49-F238E27FC236}">
-                <a16:creationId xmlns:a16="http://schemas.microsoft.com/office/drawing/2014/main" id="{E8A59122-E35F-2BFB-66D7-93310D7D2F77}"/>
+                <a16:creationId xmlns:a16="http://schemas.microsoft.com/office/drawing/2014/main" id="{C013D516-B217-CB61-6C47-0EFAF1065AC6}"/>
               </a:ext>
             </a:extLst>
           </p:cNvPr>
@@ -9116,7 +9116,7 @@
           <p:cNvPr id="120" name="visual_check">
             <a:extLst>
               <a:ext uri="{FF2B5EF4-FFF2-40B4-BE49-F238E27FC236}">
-                <a16:creationId xmlns:a16="http://schemas.microsoft.com/office/drawing/2014/main" id="{306E91B8-59BC-C6A9-8B7D-CB3BD96F69B9}"/>
+                <a16:creationId xmlns:a16="http://schemas.microsoft.com/office/drawing/2014/main" id="{E726EBB9-E7C5-D753-9EDA-1B3AB71E2561}"/>
               </a:ext>
             </a:extLst>
           </p:cNvPr>
@@ -9179,7 +9179,7 @@
           <p:cNvPr id="121" name="visual_check_stripe">
             <a:extLst>
               <a:ext uri="{FF2B5EF4-FFF2-40B4-BE49-F238E27FC236}">
-                <a16:creationId xmlns:a16="http://schemas.microsoft.com/office/drawing/2014/main" id="{3459D173-64FE-E155-76F7-E160B57C2C9B}"/>
+                <a16:creationId xmlns:a16="http://schemas.microsoft.com/office/drawing/2014/main" id="{9006428B-9C09-F3CB-000D-1268C0F9B8D3}"/>
               </a:ext>
             </a:extLst>
           </p:cNvPr>
@@ -9233,7 +9233,7 @@
           <p:cNvPr id="122" name="visual_check_seal_icon_dot">
             <a:extLst>
               <a:ext uri="{FF2B5EF4-FFF2-40B4-BE49-F238E27FC236}">
-                <a16:creationId xmlns:a16="http://schemas.microsoft.com/office/drawing/2014/main" id="{42E5384E-514D-BDD2-EE73-A6ECBEAF1907}"/>
+                <a16:creationId xmlns:a16="http://schemas.microsoft.com/office/drawing/2014/main" id="{8B543D16-A469-E9B5-2311-9EF21C3DC43C}"/>
               </a:ext>
             </a:extLst>
           </p:cNvPr>
@@ -9287,7 +9287,7 @@
           <p:cNvPr id="123" name="visual_check_seal_icon_label">
             <a:extLst>
               <a:ext uri="{FF2B5EF4-FFF2-40B4-BE49-F238E27FC236}">
-                <a16:creationId xmlns:a16="http://schemas.microsoft.com/office/drawing/2014/main" id="{8991D3DF-C7CB-3DA1-633C-2773F898A950}"/>
+                <a16:creationId xmlns:a16="http://schemas.microsoft.com/office/drawing/2014/main" id="{AA96AA34-459C-E2BB-D712-F73692A0C6AF}"/>
               </a:ext>
             </a:extLst>
           </p:cNvPr>
@@ -9334,7 +9334,7 @@
           <p:cNvPr id="124" name="visual_check_label">
             <a:extLst>
               <a:ext uri="{FF2B5EF4-FFF2-40B4-BE49-F238E27FC236}">
-                <a16:creationId xmlns:a16="http://schemas.microsoft.com/office/drawing/2014/main" id="{33E38136-0D7C-8CF2-A849-4D5A8BD8300E}"/>
+                <a16:creationId xmlns:a16="http://schemas.microsoft.com/office/drawing/2014/main" id="{46E36732-D155-AF9D-17D2-175A0B0A5755}"/>
               </a:ext>
             </a:extLst>
           </p:cNvPr>
@@ -9380,7 +9380,7 @@
           <p:cNvPr id="125" name="visual_check_text">
             <a:extLst>
               <a:ext uri="{FF2B5EF4-FFF2-40B4-BE49-F238E27FC236}">
-                <a16:creationId xmlns:a16="http://schemas.microsoft.com/office/drawing/2014/main" id="{82BBCBA4-4C27-36BB-3898-CAAE9BECC515}"/>
+                <a16:creationId xmlns:a16="http://schemas.microsoft.com/office/drawing/2014/main" id="{E04C502F-DA9A-CE99-5490-F5D36BC66B51}"/>
               </a:ext>
             </a:extLst>
           </p:cNvPr>
@@ -9426,7 +9426,7 @@
           <p:cNvPr id="126" name="coherence_band">
             <a:extLst>
               <a:ext uri="{FF2B5EF4-FFF2-40B4-BE49-F238E27FC236}">
-                <a16:creationId xmlns:a16="http://schemas.microsoft.com/office/drawing/2014/main" id="{47357692-B2F3-75F2-52B1-20D5BA34A17D}"/>
+                <a16:creationId xmlns:a16="http://schemas.microsoft.com/office/drawing/2014/main" id="{A723C1F5-7A3E-7D88-1196-937361EFB304}"/>
               </a:ext>
             </a:extLst>
           </p:cNvPr>
@@ -9435,12 +9435,12 @@
         </p:nvSpPr>
         <p:spPr>
           <a:xfrm>
-            <a:off x="783752" y="5451809"/>
-            <a:ext cx="10624192" cy="628049"/>
+            <a:off x="783752" y="5320966"/>
+            <a:ext cx="10624192" cy="575711"/>
           </a:xfrm>
           <a:prstGeom prst="roundRect">
             <a:avLst>
-              <a:gd name="adj" fmla="val 22185"/>
+              <a:gd name="adj" fmla="val 24202"/>
             </a:avLst>
           </a:prstGeom>
           <a:solidFill>
@@ -9489,7 +9489,7 @@
           <p:cNvPr id="127" name="coherence_title">
             <a:extLst>
               <a:ext uri="{FF2B5EF4-FFF2-40B4-BE49-F238E27FC236}">
-                <a16:creationId xmlns:a16="http://schemas.microsoft.com/office/drawing/2014/main" id="{B2CE74F5-488F-3B5E-754E-A9D20A91FD08}"/>
+                <a16:creationId xmlns:a16="http://schemas.microsoft.com/office/drawing/2014/main" id="{53C1ED67-CFDA-13D7-007F-029566947298}"/>
               </a:ext>
             </a:extLst>
           </p:cNvPr>
@@ -9498,7 +9498,7 @@
         </p:nvSpPr>
         <p:spPr>
           <a:xfrm>
-            <a:off x="1062419" y="5617544"/>
+            <a:off x="1062419" y="5443086"/>
             <a:ext cx="1611045" cy="294615"/>
           </a:xfrm>
           <a:prstGeom prst="rect">
@@ -9535,7 +9535,7 @@
           <p:cNvPr id="128" name="coherence_body">
             <a:extLst>
               <a:ext uri="{FF2B5EF4-FFF2-40B4-BE49-F238E27FC236}">
-                <a16:creationId xmlns:a16="http://schemas.microsoft.com/office/drawing/2014/main" id="{76F4B85E-F56A-9522-7AF5-16B257689B41}"/>
+                <a16:creationId xmlns:a16="http://schemas.microsoft.com/office/drawing/2014/main" id="{A4F95636-6EA5-6554-D5DD-57700ADC6B70}"/>
               </a:ext>
             </a:extLst>
           </p:cNvPr>
@@ -9544,7 +9544,7 @@
         </p:nvSpPr>
         <p:spPr>
           <a:xfrm>
-            <a:off x="2830215" y="5591375"/>
+            <a:off x="2830215" y="5425641"/>
             <a:ext cx="8272936" cy="294615"/>
           </a:xfrm>
           <a:prstGeom prst="rect">
@@ -9579,7 +9579,7 @@
     </p:spTree>
     <p:extLst>
       <p:ext uri="{BB962C8B-B14F-4D97-AF65-F5344CB8AC3E}">
-        <p14:creationId xmlns:p14="http://schemas.microsoft.com/office/powerpoint/2010/main" val="2434112564"/>
+        <p14:creationId xmlns:p14="http://schemas.microsoft.com/office/powerpoint/2010/main" val="3841368338"/>
       </p:ext>
     </p:extLst>
   </p:cSld>

</xml_diff>

<commit_message>
Refresh README pipeline teaser artifact
</commit_message>
<xml_diff>
--- a/docs/assets/readme-slides/mdpr-pipeline-teaser.pptx
+++ b/docs/assets/readme-slides/mdpr-pipeline-teaser.pptx
@@ -129,7 +129,7 @@
           <p:cNvPr id="2" name="제목 1">
             <a:extLst>
               <a:ext uri="{FF2B5EF4-FFF2-40B4-BE49-F238E27FC236}">
-                <a16:creationId xmlns:a16="http://schemas.microsoft.com/office/drawing/2014/main" id="{D3BFB3D8-0615-37D3-AE1B-EA799728FDE4}"/>
+                <a16:creationId xmlns:a16="http://schemas.microsoft.com/office/drawing/2014/main" id="{1DA43B27-263A-2143-600A-77D0FF18B2D7}"/>
               </a:ext>
             </a:extLst>
           </p:cNvPr>
@@ -166,7 +166,7 @@
           <p:cNvPr id="3" name="부제목 2">
             <a:extLst>
               <a:ext uri="{FF2B5EF4-FFF2-40B4-BE49-F238E27FC236}">
-                <a16:creationId xmlns:a16="http://schemas.microsoft.com/office/drawing/2014/main" id="{A9158CE0-9D32-D8B3-4AF9-3BA8DF22C842}"/>
+                <a16:creationId xmlns:a16="http://schemas.microsoft.com/office/drawing/2014/main" id="{00E77DC9-9DCF-B055-773C-29F2DDDDDA9F}"/>
               </a:ext>
             </a:extLst>
           </p:cNvPr>
@@ -236,7 +236,7 @@
           <p:cNvPr id="4" name="날짜 개체 틀 3">
             <a:extLst>
               <a:ext uri="{FF2B5EF4-FFF2-40B4-BE49-F238E27FC236}">
-                <a16:creationId xmlns:a16="http://schemas.microsoft.com/office/drawing/2014/main" id="{6B795BC0-DCA9-DD22-5E01-C4F9C9F9E38E}"/>
+                <a16:creationId xmlns:a16="http://schemas.microsoft.com/office/drawing/2014/main" id="{6BC7AC23-E70F-08A0-0483-6779C51438B8}"/>
               </a:ext>
             </a:extLst>
           </p:cNvPr>
@@ -252,7 +252,7 @@
           <a:bodyPr/>
           <a:lstStyle/>
           <a:p>
-            <a:fld id="{6A47B181-FA31-4A1A-9F99-EE3054882D27}" type="datetimeFigureOut">
+            <a:fld id="{F6C3687A-8429-4787-A5E4-66C74EFAC92C}" type="datetimeFigureOut">
               <a:rPr lang="ko-KR" altLang="en-US" smtClean="0"/>
               <a:t>2026-06-21</a:t>
             </a:fld>
@@ -265,7 +265,7 @@
           <p:cNvPr id="5" name="바닥글 개체 틀 4">
             <a:extLst>
               <a:ext uri="{FF2B5EF4-FFF2-40B4-BE49-F238E27FC236}">
-                <a16:creationId xmlns:a16="http://schemas.microsoft.com/office/drawing/2014/main" id="{296A2904-B63D-72E5-4EBE-E84A4663DDB3}"/>
+                <a16:creationId xmlns:a16="http://schemas.microsoft.com/office/drawing/2014/main" id="{E1720337-411F-0261-71B1-B53F4BFFC007}"/>
               </a:ext>
             </a:extLst>
           </p:cNvPr>
@@ -290,7 +290,7 @@
           <p:cNvPr id="6" name="슬라이드 번호 개체 틀 5">
             <a:extLst>
               <a:ext uri="{FF2B5EF4-FFF2-40B4-BE49-F238E27FC236}">
-                <a16:creationId xmlns:a16="http://schemas.microsoft.com/office/drawing/2014/main" id="{A0858DF3-7904-7AA4-150D-118D2941F18F}"/>
+                <a16:creationId xmlns:a16="http://schemas.microsoft.com/office/drawing/2014/main" id="{C69CC5CE-0CD7-BB58-5EB4-43B3CEF83F09}"/>
               </a:ext>
             </a:extLst>
           </p:cNvPr>
@@ -306,7 +306,7 @@
           <a:bodyPr/>
           <a:lstStyle/>
           <a:p>
-            <a:fld id="{68052361-CBA1-4FAA-B7D8-32A91B69C580}" type="slidenum">
+            <a:fld id="{73F896A6-F826-4F1B-8A07-4FF06BD3D008}" type="slidenum">
               <a:rPr lang="ko-KR" altLang="en-US" smtClean="0"/>
               <a:t>‹#›</a:t>
             </a:fld>
@@ -317,7 +317,7 @@
     </p:spTree>
     <p:extLst>
       <p:ext uri="{BB962C8B-B14F-4D97-AF65-F5344CB8AC3E}">
-        <p14:creationId xmlns:p14="http://schemas.microsoft.com/office/powerpoint/2010/main" val="2726838007"/>
+        <p14:creationId xmlns:p14="http://schemas.microsoft.com/office/powerpoint/2010/main" val="2566342043"/>
       </p:ext>
     </p:extLst>
   </p:cSld>
@@ -349,7 +349,7 @@
           <p:cNvPr id="2" name="제목 1">
             <a:extLst>
               <a:ext uri="{FF2B5EF4-FFF2-40B4-BE49-F238E27FC236}">
-                <a16:creationId xmlns:a16="http://schemas.microsoft.com/office/drawing/2014/main" id="{29C72B02-B3F7-5A01-1F90-A07E502E16CF}"/>
+                <a16:creationId xmlns:a16="http://schemas.microsoft.com/office/drawing/2014/main" id="{EC781ACD-FC91-6DA9-3310-32998F169E0F}"/>
               </a:ext>
             </a:extLst>
           </p:cNvPr>
@@ -377,7 +377,7 @@
           <p:cNvPr id="3" name="세로 텍스트 개체 틀 2">
             <a:extLst>
               <a:ext uri="{FF2B5EF4-FFF2-40B4-BE49-F238E27FC236}">
-                <a16:creationId xmlns:a16="http://schemas.microsoft.com/office/drawing/2014/main" id="{7AD29D3B-56E0-6322-E7A6-B9F4229090A0}"/>
+                <a16:creationId xmlns:a16="http://schemas.microsoft.com/office/drawing/2014/main" id="{C3026B95-2B7B-7EFE-6676-46581135BC85}"/>
               </a:ext>
             </a:extLst>
           </p:cNvPr>
@@ -434,7 +434,7 @@
           <p:cNvPr id="4" name="날짜 개체 틀 3">
             <a:extLst>
               <a:ext uri="{FF2B5EF4-FFF2-40B4-BE49-F238E27FC236}">
-                <a16:creationId xmlns:a16="http://schemas.microsoft.com/office/drawing/2014/main" id="{84B95E04-4781-B68A-D7CD-9764FF1A880C}"/>
+                <a16:creationId xmlns:a16="http://schemas.microsoft.com/office/drawing/2014/main" id="{71AE53E2-C232-D2C5-F021-0A492810E904}"/>
               </a:ext>
             </a:extLst>
           </p:cNvPr>
@@ -450,7 +450,7 @@
           <a:bodyPr/>
           <a:lstStyle/>
           <a:p>
-            <a:fld id="{6A47B181-FA31-4A1A-9F99-EE3054882D27}" type="datetimeFigureOut">
+            <a:fld id="{F6C3687A-8429-4787-A5E4-66C74EFAC92C}" type="datetimeFigureOut">
               <a:rPr lang="ko-KR" altLang="en-US" smtClean="0"/>
               <a:t>2026-06-21</a:t>
             </a:fld>
@@ -463,7 +463,7 @@
           <p:cNvPr id="5" name="바닥글 개체 틀 4">
             <a:extLst>
               <a:ext uri="{FF2B5EF4-FFF2-40B4-BE49-F238E27FC236}">
-                <a16:creationId xmlns:a16="http://schemas.microsoft.com/office/drawing/2014/main" id="{10173CD4-73A9-97CC-5BAB-C087A2C01A2A}"/>
+                <a16:creationId xmlns:a16="http://schemas.microsoft.com/office/drawing/2014/main" id="{A1786801-FCE4-7DE3-0533-4FDC9223B5FD}"/>
               </a:ext>
             </a:extLst>
           </p:cNvPr>
@@ -488,7 +488,7 @@
           <p:cNvPr id="6" name="슬라이드 번호 개체 틀 5">
             <a:extLst>
               <a:ext uri="{FF2B5EF4-FFF2-40B4-BE49-F238E27FC236}">
-                <a16:creationId xmlns:a16="http://schemas.microsoft.com/office/drawing/2014/main" id="{71DFCBBD-E338-4DAA-1521-B69D9117BEA8}"/>
+                <a16:creationId xmlns:a16="http://schemas.microsoft.com/office/drawing/2014/main" id="{961050EA-B532-CF80-78F7-22BEA8D80252}"/>
               </a:ext>
             </a:extLst>
           </p:cNvPr>
@@ -504,7 +504,7 @@
           <a:bodyPr/>
           <a:lstStyle/>
           <a:p>
-            <a:fld id="{68052361-CBA1-4FAA-B7D8-32A91B69C580}" type="slidenum">
+            <a:fld id="{73F896A6-F826-4F1B-8A07-4FF06BD3D008}" type="slidenum">
               <a:rPr lang="ko-KR" altLang="en-US" smtClean="0"/>
               <a:t>‹#›</a:t>
             </a:fld>
@@ -515,7 +515,7 @@
     </p:spTree>
     <p:extLst>
       <p:ext uri="{BB962C8B-B14F-4D97-AF65-F5344CB8AC3E}">
-        <p14:creationId xmlns:p14="http://schemas.microsoft.com/office/powerpoint/2010/main" val="1331600476"/>
+        <p14:creationId xmlns:p14="http://schemas.microsoft.com/office/powerpoint/2010/main" val="104019695"/>
       </p:ext>
     </p:extLst>
   </p:cSld>
@@ -547,7 +547,7 @@
           <p:cNvPr id="2" name="세로 제목 1">
             <a:extLst>
               <a:ext uri="{FF2B5EF4-FFF2-40B4-BE49-F238E27FC236}">
-                <a16:creationId xmlns:a16="http://schemas.microsoft.com/office/drawing/2014/main" id="{5CEB0DC8-29BE-3CBD-C7D2-9E4DE96A2C1F}"/>
+                <a16:creationId xmlns:a16="http://schemas.microsoft.com/office/drawing/2014/main" id="{7DFEB41F-A349-971A-4770-CB44ACE0E82A}"/>
               </a:ext>
             </a:extLst>
           </p:cNvPr>
@@ -580,7 +580,7 @@
           <p:cNvPr id="3" name="세로 텍스트 개체 틀 2">
             <a:extLst>
               <a:ext uri="{FF2B5EF4-FFF2-40B4-BE49-F238E27FC236}">
-                <a16:creationId xmlns:a16="http://schemas.microsoft.com/office/drawing/2014/main" id="{7618D6D8-56EA-E690-BCA4-CFB52CD5A383}"/>
+                <a16:creationId xmlns:a16="http://schemas.microsoft.com/office/drawing/2014/main" id="{F244307B-77FA-2648-E67C-CB0B41115DE3}"/>
               </a:ext>
             </a:extLst>
           </p:cNvPr>
@@ -642,7 +642,7 @@
           <p:cNvPr id="4" name="날짜 개체 틀 3">
             <a:extLst>
               <a:ext uri="{FF2B5EF4-FFF2-40B4-BE49-F238E27FC236}">
-                <a16:creationId xmlns:a16="http://schemas.microsoft.com/office/drawing/2014/main" id="{26B9F2CB-0517-1750-C763-1B31B0C1E953}"/>
+                <a16:creationId xmlns:a16="http://schemas.microsoft.com/office/drawing/2014/main" id="{99294348-5C87-7A77-715F-E3F06396E2CB}"/>
               </a:ext>
             </a:extLst>
           </p:cNvPr>
@@ -658,7 +658,7 @@
           <a:bodyPr/>
           <a:lstStyle/>
           <a:p>
-            <a:fld id="{6A47B181-FA31-4A1A-9F99-EE3054882D27}" type="datetimeFigureOut">
+            <a:fld id="{F6C3687A-8429-4787-A5E4-66C74EFAC92C}" type="datetimeFigureOut">
               <a:rPr lang="ko-KR" altLang="en-US" smtClean="0"/>
               <a:t>2026-06-21</a:t>
             </a:fld>
@@ -671,7 +671,7 @@
           <p:cNvPr id="5" name="바닥글 개체 틀 4">
             <a:extLst>
               <a:ext uri="{FF2B5EF4-FFF2-40B4-BE49-F238E27FC236}">
-                <a16:creationId xmlns:a16="http://schemas.microsoft.com/office/drawing/2014/main" id="{58716D94-0F63-D70B-1B1F-2E04C79A0A98}"/>
+                <a16:creationId xmlns:a16="http://schemas.microsoft.com/office/drawing/2014/main" id="{55A29EA7-02D1-87F6-C525-D1A02566ED3A}"/>
               </a:ext>
             </a:extLst>
           </p:cNvPr>
@@ -696,7 +696,7 @@
           <p:cNvPr id="6" name="슬라이드 번호 개체 틀 5">
             <a:extLst>
               <a:ext uri="{FF2B5EF4-FFF2-40B4-BE49-F238E27FC236}">
-                <a16:creationId xmlns:a16="http://schemas.microsoft.com/office/drawing/2014/main" id="{346E3BB3-2A2B-E0D2-DC9A-FB98A2C51B8D}"/>
+                <a16:creationId xmlns:a16="http://schemas.microsoft.com/office/drawing/2014/main" id="{E06CA60A-76CD-CC7E-69BD-C91F5C60E148}"/>
               </a:ext>
             </a:extLst>
           </p:cNvPr>
@@ -712,7 +712,7 @@
           <a:bodyPr/>
           <a:lstStyle/>
           <a:p>
-            <a:fld id="{68052361-CBA1-4FAA-B7D8-32A91B69C580}" type="slidenum">
+            <a:fld id="{73F896A6-F826-4F1B-8A07-4FF06BD3D008}" type="slidenum">
               <a:rPr lang="ko-KR" altLang="en-US" smtClean="0"/>
               <a:t>‹#›</a:t>
             </a:fld>
@@ -723,7 +723,7 @@
     </p:spTree>
     <p:extLst>
       <p:ext uri="{BB962C8B-B14F-4D97-AF65-F5344CB8AC3E}">
-        <p14:creationId xmlns:p14="http://schemas.microsoft.com/office/powerpoint/2010/main" val="1421833368"/>
+        <p14:creationId xmlns:p14="http://schemas.microsoft.com/office/powerpoint/2010/main" val="2945123346"/>
       </p:ext>
     </p:extLst>
   </p:cSld>
@@ -755,7 +755,7 @@
           <p:cNvPr id="2" name="제목 1">
             <a:extLst>
               <a:ext uri="{FF2B5EF4-FFF2-40B4-BE49-F238E27FC236}">
-                <a16:creationId xmlns:a16="http://schemas.microsoft.com/office/drawing/2014/main" id="{53D3D142-1E70-261C-F032-75188AB6A906}"/>
+                <a16:creationId xmlns:a16="http://schemas.microsoft.com/office/drawing/2014/main" id="{92B80E21-CDB8-7B0F-F78D-43FC4EA3BCDB}"/>
               </a:ext>
             </a:extLst>
           </p:cNvPr>
@@ -783,7 +783,7 @@
           <p:cNvPr id="3" name="내용 개체 틀 2">
             <a:extLst>
               <a:ext uri="{FF2B5EF4-FFF2-40B4-BE49-F238E27FC236}">
-                <a16:creationId xmlns:a16="http://schemas.microsoft.com/office/drawing/2014/main" id="{9B54DA40-082D-DEC7-C697-0B9B88B1B673}"/>
+                <a16:creationId xmlns:a16="http://schemas.microsoft.com/office/drawing/2014/main" id="{6F3D6DF9-D788-9FE2-8933-8B93AA815B4C}"/>
               </a:ext>
             </a:extLst>
           </p:cNvPr>
@@ -840,7 +840,7 @@
           <p:cNvPr id="4" name="날짜 개체 틀 3">
             <a:extLst>
               <a:ext uri="{FF2B5EF4-FFF2-40B4-BE49-F238E27FC236}">
-                <a16:creationId xmlns:a16="http://schemas.microsoft.com/office/drawing/2014/main" id="{15BB7109-9121-5535-91D8-848B36EB52A9}"/>
+                <a16:creationId xmlns:a16="http://schemas.microsoft.com/office/drawing/2014/main" id="{71C0564F-48F1-0C37-ACE9-F9EBF920BF62}"/>
               </a:ext>
             </a:extLst>
           </p:cNvPr>
@@ -856,7 +856,7 @@
           <a:bodyPr/>
           <a:lstStyle/>
           <a:p>
-            <a:fld id="{6A47B181-FA31-4A1A-9F99-EE3054882D27}" type="datetimeFigureOut">
+            <a:fld id="{F6C3687A-8429-4787-A5E4-66C74EFAC92C}" type="datetimeFigureOut">
               <a:rPr lang="ko-KR" altLang="en-US" smtClean="0"/>
               <a:t>2026-06-21</a:t>
             </a:fld>
@@ -869,7 +869,7 @@
           <p:cNvPr id="5" name="바닥글 개체 틀 4">
             <a:extLst>
               <a:ext uri="{FF2B5EF4-FFF2-40B4-BE49-F238E27FC236}">
-                <a16:creationId xmlns:a16="http://schemas.microsoft.com/office/drawing/2014/main" id="{75128A30-AAFB-4A5C-105F-BD4A7B596245}"/>
+                <a16:creationId xmlns:a16="http://schemas.microsoft.com/office/drawing/2014/main" id="{3C7445FB-A045-15CE-AFF3-9FA4A59313F9}"/>
               </a:ext>
             </a:extLst>
           </p:cNvPr>
@@ -894,7 +894,7 @@
           <p:cNvPr id="6" name="슬라이드 번호 개체 틀 5">
             <a:extLst>
               <a:ext uri="{FF2B5EF4-FFF2-40B4-BE49-F238E27FC236}">
-                <a16:creationId xmlns:a16="http://schemas.microsoft.com/office/drawing/2014/main" id="{B650CC19-67B7-4B8D-3AAC-EAD722563E44}"/>
+                <a16:creationId xmlns:a16="http://schemas.microsoft.com/office/drawing/2014/main" id="{EE1BB6CF-E854-1A5E-6EBC-C1B80BD32145}"/>
               </a:ext>
             </a:extLst>
           </p:cNvPr>
@@ -910,7 +910,7 @@
           <a:bodyPr/>
           <a:lstStyle/>
           <a:p>
-            <a:fld id="{68052361-CBA1-4FAA-B7D8-32A91B69C580}" type="slidenum">
+            <a:fld id="{73F896A6-F826-4F1B-8A07-4FF06BD3D008}" type="slidenum">
               <a:rPr lang="ko-KR" altLang="en-US" smtClean="0"/>
               <a:t>‹#›</a:t>
             </a:fld>
@@ -921,7 +921,7 @@
     </p:spTree>
     <p:extLst>
       <p:ext uri="{BB962C8B-B14F-4D97-AF65-F5344CB8AC3E}">
-        <p14:creationId xmlns:p14="http://schemas.microsoft.com/office/powerpoint/2010/main" val="2701600448"/>
+        <p14:creationId xmlns:p14="http://schemas.microsoft.com/office/powerpoint/2010/main" val="1382748012"/>
       </p:ext>
     </p:extLst>
   </p:cSld>
@@ -953,7 +953,7 @@
           <p:cNvPr id="2" name="제목 1">
             <a:extLst>
               <a:ext uri="{FF2B5EF4-FFF2-40B4-BE49-F238E27FC236}">
-                <a16:creationId xmlns:a16="http://schemas.microsoft.com/office/drawing/2014/main" id="{31CC123C-E6E9-F782-A089-DACE3A41B5D4}"/>
+                <a16:creationId xmlns:a16="http://schemas.microsoft.com/office/drawing/2014/main" id="{15EA642A-C966-0110-4B27-F339181F2153}"/>
               </a:ext>
             </a:extLst>
           </p:cNvPr>
@@ -990,7 +990,7 @@
           <p:cNvPr id="3" name="텍스트 개체 틀 2">
             <a:extLst>
               <a:ext uri="{FF2B5EF4-FFF2-40B4-BE49-F238E27FC236}">
-                <a16:creationId xmlns:a16="http://schemas.microsoft.com/office/drawing/2014/main" id="{A1935F95-1A08-72B4-24CE-13A24728BF66}"/>
+                <a16:creationId xmlns:a16="http://schemas.microsoft.com/office/drawing/2014/main" id="{3EDA53AC-62D2-7752-4918-FAFABF442251}"/>
               </a:ext>
             </a:extLst>
           </p:cNvPr>
@@ -1115,7 +1115,7 @@
           <p:cNvPr id="4" name="날짜 개체 틀 3">
             <a:extLst>
               <a:ext uri="{FF2B5EF4-FFF2-40B4-BE49-F238E27FC236}">
-                <a16:creationId xmlns:a16="http://schemas.microsoft.com/office/drawing/2014/main" id="{0C8C0573-0538-57AC-16D9-EEA0821636FD}"/>
+                <a16:creationId xmlns:a16="http://schemas.microsoft.com/office/drawing/2014/main" id="{551787E8-17D4-243A-258E-86D81DD386F6}"/>
               </a:ext>
             </a:extLst>
           </p:cNvPr>
@@ -1131,7 +1131,7 @@
           <a:bodyPr/>
           <a:lstStyle/>
           <a:p>
-            <a:fld id="{6A47B181-FA31-4A1A-9F99-EE3054882D27}" type="datetimeFigureOut">
+            <a:fld id="{F6C3687A-8429-4787-A5E4-66C74EFAC92C}" type="datetimeFigureOut">
               <a:rPr lang="ko-KR" altLang="en-US" smtClean="0"/>
               <a:t>2026-06-21</a:t>
             </a:fld>
@@ -1144,7 +1144,7 @@
           <p:cNvPr id="5" name="바닥글 개체 틀 4">
             <a:extLst>
               <a:ext uri="{FF2B5EF4-FFF2-40B4-BE49-F238E27FC236}">
-                <a16:creationId xmlns:a16="http://schemas.microsoft.com/office/drawing/2014/main" id="{4F1E94F6-4070-CA24-FD68-4ABC51E19332}"/>
+                <a16:creationId xmlns:a16="http://schemas.microsoft.com/office/drawing/2014/main" id="{F8192428-9247-92D7-E32F-F1DED8134F28}"/>
               </a:ext>
             </a:extLst>
           </p:cNvPr>
@@ -1169,7 +1169,7 @@
           <p:cNvPr id="6" name="슬라이드 번호 개체 틀 5">
             <a:extLst>
               <a:ext uri="{FF2B5EF4-FFF2-40B4-BE49-F238E27FC236}">
-                <a16:creationId xmlns:a16="http://schemas.microsoft.com/office/drawing/2014/main" id="{F02ACEF8-CE9E-3CE8-F4D9-B99C992BCA09}"/>
+                <a16:creationId xmlns:a16="http://schemas.microsoft.com/office/drawing/2014/main" id="{6D4BCA1B-E4DD-B0AA-BC79-1A5B499923B2}"/>
               </a:ext>
             </a:extLst>
           </p:cNvPr>
@@ -1185,7 +1185,7 @@
           <a:bodyPr/>
           <a:lstStyle/>
           <a:p>
-            <a:fld id="{68052361-CBA1-4FAA-B7D8-32A91B69C580}" type="slidenum">
+            <a:fld id="{73F896A6-F826-4F1B-8A07-4FF06BD3D008}" type="slidenum">
               <a:rPr lang="ko-KR" altLang="en-US" smtClean="0"/>
               <a:t>‹#›</a:t>
             </a:fld>
@@ -1196,7 +1196,7 @@
     </p:spTree>
     <p:extLst>
       <p:ext uri="{BB962C8B-B14F-4D97-AF65-F5344CB8AC3E}">
-        <p14:creationId xmlns:p14="http://schemas.microsoft.com/office/powerpoint/2010/main" val="690057236"/>
+        <p14:creationId xmlns:p14="http://schemas.microsoft.com/office/powerpoint/2010/main" val="2245113721"/>
       </p:ext>
     </p:extLst>
   </p:cSld>
@@ -1228,7 +1228,7 @@
           <p:cNvPr id="2" name="제목 1">
             <a:extLst>
               <a:ext uri="{FF2B5EF4-FFF2-40B4-BE49-F238E27FC236}">
-                <a16:creationId xmlns:a16="http://schemas.microsoft.com/office/drawing/2014/main" id="{77646EDD-27F6-CD2F-D314-B844FEB6401C}"/>
+                <a16:creationId xmlns:a16="http://schemas.microsoft.com/office/drawing/2014/main" id="{4E255665-EBCC-82AF-C7DF-48F5310EFCDD}"/>
               </a:ext>
             </a:extLst>
           </p:cNvPr>
@@ -1256,7 +1256,7 @@
           <p:cNvPr id="3" name="내용 개체 틀 2">
             <a:extLst>
               <a:ext uri="{FF2B5EF4-FFF2-40B4-BE49-F238E27FC236}">
-                <a16:creationId xmlns:a16="http://schemas.microsoft.com/office/drawing/2014/main" id="{B80FCCE9-DB29-EF81-9F63-3D6B5D54F555}"/>
+                <a16:creationId xmlns:a16="http://schemas.microsoft.com/office/drawing/2014/main" id="{27A43C92-BA07-1BF2-9940-88902AE2C990}"/>
               </a:ext>
             </a:extLst>
           </p:cNvPr>
@@ -1318,7 +1318,7 @@
           <p:cNvPr id="4" name="내용 개체 틀 3">
             <a:extLst>
               <a:ext uri="{FF2B5EF4-FFF2-40B4-BE49-F238E27FC236}">
-                <a16:creationId xmlns:a16="http://schemas.microsoft.com/office/drawing/2014/main" id="{D9F99D45-70D3-A199-B3D2-38D7A61D7FD1}"/>
+                <a16:creationId xmlns:a16="http://schemas.microsoft.com/office/drawing/2014/main" id="{147465C5-8252-C382-1BF7-90C1C7A2D6A4}"/>
               </a:ext>
             </a:extLst>
           </p:cNvPr>
@@ -1380,7 +1380,7 @@
           <p:cNvPr id="5" name="날짜 개체 틀 4">
             <a:extLst>
               <a:ext uri="{FF2B5EF4-FFF2-40B4-BE49-F238E27FC236}">
-                <a16:creationId xmlns:a16="http://schemas.microsoft.com/office/drawing/2014/main" id="{62B79DC6-33A3-EE15-FDD0-BEF87FFDD50A}"/>
+                <a16:creationId xmlns:a16="http://schemas.microsoft.com/office/drawing/2014/main" id="{D3FCF686-F78B-C9D2-D65C-D0DDD3045396}"/>
               </a:ext>
             </a:extLst>
           </p:cNvPr>
@@ -1396,7 +1396,7 @@
           <a:bodyPr/>
           <a:lstStyle/>
           <a:p>
-            <a:fld id="{6A47B181-FA31-4A1A-9F99-EE3054882D27}" type="datetimeFigureOut">
+            <a:fld id="{F6C3687A-8429-4787-A5E4-66C74EFAC92C}" type="datetimeFigureOut">
               <a:rPr lang="ko-KR" altLang="en-US" smtClean="0"/>
               <a:t>2026-06-21</a:t>
             </a:fld>
@@ -1409,7 +1409,7 @@
           <p:cNvPr id="6" name="바닥글 개체 틀 5">
             <a:extLst>
               <a:ext uri="{FF2B5EF4-FFF2-40B4-BE49-F238E27FC236}">
-                <a16:creationId xmlns:a16="http://schemas.microsoft.com/office/drawing/2014/main" id="{D0274CBE-E20F-96BA-B7F3-AC55A7E9CD4C}"/>
+                <a16:creationId xmlns:a16="http://schemas.microsoft.com/office/drawing/2014/main" id="{6A413718-421D-BA49-DE1F-16C493CADE9F}"/>
               </a:ext>
             </a:extLst>
           </p:cNvPr>
@@ -1434,7 +1434,7 @@
           <p:cNvPr id="7" name="슬라이드 번호 개체 틀 6">
             <a:extLst>
               <a:ext uri="{FF2B5EF4-FFF2-40B4-BE49-F238E27FC236}">
-                <a16:creationId xmlns:a16="http://schemas.microsoft.com/office/drawing/2014/main" id="{40CB64B6-F2E9-7188-3DA9-20236C3688E9}"/>
+                <a16:creationId xmlns:a16="http://schemas.microsoft.com/office/drawing/2014/main" id="{33E92B8B-58CA-939A-C813-AEEA4D09E071}"/>
               </a:ext>
             </a:extLst>
           </p:cNvPr>
@@ -1450,7 +1450,7 @@
           <a:bodyPr/>
           <a:lstStyle/>
           <a:p>
-            <a:fld id="{68052361-CBA1-4FAA-B7D8-32A91B69C580}" type="slidenum">
+            <a:fld id="{73F896A6-F826-4F1B-8A07-4FF06BD3D008}" type="slidenum">
               <a:rPr lang="ko-KR" altLang="en-US" smtClean="0"/>
               <a:t>‹#›</a:t>
             </a:fld>
@@ -1461,7 +1461,7 @@
     </p:spTree>
     <p:extLst>
       <p:ext uri="{BB962C8B-B14F-4D97-AF65-F5344CB8AC3E}">
-        <p14:creationId xmlns:p14="http://schemas.microsoft.com/office/powerpoint/2010/main" val="1128762300"/>
+        <p14:creationId xmlns:p14="http://schemas.microsoft.com/office/powerpoint/2010/main" val="3187294181"/>
       </p:ext>
     </p:extLst>
   </p:cSld>
@@ -1493,7 +1493,7 @@
           <p:cNvPr id="2" name="제목 1">
             <a:extLst>
               <a:ext uri="{FF2B5EF4-FFF2-40B4-BE49-F238E27FC236}">
-                <a16:creationId xmlns:a16="http://schemas.microsoft.com/office/drawing/2014/main" id="{3D1AD7D3-D7DE-AEA0-45CA-D2FC7FF9D985}"/>
+                <a16:creationId xmlns:a16="http://schemas.microsoft.com/office/drawing/2014/main" id="{DB9B2EA6-0F89-5AE7-D632-F14D476B8452}"/>
               </a:ext>
             </a:extLst>
           </p:cNvPr>
@@ -1526,7 +1526,7 @@
           <p:cNvPr id="3" name="텍스트 개체 틀 2">
             <a:extLst>
               <a:ext uri="{FF2B5EF4-FFF2-40B4-BE49-F238E27FC236}">
-                <a16:creationId xmlns:a16="http://schemas.microsoft.com/office/drawing/2014/main" id="{99089F5E-4C57-6A65-9780-9FE5BBB4691E}"/>
+                <a16:creationId xmlns:a16="http://schemas.microsoft.com/office/drawing/2014/main" id="{B9DE76CD-ABAF-ABB5-474C-AEA9761FFDDA}"/>
               </a:ext>
             </a:extLst>
           </p:cNvPr>
@@ -1597,7 +1597,7 @@
           <p:cNvPr id="4" name="내용 개체 틀 3">
             <a:extLst>
               <a:ext uri="{FF2B5EF4-FFF2-40B4-BE49-F238E27FC236}">
-                <a16:creationId xmlns:a16="http://schemas.microsoft.com/office/drawing/2014/main" id="{AE61E9C1-20A1-E17F-8552-CD218F4F43A7}"/>
+                <a16:creationId xmlns:a16="http://schemas.microsoft.com/office/drawing/2014/main" id="{AB27E990-77FB-6D9D-26C3-22DEDE9D9443}"/>
               </a:ext>
             </a:extLst>
           </p:cNvPr>
@@ -1659,7 +1659,7 @@
           <p:cNvPr id="5" name="텍스트 개체 틀 4">
             <a:extLst>
               <a:ext uri="{FF2B5EF4-FFF2-40B4-BE49-F238E27FC236}">
-                <a16:creationId xmlns:a16="http://schemas.microsoft.com/office/drawing/2014/main" id="{AA477D19-9BB0-0EAF-89CB-C4793F130114}"/>
+                <a16:creationId xmlns:a16="http://schemas.microsoft.com/office/drawing/2014/main" id="{C5D9A0EC-FEDC-4CB7-9B85-3DE69BF4E606}"/>
               </a:ext>
             </a:extLst>
           </p:cNvPr>
@@ -1730,7 +1730,7 @@
           <p:cNvPr id="6" name="내용 개체 틀 5">
             <a:extLst>
               <a:ext uri="{FF2B5EF4-FFF2-40B4-BE49-F238E27FC236}">
-                <a16:creationId xmlns:a16="http://schemas.microsoft.com/office/drawing/2014/main" id="{2B860321-3003-1FD9-D5F6-AEB22E59460D}"/>
+                <a16:creationId xmlns:a16="http://schemas.microsoft.com/office/drawing/2014/main" id="{7711CDBA-BA24-C7A0-E4E0-52244803FA06}"/>
               </a:ext>
             </a:extLst>
           </p:cNvPr>
@@ -1792,7 +1792,7 @@
           <p:cNvPr id="7" name="날짜 개체 틀 6">
             <a:extLst>
               <a:ext uri="{FF2B5EF4-FFF2-40B4-BE49-F238E27FC236}">
-                <a16:creationId xmlns:a16="http://schemas.microsoft.com/office/drawing/2014/main" id="{68CEBE2B-11F7-550D-CEC0-023143B2BD23}"/>
+                <a16:creationId xmlns:a16="http://schemas.microsoft.com/office/drawing/2014/main" id="{A32B8BC1-CF86-8957-F4EC-F77C213A0BD2}"/>
               </a:ext>
             </a:extLst>
           </p:cNvPr>
@@ -1808,7 +1808,7 @@
           <a:bodyPr/>
           <a:lstStyle/>
           <a:p>
-            <a:fld id="{6A47B181-FA31-4A1A-9F99-EE3054882D27}" type="datetimeFigureOut">
+            <a:fld id="{F6C3687A-8429-4787-A5E4-66C74EFAC92C}" type="datetimeFigureOut">
               <a:rPr lang="ko-KR" altLang="en-US" smtClean="0"/>
               <a:t>2026-06-21</a:t>
             </a:fld>
@@ -1821,7 +1821,7 @@
           <p:cNvPr id="8" name="바닥글 개체 틀 7">
             <a:extLst>
               <a:ext uri="{FF2B5EF4-FFF2-40B4-BE49-F238E27FC236}">
-                <a16:creationId xmlns:a16="http://schemas.microsoft.com/office/drawing/2014/main" id="{0CFC068F-E75C-7317-D62F-68BF95670EA2}"/>
+                <a16:creationId xmlns:a16="http://schemas.microsoft.com/office/drawing/2014/main" id="{B4FA4EA3-B66E-4DEC-ED7B-6DCE222B138F}"/>
               </a:ext>
             </a:extLst>
           </p:cNvPr>
@@ -1846,7 +1846,7 @@
           <p:cNvPr id="9" name="슬라이드 번호 개체 틀 8">
             <a:extLst>
               <a:ext uri="{FF2B5EF4-FFF2-40B4-BE49-F238E27FC236}">
-                <a16:creationId xmlns:a16="http://schemas.microsoft.com/office/drawing/2014/main" id="{982A7D23-B989-3626-6476-F6F5908A2A2D}"/>
+                <a16:creationId xmlns:a16="http://schemas.microsoft.com/office/drawing/2014/main" id="{0340D77E-CA47-C271-4CC0-20AC3379BE8C}"/>
               </a:ext>
             </a:extLst>
           </p:cNvPr>
@@ -1862,7 +1862,7 @@
           <a:bodyPr/>
           <a:lstStyle/>
           <a:p>
-            <a:fld id="{68052361-CBA1-4FAA-B7D8-32A91B69C580}" type="slidenum">
+            <a:fld id="{73F896A6-F826-4F1B-8A07-4FF06BD3D008}" type="slidenum">
               <a:rPr lang="ko-KR" altLang="en-US" smtClean="0"/>
               <a:t>‹#›</a:t>
             </a:fld>
@@ -1873,7 +1873,7 @@
     </p:spTree>
     <p:extLst>
       <p:ext uri="{BB962C8B-B14F-4D97-AF65-F5344CB8AC3E}">
-        <p14:creationId xmlns:p14="http://schemas.microsoft.com/office/powerpoint/2010/main" val="3404194645"/>
+        <p14:creationId xmlns:p14="http://schemas.microsoft.com/office/powerpoint/2010/main" val="1114671124"/>
       </p:ext>
     </p:extLst>
   </p:cSld>
@@ -1905,7 +1905,7 @@
           <p:cNvPr id="2" name="제목 1">
             <a:extLst>
               <a:ext uri="{FF2B5EF4-FFF2-40B4-BE49-F238E27FC236}">
-                <a16:creationId xmlns:a16="http://schemas.microsoft.com/office/drawing/2014/main" id="{2F3DE23D-4D29-BF53-FF9D-6F055B01A48B}"/>
+                <a16:creationId xmlns:a16="http://schemas.microsoft.com/office/drawing/2014/main" id="{9B229A70-34F8-35F5-FC7D-DBB20DA17535}"/>
               </a:ext>
             </a:extLst>
           </p:cNvPr>
@@ -1933,7 +1933,7 @@
           <p:cNvPr id="3" name="날짜 개체 틀 2">
             <a:extLst>
               <a:ext uri="{FF2B5EF4-FFF2-40B4-BE49-F238E27FC236}">
-                <a16:creationId xmlns:a16="http://schemas.microsoft.com/office/drawing/2014/main" id="{1D1BC2E1-DE97-85AD-DA64-B109521D1652}"/>
+                <a16:creationId xmlns:a16="http://schemas.microsoft.com/office/drawing/2014/main" id="{E40ACE28-6235-35F7-BE98-689165BE5B37}"/>
               </a:ext>
             </a:extLst>
           </p:cNvPr>
@@ -1949,7 +1949,7 @@
           <a:bodyPr/>
           <a:lstStyle/>
           <a:p>
-            <a:fld id="{6A47B181-FA31-4A1A-9F99-EE3054882D27}" type="datetimeFigureOut">
+            <a:fld id="{F6C3687A-8429-4787-A5E4-66C74EFAC92C}" type="datetimeFigureOut">
               <a:rPr lang="ko-KR" altLang="en-US" smtClean="0"/>
               <a:t>2026-06-21</a:t>
             </a:fld>
@@ -1962,7 +1962,7 @@
           <p:cNvPr id="4" name="바닥글 개체 틀 3">
             <a:extLst>
               <a:ext uri="{FF2B5EF4-FFF2-40B4-BE49-F238E27FC236}">
-                <a16:creationId xmlns:a16="http://schemas.microsoft.com/office/drawing/2014/main" id="{8F139FE6-B5E5-5A5A-45A3-4B9BD453C222}"/>
+                <a16:creationId xmlns:a16="http://schemas.microsoft.com/office/drawing/2014/main" id="{EEFBF5F8-5890-93B9-93FC-1FDDAA40A8B3}"/>
               </a:ext>
             </a:extLst>
           </p:cNvPr>
@@ -1987,7 +1987,7 @@
           <p:cNvPr id="5" name="슬라이드 번호 개체 틀 4">
             <a:extLst>
               <a:ext uri="{FF2B5EF4-FFF2-40B4-BE49-F238E27FC236}">
-                <a16:creationId xmlns:a16="http://schemas.microsoft.com/office/drawing/2014/main" id="{07F02E17-AC0A-9D62-11D5-01A209A0ACDC}"/>
+                <a16:creationId xmlns:a16="http://schemas.microsoft.com/office/drawing/2014/main" id="{2E784325-699A-94AA-E7ED-6F5699459E89}"/>
               </a:ext>
             </a:extLst>
           </p:cNvPr>
@@ -2003,7 +2003,7 @@
           <a:bodyPr/>
           <a:lstStyle/>
           <a:p>
-            <a:fld id="{68052361-CBA1-4FAA-B7D8-32A91B69C580}" type="slidenum">
+            <a:fld id="{73F896A6-F826-4F1B-8A07-4FF06BD3D008}" type="slidenum">
               <a:rPr lang="ko-KR" altLang="en-US" smtClean="0"/>
               <a:t>‹#›</a:t>
             </a:fld>
@@ -2014,7 +2014,7 @@
     </p:spTree>
     <p:extLst>
       <p:ext uri="{BB962C8B-B14F-4D97-AF65-F5344CB8AC3E}">
-        <p14:creationId xmlns:p14="http://schemas.microsoft.com/office/powerpoint/2010/main" val="1301876651"/>
+        <p14:creationId xmlns:p14="http://schemas.microsoft.com/office/powerpoint/2010/main" val="387387224"/>
       </p:ext>
     </p:extLst>
   </p:cSld>
@@ -2046,7 +2046,7 @@
           <p:cNvPr id="2" name="날짜 개체 틀 1">
             <a:extLst>
               <a:ext uri="{FF2B5EF4-FFF2-40B4-BE49-F238E27FC236}">
-                <a16:creationId xmlns:a16="http://schemas.microsoft.com/office/drawing/2014/main" id="{6B2C491C-2E82-742A-9970-15038151B5F1}"/>
+                <a16:creationId xmlns:a16="http://schemas.microsoft.com/office/drawing/2014/main" id="{E6C37F5F-9FC9-2E21-5392-339112E0A3B1}"/>
               </a:ext>
             </a:extLst>
           </p:cNvPr>
@@ -2062,7 +2062,7 @@
           <a:bodyPr/>
           <a:lstStyle/>
           <a:p>
-            <a:fld id="{6A47B181-FA31-4A1A-9F99-EE3054882D27}" type="datetimeFigureOut">
+            <a:fld id="{F6C3687A-8429-4787-A5E4-66C74EFAC92C}" type="datetimeFigureOut">
               <a:rPr lang="ko-KR" altLang="en-US" smtClean="0"/>
               <a:t>2026-06-21</a:t>
             </a:fld>
@@ -2075,7 +2075,7 @@
           <p:cNvPr id="3" name="바닥글 개체 틀 2">
             <a:extLst>
               <a:ext uri="{FF2B5EF4-FFF2-40B4-BE49-F238E27FC236}">
-                <a16:creationId xmlns:a16="http://schemas.microsoft.com/office/drawing/2014/main" id="{1A3479E6-A8C3-C38D-1FED-1C8E1CAAF573}"/>
+                <a16:creationId xmlns:a16="http://schemas.microsoft.com/office/drawing/2014/main" id="{8730A10C-F460-5E16-39B6-B9F94455214A}"/>
               </a:ext>
             </a:extLst>
           </p:cNvPr>
@@ -2100,7 +2100,7 @@
           <p:cNvPr id="4" name="슬라이드 번호 개체 틀 3">
             <a:extLst>
               <a:ext uri="{FF2B5EF4-FFF2-40B4-BE49-F238E27FC236}">
-                <a16:creationId xmlns:a16="http://schemas.microsoft.com/office/drawing/2014/main" id="{3DC5F618-AF77-EC13-C928-C8F132313866}"/>
+                <a16:creationId xmlns:a16="http://schemas.microsoft.com/office/drawing/2014/main" id="{94F7B36B-A965-D333-1ACB-94657ED2B78D}"/>
               </a:ext>
             </a:extLst>
           </p:cNvPr>
@@ -2116,7 +2116,7 @@
           <a:bodyPr/>
           <a:lstStyle/>
           <a:p>
-            <a:fld id="{68052361-CBA1-4FAA-B7D8-32A91B69C580}" type="slidenum">
+            <a:fld id="{73F896A6-F826-4F1B-8A07-4FF06BD3D008}" type="slidenum">
               <a:rPr lang="ko-KR" altLang="en-US" smtClean="0"/>
               <a:t>‹#›</a:t>
             </a:fld>
@@ -2127,7 +2127,7 @@
     </p:spTree>
     <p:extLst>
       <p:ext uri="{BB962C8B-B14F-4D97-AF65-F5344CB8AC3E}">
-        <p14:creationId xmlns:p14="http://schemas.microsoft.com/office/powerpoint/2010/main" val="4093031655"/>
+        <p14:creationId xmlns:p14="http://schemas.microsoft.com/office/powerpoint/2010/main" val="2467048889"/>
       </p:ext>
     </p:extLst>
   </p:cSld>
@@ -2159,7 +2159,7 @@
           <p:cNvPr id="2" name="제목 1">
             <a:extLst>
               <a:ext uri="{FF2B5EF4-FFF2-40B4-BE49-F238E27FC236}">
-                <a16:creationId xmlns:a16="http://schemas.microsoft.com/office/drawing/2014/main" id="{112C6E24-5E58-295E-F8CC-98608B0E17D0}"/>
+                <a16:creationId xmlns:a16="http://schemas.microsoft.com/office/drawing/2014/main" id="{855C1B78-E6E0-3451-98E5-433D9CA36AE7}"/>
               </a:ext>
             </a:extLst>
           </p:cNvPr>
@@ -2196,7 +2196,7 @@
           <p:cNvPr id="3" name="내용 개체 틀 2">
             <a:extLst>
               <a:ext uri="{FF2B5EF4-FFF2-40B4-BE49-F238E27FC236}">
-                <a16:creationId xmlns:a16="http://schemas.microsoft.com/office/drawing/2014/main" id="{8CFE4783-8294-FF42-6F7D-962CA05D6CC9}"/>
+                <a16:creationId xmlns:a16="http://schemas.microsoft.com/office/drawing/2014/main" id="{6BDEC2BD-CB35-172E-D774-A4DBE42154D0}"/>
               </a:ext>
             </a:extLst>
           </p:cNvPr>
@@ -2286,7 +2286,7 @@
           <p:cNvPr id="4" name="텍스트 개체 틀 3">
             <a:extLst>
               <a:ext uri="{FF2B5EF4-FFF2-40B4-BE49-F238E27FC236}">
-                <a16:creationId xmlns:a16="http://schemas.microsoft.com/office/drawing/2014/main" id="{F4F2AD73-4C93-7D12-007B-9F660AFD8375}"/>
+                <a16:creationId xmlns:a16="http://schemas.microsoft.com/office/drawing/2014/main" id="{98154AC6-083F-BBB4-3C8D-E76F1B6C19F5}"/>
               </a:ext>
             </a:extLst>
           </p:cNvPr>
@@ -2357,7 +2357,7 @@
           <p:cNvPr id="5" name="날짜 개체 틀 4">
             <a:extLst>
               <a:ext uri="{FF2B5EF4-FFF2-40B4-BE49-F238E27FC236}">
-                <a16:creationId xmlns:a16="http://schemas.microsoft.com/office/drawing/2014/main" id="{3E9E3913-032B-2392-12AD-2D826890BC51}"/>
+                <a16:creationId xmlns:a16="http://schemas.microsoft.com/office/drawing/2014/main" id="{EBA46D39-EA0B-8E30-FD6C-99741BDB826E}"/>
               </a:ext>
             </a:extLst>
           </p:cNvPr>
@@ -2373,7 +2373,7 @@
           <a:bodyPr/>
           <a:lstStyle/>
           <a:p>
-            <a:fld id="{6A47B181-FA31-4A1A-9F99-EE3054882D27}" type="datetimeFigureOut">
+            <a:fld id="{F6C3687A-8429-4787-A5E4-66C74EFAC92C}" type="datetimeFigureOut">
               <a:rPr lang="ko-KR" altLang="en-US" smtClean="0"/>
               <a:t>2026-06-21</a:t>
             </a:fld>
@@ -2386,7 +2386,7 @@
           <p:cNvPr id="6" name="바닥글 개체 틀 5">
             <a:extLst>
               <a:ext uri="{FF2B5EF4-FFF2-40B4-BE49-F238E27FC236}">
-                <a16:creationId xmlns:a16="http://schemas.microsoft.com/office/drawing/2014/main" id="{E939C3E0-D77F-397F-BAA5-F1C98B133626}"/>
+                <a16:creationId xmlns:a16="http://schemas.microsoft.com/office/drawing/2014/main" id="{63BEF491-7512-6A71-3707-CBFCF8188E7A}"/>
               </a:ext>
             </a:extLst>
           </p:cNvPr>
@@ -2411,7 +2411,7 @@
           <p:cNvPr id="7" name="슬라이드 번호 개체 틀 6">
             <a:extLst>
               <a:ext uri="{FF2B5EF4-FFF2-40B4-BE49-F238E27FC236}">
-                <a16:creationId xmlns:a16="http://schemas.microsoft.com/office/drawing/2014/main" id="{28904968-546E-7397-F4F6-EF0AF6CAD829}"/>
+                <a16:creationId xmlns:a16="http://schemas.microsoft.com/office/drawing/2014/main" id="{B77C4887-87D4-7184-8402-82CDD49113E5}"/>
               </a:ext>
             </a:extLst>
           </p:cNvPr>
@@ -2427,7 +2427,7 @@
           <a:bodyPr/>
           <a:lstStyle/>
           <a:p>
-            <a:fld id="{68052361-CBA1-4FAA-B7D8-32A91B69C580}" type="slidenum">
+            <a:fld id="{73F896A6-F826-4F1B-8A07-4FF06BD3D008}" type="slidenum">
               <a:rPr lang="ko-KR" altLang="en-US" smtClean="0"/>
               <a:t>‹#›</a:t>
             </a:fld>
@@ -2438,7 +2438,7 @@
     </p:spTree>
     <p:extLst>
       <p:ext uri="{BB962C8B-B14F-4D97-AF65-F5344CB8AC3E}">
-        <p14:creationId xmlns:p14="http://schemas.microsoft.com/office/powerpoint/2010/main" val="2772201553"/>
+        <p14:creationId xmlns:p14="http://schemas.microsoft.com/office/powerpoint/2010/main" val="657649752"/>
       </p:ext>
     </p:extLst>
   </p:cSld>
@@ -2470,7 +2470,7 @@
           <p:cNvPr id="2" name="제목 1">
             <a:extLst>
               <a:ext uri="{FF2B5EF4-FFF2-40B4-BE49-F238E27FC236}">
-                <a16:creationId xmlns:a16="http://schemas.microsoft.com/office/drawing/2014/main" id="{A9C808E3-43E1-5098-96FB-9B19CC4851B0}"/>
+                <a16:creationId xmlns:a16="http://schemas.microsoft.com/office/drawing/2014/main" id="{F5E30114-1B12-8422-7F05-178142915CC6}"/>
               </a:ext>
             </a:extLst>
           </p:cNvPr>
@@ -2507,7 +2507,7 @@
           <p:cNvPr id="3" name="그림 개체 틀 2">
             <a:extLst>
               <a:ext uri="{FF2B5EF4-FFF2-40B4-BE49-F238E27FC236}">
-                <a16:creationId xmlns:a16="http://schemas.microsoft.com/office/drawing/2014/main" id="{9F1ED04B-52B2-A920-6D6D-C7B01A9E1DDA}"/>
+                <a16:creationId xmlns:a16="http://schemas.microsoft.com/office/drawing/2014/main" id="{784D4F83-F51B-E1A5-B9B8-6B42A215EFE2}"/>
               </a:ext>
             </a:extLst>
           </p:cNvPr>
@@ -2574,7 +2574,7 @@
           <p:cNvPr id="4" name="텍스트 개체 틀 3">
             <a:extLst>
               <a:ext uri="{FF2B5EF4-FFF2-40B4-BE49-F238E27FC236}">
-                <a16:creationId xmlns:a16="http://schemas.microsoft.com/office/drawing/2014/main" id="{B55AB269-FB57-5A95-D483-2E1CFA0CE5C9}"/>
+                <a16:creationId xmlns:a16="http://schemas.microsoft.com/office/drawing/2014/main" id="{A315C6CE-C833-84F1-7B1A-252E4E75E561}"/>
               </a:ext>
             </a:extLst>
           </p:cNvPr>
@@ -2645,7 +2645,7 @@
           <p:cNvPr id="5" name="날짜 개체 틀 4">
             <a:extLst>
               <a:ext uri="{FF2B5EF4-FFF2-40B4-BE49-F238E27FC236}">
-                <a16:creationId xmlns:a16="http://schemas.microsoft.com/office/drawing/2014/main" id="{C587CE6B-2A53-18B2-7C1F-B2C8415B9527}"/>
+                <a16:creationId xmlns:a16="http://schemas.microsoft.com/office/drawing/2014/main" id="{F7600152-ADFB-1B01-A18C-765EAA2BF91F}"/>
               </a:ext>
             </a:extLst>
           </p:cNvPr>
@@ -2661,7 +2661,7 @@
           <a:bodyPr/>
           <a:lstStyle/>
           <a:p>
-            <a:fld id="{6A47B181-FA31-4A1A-9F99-EE3054882D27}" type="datetimeFigureOut">
+            <a:fld id="{F6C3687A-8429-4787-A5E4-66C74EFAC92C}" type="datetimeFigureOut">
               <a:rPr lang="ko-KR" altLang="en-US" smtClean="0"/>
               <a:t>2026-06-21</a:t>
             </a:fld>
@@ -2674,7 +2674,7 @@
           <p:cNvPr id="6" name="바닥글 개체 틀 5">
             <a:extLst>
               <a:ext uri="{FF2B5EF4-FFF2-40B4-BE49-F238E27FC236}">
-                <a16:creationId xmlns:a16="http://schemas.microsoft.com/office/drawing/2014/main" id="{AC7693CE-EA97-4626-45DB-4180238AA4AA}"/>
+                <a16:creationId xmlns:a16="http://schemas.microsoft.com/office/drawing/2014/main" id="{8ADF6D2D-C9A2-A4E6-B4DF-4CB1A5770F97}"/>
               </a:ext>
             </a:extLst>
           </p:cNvPr>
@@ -2699,7 +2699,7 @@
           <p:cNvPr id="7" name="슬라이드 번호 개체 틀 6">
             <a:extLst>
               <a:ext uri="{FF2B5EF4-FFF2-40B4-BE49-F238E27FC236}">
-                <a16:creationId xmlns:a16="http://schemas.microsoft.com/office/drawing/2014/main" id="{31034976-7AF2-5CCC-5412-492A64D42ABD}"/>
+                <a16:creationId xmlns:a16="http://schemas.microsoft.com/office/drawing/2014/main" id="{E39FDE1A-2376-3B6A-9E68-CF58FDF9E62A}"/>
               </a:ext>
             </a:extLst>
           </p:cNvPr>
@@ -2715,7 +2715,7 @@
           <a:bodyPr/>
           <a:lstStyle/>
           <a:p>
-            <a:fld id="{68052361-CBA1-4FAA-B7D8-32A91B69C580}" type="slidenum">
+            <a:fld id="{73F896A6-F826-4F1B-8A07-4FF06BD3D008}" type="slidenum">
               <a:rPr lang="ko-KR" altLang="en-US" smtClean="0"/>
               <a:t>‹#›</a:t>
             </a:fld>
@@ -2726,7 +2726,7 @@
     </p:spTree>
     <p:extLst>
       <p:ext uri="{BB962C8B-B14F-4D97-AF65-F5344CB8AC3E}">
-        <p14:creationId xmlns:p14="http://schemas.microsoft.com/office/powerpoint/2010/main" val="3514025320"/>
+        <p14:creationId xmlns:p14="http://schemas.microsoft.com/office/powerpoint/2010/main" val="1828283875"/>
       </p:ext>
     </p:extLst>
   </p:cSld>
@@ -2763,7 +2763,7 @@
           <p:cNvPr id="2" name="제목 개체 틀 1">
             <a:extLst>
               <a:ext uri="{FF2B5EF4-FFF2-40B4-BE49-F238E27FC236}">
-                <a16:creationId xmlns:a16="http://schemas.microsoft.com/office/drawing/2014/main" id="{2C1B15B6-E4F8-19BA-489B-8D61C6D04433}"/>
+                <a16:creationId xmlns:a16="http://schemas.microsoft.com/office/drawing/2014/main" id="{8C0EE3BD-D3AF-2C9F-2EB6-C50B4CC8A1BC}"/>
               </a:ext>
             </a:extLst>
           </p:cNvPr>
@@ -2801,7 +2801,7 @@
           <p:cNvPr id="3" name="텍스트 개체 틀 2">
             <a:extLst>
               <a:ext uri="{FF2B5EF4-FFF2-40B4-BE49-F238E27FC236}">
-                <a16:creationId xmlns:a16="http://schemas.microsoft.com/office/drawing/2014/main" id="{F6EA60EB-3B73-C15A-FC9F-92D655643390}"/>
+                <a16:creationId xmlns:a16="http://schemas.microsoft.com/office/drawing/2014/main" id="{AB8C22EC-B6E0-D6B6-2F30-32EA0B192C35}"/>
               </a:ext>
             </a:extLst>
           </p:cNvPr>
@@ -2868,7 +2868,7 @@
           <p:cNvPr id="4" name="날짜 개체 틀 3">
             <a:extLst>
               <a:ext uri="{FF2B5EF4-FFF2-40B4-BE49-F238E27FC236}">
-                <a16:creationId xmlns:a16="http://schemas.microsoft.com/office/drawing/2014/main" id="{DE3D5302-E9DB-1DB3-94A3-E2D8FC9AABCB}"/>
+                <a16:creationId xmlns:a16="http://schemas.microsoft.com/office/drawing/2014/main" id="{FD423D9A-CC4C-6EC9-9AF0-27BADB2E6242}"/>
               </a:ext>
             </a:extLst>
           </p:cNvPr>
@@ -2902,7 +2902,7 @@
             </a:lvl1pPr>
           </a:lstStyle>
           <a:p>
-            <a:fld id="{6A47B181-FA31-4A1A-9F99-EE3054882D27}" type="datetimeFigureOut">
+            <a:fld id="{F6C3687A-8429-4787-A5E4-66C74EFAC92C}" type="datetimeFigureOut">
               <a:rPr lang="ko-KR" altLang="en-US" smtClean="0"/>
               <a:t>2026-06-21</a:t>
             </a:fld>
@@ -2915,7 +2915,7 @@
           <p:cNvPr id="5" name="바닥글 개체 틀 4">
             <a:extLst>
               <a:ext uri="{FF2B5EF4-FFF2-40B4-BE49-F238E27FC236}">
-                <a16:creationId xmlns:a16="http://schemas.microsoft.com/office/drawing/2014/main" id="{D20522DA-08BC-0952-E0F6-30AC160DE239}"/>
+                <a16:creationId xmlns:a16="http://schemas.microsoft.com/office/drawing/2014/main" id="{5D32A48C-1094-8F66-9A8D-A8B583A27BAA}"/>
               </a:ext>
             </a:extLst>
           </p:cNvPr>
@@ -2958,7 +2958,7 @@
           <p:cNvPr id="6" name="슬라이드 번호 개체 틀 5">
             <a:extLst>
               <a:ext uri="{FF2B5EF4-FFF2-40B4-BE49-F238E27FC236}">
-                <a16:creationId xmlns:a16="http://schemas.microsoft.com/office/drawing/2014/main" id="{C356FFAD-950E-5EB8-BAA4-29180D6896C5}"/>
+                <a16:creationId xmlns:a16="http://schemas.microsoft.com/office/drawing/2014/main" id="{19E8EA66-8353-022B-FEA8-69756BFAF2F1}"/>
               </a:ext>
             </a:extLst>
           </p:cNvPr>
@@ -2992,7 +2992,7 @@
             </a:lvl1pPr>
           </a:lstStyle>
           <a:p>
-            <a:fld id="{68052361-CBA1-4FAA-B7D8-32A91B69C580}" type="slidenum">
+            <a:fld id="{73F896A6-F826-4F1B-8A07-4FF06BD3D008}" type="slidenum">
               <a:rPr lang="ko-KR" altLang="en-US" smtClean="0"/>
               <a:t>‹#›</a:t>
             </a:fld>
@@ -3003,7 +3003,7 @@
     </p:spTree>
     <p:extLst>
       <p:ext uri="{BB962C8B-B14F-4D97-AF65-F5344CB8AC3E}">
-        <p14:creationId xmlns:p14="http://schemas.microsoft.com/office/powerpoint/2010/main" val="1113700523"/>
+        <p14:creationId xmlns:p14="http://schemas.microsoft.com/office/powerpoint/2010/main" val="4009963830"/>
       </p:ext>
     </p:extLst>
   </p:cSld>
@@ -3326,7 +3326,7 @@
           <p:cNvPr id="2" name="z00_grid_top">
             <a:extLst>
               <a:ext uri="{FF2B5EF4-FFF2-40B4-BE49-F238E27FC236}">
-                <a16:creationId xmlns:a16="http://schemas.microsoft.com/office/drawing/2014/main" id="{BBC07FA7-0780-9CA7-1129-F9C873D03E48}"/>
+                <a16:creationId xmlns:a16="http://schemas.microsoft.com/office/drawing/2014/main" id="{D48804EC-3A7E-2B7D-D236-E8919BCB64C3}"/>
               </a:ext>
             </a:extLst>
           </p:cNvPr>
@@ -3369,7 +3369,7 @@
           <p:cNvPr id="3" name="z00_grid_bottom">
             <a:extLst>
               <a:ext uri="{FF2B5EF4-FFF2-40B4-BE49-F238E27FC236}">
-                <a16:creationId xmlns:a16="http://schemas.microsoft.com/office/drawing/2014/main" id="{8FC6958F-BF06-76E2-DC69-D06BAA68DB6C}"/>
+                <a16:creationId xmlns:a16="http://schemas.microsoft.com/office/drawing/2014/main" id="{22E1F044-10FF-D11D-FBCE-BAF172013914}"/>
               </a:ext>
             </a:extLst>
           </p:cNvPr>
@@ -3412,7 +3412,7 @@
           <p:cNvPr id="4" name="z00_grid_v_0">
             <a:extLst>
               <a:ext uri="{FF2B5EF4-FFF2-40B4-BE49-F238E27FC236}">
-                <a16:creationId xmlns:a16="http://schemas.microsoft.com/office/drawing/2014/main" id="{660382F3-3295-C71D-0E23-9311D1C8F643}"/>
+                <a16:creationId xmlns:a16="http://schemas.microsoft.com/office/drawing/2014/main" id="{DE22D99D-3301-F5C2-D578-BABE0F8D0390}"/>
               </a:ext>
             </a:extLst>
           </p:cNvPr>
@@ -3455,7 +3455,7 @@
           <p:cNvPr id="5" name="z00_grid_v_1">
             <a:extLst>
               <a:ext uri="{FF2B5EF4-FFF2-40B4-BE49-F238E27FC236}">
-                <a16:creationId xmlns:a16="http://schemas.microsoft.com/office/drawing/2014/main" id="{9D0A476B-626F-4BDB-5C34-9468D83C2C23}"/>
+                <a16:creationId xmlns:a16="http://schemas.microsoft.com/office/drawing/2014/main" id="{0F775E92-E570-5D11-D3F4-931355D42332}"/>
               </a:ext>
             </a:extLst>
           </p:cNvPr>
@@ -3498,7 +3498,7 @@
           <p:cNvPr id="6" name="z00_grid_v_2">
             <a:extLst>
               <a:ext uri="{FF2B5EF4-FFF2-40B4-BE49-F238E27FC236}">
-                <a16:creationId xmlns:a16="http://schemas.microsoft.com/office/drawing/2014/main" id="{3C454BA8-C787-5F37-600C-836A23F21442}"/>
+                <a16:creationId xmlns:a16="http://schemas.microsoft.com/office/drawing/2014/main" id="{88892D46-04C3-4113-C594-F6480209CE8E}"/>
               </a:ext>
             </a:extLst>
           </p:cNvPr>
@@ -3541,7 +3541,7 @@
           <p:cNvPr id="7" name="header_title">
             <a:extLst>
               <a:ext uri="{FF2B5EF4-FFF2-40B4-BE49-F238E27FC236}">
-                <a16:creationId xmlns:a16="http://schemas.microsoft.com/office/drawing/2014/main" id="{590B2376-AEAC-D618-816C-512AF7795AEA}"/>
+                <a16:creationId xmlns:a16="http://schemas.microsoft.com/office/drawing/2014/main" id="{210426CE-D42D-3A30-8982-9B0081D5895C}"/>
               </a:ext>
             </a:extLst>
           </p:cNvPr>
@@ -3587,7 +3587,7 @@
           <p:cNvPr id="8" name="header_subtitle">
             <a:extLst>
               <a:ext uri="{FF2B5EF4-FFF2-40B4-BE49-F238E27FC236}">
-                <a16:creationId xmlns:a16="http://schemas.microsoft.com/office/drawing/2014/main" id="{9F27B11C-999A-4E8A-45F8-6484CE4E3F48}"/>
+                <a16:creationId xmlns:a16="http://schemas.microsoft.com/office/drawing/2014/main" id="{71C91D42-F679-9F67-2816-B39DEAD33FFB}"/>
               </a:ext>
             </a:extLst>
           </p:cNvPr>
@@ -3633,7 +3633,7 @@
           <p:cNvPr id="9" name="zone_content_panel">
             <a:extLst>
               <a:ext uri="{FF2B5EF4-FFF2-40B4-BE49-F238E27FC236}">
-                <a16:creationId xmlns:a16="http://schemas.microsoft.com/office/drawing/2014/main" id="{F6146D47-8BB7-B5B7-A671-CDCA44A2D966}"/>
+                <a16:creationId xmlns:a16="http://schemas.microsoft.com/office/drawing/2014/main" id="{7E4F89DE-3A4C-3F75-E851-6B71FA229236}"/>
               </a:ext>
             </a:extLst>
           </p:cNvPr>
@@ -3696,7 +3696,7 @@
           <p:cNvPr id="10" name="zone_content_title">
             <a:extLst>
               <a:ext uri="{FF2B5EF4-FFF2-40B4-BE49-F238E27FC236}">
-                <a16:creationId xmlns:a16="http://schemas.microsoft.com/office/drawing/2014/main" id="{88A6085E-6320-BAAF-C082-5902CEE65BC4}"/>
+                <a16:creationId xmlns:a16="http://schemas.microsoft.com/office/drawing/2014/main" id="{5DBB4F46-82F7-8F2E-7A29-EBF095065C9E}"/>
               </a:ext>
             </a:extLst>
           </p:cNvPr>
@@ -3742,7 +3742,7 @@
           <p:cNvPr id="11" name="zone_content_subtitle">
             <a:extLst>
               <a:ext uri="{FF2B5EF4-FFF2-40B4-BE49-F238E27FC236}">
-                <a16:creationId xmlns:a16="http://schemas.microsoft.com/office/drawing/2014/main" id="{036CDB35-46A5-C407-503C-0AB58C55DA04}"/>
+                <a16:creationId xmlns:a16="http://schemas.microsoft.com/office/drawing/2014/main" id="{C2EACD2F-96EE-22CE-0B5E-7B874DA1D8E2}"/>
               </a:ext>
             </a:extLst>
           </p:cNvPr>
@@ -3788,7 +3788,7 @@
           <p:cNvPr id="12" name="zone_reasoning_panel">
             <a:extLst>
               <a:ext uri="{FF2B5EF4-FFF2-40B4-BE49-F238E27FC236}">
-                <a16:creationId xmlns:a16="http://schemas.microsoft.com/office/drawing/2014/main" id="{0E07AAF9-E8AD-E9A5-98C5-260482FAA21D}"/>
+                <a16:creationId xmlns:a16="http://schemas.microsoft.com/office/drawing/2014/main" id="{9863AD52-291D-745F-03DD-0CD4478A15A1}"/>
               </a:ext>
             </a:extLst>
           </p:cNvPr>
@@ -3851,7 +3851,7 @@
           <p:cNvPr id="13" name="zone_reasoning_title">
             <a:extLst>
               <a:ext uri="{FF2B5EF4-FFF2-40B4-BE49-F238E27FC236}">
-                <a16:creationId xmlns:a16="http://schemas.microsoft.com/office/drawing/2014/main" id="{66A1CB70-7312-FBD7-CC0A-2B1C14E4B318}"/>
+                <a16:creationId xmlns:a16="http://schemas.microsoft.com/office/drawing/2014/main" id="{BBB0CF4A-C694-9514-4BAA-F944FB1FF51C}"/>
               </a:ext>
             </a:extLst>
           </p:cNvPr>
@@ -3897,7 +3897,7 @@
           <p:cNvPr id="14" name="zone_reasoning_subtitle">
             <a:extLst>
               <a:ext uri="{FF2B5EF4-FFF2-40B4-BE49-F238E27FC236}">
-                <a16:creationId xmlns:a16="http://schemas.microsoft.com/office/drawing/2014/main" id="{87645791-E4C4-9134-B993-DDF67E197FDC}"/>
+                <a16:creationId xmlns:a16="http://schemas.microsoft.com/office/drawing/2014/main" id="{15293A4E-D554-B709-06E1-37C756F4A109}"/>
               </a:ext>
             </a:extLst>
           </p:cNvPr>
@@ -3943,7 +3943,7 @@
           <p:cNvPr id="15" name="zone_rules_panel">
             <a:extLst>
               <a:ext uri="{FF2B5EF4-FFF2-40B4-BE49-F238E27FC236}">
-                <a16:creationId xmlns:a16="http://schemas.microsoft.com/office/drawing/2014/main" id="{6F5F299C-447C-21D7-F3E6-A2AC46F6EAAB}"/>
+                <a16:creationId xmlns:a16="http://schemas.microsoft.com/office/drawing/2014/main" id="{61A3CDF5-B6AC-7B77-A966-D12F4D7DBD17}"/>
               </a:ext>
             </a:extLst>
           </p:cNvPr>
@@ -4006,7 +4006,7 @@
           <p:cNvPr id="16" name="zone_rules_title">
             <a:extLst>
               <a:ext uri="{FF2B5EF4-FFF2-40B4-BE49-F238E27FC236}">
-                <a16:creationId xmlns:a16="http://schemas.microsoft.com/office/drawing/2014/main" id="{D5FE949B-88DF-71FD-A7BD-78C4C38FCCDA}"/>
+                <a16:creationId xmlns:a16="http://schemas.microsoft.com/office/drawing/2014/main" id="{8DD942D5-6B8B-FE31-60E0-4011A4F5DC04}"/>
               </a:ext>
             </a:extLst>
           </p:cNvPr>
@@ -4052,7 +4052,7 @@
           <p:cNvPr id="17" name="zone_rules_subtitle">
             <a:extLst>
               <a:ext uri="{FF2B5EF4-FFF2-40B4-BE49-F238E27FC236}">
-                <a16:creationId xmlns:a16="http://schemas.microsoft.com/office/drawing/2014/main" id="{997DE95D-E364-C231-03F0-886F17AB25D0}"/>
+                <a16:creationId xmlns:a16="http://schemas.microsoft.com/office/drawing/2014/main" id="{3FD4AA09-6069-233C-4BF4-4BA1E9D48142}"/>
               </a:ext>
             </a:extLst>
           </p:cNvPr>
@@ -4098,7 +4098,7 @@
           <p:cNvPr id="18" name="zone_outputs_panel">
             <a:extLst>
               <a:ext uri="{FF2B5EF4-FFF2-40B4-BE49-F238E27FC236}">
-                <a16:creationId xmlns:a16="http://schemas.microsoft.com/office/drawing/2014/main" id="{64EA4A91-BF38-51C5-98CB-51FD471877BD}"/>
+                <a16:creationId xmlns:a16="http://schemas.microsoft.com/office/drawing/2014/main" id="{B44F1807-9B7A-58B7-DA99-5F134ED9A178}"/>
               </a:ext>
             </a:extLst>
           </p:cNvPr>
@@ -4161,7 +4161,7 @@
           <p:cNvPr id="19" name="zone_outputs_title">
             <a:extLst>
               <a:ext uri="{FF2B5EF4-FFF2-40B4-BE49-F238E27FC236}">
-                <a16:creationId xmlns:a16="http://schemas.microsoft.com/office/drawing/2014/main" id="{0C290D0D-1046-B83E-27D7-9CE14DB13377}"/>
+                <a16:creationId xmlns:a16="http://schemas.microsoft.com/office/drawing/2014/main" id="{E75FAA43-A890-A267-91FA-CAB25B5BAD18}"/>
               </a:ext>
             </a:extLst>
           </p:cNvPr>
@@ -4207,7 +4207,7 @@
           <p:cNvPr id="20" name="zone_outputs_subtitle">
             <a:extLst>
               <a:ext uri="{FF2B5EF4-FFF2-40B4-BE49-F238E27FC236}">
-                <a16:creationId xmlns:a16="http://schemas.microsoft.com/office/drawing/2014/main" id="{21C79BFD-026A-D9EA-BC0A-9EE720256138}"/>
+                <a16:creationId xmlns:a16="http://schemas.microsoft.com/office/drawing/2014/main" id="{B8836DF6-EA97-F98E-088D-867251A29948}"/>
               </a:ext>
             </a:extLst>
           </p:cNvPr>
@@ -4253,7 +4253,7 @@
           <p:cNvPr id="21" name="main_start_markdown">
             <a:extLst>
               <a:ext uri="{FF2B5EF4-FFF2-40B4-BE49-F238E27FC236}">
-                <a16:creationId xmlns:a16="http://schemas.microsoft.com/office/drawing/2014/main" id="{B25CCEC9-2FCE-355E-EADF-060C458F40E8}"/>
+                <a16:creationId xmlns:a16="http://schemas.microsoft.com/office/drawing/2014/main" id="{14B67C3B-FF84-46ED-ABEC-6F09C3DE1293}"/>
               </a:ext>
             </a:extLst>
           </p:cNvPr>
@@ -4296,7 +4296,7 @@
           <p:cNvPr id="22" name="main_markdown_splitter">
             <a:extLst>
               <a:ext uri="{FF2B5EF4-FFF2-40B4-BE49-F238E27FC236}">
-                <a16:creationId xmlns:a16="http://schemas.microsoft.com/office/drawing/2014/main" id="{CD21ED63-BF8A-43EE-2BE0-259D180BA063}"/>
+                <a16:creationId xmlns:a16="http://schemas.microsoft.com/office/drawing/2014/main" id="{C5ED3FA5-9F9A-6165-80E0-E55F8C340C40}"/>
               </a:ext>
             </a:extLst>
           </p:cNvPr>
@@ -4339,7 +4339,7 @@
           <p:cNvPr id="23" name="main_splitter_ir_seg_1">
             <a:extLst>
               <a:ext uri="{FF2B5EF4-FFF2-40B4-BE49-F238E27FC236}">
-                <a16:creationId xmlns:a16="http://schemas.microsoft.com/office/drawing/2014/main" id="{3EF9FB58-7D09-D286-7D2B-B2665F62DD90}"/>
+                <a16:creationId xmlns:a16="http://schemas.microsoft.com/office/drawing/2014/main" id="{7EA5828E-856F-61EF-05A0-358F914CBEEB}"/>
               </a:ext>
             </a:extLst>
           </p:cNvPr>
@@ -4382,7 +4382,7 @@
           <p:cNvPr id="24" name="main_splitter_ir_seg_2">
             <a:extLst>
               <a:ext uri="{FF2B5EF4-FFF2-40B4-BE49-F238E27FC236}">
-                <a16:creationId xmlns:a16="http://schemas.microsoft.com/office/drawing/2014/main" id="{9B28F15B-D2AA-032B-8198-40CA1214A1A5}"/>
+                <a16:creationId xmlns:a16="http://schemas.microsoft.com/office/drawing/2014/main" id="{7DB801DC-6310-88E2-9660-1BB2233BCE4C}"/>
               </a:ext>
             </a:extLst>
           </p:cNvPr>
@@ -4425,7 +4425,7 @@
           <p:cNvPr id="25" name="main_splitter_ir_seg_3">
             <a:extLst>
               <a:ext uri="{FF2B5EF4-FFF2-40B4-BE49-F238E27FC236}">
-                <a16:creationId xmlns:a16="http://schemas.microsoft.com/office/drawing/2014/main" id="{B5D60F31-67E0-3C29-13E3-CAE422D8DF68}"/>
+                <a16:creationId xmlns:a16="http://schemas.microsoft.com/office/drawing/2014/main" id="{13894938-621D-8F55-486F-8C5730C01D21}"/>
               </a:ext>
             </a:extLst>
           </p:cNvPr>
@@ -4468,7 +4468,7 @@
           <p:cNvPr id="26" name="hint_ir_reasoning">
             <a:extLst>
               <a:ext uri="{FF2B5EF4-FFF2-40B4-BE49-F238E27FC236}">
-                <a16:creationId xmlns:a16="http://schemas.microsoft.com/office/drawing/2014/main" id="{8124FDD9-CD42-E41E-463C-B0A6F2DDF62F}"/>
+                <a16:creationId xmlns:a16="http://schemas.microsoft.com/office/drawing/2014/main" id="{D906D085-448D-9C0F-5231-A6FF01B61844}"/>
               </a:ext>
             </a:extLst>
           </p:cNvPr>
@@ -4512,7 +4512,7 @@
           <p:cNvPr id="27" name="main_ir_rules">
             <a:extLst>
               <a:ext uri="{FF2B5EF4-FFF2-40B4-BE49-F238E27FC236}">
-                <a16:creationId xmlns:a16="http://schemas.microsoft.com/office/drawing/2014/main" id="{4A62A13B-37E0-F288-95DC-46799C0865AF}"/>
+                <a16:creationId xmlns:a16="http://schemas.microsoft.com/office/drawing/2014/main" id="{DDA92709-434E-956A-20C5-0A8F97F1CA91}"/>
               </a:ext>
             </a:extLst>
           </p:cNvPr>
@@ -4555,7 +4555,7 @@
           <p:cNvPr id="28" name="hint_reasoning_rules_seg_1">
             <a:extLst>
               <a:ext uri="{FF2B5EF4-FFF2-40B4-BE49-F238E27FC236}">
-                <a16:creationId xmlns:a16="http://schemas.microsoft.com/office/drawing/2014/main" id="{1DBC5C4C-F5D9-2BB3-97AB-211E1E8FAFFA}"/>
+                <a16:creationId xmlns:a16="http://schemas.microsoft.com/office/drawing/2014/main" id="{4BEDCD99-EBF7-5132-BD85-ABA636E6FB07}"/>
               </a:ext>
             </a:extLst>
           </p:cNvPr>
@@ -4599,7 +4599,7 @@
           <p:cNvPr id="29" name="hint_reasoning_rules_seg_2">
             <a:extLst>
               <a:ext uri="{FF2B5EF4-FFF2-40B4-BE49-F238E27FC236}">
-                <a16:creationId xmlns:a16="http://schemas.microsoft.com/office/drawing/2014/main" id="{885526EA-2E67-C8AE-6F9F-D226A2766A74}"/>
+                <a16:creationId xmlns:a16="http://schemas.microsoft.com/office/drawing/2014/main" id="{E6D7AD6D-5C68-DC9F-F0FE-E805249390DC}"/>
               </a:ext>
             </a:extLst>
           </p:cNvPr>
@@ -4643,7 +4643,7 @@
           <p:cNvPr id="30" name="hint_reasoning_rules_seg_3">
             <a:extLst>
               <a:ext uri="{FF2B5EF4-FFF2-40B4-BE49-F238E27FC236}">
-                <a16:creationId xmlns:a16="http://schemas.microsoft.com/office/drawing/2014/main" id="{A4B9C116-74A7-BE45-DF5C-868B9F41A806}"/>
+                <a16:creationId xmlns:a16="http://schemas.microsoft.com/office/drawing/2014/main" id="{50C9EDC0-CF2C-D605-F563-CA6EE3CE0EFE}"/>
               </a:ext>
             </a:extLst>
           </p:cNvPr>
@@ -4687,7 +4687,7 @@
           <p:cNvPr id="31" name="rule_features_recipes">
             <a:extLst>
               <a:ext uri="{FF2B5EF4-FFF2-40B4-BE49-F238E27FC236}">
-                <a16:creationId xmlns:a16="http://schemas.microsoft.com/office/drawing/2014/main" id="{17D20FA8-B0C1-3B56-D386-F0D873A90F0B}"/>
+                <a16:creationId xmlns:a16="http://schemas.microsoft.com/office/drawing/2014/main" id="{77BD44DD-5865-98A7-60DB-A3904882A174}"/>
               </a:ext>
             </a:extLst>
           </p:cNvPr>
@@ -4730,7 +4730,7 @@
           <p:cNvPr id="32" name="rule_recipes_theme">
             <a:extLst>
               <a:ext uri="{FF2B5EF4-FFF2-40B4-BE49-F238E27FC236}">
-                <a16:creationId xmlns:a16="http://schemas.microsoft.com/office/drawing/2014/main" id="{BB80CEEA-7844-476F-6D85-1FA5B7825AAC}"/>
+                <a16:creationId xmlns:a16="http://schemas.microsoft.com/office/drawing/2014/main" id="{0099CF06-F486-C3C5-8171-3653138E5B5B}"/>
               </a:ext>
             </a:extLst>
           </p:cNvPr>
@@ -4773,7 +4773,7 @@
           <p:cNvPr id="33" name="rule_features_compose">
             <a:extLst>
               <a:ext uri="{FF2B5EF4-FFF2-40B4-BE49-F238E27FC236}">
-                <a16:creationId xmlns:a16="http://schemas.microsoft.com/office/drawing/2014/main" id="{3CA6E903-8BCB-5166-6199-586EB2D5439B}"/>
+                <a16:creationId xmlns:a16="http://schemas.microsoft.com/office/drawing/2014/main" id="{F22E1295-69D0-3850-0297-E2953743D9BD}"/>
               </a:ext>
             </a:extLst>
           </p:cNvPr>
@@ -4816,7 +4816,7 @@
           <p:cNvPr id="34" name="rule_recipes_objects">
             <a:extLst>
               <a:ext uri="{FF2B5EF4-FFF2-40B4-BE49-F238E27FC236}">
-                <a16:creationId xmlns:a16="http://schemas.microsoft.com/office/drawing/2014/main" id="{79641A3E-5BCB-301D-F842-D30D988DDC93}"/>
+                <a16:creationId xmlns:a16="http://schemas.microsoft.com/office/drawing/2014/main" id="{B2EED9AD-E00B-BBB4-6CB4-7CE3B9111D11}"/>
               </a:ext>
             </a:extLst>
           </p:cNvPr>
@@ -4859,7 +4859,7 @@
           <p:cNvPr id="35" name="rule_theme_decorate">
             <a:extLst>
               <a:ext uri="{FF2B5EF4-FFF2-40B4-BE49-F238E27FC236}">
-                <a16:creationId xmlns:a16="http://schemas.microsoft.com/office/drawing/2014/main" id="{0A11DBF1-C577-64DB-874E-1CE4FCE447AF}"/>
+                <a16:creationId xmlns:a16="http://schemas.microsoft.com/office/drawing/2014/main" id="{8CD5A6DC-410C-1C55-0929-16D2AFA517F1}"/>
               </a:ext>
             </a:extLst>
           </p:cNvPr>
@@ -4902,7 +4902,7 @@
           <p:cNvPr id="36" name="rule_compose_objects">
             <a:extLst>
               <a:ext uri="{FF2B5EF4-FFF2-40B4-BE49-F238E27FC236}">
-                <a16:creationId xmlns:a16="http://schemas.microsoft.com/office/drawing/2014/main" id="{00BD5917-7E6E-495F-4C3A-8D517C75D520}"/>
+                <a16:creationId xmlns:a16="http://schemas.microsoft.com/office/drawing/2014/main" id="{5E9B9B39-8559-9ED7-FA76-E210A3B6A58C}"/>
               </a:ext>
             </a:extLst>
           </p:cNvPr>
@@ -4945,7 +4945,7 @@
           <p:cNvPr id="37" name="rule_objects_decorate">
             <a:extLst>
               <a:ext uri="{FF2B5EF4-FFF2-40B4-BE49-F238E27FC236}">
-                <a16:creationId xmlns:a16="http://schemas.microsoft.com/office/drawing/2014/main" id="{A504134A-83E7-0887-5974-1E681AB657A8}"/>
+                <a16:creationId xmlns:a16="http://schemas.microsoft.com/office/drawing/2014/main" id="{352156E9-5719-15F2-9B53-33E9295BD7BD}"/>
               </a:ext>
             </a:extLst>
           </p:cNvPr>
@@ -4988,7 +4988,7 @@
           <p:cNvPr id="38" name="main_rules_styled_ir">
             <a:extLst>
               <a:ext uri="{FF2B5EF4-FFF2-40B4-BE49-F238E27FC236}">
-                <a16:creationId xmlns:a16="http://schemas.microsoft.com/office/drawing/2014/main" id="{8FEB8ACC-7F34-F3B9-036B-8B366137B47C}"/>
+                <a16:creationId xmlns:a16="http://schemas.microsoft.com/office/drawing/2014/main" id="{FE01184C-F1EB-AA0A-4CDB-51CF33C60D62}"/>
               </a:ext>
             </a:extLst>
           </p:cNvPr>
@@ -5031,7 +5031,7 @@
           <p:cNvPr id="39" name="main_styled_renderers">
             <a:extLst>
               <a:ext uri="{FF2B5EF4-FFF2-40B4-BE49-F238E27FC236}">
-                <a16:creationId xmlns:a16="http://schemas.microsoft.com/office/drawing/2014/main" id="{0AF80413-CAD0-33B0-5131-359255CA5A8B}"/>
+                <a16:creationId xmlns:a16="http://schemas.microsoft.com/office/drawing/2014/main" id="{4937D9DD-E24B-594F-F8F3-88E053DD8A3B}"/>
               </a:ext>
             </a:extLst>
           </p:cNvPr>
@@ -5074,7 +5074,7 @@
           <p:cNvPr id="40" name="validation_loop">
             <a:extLst>
               <a:ext uri="{FF2B5EF4-FFF2-40B4-BE49-F238E27FC236}">
-                <a16:creationId xmlns:a16="http://schemas.microsoft.com/office/drawing/2014/main" id="{B8FD94E9-E956-AEE6-5186-3DDE902B1D1A}"/>
+                <a16:creationId xmlns:a16="http://schemas.microsoft.com/office/drawing/2014/main" id="{F28E888B-D906-1E67-4D90-2D018137629A}"/>
               </a:ext>
             </a:extLst>
           </p:cNvPr>
@@ -5117,7 +5117,7 @@
           <p:cNvPr id="41" name="source_chip">
             <a:extLst>
               <a:ext uri="{FF2B5EF4-FFF2-40B4-BE49-F238E27FC236}">
-                <a16:creationId xmlns:a16="http://schemas.microsoft.com/office/drawing/2014/main" id="{71670E4E-AD97-0A36-4459-C70E9C294A17}"/>
+                <a16:creationId xmlns:a16="http://schemas.microsoft.com/office/drawing/2014/main" id="{BD88B740-6655-53EE-6F9F-76350581EC6C}"/>
               </a:ext>
             </a:extLst>
           </p:cNvPr>
@@ -5180,7 +5180,7 @@
           <p:cNvPr id="42" name="source_chip_text">
             <a:extLst>
               <a:ext uri="{FF2B5EF4-FFF2-40B4-BE49-F238E27FC236}">
-                <a16:creationId xmlns:a16="http://schemas.microsoft.com/office/drawing/2014/main" id="{87855D48-3541-7FA1-2180-9EEE59B00A1B}"/>
+                <a16:creationId xmlns:a16="http://schemas.microsoft.com/office/drawing/2014/main" id="{4A462A26-3726-6C78-9F5B-4A07BADC401E}"/>
               </a:ext>
             </a:extLst>
           </p:cNvPr>
@@ -5227,7 +5227,7 @@
           <p:cNvPr id="43" name="markdown_card">
             <a:extLst>
               <a:ext uri="{FF2B5EF4-FFF2-40B4-BE49-F238E27FC236}">
-                <a16:creationId xmlns:a16="http://schemas.microsoft.com/office/drawing/2014/main" id="{AD5B18E5-F5A2-A818-3A1F-E7DF815D82DC}"/>
+                <a16:creationId xmlns:a16="http://schemas.microsoft.com/office/drawing/2014/main" id="{CC7402D4-8DEC-9E55-6699-4CE2FD86FD22}"/>
               </a:ext>
             </a:extLst>
           </p:cNvPr>
@@ -5290,7 +5290,7 @@
           <p:cNvPr id="44" name="markdown_icon_dot">
             <a:extLst>
               <a:ext uri="{FF2B5EF4-FFF2-40B4-BE49-F238E27FC236}">
-                <a16:creationId xmlns:a16="http://schemas.microsoft.com/office/drawing/2014/main" id="{32F70DE0-0A02-FBD6-BF88-E6B6784AA532}"/>
+                <a16:creationId xmlns:a16="http://schemas.microsoft.com/office/drawing/2014/main" id="{11ABB2FB-AF4D-C62D-2BC4-BCBA0B24D5B1}"/>
               </a:ext>
             </a:extLst>
           </p:cNvPr>
@@ -5344,7 +5344,7 @@
           <p:cNvPr id="45" name="markdown_icon_label">
             <a:extLst>
               <a:ext uri="{FF2B5EF4-FFF2-40B4-BE49-F238E27FC236}">
-                <a16:creationId xmlns:a16="http://schemas.microsoft.com/office/drawing/2014/main" id="{020214C6-725A-E4CB-947C-4BB8AC1E3698}"/>
+                <a16:creationId xmlns:a16="http://schemas.microsoft.com/office/drawing/2014/main" id="{325404F3-B025-34D9-6000-EFB4B38A949D}"/>
               </a:ext>
             </a:extLst>
           </p:cNvPr>
@@ -5391,7 +5391,7 @@
           <p:cNvPr id="46" name="markdown_title">
             <a:extLst>
               <a:ext uri="{FF2B5EF4-FFF2-40B4-BE49-F238E27FC236}">
-                <a16:creationId xmlns:a16="http://schemas.microsoft.com/office/drawing/2014/main" id="{D50D4324-4348-E40F-F479-4993672D44DB}"/>
+                <a16:creationId xmlns:a16="http://schemas.microsoft.com/office/drawing/2014/main" id="{FB6154BA-D861-B737-C65F-DFB116349A20}"/>
               </a:ext>
             </a:extLst>
           </p:cNvPr>
@@ -5437,7 +5437,7 @@
           <p:cNvPr id="47" name="markdown_line_0">
             <a:extLst>
               <a:ext uri="{FF2B5EF4-FFF2-40B4-BE49-F238E27FC236}">
-                <a16:creationId xmlns:a16="http://schemas.microsoft.com/office/drawing/2014/main" id="{718A56CD-E826-B448-B8AE-F665F784B285}"/>
+                <a16:creationId xmlns:a16="http://schemas.microsoft.com/office/drawing/2014/main" id="{0178B4F7-4C10-F8F8-756F-F63F6CCFAB50}"/>
               </a:ext>
             </a:extLst>
           </p:cNvPr>
@@ -5483,7 +5483,7 @@
           <p:cNvPr id="48" name="markdown_line_1">
             <a:extLst>
               <a:ext uri="{FF2B5EF4-FFF2-40B4-BE49-F238E27FC236}">
-                <a16:creationId xmlns:a16="http://schemas.microsoft.com/office/drawing/2014/main" id="{61D573E8-1C34-A526-F679-5B0661EA2606}"/>
+                <a16:creationId xmlns:a16="http://schemas.microsoft.com/office/drawing/2014/main" id="{0A5DF803-A2E9-548C-BCAF-7C8CCAEA34C2}"/>
               </a:ext>
             </a:extLst>
           </p:cNvPr>
@@ -5529,7 +5529,7 @@
           <p:cNvPr id="49" name="splitter_card">
             <a:extLst>
               <a:ext uri="{FF2B5EF4-FFF2-40B4-BE49-F238E27FC236}">
-                <a16:creationId xmlns:a16="http://schemas.microsoft.com/office/drawing/2014/main" id="{E7BD497F-DA7E-9A9F-2611-0238D10B8034}"/>
+                <a16:creationId xmlns:a16="http://schemas.microsoft.com/office/drawing/2014/main" id="{9D1F83B9-F1E9-6DE8-C134-25DB20670FB4}"/>
               </a:ext>
             </a:extLst>
           </p:cNvPr>
@@ -5592,7 +5592,7 @@
           <p:cNvPr id="50" name="splitter_icon_dot">
             <a:extLst>
               <a:ext uri="{FF2B5EF4-FFF2-40B4-BE49-F238E27FC236}">
-                <a16:creationId xmlns:a16="http://schemas.microsoft.com/office/drawing/2014/main" id="{EAD3FDDB-B1CA-67F6-33DC-4F8EE7B4ECC2}"/>
+                <a16:creationId xmlns:a16="http://schemas.microsoft.com/office/drawing/2014/main" id="{9E6E00AD-860A-31C2-11A9-F6DD518B299A}"/>
               </a:ext>
             </a:extLst>
           </p:cNvPr>
@@ -5646,7 +5646,7 @@
           <p:cNvPr id="51" name="splitter_icon_label">
             <a:extLst>
               <a:ext uri="{FF2B5EF4-FFF2-40B4-BE49-F238E27FC236}">
-                <a16:creationId xmlns:a16="http://schemas.microsoft.com/office/drawing/2014/main" id="{1931CB0C-2063-EB1A-82D8-36756221E5CA}"/>
+                <a16:creationId xmlns:a16="http://schemas.microsoft.com/office/drawing/2014/main" id="{0DDBC473-F8AC-5AB8-48D1-9CA93086ED62}"/>
               </a:ext>
             </a:extLst>
           </p:cNvPr>
@@ -5693,7 +5693,7 @@
           <p:cNvPr id="52" name="splitter_title">
             <a:extLst>
               <a:ext uri="{FF2B5EF4-FFF2-40B4-BE49-F238E27FC236}">
-                <a16:creationId xmlns:a16="http://schemas.microsoft.com/office/drawing/2014/main" id="{FB005FBB-8C2B-CAA9-2B8A-DB4526C79D98}"/>
+                <a16:creationId xmlns:a16="http://schemas.microsoft.com/office/drawing/2014/main" id="{594031DC-CD7B-EF21-3077-2E49BB8BA8A9}"/>
               </a:ext>
             </a:extLst>
           </p:cNvPr>
@@ -5739,7 +5739,7 @@
           <p:cNvPr id="53" name="splitter_line_0">
             <a:extLst>
               <a:ext uri="{FF2B5EF4-FFF2-40B4-BE49-F238E27FC236}">
-                <a16:creationId xmlns:a16="http://schemas.microsoft.com/office/drawing/2014/main" id="{E58F6431-D221-5727-D788-9E6F02FC3EA3}"/>
+                <a16:creationId xmlns:a16="http://schemas.microsoft.com/office/drawing/2014/main" id="{46535F6D-C71A-12DF-B4BF-DD9384638169}"/>
               </a:ext>
             </a:extLst>
           </p:cNvPr>
@@ -5785,7 +5785,7 @@
           <p:cNvPr id="54" name="splitter_line_1">
             <a:extLst>
               <a:ext uri="{FF2B5EF4-FFF2-40B4-BE49-F238E27FC236}">
-                <a16:creationId xmlns:a16="http://schemas.microsoft.com/office/drawing/2014/main" id="{D598DCC2-2362-9797-1BE9-3B3D21E4BC17}"/>
+                <a16:creationId xmlns:a16="http://schemas.microsoft.com/office/drawing/2014/main" id="{73B57153-12AF-2411-A090-71FE550EE98E}"/>
               </a:ext>
             </a:extLst>
           </p:cNvPr>
@@ -5831,7 +5831,7 @@
           <p:cNvPr id="55" name="ir_core_card">
             <a:extLst>
               <a:ext uri="{FF2B5EF4-FFF2-40B4-BE49-F238E27FC236}">
-                <a16:creationId xmlns:a16="http://schemas.microsoft.com/office/drawing/2014/main" id="{64188A96-9822-5A3A-2BDC-63AD671FEA4F}"/>
+                <a16:creationId xmlns:a16="http://schemas.microsoft.com/office/drawing/2014/main" id="{3193F464-88C7-4330-B15C-8B8E1F759BA0}"/>
               </a:ext>
             </a:extLst>
           </p:cNvPr>
@@ -5894,7 +5894,7 @@
           <p:cNvPr id="56" name="ir_core_icon_dot">
             <a:extLst>
               <a:ext uri="{FF2B5EF4-FFF2-40B4-BE49-F238E27FC236}">
-                <a16:creationId xmlns:a16="http://schemas.microsoft.com/office/drawing/2014/main" id="{435B1B2B-AA22-98B4-BE07-7FC16AA31726}"/>
+                <a16:creationId xmlns:a16="http://schemas.microsoft.com/office/drawing/2014/main" id="{D0C792A0-EE86-08C2-7408-F3149DE1E2BB}"/>
               </a:ext>
             </a:extLst>
           </p:cNvPr>
@@ -5948,7 +5948,7 @@
           <p:cNvPr id="57" name="ir_core_icon_label">
             <a:extLst>
               <a:ext uri="{FF2B5EF4-FFF2-40B4-BE49-F238E27FC236}">
-                <a16:creationId xmlns:a16="http://schemas.microsoft.com/office/drawing/2014/main" id="{F25ACC7D-430A-99E8-E8B3-C78358E73DE9}"/>
+                <a16:creationId xmlns:a16="http://schemas.microsoft.com/office/drawing/2014/main" id="{73F9675C-5992-B8F7-CA93-A23012B06F65}"/>
               </a:ext>
             </a:extLst>
           </p:cNvPr>
@@ -5995,7 +5995,7 @@
           <p:cNvPr id="58" name="ir_core_title">
             <a:extLst>
               <a:ext uri="{FF2B5EF4-FFF2-40B4-BE49-F238E27FC236}">
-                <a16:creationId xmlns:a16="http://schemas.microsoft.com/office/drawing/2014/main" id="{85601D28-97FA-E3D7-625A-80C8DB49F373}"/>
+                <a16:creationId xmlns:a16="http://schemas.microsoft.com/office/drawing/2014/main" id="{65025D87-F364-6BDD-0D11-2972A88985E7}"/>
               </a:ext>
             </a:extLst>
           </p:cNvPr>
@@ -6041,7 +6041,7 @@
           <p:cNvPr id="59" name="ir_core_line_0">
             <a:extLst>
               <a:ext uri="{FF2B5EF4-FFF2-40B4-BE49-F238E27FC236}">
-                <a16:creationId xmlns:a16="http://schemas.microsoft.com/office/drawing/2014/main" id="{AF2FC9AC-0996-14F7-9342-849A23797D80}"/>
+                <a16:creationId xmlns:a16="http://schemas.microsoft.com/office/drawing/2014/main" id="{9D9625DB-6E4E-1BA9-8E84-D986BC43978B}"/>
               </a:ext>
             </a:extLst>
           </p:cNvPr>
@@ -6087,7 +6087,7 @@
           <p:cNvPr id="60" name="ir_core_line_1">
             <a:extLst>
               <a:ext uri="{FF2B5EF4-FFF2-40B4-BE49-F238E27FC236}">
-                <a16:creationId xmlns:a16="http://schemas.microsoft.com/office/drawing/2014/main" id="{EAED34BC-ED86-763D-362F-F8648AE31D46}"/>
+                <a16:creationId xmlns:a16="http://schemas.microsoft.com/office/drawing/2014/main" id="{E01882F5-4742-881E-433F-4F8C0D549064}"/>
               </a:ext>
             </a:extLst>
           </p:cNvPr>
@@ -6133,7 +6133,7 @@
           <p:cNvPr id="61" name="reasoning_card">
             <a:extLst>
               <a:ext uri="{FF2B5EF4-FFF2-40B4-BE49-F238E27FC236}">
-                <a16:creationId xmlns:a16="http://schemas.microsoft.com/office/drawing/2014/main" id="{BDB556A3-143E-20D1-91A3-3BD9B1779ADD}"/>
+                <a16:creationId xmlns:a16="http://schemas.microsoft.com/office/drawing/2014/main" id="{3F78DFD8-DE83-5DF4-CCA8-D763BBE16B58}"/>
               </a:ext>
             </a:extLst>
           </p:cNvPr>
@@ -6196,7 +6196,7 @@
           <p:cNvPr id="62" name="reasoning_icon_dot">
             <a:extLst>
               <a:ext uri="{FF2B5EF4-FFF2-40B4-BE49-F238E27FC236}">
-                <a16:creationId xmlns:a16="http://schemas.microsoft.com/office/drawing/2014/main" id="{660A2FBA-AEA5-42B3-FC35-6D71A6D7CD35}"/>
+                <a16:creationId xmlns:a16="http://schemas.microsoft.com/office/drawing/2014/main" id="{554A17DC-BB96-A4F4-267C-F90117173A6B}"/>
               </a:ext>
             </a:extLst>
           </p:cNvPr>
@@ -6250,7 +6250,7 @@
           <p:cNvPr id="63" name="reasoning_icon_label">
             <a:extLst>
               <a:ext uri="{FF2B5EF4-FFF2-40B4-BE49-F238E27FC236}">
-                <a16:creationId xmlns:a16="http://schemas.microsoft.com/office/drawing/2014/main" id="{5485074D-2806-CBE3-F26E-4AF53D1AA22C}"/>
+                <a16:creationId xmlns:a16="http://schemas.microsoft.com/office/drawing/2014/main" id="{AFAC66E8-E253-5604-D409-838675E85E8E}"/>
               </a:ext>
             </a:extLst>
           </p:cNvPr>
@@ -6297,7 +6297,7 @@
           <p:cNvPr id="64" name="reasoning_title">
             <a:extLst>
               <a:ext uri="{FF2B5EF4-FFF2-40B4-BE49-F238E27FC236}">
-                <a16:creationId xmlns:a16="http://schemas.microsoft.com/office/drawing/2014/main" id="{6AB1AA79-C047-D5A5-5B46-625C86D5CEF3}"/>
+                <a16:creationId xmlns:a16="http://schemas.microsoft.com/office/drawing/2014/main" id="{487EF316-7A19-54B5-3C5F-594B929CB220}"/>
               </a:ext>
             </a:extLst>
           </p:cNvPr>
@@ -6343,7 +6343,7 @@
           <p:cNvPr id="65" name="reasoning_line_0">
             <a:extLst>
               <a:ext uri="{FF2B5EF4-FFF2-40B4-BE49-F238E27FC236}">
-                <a16:creationId xmlns:a16="http://schemas.microsoft.com/office/drawing/2014/main" id="{861E87AD-2A2D-7AE0-CF66-6DB295DA279F}"/>
+                <a16:creationId xmlns:a16="http://schemas.microsoft.com/office/drawing/2014/main" id="{6AC4823F-422E-C398-B16E-0418DA4A8F6F}"/>
               </a:ext>
             </a:extLst>
           </p:cNvPr>
@@ -6389,7 +6389,7 @@
           <p:cNvPr id="66" name="reasoning_guard">
             <a:extLst>
               <a:ext uri="{FF2B5EF4-FFF2-40B4-BE49-F238E27FC236}">
-                <a16:creationId xmlns:a16="http://schemas.microsoft.com/office/drawing/2014/main" id="{62DE25E4-B8EE-5C35-D428-F2C923A9EBBD}"/>
+                <a16:creationId xmlns:a16="http://schemas.microsoft.com/office/drawing/2014/main" id="{C0D81ADC-DC35-F98D-D6F8-8D62D75FB5A6}"/>
               </a:ext>
             </a:extLst>
           </p:cNvPr>
@@ -6452,7 +6452,7 @@
           <p:cNvPr id="67" name="reasoning_guard_text">
             <a:extLst>
               <a:ext uri="{FF2B5EF4-FFF2-40B4-BE49-F238E27FC236}">
-                <a16:creationId xmlns:a16="http://schemas.microsoft.com/office/drawing/2014/main" id="{330D95F9-985F-953B-D703-2B9A7E5F02EC}"/>
+                <a16:creationId xmlns:a16="http://schemas.microsoft.com/office/drawing/2014/main" id="{A58EA47E-025F-093F-F3AA-8B69F2B542D6}"/>
               </a:ext>
             </a:extLst>
           </p:cNvPr>
@@ -6499,7 +6499,7 @@
           <p:cNvPr id="68" name="reasoning_limit">
             <a:extLst>
               <a:ext uri="{FF2B5EF4-FFF2-40B4-BE49-F238E27FC236}">
-                <a16:creationId xmlns:a16="http://schemas.microsoft.com/office/drawing/2014/main" id="{F78B4B27-BBC6-69AF-AB34-D58B3C2F6B99}"/>
+                <a16:creationId xmlns:a16="http://schemas.microsoft.com/office/drawing/2014/main" id="{7B5E9F9F-AD38-7C28-A3DE-96AFFC7B4C4A}"/>
               </a:ext>
             </a:extLst>
           </p:cNvPr>
@@ -6545,7 +6545,7 @@
           <p:cNvPr id="69" name="rule_engine_card">
             <a:extLst>
               <a:ext uri="{FF2B5EF4-FFF2-40B4-BE49-F238E27FC236}">
-                <a16:creationId xmlns:a16="http://schemas.microsoft.com/office/drawing/2014/main" id="{FFB12D10-9820-116A-1F95-D9646FADE03A}"/>
+                <a16:creationId xmlns:a16="http://schemas.microsoft.com/office/drawing/2014/main" id="{B0394AF3-5D8B-A06D-C684-E249587DAED4}"/>
               </a:ext>
             </a:extLst>
           </p:cNvPr>
@@ -6608,7 +6608,7 @@
           <p:cNvPr id="70" name="rule_engine_title">
             <a:extLst>
               <a:ext uri="{FF2B5EF4-FFF2-40B4-BE49-F238E27FC236}">
-                <a16:creationId xmlns:a16="http://schemas.microsoft.com/office/drawing/2014/main" id="{AAEE0978-8BD3-FED0-6341-2331E2DE5314}"/>
+                <a16:creationId xmlns:a16="http://schemas.microsoft.com/office/drawing/2014/main" id="{19E33451-E463-295B-C43A-4E7DC3CCBF20}"/>
               </a:ext>
             </a:extLst>
           </p:cNvPr>
@@ -6654,7 +6654,7 @@
           <p:cNvPr id="71" name="rule_engine_body">
             <a:extLst>
               <a:ext uri="{FF2B5EF4-FFF2-40B4-BE49-F238E27FC236}">
-                <a16:creationId xmlns:a16="http://schemas.microsoft.com/office/drawing/2014/main" id="{444C2A7E-D56F-FDDB-422F-395D99576AE4}"/>
+                <a16:creationId xmlns:a16="http://schemas.microsoft.com/office/drawing/2014/main" id="{9A1C93FC-17E6-82D3-9265-898BC89EC5C9}"/>
               </a:ext>
             </a:extLst>
           </p:cNvPr>
@@ -6700,7 +6700,7 @@
           <p:cNvPr id="72" name="features_card">
             <a:extLst>
               <a:ext uri="{FF2B5EF4-FFF2-40B4-BE49-F238E27FC236}">
-                <a16:creationId xmlns:a16="http://schemas.microsoft.com/office/drawing/2014/main" id="{5CC2B4B9-8947-F6A8-5559-5EA8C23362EB}"/>
+                <a16:creationId xmlns:a16="http://schemas.microsoft.com/office/drawing/2014/main" id="{FB7BA22B-A065-2685-ACFA-A8F7660E1B95}"/>
               </a:ext>
             </a:extLst>
           </p:cNvPr>
@@ -6763,7 +6763,7 @@
           <p:cNvPr id="73" name="features_icon_dot">
             <a:extLst>
               <a:ext uri="{FF2B5EF4-FFF2-40B4-BE49-F238E27FC236}">
-                <a16:creationId xmlns:a16="http://schemas.microsoft.com/office/drawing/2014/main" id="{0446AA2D-69E6-A33E-3E94-2858E1A2231A}"/>
+                <a16:creationId xmlns:a16="http://schemas.microsoft.com/office/drawing/2014/main" id="{C91FB2D4-E98D-F034-A436-3A06146CE474}"/>
               </a:ext>
             </a:extLst>
           </p:cNvPr>
@@ -6817,7 +6817,7 @@
           <p:cNvPr id="74" name="features_icon_label">
             <a:extLst>
               <a:ext uri="{FF2B5EF4-FFF2-40B4-BE49-F238E27FC236}">
-                <a16:creationId xmlns:a16="http://schemas.microsoft.com/office/drawing/2014/main" id="{E8F18958-6119-62C0-4777-FD374B679735}"/>
+                <a16:creationId xmlns:a16="http://schemas.microsoft.com/office/drawing/2014/main" id="{57D8FDC3-B1E7-0791-A018-85C044D7AB5C}"/>
               </a:ext>
             </a:extLst>
           </p:cNvPr>
@@ -6864,7 +6864,7 @@
           <p:cNvPr id="75" name="features_title">
             <a:extLst>
               <a:ext uri="{FF2B5EF4-FFF2-40B4-BE49-F238E27FC236}">
-                <a16:creationId xmlns:a16="http://schemas.microsoft.com/office/drawing/2014/main" id="{804D787B-0131-F0D8-BA59-565E281C7B40}"/>
+                <a16:creationId xmlns:a16="http://schemas.microsoft.com/office/drawing/2014/main" id="{4BC342DC-EF1B-E1AC-69EC-DCA55F380E69}"/>
               </a:ext>
             </a:extLst>
           </p:cNvPr>
@@ -6910,7 +6910,7 @@
           <p:cNvPr id="76" name="features_line_0">
             <a:extLst>
               <a:ext uri="{FF2B5EF4-FFF2-40B4-BE49-F238E27FC236}">
-                <a16:creationId xmlns:a16="http://schemas.microsoft.com/office/drawing/2014/main" id="{179358D2-83CC-3581-827A-65CAF02A89DB}"/>
+                <a16:creationId xmlns:a16="http://schemas.microsoft.com/office/drawing/2014/main" id="{8A6839CE-0F4A-653E-9722-2CEBFE3734B6}"/>
               </a:ext>
             </a:extLst>
           </p:cNvPr>
@@ -6956,7 +6956,7 @@
           <p:cNvPr id="77" name="features_line_1">
             <a:extLst>
               <a:ext uri="{FF2B5EF4-FFF2-40B4-BE49-F238E27FC236}">
-                <a16:creationId xmlns:a16="http://schemas.microsoft.com/office/drawing/2014/main" id="{87A43A2F-DCF6-2568-EF5D-C82BDD11FE2F}"/>
+                <a16:creationId xmlns:a16="http://schemas.microsoft.com/office/drawing/2014/main" id="{57A57BC1-273F-9482-B3A9-4E39AE868213}"/>
               </a:ext>
             </a:extLst>
           </p:cNvPr>
@@ -7002,7 +7002,7 @@
           <p:cNvPr id="78" name="recipes_card">
             <a:extLst>
               <a:ext uri="{FF2B5EF4-FFF2-40B4-BE49-F238E27FC236}">
-                <a16:creationId xmlns:a16="http://schemas.microsoft.com/office/drawing/2014/main" id="{E9C9802E-C02F-5E94-D264-3A974F9E0CE3}"/>
+                <a16:creationId xmlns:a16="http://schemas.microsoft.com/office/drawing/2014/main" id="{61A7B2C5-3602-44D5-C9C9-BA7959DB0350}"/>
               </a:ext>
             </a:extLst>
           </p:cNvPr>
@@ -7065,7 +7065,7 @@
           <p:cNvPr id="79" name="recipes_icon_dot">
             <a:extLst>
               <a:ext uri="{FF2B5EF4-FFF2-40B4-BE49-F238E27FC236}">
-                <a16:creationId xmlns:a16="http://schemas.microsoft.com/office/drawing/2014/main" id="{F67034B3-14B6-F0DE-C3F8-69EC02776383}"/>
+                <a16:creationId xmlns:a16="http://schemas.microsoft.com/office/drawing/2014/main" id="{089B76B4-C689-983A-FB8E-C5965200D669}"/>
               </a:ext>
             </a:extLst>
           </p:cNvPr>
@@ -7119,7 +7119,7 @@
           <p:cNvPr id="80" name="recipes_icon_label">
             <a:extLst>
               <a:ext uri="{FF2B5EF4-FFF2-40B4-BE49-F238E27FC236}">
-                <a16:creationId xmlns:a16="http://schemas.microsoft.com/office/drawing/2014/main" id="{7A6265CE-75A6-7CE3-9158-F31C1FD05582}"/>
+                <a16:creationId xmlns:a16="http://schemas.microsoft.com/office/drawing/2014/main" id="{97C18FAE-8D18-39F3-47F1-33365CC15BC6}"/>
               </a:ext>
             </a:extLst>
           </p:cNvPr>
@@ -7166,7 +7166,7 @@
           <p:cNvPr id="81" name="recipes_title">
             <a:extLst>
               <a:ext uri="{FF2B5EF4-FFF2-40B4-BE49-F238E27FC236}">
-                <a16:creationId xmlns:a16="http://schemas.microsoft.com/office/drawing/2014/main" id="{5F5D5136-C27C-BC91-6CF9-6097A0B983F9}"/>
+                <a16:creationId xmlns:a16="http://schemas.microsoft.com/office/drawing/2014/main" id="{931657E4-C68B-A208-78CE-7F86BB240B21}"/>
               </a:ext>
             </a:extLst>
           </p:cNvPr>
@@ -7212,7 +7212,7 @@
           <p:cNvPr id="82" name="recipes_line_0">
             <a:extLst>
               <a:ext uri="{FF2B5EF4-FFF2-40B4-BE49-F238E27FC236}">
-                <a16:creationId xmlns:a16="http://schemas.microsoft.com/office/drawing/2014/main" id="{3834542B-F517-6351-B80A-739153E6F21E}"/>
+                <a16:creationId xmlns:a16="http://schemas.microsoft.com/office/drawing/2014/main" id="{9049DD6E-9415-1F36-5BA5-F2FDA129B374}"/>
               </a:ext>
             </a:extLst>
           </p:cNvPr>
@@ -7258,7 +7258,7 @@
           <p:cNvPr id="83" name="recipes_line_1">
             <a:extLst>
               <a:ext uri="{FF2B5EF4-FFF2-40B4-BE49-F238E27FC236}">
-                <a16:creationId xmlns:a16="http://schemas.microsoft.com/office/drawing/2014/main" id="{9EE72946-942E-561C-D746-70B076B66AA8}"/>
+                <a16:creationId xmlns:a16="http://schemas.microsoft.com/office/drawing/2014/main" id="{607DA9AE-F76A-7E67-4BBA-17A590F9328E}"/>
               </a:ext>
             </a:extLst>
           </p:cNvPr>
@@ -7304,7 +7304,7 @@
           <p:cNvPr id="84" name="theme_card">
             <a:extLst>
               <a:ext uri="{FF2B5EF4-FFF2-40B4-BE49-F238E27FC236}">
-                <a16:creationId xmlns:a16="http://schemas.microsoft.com/office/drawing/2014/main" id="{4AE14BC6-2301-C321-D621-0449E0BDC32D}"/>
+                <a16:creationId xmlns:a16="http://schemas.microsoft.com/office/drawing/2014/main" id="{809F5DD8-B123-9761-1705-57D3C07E0224}"/>
               </a:ext>
             </a:extLst>
           </p:cNvPr>
@@ -7367,7 +7367,7 @@
           <p:cNvPr id="85" name="theme_icon_dot">
             <a:extLst>
               <a:ext uri="{FF2B5EF4-FFF2-40B4-BE49-F238E27FC236}">
-                <a16:creationId xmlns:a16="http://schemas.microsoft.com/office/drawing/2014/main" id="{572554FF-0A03-E1EE-E491-227878B416BA}"/>
+                <a16:creationId xmlns:a16="http://schemas.microsoft.com/office/drawing/2014/main" id="{8603C132-C629-879B-4EBC-E7F912067D24}"/>
               </a:ext>
             </a:extLst>
           </p:cNvPr>
@@ -7421,7 +7421,7 @@
           <p:cNvPr id="86" name="theme_icon_label">
             <a:extLst>
               <a:ext uri="{FF2B5EF4-FFF2-40B4-BE49-F238E27FC236}">
-                <a16:creationId xmlns:a16="http://schemas.microsoft.com/office/drawing/2014/main" id="{1FBD42C7-4176-F7E0-FD6B-71093B2F0EE9}"/>
+                <a16:creationId xmlns:a16="http://schemas.microsoft.com/office/drawing/2014/main" id="{AE14F092-1B5C-7638-3941-28A0C7CDEC80}"/>
               </a:ext>
             </a:extLst>
           </p:cNvPr>
@@ -7468,7 +7468,7 @@
           <p:cNvPr id="87" name="theme_title">
             <a:extLst>
               <a:ext uri="{FF2B5EF4-FFF2-40B4-BE49-F238E27FC236}">
-                <a16:creationId xmlns:a16="http://schemas.microsoft.com/office/drawing/2014/main" id="{BA14FB26-C0EC-7028-38D4-EF6EFFADCD3D}"/>
+                <a16:creationId xmlns:a16="http://schemas.microsoft.com/office/drawing/2014/main" id="{FC8D6B82-6C32-D846-90BA-C61FD32833FB}"/>
               </a:ext>
             </a:extLst>
           </p:cNvPr>
@@ -7514,7 +7514,7 @@
           <p:cNvPr id="88" name="theme_line_0">
             <a:extLst>
               <a:ext uri="{FF2B5EF4-FFF2-40B4-BE49-F238E27FC236}">
-                <a16:creationId xmlns:a16="http://schemas.microsoft.com/office/drawing/2014/main" id="{CB4411CC-4350-3661-3416-7605EF4B73D1}"/>
+                <a16:creationId xmlns:a16="http://schemas.microsoft.com/office/drawing/2014/main" id="{0DE6E92D-3058-D8A0-9131-6405981E4A43}"/>
               </a:ext>
             </a:extLst>
           </p:cNvPr>
@@ -7560,7 +7560,7 @@
           <p:cNvPr id="89" name="theme_line_1">
             <a:extLst>
               <a:ext uri="{FF2B5EF4-FFF2-40B4-BE49-F238E27FC236}">
-                <a16:creationId xmlns:a16="http://schemas.microsoft.com/office/drawing/2014/main" id="{14430741-CD17-0CC7-E5E1-36B9B0B8E7E0}"/>
+                <a16:creationId xmlns:a16="http://schemas.microsoft.com/office/drawing/2014/main" id="{9D799DE0-C6CA-67A3-BB26-DA1E180F9A36}"/>
               </a:ext>
             </a:extLst>
           </p:cNvPr>
@@ -7606,7 +7606,7 @@
           <p:cNvPr id="90" name="compose_card">
             <a:extLst>
               <a:ext uri="{FF2B5EF4-FFF2-40B4-BE49-F238E27FC236}">
-                <a16:creationId xmlns:a16="http://schemas.microsoft.com/office/drawing/2014/main" id="{E125A966-DC5A-C091-82CD-739ECCA8D155}"/>
+                <a16:creationId xmlns:a16="http://schemas.microsoft.com/office/drawing/2014/main" id="{F87CA34C-B5DF-5BAD-06C4-C3F5C66DF519}"/>
               </a:ext>
             </a:extLst>
           </p:cNvPr>
@@ -7669,7 +7669,7 @@
           <p:cNvPr id="91" name="compose_icon_dot">
             <a:extLst>
               <a:ext uri="{FF2B5EF4-FFF2-40B4-BE49-F238E27FC236}">
-                <a16:creationId xmlns:a16="http://schemas.microsoft.com/office/drawing/2014/main" id="{AE3CD39E-9200-D5DE-A0F2-47EDCED2741A}"/>
+                <a16:creationId xmlns:a16="http://schemas.microsoft.com/office/drawing/2014/main" id="{CB9483C5-70D8-FC8D-9F79-1B70970D275E}"/>
               </a:ext>
             </a:extLst>
           </p:cNvPr>
@@ -7723,7 +7723,7 @@
           <p:cNvPr id="92" name="compose_icon_label">
             <a:extLst>
               <a:ext uri="{FF2B5EF4-FFF2-40B4-BE49-F238E27FC236}">
-                <a16:creationId xmlns:a16="http://schemas.microsoft.com/office/drawing/2014/main" id="{C682F05D-99C2-CD0F-6A3E-0BC6CC55211E}"/>
+                <a16:creationId xmlns:a16="http://schemas.microsoft.com/office/drawing/2014/main" id="{75A18E84-E69A-63D4-8985-F2B0D93B6F4E}"/>
               </a:ext>
             </a:extLst>
           </p:cNvPr>
@@ -7770,7 +7770,7 @@
           <p:cNvPr id="93" name="compose_title">
             <a:extLst>
               <a:ext uri="{FF2B5EF4-FFF2-40B4-BE49-F238E27FC236}">
-                <a16:creationId xmlns:a16="http://schemas.microsoft.com/office/drawing/2014/main" id="{29C798BF-2AED-86DE-9A15-BB38B8A23B57}"/>
+                <a16:creationId xmlns:a16="http://schemas.microsoft.com/office/drawing/2014/main" id="{4E1D927C-CB95-D607-205E-19C612B37BFA}"/>
               </a:ext>
             </a:extLst>
           </p:cNvPr>
@@ -7816,7 +7816,7 @@
           <p:cNvPr id="94" name="compose_line_0">
             <a:extLst>
               <a:ext uri="{FF2B5EF4-FFF2-40B4-BE49-F238E27FC236}">
-                <a16:creationId xmlns:a16="http://schemas.microsoft.com/office/drawing/2014/main" id="{0124EF60-D48A-EA96-E214-769F3BA20B73}"/>
+                <a16:creationId xmlns:a16="http://schemas.microsoft.com/office/drawing/2014/main" id="{A68C9AEB-4D9B-E974-9696-4885972AC608}"/>
               </a:ext>
             </a:extLst>
           </p:cNvPr>
@@ -7862,7 +7862,7 @@
           <p:cNvPr id="95" name="compose_line_1">
             <a:extLst>
               <a:ext uri="{FF2B5EF4-FFF2-40B4-BE49-F238E27FC236}">
-                <a16:creationId xmlns:a16="http://schemas.microsoft.com/office/drawing/2014/main" id="{CC17FCEA-EB95-2629-4FE9-FC03E28B01B1}"/>
+                <a16:creationId xmlns:a16="http://schemas.microsoft.com/office/drawing/2014/main" id="{B8876CEE-1640-C4D7-E00C-577445BC05E3}"/>
               </a:ext>
             </a:extLst>
           </p:cNvPr>
@@ -7908,7 +7908,7 @@
           <p:cNvPr id="96" name="objects_card">
             <a:extLst>
               <a:ext uri="{FF2B5EF4-FFF2-40B4-BE49-F238E27FC236}">
-                <a16:creationId xmlns:a16="http://schemas.microsoft.com/office/drawing/2014/main" id="{EF8B83B2-CAE8-3466-6B48-18DA818388AB}"/>
+                <a16:creationId xmlns:a16="http://schemas.microsoft.com/office/drawing/2014/main" id="{264BA856-E567-D162-D3BB-0F55DC796523}"/>
               </a:ext>
             </a:extLst>
           </p:cNvPr>
@@ -7971,7 +7971,7 @@
           <p:cNvPr id="97" name="objects_icon_dot">
             <a:extLst>
               <a:ext uri="{FF2B5EF4-FFF2-40B4-BE49-F238E27FC236}">
-                <a16:creationId xmlns:a16="http://schemas.microsoft.com/office/drawing/2014/main" id="{4992EB2F-B54B-7349-7217-ADF83345F90E}"/>
+                <a16:creationId xmlns:a16="http://schemas.microsoft.com/office/drawing/2014/main" id="{90D66807-60AA-ADF8-5870-F9D371637A36}"/>
               </a:ext>
             </a:extLst>
           </p:cNvPr>
@@ -8025,7 +8025,7 @@
           <p:cNvPr id="98" name="objects_icon_label">
             <a:extLst>
               <a:ext uri="{FF2B5EF4-FFF2-40B4-BE49-F238E27FC236}">
-                <a16:creationId xmlns:a16="http://schemas.microsoft.com/office/drawing/2014/main" id="{2324F3C8-D8B7-719F-ADA0-F0C9552AC43D}"/>
+                <a16:creationId xmlns:a16="http://schemas.microsoft.com/office/drawing/2014/main" id="{F362FAF9-058E-7FA8-3D2A-FFF3563419D5}"/>
               </a:ext>
             </a:extLst>
           </p:cNvPr>
@@ -8072,7 +8072,7 @@
           <p:cNvPr id="99" name="objects_title">
             <a:extLst>
               <a:ext uri="{FF2B5EF4-FFF2-40B4-BE49-F238E27FC236}">
-                <a16:creationId xmlns:a16="http://schemas.microsoft.com/office/drawing/2014/main" id="{4F439B8E-9669-518A-A962-3F476B1D4213}"/>
+                <a16:creationId xmlns:a16="http://schemas.microsoft.com/office/drawing/2014/main" id="{6C1A9AFD-E280-FE33-D3B0-12E08DF895FE}"/>
               </a:ext>
             </a:extLst>
           </p:cNvPr>
@@ -8118,7 +8118,7 @@
           <p:cNvPr id="100" name="objects_line_0">
             <a:extLst>
               <a:ext uri="{FF2B5EF4-FFF2-40B4-BE49-F238E27FC236}">
-                <a16:creationId xmlns:a16="http://schemas.microsoft.com/office/drawing/2014/main" id="{C6CD8187-13DA-98FB-B7CA-74A987F3E91F}"/>
+                <a16:creationId xmlns:a16="http://schemas.microsoft.com/office/drawing/2014/main" id="{F913BBEB-8DD4-94CC-65D0-5E41EB5D497E}"/>
               </a:ext>
             </a:extLst>
           </p:cNvPr>
@@ -8164,7 +8164,7 @@
           <p:cNvPr id="101" name="objects_line_1">
             <a:extLst>
               <a:ext uri="{FF2B5EF4-FFF2-40B4-BE49-F238E27FC236}">
-                <a16:creationId xmlns:a16="http://schemas.microsoft.com/office/drawing/2014/main" id="{922C9BE8-E708-CBCA-E711-A2E78840A748}"/>
+                <a16:creationId xmlns:a16="http://schemas.microsoft.com/office/drawing/2014/main" id="{2F97EFAD-39DE-D982-66E8-0543850BC361}"/>
               </a:ext>
             </a:extLst>
           </p:cNvPr>
@@ -8210,7 +8210,7 @@
           <p:cNvPr id="102" name="decorate_card">
             <a:extLst>
               <a:ext uri="{FF2B5EF4-FFF2-40B4-BE49-F238E27FC236}">
-                <a16:creationId xmlns:a16="http://schemas.microsoft.com/office/drawing/2014/main" id="{FCC185D2-B74A-E470-B9EE-ABCE21D0F5CC}"/>
+                <a16:creationId xmlns:a16="http://schemas.microsoft.com/office/drawing/2014/main" id="{364581D2-6B54-0748-7DED-BDEA2AE5216A}"/>
               </a:ext>
             </a:extLst>
           </p:cNvPr>
@@ -8273,7 +8273,7 @@
           <p:cNvPr id="103" name="decorate_icon_dot">
             <a:extLst>
               <a:ext uri="{FF2B5EF4-FFF2-40B4-BE49-F238E27FC236}">
-                <a16:creationId xmlns:a16="http://schemas.microsoft.com/office/drawing/2014/main" id="{A5693CBA-2671-C952-51CD-CB365D1770BB}"/>
+                <a16:creationId xmlns:a16="http://schemas.microsoft.com/office/drawing/2014/main" id="{34711A12-AD4C-D023-099A-85CFAE2426A2}"/>
               </a:ext>
             </a:extLst>
           </p:cNvPr>
@@ -8327,7 +8327,7 @@
           <p:cNvPr id="104" name="decorate_icon_label">
             <a:extLst>
               <a:ext uri="{FF2B5EF4-FFF2-40B4-BE49-F238E27FC236}">
-                <a16:creationId xmlns:a16="http://schemas.microsoft.com/office/drawing/2014/main" id="{4595748E-61C5-603A-4B53-5CF518451E85}"/>
+                <a16:creationId xmlns:a16="http://schemas.microsoft.com/office/drawing/2014/main" id="{5BE4AF1E-BEA9-B1BC-9138-C8900F853C64}"/>
               </a:ext>
             </a:extLst>
           </p:cNvPr>
@@ -8374,7 +8374,7 @@
           <p:cNvPr id="105" name="decorate_title">
             <a:extLst>
               <a:ext uri="{FF2B5EF4-FFF2-40B4-BE49-F238E27FC236}">
-                <a16:creationId xmlns:a16="http://schemas.microsoft.com/office/drawing/2014/main" id="{4E307F0D-0E7C-5399-546A-1DC105EFA8B7}"/>
+                <a16:creationId xmlns:a16="http://schemas.microsoft.com/office/drawing/2014/main" id="{C3770C47-68AC-34CC-C538-34953564D6E3}"/>
               </a:ext>
             </a:extLst>
           </p:cNvPr>
@@ -8420,7 +8420,7 @@
           <p:cNvPr id="106" name="decorate_line_0">
             <a:extLst>
               <a:ext uri="{FF2B5EF4-FFF2-40B4-BE49-F238E27FC236}">
-                <a16:creationId xmlns:a16="http://schemas.microsoft.com/office/drawing/2014/main" id="{134B588E-C1A4-76AF-C2B9-9960821BB2C8}"/>
+                <a16:creationId xmlns:a16="http://schemas.microsoft.com/office/drawing/2014/main" id="{1DE748D5-2C9D-D505-2238-DD98759325F6}"/>
               </a:ext>
             </a:extLst>
           </p:cNvPr>
@@ -8466,7 +8466,7 @@
           <p:cNvPr id="107" name="decorate_line_1">
             <a:extLst>
               <a:ext uri="{FF2B5EF4-FFF2-40B4-BE49-F238E27FC236}">
-                <a16:creationId xmlns:a16="http://schemas.microsoft.com/office/drawing/2014/main" id="{E358D272-DAC5-6C86-4E9A-D43C3860437A}"/>
+                <a16:creationId xmlns:a16="http://schemas.microsoft.com/office/drawing/2014/main" id="{B363EE3B-0992-2034-0593-5DA334A21BB4}"/>
               </a:ext>
             </a:extLst>
           </p:cNvPr>
@@ -8512,7 +8512,7 @@
           <p:cNvPr id="108" name="styled_ir_card">
             <a:extLst>
               <a:ext uri="{FF2B5EF4-FFF2-40B4-BE49-F238E27FC236}">
-                <a16:creationId xmlns:a16="http://schemas.microsoft.com/office/drawing/2014/main" id="{7ECDB28D-7558-C263-78C1-26EFF7F3BF15}"/>
+                <a16:creationId xmlns:a16="http://schemas.microsoft.com/office/drawing/2014/main" id="{11C2D0E8-1FC3-3AC0-7018-00169D3540CF}"/>
               </a:ext>
             </a:extLst>
           </p:cNvPr>
@@ -8575,7 +8575,7 @@
           <p:cNvPr id="109" name="styled_ir_icon_dot">
             <a:extLst>
               <a:ext uri="{FF2B5EF4-FFF2-40B4-BE49-F238E27FC236}">
-                <a16:creationId xmlns:a16="http://schemas.microsoft.com/office/drawing/2014/main" id="{98AC941A-877B-23D3-FE6F-40AF809FD111}"/>
+                <a16:creationId xmlns:a16="http://schemas.microsoft.com/office/drawing/2014/main" id="{B8B930A7-6ED5-0474-95D8-08BD56C35CF1}"/>
               </a:ext>
             </a:extLst>
           </p:cNvPr>
@@ -8629,7 +8629,7 @@
           <p:cNvPr id="110" name="styled_ir_icon_label">
             <a:extLst>
               <a:ext uri="{FF2B5EF4-FFF2-40B4-BE49-F238E27FC236}">
-                <a16:creationId xmlns:a16="http://schemas.microsoft.com/office/drawing/2014/main" id="{A7864D73-C7A1-88A8-F010-B2C7607C74B5}"/>
+                <a16:creationId xmlns:a16="http://schemas.microsoft.com/office/drawing/2014/main" id="{22C85092-F6DF-70DE-BEA9-B7E06D6B19FC}"/>
               </a:ext>
             </a:extLst>
           </p:cNvPr>
@@ -8676,7 +8676,7 @@
           <p:cNvPr id="111" name="styled_ir_title">
             <a:extLst>
               <a:ext uri="{FF2B5EF4-FFF2-40B4-BE49-F238E27FC236}">
-                <a16:creationId xmlns:a16="http://schemas.microsoft.com/office/drawing/2014/main" id="{5083F212-C411-20BD-47A9-FA6BCBFACB2D}"/>
+                <a16:creationId xmlns:a16="http://schemas.microsoft.com/office/drawing/2014/main" id="{CD513EC3-CC10-89A3-D071-C93E1D267978}"/>
               </a:ext>
             </a:extLst>
           </p:cNvPr>
@@ -8722,7 +8722,7 @@
           <p:cNvPr id="112" name="styled_ir_line_0">
             <a:extLst>
               <a:ext uri="{FF2B5EF4-FFF2-40B4-BE49-F238E27FC236}">
-                <a16:creationId xmlns:a16="http://schemas.microsoft.com/office/drawing/2014/main" id="{3B432C65-7A18-E528-E6C4-A64F9C96940D}"/>
+                <a16:creationId xmlns:a16="http://schemas.microsoft.com/office/drawing/2014/main" id="{A3DB128E-25F6-F931-90A8-4647FA18AA63}"/>
               </a:ext>
             </a:extLst>
           </p:cNvPr>
@@ -8768,7 +8768,7 @@
           <p:cNvPr id="113" name="styled_ir_line_1">
             <a:extLst>
               <a:ext uri="{FF2B5EF4-FFF2-40B4-BE49-F238E27FC236}">
-                <a16:creationId xmlns:a16="http://schemas.microsoft.com/office/drawing/2014/main" id="{5266272F-AA53-575F-51A5-EE2DE73C16AF}"/>
+                <a16:creationId xmlns:a16="http://schemas.microsoft.com/office/drawing/2014/main" id="{FA9E8C6A-DED0-E06E-F153-6BD3BCF6DF7F}"/>
               </a:ext>
             </a:extLst>
           </p:cNvPr>
@@ -8814,7 +8814,7 @@
           <p:cNvPr id="114" name="renderers_card">
             <a:extLst>
               <a:ext uri="{FF2B5EF4-FFF2-40B4-BE49-F238E27FC236}">
-                <a16:creationId xmlns:a16="http://schemas.microsoft.com/office/drawing/2014/main" id="{15B8F007-C1FE-F992-695F-CE6B67D6E7B3}"/>
+                <a16:creationId xmlns:a16="http://schemas.microsoft.com/office/drawing/2014/main" id="{C4CC0BDB-5B38-DEA0-E9DF-1F19FCBC2A75}"/>
               </a:ext>
             </a:extLst>
           </p:cNvPr>
@@ -8877,7 +8877,7 @@
           <p:cNvPr id="115" name="renderers_icon_dot">
             <a:extLst>
               <a:ext uri="{FF2B5EF4-FFF2-40B4-BE49-F238E27FC236}">
-                <a16:creationId xmlns:a16="http://schemas.microsoft.com/office/drawing/2014/main" id="{BF7E7937-9A64-36DD-A735-D0728C1FF5C7}"/>
+                <a16:creationId xmlns:a16="http://schemas.microsoft.com/office/drawing/2014/main" id="{C8DF272C-AE4E-7D1D-D824-724640B12635}"/>
               </a:ext>
             </a:extLst>
           </p:cNvPr>
@@ -8931,7 +8931,7 @@
           <p:cNvPr id="116" name="renderers_icon_label">
             <a:extLst>
               <a:ext uri="{FF2B5EF4-FFF2-40B4-BE49-F238E27FC236}">
-                <a16:creationId xmlns:a16="http://schemas.microsoft.com/office/drawing/2014/main" id="{0AFDAC46-798B-C5DC-32B2-53F9495A8F7A}"/>
+                <a16:creationId xmlns:a16="http://schemas.microsoft.com/office/drawing/2014/main" id="{1ED35E4E-A494-5145-BD7E-57D6A6CFCE03}"/>
               </a:ext>
             </a:extLst>
           </p:cNvPr>
@@ -8978,7 +8978,7 @@
           <p:cNvPr id="117" name="renderers_title">
             <a:extLst>
               <a:ext uri="{FF2B5EF4-FFF2-40B4-BE49-F238E27FC236}">
-                <a16:creationId xmlns:a16="http://schemas.microsoft.com/office/drawing/2014/main" id="{92B21AEE-E9AF-C738-BDD5-0C68E498D923}"/>
+                <a16:creationId xmlns:a16="http://schemas.microsoft.com/office/drawing/2014/main" id="{93693208-2F22-7316-C8E6-320B7103AB98}"/>
               </a:ext>
             </a:extLst>
           </p:cNvPr>
@@ -9024,7 +9024,7 @@
           <p:cNvPr id="118" name="renderers_line_0">
             <a:extLst>
               <a:ext uri="{FF2B5EF4-FFF2-40B4-BE49-F238E27FC236}">
-                <a16:creationId xmlns:a16="http://schemas.microsoft.com/office/drawing/2014/main" id="{487987AF-1EE9-3FB9-ED40-7B2F78E95366}"/>
+                <a16:creationId xmlns:a16="http://schemas.microsoft.com/office/drawing/2014/main" id="{508B74AE-F450-E102-7BC5-309792038F1E}"/>
               </a:ext>
             </a:extLst>
           </p:cNvPr>
@@ -9070,7 +9070,7 @@
           <p:cNvPr id="119" name="renderers_line_1">
             <a:extLst>
               <a:ext uri="{FF2B5EF4-FFF2-40B4-BE49-F238E27FC236}">
-                <a16:creationId xmlns:a16="http://schemas.microsoft.com/office/drawing/2014/main" id="{FE0FA7C8-5359-8207-E42D-21997E36BBBD}"/>
+                <a16:creationId xmlns:a16="http://schemas.microsoft.com/office/drawing/2014/main" id="{B240AF80-D133-8B13-DDC5-7285E9F1C0F8}"/>
               </a:ext>
             </a:extLst>
           </p:cNvPr>
@@ -9116,7 +9116,7 @@
           <p:cNvPr id="120" name="visual_check">
             <a:extLst>
               <a:ext uri="{FF2B5EF4-FFF2-40B4-BE49-F238E27FC236}">
-                <a16:creationId xmlns:a16="http://schemas.microsoft.com/office/drawing/2014/main" id="{BB8D57CF-53C5-DD73-DB5F-6ABBEC56D6AE}"/>
+                <a16:creationId xmlns:a16="http://schemas.microsoft.com/office/drawing/2014/main" id="{84F1FF14-588D-2971-C080-55B56495F2A0}"/>
               </a:ext>
             </a:extLst>
           </p:cNvPr>
@@ -9179,7 +9179,7 @@
           <p:cNvPr id="121" name="visual_check_stripe">
             <a:extLst>
               <a:ext uri="{FF2B5EF4-FFF2-40B4-BE49-F238E27FC236}">
-                <a16:creationId xmlns:a16="http://schemas.microsoft.com/office/drawing/2014/main" id="{DBDB603B-A036-4F6C-B73A-645C434479E0}"/>
+                <a16:creationId xmlns:a16="http://schemas.microsoft.com/office/drawing/2014/main" id="{D949E05C-D844-E600-9352-56BE9338F038}"/>
               </a:ext>
             </a:extLst>
           </p:cNvPr>
@@ -9233,7 +9233,7 @@
           <p:cNvPr id="122" name="visual_check_seal_icon_dot">
             <a:extLst>
               <a:ext uri="{FF2B5EF4-FFF2-40B4-BE49-F238E27FC236}">
-                <a16:creationId xmlns:a16="http://schemas.microsoft.com/office/drawing/2014/main" id="{069EBF58-9805-9D72-43E6-C96E16AE12EE}"/>
+                <a16:creationId xmlns:a16="http://schemas.microsoft.com/office/drawing/2014/main" id="{24179B16-512F-19EB-183A-B6ABC9F24F7D}"/>
               </a:ext>
             </a:extLst>
           </p:cNvPr>
@@ -9287,7 +9287,7 @@
           <p:cNvPr id="123" name="visual_check_seal_icon_label">
             <a:extLst>
               <a:ext uri="{FF2B5EF4-FFF2-40B4-BE49-F238E27FC236}">
-                <a16:creationId xmlns:a16="http://schemas.microsoft.com/office/drawing/2014/main" id="{13AF6BEC-9AEB-060A-E9A3-CD147CE0ABB8}"/>
+                <a16:creationId xmlns:a16="http://schemas.microsoft.com/office/drawing/2014/main" id="{C245C93B-E8FC-56D3-58DA-43966229AF25}"/>
               </a:ext>
             </a:extLst>
           </p:cNvPr>
@@ -9334,7 +9334,7 @@
           <p:cNvPr id="124" name="visual_check_label">
             <a:extLst>
               <a:ext uri="{FF2B5EF4-FFF2-40B4-BE49-F238E27FC236}">
-                <a16:creationId xmlns:a16="http://schemas.microsoft.com/office/drawing/2014/main" id="{E69545DD-3F0C-0EFB-DB26-7D448CC43398}"/>
+                <a16:creationId xmlns:a16="http://schemas.microsoft.com/office/drawing/2014/main" id="{B6D75835-B2EE-EE21-9DB1-99589551BD4F}"/>
               </a:ext>
             </a:extLst>
           </p:cNvPr>
@@ -9380,7 +9380,7 @@
           <p:cNvPr id="125" name="visual_check_text">
             <a:extLst>
               <a:ext uri="{FF2B5EF4-FFF2-40B4-BE49-F238E27FC236}">
-                <a16:creationId xmlns:a16="http://schemas.microsoft.com/office/drawing/2014/main" id="{310BA757-DA9E-AEE3-BAEF-EF3B04C77380}"/>
+                <a16:creationId xmlns:a16="http://schemas.microsoft.com/office/drawing/2014/main" id="{188B0F49-E90F-867B-B37E-FEC504008898}"/>
               </a:ext>
             </a:extLst>
           </p:cNvPr>
@@ -9426,7 +9426,7 @@
           <p:cNvPr id="126" name="coherence_band">
             <a:extLst>
               <a:ext uri="{FF2B5EF4-FFF2-40B4-BE49-F238E27FC236}">
-                <a16:creationId xmlns:a16="http://schemas.microsoft.com/office/drawing/2014/main" id="{D927173A-648B-E1A2-FE8B-BDB781D75BBA}"/>
+                <a16:creationId xmlns:a16="http://schemas.microsoft.com/office/drawing/2014/main" id="{36FE1C46-6FF1-B70B-B5DA-346144104C84}"/>
               </a:ext>
             </a:extLst>
           </p:cNvPr>
@@ -9489,7 +9489,7 @@
           <p:cNvPr id="127" name="coherence_title">
             <a:extLst>
               <a:ext uri="{FF2B5EF4-FFF2-40B4-BE49-F238E27FC236}">
-                <a16:creationId xmlns:a16="http://schemas.microsoft.com/office/drawing/2014/main" id="{A839161C-BACF-0101-9E95-510F402FF619}"/>
+                <a16:creationId xmlns:a16="http://schemas.microsoft.com/office/drawing/2014/main" id="{83A695C6-DE9F-749D-8819-62139B053109}"/>
               </a:ext>
             </a:extLst>
           </p:cNvPr>
@@ -9535,7 +9535,7 @@
           <p:cNvPr id="128" name="coherence_body">
             <a:extLst>
               <a:ext uri="{FF2B5EF4-FFF2-40B4-BE49-F238E27FC236}">
-                <a16:creationId xmlns:a16="http://schemas.microsoft.com/office/drawing/2014/main" id="{9385964B-AE51-AAAB-2D92-A24743AD0451}"/>
+                <a16:creationId xmlns:a16="http://schemas.microsoft.com/office/drawing/2014/main" id="{5792196D-067C-C07B-9D37-D17306228864}"/>
               </a:ext>
             </a:extLst>
           </p:cNvPr>
@@ -9579,7 +9579,7 @@
     </p:spTree>
     <p:extLst>
       <p:ext uri="{BB962C8B-B14F-4D97-AF65-F5344CB8AC3E}">
-        <p14:creationId xmlns:p14="http://schemas.microsoft.com/office/powerpoint/2010/main" val="2536535568"/>
+        <p14:creationId xmlns:p14="http://schemas.microsoft.com/office/powerpoint/2010/main" val="18344693"/>
       </p:ext>
     </p:extLst>
   </p:cSld>

</xml_diff>

<commit_message>
Harden README teaser layout validation
</commit_message>
<xml_diff>
--- a/docs/assets/readme-slides/mdpr-pipeline-teaser.pptx
+++ b/docs/assets/readme-slides/mdpr-pipeline-teaser.pptx
@@ -129,7 +129,7 @@
           <p:cNvPr id="2" name="제목 1">
             <a:extLst>
               <a:ext uri="{FF2B5EF4-FFF2-40B4-BE49-F238E27FC236}">
-                <a16:creationId xmlns:a16="http://schemas.microsoft.com/office/drawing/2014/main" id="{268E8072-8242-5E85-7396-F9FEDD74FCE9}"/>
+                <a16:creationId xmlns:a16="http://schemas.microsoft.com/office/drawing/2014/main" id="{640F8F56-4F1A-F2A6-00B5-232442BB1F99}"/>
               </a:ext>
             </a:extLst>
           </p:cNvPr>
@@ -166,7 +166,7 @@
           <p:cNvPr id="3" name="부제목 2">
             <a:extLst>
               <a:ext uri="{FF2B5EF4-FFF2-40B4-BE49-F238E27FC236}">
-                <a16:creationId xmlns:a16="http://schemas.microsoft.com/office/drawing/2014/main" id="{72574503-A888-4C7A-7243-99FE6A7DBCF6}"/>
+                <a16:creationId xmlns:a16="http://schemas.microsoft.com/office/drawing/2014/main" id="{DEBC6058-C6BC-41FD-7DB7-EEDE639AF1DA}"/>
               </a:ext>
             </a:extLst>
           </p:cNvPr>
@@ -236,7 +236,7 @@
           <p:cNvPr id="4" name="날짜 개체 틀 3">
             <a:extLst>
               <a:ext uri="{FF2B5EF4-FFF2-40B4-BE49-F238E27FC236}">
-                <a16:creationId xmlns:a16="http://schemas.microsoft.com/office/drawing/2014/main" id="{A7E0BA20-4A8A-82EB-A796-E358CBFEDA92}"/>
+                <a16:creationId xmlns:a16="http://schemas.microsoft.com/office/drawing/2014/main" id="{528846A2-69A1-E13B-D102-B8E35F42B19F}"/>
               </a:ext>
             </a:extLst>
           </p:cNvPr>
@@ -252,7 +252,7 @@
           <a:bodyPr/>
           <a:lstStyle/>
           <a:p>
-            <a:fld id="{61D2EE60-430B-4588-84F2-5882C97E02B5}" type="datetimeFigureOut">
+            <a:fld id="{15C0B7B1-677A-41FB-B453-90FAB63ECAC5}" type="datetimeFigureOut">
               <a:rPr lang="ko-KR" altLang="en-US" smtClean="0"/>
               <a:t>2026-06-21</a:t>
             </a:fld>
@@ -265,7 +265,7 @@
           <p:cNvPr id="5" name="바닥글 개체 틀 4">
             <a:extLst>
               <a:ext uri="{FF2B5EF4-FFF2-40B4-BE49-F238E27FC236}">
-                <a16:creationId xmlns:a16="http://schemas.microsoft.com/office/drawing/2014/main" id="{6A08D243-FA96-0C27-22CE-B7B0AAAC4AAC}"/>
+                <a16:creationId xmlns:a16="http://schemas.microsoft.com/office/drawing/2014/main" id="{73621DB2-8921-C433-E7B8-A29FF362BF85}"/>
               </a:ext>
             </a:extLst>
           </p:cNvPr>
@@ -290,7 +290,7 @@
           <p:cNvPr id="6" name="슬라이드 번호 개체 틀 5">
             <a:extLst>
               <a:ext uri="{FF2B5EF4-FFF2-40B4-BE49-F238E27FC236}">
-                <a16:creationId xmlns:a16="http://schemas.microsoft.com/office/drawing/2014/main" id="{83A916A0-4960-7280-651F-E06202FA73F4}"/>
+                <a16:creationId xmlns:a16="http://schemas.microsoft.com/office/drawing/2014/main" id="{E9376F93-819A-58DF-2175-B630E8A98D68}"/>
               </a:ext>
             </a:extLst>
           </p:cNvPr>
@@ -306,7 +306,7 @@
           <a:bodyPr/>
           <a:lstStyle/>
           <a:p>
-            <a:fld id="{04835B4B-883C-40BD-841B-0E5E6E202C4B}" type="slidenum">
+            <a:fld id="{14F36FE2-5F7D-4CD9-9A15-7CE305A53C22}" type="slidenum">
               <a:rPr lang="ko-KR" altLang="en-US" smtClean="0"/>
               <a:t>‹#›</a:t>
             </a:fld>
@@ -317,7 +317,7 @@
     </p:spTree>
     <p:extLst>
       <p:ext uri="{BB962C8B-B14F-4D97-AF65-F5344CB8AC3E}">
-        <p14:creationId xmlns:p14="http://schemas.microsoft.com/office/powerpoint/2010/main" val="1082396533"/>
+        <p14:creationId xmlns:p14="http://schemas.microsoft.com/office/powerpoint/2010/main" val="1795498924"/>
       </p:ext>
     </p:extLst>
   </p:cSld>
@@ -349,7 +349,7 @@
           <p:cNvPr id="2" name="제목 1">
             <a:extLst>
               <a:ext uri="{FF2B5EF4-FFF2-40B4-BE49-F238E27FC236}">
-                <a16:creationId xmlns:a16="http://schemas.microsoft.com/office/drawing/2014/main" id="{E3432B04-BFB2-21A7-1DEA-D21C80A05018}"/>
+                <a16:creationId xmlns:a16="http://schemas.microsoft.com/office/drawing/2014/main" id="{919F4112-04BA-D6EB-2CD4-BE08E4C60681}"/>
               </a:ext>
             </a:extLst>
           </p:cNvPr>
@@ -377,7 +377,7 @@
           <p:cNvPr id="3" name="세로 텍스트 개체 틀 2">
             <a:extLst>
               <a:ext uri="{FF2B5EF4-FFF2-40B4-BE49-F238E27FC236}">
-                <a16:creationId xmlns:a16="http://schemas.microsoft.com/office/drawing/2014/main" id="{A0A25606-6E56-CB77-1F1F-8620894965B4}"/>
+                <a16:creationId xmlns:a16="http://schemas.microsoft.com/office/drawing/2014/main" id="{19BBCBDD-3819-29C7-3CE2-A1B600500EDB}"/>
               </a:ext>
             </a:extLst>
           </p:cNvPr>
@@ -434,7 +434,7 @@
           <p:cNvPr id="4" name="날짜 개체 틀 3">
             <a:extLst>
               <a:ext uri="{FF2B5EF4-FFF2-40B4-BE49-F238E27FC236}">
-                <a16:creationId xmlns:a16="http://schemas.microsoft.com/office/drawing/2014/main" id="{4E152DE9-A97D-9159-EC74-C64F633012CA}"/>
+                <a16:creationId xmlns:a16="http://schemas.microsoft.com/office/drawing/2014/main" id="{6E2E307A-EFE0-EFA5-6535-7DA410628EB6}"/>
               </a:ext>
             </a:extLst>
           </p:cNvPr>
@@ -450,7 +450,7 @@
           <a:bodyPr/>
           <a:lstStyle/>
           <a:p>
-            <a:fld id="{61D2EE60-430B-4588-84F2-5882C97E02B5}" type="datetimeFigureOut">
+            <a:fld id="{15C0B7B1-677A-41FB-B453-90FAB63ECAC5}" type="datetimeFigureOut">
               <a:rPr lang="ko-KR" altLang="en-US" smtClean="0"/>
               <a:t>2026-06-21</a:t>
             </a:fld>
@@ -463,7 +463,7 @@
           <p:cNvPr id="5" name="바닥글 개체 틀 4">
             <a:extLst>
               <a:ext uri="{FF2B5EF4-FFF2-40B4-BE49-F238E27FC236}">
-                <a16:creationId xmlns:a16="http://schemas.microsoft.com/office/drawing/2014/main" id="{6D2219D8-33EB-AD9E-EB9F-D2DBA2CC9417}"/>
+                <a16:creationId xmlns:a16="http://schemas.microsoft.com/office/drawing/2014/main" id="{FB01B625-04D3-6148-802B-7296E771C530}"/>
               </a:ext>
             </a:extLst>
           </p:cNvPr>
@@ -488,7 +488,7 @@
           <p:cNvPr id="6" name="슬라이드 번호 개체 틀 5">
             <a:extLst>
               <a:ext uri="{FF2B5EF4-FFF2-40B4-BE49-F238E27FC236}">
-                <a16:creationId xmlns:a16="http://schemas.microsoft.com/office/drawing/2014/main" id="{D374631D-C181-FEB5-8AD9-6B0734FAA2C8}"/>
+                <a16:creationId xmlns:a16="http://schemas.microsoft.com/office/drawing/2014/main" id="{E1F6FA21-D1A5-EB10-DBA2-F14D8226CC2E}"/>
               </a:ext>
             </a:extLst>
           </p:cNvPr>
@@ -504,7 +504,7 @@
           <a:bodyPr/>
           <a:lstStyle/>
           <a:p>
-            <a:fld id="{04835B4B-883C-40BD-841B-0E5E6E202C4B}" type="slidenum">
+            <a:fld id="{14F36FE2-5F7D-4CD9-9A15-7CE305A53C22}" type="slidenum">
               <a:rPr lang="ko-KR" altLang="en-US" smtClean="0"/>
               <a:t>‹#›</a:t>
             </a:fld>
@@ -515,7 +515,7 @@
     </p:spTree>
     <p:extLst>
       <p:ext uri="{BB962C8B-B14F-4D97-AF65-F5344CB8AC3E}">
-        <p14:creationId xmlns:p14="http://schemas.microsoft.com/office/powerpoint/2010/main" val="3376018941"/>
+        <p14:creationId xmlns:p14="http://schemas.microsoft.com/office/powerpoint/2010/main" val="3568122155"/>
       </p:ext>
     </p:extLst>
   </p:cSld>
@@ -547,7 +547,7 @@
           <p:cNvPr id="2" name="세로 제목 1">
             <a:extLst>
               <a:ext uri="{FF2B5EF4-FFF2-40B4-BE49-F238E27FC236}">
-                <a16:creationId xmlns:a16="http://schemas.microsoft.com/office/drawing/2014/main" id="{35029260-0835-F242-C74F-0E0552338D3F}"/>
+                <a16:creationId xmlns:a16="http://schemas.microsoft.com/office/drawing/2014/main" id="{4EF49BB3-034B-B47C-EA6A-4DAB77ADFDA0}"/>
               </a:ext>
             </a:extLst>
           </p:cNvPr>
@@ -580,7 +580,7 @@
           <p:cNvPr id="3" name="세로 텍스트 개체 틀 2">
             <a:extLst>
               <a:ext uri="{FF2B5EF4-FFF2-40B4-BE49-F238E27FC236}">
-                <a16:creationId xmlns:a16="http://schemas.microsoft.com/office/drawing/2014/main" id="{E1A16BE1-CFB9-064C-ABED-778ECF4BD559}"/>
+                <a16:creationId xmlns:a16="http://schemas.microsoft.com/office/drawing/2014/main" id="{33A046A3-0274-ED5F-935A-8F6C92B3225A}"/>
               </a:ext>
             </a:extLst>
           </p:cNvPr>
@@ -642,7 +642,7 @@
           <p:cNvPr id="4" name="날짜 개체 틀 3">
             <a:extLst>
               <a:ext uri="{FF2B5EF4-FFF2-40B4-BE49-F238E27FC236}">
-                <a16:creationId xmlns:a16="http://schemas.microsoft.com/office/drawing/2014/main" id="{EEE94898-6D32-0DED-59A6-72014FB8B688}"/>
+                <a16:creationId xmlns:a16="http://schemas.microsoft.com/office/drawing/2014/main" id="{EB07DC85-9FC9-B6D5-F425-10AE6D3A6329}"/>
               </a:ext>
             </a:extLst>
           </p:cNvPr>
@@ -658,7 +658,7 @@
           <a:bodyPr/>
           <a:lstStyle/>
           <a:p>
-            <a:fld id="{61D2EE60-430B-4588-84F2-5882C97E02B5}" type="datetimeFigureOut">
+            <a:fld id="{15C0B7B1-677A-41FB-B453-90FAB63ECAC5}" type="datetimeFigureOut">
               <a:rPr lang="ko-KR" altLang="en-US" smtClean="0"/>
               <a:t>2026-06-21</a:t>
             </a:fld>
@@ -671,7 +671,7 @@
           <p:cNvPr id="5" name="바닥글 개체 틀 4">
             <a:extLst>
               <a:ext uri="{FF2B5EF4-FFF2-40B4-BE49-F238E27FC236}">
-                <a16:creationId xmlns:a16="http://schemas.microsoft.com/office/drawing/2014/main" id="{9F104281-E119-DDFA-1BF4-6A8A0833F3C4}"/>
+                <a16:creationId xmlns:a16="http://schemas.microsoft.com/office/drawing/2014/main" id="{8FEE7C76-F6EC-882A-25A7-E13CB3AAC6A6}"/>
               </a:ext>
             </a:extLst>
           </p:cNvPr>
@@ -696,7 +696,7 @@
           <p:cNvPr id="6" name="슬라이드 번호 개체 틀 5">
             <a:extLst>
               <a:ext uri="{FF2B5EF4-FFF2-40B4-BE49-F238E27FC236}">
-                <a16:creationId xmlns:a16="http://schemas.microsoft.com/office/drawing/2014/main" id="{0376A74D-6C9D-B6DE-69F9-EA8617BB5FCE}"/>
+                <a16:creationId xmlns:a16="http://schemas.microsoft.com/office/drawing/2014/main" id="{1D2F025B-159D-A07D-86F3-AEF80C2E71E6}"/>
               </a:ext>
             </a:extLst>
           </p:cNvPr>
@@ -712,7 +712,7 @@
           <a:bodyPr/>
           <a:lstStyle/>
           <a:p>
-            <a:fld id="{04835B4B-883C-40BD-841B-0E5E6E202C4B}" type="slidenum">
+            <a:fld id="{14F36FE2-5F7D-4CD9-9A15-7CE305A53C22}" type="slidenum">
               <a:rPr lang="ko-KR" altLang="en-US" smtClean="0"/>
               <a:t>‹#›</a:t>
             </a:fld>
@@ -723,7 +723,7 @@
     </p:spTree>
     <p:extLst>
       <p:ext uri="{BB962C8B-B14F-4D97-AF65-F5344CB8AC3E}">
-        <p14:creationId xmlns:p14="http://schemas.microsoft.com/office/powerpoint/2010/main" val="3394472661"/>
+        <p14:creationId xmlns:p14="http://schemas.microsoft.com/office/powerpoint/2010/main" val="1805415001"/>
       </p:ext>
     </p:extLst>
   </p:cSld>
@@ -755,7 +755,7 @@
           <p:cNvPr id="2" name="제목 1">
             <a:extLst>
               <a:ext uri="{FF2B5EF4-FFF2-40B4-BE49-F238E27FC236}">
-                <a16:creationId xmlns:a16="http://schemas.microsoft.com/office/drawing/2014/main" id="{49BF6ED5-8C0F-627A-AA3F-140CCE3E70C3}"/>
+                <a16:creationId xmlns:a16="http://schemas.microsoft.com/office/drawing/2014/main" id="{8CB83152-AB72-6807-D9FC-A5434BBC0D89}"/>
               </a:ext>
             </a:extLst>
           </p:cNvPr>
@@ -783,7 +783,7 @@
           <p:cNvPr id="3" name="내용 개체 틀 2">
             <a:extLst>
               <a:ext uri="{FF2B5EF4-FFF2-40B4-BE49-F238E27FC236}">
-                <a16:creationId xmlns:a16="http://schemas.microsoft.com/office/drawing/2014/main" id="{AE5D9F95-D696-9131-C293-1F97F8BF361F}"/>
+                <a16:creationId xmlns:a16="http://schemas.microsoft.com/office/drawing/2014/main" id="{91988632-ADA5-9D0B-F78B-9FDCCFEC1F1D}"/>
               </a:ext>
             </a:extLst>
           </p:cNvPr>
@@ -840,7 +840,7 @@
           <p:cNvPr id="4" name="날짜 개체 틀 3">
             <a:extLst>
               <a:ext uri="{FF2B5EF4-FFF2-40B4-BE49-F238E27FC236}">
-                <a16:creationId xmlns:a16="http://schemas.microsoft.com/office/drawing/2014/main" id="{EB4182B9-CFFF-A60E-AB91-F9560C789D59}"/>
+                <a16:creationId xmlns:a16="http://schemas.microsoft.com/office/drawing/2014/main" id="{5DCE907F-2837-087D-20BE-1E341CC72DE1}"/>
               </a:ext>
             </a:extLst>
           </p:cNvPr>
@@ -856,7 +856,7 @@
           <a:bodyPr/>
           <a:lstStyle/>
           <a:p>
-            <a:fld id="{61D2EE60-430B-4588-84F2-5882C97E02B5}" type="datetimeFigureOut">
+            <a:fld id="{15C0B7B1-677A-41FB-B453-90FAB63ECAC5}" type="datetimeFigureOut">
               <a:rPr lang="ko-KR" altLang="en-US" smtClean="0"/>
               <a:t>2026-06-21</a:t>
             </a:fld>
@@ -869,7 +869,7 @@
           <p:cNvPr id="5" name="바닥글 개체 틀 4">
             <a:extLst>
               <a:ext uri="{FF2B5EF4-FFF2-40B4-BE49-F238E27FC236}">
-                <a16:creationId xmlns:a16="http://schemas.microsoft.com/office/drawing/2014/main" id="{BD22D787-61BA-BB68-1631-BCE7FC28C5E8}"/>
+                <a16:creationId xmlns:a16="http://schemas.microsoft.com/office/drawing/2014/main" id="{2C9CAE06-4BFB-2994-7A7C-A6AC750B4589}"/>
               </a:ext>
             </a:extLst>
           </p:cNvPr>
@@ -894,7 +894,7 @@
           <p:cNvPr id="6" name="슬라이드 번호 개체 틀 5">
             <a:extLst>
               <a:ext uri="{FF2B5EF4-FFF2-40B4-BE49-F238E27FC236}">
-                <a16:creationId xmlns:a16="http://schemas.microsoft.com/office/drawing/2014/main" id="{3A0DA2AF-2EB3-3523-3DE6-CC516DC6E68F}"/>
+                <a16:creationId xmlns:a16="http://schemas.microsoft.com/office/drawing/2014/main" id="{6F48527F-F203-2BC6-1379-BF7500E08388}"/>
               </a:ext>
             </a:extLst>
           </p:cNvPr>
@@ -910,7 +910,7 @@
           <a:bodyPr/>
           <a:lstStyle/>
           <a:p>
-            <a:fld id="{04835B4B-883C-40BD-841B-0E5E6E202C4B}" type="slidenum">
+            <a:fld id="{14F36FE2-5F7D-4CD9-9A15-7CE305A53C22}" type="slidenum">
               <a:rPr lang="ko-KR" altLang="en-US" smtClean="0"/>
               <a:t>‹#›</a:t>
             </a:fld>
@@ -921,7 +921,7 @@
     </p:spTree>
     <p:extLst>
       <p:ext uri="{BB962C8B-B14F-4D97-AF65-F5344CB8AC3E}">
-        <p14:creationId xmlns:p14="http://schemas.microsoft.com/office/powerpoint/2010/main" val="683875029"/>
+        <p14:creationId xmlns:p14="http://schemas.microsoft.com/office/powerpoint/2010/main" val="1692401691"/>
       </p:ext>
     </p:extLst>
   </p:cSld>
@@ -953,7 +953,7 @@
           <p:cNvPr id="2" name="제목 1">
             <a:extLst>
               <a:ext uri="{FF2B5EF4-FFF2-40B4-BE49-F238E27FC236}">
-                <a16:creationId xmlns:a16="http://schemas.microsoft.com/office/drawing/2014/main" id="{765CBABA-573C-5A4A-6FC8-CBF09C962417}"/>
+                <a16:creationId xmlns:a16="http://schemas.microsoft.com/office/drawing/2014/main" id="{64B34057-442F-653C-563C-EA57ECF4F709}"/>
               </a:ext>
             </a:extLst>
           </p:cNvPr>
@@ -990,7 +990,7 @@
           <p:cNvPr id="3" name="텍스트 개체 틀 2">
             <a:extLst>
               <a:ext uri="{FF2B5EF4-FFF2-40B4-BE49-F238E27FC236}">
-                <a16:creationId xmlns:a16="http://schemas.microsoft.com/office/drawing/2014/main" id="{74E9BAA3-ED4B-1371-4186-86A11A0FB872}"/>
+                <a16:creationId xmlns:a16="http://schemas.microsoft.com/office/drawing/2014/main" id="{AD67322F-A786-2713-1E0F-C9B72976C70F}"/>
               </a:ext>
             </a:extLst>
           </p:cNvPr>
@@ -1115,7 +1115,7 @@
           <p:cNvPr id="4" name="날짜 개체 틀 3">
             <a:extLst>
               <a:ext uri="{FF2B5EF4-FFF2-40B4-BE49-F238E27FC236}">
-                <a16:creationId xmlns:a16="http://schemas.microsoft.com/office/drawing/2014/main" id="{0486B670-2C61-2322-80C3-797856BD2649}"/>
+                <a16:creationId xmlns:a16="http://schemas.microsoft.com/office/drawing/2014/main" id="{BBADA6EA-C31A-A918-EB11-66E9ACA03A2E}"/>
               </a:ext>
             </a:extLst>
           </p:cNvPr>
@@ -1131,7 +1131,7 @@
           <a:bodyPr/>
           <a:lstStyle/>
           <a:p>
-            <a:fld id="{61D2EE60-430B-4588-84F2-5882C97E02B5}" type="datetimeFigureOut">
+            <a:fld id="{15C0B7B1-677A-41FB-B453-90FAB63ECAC5}" type="datetimeFigureOut">
               <a:rPr lang="ko-KR" altLang="en-US" smtClean="0"/>
               <a:t>2026-06-21</a:t>
             </a:fld>
@@ -1144,7 +1144,7 @@
           <p:cNvPr id="5" name="바닥글 개체 틀 4">
             <a:extLst>
               <a:ext uri="{FF2B5EF4-FFF2-40B4-BE49-F238E27FC236}">
-                <a16:creationId xmlns:a16="http://schemas.microsoft.com/office/drawing/2014/main" id="{3ED4B914-DAE4-5B6D-8664-4CB201455183}"/>
+                <a16:creationId xmlns:a16="http://schemas.microsoft.com/office/drawing/2014/main" id="{A1DAA87E-CAF9-42FC-278C-BFCF11EAEE79}"/>
               </a:ext>
             </a:extLst>
           </p:cNvPr>
@@ -1169,7 +1169,7 @@
           <p:cNvPr id="6" name="슬라이드 번호 개체 틀 5">
             <a:extLst>
               <a:ext uri="{FF2B5EF4-FFF2-40B4-BE49-F238E27FC236}">
-                <a16:creationId xmlns:a16="http://schemas.microsoft.com/office/drawing/2014/main" id="{E35384C7-BE24-F4CA-93AF-759E485A39FC}"/>
+                <a16:creationId xmlns:a16="http://schemas.microsoft.com/office/drawing/2014/main" id="{76C7FB17-A4FA-74CB-3278-47DA5CF51EAF}"/>
               </a:ext>
             </a:extLst>
           </p:cNvPr>
@@ -1185,7 +1185,7 @@
           <a:bodyPr/>
           <a:lstStyle/>
           <a:p>
-            <a:fld id="{04835B4B-883C-40BD-841B-0E5E6E202C4B}" type="slidenum">
+            <a:fld id="{14F36FE2-5F7D-4CD9-9A15-7CE305A53C22}" type="slidenum">
               <a:rPr lang="ko-KR" altLang="en-US" smtClean="0"/>
               <a:t>‹#›</a:t>
             </a:fld>
@@ -1196,7 +1196,7 @@
     </p:spTree>
     <p:extLst>
       <p:ext uri="{BB962C8B-B14F-4D97-AF65-F5344CB8AC3E}">
-        <p14:creationId xmlns:p14="http://schemas.microsoft.com/office/powerpoint/2010/main" val="3950218679"/>
+        <p14:creationId xmlns:p14="http://schemas.microsoft.com/office/powerpoint/2010/main" val="2937711412"/>
       </p:ext>
     </p:extLst>
   </p:cSld>
@@ -1228,7 +1228,7 @@
           <p:cNvPr id="2" name="제목 1">
             <a:extLst>
               <a:ext uri="{FF2B5EF4-FFF2-40B4-BE49-F238E27FC236}">
-                <a16:creationId xmlns:a16="http://schemas.microsoft.com/office/drawing/2014/main" id="{60BEA5F8-0092-C905-24EF-F9C5BDE033EB}"/>
+                <a16:creationId xmlns:a16="http://schemas.microsoft.com/office/drawing/2014/main" id="{D8C8B17A-ACFB-F772-2B50-8B82D21802FB}"/>
               </a:ext>
             </a:extLst>
           </p:cNvPr>
@@ -1256,7 +1256,7 @@
           <p:cNvPr id="3" name="내용 개체 틀 2">
             <a:extLst>
               <a:ext uri="{FF2B5EF4-FFF2-40B4-BE49-F238E27FC236}">
-                <a16:creationId xmlns:a16="http://schemas.microsoft.com/office/drawing/2014/main" id="{301D7503-F990-D77B-038F-B432822233F3}"/>
+                <a16:creationId xmlns:a16="http://schemas.microsoft.com/office/drawing/2014/main" id="{24E9B0CE-6BBD-9D3B-45A9-781F5F93D248}"/>
               </a:ext>
             </a:extLst>
           </p:cNvPr>
@@ -1318,7 +1318,7 @@
           <p:cNvPr id="4" name="내용 개체 틀 3">
             <a:extLst>
               <a:ext uri="{FF2B5EF4-FFF2-40B4-BE49-F238E27FC236}">
-                <a16:creationId xmlns:a16="http://schemas.microsoft.com/office/drawing/2014/main" id="{07A1B4E0-1214-C8DD-690D-71707E9B4D47}"/>
+                <a16:creationId xmlns:a16="http://schemas.microsoft.com/office/drawing/2014/main" id="{FCBEEA62-3C09-4DDE-956C-90C8AAE3AEE9}"/>
               </a:ext>
             </a:extLst>
           </p:cNvPr>
@@ -1380,7 +1380,7 @@
           <p:cNvPr id="5" name="날짜 개체 틀 4">
             <a:extLst>
               <a:ext uri="{FF2B5EF4-FFF2-40B4-BE49-F238E27FC236}">
-                <a16:creationId xmlns:a16="http://schemas.microsoft.com/office/drawing/2014/main" id="{86C1F94F-3AE2-B4EB-71D6-0CC12E598E31}"/>
+                <a16:creationId xmlns:a16="http://schemas.microsoft.com/office/drawing/2014/main" id="{27DEABED-50F9-B456-7CB6-2C263B45E1AE}"/>
               </a:ext>
             </a:extLst>
           </p:cNvPr>
@@ -1396,7 +1396,7 @@
           <a:bodyPr/>
           <a:lstStyle/>
           <a:p>
-            <a:fld id="{61D2EE60-430B-4588-84F2-5882C97E02B5}" type="datetimeFigureOut">
+            <a:fld id="{15C0B7B1-677A-41FB-B453-90FAB63ECAC5}" type="datetimeFigureOut">
               <a:rPr lang="ko-KR" altLang="en-US" smtClean="0"/>
               <a:t>2026-06-21</a:t>
             </a:fld>
@@ -1409,7 +1409,7 @@
           <p:cNvPr id="6" name="바닥글 개체 틀 5">
             <a:extLst>
               <a:ext uri="{FF2B5EF4-FFF2-40B4-BE49-F238E27FC236}">
-                <a16:creationId xmlns:a16="http://schemas.microsoft.com/office/drawing/2014/main" id="{95E3B49B-9366-368B-FA42-2FC008CCAF7B}"/>
+                <a16:creationId xmlns:a16="http://schemas.microsoft.com/office/drawing/2014/main" id="{AEBB4C35-C880-2D48-B203-EA11A37F34FB}"/>
               </a:ext>
             </a:extLst>
           </p:cNvPr>
@@ -1434,7 +1434,7 @@
           <p:cNvPr id="7" name="슬라이드 번호 개체 틀 6">
             <a:extLst>
               <a:ext uri="{FF2B5EF4-FFF2-40B4-BE49-F238E27FC236}">
-                <a16:creationId xmlns:a16="http://schemas.microsoft.com/office/drawing/2014/main" id="{75B57087-4A48-0261-6606-D37862C18208}"/>
+                <a16:creationId xmlns:a16="http://schemas.microsoft.com/office/drawing/2014/main" id="{4150E475-6EF3-B70E-BCE5-093667669672}"/>
               </a:ext>
             </a:extLst>
           </p:cNvPr>
@@ -1450,7 +1450,7 @@
           <a:bodyPr/>
           <a:lstStyle/>
           <a:p>
-            <a:fld id="{04835B4B-883C-40BD-841B-0E5E6E202C4B}" type="slidenum">
+            <a:fld id="{14F36FE2-5F7D-4CD9-9A15-7CE305A53C22}" type="slidenum">
               <a:rPr lang="ko-KR" altLang="en-US" smtClean="0"/>
               <a:t>‹#›</a:t>
             </a:fld>
@@ -1461,7 +1461,7 @@
     </p:spTree>
     <p:extLst>
       <p:ext uri="{BB962C8B-B14F-4D97-AF65-F5344CB8AC3E}">
-        <p14:creationId xmlns:p14="http://schemas.microsoft.com/office/powerpoint/2010/main" val="2260912600"/>
+        <p14:creationId xmlns:p14="http://schemas.microsoft.com/office/powerpoint/2010/main" val="659587322"/>
       </p:ext>
     </p:extLst>
   </p:cSld>
@@ -1493,7 +1493,7 @@
           <p:cNvPr id="2" name="제목 1">
             <a:extLst>
               <a:ext uri="{FF2B5EF4-FFF2-40B4-BE49-F238E27FC236}">
-                <a16:creationId xmlns:a16="http://schemas.microsoft.com/office/drawing/2014/main" id="{66CBA3EE-674D-6139-1ED5-A3B4E156099A}"/>
+                <a16:creationId xmlns:a16="http://schemas.microsoft.com/office/drawing/2014/main" id="{3E886229-03B0-78E0-B74B-14003F6CBD55}"/>
               </a:ext>
             </a:extLst>
           </p:cNvPr>
@@ -1526,7 +1526,7 @@
           <p:cNvPr id="3" name="텍스트 개체 틀 2">
             <a:extLst>
               <a:ext uri="{FF2B5EF4-FFF2-40B4-BE49-F238E27FC236}">
-                <a16:creationId xmlns:a16="http://schemas.microsoft.com/office/drawing/2014/main" id="{441A35BF-1279-C063-2A50-9AEC81DBDC92}"/>
+                <a16:creationId xmlns:a16="http://schemas.microsoft.com/office/drawing/2014/main" id="{12763DD0-BE52-21ED-383D-DD0F04140FBD}"/>
               </a:ext>
             </a:extLst>
           </p:cNvPr>
@@ -1597,7 +1597,7 @@
           <p:cNvPr id="4" name="내용 개체 틀 3">
             <a:extLst>
               <a:ext uri="{FF2B5EF4-FFF2-40B4-BE49-F238E27FC236}">
-                <a16:creationId xmlns:a16="http://schemas.microsoft.com/office/drawing/2014/main" id="{0F2552BF-FBDD-C1BF-E72A-D073C032BB0B}"/>
+                <a16:creationId xmlns:a16="http://schemas.microsoft.com/office/drawing/2014/main" id="{7A43D0B2-6003-9DA1-F4F3-813467B70A02}"/>
               </a:ext>
             </a:extLst>
           </p:cNvPr>
@@ -1659,7 +1659,7 @@
           <p:cNvPr id="5" name="텍스트 개체 틀 4">
             <a:extLst>
               <a:ext uri="{FF2B5EF4-FFF2-40B4-BE49-F238E27FC236}">
-                <a16:creationId xmlns:a16="http://schemas.microsoft.com/office/drawing/2014/main" id="{FF5F8130-63CF-9CCB-D7E8-112FD3BB09BF}"/>
+                <a16:creationId xmlns:a16="http://schemas.microsoft.com/office/drawing/2014/main" id="{ED85157E-A692-6859-354E-2D0AF779E655}"/>
               </a:ext>
             </a:extLst>
           </p:cNvPr>
@@ -1730,7 +1730,7 @@
           <p:cNvPr id="6" name="내용 개체 틀 5">
             <a:extLst>
               <a:ext uri="{FF2B5EF4-FFF2-40B4-BE49-F238E27FC236}">
-                <a16:creationId xmlns:a16="http://schemas.microsoft.com/office/drawing/2014/main" id="{DA113EE3-57CD-BE90-DDAE-8FA1A17FBCB8}"/>
+                <a16:creationId xmlns:a16="http://schemas.microsoft.com/office/drawing/2014/main" id="{A5CD9491-CF84-0925-8E8C-108F9D73298E}"/>
               </a:ext>
             </a:extLst>
           </p:cNvPr>
@@ -1792,7 +1792,7 @@
           <p:cNvPr id="7" name="날짜 개체 틀 6">
             <a:extLst>
               <a:ext uri="{FF2B5EF4-FFF2-40B4-BE49-F238E27FC236}">
-                <a16:creationId xmlns:a16="http://schemas.microsoft.com/office/drawing/2014/main" id="{55EA23E0-0A15-4EFC-C2F7-ACBA6ED045AF}"/>
+                <a16:creationId xmlns:a16="http://schemas.microsoft.com/office/drawing/2014/main" id="{05578871-7C9E-19A4-9947-A1DA4065B449}"/>
               </a:ext>
             </a:extLst>
           </p:cNvPr>
@@ -1808,7 +1808,7 @@
           <a:bodyPr/>
           <a:lstStyle/>
           <a:p>
-            <a:fld id="{61D2EE60-430B-4588-84F2-5882C97E02B5}" type="datetimeFigureOut">
+            <a:fld id="{15C0B7B1-677A-41FB-B453-90FAB63ECAC5}" type="datetimeFigureOut">
               <a:rPr lang="ko-KR" altLang="en-US" smtClean="0"/>
               <a:t>2026-06-21</a:t>
             </a:fld>
@@ -1821,7 +1821,7 @@
           <p:cNvPr id="8" name="바닥글 개체 틀 7">
             <a:extLst>
               <a:ext uri="{FF2B5EF4-FFF2-40B4-BE49-F238E27FC236}">
-                <a16:creationId xmlns:a16="http://schemas.microsoft.com/office/drawing/2014/main" id="{A25E4BF5-D733-70BA-FC53-FAD80145FDD9}"/>
+                <a16:creationId xmlns:a16="http://schemas.microsoft.com/office/drawing/2014/main" id="{CA02E796-6BFA-791A-4602-9BF9F6A29E1E}"/>
               </a:ext>
             </a:extLst>
           </p:cNvPr>
@@ -1846,7 +1846,7 @@
           <p:cNvPr id="9" name="슬라이드 번호 개체 틀 8">
             <a:extLst>
               <a:ext uri="{FF2B5EF4-FFF2-40B4-BE49-F238E27FC236}">
-                <a16:creationId xmlns:a16="http://schemas.microsoft.com/office/drawing/2014/main" id="{876FD1C1-4223-DC12-1A7F-517DC4FFBB52}"/>
+                <a16:creationId xmlns:a16="http://schemas.microsoft.com/office/drawing/2014/main" id="{8D2C71DB-B530-6F6C-A144-11DCB35ED4D6}"/>
               </a:ext>
             </a:extLst>
           </p:cNvPr>
@@ -1862,7 +1862,7 @@
           <a:bodyPr/>
           <a:lstStyle/>
           <a:p>
-            <a:fld id="{04835B4B-883C-40BD-841B-0E5E6E202C4B}" type="slidenum">
+            <a:fld id="{14F36FE2-5F7D-4CD9-9A15-7CE305A53C22}" type="slidenum">
               <a:rPr lang="ko-KR" altLang="en-US" smtClean="0"/>
               <a:t>‹#›</a:t>
             </a:fld>
@@ -1873,7 +1873,7 @@
     </p:spTree>
     <p:extLst>
       <p:ext uri="{BB962C8B-B14F-4D97-AF65-F5344CB8AC3E}">
-        <p14:creationId xmlns:p14="http://schemas.microsoft.com/office/powerpoint/2010/main" val="1987285344"/>
+        <p14:creationId xmlns:p14="http://schemas.microsoft.com/office/powerpoint/2010/main" val="2964501445"/>
       </p:ext>
     </p:extLst>
   </p:cSld>
@@ -1905,7 +1905,7 @@
           <p:cNvPr id="2" name="제목 1">
             <a:extLst>
               <a:ext uri="{FF2B5EF4-FFF2-40B4-BE49-F238E27FC236}">
-                <a16:creationId xmlns:a16="http://schemas.microsoft.com/office/drawing/2014/main" id="{81D744BC-C6BE-DD6E-25AC-81E0A82667E4}"/>
+                <a16:creationId xmlns:a16="http://schemas.microsoft.com/office/drawing/2014/main" id="{1851BDB0-C8E0-1887-9B86-415568B9B81D}"/>
               </a:ext>
             </a:extLst>
           </p:cNvPr>
@@ -1933,7 +1933,7 @@
           <p:cNvPr id="3" name="날짜 개체 틀 2">
             <a:extLst>
               <a:ext uri="{FF2B5EF4-FFF2-40B4-BE49-F238E27FC236}">
-                <a16:creationId xmlns:a16="http://schemas.microsoft.com/office/drawing/2014/main" id="{9F1ECAD7-5DCF-56AB-4BD6-81DE71C381A9}"/>
+                <a16:creationId xmlns:a16="http://schemas.microsoft.com/office/drawing/2014/main" id="{01106B9C-CB19-DBB2-F987-FB459D779A53}"/>
               </a:ext>
             </a:extLst>
           </p:cNvPr>
@@ -1949,7 +1949,7 @@
           <a:bodyPr/>
           <a:lstStyle/>
           <a:p>
-            <a:fld id="{61D2EE60-430B-4588-84F2-5882C97E02B5}" type="datetimeFigureOut">
+            <a:fld id="{15C0B7B1-677A-41FB-B453-90FAB63ECAC5}" type="datetimeFigureOut">
               <a:rPr lang="ko-KR" altLang="en-US" smtClean="0"/>
               <a:t>2026-06-21</a:t>
             </a:fld>
@@ -1962,7 +1962,7 @@
           <p:cNvPr id="4" name="바닥글 개체 틀 3">
             <a:extLst>
               <a:ext uri="{FF2B5EF4-FFF2-40B4-BE49-F238E27FC236}">
-                <a16:creationId xmlns:a16="http://schemas.microsoft.com/office/drawing/2014/main" id="{972DAD46-1240-CD11-8C84-DC55C2140841}"/>
+                <a16:creationId xmlns:a16="http://schemas.microsoft.com/office/drawing/2014/main" id="{A3EBFE81-3A3F-933F-A57C-947860D0F8F6}"/>
               </a:ext>
             </a:extLst>
           </p:cNvPr>
@@ -1987,7 +1987,7 @@
           <p:cNvPr id="5" name="슬라이드 번호 개체 틀 4">
             <a:extLst>
               <a:ext uri="{FF2B5EF4-FFF2-40B4-BE49-F238E27FC236}">
-                <a16:creationId xmlns:a16="http://schemas.microsoft.com/office/drawing/2014/main" id="{80001214-F2DF-D4A6-8190-A2A6EDB97A58}"/>
+                <a16:creationId xmlns:a16="http://schemas.microsoft.com/office/drawing/2014/main" id="{C3FC8C05-8A87-E996-0318-E8BAC52C1AFC}"/>
               </a:ext>
             </a:extLst>
           </p:cNvPr>
@@ -2003,7 +2003,7 @@
           <a:bodyPr/>
           <a:lstStyle/>
           <a:p>
-            <a:fld id="{04835B4B-883C-40BD-841B-0E5E6E202C4B}" type="slidenum">
+            <a:fld id="{14F36FE2-5F7D-4CD9-9A15-7CE305A53C22}" type="slidenum">
               <a:rPr lang="ko-KR" altLang="en-US" smtClean="0"/>
               <a:t>‹#›</a:t>
             </a:fld>
@@ -2014,7 +2014,7 @@
     </p:spTree>
     <p:extLst>
       <p:ext uri="{BB962C8B-B14F-4D97-AF65-F5344CB8AC3E}">
-        <p14:creationId xmlns:p14="http://schemas.microsoft.com/office/powerpoint/2010/main" val="1786456498"/>
+        <p14:creationId xmlns:p14="http://schemas.microsoft.com/office/powerpoint/2010/main" val="1940399083"/>
       </p:ext>
     </p:extLst>
   </p:cSld>
@@ -2046,7 +2046,7 @@
           <p:cNvPr id="2" name="날짜 개체 틀 1">
             <a:extLst>
               <a:ext uri="{FF2B5EF4-FFF2-40B4-BE49-F238E27FC236}">
-                <a16:creationId xmlns:a16="http://schemas.microsoft.com/office/drawing/2014/main" id="{449A257D-E59F-AF89-9BC5-C2BAF3B59EDD}"/>
+                <a16:creationId xmlns:a16="http://schemas.microsoft.com/office/drawing/2014/main" id="{AA663145-3C87-0B7C-EDC2-D26E03BB79A4}"/>
               </a:ext>
             </a:extLst>
           </p:cNvPr>
@@ -2062,7 +2062,7 @@
           <a:bodyPr/>
           <a:lstStyle/>
           <a:p>
-            <a:fld id="{61D2EE60-430B-4588-84F2-5882C97E02B5}" type="datetimeFigureOut">
+            <a:fld id="{15C0B7B1-677A-41FB-B453-90FAB63ECAC5}" type="datetimeFigureOut">
               <a:rPr lang="ko-KR" altLang="en-US" smtClean="0"/>
               <a:t>2026-06-21</a:t>
             </a:fld>
@@ -2075,7 +2075,7 @@
           <p:cNvPr id="3" name="바닥글 개체 틀 2">
             <a:extLst>
               <a:ext uri="{FF2B5EF4-FFF2-40B4-BE49-F238E27FC236}">
-                <a16:creationId xmlns:a16="http://schemas.microsoft.com/office/drawing/2014/main" id="{2CB2B5CD-3A65-EFC4-74A5-A500DB81565E}"/>
+                <a16:creationId xmlns:a16="http://schemas.microsoft.com/office/drawing/2014/main" id="{AE7B0AA1-3959-96EA-7095-61E0FD043464}"/>
               </a:ext>
             </a:extLst>
           </p:cNvPr>
@@ -2100,7 +2100,7 @@
           <p:cNvPr id="4" name="슬라이드 번호 개체 틀 3">
             <a:extLst>
               <a:ext uri="{FF2B5EF4-FFF2-40B4-BE49-F238E27FC236}">
-                <a16:creationId xmlns:a16="http://schemas.microsoft.com/office/drawing/2014/main" id="{1189ABDD-5A77-7C86-A27D-A58497FFD6F2}"/>
+                <a16:creationId xmlns:a16="http://schemas.microsoft.com/office/drawing/2014/main" id="{BDCFA9DA-E345-A1B5-44DA-456C95E0CD9D}"/>
               </a:ext>
             </a:extLst>
           </p:cNvPr>
@@ -2116,7 +2116,7 @@
           <a:bodyPr/>
           <a:lstStyle/>
           <a:p>
-            <a:fld id="{04835B4B-883C-40BD-841B-0E5E6E202C4B}" type="slidenum">
+            <a:fld id="{14F36FE2-5F7D-4CD9-9A15-7CE305A53C22}" type="slidenum">
               <a:rPr lang="ko-KR" altLang="en-US" smtClean="0"/>
               <a:t>‹#›</a:t>
             </a:fld>
@@ -2127,7 +2127,7 @@
     </p:spTree>
     <p:extLst>
       <p:ext uri="{BB962C8B-B14F-4D97-AF65-F5344CB8AC3E}">
-        <p14:creationId xmlns:p14="http://schemas.microsoft.com/office/powerpoint/2010/main" val="1467799046"/>
+        <p14:creationId xmlns:p14="http://schemas.microsoft.com/office/powerpoint/2010/main" val="1032484525"/>
       </p:ext>
     </p:extLst>
   </p:cSld>
@@ -2159,7 +2159,7 @@
           <p:cNvPr id="2" name="제목 1">
             <a:extLst>
               <a:ext uri="{FF2B5EF4-FFF2-40B4-BE49-F238E27FC236}">
-                <a16:creationId xmlns:a16="http://schemas.microsoft.com/office/drawing/2014/main" id="{85DFE8F4-56C1-0920-DA83-B862E2D39CDA}"/>
+                <a16:creationId xmlns:a16="http://schemas.microsoft.com/office/drawing/2014/main" id="{B6E1CE17-557E-7C6F-9410-5427C5395148}"/>
               </a:ext>
             </a:extLst>
           </p:cNvPr>
@@ -2196,7 +2196,7 @@
           <p:cNvPr id="3" name="내용 개체 틀 2">
             <a:extLst>
               <a:ext uri="{FF2B5EF4-FFF2-40B4-BE49-F238E27FC236}">
-                <a16:creationId xmlns:a16="http://schemas.microsoft.com/office/drawing/2014/main" id="{03FE2211-E872-92FB-5498-EA3A3A50794B}"/>
+                <a16:creationId xmlns:a16="http://schemas.microsoft.com/office/drawing/2014/main" id="{66EDB5C7-CD3B-8EDD-DE1C-954FD975532F}"/>
               </a:ext>
             </a:extLst>
           </p:cNvPr>
@@ -2286,7 +2286,7 @@
           <p:cNvPr id="4" name="텍스트 개체 틀 3">
             <a:extLst>
               <a:ext uri="{FF2B5EF4-FFF2-40B4-BE49-F238E27FC236}">
-                <a16:creationId xmlns:a16="http://schemas.microsoft.com/office/drawing/2014/main" id="{87D3CA41-C761-0C65-B626-C5CF78048751}"/>
+                <a16:creationId xmlns:a16="http://schemas.microsoft.com/office/drawing/2014/main" id="{33D2BE31-40B7-EAC0-BD76-C7DB9A261BA1}"/>
               </a:ext>
             </a:extLst>
           </p:cNvPr>
@@ -2357,7 +2357,7 @@
           <p:cNvPr id="5" name="날짜 개체 틀 4">
             <a:extLst>
               <a:ext uri="{FF2B5EF4-FFF2-40B4-BE49-F238E27FC236}">
-                <a16:creationId xmlns:a16="http://schemas.microsoft.com/office/drawing/2014/main" id="{56405B81-0185-3D35-62B8-D2EF13563204}"/>
+                <a16:creationId xmlns:a16="http://schemas.microsoft.com/office/drawing/2014/main" id="{0E0AA949-8017-7B50-8BDA-AF849D51491D}"/>
               </a:ext>
             </a:extLst>
           </p:cNvPr>
@@ -2373,7 +2373,7 @@
           <a:bodyPr/>
           <a:lstStyle/>
           <a:p>
-            <a:fld id="{61D2EE60-430B-4588-84F2-5882C97E02B5}" type="datetimeFigureOut">
+            <a:fld id="{15C0B7B1-677A-41FB-B453-90FAB63ECAC5}" type="datetimeFigureOut">
               <a:rPr lang="ko-KR" altLang="en-US" smtClean="0"/>
               <a:t>2026-06-21</a:t>
             </a:fld>
@@ -2386,7 +2386,7 @@
           <p:cNvPr id="6" name="바닥글 개체 틀 5">
             <a:extLst>
               <a:ext uri="{FF2B5EF4-FFF2-40B4-BE49-F238E27FC236}">
-                <a16:creationId xmlns:a16="http://schemas.microsoft.com/office/drawing/2014/main" id="{C66FC312-441E-4F3B-8CC2-7230E2BA9A60}"/>
+                <a16:creationId xmlns:a16="http://schemas.microsoft.com/office/drawing/2014/main" id="{F5DB742C-E660-4E19-FC96-71092B8E6D01}"/>
               </a:ext>
             </a:extLst>
           </p:cNvPr>
@@ -2411,7 +2411,7 @@
           <p:cNvPr id="7" name="슬라이드 번호 개체 틀 6">
             <a:extLst>
               <a:ext uri="{FF2B5EF4-FFF2-40B4-BE49-F238E27FC236}">
-                <a16:creationId xmlns:a16="http://schemas.microsoft.com/office/drawing/2014/main" id="{65326699-284C-805A-E8B2-4E51029143C5}"/>
+                <a16:creationId xmlns:a16="http://schemas.microsoft.com/office/drawing/2014/main" id="{8C9C3041-A685-2A19-075D-27B0B089B9B6}"/>
               </a:ext>
             </a:extLst>
           </p:cNvPr>
@@ -2427,7 +2427,7 @@
           <a:bodyPr/>
           <a:lstStyle/>
           <a:p>
-            <a:fld id="{04835B4B-883C-40BD-841B-0E5E6E202C4B}" type="slidenum">
+            <a:fld id="{14F36FE2-5F7D-4CD9-9A15-7CE305A53C22}" type="slidenum">
               <a:rPr lang="ko-KR" altLang="en-US" smtClean="0"/>
               <a:t>‹#›</a:t>
             </a:fld>
@@ -2438,7 +2438,7 @@
     </p:spTree>
     <p:extLst>
       <p:ext uri="{BB962C8B-B14F-4D97-AF65-F5344CB8AC3E}">
-        <p14:creationId xmlns:p14="http://schemas.microsoft.com/office/powerpoint/2010/main" val="4002045868"/>
+        <p14:creationId xmlns:p14="http://schemas.microsoft.com/office/powerpoint/2010/main" val="2499130130"/>
       </p:ext>
     </p:extLst>
   </p:cSld>
@@ -2470,7 +2470,7 @@
           <p:cNvPr id="2" name="제목 1">
             <a:extLst>
               <a:ext uri="{FF2B5EF4-FFF2-40B4-BE49-F238E27FC236}">
-                <a16:creationId xmlns:a16="http://schemas.microsoft.com/office/drawing/2014/main" id="{09DDD962-1B91-6611-8487-10712C67390B}"/>
+                <a16:creationId xmlns:a16="http://schemas.microsoft.com/office/drawing/2014/main" id="{BF03BBBA-6754-A262-8C2B-459DAC1300BA}"/>
               </a:ext>
             </a:extLst>
           </p:cNvPr>
@@ -2507,7 +2507,7 @@
           <p:cNvPr id="3" name="그림 개체 틀 2">
             <a:extLst>
               <a:ext uri="{FF2B5EF4-FFF2-40B4-BE49-F238E27FC236}">
-                <a16:creationId xmlns:a16="http://schemas.microsoft.com/office/drawing/2014/main" id="{836E3CC4-DB94-64DB-AF52-959EE0023807}"/>
+                <a16:creationId xmlns:a16="http://schemas.microsoft.com/office/drawing/2014/main" id="{5CDA0BE9-61C1-D592-B06C-5BEB7FCE04F0}"/>
               </a:ext>
             </a:extLst>
           </p:cNvPr>
@@ -2574,7 +2574,7 @@
           <p:cNvPr id="4" name="텍스트 개체 틀 3">
             <a:extLst>
               <a:ext uri="{FF2B5EF4-FFF2-40B4-BE49-F238E27FC236}">
-                <a16:creationId xmlns:a16="http://schemas.microsoft.com/office/drawing/2014/main" id="{B37C1BE1-5F97-9027-30D0-84ED298678D2}"/>
+                <a16:creationId xmlns:a16="http://schemas.microsoft.com/office/drawing/2014/main" id="{914947E2-A8B4-97EB-7621-B7B1D07EA027}"/>
               </a:ext>
             </a:extLst>
           </p:cNvPr>
@@ -2645,7 +2645,7 @@
           <p:cNvPr id="5" name="날짜 개체 틀 4">
             <a:extLst>
               <a:ext uri="{FF2B5EF4-FFF2-40B4-BE49-F238E27FC236}">
-                <a16:creationId xmlns:a16="http://schemas.microsoft.com/office/drawing/2014/main" id="{F4B3AA63-11C8-F211-B23E-B09AE7A96DB3}"/>
+                <a16:creationId xmlns:a16="http://schemas.microsoft.com/office/drawing/2014/main" id="{8B3962C0-A298-8E3F-24F7-692B2DFB6A20}"/>
               </a:ext>
             </a:extLst>
           </p:cNvPr>
@@ -2661,7 +2661,7 @@
           <a:bodyPr/>
           <a:lstStyle/>
           <a:p>
-            <a:fld id="{61D2EE60-430B-4588-84F2-5882C97E02B5}" type="datetimeFigureOut">
+            <a:fld id="{15C0B7B1-677A-41FB-B453-90FAB63ECAC5}" type="datetimeFigureOut">
               <a:rPr lang="ko-KR" altLang="en-US" smtClean="0"/>
               <a:t>2026-06-21</a:t>
             </a:fld>
@@ -2674,7 +2674,7 @@
           <p:cNvPr id="6" name="바닥글 개체 틀 5">
             <a:extLst>
               <a:ext uri="{FF2B5EF4-FFF2-40B4-BE49-F238E27FC236}">
-                <a16:creationId xmlns:a16="http://schemas.microsoft.com/office/drawing/2014/main" id="{3A0DC9E3-FEC0-A9DF-794A-B90BCE2D4FB1}"/>
+                <a16:creationId xmlns:a16="http://schemas.microsoft.com/office/drawing/2014/main" id="{64BF42F4-3900-E808-FE62-81AA166BC964}"/>
               </a:ext>
             </a:extLst>
           </p:cNvPr>
@@ -2699,7 +2699,7 @@
           <p:cNvPr id="7" name="슬라이드 번호 개체 틀 6">
             <a:extLst>
               <a:ext uri="{FF2B5EF4-FFF2-40B4-BE49-F238E27FC236}">
-                <a16:creationId xmlns:a16="http://schemas.microsoft.com/office/drawing/2014/main" id="{AA2F82B7-4ABE-3EE4-E919-2B93861429F7}"/>
+                <a16:creationId xmlns:a16="http://schemas.microsoft.com/office/drawing/2014/main" id="{16C79FBC-22F7-3AA6-1F89-CDB2BCA8D22E}"/>
               </a:ext>
             </a:extLst>
           </p:cNvPr>
@@ -2715,7 +2715,7 @@
           <a:bodyPr/>
           <a:lstStyle/>
           <a:p>
-            <a:fld id="{04835B4B-883C-40BD-841B-0E5E6E202C4B}" type="slidenum">
+            <a:fld id="{14F36FE2-5F7D-4CD9-9A15-7CE305A53C22}" type="slidenum">
               <a:rPr lang="ko-KR" altLang="en-US" smtClean="0"/>
               <a:t>‹#›</a:t>
             </a:fld>
@@ -2726,7 +2726,7 @@
     </p:spTree>
     <p:extLst>
       <p:ext uri="{BB962C8B-B14F-4D97-AF65-F5344CB8AC3E}">
-        <p14:creationId xmlns:p14="http://schemas.microsoft.com/office/powerpoint/2010/main" val="1466850284"/>
+        <p14:creationId xmlns:p14="http://schemas.microsoft.com/office/powerpoint/2010/main" val="2934782820"/>
       </p:ext>
     </p:extLst>
   </p:cSld>
@@ -2763,7 +2763,7 @@
           <p:cNvPr id="2" name="제목 개체 틀 1">
             <a:extLst>
               <a:ext uri="{FF2B5EF4-FFF2-40B4-BE49-F238E27FC236}">
-                <a16:creationId xmlns:a16="http://schemas.microsoft.com/office/drawing/2014/main" id="{4847ABB8-59FD-CA93-3A17-BE1D46C911DA}"/>
+                <a16:creationId xmlns:a16="http://schemas.microsoft.com/office/drawing/2014/main" id="{1B819CAB-B37E-715D-9C09-50A0E3A82F17}"/>
               </a:ext>
             </a:extLst>
           </p:cNvPr>
@@ -2801,7 +2801,7 @@
           <p:cNvPr id="3" name="텍스트 개체 틀 2">
             <a:extLst>
               <a:ext uri="{FF2B5EF4-FFF2-40B4-BE49-F238E27FC236}">
-                <a16:creationId xmlns:a16="http://schemas.microsoft.com/office/drawing/2014/main" id="{07FCE8E2-D6CF-442F-901B-433938325B30}"/>
+                <a16:creationId xmlns:a16="http://schemas.microsoft.com/office/drawing/2014/main" id="{EDF9A95C-CF10-BA42-493D-59F5D6A315DE}"/>
               </a:ext>
             </a:extLst>
           </p:cNvPr>
@@ -2868,7 +2868,7 @@
           <p:cNvPr id="4" name="날짜 개체 틀 3">
             <a:extLst>
               <a:ext uri="{FF2B5EF4-FFF2-40B4-BE49-F238E27FC236}">
-                <a16:creationId xmlns:a16="http://schemas.microsoft.com/office/drawing/2014/main" id="{A212EB43-6378-2E2A-19A2-87C9284AA6F0}"/>
+                <a16:creationId xmlns:a16="http://schemas.microsoft.com/office/drawing/2014/main" id="{E3BF9A9A-C450-A1F1-2A87-FA3A3B2E99A6}"/>
               </a:ext>
             </a:extLst>
           </p:cNvPr>
@@ -2902,7 +2902,7 @@
             </a:lvl1pPr>
           </a:lstStyle>
           <a:p>
-            <a:fld id="{61D2EE60-430B-4588-84F2-5882C97E02B5}" type="datetimeFigureOut">
+            <a:fld id="{15C0B7B1-677A-41FB-B453-90FAB63ECAC5}" type="datetimeFigureOut">
               <a:rPr lang="ko-KR" altLang="en-US" smtClean="0"/>
               <a:t>2026-06-21</a:t>
             </a:fld>
@@ -2915,7 +2915,7 @@
           <p:cNvPr id="5" name="바닥글 개체 틀 4">
             <a:extLst>
               <a:ext uri="{FF2B5EF4-FFF2-40B4-BE49-F238E27FC236}">
-                <a16:creationId xmlns:a16="http://schemas.microsoft.com/office/drawing/2014/main" id="{DB7F0C51-FB7C-F87D-C4CF-4A7C9FF9D6BF}"/>
+                <a16:creationId xmlns:a16="http://schemas.microsoft.com/office/drawing/2014/main" id="{838FB9F4-796A-5E63-C8A9-C4F5C5335A4F}"/>
               </a:ext>
             </a:extLst>
           </p:cNvPr>
@@ -2958,7 +2958,7 @@
           <p:cNvPr id="6" name="슬라이드 번호 개체 틀 5">
             <a:extLst>
               <a:ext uri="{FF2B5EF4-FFF2-40B4-BE49-F238E27FC236}">
-                <a16:creationId xmlns:a16="http://schemas.microsoft.com/office/drawing/2014/main" id="{DDED3D67-6293-E6AD-D00F-A7EFD9EAAC72}"/>
+                <a16:creationId xmlns:a16="http://schemas.microsoft.com/office/drawing/2014/main" id="{3D1586C0-8C60-7056-E270-BEB12732444D}"/>
               </a:ext>
             </a:extLst>
           </p:cNvPr>
@@ -2992,7 +2992,7 @@
             </a:lvl1pPr>
           </a:lstStyle>
           <a:p>
-            <a:fld id="{04835B4B-883C-40BD-841B-0E5E6E202C4B}" type="slidenum">
+            <a:fld id="{14F36FE2-5F7D-4CD9-9A15-7CE305A53C22}" type="slidenum">
               <a:rPr lang="ko-KR" altLang="en-US" smtClean="0"/>
               <a:t>‹#›</a:t>
             </a:fld>
@@ -3003,7 +3003,7 @@
     </p:spTree>
     <p:extLst>
       <p:ext uri="{BB962C8B-B14F-4D97-AF65-F5344CB8AC3E}">
-        <p14:creationId xmlns:p14="http://schemas.microsoft.com/office/powerpoint/2010/main" val="735943349"/>
+        <p14:creationId xmlns:p14="http://schemas.microsoft.com/office/powerpoint/2010/main" val="4285767319"/>
       </p:ext>
     </p:extLst>
   </p:cSld>
@@ -3334,7 +3334,7 @@
           <p:cNvPr id="2" name="직사각형 1">
             <a:extLst>
               <a:ext uri="{FF2B5EF4-FFF2-40B4-BE49-F238E27FC236}">
-                <a16:creationId xmlns:a16="http://schemas.microsoft.com/office/drawing/2014/main" id="{0448F5C8-AF95-46FF-6014-6E4C3B4D9EF0}"/>
+                <a16:creationId xmlns:a16="http://schemas.microsoft.com/office/drawing/2014/main" id="{2186499B-E17B-DD8E-5DFF-4D26864BF62F}"/>
               </a:ext>
             </a:extLst>
           </p:cNvPr>
@@ -3388,7 +3388,7 @@
           <p:cNvPr id="3" name="TextBox 2">
             <a:extLst>
               <a:ext uri="{FF2B5EF4-FFF2-40B4-BE49-F238E27FC236}">
-                <a16:creationId xmlns:a16="http://schemas.microsoft.com/office/drawing/2014/main" id="{C698CF23-9854-8FAF-6CF1-01327A278C00}"/>
+                <a16:creationId xmlns:a16="http://schemas.microsoft.com/office/drawing/2014/main" id="{EB6CBAF6-F989-F9D4-B6CC-31D8AC1AA83B}"/>
               </a:ext>
             </a:extLst>
           </p:cNvPr>
@@ -3434,7 +3434,7 @@
           <p:cNvPr id="4" name="TextBox 3">
             <a:extLst>
               <a:ext uri="{FF2B5EF4-FFF2-40B4-BE49-F238E27FC236}">
-                <a16:creationId xmlns:a16="http://schemas.microsoft.com/office/drawing/2014/main" id="{A7A11A41-B37C-36AE-131E-7A48E3F5B17F}"/>
+                <a16:creationId xmlns:a16="http://schemas.microsoft.com/office/drawing/2014/main" id="{103ABBE3-98FA-2562-C37D-6FA2E0563040}"/>
               </a:ext>
             </a:extLst>
           </p:cNvPr>
@@ -3480,7 +3480,7 @@
           <p:cNvPr id="5" name="직사각형 4">
             <a:extLst>
               <a:ext uri="{FF2B5EF4-FFF2-40B4-BE49-F238E27FC236}">
-                <a16:creationId xmlns:a16="http://schemas.microsoft.com/office/drawing/2014/main" id="{3935F2F4-CF8A-2D38-556F-634AAB04311F}"/>
+                <a16:creationId xmlns:a16="http://schemas.microsoft.com/office/drawing/2014/main" id="{53FD80F4-C8A0-0099-FA62-E32700A1D97A}"/>
               </a:ext>
             </a:extLst>
           </p:cNvPr>
@@ -3534,7 +3534,7 @@
           <p:cNvPr id="6" name="직사각형 5">
             <a:extLst>
               <a:ext uri="{FF2B5EF4-FFF2-40B4-BE49-F238E27FC236}">
-                <a16:creationId xmlns:a16="http://schemas.microsoft.com/office/drawing/2014/main" id="{5F5A6928-47E2-96CC-DD22-48C13283A721}"/>
+                <a16:creationId xmlns:a16="http://schemas.microsoft.com/office/drawing/2014/main" id="{923BEF26-2CBB-A4A6-45BF-769127CDE8F5}"/>
               </a:ext>
             </a:extLst>
           </p:cNvPr>
@@ -3588,7 +3588,7 @@
           <p:cNvPr id="7" name="직사각형 6">
             <a:extLst>
               <a:ext uri="{FF2B5EF4-FFF2-40B4-BE49-F238E27FC236}">
-                <a16:creationId xmlns:a16="http://schemas.microsoft.com/office/drawing/2014/main" id="{1A72F7A3-D3D4-053F-6A75-F5BEB26522E7}"/>
+                <a16:creationId xmlns:a16="http://schemas.microsoft.com/office/drawing/2014/main" id="{6C6A4277-4C67-1339-5710-5DE4D72F6D44}"/>
               </a:ext>
             </a:extLst>
           </p:cNvPr>
@@ -3642,7 +3642,7 @@
           <p:cNvPr id="8" name="직사각형 7">
             <a:extLst>
               <a:ext uri="{FF2B5EF4-FFF2-40B4-BE49-F238E27FC236}">
-                <a16:creationId xmlns:a16="http://schemas.microsoft.com/office/drawing/2014/main" id="{47AAC75D-54C1-5001-EE41-8BE166DC486E}"/>
+                <a16:creationId xmlns:a16="http://schemas.microsoft.com/office/drawing/2014/main" id="{E4BFE455-15A0-6D16-6C23-84022E06E56A}"/>
               </a:ext>
             </a:extLst>
           </p:cNvPr>
@@ -3696,7 +3696,7 @@
           <p:cNvPr id="9" name="사각형: 둥근 모서리 8">
             <a:extLst>
               <a:ext uri="{FF2B5EF4-FFF2-40B4-BE49-F238E27FC236}">
-                <a16:creationId xmlns:a16="http://schemas.microsoft.com/office/drawing/2014/main" id="{A09A76C3-0500-5646-8766-0C710120C32B}"/>
+                <a16:creationId xmlns:a16="http://schemas.microsoft.com/office/drawing/2014/main" id="{CFA68D59-8C13-A353-3D3E-F330CA322DD0}"/>
               </a:ext>
             </a:extLst>
           </p:cNvPr>
@@ -3766,7 +3766,7 @@
           <p:cNvPr id="10" name="사각형: 둥근 모서리 9">
             <a:extLst>
               <a:ext uri="{FF2B5EF4-FFF2-40B4-BE49-F238E27FC236}">
-                <a16:creationId xmlns:a16="http://schemas.microsoft.com/office/drawing/2014/main" id="{6D72F19E-0475-C53A-FAE1-2BF66047DB5F}"/>
+                <a16:creationId xmlns:a16="http://schemas.microsoft.com/office/drawing/2014/main" id="{725D290E-FBEE-FC40-AA00-493E02593468}"/>
               </a:ext>
             </a:extLst>
           </p:cNvPr>
@@ -3820,7 +3820,7 @@
           <p:cNvPr id="11" name="TextBox 10">
             <a:extLst>
               <a:ext uri="{FF2B5EF4-FFF2-40B4-BE49-F238E27FC236}">
-                <a16:creationId xmlns:a16="http://schemas.microsoft.com/office/drawing/2014/main" id="{DE6D7FB0-D015-6D9C-B851-56E9E200F7B7}"/>
+                <a16:creationId xmlns:a16="http://schemas.microsoft.com/office/drawing/2014/main" id="{00BC7D34-535E-9C36-BB98-555CC7B22FEE}"/>
               </a:ext>
             </a:extLst>
           </p:cNvPr>
@@ -3866,7 +3866,7 @@
           <p:cNvPr id="12" name="TextBox 11">
             <a:extLst>
               <a:ext uri="{FF2B5EF4-FFF2-40B4-BE49-F238E27FC236}">
-                <a16:creationId xmlns:a16="http://schemas.microsoft.com/office/drawing/2014/main" id="{5F446DB3-9A18-87AD-3C9D-33C771E59B1D}"/>
+                <a16:creationId xmlns:a16="http://schemas.microsoft.com/office/drawing/2014/main" id="{1B9DD678-D8CC-3007-CBE7-C603465222CB}"/>
               </a:ext>
             </a:extLst>
           </p:cNvPr>
@@ -3912,7 +3912,7 @@
           <p:cNvPr id="13" name="사각형: 둥근 모서리 12">
             <a:extLst>
               <a:ext uri="{FF2B5EF4-FFF2-40B4-BE49-F238E27FC236}">
-                <a16:creationId xmlns:a16="http://schemas.microsoft.com/office/drawing/2014/main" id="{F97C030B-99ED-4021-ADE1-6CD9F635DCC2}"/>
+                <a16:creationId xmlns:a16="http://schemas.microsoft.com/office/drawing/2014/main" id="{91D230D6-0495-CF4D-8052-27382547F8DF}"/>
               </a:ext>
             </a:extLst>
           </p:cNvPr>
@@ -3982,7 +3982,7 @@
           <p:cNvPr id="14" name="사각형: 둥근 모서리 13">
             <a:extLst>
               <a:ext uri="{FF2B5EF4-FFF2-40B4-BE49-F238E27FC236}">
-                <a16:creationId xmlns:a16="http://schemas.microsoft.com/office/drawing/2014/main" id="{61FC47E9-6BE8-9A06-04F2-05022284A3B3}"/>
+                <a16:creationId xmlns:a16="http://schemas.microsoft.com/office/drawing/2014/main" id="{558EBA79-4AAA-6282-8FE5-A029A97BA9DE}"/>
               </a:ext>
             </a:extLst>
           </p:cNvPr>
@@ -4036,7 +4036,7 @@
           <p:cNvPr id="15" name="TextBox 14">
             <a:extLst>
               <a:ext uri="{FF2B5EF4-FFF2-40B4-BE49-F238E27FC236}">
-                <a16:creationId xmlns:a16="http://schemas.microsoft.com/office/drawing/2014/main" id="{1A031B8D-5341-8308-34CF-3555D3524083}"/>
+                <a16:creationId xmlns:a16="http://schemas.microsoft.com/office/drawing/2014/main" id="{A5D7BD17-C733-88D7-AF0C-1CAD17C73134}"/>
               </a:ext>
             </a:extLst>
           </p:cNvPr>
@@ -4082,7 +4082,7 @@
           <p:cNvPr id="16" name="TextBox 15">
             <a:extLst>
               <a:ext uri="{FF2B5EF4-FFF2-40B4-BE49-F238E27FC236}">
-                <a16:creationId xmlns:a16="http://schemas.microsoft.com/office/drawing/2014/main" id="{BC94B800-68F9-BD76-F33E-1B9D522551E5}"/>
+                <a16:creationId xmlns:a16="http://schemas.microsoft.com/office/drawing/2014/main" id="{CB5C0756-37BE-7B09-C2F6-57BA947CF332}"/>
               </a:ext>
             </a:extLst>
           </p:cNvPr>
@@ -4128,7 +4128,7 @@
           <p:cNvPr id="17" name="사각형: 둥근 모서리 16">
             <a:extLst>
               <a:ext uri="{FF2B5EF4-FFF2-40B4-BE49-F238E27FC236}">
-                <a16:creationId xmlns:a16="http://schemas.microsoft.com/office/drawing/2014/main" id="{DC93C77C-31C9-1C15-F033-A6DEC79B8C10}"/>
+                <a16:creationId xmlns:a16="http://schemas.microsoft.com/office/drawing/2014/main" id="{616907A4-CBA6-5EB5-497A-8CC3DAA45947}"/>
               </a:ext>
             </a:extLst>
           </p:cNvPr>
@@ -4198,7 +4198,7 @@
           <p:cNvPr id="18" name="사각형: 둥근 모서리 17">
             <a:extLst>
               <a:ext uri="{FF2B5EF4-FFF2-40B4-BE49-F238E27FC236}">
-                <a16:creationId xmlns:a16="http://schemas.microsoft.com/office/drawing/2014/main" id="{140A0549-576F-CE93-B849-7C9149C33C72}"/>
+                <a16:creationId xmlns:a16="http://schemas.microsoft.com/office/drawing/2014/main" id="{2EC3BF48-1F3F-4CD8-3EFB-051CF93DFA61}"/>
               </a:ext>
             </a:extLst>
           </p:cNvPr>
@@ -4252,7 +4252,7 @@
           <p:cNvPr id="19" name="TextBox 18">
             <a:extLst>
               <a:ext uri="{FF2B5EF4-FFF2-40B4-BE49-F238E27FC236}">
-                <a16:creationId xmlns:a16="http://schemas.microsoft.com/office/drawing/2014/main" id="{30B3B763-BD48-9475-10AA-F1AF21C9DB32}"/>
+                <a16:creationId xmlns:a16="http://schemas.microsoft.com/office/drawing/2014/main" id="{CEF6D7B7-2AD1-90DA-BF0E-D1E89C70D7AF}"/>
               </a:ext>
             </a:extLst>
           </p:cNvPr>
@@ -4298,7 +4298,7 @@
           <p:cNvPr id="20" name="TextBox 19">
             <a:extLst>
               <a:ext uri="{FF2B5EF4-FFF2-40B4-BE49-F238E27FC236}">
-                <a16:creationId xmlns:a16="http://schemas.microsoft.com/office/drawing/2014/main" id="{79838B57-277B-63A9-2B64-92ADBCADDB94}"/>
+                <a16:creationId xmlns:a16="http://schemas.microsoft.com/office/drawing/2014/main" id="{9F831608-E5AA-749E-12DF-92B1F65F293A}"/>
               </a:ext>
             </a:extLst>
           </p:cNvPr>
@@ -4344,7 +4344,7 @@
           <p:cNvPr id="21" name="사각형: 둥근 모서리 20">
             <a:extLst>
               <a:ext uri="{FF2B5EF4-FFF2-40B4-BE49-F238E27FC236}">
-                <a16:creationId xmlns:a16="http://schemas.microsoft.com/office/drawing/2014/main" id="{184B4B6C-DC70-3772-9828-3CF523368A1F}"/>
+                <a16:creationId xmlns:a16="http://schemas.microsoft.com/office/drawing/2014/main" id="{67374211-FEEC-94E3-315B-88D5B105527E}"/>
               </a:ext>
             </a:extLst>
           </p:cNvPr>
@@ -4414,7 +4414,7 @@
           <p:cNvPr id="22" name="사각형: 둥근 모서리 21">
             <a:extLst>
               <a:ext uri="{FF2B5EF4-FFF2-40B4-BE49-F238E27FC236}">
-                <a16:creationId xmlns:a16="http://schemas.microsoft.com/office/drawing/2014/main" id="{0AE4D1B1-DE8D-80CA-CFCB-6B83A18FB0AB}"/>
+                <a16:creationId xmlns:a16="http://schemas.microsoft.com/office/drawing/2014/main" id="{24D32F66-D6E0-8AE5-1B1D-697F3B67E78E}"/>
               </a:ext>
             </a:extLst>
           </p:cNvPr>
@@ -4468,7 +4468,7 @@
           <p:cNvPr id="23" name="TextBox 22">
             <a:extLst>
               <a:ext uri="{FF2B5EF4-FFF2-40B4-BE49-F238E27FC236}">
-                <a16:creationId xmlns:a16="http://schemas.microsoft.com/office/drawing/2014/main" id="{419AE274-1F43-52FA-6DFC-9E7C09971759}"/>
+                <a16:creationId xmlns:a16="http://schemas.microsoft.com/office/drawing/2014/main" id="{CC4CFEFC-9AC5-AC40-3FFD-A8F29CBB8A12}"/>
               </a:ext>
             </a:extLst>
           </p:cNvPr>
@@ -4514,7 +4514,7 @@
           <p:cNvPr id="24" name="TextBox 23">
             <a:extLst>
               <a:ext uri="{FF2B5EF4-FFF2-40B4-BE49-F238E27FC236}">
-                <a16:creationId xmlns:a16="http://schemas.microsoft.com/office/drawing/2014/main" id="{E37BF53D-7F1C-8034-9650-9AB668E3668B}"/>
+                <a16:creationId xmlns:a16="http://schemas.microsoft.com/office/drawing/2014/main" id="{84E2AD27-65AE-857E-BEE5-0D3CA2206B73}"/>
               </a:ext>
             </a:extLst>
           </p:cNvPr>
@@ -4560,7 +4560,7 @@
           <p:cNvPr id="25" name="사각형: 둥근 모서리 24">
             <a:extLst>
               <a:ext uri="{FF2B5EF4-FFF2-40B4-BE49-F238E27FC236}">
-                <a16:creationId xmlns:a16="http://schemas.microsoft.com/office/drawing/2014/main" id="{7FD492F8-2CA7-6F1C-6853-0FAC89508661}"/>
+                <a16:creationId xmlns:a16="http://schemas.microsoft.com/office/drawing/2014/main" id="{1C3F3631-F691-426F-AA70-F8875FCB72FA}"/>
               </a:ext>
             </a:extLst>
           </p:cNvPr>
@@ -4630,7 +4630,7 @@
           <p:cNvPr id="26" name="사각형: 둥근 모서리 25">
             <a:extLst>
               <a:ext uri="{FF2B5EF4-FFF2-40B4-BE49-F238E27FC236}">
-                <a16:creationId xmlns:a16="http://schemas.microsoft.com/office/drawing/2014/main" id="{D1D6CF5E-DFE7-5597-60E6-876CBF6A7DF5}"/>
+                <a16:creationId xmlns:a16="http://schemas.microsoft.com/office/drawing/2014/main" id="{69C2EF00-DB2F-DC58-36A8-B17AFFD5257A}"/>
               </a:ext>
             </a:extLst>
           </p:cNvPr>
@@ -4684,7 +4684,7 @@
           <p:cNvPr id="27" name="TextBox 26">
             <a:extLst>
               <a:ext uri="{FF2B5EF4-FFF2-40B4-BE49-F238E27FC236}">
-                <a16:creationId xmlns:a16="http://schemas.microsoft.com/office/drawing/2014/main" id="{45690CD0-AC15-D9C2-10D7-C90D237324A3}"/>
+                <a16:creationId xmlns:a16="http://schemas.microsoft.com/office/drawing/2014/main" id="{A81B611B-8BEC-8B4F-0970-3CE5D9220082}"/>
               </a:ext>
             </a:extLst>
           </p:cNvPr>
@@ -4731,7 +4731,7 @@
           <p:cNvPr id="28" name="사각형: 둥근 모서리 27">
             <a:extLst>
               <a:ext uri="{FF2B5EF4-FFF2-40B4-BE49-F238E27FC236}">
-                <a16:creationId xmlns:a16="http://schemas.microsoft.com/office/drawing/2014/main" id="{D97A83FB-9804-2B91-9669-FBE06285889D}"/>
+                <a16:creationId xmlns:a16="http://schemas.microsoft.com/office/drawing/2014/main" id="{51F74EB4-302A-C7B9-AD31-4606EAC14318}"/>
               </a:ext>
             </a:extLst>
           </p:cNvPr>
@@ -4801,7 +4801,7 @@
           <p:cNvPr id="29" name="사각형: 둥근 모서리 28">
             <a:extLst>
               <a:ext uri="{FF2B5EF4-FFF2-40B4-BE49-F238E27FC236}">
-                <a16:creationId xmlns:a16="http://schemas.microsoft.com/office/drawing/2014/main" id="{0531A797-8204-D307-121C-97BE33E6E0F4}"/>
+                <a16:creationId xmlns:a16="http://schemas.microsoft.com/office/drawing/2014/main" id="{5FDCE34D-AA65-A43C-7E00-15030873600E}"/>
               </a:ext>
             </a:extLst>
           </p:cNvPr>
@@ -4855,7 +4855,7 @@
           <p:cNvPr id="30" name="타원 29">
             <a:extLst>
               <a:ext uri="{FF2B5EF4-FFF2-40B4-BE49-F238E27FC236}">
-                <a16:creationId xmlns:a16="http://schemas.microsoft.com/office/drawing/2014/main" id="{86D0379C-0D4A-CD0C-17D1-E4470EDDAE94}"/>
+                <a16:creationId xmlns:a16="http://schemas.microsoft.com/office/drawing/2014/main" id="{5EEF364A-3D17-1EC6-5FA6-052D42C1CF57}"/>
               </a:ext>
             </a:extLst>
           </p:cNvPr>
@@ -4909,7 +4909,7 @@
           <p:cNvPr id="31" name="TextBox 30">
             <a:extLst>
               <a:ext uri="{FF2B5EF4-FFF2-40B4-BE49-F238E27FC236}">
-                <a16:creationId xmlns:a16="http://schemas.microsoft.com/office/drawing/2014/main" id="{A6C0B3C9-2FD7-6C8F-7A59-F99D4A7E64E1}"/>
+                <a16:creationId xmlns:a16="http://schemas.microsoft.com/office/drawing/2014/main" id="{6BE9040C-D3D6-6A32-0548-E534849F5459}"/>
               </a:ext>
             </a:extLst>
           </p:cNvPr>
@@ -4955,7 +4955,7 @@
           <p:cNvPr id="32" name="TextBox 31">
             <a:extLst>
               <a:ext uri="{FF2B5EF4-FFF2-40B4-BE49-F238E27FC236}">
-                <a16:creationId xmlns:a16="http://schemas.microsoft.com/office/drawing/2014/main" id="{4CB823A7-2C27-9E4B-1E40-F340B2754760}"/>
+                <a16:creationId xmlns:a16="http://schemas.microsoft.com/office/drawing/2014/main" id="{6FE691DB-5CF0-A63C-F42A-EFD8C2D8A773}"/>
               </a:ext>
             </a:extLst>
           </p:cNvPr>
@@ -5001,7 +5001,7 @@
           <p:cNvPr id="33" name="TextBox 32">
             <a:extLst>
               <a:ext uri="{FF2B5EF4-FFF2-40B4-BE49-F238E27FC236}">
-                <a16:creationId xmlns:a16="http://schemas.microsoft.com/office/drawing/2014/main" id="{7F4DD6A5-6B5D-9051-28CB-035AA9AEEB95}"/>
+                <a16:creationId xmlns:a16="http://schemas.microsoft.com/office/drawing/2014/main" id="{3F8CB4E7-2851-BDB0-6DC0-617F197AEB28}"/>
               </a:ext>
             </a:extLst>
           </p:cNvPr>
@@ -5047,7 +5047,7 @@
           <p:cNvPr id="34" name="사각형: 둥근 모서리 33">
             <a:extLst>
               <a:ext uri="{FF2B5EF4-FFF2-40B4-BE49-F238E27FC236}">
-                <a16:creationId xmlns:a16="http://schemas.microsoft.com/office/drawing/2014/main" id="{A32BFDA7-A249-89DC-1434-F92C67A02AA8}"/>
+                <a16:creationId xmlns:a16="http://schemas.microsoft.com/office/drawing/2014/main" id="{B3204C2E-3892-20BA-1DDE-73795388AC9D}"/>
               </a:ext>
             </a:extLst>
           </p:cNvPr>
@@ -5117,7 +5117,7 @@
           <p:cNvPr id="35" name="사각형: 둥근 모서리 34">
             <a:extLst>
               <a:ext uri="{FF2B5EF4-FFF2-40B4-BE49-F238E27FC236}">
-                <a16:creationId xmlns:a16="http://schemas.microsoft.com/office/drawing/2014/main" id="{834EDC95-9B43-DC77-2CD7-FE56A77BFFE8}"/>
+                <a16:creationId xmlns:a16="http://schemas.microsoft.com/office/drawing/2014/main" id="{1FC5F13E-6988-5BF0-4E41-D64BB16D13A4}"/>
               </a:ext>
             </a:extLst>
           </p:cNvPr>
@@ -5171,7 +5171,7 @@
           <p:cNvPr id="36" name="타원 35">
             <a:extLst>
               <a:ext uri="{FF2B5EF4-FFF2-40B4-BE49-F238E27FC236}">
-                <a16:creationId xmlns:a16="http://schemas.microsoft.com/office/drawing/2014/main" id="{736BC03C-5BDF-B4F4-886B-7B2B991CF3CD}"/>
+                <a16:creationId xmlns:a16="http://schemas.microsoft.com/office/drawing/2014/main" id="{5655EDF6-08CB-40C1-6103-F7E4B8293559}"/>
               </a:ext>
             </a:extLst>
           </p:cNvPr>
@@ -5225,7 +5225,7 @@
           <p:cNvPr id="37" name="TextBox 36">
             <a:extLst>
               <a:ext uri="{FF2B5EF4-FFF2-40B4-BE49-F238E27FC236}">
-                <a16:creationId xmlns:a16="http://schemas.microsoft.com/office/drawing/2014/main" id="{B10E09B3-513C-BA7C-0688-AF8142919951}"/>
+                <a16:creationId xmlns:a16="http://schemas.microsoft.com/office/drawing/2014/main" id="{5F53A1E4-348A-DCD5-1530-E20EAB311EC1}"/>
               </a:ext>
             </a:extLst>
           </p:cNvPr>
@@ -5271,7 +5271,7 @@
           <p:cNvPr id="38" name="TextBox 37">
             <a:extLst>
               <a:ext uri="{FF2B5EF4-FFF2-40B4-BE49-F238E27FC236}">
-                <a16:creationId xmlns:a16="http://schemas.microsoft.com/office/drawing/2014/main" id="{5888E2FB-3BA2-422D-FF95-27925C8DC0D4}"/>
+                <a16:creationId xmlns:a16="http://schemas.microsoft.com/office/drawing/2014/main" id="{90779AB8-1D7E-7961-16D9-DBA092DA880D}"/>
               </a:ext>
             </a:extLst>
           </p:cNvPr>
@@ -5317,7 +5317,7 @@
           <p:cNvPr id="39" name="TextBox 38">
             <a:extLst>
               <a:ext uri="{FF2B5EF4-FFF2-40B4-BE49-F238E27FC236}">
-                <a16:creationId xmlns:a16="http://schemas.microsoft.com/office/drawing/2014/main" id="{A1AA1457-7976-A995-7CA5-97D0C0FA5B8C}"/>
+                <a16:creationId xmlns:a16="http://schemas.microsoft.com/office/drawing/2014/main" id="{EC7F17EC-7561-A140-E70D-A68BB6C5CDB5}"/>
               </a:ext>
             </a:extLst>
           </p:cNvPr>
@@ -5363,7 +5363,7 @@
           <p:cNvPr id="40" name="직선 연결선 39">
             <a:extLst>
               <a:ext uri="{FF2B5EF4-FFF2-40B4-BE49-F238E27FC236}">
-                <a16:creationId xmlns:a16="http://schemas.microsoft.com/office/drawing/2014/main" id="{736B41C8-53BD-5010-C5BB-6E7A7FC3B13C}"/>
+                <a16:creationId xmlns:a16="http://schemas.microsoft.com/office/drawing/2014/main" id="{2814C7AF-772B-C04B-91F3-E034749F91E7}"/>
               </a:ext>
             </a:extLst>
           </p:cNvPr>
@@ -5406,7 +5406,7 @@
           <p:cNvPr id="41" name="직선 연결선 40">
             <a:extLst>
               <a:ext uri="{FF2B5EF4-FFF2-40B4-BE49-F238E27FC236}">
-                <a16:creationId xmlns:a16="http://schemas.microsoft.com/office/drawing/2014/main" id="{4BB2B9A7-0F9A-0E45-A25D-A27BACC577C1}"/>
+                <a16:creationId xmlns:a16="http://schemas.microsoft.com/office/drawing/2014/main" id="{9763755B-E6B6-47F5-8AB9-E05AC95B03D3}"/>
               </a:ext>
             </a:extLst>
           </p:cNvPr>
@@ -5449,7 +5449,7 @@
           <p:cNvPr id="42" name="사각형: 둥근 모서리 41">
             <a:extLst>
               <a:ext uri="{FF2B5EF4-FFF2-40B4-BE49-F238E27FC236}">
-                <a16:creationId xmlns:a16="http://schemas.microsoft.com/office/drawing/2014/main" id="{F2E76EA3-2998-9AC5-023A-BFAE63656D0F}"/>
+                <a16:creationId xmlns:a16="http://schemas.microsoft.com/office/drawing/2014/main" id="{80F0C537-84CA-87A4-1C22-05C255A15293}"/>
               </a:ext>
             </a:extLst>
           </p:cNvPr>
@@ -5519,7 +5519,7 @@
           <p:cNvPr id="43" name="사각형: 둥근 모서리 42">
             <a:extLst>
               <a:ext uri="{FF2B5EF4-FFF2-40B4-BE49-F238E27FC236}">
-                <a16:creationId xmlns:a16="http://schemas.microsoft.com/office/drawing/2014/main" id="{B41940D8-3ECC-7B73-60DD-01098BB261D9}"/>
+                <a16:creationId xmlns:a16="http://schemas.microsoft.com/office/drawing/2014/main" id="{BAD5D2F5-FB11-E4FB-8690-C3E01BCA2FC8}"/>
               </a:ext>
             </a:extLst>
           </p:cNvPr>
@@ -5573,7 +5573,7 @@
           <p:cNvPr id="44" name="타원 43">
             <a:extLst>
               <a:ext uri="{FF2B5EF4-FFF2-40B4-BE49-F238E27FC236}">
-                <a16:creationId xmlns:a16="http://schemas.microsoft.com/office/drawing/2014/main" id="{286A4B32-2013-823C-6F5A-8D0ED1DC8605}"/>
+                <a16:creationId xmlns:a16="http://schemas.microsoft.com/office/drawing/2014/main" id="{62C6D0E0-C273-8BA3-45AC-6652543DB188}"/>
               </a:ext>
             </a:extLst>
           </p:cNvPr>
@@ -5627,7 +5627,7 @@
           <p:cNvPr id="45" name="TextBox 44">
             <a:extLst>
               <a:ext uri="{FF2B5EF4-FFF2-40B4-BE49-F238E27FC236}">
-                <a16:creationId xmlns:a16="http://schemas.microsoft.com/office/drawing/2014/main" id="{AA8A30A8-057E-5318-AA74-45AEAFB161D0}"/>
+                <a16:creationId xmlns:a16="http://schemas.microsoft.com/office/drawing/2014/main" id="{85B94A04-1DF3-8932-8D8C-A79C6E8883B2}"/>
               </a:ext>
             </a:extLst>
           </p:cNvPr>
@@ -5673,7 +5673,7 @@
           <p:cNvPr id="46" name="TextBox 45">
             <a:extLst>
               <a:ext uri="{FF2B5EF4-FFF2-40B4-BE49-F238E27FC236}">
-                <a16:creationId xmlns:a16="http://schemas.microsoft.com/office/drawing/2014/main" id="{43D782DA-DD0A-DC81-7F9B-13D1B77E9DA7}"/>
+                <a16:creationId xmlns:a16="http://schemas.microsoft.com/office/drawing/2014/main" id="{138D04A9-2D46-744E-CE73-30BF479C653D}"/>
               </a:ext>
             </a:extLst>
           </p:cNvPr>
@@ -5719,7 +5719,7 @@
           <p:cNvPr id="47" name="TextBox 46">
             <a:extLst>
               <a:ext uri="{FF2B5EF4-FFF2-40B4-BE49-F238E27FC236}">
-                <a16:creationId xmlns:a16="http://schemas.microsoft.com/office/drawing/2014/main" id="{DD945181-F594-C2DC-497B-CA63BAE65A4F}"/>
+                <a16:creationId xmlns:a16="http://schemas.microsoft.com/office/drawing/2014/main" id="{3B92494C-3F9A-FED2-F596-6810366966B7}"/>
               </a:ext>
             </a:extLst>
           </p:cNvPr>
@@ -5765,7 +5765,7 @@
           <p:cNvPr id="48" name="사각형: 둥근 모서리 47">
             <a:extLst>
               <a:ext uri="{FF2B5EF4-FFF2-40B4-BE49-F238E27FC236}">
-                <a16:creationId xmlns:a16="http://schemas.microsoft.com/office/drawing/2014/main" id="{36129ED3-145D-564B-E330-5207E89F21F7}"/>
+                <a16:creationId xmlns:a16="http://schemas.microsoft.com/office/drawing/2014/main" id="{4ABF1F71-1706-CCB5-8C4E-D6A428D7F9D6}"/>
               </a:ext>
             </a:extLst>
           </p:cNvPr>
@@ -5835,7 +5835,7 @@
           <p:cNvPr id="49" name="사각형: 둥근 모서리 48">
             <a:extLst>
               <a:ext uri="{FF2B5EF4-FFF2-40B4-BE49-F238E27FC236}">
-                <a16:creationId xmlns:a16="http://schemas.microsoft.com/office/drawing/2014/main" id="{5EAA3CB1-3EAF-BC81-9176-79385CC16AE3}"/>
+                <a16:creationId xmlns:a16="http://schemas.microsoft.com/office/drawing/2014/main" id="{36E173A5-A88F-EA79-DE80-E000C4C1B652}"/>
               </a:ext>
             </a:extLst>
           </p:cNvPr>
@@ -5889,7 +5889,7 @@
           <p:cNvPr id="50" name="타원 49">
             <a:extLst>
               <a:ext uri="{FF2B5EF4-FFF2-40B4-BE49-F238E27FC236}">
-                <a16:creationId xmlns:a16="http://schemas.microsoft.com/office/drawing/2014/main" id="{B1BC2B26-BCCC-F1B5-B996-90B56492AD85}"/>
+                <a16:creationId xmlns:a16="http://schemas.microsoft.com/office/drawing/2014/main" id="{D4673877-C048-D090-386A-38FFAD3FEED6}"/>
               </a:ext>
             </a:extLst>
           </p:cNvPr>
@@ -5943,7 +5943,7 @@
           <p:cNvPr id="51" name="TextBox 50">
             <a:extLst>
               <a:ext uri="{FF2B5EF4-FFF2-40B4-BE49-F238E27FC236}">
-                <a16:creationId xmlns:a16="http://schemas.microsoft.com/office/drawing/2014/main" id="{F95B5D25-7DE0-B4D0-87EA-13E8A50C7E41}"/>
+                <a16:creationId xmlns:a16="http://schemas.microsoft.com/office/drawing/2014/main" id="{743A3FD4-72B9-B7C4-0E6E-A6B4595DFC51}"/>
               </a:ext>
             </a:extLst>
           </p:cNvPr>
@@ -5989,7 +5989,7 @@
           <p:cNvPr id="52" name="사각형: 둥근 모서리 51">
             <a:extLst>
               <a:ext uri="{FF2B5EF4-FFF2-40B4-BE49-F238E27FC236}">
-                <a16:creationId xmlns:a16="http://schemas.microsoft.com/office/drawing/2014/main" id="{173E8CA9-E62A-455D-5901-609C9E01008F}"/>
+                <a16:creationId xmlns:a16="http://schemas.microsoft.com/office/drawing/2014/main" id="{C4507F6C-536A-1EAE-EA44-7E930D7F5FC4}"/>
               </a:ext>
             </a:extLst>
           </p:cNvPr>
@@ -6043,7 +6043,7 @@
           <p:cNvPr id="53" name="TextBox 52">
             <a:extLst>
               <a:ext uri="{FF2B5EF4-FFF2-40B4-BE49-F238E27FC236}">
-                <a16:creationId xmlns:a16="http://schemas.microsoft.com/office/drawing/2014/main" id="{95F9F10E-B65D-9E22-2B7D-8FE0D20BAC72}"/>
+                <a16:creationId xmlns:a16="http://schemas.microsoft.com/office/drawing/2014/main" id="{A0B4BEA2-5176-3C50-5627-1D92009FF88B}"/>
               </a:ext>
             </a:extLst>
           </p:cNvPr>
@@ -6090,7 +6090,7 @@
           <p:cNvPr id="54" name="직선 연결선 53">
             <a:extLst>
               <a:ext uri="{FF2B5EF4-FFF2-40B4-BE49-F238E27FC236}">
-                <a16:creationId xmlns:a16="http://schemas.microsoft.com/office/drawing/2014/main" id="{3B50694F-B2D8-64D8-ABC0-C6EB56AD69A1}"/>
+                <a16:creationId xmlns:a16="http://schemas.microsoft.com/office/drawing/2014/main" id="{A596B58A-63C0-1A5D-2930-0A158CDE55FC}"/>
               </a:ext>
             </a:extLst>
           </p:cNvPr>
@@ -6133,7 +6133,7 @@
           <p:cNvPr id="55" name="직선 연결선 54">
             <a:extLst>
               <a:ext uri="{FF2B5EF4-FFF2-40B4-BE49-F238E27FC236}">
-                <a16:creationId xmlns:a16="http://schemas.microsoft.com/office/drawing/2014/main" id="{FF8B2ED1-B866-2227-0B5E-3B107131F19F}"/>
+                <a16:creationId xmlns:a16="http://schemas.microsoft.com/office/drawing/2014/main" id="{B071CDAC-D8FB-0D62-83F1-F93C08D3226E}"/>
               </a:ext>
             </a:extLst>
           </p:cNvPr>
@@ -6176,7 +6176,7 @@
           <p:cNvPr id="56" name="직선 연결선 55">
             <a:extLst>
               <a:ext uri="{FF2B5EF4-FFF2-40B4-BE49-F238E27FC236}">
-                <a16:creationId xmlns:a16="http://schemas.microsoft.com/office/drawing/2014/main" id="{A1E4214F-3F1B-1F58-333D-23AAEE61C055}"/>
+                <a16:creationId xmlns:a16="http://schemas.microsoft.com/office/drawing/2014/main" id="{4A137D47-6A8F-2973-88F5-213F078E2704}"/>
               </a:ext>
             </a:extLst>
           </p:cNvPr>
@@ -6219,7 +6219,7 @@
           <p:cNvPr id="57" name="직선 연결선 56">
             <a:extLst>
               <a:ext uri="{FF2B5EF4-FFF2-40B4-BE49-F238E27FC236}">
-                <a16:creationId xmlns:a16="http://schemas.microsoft.com/office/drawing/2014/main" id="{C0635751-74CA-5874-9E59-E04343B677FF}"/>
+                <a16:creationId xmlns:a16="http://schemas.microsoft.com/office/drawing/2014/main" id="{F62BF468-3412-C3C2-146F-A88E030797BB}"/>
               </a:ext>
             </a:extLst>
           </p:cNvPr>
@@ -6263,7 +6263,7 @@
           <p:cNvPr id="58" name="사각형: 둥근 모서리 57">
             <a:extLst>
               <a:ext uri="{FF2B5EF4-FFF2-40B4-BE49-F238E27FC236}">
-                <a16:creationId xmlns:a16="http://schemas.microsoft.com/office/drawing/2014/main" id="{EE059C2E-A744-75A0-77E1-129366EFE5C5}"/>
+                <a16:creationId xmlns:a16="http://schemas.microsoft.com/office/drawing/2014/main" id="{4FA6C583-9DF5-AA6B-905D-6850B389A525}"/>
               </a:ext>
             </a:extLst>
           </p:cNvPr>
@@ -6333,7 +6333,7 @@
           <p:cNvPr id="59" name="사각형: 둥근 모서리 58">
             <a:extLst>
               <a:ext uri="{FF2B5EF4-FFF2-40B4-BE49-F238E27FC236}">
-                <a16:creationId xmlns:a16="http://schemas.microsoft.com/office/drawing/2014/main" id="{5DB98430-FCDE-B4D6-A045-3D72CFEF51CC}"/>
+                <a16:creationId xmlns:a16="http://schemas.microsoft.com/office/drawing/2014/main" id="{97910EEB-14F6-FF48-07AF-1532804E8401}"/>
               </a:ext>
             </a:extLst>
           </p:cNvPr>
@@ -6387,7 +6387,7 @@
           <p:cNvPr id="60" name="TextBox 59">
             <a:extLst>
               <a:ext uri="{FF2B5EF4-FFF2-40B4-BE49-F238E27FC236}">
-                <a16:creationId xmlns:a16="http://schemas.microsoft.com/office/drawing/2014/main" id="{725B799A-AB1C-9A9D-98C3-DF422C18B9DD}"/>
+                <a16:creationId xmlns:a16="http://schemas.microsoft.com/office/drawing/2014/main" id="{B6631C49-54BD-D744-261B-470E66B2426F}"/>
               </a:ext>
             </a:extLst>
           </p:cNvPr>
@@ -6433,7 +6433,7 @@
           <p:cNvPr id="61" name="TextBox 60">
             <a:extLst>
               <a:ext uri="{FF2B5EF4-FFF2-40B4-BE49-F238E27FC236}">
-                <a16:creationId xmlns:a16="http://schemas.microsoft.com/office/drawing/2014/main" id="{CDF815AB-C6F2-8C0B-6AC7-EAF93AE313DD}"/>
+                <a16:creationId xmlns:a16="http://schemas.microsoft.com/office/drawing/2014/main" id="{E204D2B5-3717-D6F9-D791-4B2A1E8985BD}"/>
               </a:ext>
             </a:extLst>
           </p:cNvPr>
@@ -6479,7 +6479,7 @@
           <p:cNvPr id="62" name="직선 연결선 61">
             <a:extLst>
               <a:ext uri="{FF2B5EF4-FFF2-40B4-BE49-F238E27FC236}">
-                <a16:creationId xmlns:a16="http://schemas.microsoft.com/office/drawing/2014/main" id="{4D09EA3F-88AD-326A-B2E9-AA9BD85E19C5}"/>
+                <a16:creationId xmlns:a16="http://schemas.microsoft.com/office/drawing/2014/main" id="{0616E4AB-A752-B8D7-FC70-F433325FC536}"/>
               </a:ext>
             </a:extLst>
           </p:cNvPr>
@@ -6522,7 +6522,7 @@
           <p:cNvPr id="63" name="사각형: 둥근 모서리 62">
             <a:extLst>
               <a:ext uri="{FF2B5EF4-FFF2-40B4-BE49-F238E27FC236}">
-                <a16:creationId xmlns:a16="http://schemas.microsoft.com/office/drawing/2014/main" id="{B333238E-BE2D-F401-FA7C-189EBB39606E}"/>
+                <a16:creationId xmlns:a16="http://schemas.microsoft.com/office/drawing/2014/main" id="{1DDBE362-9A26-59C6-CAC7-EA5B5C0D7FE2}"/>
               </a:ext>
             </a:extLst>
           </p:cNvPr>
@@ -6592,7 +6592,7 @@
           <p:cNvPr id="64" name="사각형: 둥근 모서리 63">
             <a:extLst>
               <a:ext uri="{FF2B5EF4-FFF2-40B4-BE49-F238E27FC236}">
-                <a16:creationId xmlns:a16="http://schemas.microsoft.com/office/drawing/2014/main" id="{58A33B47-B258-4FA3-ED25-6D7EB3CC22EB}"/>
+                <a16:creationId xmlns:a16="http://schemas.microsoft.com/office/drawing/2014/main" id="{27DDFAA5-4F15-1090-3B53-8D388365C0FA}"/>
               </a:ext>
             </a:extLst>
           </p:cNvPr>
@@ -6646,7 +6646,7 @@
           <p:cNvPr id="65" name="타원 64">
             <a:extLst>
               <a:ext uri="{FF2B5EF4-FFF2-40B4-BE49-F238E27FC236}">
-                <a16:creationId xmlns:a16="http://schemas.microsoft.com/office/drawing/2014/main" id="{1215048F-841C-AEF9-B7DA-1C776FECEE74}"/>
+                <a16:creationId xmlns:a16="http://schemas.microsoft.com/office/drawing/2014/main" id="{44E8B4F7-3038-B6A1-F137-B4D75C794384}"/>
               </a:ext>
             </a:extLst>
           </p:cNvPr>
@@ -6700,7 +6700,7 @@
           <p:cNvPr id="66" name="TextBox 65">
             <a:extLst>
               <a:ext uri="{FF2B5EF4-FFF2-40B4-BE49-F238E27FC236}">
-                <a16:creationId xmlns:a16="http://schemas.microsoft.com/office/drawing/2014/main" id="{034A759F-FFD5-D181-A950-2A8AB87F52A0}"/>
+                <a16:creationId xmlns:a16="http://schemas.microsoft.com/office/drawing/2014/main" id="{5255B1FC-36E3-2CA2-95FF-1FAF4ACB00A0}"/>
               </a:ext>
             </a:extLst>
           </p:cNvPr>
@@ -6746,7 +6746,7 @@
           <p:cNvPr id="67" name="TextBox 66">
             <a:extLst>
               <a:ext uri="{FF2B5EF4-FFF2-40B4-BE49-F238E27FC236}">
-                <a16:creationId xmlns:a16="http://schemas.microsoft.com/office/drawing/2014/main" id="{C14C9505-9149-CA70-2A06-074A3DA75D81}"/>
+                <a16:creationId xmlns:a16="http://schemas.microsoft.com/office/drawing/2014/main" id="{D53A17F8-8D98-F8F1-8BAD-DF8610F7C1B3}"/>
               </a:ext>
             </a:extLst>
           </p:cNvPr>
@@ -6793,7 +6793,7 @@
           <p:cNvPr id="68" name="사각형: 둥근 모서리 67">
             <a:extLst>
               <a:ext uri="{FF2B5EF4-FFF2-40B4-BE49-F238E27FC236}">
-                <a16:creationId xmlns:a16="http://schemas.microsoft.com/office/drawing/2014/main" id="{8533F31E-B079-2E1A-B3B9-86F5F5A7F088}"/>
+                <a16:creationId xmlns:a16="http://schemas.microsoft.com/office/drawing/2014/main" id="{5B320B3C-78D9-1384-59CE-1ABA9BA384C7}"/>
               </a:ext>
             </a:extLst>
           </p:cNvPr>
@@ -6863,7 +6863,7 @@
           <p:cNvPr id="69" name="사각형: 둥근 모서리 68">
             <a:extLst>
               <a:ext uri="{FF2B5EF4-FFF2-40B4-BE49-F238E27FC236}">
-                <a16:creationId xmlns:a16="http://schemas.microsoft.com/office/drawing/2014/main" id="{83EDDDAF-9EE0-6089-D371-4F060EE45083}"/>
+                <a16:creationId xmlns:a16="http://schemas.microsoft.com/office/drawing/2014/main" id="{006E5408-6524-B09E-03B1-EB0AA9461C46}"/>
               </a:ext>
             </a:extLst>
           </p:cNvPr>
@@ -6917,7 +6917,7 @@
           <p:cNvPr id="70" name="타원 69">
             <a:extLst>
               <a:ext uri="{FF2B5EF4-FFF2-40B4-BE49-F238E27FC236}">
-                <a16:creationId xmlns:a16="http://schemas.microsoft.com/office/drawing/2014/main" id="{50685072-0378-F7AF-F40B-6CAACBFC9678}"/>
+                <a16:creationId xmlns:a16="http://schemas.microsoft.com/office/drawing/2014/main" id="{0777159B-47C8-E1C8-5D0A-31A0F9C8C455}"/>
               </a:ext>
             </a:extLst>
           </p:cNvPr>
@@ -6971,7 +6971,7 @@
           <p:cNvPr id="71" name="TextBox 70">
             <a:extLst>
               <a:ext uri="{FF2B5EF4-FFF2-40B4-BE49-F238E27FC236}">
-                <a16:creationId xmlns:a16="http://schemas.microsoft.com/office/drawing/2014/main" id="{7BE8011B-AD00-EA60-4475-40B39B191384}"/>
+                <a16:creationId xmlns:a16="http://schemas.microsoft.com/office/drawing/2014/main" id="{CB495C44-1F8C-0EE0-ED0C-B48D823D6D08}"/>
               </a:ext>
             </a:extLst>
           </p:cNvPr>
@@ -7017,7 +7017,7 @@
           <p:cNvPr id="72" name="TextBox 71">
             <a:extLst>
               <a:ext uri="{FF2B5EF4-FFF2-40B4-BE49-F238E27FC236}">
-                <a16:creationId xmlns:a16="http://schemas.microsoft.com/office/drawing/2014/main" id="{BC570345-9A8F-28D1-8E42-D16EAA387EF6}"/>
+                <a16:creationId xmlns:a16="http://schemas.microsoft.com/office/drawing/2014/main" id="{A8266F20-BD7B-48CE-3E41-9C25AF64ABF4}"/>
               </a:ext>
             </a:extLst>
           </p:cNvPr>
@@ -7064,7 +7064,7 @@
           <p:cNvPr id="73" name="사각형: 둥근 모서리 72">
             <a:extLst>
               <a:ext uri="{FF2B5EF4-FFF2-40B4-BE49-F238E27FC236}">
-                <a16:creationId xmlns:a16="http://schemas.microsoft.com/office/drawing/2014/main" id="{B981FF87-60AF-EEAE-C338-ACBC906956F0}"/>
+                <a16:creationId xmlns:a16="http://schemas.microsoft.com/office/drawing/2014/main" id="{2D3B3C6B-63F2-B341-F8D0-68D18C787D98}"/>
               </a:ext>
             </a:extLst>
           </p:cNvPr>
@@ -7134,7 +7134,7 @@
           <p:cNvPr id="74" name="사각형: 둥근 모서리 73">
             <a:extLst>
               <a:ext uri="{FF2B5EF4-FFF2-40B4-BE49-F238E27FC236}">
-                <a16:creationId xmlns:a16="http://schemas.microsoft.com/office/drawing/2014/main" id="{A64B2383-BBFD-F8B8-F34A-A4C714C0380E}"/>
+                <a16:creationId xmlns:a16="http://schemas.microsoft.com/office/drawing/2014/main" id="{34CE0093-2ECD-245E-D101-5DF03A43E2A0}"/>
               </a:ext>
             </a:extLst>
           </p:cNvPr>
@@ -7188,7 +7188,7 @@
           <p:cNvPr id="75" name="타원 74">
             <a:extLst>
               <a:ext uri="{FF2B5EF4-FFF2-40B4-BE49-F238E27FC236}">
-                <a16:creationId xmlns:a16="http://schemas.microsoft.com/office/drawing/2014/main" id="{C6426748-9FFB-B918-AEC7-8F39342C015F}"/>
+                <a16:creationId xmlns:a16="http://schemas.microsoft.com/office/drawing/2014/main" id="{28554304-7699-546F-3C6F-7EBEEB64EF8C}"/>
               </a:ext>
             </a:extLst>
           </p:cNvPr>
@@ -7242,7 +7242,7 @@
           <p:cNvPr id="76" name="TextBox 75">
             <a:extLst>
               <a:ext uri="{FF2B5EF4-FFF2-40B4-BE49-F238E27FC236}">
-                <a16:creationId xmlns:a16="http://schemas.microsoft.com/office/drawing/2014/main" id="{84672674-B9B5-7961-C650-0785A4D5FD4E}"/>
+                <a16:creationId xmlns:a16="http://schemas.microsoft.com/office/drawing/2014/main" id="{E87DA7E0-D83A-21BB-A080-17E8E1D41A6F}"/>
               </a:ext>
             </a:extLst>
           </p:cNvPr>
@@ -7288,7 +7288,7 @@
           <p:cNvPr id="77" name="TextBox 76">
             <a:extLst>
               <a:ext uri="{FF2B5EF4-FFF2-40B4-BE49-F238E27FC236}">
-                <a16:creationId xmlns:a16="http://schemas.microsoft.com/office/drawing/2014/main" id="{3BCD2A22-EAAB-F74A-CDD1-198A5D2A03D9}"/>
+                <a16:creationId xmlns:a16="http://schemas.microsoft.com/office/drawing/2014/main" id="{15E9697C-28BD-E673-DF41-1E60C4061DDB}"/>
               </a:ext>
             </a:extLst>
           </p:cNvPr>
@@ -7335,7 +7335,7 @@
           <p:cNvPr id="78" name="사각형: 둥근 모서리 77">
             <a:extLst>
               <a:ext uri="{FF2B5EF4-FFF2-40B4-BE49-F238E27FC236}">
-                <a16:creationId xmlns:a16="http://schemas.microsoft.com/office/drawing/2014/main" id="{E1055928-ACE1-AF45-E4FD-CE1FDEBB9765}"/>
+                <a16:creationId xmlns:a16="http://schemas.microsoft.com/office/drawing/2014/main" id="{6177ABE3-EC35-1E54-0A87-7B3817D07EB0}"/>
               </a:ext>
             </a:extLst>
           </p:cNvPr>
@@ -7405,7 +7405,7 @@
           <p:cNvPr id="79" name="사각형: 둥근 모서리 78">
             <a:extLst>
               <a:ext uri="{FF2B5EF4-FFF2-40B4-BE49-F238E27FC236}">
-                <a16:creationId xmlns:a16="http://schemas.microsoft.com/office/drawing/2014/main" id="{FE499AE3-72CB-5EF1-3C6B-4EA87A4A9105}"/>
+                <a16:creationId xmlns:a16="http://schemas.microsoft.com/office/drawing/2014/main" id="{D9F5BB4D-BCE6-E7A7-D29E-5804D00A338A}"/>
               </a:ext>
             </a:extLst>
           </p:cNvPr>
@@ -7459,7 +7459,7 @@
           <p:cNvPr id="80" name="타원 79">
             <a:extLst>
               <a:ext uri="{FF2B5EF4-FFF2-40B4-BE49-F238E27FC236}">
-                <a16:creationId xmlns:a16="http://schemas.microsoft.com/office/drawing/2014/main" id="{79F4BC1B-8E4A-3840-7964-7F98B9593566}"/>
+                <a16:creationId xmlns:a16="http://schemas.microsoft.com/office/drawing/2014/main" id="{5FCF1C61-9596-2EE0-3D06-C30EE63D93F9}"/>
               </a:ext>
             </a:extLst>
           </p:cNvPr>
@@ -7513,7 +7513,7 @@
           <p:cNvPr id="81" name="TextBox 80">
             <a:extLst>
               <a:ext uri="{FF2B5EF4-FFF2-40B4-BE49-F238E27FC236}">
-                <a16:creationId xmlns:a16="http://schemas.microsoft.com/office/drawing/2014/main" id="{033F9426-726F-5C85-54A4-0B551CF394AF}"/>
+                <a16:creationId xmlns:a16="http://schemas.microsoft.com/office/drawing/2014/main" id="{EF562CF6-3532-EE2B-E5C3-D2A45E5E9EB5}"/>
               </a:ext>
             </a:extLst>
           </p:cNvPr>
@@ -7559,7 +7559,7 @@
           <p:cNvPr id="82" name="TextBox 81">
             <a:extLst>
               <a:ext uri="{FF2B5EF4-FFF2-40B4-BE49-F238E27FC236}">
-                <a16:creationId xmlns:a16="http://schemas.microsoft.com/office/drawing/2014/main" id="{05107169-4792-45F2-7615-3A11600A0670}"/>
+                <a16:creationId xmlns:a16="http://schemas.microsoft.com/office/drawing/2014/main" id="{6FA53795-8F01-4E2D-31CB-96ED7A722811}"/>
               </a:ext>
             </a:extLst>
           </p:cNvPr>
@@ -7606,7 +7606,7 @@
           <p:cNvPr id="83" name="사각형: 둥근 모서리 82">
             <a:extLst>
               <a:ext uri="{FF2B5EF4-FFF2-40B4-BE49-F238E27FC236}">
-                <a16:creationId xmlns:a16="http://schemas.microsoft.com/office/drawing/2014/main" id="{B74029D9-ADDC-A92D-E521-A1A2170A6A27}"/>
+                <a16:creationId xmlns:a16="http://schemas.microsoft.com/office/drawing/2014/main" id="{65BF37CF-4002-2AB3-5BD2-10619F684FE8}"/>
               </a:ext>
             </a:extLst>
           </p:cNvPr>
@@ -7676,7 +7676,7 @@
           <p:cNvPr id="84" name="사각형: 둥근 모서리 83">
             <a:extLst>
               <a:ext uri="{FF2B5EF4-FFF2-40B4-BE49-F238E27FC236}">
-                <a16:creationId xmlns:a16="http://schemas.microsoft.com/office/drawing/2014/main" id="{754B2884-D3A4-E163-C189-6662049F9592}"/>
+                <a16:creationId xmlns:a16="http://schemas.microsoft.com/office/drawing/2014/main" id="{19E4D96E-CDC2-8F45-F4AA-43D7CFAD3475}"/>
               </a:ext>
             </a:extLst>
           </p:cNvPr>
@@ -7730,7 +7730,7 @@
           <p:cNvPr id="85" name="타원 84">
             <a:extLst>
               <a:ext uri="{FF2B5EF4-FFF2-40B4-BE49-F238E27FC236}">
-                <a16:creationId xmlns:a16="http://schemas.microsoft.com/office/drawing/2014/main" id="{F539A6F1-B95B-3598-7124-D9ABEA00A57E}"/>
+                <a16:creationId xmlns:a16="http://schemas.microsoft.com/office/drawing/2014/main" id="{3FF46FBE-F3D8-C525-564B-3E028F6085A0}"/>
               </a:ext>
             </a:extLst>
           </p:cNvPr>
@@ -7784,7 +7784,7 @@
           <p:cNvPr id="86" name="TextBox 85">
             <a:extLst>
               <a:ext uri="{FF2B5EF4-FFF2-40B4-BE49-F238E27FC236}">
-                <a16:creationId xmlns:a16="http://schemas.microsoft.com/office/drawing/2014/main" id="{157CF915-0680-5C40-E4B1-D0F22DA4332A}"/>
+                <a16:creationId xmlns:a16="http://schemas.microsoft.com/office/drawing/2014/main" id="{51D3336D-C116-FADD-8A57-195758CC96F9}"/>
               </a:ext>
             </a:extLst>
           </p:cNvPr>
@@ -7830,7 +7830,7 @@
           <p:cNvPr id="87" name="TextBox 86">
             <a:extLst>
               <a:ext uri="{FF2B5EF4-FFF2-40B4-BE49-F238E27FC236}">
-                <a16:creationId xmlns:a16="http://schemas.microsoft.com/office/drawing/2014/main" id="{2A7C2A5E-4B22-1064-A741-EE6CC064D858}"/>
+                <a16:creationId xmlns:a16="http://schemas.microsoft.com/office/drawing/2014/main" id="{E9A47AA6-45D1-4F4F-C38E-7371D9DDE916}"/>
               </a:ext>
             </a:extLst>
           </p:cNvPr>
@@ -7877,7 +7877,7 @@
           <p:cNvPr id="88" name="사각형: 둥근 모서리 87">
             <a:extLst>
               <a:ext uri="{FF2B5EF4-FFF2-40B4-BE49-F238E27FC236}">
-                <a16:creationId xmlns:a16="http://schemas.microsoft.com/office/drawing/2014/main" id="{183E8C07-5993-CA08-268E-353602C523C6}"/>
+                <a16:creationId xmlns:a16="http://schemas.microsoft.com/office/drawing/2014/main" id="{B4E8A0CA-AC66-20A3-2F38-5321A4D28A69}"/>
               </a:ext>
             </a:extLst>
           </p:cNvPr>
@@ -7947,7 +7947,7 @@
           <p:cNvPr id="89" name="사각형: 둥근 모서리 88">
             <a:extLst>
               <a:ext uri="{FF2B5EF4-FFF2-40B4-BE49-F238E27FC236}">
-                <a16:creationId xmlns:a16="http://schemas.microsoft.com/office/drawing/2014/main" id="{F0B2B602-4838-3AC9-1769-D5BEF3430674}"/>
+                <a16:creationId xmlns:a16="http://schemas.microsoft.com/office/drawing/2014/main" id="{28FBE15B-F993-5558-8785-2BC396B91E17}"/>
               </a:ext>
             </a:extLst>
           </p:cNvPr>
@@ -8001,7 +8001,7 @@
           <p:cNvPr id="90" name="타원 89">
             <a:extLst>
               <a:ext uri="{FF2B5EF4-FFF2-40B4-BE49-F238E27FC236}">
-                <a16:creationId xmlns:a16="http://schemas.microsoft.com/office/drawing/2014/main" id="{B87AAF74-356D-36A8-73EC-F48BA4628C20}"/>
+                <a16:creationId xmlns:a16="http://schemas.microsoft.com/office/drawing/2014/main" id="{2D3EC4CD-B92C-261A-4943-43EA1C77CC8F}"/>
               </a:ext>
             </a:extLst>
           </p:cNvPr>
@@ -8055,7 +8055,7 @@
           <p:cNvPr id="91" name="TextBox 90">
             <a:extLst>
               <a:ext uri="{FF2B5EF4-FFF2-40B4-BE49-F238E27FC236}">
-                <a16:creationId xmlns:a16="http://schemas.microsoft.com/office/drawing/2014/main" id="{D15B7ED5-B78D-3B30-B752-35943806176E}"/>
+                <a16:creationId xmlns:a16="http://schemas.microsoft.com/office/drawing/2014/main" id="{002C3360-B512-C496-ADDC-BB0849C61CDD}"/>
               </a:ext>
             </a:extLst>
           </p:cNvPr>
@@ -8101,7 +8101,7 @@
           <p:cNvPr id="92" name="TextBox 91">
             <a:extLst>
               <a:ext uri="{FF2B5EF4-FFF2-40B4-BE49-F238E27FC236}">
-                <a16:creationId xmlns:a16="http://schemas.microsoft.com/office/drawing/2014/main" id="{72FD6F21-86D2-CF5F-9DCC-155B62247300}"/>
+                <a16:creationId xmlns:a16="http://schemas.microsoft.com/office/drawing/2014/main" id="{8A20C419-AB30-42A6-133B-68E6EB67A220}"/>
               </a:ext>
             </a:extLst>
           </p:cNvPr>
@@ -8148,7 +8148,7 @@
           <p:cNvPr id="93" name="직선 연결선 92">
             <a:extLst>
               <a:ext uri="{FF2B5EF4-FFF2-40B4-BE49-F238E27FC236}">
-                <a16:creationId xmlns:a16="http://schemas.microsoft.com/office/drawing/2014/main" id="{E0F99A48-B346-761E-CF35-4CA91F94E0C2}"/>
+                <a16:creationId xmlns:a16="http://schemas.microsoft.com/office/drawing/2014/main" id="{D6EBEB15-E074-199E-89A4-BF2DF5C0D541}"/>
               </a:ext>
             </a:extLst>
           </p:cNvPr>
@@ -8191,7 +8191,7 @@
           <p:cNvPr id="94" name="직선 연결선 93">
             <a:extLst>
               <a:ext uri="{FF2B5EF4-FFF2-40B4-BE49-F238E27FC236}">
-                <a16:creationId xmlns:a16="http://schemas.microsoft.com/office/drawing/2014/main" id="{7771409A-0DA1-A276-4147-7C3E96628D1D}"/>
+                <a16:creationId xmlns:a16="http://schemas.microsoft.com/office/drawing/2014/main" id="{7EDA2E13-6B3F-E97E-06BD-FB5C91A05F41}"/>
               </a:ext>
             </a:extLst>
           </p:cNvPr>
@@ -8234,7 +8234,7 @@
           <p:cNvPr id="95" name="직선 연결선 94">
             <a:extLst>
               <a:ext uri="{FF2B5EF4-FFF2-40B4-BE49-F238E27FC236}">
-                <a16:creationId xmlns:a16="http://schemas.microsoft.com/office/drawing/2014/main" id="{CBF0A95C-B54C-D31A-0B6B-145C0A687F5A}"/>
+                <a16:creationId xmlns:a16="http://schemas.microsoft.com/office/drawing/2014/main" id="{747BA606-F549-E812-47AC-FF5DF9CE969A}"/>
               </a:ext>
             </a:extLst>
           </p:cNvPr>
@@ -8277,7 +8277,7 @@
           <p:cNvPr id="96" name="직선 연결선 95">
             <a:extLst>
               <a:ext uri="{FF2B5EF4-FFF2-40B4-BE49-F238E27FC236}">
-                <a16:creationId xmlns:a16="http://schemas.microsoft.com/office/drawing/2014/main" id="{F060A169-E98A-236C-3900-2930B10A59D2}"/>
+                <a16:creationId xmlns:a16="http://schemas.microsoft.com/office/drawing/2014/main" id="{BE9BEF52-3180-90A0-535A-7D15182B71FE}"/>
               </a:ext>
             </a:extLst>
           </p:cNvPr>
@@ -8320,7 +8320,7 @@
           <p:cNvPr id="97" name="직선 연결선 96">
             <a:extLst>
               <a:ext uri="{FF2B5EF4-FFF2-40B4-BE49-F238E27FC236}">
-                <a16:creationId xmlns:a16="http://schemas.microsoft.com/office/drawing/2014/main" id="{DDA1AEBD-5D78-6573-6C70-E1A927577071}"/>
+                <a16:creationId xmlns:a16="http://schemas.microsoft.com/office/drawing/2014/main" id="{CB74F33F-DF27-00F5-CAB3-F91CDB7B4781}"/>
               </a:ext>
             </a:extLst>
           </p:cNvPr>
@@ -8363,7 +8363,7 @@
           <p:cNvPr id="98" name="직선 연결선 97">
             <a:extLst>
               <a:ext uri="{FF2B5EF4-FFF2-40B4-BE49-F238E27FC236}">
-                <a16:creationId xmlns:a16="http://schemas.microsoft.com/office/drawing/2014/main" id="{2C19A15C-70D8-FABF-DAA6-7C6D0D08F72D}"/>
+                <a16:creationId xmlns:a16="http://schemas.microsoft.com/office/drawing/2014/main" id="{069D7C25-A180-F481-6950-2B2FB83822E3}"/>
               </a:ext>
             </a:extLst>
           </p:cNvPr>
@@ -8406,7 +8406,7 @@
           <p:cNvPr id="99" name="직선 연결선 98">
             <a:extLst>
               <a:ext uri="{FF2B5EF4-FFF2-40B4-BE49-F238E27FC236}">
-                <a16:creationId xmlns:a16="http://schemas.microsoft.com/office/drawing/2014/main" id="{41FCADBA-22D3-66C3-4462-35E8290B2B52}"/>
+                <a16:creationId xmlns:a16="http://schemas.microsoft.com/office/drawing/2014/main" id="{7291478E-B13B-40C7-CA8D-DCE97599346B}"/>
               </a:ext>
             </a:extLst>
           </p:cNvPr>
@@ -8449,7 +8449,7 @@
           <p:cNvPr id="100" name="직선 연결선 99">
             <a:extLst>
               <a:ext uri="{FF2B5EF4-FFF2-40B4-BE49-F238E27FC236}">
-                <a16:creationId xmlns:a16="http://schemas.microsoft.com/office/drawing/2014/main" id="{4815C80D-8B51-B3C5-6A43-F3D246B7D79D}"/>
+                <a16:creationId xmlns:a16="http://schemas.microsoft.com/office/drawing/2014/main" id="{AC3B7805-05C7-3FB0-F910-F4310694321A}"/>
               </a:ext>
             </a:extLst>
           </p:cNvPr>
@@ -8493,7 +8493,7 @@
           <p:cNvPr id="101" name="직선 연결선 100">
             <a:extLst>
               <a:ext uri="{FF2B5EF4-FFF2-40B4-BE49-F238E27FC236}">
-                <a16:creationId xmlns:a16="http://schemas.microsoft.com/office/drawing/2014/main" id="{3BEFA018-2E5E-F150-2AF8-D272F787E2F2}"/>
+                <a16:creationId xmlns:a16="http://schemas.microsoft.com/office/drawing/2014/main" id="{51AB3C7A-0124-4B78-4EB5-5DF5293A9C18}"/>
               </a:ext>
             </a:extLst>
           </p:cNvPr>
@@ -8537,7 +8537,7 @@
           <p:cNvPr id="102" name="직선 연결선 101">
             <a:extLst>
               <a:ext uri="{FF2B5EF4-FFF2-40B4-BE49-F238E27FC236}">
-                <a16:creationId xmlns:a16="http://schemas.microsoft.com/office/drawing/2014/main" id="{6753D295-352E-CF67-E975-EF8B36FD7591}"/>
+                <a16:creationId xmlns:a16="http://schemas.microsoft.com/office/drawing/2014/main" id="{4FAB1C89-138F-2078-88A2-55B3BC28FA74}"/>
               </a:ext>
             </a:extLst>
           </p:cNvPr>
@@ -8581,7 +8581,7 @@
           <p:cNvPr id="103" name="직선 연결선 102">
             <a:extLst>
               <a:ext uri="{FF2B5EF4-FFF2-40B4-BE49-F238E27FC236}">
-                <a16:creationId xmlns:a16="http://schemas.microsoft.com/office/drawing/2014/main" id="{A0FCCFF3-8A2A-0F80-F7F4-8CBA5617B719}"/>
+                <a16:creationId xmlns:a16="http://schemas.microsoft.com/office/drawing/2014/main" id="{4F534235-EB47-3F80-1065-2B4616A3646F}"/>
               </a:ext>
             </a:extLst>
           </p:cNvPr>
@@ -8624,7 +8624,7 @@
           <p:cNvPr id="104" name="사각형: 둥근 모서리 103">
             <a:extLst>
               <a:ext uri="{FF2B5EF4-FFF2-40B4-BE49-F238E27FC236}">
-                <a16:creationId xmlns:a16="http://schemas.microsoft.com/office/drawing/2014/main" id="{D400527A-58AB-B172-1D2B-31F3845A5F82}"/>
+                <a16:creationId xmlns:a16="http://schemas.microsoft.com/office/drawing/2014/main" id="{D4012608-1504-6073-B8CC-CCFF06B4BE88}"/>
               </a:ext>
             </a:extLst>
           </p:cNvPr>
@@ -8694,7 +8694,7 @@
           <p:cNvPr id="105" name="사각형: 둥근 모서리 104">
             <a:extLst>
               <a:ext uri="{FF2B5EF4-FFF2-40B4-BE49-F238E27FC236}">
-                <a16:creationId xmlns:a16="http://schemas.microsoft.com/office/drawing/2014/main" id="{A43CC21A-8513-BB56-6F2E-99C580062EFD}"/>
+                <a16:creationId xmlns:a16="http://schemas.microsoft.com/office/drawing/2014/main" id="{3291C3EA-0796-D430-E3E8-94DFEDA4EC6A}"/>
               </a:ext>
             </a:extLst>
           </p:cNvPr>
@@ -8748,7 +8748,7 @@
           <p:cNvPr id="106" name="타원 105">
             <a:extLst>
               <a:ext uri="{FF2B5EF4-FFF2-40B4-BE49-F238E27FC236}">
-                <a16:creationId xmlns:a16="http://schemas.microsoft.com/office/drawing/2014/main" id="{764D6E09-A4F2-2833-269B-CFA135532BDA}"/>
+                <a16:creationId xmlns:a16="http://schemas.microsoft.com/office/drawing/2014/main" id="{0783C2B5-1020-89BB-60CD-83351FFFD825}"/>
               </a:ext>
             </a:extLst>
           </p:cNvPr>
@@ -8802,7 +8802,7 @@
           <p:cNvPr id="107" name="TextBox 106">
             <a:extLst>
               <a:ext uri="{FF2B5EF4-FFF2-40B4-BE49-F238E27FC236}">
-                <a16:creationId xmlns:a16="http://schemas.microsoft.com/office/drawing/2014/main" id="{4669CAD7-4EDD-65EE-0B95-D2E473377DE8}"/>
+                <a16:creationId xmlns:a16="http://schemas.microsoft.com/office/drawing/2014/main" id="{B02A6152-0FD0-74B2-F8AF-889457778450}"/>
               </a:ext>
             </a:extLst>
           </p:cNvPr>
@@ -8848,7 +8848,7 @@
           <p:cNvPr id="108" name="TextBox 107">
             <a:extLst>
               <a:ext uri="{FF2B5EF4-FFF2-40B4-BE49-F238E27FC236}">
-                <a16:creationId xmlns:a16="http://schemas.microsoft.com/office/drawing/2014/main" id="{5147EEEF-E86D-4528-0C5A-610CFC23C4C5}"/>
+                <a16:creationId xmlns:a16="http://schemas.microsoft.com/office/drawing/2014/main" id="{2F9C6BBE-12D7-AE26-9FB3-D6FE364E0617}"/>
               </a:ext>
             </a:extLst>
           </p:cNvPr>
@@ -8894,7 +8894,7 @@
           <p:cNvPr id="109" name="사각형: 둥근 모서리 108">
             <a:extLst>
               <a:ext uri="{FF2B5EF4-FFF2-40B4-BE49-F238E27FC236}">
-                <a16:creationId xmlns:a16="http://schemas.microsoft.com/office/drawing/2014/main" id="{5CDFA5CE-3683-CB03-728A-C81973482F76}"/>
+                <a16:creationId xmlns:a16="http://schemas.microsoft.com/office/drawing/2014/main" id="{68C57483-ADDA-B5EA-03E5-93A9BA431AF8}"/>
               </a:ext>
             </a:extLst>
           </p:cNvPr>
@@ -8964,7 +8964,7 @@
           <p:cNvPr id="110" name="사각형: 둥근 모서리 109">
             <a:extLst>
               <a:ext uri="{FF2B5EF4-FFF2-40B4-BE49-F238E27FC236}">
-                <a16:creationId xmlns:a16="http://schemas.microsoft.com/office/drawing/2014/main" id="{A1C1A95A-BE25-E173-C9F5-ED8122D46107}"/>
+                <a16:creationId xmlns:a16="http://schemas.microsoft.com/office/drawing/2014/main" id="{373A19F7-827A-5DCD-5A61-70C90245902A}"/>
               </a:ext>
             </a:extLst>
           </p:cNvPr>
@@ -9018,7 +9018,7 @@
           <p:cNvPr id="111" name="타원 110">
             <a:extLst>
               <a:ext uri="{FF2B5EF4-FFF2-40B4-BE49-F238E27FC236}">
-                <a16:creationId xmlns:a16="http://schemas.microsoft.com/office/drawing/2014/main" id="{8F64A1BA-70BE-FCAB-EA60-F3B44C50035E}"/>
+                <a16:creationId xmlns:a16="http://schemas.microsoft.com/office/drawing/2014/main" id="{FEBDB25D-0A12-48AC-3BA6-6458408634E2}"/>
               </a:ext>
             </a:extLst>
           </p:cNvPr>
@@ -9072,7 +9072,7 @@
           <p:cNvPr id="112" name="TextBox 111">
             <a:extLst>
               <a:ext uri="{FF2B5EF4-FFF2-40B4-BE49-F238E27FC236}">
-                <a16:creationId xmlns:a16="http://schemas.microsoft.com/office/drawing/2014/main" id="{60FB369C-9B1A-E3EC-45CF-6705FF57BA7E}"/>
+                <a16:creationId xmlns:a16="http://schemas.microsoft.com/office/drawing/2014/main" id="{DCB88F98-A47B-7F4B-0FFA-EA6AFE6F6666}"/>
               </a:ext>
             </a:extLst>
           </p:cNvPr>
@@ -9118,7 +9118,7 @@
           <p:cNvPr id="113" name="TextBox 112">
             <a:extLst>
               <a:ext uri="{FF2B5EF4-FFF2-40B4-BE49-F238E27FC236}">
-                <a16:creationId xmlns:a16="http://schemas.microsoft.com/office/drawing/2014/main" id="{B93BA7A4-1DCD-CFC8-0502-4EF879A68953}"/>
+                <a16:creationId xmlns:a16="http://schemas.microsoft.com/office/drawing/2014/main" id="{BC640AC4-8B82-B288-1E88-D7EE44D7D182}"/>
               </a:ext>
             </a:extLst>
           </p:cNvPr>
@@ -9164,7 +9164,7 @@
           <p:cNvPr id="114" name="직선 연결선 113">
             <a:extLst>
               <a:ext uri="{FF2B5EF4-FFF2-40B4-BE49-F238E27FC236}">
-                <a16:creationId xmlns:a16="http://schemas.microsoft.com/office/drawing/2014/main" id="{2595441D-943A-1CFA-8814-C22DC441E5E5}"/>
+                <a16:creationId xmlns:a16="http://schemas.microsoft.com/office/drawing/2014/main" id="{C867B46B-17FE-C343-83AF-8A7D0466C65F}"/>
               </a:ext>
             </a:extLst>
           </p:cNvPr>
@@ -9207,7 +9207,7 @@
           <p:cNvPr id="115" name="사각형: 둥근 모서리 114">
             <a:extLst>
               <a:ext uri="{FF2B5EF4-FFF2-40B4-BE49-F238E27FC236}">
-                <a16:creationId xmlns:a16="http://schemas.microsoft.com/office/drawing/2014/main" id="{AAA80C96-D135-CE4E-E6B9-5AF575C43460}"/>
+                <a16:creationId xmlns:a16="http://schemas.microsoft.com/office/drawing/2014/main" id="{96B6760E-5F5B-310D-067D-4BFD8A53A753}"/>
               </a:ext>
             </a:extLst>
           </p:cNvPr>
@@ -9277,7 +9277,7 @@
           <p:cNvPr id="116" name="사각형: 둥근 모서리 115">
             <a:extLst>
               <a:ext uri="{FF2B5EF4-FFF2-40B4-BE49-F238E27FC236}">
-                <a16:creationId xmlns:a16="http://schemas.microsoft.com/office/drawing/2014/main" id="{58826FCB-F04C-56A0-B318-A2203F71FBAE}"/>
+                <a16:creationId xmlns:a16="http://schemas.microsoft.com/office/drawing/2014/main" id="{3452011A-5601-2DEE-A47F-5B3DD5DFA17A}"/>
               </a:ext>
             </a:extLst>
           </p:cNvPr>
@@ -9331,7 +9331,7 @@
           <p:cNvPr id="117" name="타원 116">
             <a:extLst>
               <a:ext uri="{FF2B5EF4-FFF2-40B4-BE49-F238E27FC236}">
-                <a16:creationId xmlns:a16="http://schemas.microsoft.com/office/drawing/2014/main" id="{735C9753-805C-FD40-52B9-055E7E8137B7}"/>
+                <a16:creationId xmlns:a16="http://schemas.microsoft.com/office/drawing/2014/main" id="{E8DE3B27-D841-02D8-9AF2-5CD2AD54C64A}"/>
               </a:ext>
             </a:extLst>
           </p:cNvPr>
@@ -9385,7 +9385,7 @@
           <p:cNvPr id="118" name="TextBox 117">
             <a:extLst>
               <a:ext uri="{FF2B5EF4-FFF2-40B4-BE49-F238E27FC236}">
-                <a16:creationId xmlns:a16="http://schemas.microsoft.com/office/drawing/2014/main" id="{30F1DE5A-FD3B-5B93-89D9-DDE260B60769}"/>
+                <a16:creationId xmlns:a16="http://schemas.microsoft.com/office/drawing/2014/main" id="{BBFAE9B5-15BE-A403-4422-8DAD77CD05D5}"/>
               </a:ext>
             </a:extLst>
           </p:cNvPr>
@@ -9431,7 +9431,7 @@
           <p:cNvPr id="119" name="직선 연결선 118">
             <a:extLst>
               <a:ext uri="{FF2B5EF4-FFF2-40B4-BE49-F238E27FC236}">
-                <a16:creationId xmlns:a16="http://schemas.microsoft.com/office/drawing/2014/main" id="{33A754BF-6204-43E7-C2D5-D525F922A1D3}"/>
+                <a16:creationId xmlns:a16="http://schemas.microsoft.com/office/drawing/2014/main" id="{78EFCFD1-39C7-B7F2-9B46-410E5EBE5933}"/>
               </a:ext>
             </a:extLst>
           </p:cNvPr>
@@ -9474,7 +9474,7 @@
           <p:cNvPr id="120" name="사각형: 둥근 모서리 119">
             <a:extLst>
               <a:ext uri="{FF2B5EF4-FFF2-40B4-BE49-F238E27FC236}">
-                <a16:creationId xmlns:a16="http://schemas.microsoft.com/office/drawing/2014/main" id="{B1D3F271-CFE3-5E39-1B8E-7FE64B742D01}"/>
+                <a16:creationId xmlns:a16="http://schemas.microsoft.com/office/drawing/2014/main" id="{32299BAE-43F0-C0F7-9997-797F83669B4C}"/>
               </a:ext>
             </a:extLst>
           </p:cNvPr>
@@ -9544,7 +9544,7 @@
           <p:cNvPr id="121" name="사각형: 둥근 모서리 120">
             <a:extLst>
               <a:ext uri="{FF2B5EF4-FFF2-40B4-BE49-F238E27FC236}">
-                <a16:creationId xmlns:a16="http://schemas.microsoft.com/office/drawing/2014/main" id="{5C762164-333D-E74F-F18E-858B4EDDB4C4}"/>
+                <a16:creationId xmlns:a16="http://schemas.microsoft.com/office/drawing/2014/main" id="{75FA555C-D4C2-A42F-B096-66D6D012C402}"/>
               </a:ext>
             </a:extLst>
           </p:cNvPr>
@@ -9598,7 +9598,7 @@
           <p:cNvPr id="122" name="TextBox 121">
             <a:extLst>
               <a:ext uri="{FF2B5EF4-FFF2-40B4-BE49-F238E27FC236}">
-                <a16:creationId xmlns:a16="http://schemas.microsoft.com/office/drawing/2014/main" id="{D77F2972-CF88-7752-3220-83545652A0F5}"/>
+                <a16:creationId xmlns:a16="http://schemas.microsoft.com/office/drawing/2014/main" id="{8281831D-A1D0-364C-76BF-9B408626E143}"/>
               </a:ext>
             </a:extLst>
           </p:cNvPr>
@@ -9644,7 +9644,7 @@
           <p:cNvPr id="123" name="TextBox 122">
             <a:extLst>
               <a:ext uri="{FF2B5EF4-FFF2-40B4-BE49-F238E27FC236}">
-                <a16:creationId xmlns:a16="http://schemas.microsoft.com/office/drawing/2014/main" id="{F466EC6D-EBD7-B8B8-856E-8E5FCFDC0FAF}"/>
+                <a16:creationId xmlns:a16="http://schemas.microsoft.com/office/drawing/2014/main" id="{576B5278-612A-0D16-D3A5-A089B64929BF}"/>
               </a:ext>
             </a:extLst>
           </p:cNvPr>
@@ -9688,7 +9688,7 @@
     </p:spTree>
     <p:extLst>
       <p:ext uri="{BB962C8B-B14F-4D97-AF65-F5344CB8AC3E}">
-        <p14:creationId xmlns:p14="http://schemas.microsoft.com/office/powerpoint/2010/main" val="1181512238"/>
+        <p14:creationId xmlns:p14="http://schemas.microsoft.com/office/powerpoint/2010/main" val="3677543617"/>
       </p:ext>
     </p:extLst>
   </p:cSld>

</xml_diff>

<commit_message>
docs(readme): highlight visual proof workflow
</commit_message>
<xml_diff>
--- a/docs/assets/readme-slides/mdpr-pipeline-teaser.pptx
+++ b/docs/assets/readme-slides/mdpr-pipeline-teaser.pptx
@@ -129,7 +129,7 @@
           <p:cNvPr id="2" name="제목 1">
             <a:extLst>
               <a:ext uri="{FF2B5EF4-FFF2-40B4-BE49-F238E27FC236}">
-                <a16:creationId xmlns:a16="http://schemas.microsoft.com/office/drawing/2014/main" id="{11A10472-9A70-9D04-97B6-7D3D15D1DD82}"/>
+                <a16:creationId xmlns:a16="http://schemas.microsoft.com/office/drawing/2014/main" id="{958BE2AA-C7FD-3290-D8C1-FC351DA37BC2}"/>
               </a:ext>
             </a:extLst>
           </p:cNvPr>
@@ -166,7 +166,7 @@
           <p:cNvPr id="3" name="부제목 2">
             <a:extLst>
               <a:ext uri="{FF2B5EF4-FFF2-40B4-BE49-F238E27FC236}">
-                <a16:creationId xmlns:a16="http://schemas.microsoft.com/office/drawing/2014/main" id="{6B682E91-BE49-E541-75E3-A00B15FF663C}"/>
+                <a16:creationId xmlns:a16="http://schemas.microsoft.com/office/drawing/2014/main" id="{BA505DF1-161C-3875-5440-936C9CB91E4C}"/>
               </a:ext>
             </a:extLst>
           </p:cNvPr>
@@ -236,7 +236,7 @@
           <p:cNvPr id="4" name="날짜 개체 틀 3">
             <a:extLst>
               <a:ext uri="{FF2B5EF4-FFF2-40B4-BE49-F238E27FC236}">
-                <a16:creationId xmlns:a16="http://schemas.microsoft.com/office/drawing/2014/main" id="{84742797-7793-2356-879F-CCB8E47AF810}"/>
+                <a16:creationId xmlns:a16="http://schemas.microsoft.com/office/drawing/2014/main" id="{9CEECE89-056C-5459-D88F-9611DDD9B88D}"/>
               </a:ext>
             </a:extLst>
           </p:cNvPr>
@@ -252,9 +252,9 @@
           <a:bodyPr/>
           <a:lstStyle/>
           <a:p>
-            <a:fld id="{787DB82E-6582-4BBE-BEBA-7C4FEA228F3D}" type="datetimeFigureOut">
+            <a:fld id="{DE75A3BA-15A2-45A3-90E0-81E6670C4DBE}" type="datetimeFigureOut">
               <a:rPr lang="ko-KR" altLang="en-US" smtClean="0"/>
-              <a:t>2026-06-25</a:t>
+              <a:t>2026-06-27</a:t>
             </a:fld>
             <a:endParaRPr lang="ko-KR" altLang="en-US"/>
           </a:p>
@@ -265,7 +265,7 @@
           <p:cNvPr id="5" name="바닥글 개체 틀 4">
             <a:extLst>
               <a:ext uri="{FF2B5EF4-FFF2-40B4-BE49-F238E27FC236}">
-                <a16:creationId xmlns:a16="http://schemas.microsoft.com/office/drawing/2014/main" id="{844A9FAC-6E1C-A171-88C6-6415CC7ABD99}"/>
+                <a16:creationId xmlns:a16="http://schemas.microsoft.com/office/drawing/2014/main" id="{B71D6835-FDDA-ECD9-AD9A-2ECCAC25A33D}"/>
               </a:ext>
             </a:extLst>
           </p:cNvPr>
@@ -290,7 +290,7 @@
           <p:cNvPr id="6" name="슬라이드 번호 개체 틀 5">
             <a:extLst>
               <a:ext uri="{FF2B5EF4-FFF2-40B4-BE49-F238E27FC236}">
-                <a16:creationId xmlns:a16="http://schemas.microsoft.com/office/drawing/2014/main" id="{B6CB6A28-C796-9CB0-6A15-57350EABDA7A}"/>
+                <a16:creationId xmlns:a16="http://schemas.microsoft.com/office/drawing/2014/main" id="{221E3D5B-DEB6-141B-B83C-9B4381E22A8B}"/>
               </a:ext>
             </a:extLst>
           </p:cNvPr>
@@ -306,7 +306,7 @@
           <a:bodyPr/>
           <a:lstStyle/>
           <a:p>
-            <a:fld id="{43A37AEE-7CAF-4C20-B1E8-E65D179D62A7}" type="slidenum">
+            <a:fld id="{B88F6202-0140-4DE3-8B22-3EA9DB6A3C84}" type="slidenum">
               <a:rPr lang="ko-KR" altLang="en-US" smtClean="0"/>
               <a:t>‹#›</a:t>
             </a:fld>
@@ -317,7 +317,7 @@
     </p:spTree>
     <p:extLst>
       <p:ext uri="{BB962C8B-B14F-4D97-AF65-F5344CB8AC3E}">
-        <p14:creationId xmlns:p14="http://schemas.microsoft.com/office/powerpoint/2010/main" val="4211607326"/>
+        <p14:creationId xmlns:p14="http://schemas.microsoft.com/office/powerpoint/2010/main" val="285496844"/>
       </p:ext>
     </p:extLst>
   </p:cSld>
@@ -349,7 +349,7 @@
           <p:cNvPr id="2" name="제목 1">
             <a:extLst>
               <a:ext uri="{FF2B5EF4-FFF2-40B4-BE49-F238E27FC236}">
-                <a16:creationId xmlns:a16="http://schemas.microsoft.com/office/drawing/2014/main" id="{E7BC9DA0-44E0-460D-5FEB-EDCB8A4A5F29}"/>
+                <a16:creationId xmlns:a16="http://schemas.microsoft.com/office/drawing/2014/main" id="{26DF8ADB-91E8-5196-B232-7AD8C9B70C9E}"/>
               </a:ext>
             </a:extLst>
           </p:cNvPr>
@@ -377,7 +377,7 @@
           <p:cNvPr id="3" name="세로 텍스트 개체 틀 2">
             <a:extLst>
               <a:ext uri="{FF2B5EF4-FFF2-40B4-BE49-F238E27FC236}">
-                <a16:creationId xmlns:a16="http://schemas.microsoft.com/office/drawing/2014/main" id="{90A23FC0-3566-546B-B5CB-CC0F6A56809F}"/>
+                <a16:creationId xmlns:a16="http://schemas.microsoft.com/office/drawing/2014/main" id="{BDBA1BC8-A87C-4EBD-D1D2-F3CF4AEED9DB}"/>
               </a:ext>
             </a:extLst>
           </p:cNvPr>
@@ -434,7 +434,7 @@
           <p:cNvPr id="4" name="날짜 개체 틀 3">
             <a:extLst>
               <a:ext uri="{FF2B5EF4-FFF2-40B4-BE49-F238E27FC236}">
-                <a16:creationId xmlns:a16="http://schemas.microsoft.com/office/drawing/2014/main" id="{ECA9AA1B-A710-E633-E08C-0098843841F2}"/>
+                <a16:creationId xmlns:a16="http://schemas.microsoft.com/office/drawing/2014/main" id="{D2000CD3-DA9E-5137-1F62-B3EFABB66589}"/>
               </a:ext>
             </a:extLst>
           </p:cNvPr>
@@ -450,9 +450,9 @@
           <a:bodyPr/>
           <a:lstStyle/>
           <a:p>
-            <a:fld id="{787DB82E-6582-4BBE-BEBA-7C4FEA228F3D}" type="datetimeFigureOut">
+            <a:fld id="{DE75A3BA-15A2-45A3-90E0-81E6670C4DBE}" type="datetimeFigureOut">
               <a:rPr lang="ko-KR" altLang="en-US" smtClean="0"/>
-              <a:t>2026-06-25</a:t>
+              <a:t>2026-06-27</a:t>
             </a:fld>
             <a:endParaRPr lang="ko-KR" altLang="en-US"/>
           </a:p>
@@ -463,7 +463,7 @@
           <p:cNvPr id="5" name="바닥글 개체 틀 4">
             <a:extLst>
               <a:ext uri="{FF2B5EF4-FFF2-40B4-BE49-F238E27FC236}">
-                <a16:creationId xmlns:a16="http://schemas.microsoft.com/office/drawing/2014/main" id="{43B0E489-7725-2D3F-D660-D9A1EA6296D0}"/>
+                <a16:creationId xmlns:a16="http://schemas.microsoft.com/office/drawing/2014/main" id="{3F1BB60B-6E3A-2642-578D-611AB7BB499C}"/>
               </a:ext>
             </a:extLst>
           </p:cNvPr>
@@ -488,7 +488,7 @@
           <p:cNvPr id="6" name="슬라이드 번호 개체 틀 5">
             <a:extLst>
               <a:ext uri="{FF2B5EF4-FFF2-40B4-BE49-F238E27FC236}">
-                <a16:creationId xmlns:a16="http://schemas.microsoft.com/office/drawing/2014/main" id="{B608A6C5-E1AD-B12A-08CF-3F2249C2DDCE}"/>
+                <a16:creationId xmlns:a16="http://schemas.microsoft.com/office/drawing/2014/main" id="{7FA13224-6BEE-CA06-15B0-683D4FE80D20}"/>
               </a:ext>
             </a:extLst>
           </p:cNvPr>
@@ -504,7 +504,7 @@
           <a:bodyPr/>
           <a:lstStyle/>
           <a:p>
-            <a:fld id="{43A37AEE-7CAF-4C20-B1E8-E65D179D62A7}" type="slidenum">
+            <a:fld id="{B88F6202-0140-4DE3-8B22-3EA9DB6A3C84}" type="slidenum">
               <a:rPr lang="ko-KR" altLang="en-US" smtClean="0"/>
               <a:t>‹#›</a:t>
             </a:fld>
@@ -515,7 +515,7 @@
     </p:spTree>
     <p:extLst>
       <p:ext uri="{BB962C8B-B14F-4D97-AF65-F5344CB8AC3E}">
-        <p14:creationId xmlns:p14="http://schemas.microsoft.com/office/powerpoint/2010/main" val="3652484355"/>
+        <p14:creationId xmlns:p14="http://schemas.microsoft.com/office/powerpoint/2010/main" val="2493489761"/>
       </p:ext>
     </p:extLst>
   </p:cSld>
@@ -547,7 +547,7 @@
           <p:cNvPr id="2" name="세로 제목 1">
             <a:extLst>
               <a:ext uri="{FF2B5EF4-FFF2-40B4-BE49-F238E27FC236}">
-                <a16:creationId xmlns:a16="http://schemas.microsoft.com/office/drawing/2014/main" id="{8FD9701F-AE8B-EF35-8B6F-1975C635CD3D}"/>
+                <a16:creationId xmlns:a16="http://schemas.microsoft.com/office/drawing/2014/main" id="{A49E050C-DDB9-FE05-CE47-D2E1A0EFAEF3}"/>
               </a:ext>
             </a:extLst>
           </p:cNvPr>
@@ -580,7 +580,7 @@
           <p:cNvPr id="3" name="세로 텍스트 개체 틀 2">
             <a:extLst>
               <a:ext uri="{FF2B5EF4-FFF2-40B4-BE49-F238E27FC236}">
-                <a16:creationId xmlns:a16="http://schemas.microsoft.com/office/drawing/2014/main" id="{0E966D0C-D324-08CE-1603-268C0B2BE744}"/>
+                <a16:creationId xmlns:a16="http://schemas.microsoft.com/office/drawing/2014/main" id="{BCC2E71C-F1B7-8228-CAB2-84741A87590F}"/>
               </a:ext>
             </a:extLst>
           </p:cNvPr>
@@ -642,7 +642,7 @@
           <p:cNvPr id="4" name="날짜 개체 틀 3">
             <a:extLst>
               <a:ext uri="{FF2B5EF4-FFF2-40B4-BE49-F238E27FC236}">
-                <a16:creationId xmlns:a16="http://schemas.microsoft.com/office/drawing/2014/main" id="{0E101D64-56ED-EA61-5E1E-640845BA7331}"/>
+                <a16:creationId xmlns:a16="http://schemas.microsoft.com/office/drawing/2014/main" id="{C521DA05-5092-098C-9E71-91BF0926316C}"/>
               </a:ext>
             </a:extLst>
           </p:cNvPr>
@@ -658,9 +658,9 @@
           <a:bodyPr/>
           <a:lstStyle/>
           <a:p>
-            <a:fld id="{787DB82E-6582-4BBE-BEBA-7C4FEA228F3D}" type="datetimeFigureOut">
+            <a:fld id="{DE75A3BA-15A2-45A3-90E0-81E6670C4DBE}" type="datetimeFigureOut">
               <a:rPr lang="ko-KR" altLang="en-US" smtClean="0"/>
-              <a:t>2026-06-25</a:t>
+              <a:t>2026-06-27</a:t>
             </a:fld>
             <a:endParaRPr lang="ko-KR" altLang="en-US"/>
           </a:p>
@@ -671,7 +671,7 @@
           <p:cNvPr id="5" name="바닥글 개체 틀 4">
             <a:extLst>
               <a:ext uri="{FF2B5EF4-FFF2-40B4-BE49-F238E27FC236}">
-                <a16:creationId xmlns:a16="http://schemas.microsoft.com/office/drawing/2014/main" id="{9491593D-EDE5-84B2-028B-9DF575A439CB}"/>
+                <a16:creationId xmlns:a16="http://schemas.microsoft.com/office/drawing/2014/main" id="{DCD719DB-9F7A-F824-F6D8-27881892F135}"/>
               </a:ext>
             </a:extLst>
           </p:cNvPr>
@@ -696,7 +696,7 @@
           <p:cNvPr id="6" name="슬라이드 번호 개체 틀 5">
             <a:extLst>
               <a:ext uri="{FF2B5EF4-FFF2-40B4-BE49-F238E27FC236}">
-                <a16:creationId xmlns:a16="http://schemas.microsoft.com/office/drawing/2014/main" id="{DEB3FDE7-2C03-E112-4861-6EAAE99B1E3B}"/>
+                <a16:creationId xmlns:a16="http://schemas.microsoft.com/office/drawing/2014/main" id="{5E82A0DF-01E4-A8F8-2E4C-934557C59742}"/>
               </a:ext>
             </a:extLst>
           </p:cNvPr>
@@ -712,7 +712,7 @@
           <a:bodyPr/>
           <a:lstStyle/>
           <a:p>
-            <a:fld id="{43A37AEE-7CAF-4C20-B1E8-E65D179D62A7}" type="slidenum">
+            <a:fld id="{B88F6202-0140-4DE3-8B22-3EA9DB6A3C84}" type="slidenum">
               <a:rPr lang="ko-KR" altLang="en-US" smtClean="0"/>
               <a:t>‹#›</a:t>
             </a:fld>
@@ -723,7 +723,7 @@
     </p:spTree>
     <p:extLst>
       <p:ext uri="{BB962C8B-B14F-4D97-AF65-F5344CB8AC3E}">
-        <p14:creationId xmlns:p14="http://schemas.microsoft.com/office/powerpoint/2010/main" val="3711444645"/>
+        <p14:creationId xmlns:p14="http://schemas.microsoft.com/office/powerpoint/2010/main" val="2559271092"/>
       </p:ext>
     </p:extLst>
   </p:cSld>
@@ -755,7 +755,7 @@
           <p:cNvPr id="2" name="제목 1">
             <a:extLst>
               <a:ext uri="{FF2B5EF4-FFF2-40B4-BE49-F238E27FC236}">
-                <a16:creationId xmlns:a16="http://schemas.microsoft.com/office/drawing/2014/main" id="{99F6CB20-0F5E-DC1E-6E72-FFF5BBDDC921}"/>
+                <a16:creationId xmlns:a16="http://schemas.microsoft.com/office/drawing/2014/main" id="{51871DBA-BFEA-B86E-3C4E-FD662437164C}"/>
               </a:ext>
             </a:extLst>
           </p:cNvPr>
@@ -783,7 +783,7 @@
           <p:cNvPr id="3" name="내용 개체 틀 2">
             <a:extLst>
               <a:ext uri="{FF2B5EF4-FFF2-40B4-BE49-F238E27FC236}">
-                <a16:creationId xmlns:a16="http://schemas.microsoft.com/office/drawing/2014/main" id="{589EF5F2-FE4A-8FFF-EFCC-99881667A7E6}"/>
+                <a16:creationId xmlns:a16="http://schemas.microsoft.com/office/drawing/2014/main" id="{08F84488-5176-EB44-C453-B7B96ED7816B}"/>
               </a:ext>
             </a:extLst>
           </p:cNvPr>
@@ -840,7 +840,7 @@
           <p:cNvPr id="4" name="날짜 개체 틀 3">
             <a:extLst>
               <a:ext uri="{FF2B5EF4-FFF2-40B4-BE49-F238E27FC236}">
-                <a16:creationId xmlns:a16="http://schemas.microsoft.com/office/drawing/2014/main" id="{FFCCED19-93BE-67B7-E260-1A5CFA1C6133}"/>
+                <a16:creationId xmlns:a16="http://schemas.microsoft.com/office/drawing/2014/main" id="{2F429E1F-C617-E4D4-642A-53FE76BC480C}"/>
               </a:ext>
             </a:extLst>
           </p:cNvPr>
@@ -856,9 +856,9 @@
           <a:bodyPr/>
           <a:lstStyle/>
           <a:p>
-            <a:fld id="{787DB82E-6582-4BBE-BEBA-7C4FEA228F3D}" type="datetimeFigureOut">
+            <a:fld id="{DE75A3BA-15A2-45A3-90E0-81E6670C4DBE}" type="datetimeFigureOut">
               <a:rPr lang="ko-KR" altLang="en-US" smtClean="0"/>
-              <a:t>2026-06-25</a:t>
+              <a:t>2026-06-27</a:t>
             </a:fld>
             <a:endParaRPr lang="ko-KR" altLang="en-US"/>
           </a:p>
@@ -869,7 +869,7 @@
           <p:cNvPr id="5" name="바닥글 개체 틀 4">
             <a:extLst>
               <a:ext uri="{FF2B5EF4-FFF2-40B4-BE49-F238E27FC236}">
-                <a16:creationId xmlns:a16="http://schemas.microsoft.com/office/drawing/2014/main" id="{1F04850D-02EB-A67C-C5E6-13B4A2BE32E8}"/>
+                <a16:creationId xmlns:a16="http://schemas.microsoft.com/office/drawing/2014/main" id="{3A84A34E-2A4C-4568-8148-F9E49339CD97}"/>
               </a:ext>
             </a:extLst>
           </p:cNvPr>
@@ -894,7 +894,7 @@
           <p:cNvPr id="6" name="슬라이드 번호 개체 틀 5">
             <a:extLst>
               <a:ext uri="{FF2B5EF4-FFF2-40B4-BE49-F238E27FC236}">
-                <a16:creationId xmlns:a16="http://schemas.microsoft.com/office/drawing/2014/main" id="{B34EFCC8-5206-7B1B-7A59-B4530CE32B3A}"/>
+                <a16:creationId xmlns:a16="http://schemas.microsoft.com/office/drawing/2014/main" id="{C86D43EA-2469-9C11-574A-FD2DD5EDC287}"/>
               </a:ext>
             </a:extLst>
           </p:cNvPr>
@@ -910,7 +910,7 @@
           <a:bodyPr/>
           <a:lstStyle/>
           <a:p>
-            <a:fld id="{43A37AEE-7CAF-4C20-B1E8-E65D179D62A7}" type="slidenum">
+            <a:fld id="{B88F6202-0140-4DE3-8B22-3EA9DB6A3C84}" type="slidenum">
               <a:rPr lang="ko-KR" altLang="en-US" smtClean="0"/>
               <a:t>‹#›</a:t>
             </a:fld>
@@ -921,7 +921,7 @@
     </p:spTree>
     <p:extLst>
       <p:ext uri="{BB962C8B-B14F-4D97-AF65-F5344CB8AC3E}">
-        <p14:creationId xmlns:p14="http://schemas.microsoft.com/office/powerpoint/2010/main" val="2063467502"/>
+        <p14:creationId xmlns:p14="http://schemas.microsoft.com/office/powerpoint/2010/main" val="2661636068"/>
       </p:ext>
     </p:extLst>
   </p:cSld>
@@ -953,7 +953,7 @@
           <p:cNvPr id="2" name="제목 1">
             <a:extLst>
               <a:ext uri="{FF2B5EF4-FFF2-40B4-BE49-F238E27FC236}">
-                <a16:creationId xmlns:a16="http://schemas.microsoft.com/office/drawing/2014/main" id="{421DDEAE-C2BC-4817-CE9D-22EA3FFF27EF}"/>
+                <a16:creationId xmlns:a16="http://schemas.microsoft.com/office/drawing/2014/main" id="{77503751-2097-EFE7-7E62-27BF2C8E9B3A}"/>
               </a:ext>
             </a:extLst>
           </p:cNvPr>
@@ -990,7 +990,7 @@
           <p:cNvPr id="3" name="텍스트 개체 틀 2">
             <a:extLst>
               <a:ext uri="{FF2B5EF4-FFF2-40B4-BE49-F238E27FC236}">
-                <a16:creationId xmlns:a16="http://schemas.microsoft.com/office/drawing/2014/main" id="{AAFD6BC6-FF61-ABC6-59D5-0CF619909CF6}"/>
+                <a16:creationId xmlns:a16="http://schemas.microsoft.com/office/drawing/2014/main" id="{B25971C2-BE04-F012-EF00-CD97690B64EF}"/>
               </a:ext>
             </a:extLst>
           </p:cNvPr>
@@ -1115,7 +1115,7 @@
           <p:cNvPr id="4" name="날짜 개체 틀 3">
             <a:extLst>
               <a:ext uri="{FF2B5EF4-FFF2-40B4-BE49-F238E27FC236}">
-                <a16:creationId xmlns:a16="http://schemas.microsoft.com/office/drawing/2014/main" id="{F017222B-06B5-EE41-E089-6D535DB2B92F}"/>
+                <a16:creationId xmlns:a16="http://schemas.microsoft.com/office/drawing/2014/main" id="{C25B3236-EC56-C0F4-E255-B462074A213D}"/>
               </a:ext>
             </a:extLst>
           </p:cNvPr>
@@ -1131,9 +1131,9 @@
           <a:bodyPr/>
           <a:lstStyle/>
           <a:p>
-            <a:fld id="{787DB82E-6582-4BBE-BEBA-7C4FEA228F3D}" type="datetimeFigureOut">
+            <a:fld id="{DE75A3BA-15A2-45A3-90E0-81E6670C4DBE}" type="datetimeFigureOut">
               <a:rPr lang="ko-KR" altLang="en-US" smtClean="0"/>
-              <a:t>2026-06-25</a:t>
+              <a:t>2026-06-27</a:t>
             </a:fld>
             <a:endParaRPr lang="ko-KR" altLang="en-US"/>
           </a:p>
@@ -1144,7 +1144,7 @@
           <p:cNvPr id="5" name="바닥글 개체 틀 4">
             <a:extLst>
               <a:ext uri="{FF2B5EF4-FFF2-40B4-BE49-F238E27FC236}">
-                <a16:creationId xmlns:a16="http://schemas.microsoft.com/office/drawing/2014/main" id="{F80153E6-D798-55EA-FE00-CA428CCB4C62}"/>
+                <a16:creationId xmlns:a16="http://schemas.microsoft.com/office/drawing/2014/main" id="{9C399269-7F12-3DBB-C0F7-0DF35AB0AE5C}"/>
               </a:ext>
             </a:extLst>
           </p:cNvPr>
@@ -1169,7 +1169,7 @@
           <p:cNvPr id="6" name="슬라이드 번호 개체 틀 5">
             <a:extLst>
               <a:ext uri="{FF2B5EF4-FFF2-40B4-BE49-F238E27FC236}">
-                <a16:creationId xmlns:a16="http://schemas.microsoft.com/office/drawing/2014/main" id="{52BD5717-AD5F-59AE-F031-D8B38AB2342F}"/>
+                <a16:creationId xmlns:a16="http://schemas.microsoft.com/office/drawing/2014/main" id="{B27AA494-61BE-73D1-245F-72111545A1D7}"/>
               </a:ext>
             </a:extLst>
           </p:cNvPr>
@@ -1185,7 +1185,7 @@
           <a:bodyPr/>
           <a:lstStyle/>
           <a:p>
-            <a:fld id="{43A37AEE-7CAF-4C20-B1E8-E65D179D62A7}" type="slidenum">
+            <a:fld id="{B88F6202-0140-4DE3-8B22-3EA9DB6A3C84}" type="slidenum">
               <a:rPr lang="ko-KR" altLang="en-US" smtClean="0"/>
               <a:t>‹#›</a:t>
             </a:fld>
@@ -1196,7 +1196,7 @@
     </p:spTree>
     <p:extLst>
       <p:ext uri="{BB962C8B-B14F-4D97-AF65-F5344CB8AC3E}">
-        <p14:creationId xmlns:p14="http://schemas.microsoft.com/office/powerpoint/2010/main" val="3593611646"/>
+        <p14:creationId xmlns:p14="http://schemas.microsoft.com/office/powerpoint/2010/main" val="718853334"/>
       </p:ext>
     </p:extLst>
   </p:cSld>
@@ -1228,7 +1228,7 @@
           <p:cNvPr id="2" name="제목 1">
             <a:extLst>
               <a:ext uri="{FF2B5EF4-FFF2-40B4-BE49-F238E27FC236}">
-                <a16:creationId xmlns:a16="http://schemas.microsoft.com/office/drawing/2014/main" id="{3A4B8BDE-CA36-5DD2-B9D5-A3D5B455BA73}"/>
+                <a16:creationId xmlns:a16="http://schemas.microsoft.com/office/drawing/2014/main" id="{BFFA70FE-1899-ABA2-5F3F-AA10904DAC94}"/>
               </a:ext>
             </a:extLst>
           </p:cNvPr>
@@ -1256,7 +1256,7 @@
           <p:cNvPr id="3" name="내용 개체 틀 2">
             <a:extLst>
               <a:ext uri="{FF2B5EF4-FFF2-40B4-BE49-F238E27FC236}">
-                <a16:creationId xmlns:a16="http://schemas.microsoft.com/office/drawing/2014/main" id="{898CDC27-FD93-8C1A-D9EF-BD50E3715C77}"/>
+                <a16:creationId xmlns:a16="http://schemas.microsoft.com/office/drawing/2014/main" id="{8165C53B-DC8E-F36A-A73F-876A0452DF03}"/>
               </a:ext>
             </a:extLst>
           </p:cNvPr>
@@ -1318,7 +1318,7 @@
           <p:cNvPr id="4" name="내용 개체 틀 3">
             <a:extLst>
               <a:ext uri="{FF2B5EF4-FFF2-40B4-BE49-F238E27FC236}">
-                <a16:creationId xmlns:a16="http://schemas.microsoft.com/office/drawing/2014/main" id="{83D14B5E-18CB-D8CF-C34D-3DDB82F0E92D}"/>
+                <a16:creationId xmlns:a16="http://schemas.microsoft.com/office/drawing/2014/main" id="{AA1B8589-CC0D-A9D8-57C2-9B74D8F29A3D}"/>
               </a:ext>
             </a:extLst>
           </p:cNvPr>
@@ -1380,7 +1380,7 @@
           <p:cNvPr id="5" name="날짜 개체 틀 4">
             <a:extLst>
               <a:ext uri="{FF2B5EF4-FFF2-40B4-BE49-F238E27FC236}">
-                <a16:creationId xmlns:a16="http://schemas.microsoft.com/office/drawing/2014/main" id="{B241D6C9-ED87-6CEB-6D12-B9D8EF639328}"/>
+                <a16:creationId xmlns:a16="http://schemas.microsoft.com/office/drawing/2014/main" id="{C0459D9C-CAF7-FAE6-B841-8A397F514EDE}"/>
               </a:ext>
             </a:extLst>
           </p:cNvPr>
@@ -1396,9 +1396,9 @@
           <a:bodyPr/>
           <a:lstStyle/>
           <a:p>
-            <a:fld id="{787DB82E-6582-4BBE-BEBA-7C4FEA228F3D}" type="datetimeFigureOut">
+            <a:fld id="{DE75A3BA-15A2-45A3-90E0-81E6670C4DBE}" type="datetimeFigureOut">
               <a:rPr lang="ko-KR" altLang="en-US" smtClean="0"/>
-              <a:t>2026-06-25</a:t>
+              <a:t>2026-06-27</a:t>
             </a:fld>
             <a:endParaRPr lang="ko-KR" altLang="en-US"/>
           </a:p>
@@ -1409,7 +1409,7 @@
           <p:cNvPr id="6" name="바닥글 개체 틀 5">
             <a:extLst>
               <a:ext uri="{FF2B5EF4-FFF2-40B4-BE49-F238E27FC236}">
-                <a16:creationId xmlns:a16="http://schemas.microsoft.com/office/drawing/2014/main" id="{916B1D37-ADA4-1E1E-E13C-765B406AEB81}"/>
+                <a16:creationId xmlns:a16="http://schemas.microsoft.com/office/drawing/2014/main" id="{0EFABC3B-6CBD-0CA7-CA9B-A4EF58CC63B6}"/>
               </a:ext>
             </a:extLst>
           </p:cNvPr>
@@ -1434,7 +1434,7 @@
           <p:cNvPr id="7" name="슬라이드 번호 개체 틀 6">
             <a:extLst>
               <a:ext uri="{FF2B5EF4-FFF2-40B4-BE49-F238E27FC236}">
-                <a16:creationId xmlns:a16="http://schemas.microsoft.com/office/drawing/2014/main" id="{2C86AEE3-6845-7912-BEA3-2D51AFB9D3D5}"/>
+                <a16:creationId xmlns:a16="http://schemas.microsoft.com/office/drawing/2014/main" id="{8A2F668B-F8E6-85D2-3CA8-EA64553F3A68}"/>
               </a:ext>
             </a:extLst>
           </p:cNvPr>
@@ -1450,7 +1450,7 @@
           <a:bodyPr/>
           <a:lstStyle/>
           <a:p>
-            <a:fld id="{43A37AEE-7CAF-4C20-B1E8-E65D179D62A7}" type="slidenum">
+            <a:fld id="{B88F6202-0140-4DE3-8B22-3EA9DB6A3C84}" type="slidenum">
               <a:rPr lang="ko-KR" altLang="en-US" smtClean="0"/>
               <a:t>‹#›</a:t>
             </a:fld>
@@ -1461,7 +1461,7 @@
     </p:spTree>
     <p:extLst>
       <p:ext uri="{BB962C8B-B14F-4D97-AF65-F5344CB8AC3E}">
-        <p14:creationId xmlns:p14="http://schemas.microsoft.com/office/powerpoint/2010/main" val="4123864501"/>
+        <p14:creationId xmlns:p14="http://schemas.microsoft.com/office/powerpoint/2010/main" val="1487302252"/>
       </p:ext>
     </p:extLst>
   </p:cSld>
@@ -1493,7 +1493,7 @@
           <p:cNvPr id="2" name="제목 1">
             <a:extLst>
               <a:ext uri="{FF2B5EF4-FFF2-40B4-BE49-F238E27FC236}">
-                <a16:creationId xmlns:a16="http://schemas.microsoft.com/office/drawing/2014/main" id="{1F8EB8AD-885D-E377-690A-0FC9030127F9}"/>
+                <a16:creationId xmlns:a16="http://schemas.microsoft.com/office/drawing/2014/main" id="{AAF30C73-77A9-889D-21D9-0ED33706A7BB}"/>
               </a:ext>
             </a:extLst>
           </p:cNvPr>
@@ -1526,7 +1526,7 @@
           <p:cNvPr id="3" name="텍스트 개체 틀 2">
             <a:extLst>
               <a:ext uri="{FF2B5EF4-FFF2-40B4-BE49-F238E27FC236}">
-                <a16:creationId xmlns:a16="http://schemas.microsoft.com/office/drawing/2014/main" id="{A0616F82-713D-87A8-7F40-D2A52B4CEE92}"/>
+                <a16:creationId xmlns:a16="http://schemas.microsoft.com/office/drawing/2014/main" id="{7E48FB89-41D8-A328-C1C3-12B44EAD6BC7}"/>
               </a:ext>
             </a:extLst>
           </p:cNvPr>
@@ -1597,7 +1597,7 @@
           <p:cNvPr id="4" name="내용 개체 틀 3">
             <a:extLst>
               <a:ext uri="{FF2B5EF4-FFF2-40B4-BE49-F238E27FC236}">
-                <a16:creationId xmlns:a16="http://schemas.microsoft.com/office/drawing/2014/main" id="{98F06482-33A3-9027-54D5-B7BB7805AB2C}"/>
+                <a16:creationId xmlns:a16="http://schemas.microsoft.com/office/drawing/2014/main" id="{3B3EC8AD-92CB-DE8F-BCD4-DEEEBA29CBF4}"/>
               </a:ext>
             </a:extLst>
           </p:cNvPr>
@@ -1659,7 +1659,7 @@
           <p:cNvPr id="5" name="텍스트 개체 틀 4">
             <a:extLst>
               <a:ext uri="{FF2B5EF4-FFF2-40B4-BE49-F238E27FC236}">
-                <a16:creationId xmlns:a16="http://schemas.microsoft.com/office/drawing/2014/main" id="{9BBED3B4-2C30-D93E-1CC5-E24666C44AB1}"/>
+                <a16:creationId xmlns:a16="http://schemas.microsoft.com/office/drawing/2014/main" id="{40E3ACB0-2F51-D926-22F7-3555278930B7}"/>
               </a:ext>
             </a:extLst>
           </p:cNvPr>
@@ -1730,7 +1730,7 @@
           <p:cNvPr id="6" name="내용 개체 틀 5">
             <a:extLst>
               <a:ext uri="{FF2B5EF4-FFF2-40B4-BE49-F238E27FC236}">
-                <a16:creationId xmlns:a16="http://schemas.microsoft.com/office/drawing/2014/main" id="{5EA72DD4-E24F-2676-3923-C3025A8DDEE8}"/>
+                <a16:creationId xmlns:a16="http://schemas.microsoft.com/office/drawing/2014/main" id="{07531F14-87D4-3FBE-E438-1C9B94C2BD21}"/>
               </a:ext>
             </a:extLst>
           </p:cNvPr>
@@ -1792,7 +1792,7 @@
           <p:cNvPr id="7" name="날짜 개체 틀 6">
             <a:extLst>
               <a:ext uri="{FF2B5EF4-FFF2-40B4-BE49-F238E27FC236}">
-                <a16:creationId xmlns:a16="http://schemas.microsoft.com/office/drawing/2014/main" id="{B8D06687-419D-FC44-0A1E-A40E827A17A4}"/>
+                <a16:creationId xmlns:a16="http://schemas.microsoft.com/office/drawing/2014/main" id="{CB2D0020-8B2D-803F-C4BA-BD1544E4F806}"/>
               </a:ext>
             </a:extLst>
           </p:cNvPr>
@@ -1808,9 +1808,9 @@
           <a:bodyPr/>
           <a:lstStyle/>
           <a:p>
-            <a:fld id="{787DB82E-6582-4BBE-BEBA-7C4FEA228F3D}" type="datetimeFigureOut">
+            <a:fld id="{DE75A3BA-15A2-45A3-90E0-81E6670C4DBE}" type="datetimeFigureOut">
               <a:rPr lang="ko-KR" altLang="en-US" smtClean="0"/>
-              <a:t>2026-06-25</a:t>
+              <a:t>2026-06-27</a:t>
             </a:fld>
             <a:endParaRPr lang="ko-KR" altLang="en-US"/>
           </a:p>
@@ -1821,7 +1821,7 @@
           <p:cNvPr id="8" name="바닥글 개체 틀 7">
             <a:extLst>
               <a:ext uri="{FF2B5EF4-FFF2-40B4-BE49-F238E27FC236}">
-                <a16:creationId xmlns:a16="http://schemas.microsoft.com/office/drawing/2014/main" id="{B7CD0844-98D8-F4BF-5BBF-957C4FFD9755}"/>
+                <a16:creationId xmlns:a16="http://schemas.microsoft.com/office/drawing/2014/main" id="{4B4DD5BF-4A06-A4F3-7065-1153A433DAC1}"/>
               </a:ext>
             </a:extLst>
           </p:cNvPr>
@@ -1846,7 +1846,7 @@
           <p:cNvPr id="9" name="슬라이드 번호 개체 틀 8">
             <a:extLst>
               <a:ext uri="{FF2B5EF4-FFF2-40B4-BE49-F238E27FC236}">
-                <a16:creationId xmlns:a16="http://schemas.microsoft.com/office/drawing/2014/main" id="{30E30E16-1730-C6E4-79B5-E95CA5EB2012}"/>
+                <a16:creationId xmlns:a16="http://schemas.microsoft.com/office/drawing/2014/main" id="{131DD47C-D74E-739C-83DA-BC29CB578EA2}"/>
               </a:ext>
             </a:extLst>
           </p:cNvPr>
@@ -1862,7 +1862,7 @@
           <a:bodyPr/>
           <a:lstStyle/>
           <a:p>
-            <a:fld id="{43A37AEE-7CAF-4C20-B1E8-E65D179D62A7}" type="slidenum">
+            <a:fld id="{B88F6202-0140-4DE3-8B22-3EA9DB6A3C84}" type="slidenum">
               <a:rPr lang="ko-KR" altLang="en-US" smtClean="0"/>
               <a:t>‹#›</a:t>
             </a:fld>
@@ -1873,7 +1873,7 @@
     </p:spTree>
     <p:extLst>
       <p:ext uri="{BB962C8B-B14F-4D97-AF65-F5344CB8AC3E}">
-        <p14:creationId xmlns:p14="http://schemas.microsoft.com/office/powerpoint/2010/main" val="1012572248"/>
+        <p14:creationId xmlns:p14="http://schemas.microsoft.com/office/powerpoint/2010/main" val="3189931345"/>
       </p:ext>
     </p:extLst>
   </p:cSld>
@@ -1905,7 +1905,7 @@
           <p:cNvPr id="2" name="제목 1">
             <a:extLst>
               <a:ext uri="{FF2B5EF4-FFF2-40B4-BE49-F238E27FC236}">
-                <a16:creationId xmlns:a16="http://schemas.microsoft.com/office/drawing/2014/main" id="{73645483-D25B-5821-E321-DADBA51EB0C3}"/>
+                <a16:creationId xmlns:a16="http://schemas.microsoft.com/office/drawing/2014/main" id="{9184E5BC-0513-F0BF-BDE9-C7B3C402742C}"/>
               </a:ext>
             </a:extLst>
           </p:cNvPr>
@@ -1933,7 +1933,7 @@
           <p:cNvPr id="3" name="날짜 개체 틀 2">
             <a:extLst>
               <a:ext uri="{FF2B5EF4-FFF2-40B4-BE49-F238E27FC236}">
-                <a16:creationId xmlns:a16="http://schemas.microsoft.com/office/drawing/2014/main" id="{E431E6C2-4A3B-1850-1EE3-3617A8175D68}"/>
+                <a16:creationId xmlns:a16="http://schemas.microsoft.com/office/drawing/2014/main" id="{EEF0B3CC-A4CD-D5A7-121B-F42EF5746B1F}"/>
               </a:ext>
             </a:extLst>
           </p:cNvPr>
@@ -1949,9 +1949,9 @@
           <a:bodyPr/>
           <a:lstStyle/>
           <a:p>
-            <a:fld id="{787DB82E-6582-4BBE-BEBA-7C4FEA228F3D}" type="datetimeFigureOut">
+            <a:fld id="{DE75A3BA-15A2-45A3-90E0-81E6670C4DBE}" type="datetimeFigureOut">
               <a:rPr lang="ko-KR" altLang="en-US" smtClean="0"/>
-              <a:t>2026-06-25</a:t>
+              <a:t>2026-06-27</a:t>
             </a:fld>
             <a:endParaRPr lang="ko-KR" altLang="en-US"/>
           </a:p>
@@ -1962,7 +1962,7 @@
           <p:cNvPr id="4" name="바닥글 개체 틀 3">
             <a:extLst>
               <a:ext uri="{FF2B5EF4-FFF2-40B4-BE49-F238E27FC236}">
-                <a16:creationId xmlns:a16="http://schemas.microsoft.com/office/drawing/2014/main" id="{FA07E8DB-6B3B-6754-5F82-779AA77E750E}"/>
+                <a16:creationId xmlns:a16="http://schemas.microsoft.com/office/drawing/2014/main" id="{58253767-352B-0D78-44B7-5FD0C6A20D2E}"/>
               </a:ext>
             </a:extLst>
           </p:cNvPr>
@@ -1987,7 +1987,7 @@
           <p:cNvPr id="5" name="슬라이드 번호 개체 틀 4">
             <a:extLst>
               <a:ext uri="{FF2B5EF4-FFF2-40B4-BE49-F238E27FC236}">
-                <a16:creationId xmlns:a16="http://schemas.microsoft.com/office/drawing/2014/main" id="{4D0AAC83-BAC6-EA82-126C-B45BE3CEFA49}"/>
+                <a16:creationId xmlns:a16="http://schemas.microsoft.com/office/drawing/2014/main" id="{D8986A57-7DED-2F61-1DCC-BE7863A67C11}"/>
               </a:ext>
             </a:extLst>
           </p:cNvPr>
@@ -2003,7 +2003,7 @@
           <a:bodyPr/>
           <a:lstStyle/>
           <a:p>
-            <a:fld id="{43A37AEE-7CAF-4C20-B1E8-E65D179D62A7}" type="slidenum">
+            <a:fld id="{B88F6202-0140-4DE3-8B22-3EA9DB6A3C84}" type="slidenum">
               <a:rPr lang="ko-KR" altLang="en-US" smtClean="0"/>
               <a:t>‹#›</a:t>
             </a:fld>
@@ -2014,7 +2014,7 @@
     </p:spTree>
     <p:extLst>
       <p:ext uri="{BB962C8B-B14F-4D97-AF65-F5344CB8AC3E}">
-        <p14:creationId xmlns:p14="http://schemas.microsoft.com/office/powerpoint/2010/main" val="1699616446"/>
+        <p14:creationId xmlns:p14="http://schemas.microsoft.com/office/powerpoint/2010/main" val="3766014110"/>
       </p:ext>
     </p:extLst>
   </p:cSld>
@@ -2046,7 +2046,7 @@
           <p:cNvPr id="2" name="날짜 개체 틀 1">
             <a:extLst>
               <a:ext uri="{FF2B5EF4-FFF2-40B4-BE49-F238E27FC236}">
-                <a16:creationId xmlns:a16="http://schemas.microsoft.com/office/drawing/2014/main" id="{73CBD75D-9AB9-F0EC-2DEA-9F8AAAE0C0D2}"/>
+                <a16:creationId xmlns:a16="http://schemas.microsoft.com/office/drawing/2014/main" id="{605848FE-DE93-5276-DEF5-E8135CBE1BA3}"/>
               </a:ext>
             </a:extLst>
           </p:cNvPr>
@@ -2062,9 +2062,9 @@
           <a:bodyPr/>
           <a:lstStyle/>
           <a:p>
-            <a:fld id="{787DB82E-6582-4BBE-BEBA-7C4FEA228F3D}" type="datetimeFigureOut">
+            <a:fld id="{DE75A3BA-15A2-45A3-90E0-81E6670C4DBE}" type="datetimeFigureOut">
               <a:rPr lang="ko-KR" altLang="en-US" smtClean="0"/>
-              <a:t>2026-06-25</a:t>
+              <a:t>2026-06-27</a:t>
             </a:fld>
             <a:endParaRPr lang="ko-KR" altLang="en-US"/>
           </a:p>
@@ -2075,7 +2075,7 @@
           <p:cNvPr id="3" name="바닥글 개체 틀 2">
             <a:extLst>
               <a:ext uri="{FF2B5EF4-FFF2-40B4-BE49-F238E27FC236}">
-                <a16:creationId xmlns:a16="http://schemas.microsoft.com/office/drawing/2014/main" id="{712F54C2-B2F1-AFB0-C3BA-ED32FF7821C5}"/>
+                <a16:creationId xmlns:a16="http://schemas.microsoft.com/office/drawing/2014/main" id="{37C3E31C-DE01-C8E7-566D-3D767C4657A1}"/>
               </a:ext>
             </a:extLst>
           </p:cNvPr>
@@ -2100,7 +2100,7 @@
           <p:cNvPr id="4" name="슬라이드 번호 개체 틀 3">
             <a:extLst>
               <a:ext uri="{FF2B5EF4-FFF2-40B4-BE49-F238E27FC236}">
-                <a16:creationId xmlns:a16="http://schemas.microsoft.com/office/drawing/2014/main" id="{443AE213-A856-F1CC-5C1B-BC8036E9D8B9}"/>
+                <a16:creationId xmlns:a16="http://schemas.microsoft.com/office/drawing/2014/main" id="{43AE7EA7-3396-75D7-6261-119CD5D8D132}"/>
               </a:ext>
             </a:extLst>
           </p:cNvPr>
@@ -2116,7 +2116,7 @@
           <a:bodyPr/>
           <a:lstStyle/>
           <a:p>
-            <a:fld id="{43A37AEE-7CAF-4C20-B1E8-E65D179D62A7}" type="slidenum">
+            <a:fld id="{B88F6202-0140-4DE3-8B22-3EA9DB6A3C84}" type="slidenum">
               <a:rPr lang="ko-KR" altLang="en-US" smtClean="0"/>
               <a:t>‹#›</a:t>
             </a:fld>
@@ -2127,7 +2127,7 @@
     </p:spTree>
     <p:extLst>
       <p:ext uri="{BB962C8B-B14F-4D97-AF65-F5344CB8AC3E}">
-        <p14:creationId xmlns:p14="http://schemas.microsoft.com/office/powerpoint/2010/main" val="110498727"/>
+        <p14:creationId xmlns:p14="http://schemas.microsoft.com/office/powerpoint/2010/main" val="2033517382"/>
       </p:ext>
     </p:extLst>
   </p:cSld>
@@ -2159,7 +2159,7 @@
           <p:cNvPr id="2" name="제목 1">
             <a:extLst>
               <a:ext uri="{FF2B5EF4-FFF2-40B4-BE49-F238E27FC236}">
-                <a16:creationId xmlns:a16="http://schemas.microsoft.com/office/drawing/2014/main" id="{96FC878D-3C89-64E8-A4EA-423A2BCC58FE}"/>
+                <a16:creationId xmlns:a16="http://schemas.microsoft.com/office/drawing/2014/main" id="{77E67E62-3909-EC6D-73F0-6529C3529BD0}"/>
               </a:ext>
             </a:extLst>
           </p:cNvPr>
@@ -2196,7 +2196,7 @@
           <p:cNvPr id="3" name="내용 개체 틀 2">
             <a:extLst>
               <a:ext uri="{FF2B5EF4-FFF2-40B4-BE49-F238E27FC236}">
-                <a16:creationId xmlns:a16="http://schemas.microsoft.com/office/drawing/2014/main" id="{2EFE011B-1468-ABC1-940C-A3ACC73AE8CF}"/>
+                <a16:creationId xmlns:a16="http://schemas.microsoft.com/office/drawing/2014/main" id="{C29B442F-05AF-0188-5F65-A283DD68EBBA}"/>
               </a:ext>
             </a:extLst>
           </p:cNvPr>
@@ -2286,7 +2286,7 @@
           <p:cNvPr id="4" name="텍스트 개체 틀 3">
             <a:extLst>
               <a:ext uri="{FF2B5EF4-FFF2-40B4-BE49-F238E27FC236}">
-                <a16:creationId xmlns:a16="http://schemas.microsoft.com/office/drawing/2014/main" id="{961B9244-C933-A370-966A-38AE4EECAB2B}"/>
+                <a16:creationId xmlns:a16="http://schemas.microsoft.com/office/drawing/2014/main" id="{28FE149E-569B-FEDF-80B5-DAB8F5281A8D}"/>
               </a:ext>
             </a:extLst>
           </p:cNvPr>
@@ -2357,7 +2357,7 @@
           <p:cNvPr id="5" name="날짜 개체 틀 4">
             <a:extLst>
               <a:ext uri="{FF2B5EF4-FFF2-40B4-BE49-F238E27FC236}">
-                <a16:creationId xmlns:a16="http://schemas.microsoft.com/office/drawing/2014/main" id="{406FC317-A84B-85D5-FFFF-782A02C48A94}"/>
+                <a16:creationId xmlns:a16="http://schemas.microsoft.com/office/drawing/2014/main" id="{B3EBC401-95C9-8A96-41FE-3ADB0A5F19E5}"/>
               </a:ext>
             </a:extLst>
           </p:cNvPr>
@@ -2373,9 +2373,9 @@
           <a:bodyPr/>
           <a:lstStyle/>
           <a:p>
-            <a:fld id="{787DB82E-6582-4BBE-BEBA-7C4FEA228F3D}" type="datetimeFigureOut">
+            <a:fld id="{DE75A3BA-15A2-45A3-90E0-81E6670C4DBE}" type="datetimeFigureOut">
               <a:rPr lang="ko-KR" altLang="en-US" smtClean="0"/>
-              <a:t>2026-06-25</a:t>
+              <a:t>2026-06-27</a:t>
             </a:fld>
             <a:endParaRPr lang="ko-KR" altLang="en-US"/>
           </a:p>
@@ -2386,7 +2386,7 @@
           <p:cNvPr id="6" name="바닥글 개체 틀 5">
             <a:extLst>
               <a:ext uri="{FF2B5EF4-FFF2-40B4-BE49-F238E27FC236}">
-                <a16:creationId xmlns:a16="http://schemas.microsoft.com/office/drawing/2014/main" id="{A318DD0B-3B17-EEF4-E831-DFFCC6D21AC0}"/>
+                <a16:creationId xmlns:a16="http://schemas.microsoft.com/office/drawing/2014/main" id="{0DAB2696-320C-A169-A944-4CE6989F1D85}"/>
               </a:ext>
             </a:extLst>
           </p:cNvPr>
@@ -2411,7 +2411,7 @@
           <p:cNvPr id="7" name="슬라이드 번호 개체 틀 6">
             <a:extLst>
               <a:ext uri="{FF2B5EF4-FFF2-40B4-BE49-F238E27FC236}">
-                <a16:creationId xmlns:a16="http://schemas.microsoft.com/office/drawing/2014/main" id="{8F91A6C5-75ED-ED18-A2F7-018AC14DF3FA}"/>
+                <a16:creationId xmlns:a16="http://schemas.microsoft.com/office/drawing/2014/main" id="{EC80A11D-119E-D5E9-85E1-810A34D54B9A}"/>
               </a:ext>
             </a:extLst>
           </p:cNvPr>
@@ -2427,7 +2427,7 @@
           <a:bodyPr/>
           <a:lstStyle/>
           <a:p>
-            <a:fld id="{43A37AEE-7CAF-4C20-B1E8-E65D179D62A7}" type="slidenum">
+            <a:fld id="{B88F6202-0140-4DE3-8B22-3EA9DB6A3C84}" type="slidenum">
               <a:rPr lang="ko-KR" altLang="en-US" smtClean="0"/>
               <a:t>‹#›</a:t>
             </a:fld>
@@ -2438,7 +2438,7 @@
     </p:spTree>
     <p:extLst>
       <p:ext uri="{BB962C8B-B14F-4D97-AF65-F5344CB8AC3E}">
-        <p14:creationId xmlns:p14="http://schemas.microsoft.com/office/powerpoint/2010/main" val="3357211108"/>
+        <p14:creationId xmlns:p14="http://schemas.microsoft.com/office/powerpoint/2010/main" val="2530069206"/>
       </p:ext>
     </p:extLst>
   </p:cSld>
@@ -2470,7 +2470,7 @@
           <p:cNvPr id="2" name="제목 1">
             <a:extLst>
               <a:ext uri="{FF2B5EF4-FFF2-40B4-BE49-F238E27FC236}">
-                <a16:creationId xmlns:a16="http://schemas.microsoft.com/office/drawing/2014/main" id="{EEFE717A-F712-2BFD-58F7-44D760FA740F}"/>
+                <a16:creationId xmlns:a16="http://schemas.microsoft.com/office/drawing/2014/main" id="{13EC0CAD-B652-E568-5AE8-7839BC8772DA}"/>
               </a:ext>
             </a:extLst>
           </p:cNvPr>
@@ -2507,7 +2507,7 @@
           <p:cNvPr id="3" name="그림 개체 틀 2">
             <a:extLst>
               <a:ext uri="{FF2B5EF4-FFF2-40B4-BE49-F238E27FC236}">
-                <a16:creationId xmlns:a16="http://schemas.microsoft.com/office/drawing/2014/main" id="{9E05E67F-0C98-8818-DE02-D50D0A3BAA75}"/>
+                <a16:creationId xmlns:a16="http://schemas.microsoft.com/office/drawing/2014/main" id="{AA992B3C-5B2C-AA0D-B184-2F7F312FA76A}"/>
               </a:ext>
             </a:extLst>
           </p:cNvPr>
@@ -2574,7 +2574,7 @@
           <p:cNvPr id="4" name="텍스트 개체 틀 3">
             <a:extLst>
               <a:ext uri="{FF2B5EF4-FFF2-40B4-BE49-F238E27FC236}">
-                <a16:creationId xmlns:a16="http://schemas.microsoft.com/office/drawing/2014/main" id="{1F253DD7-3FF0-4307-779B-CE2207BFD657}"/>
+                <a16:creationId xmlns:a16="http://schemas.microsoft.com/office/drawing/2014/main" id="{406C3ACA-A893-0A3F-A4C8-F05C5F6F1645}"/>
               </a:ext>
             </a:extLst>
           </p:cNvPr>
@@ -2645,7 +2645,7 @@
           <p:cNvPr id="5" name="날짜 개체 틀 4">
             <a:extLst>
               <a:ext uri="{FF2B5EF4-FFF2-40B4-BE49-F238E27FC236}">
-                <a16:creationId xmlns:a16="http://schemas.microsoft.com/office/drawing/2014/main" id="{9D3490D1-FD5D-57B1-6B89-CC195985D806}"/>
+                <a16:creationId xmlns:a16="http://schemas.microsoft.com/office/drawing/2014/main" id="{0B22DC5C-1A5E-AAA2-09BB-49A8D91540EF}"/>
               </a:ext>
             </a:extLst>
           </p:cNvPr>
@@ -2661,9 +2661,9 @@
           <a:bodyPr/>
           <a:lstStyle/>
           <a:p>
-            <a:fld id="{787DB82E-6582-4BBE-BEBA-7C4FEA228F3D}" type="datetimeFigureOut">
+            <a:fld id="{DE75A3BA-15A2-45A3-90E0-81E6670C4DBE}" type="datetimeFigureOut">
               <a:rPr lang="ko-KR" altLang="en-US" smtClean="0"/>
-              <a:t>2026-06-25</a:t>
+              <a:t>2026-06-27</a:t>
             </a:fld>
             <a:endParaRPr lang="ko-KR" altLang="en-US"/>
           </a:p>
@@ -2674,7 +2674,7 @@
           <p:cNvPr id="6" name="바닥글 개체 틀 5">
             <a:extLst>
               <a:ext uri="{FF2B5EF4-FFF2-40B4-BE49-F238E27FC236}">
-                <a16:creationId xmlns:a16="http://schemas.microsoft.com/office/drawing/2014/main" id="{7F40F325-BE1D-D291-9C3F-2DF932A56E78}"/>
+                <a16:creationId xmlns:a16="http://schemas.microsoft.com/office/drawing/2014/main" id="{AD39D7F0-C0DE-B83C-2A36-8ECF5D343A53}"/>
               </a:ext>
             </a:extLst>
           </p:cNvPr>
@@ -2699,7 +2699,7 @@
           <p:cNvPr id="7" name="슬라이드 번호 개체 틀 6">
             <a:extLst>
               <a:ext uri="{FF2B5EF4-FFF2-40B4-BE49-F238E27FC236}">
-                <a16:creationId xmlns:a16="http://schemas.microsoft.com/office/drawing/2014/main" id="{1F9DFB25-3AAF-537F-CBDF-BB6ED610C93C}"/>
+                <a16:creationId xmlns:a16="http://schemas.microsoft.com/office/drawing/2014/main" id="{76BCD5D6-9D91-FC44-288A-9D519C71305F}"/>
               </a:ext>
             </a:extLst>
           </p:cNvPr>
@@ -2715,7 +2715,7 @@
           <a:bodyPr/>
           <a:lstStyle/>
           <a:p>
-            <a:fld id="{43A37AEE-7CAF-4C20-B1E8-E65D179D62A7}" type="slidenum">
+            <a:fld id="{B88F6202-0140-4DE3-8B22-3EA9DB6A3C84}" type="slidenum">
               <a:rPr lang="ko-KR" altLang="en-US" smtClean="0"/>
               <a:t>‹#›</a:t>
             </a:fld>
@@ -2726,7 +2726,7 @@
     </p:spTree>
     <p:extLst>
       <p:ext uri="{BB962C8B-B14F-4D97-AF65-F5344CB8AC3E}">
-        <p14:creationId xmlns:p14="http://schemas.microsoft.com/office/powerpoint/2010/main" val="2242996727"/>
+        <p14:creationId xmlns:p14="http://schemas.microsoft.com/office/powerpoint/2010/main" val="335870407"/>
       </p:ext>
     </p:extLst>
   </p:cSld>
@@ -2763,7 +2763,7 @@
           <p:cNvPr id="2" name="제목 개체 틀 1">
             <a:extLst>
               <a:ext uri="{FF2B5EF4-FFF2-40B4-BE49-F238E27FC236}">
-                <a16:creationId xmlns:a16="http://schemas.microsoft.com/office/drawing/2014/main" id="{F4370006-13B4-B142-9EC3-B6B9CBB1E911}"/>
+                <a16:creationId xmlns:a16="http://schemas.microsoft.com/office/drawing/2014/main" id="{E174E9A2-7AC4-6CE0-45CD-82D8C5930886}"/>
               </a:ext>
             </a:extLst>
           </p:cNvPr>
@@ -2801,7 +2801,7 @@
           <p:cNvPr id="3" name="텍스트 개체 틀 2">
             <a:extLst>
               <a:ext uri="{FF2B5EF4-FFF2-40B4-BE49-F238E27FC236}">
-                <a16:creationId xmlns:a16="http://schemas.microsoft.com/office/drawing/2014/main" id="{603A0854-8D7E-30D6-D4C5-B155100FC438}"/>
+                <a16:creationId xmlns:a16="http://schemas.microsoft.com/office/drawing/2014/main" id="{2D63D96D-FA0A-9F46-0927-43693F29DCA9}"/>
               </a:ext>
             </a:extLst>
           </p:cNvPr>
@@ -2868,7 +2868,7 @@
           <p:cNvPr id="4" name="날짜 개체 틀 3">
             <a:extLst>
               <a:ext uri="{FF2B5EF4-FFF2-40B4-BE49-F238E27FC236}">
-                <a16:creationId xmlns:a16="http://schemas.microsoft.com/office/drawing/2014/main" id="{3E87ED58-00F5-05F5-35E3-38FDC2E302F0}"/>
+                <a16:creationId xmlns:a16="http://schemas.microsoft.com/office/drawing/2014/main" id="{5BF80F11-45AE-29B7-81E2-B37E5078588D}"/>
               </a:ext>
             </a:extLst>
           </p:cNvPr>
@@ -2902,9 +2902,9 @@
             </a:lvl1pPr>
           </a:lstStyle>
           <a:p>
-            <a:fld id="{787DB82E-6582-4BBE-BEBA-7C4FEA228F3D}" type="datetimeFigureOut">
+            <a:fld id="{DE75A3BA-15A2-45A3-90E0-81E6670C4DBE}" type="datetimeFigureOut">
               <a:rPr lang="ko-KR" altLang="en-US" smtClean="0"/>
-              <a:t>2026-06-25</a:t>
+              <a:t>2026-06-27</a:t>
             </a:fld>
             <a:endParaRPr lang="ko-KR" altLang="en-US"/>
           </a:p>
@@ -2915,7 +2915,7 @@
           <p:cNvPr id="5" name="바닥글 개체 틀 4">
             <a:extLst>
               <a:ext uri="{FF2B5EF4-FFF2-40B4-BE49-F238E27FC236}">
-                <a16:creationId xmlns:a16="http://schemas.microsoft.com/office/drawing/2014/main" id="{3E481BA4-C468-D6EC-AC61-4E514096B037}"/>
+                <a16:creationId xmlns:a16="http://schemas.microsoft.com/office/drawing/2014/main" id="{D2ECE79D-A426-5A3E-9406-1A9E6BBBB275}"/>
               </a:ext>
             </a:extLst>
           </p:cNvPr>
@@ -2958,7 +2958,7 @@
           <p:cNvPr id="6" name="슬라이드 번호 개체 틀 5">
             <a:extLst>
               <a:ext uri="{FF2B5EF4-FFF2-40B4-BE49-F238E27FC236}">
-                <a16:creationId xmlns:a16="http://schemas.microsoft.com/office/drawing/2014/main" id="{DD673D86-9BD3-A502-2CAA-D3D451703510}"/>
+                <a16:creationId xmlns:a16="http://schemas.microsoft.com/office/drawing/2014/main" id="{D4C97CC7-D6FF-84B3-4441-4C08A980AA66}"/>
               </a:ext>
             </a:extLst>
           </p:cNvPr>
@@ -2992,7 +2992,7 @@
             </a:lvl1pPr>
           </a:lstStyle>
           <a:p>
-            <a:fld id="{43A37AEE-7CAF-4C20-B1E8-E65D179D62A7}" type="slidenum">
+            <a:fld id="{B88F6202-0140-4DE3-8B22-3EA9DB6A3C84}" type="slidenum">
               <a:rPr lang="ko-KR" altLang="en-US" smtClean="0"/>
               <a:t>‹#›</a:t>
             </a:fld>
@@ -3003,7 +3003,7 @@
     </p:spTree>
     <p:extLst>
       <p:ext uri="{BB962C8B-B14F-4D97-AF65-F5344CB8AC3E}">
-        <p14:creationId xmlns:p14="http://schemas.microsoft.com/office/powerpoint/2010/main" val="2530021009"/>
+        <p14:creationId xmlns:p14="http://schemas.microsoft.com/office/powerpoint/2010/main" val="2319451274"/>
       </p:ext>
     </p:extLst>
   </p:cSld>
@@ -3326,7 +3326,7 @@
           <p:cNvPr id="2" name="z00_grid_top">
             <a:extLst>
               <a:ext uri="{FF2B5EF4-FFF2-40B4-BE49-F238E27FC236}">
-                <a16:creationId xmlns:a16="http://schemas.microsoft.com/office/drawing/2014/main" id="{127AC118-96F3-A883-5CEE-A8637E074F63}"/>
+                <a16:creationId xmlns:a16="http://schemas.microsoft.com/office/drawing/2014/main" id="{CA4B1B1F-2765-C9A8-0EE1-8D333BCDB16B}"/>
               </a:ext>
             </a:extLst>
           </p:cNvPr>
@@ -3369,7 +3369,7 @@
           <p:cNvPr id="3" name="z00_grid_bottom">
             <a:extLst>
               <a:ext uri="{FF2B5EF4-FFF2-40B4-BE49-F238E27FC236}">
-                <a16:creationId xmlns:a16="http://schemas.microsoft.com/office/drawing/2014/main" id="{C1242729-47F3-E5E0-9E83-D2514F47A91D}"/>
+                <a16:creationId xmlns:a16="http://schemas.microsoft.com/office/drawing/2014/main" id="{872CBD0B-B854-295A-DDBA-6DDFBB003386}"/>
               </a:ext>
             </a:extLst>
           </p:cNvPr>
@@ -3412,7 +3412,7 @@
           <p:cNvPr id="4" name="z00_grid_v_0">
             <a:extLst>
               <a:ext uri="{FF2B5EF4-FFF2-40B4-BE49-F238E27FC236}">
-                <a16:creationId xmlns:a16="http://schemas.microsoft.com/office/drawing/2014/main" id="{CD98AB76-C48C-E237-3546-D8DEEE647282}"/>
+                <a16:creationId xmlns:a16="http://schemas.microsoft.com/office/drawing/2014/main" id="{A2EB6613-BDCF-55E9-506F-035F728DE36C}"/>
               </a:ext>
             </a:extLst>
           </p:cNvPr>
@@ -3455,7 +3455,7 @@
           <p:cNvPr id="5" name="z00_grid_v_1">
             <a:extLst>
               <a:ext uri="{FF2B5EF4-FFF2-40B4-BE49-F238E27FC236}">
-                <a16:creationId xmlns:a16="http://schemas.microsoft.com/office/drawing/2014/main" id="{D735429C-939B-E682-A123-D0A9CA009911}"/>
+                <a16:creationId xmlns:a16="http://schemas.microsoft.com/office/drawing/2014/main" id="{7F642C62-C50D-D2DC-28BB-97CF8769D478}"/>
               </a:ext>
             </a:extLst>
           </p:cNvPr>
@@ -3498,7 +3498,7 @@
           <p:cNvPr id="6" name="z00_grid_v_2">
             <a:extLst>
               <a:ext uri="{FF2B5EF4-FFF2-40B4-BE49-F238E27FC236}">
-                <a16:creationId xmlns:a16="http://schemas.microsoft.com/office/drawing/2014/main" id="{2A9A221E-68F4-33C3-BE7F-F4A4075D64E2}"/>
+                <a16:creationId xmlns:a16="http://schemas.microsoft.com/office/drawing/2014/main" id="{88956942-5AF3-7115-09D4-BD89688D0848}"/>
               </a:ext>
             </a:extLst>
           </p:cNvPr>
@@ -3541,7 +3541,7 @@
           <p:cNvPr id="7" name="header_title">
             <a:extLst>
               <a:ext uri="{FF2B5EF4-FFF2-40B4-BE49-F238E27FC236}">
-                <a16:creationId xmlns:a16="http://schemas.microsoft.com/office/drawing/2014/main" id="{4C51FE86-874D-F892-E57D-7B36C10A2728}"/>
+                <a16:creationId xmlns:a16="http://schemas.microsoft.com/office/drawing/2014/main" id="{E7C4B52B-5262-B6D0-A160-F68F97C1BDA0}"/>
               </a:ext>
             </a:extLst>
           </p:cNvPr>
@@ -3587,7 +3587,7 @@
           <p:cNvPr id="8" name="header_subtitle">
             <a:extLst>
               <a:ext uri="{FF2B5EF4-FFF2-40B4-BE49-F238E27FC236}">
-                <a16:creationId xmlns:a16="http://schemas.microsoft.com/office/drawing/2014/main" id="{9E25A9BF-367E-3B87-056D-B3206391EBB2}"/>
+                <a16:creationId xmlns:a16="http://schemas.microsoft.com/office/drawing/2014/main" id="{304D951F-3FA0-0C1D-38A1-91507B05EA77}"/>
               </a:ext>
             </a:extLst>
           </p:cNvPr>
@@ -3633,7 +3633,7 @@
           <p:cNvPr id="9" name="zone_content_panel">
             <a:extLst>
               <a:ext uri="{FF2B5EF4-FFF2-40B4-BE49-F238E27FC236}">
-                <a16:creationId xmlns:a16="http://schemas.microsoft.com/office/drawing/2014/main" id="{75EEA66F-E4A7-5491-4469-1CB5FBEF3FD6}"/>
+                <a16:creationId xmlns:a16="http://schemas.microsoft.com/office/drawing/2014/main" id="{B1A402D1-68D2-40D2-B5AC-BAF5F1FF43B2}"/>
               </a:ext>
             </a:extLst>
           </p:cNvPr>
@@ -3696,7 +3696,7 @@
           <p:cNvPr id="10" name="zone_content_title">
             <a:extLst>
               <a:ext uri="{FF2B5EF4-FFF2-40B4-BE49-F238E27FC236}">
-                <a16:creationId xmlns:a16="http://schemas.microsoft.com/office/drawing/2014/main" id="{640544BA-6E3B-8271-B442-75F93DF83507}"/>
+                <a16:creationId xmlns:a16="http://schemas.microsoft.com/office/drawing/2014/main" id="{BD69AD21-83C2-33F0-8FFC-41904E87D36D}"/>
               </a:ext>
             </a:extLst>
           </p:cNvPr>
@@ -3742,7 +3742,7 @@
           <p:cNvPr id="11" name="zone_content_subtitle">
             <a:extLst>
               <a:ext uri="{FF2B5EF4-FFF2-40B4-BE49-F238E27FC236}">
-                <a16:creationId xmlns:a16="http://schemas.microsoft.com/office/drawing/2014/main" id="{73FF655D-C4A6-920A-D913-642793AA6FA7}"/>
+                <a16:creationId xmlns:a16="http://schemas.microsoft.com/office/drawing/2014/main" id="{EC581DE1-5863-1A60-CFAD-BD178341572D}"/>
               </a:ext>
             </a:extLst>
           </p:cNvPr>
@@ -3788,7 +3788,7 @@
           <p:cNvPr id="12" name="zone_reasoning_panel">
             <a:extLst>
               <a:ext uri="{FF2B5EF4-FFF2-40B4-BE49-F238E27FC236}">
-                <a16:creationId xmlns:a16="http://schemas.microsoft.com/office/drawing/2014/main" id="{5D37F165-68D0-FBC7-645E-AD4C86297C4B}"/>
+                <a16:creationId xmlns:a16="http://schemas.microsoft.com/office/drawing/2014/main" id="{156402AB-4EC5-DD74-9814-95D9C7E360D4}"/>
               </a:ext>
             </a:extLst>
           </p:cNvPr>
@@ -3851,7 +3851,7 @@
           <p:cNvPr id="13" name="zone_reasoning_title">
             <a:extLst>
               <a:ext uri="{FF2B5EF4-FFF2-40B4-BE49-F238E27FC236}">
-                <a16:creationId xmlns:a16="http://schemas.microsoft.com/office/drawing/2014/main" id="{2E8AFBF9-D906-E35C-D302-3364A6F73A87}"/>
+                <a16:creationId xmlns:a16="http://schemas.microsoft.com/office/drawing/2014/main" id="{20F6C67E-B70C-E50C-F4A6-5BC6BA949E87}"/>
               </a:ext>
             </a:extLst>
           </p:cNvPr>
@@ -3897,7 +3897,7 @@
           <p:cNvPr id="14" name="zone_reasoning_subtitle">
             <a:extLst>
               <a:ext uri="{FF2B5EF4-FFF2-40B4-BE49-F238E27FC236}">
-                <a16:creationId xmlns:a16="http://schemas.microsoft.com/office/drawing/2014/main" id="{390FF551-A831-969F-3478-10EB587D16FD}"/>
+                <a16:creationId xmlns:a16="http://schemas.microsoft.com/office/drawing/2014/main" id="{92D8154F-8E38-0FCC-3EED-7CE6F44107D9}"/>
               </a:ext>
             </a:extLst>
           </p:cNvPr>
@@ -3943,7 +3943,7 @@
           <p:cNvPr id="15" name="zone_rules_panel">
             <a:extLst>
               <a:ext uri="{FF2B5EF4-FFF2-40B4-BE49-F238E27FC236}">
-                <a16:creationId xmlns:a16="http://schemas.microsoft.com/office/drawing/2014/main" id="{5DC147B4-44CF-275F-33D4-53DFC7E52571}"/>
+                <a16:creationId xmlns:a16="http://schemas.microsoft.com/office/drawing/2014/main" id="{CF94BBD3-016C-FA11-B5A4-4E7F73BF285F}"/>
               </a:ext>
             </a:extLst>
           </p:cNvPr>
@@ -4006,7 +4006,7 @@
           <p:cNvPr id="16" name="zone_rules_title">
             <a:extLst>
               <a:ext uri="{FF2B5EF4-FFF2-40B4-BE49-F238E27FC236}">
-                <a16:creationId xmlns:a16="http://schemas.microsoft.com/office/drawing/2014/main" id="{2C69B890-D636-362A-A71C-6B09CE8A021E}"/>
+                <a16:creationId xmlns:a16="http://schemas.microsoft.com/office/drawing/2014/main" id="{8606292C-B854-645C-6DA0-706B2737DC08}"/>
               </a:ext>
             </a:extLst>
           </p:cNvPr>
@@ -4052,7 +4052,7 @@
           <p:cNvPr id="17" name="zone_rules_subtitle">
             <a:extLst>
               <a:ext uri="{FF2B5EF4-FFF2-40B4-BE49-F238E27FC236}">
-                <a16:creationId xmlns:a16="http://schemas.microsoft.com/office/drawing/2014/main" id="{CA96A8E5-402D-9D32-B3F0-9AEDF4406A42}"/>
+                <a16:creationId xmlns:a16="http://schemas.microsoft.com/office/drawing/2014/main" id="{0742C7DE-9988-672C-0083-1B7B1500C999}"/>
               </a:ext>
             </a:extLst>
           </p:cNvPr>
@@ -4098,7 +4098,7 @@
           <p:cNvPr id="18" name="zone_outputs_panel">
             <a:extLst>
               <a:ext uri="{FF2B5EF4-FFF2-40B4-BE49-F238E27FC236}">
-                <a16:creationId xmlns:a16="http://schemas.microsoft.com/office/drawing/2014/main" id="{8A9D16F1-C697-BB34-68EB-844CEFEDB228}"/>
+                <a16:creationId xmlns:a16="http://schemas.microsoft.com/office/drawing/2014/main" id="{517B4936-F0DE-12C4-559A-EE00E14EB294}"/>
               </a:ext>
             </a:extLst>
           </p:cNvPr>
@@ -4161,7 +4161,7 @@
           <p:cNvPr id="19" name="zone_outputs_title">
             <a:extLst>
               <a:ext uri="{FF2B5EF4-FFF2-40B4-BE49-F238E27FC236}">
-                <a16:creationId xmlns:a16="http://schemas.microsoft.com/office/drawing/2014/main" id="{95A3574E-0AC8-8874-A8CC-E1EC874D40E4}"/>
+                <a16:creationId xmlns:a16="http://schemas.microsoft.com/office/drawing/2014/main" id="{90B49BC0-2FD5-C48F-E423-5439029BABBC}"/>
               </a:ext>
             </a:extLst>
           </p:cNvPr>
@@ -4207,7 +4207,7 @@
           <p:cNvPr id="20" name="zone_outputs_subtitle">
             <a:extLst>
               <a:ext uri="{FF2B5EF4-FFF2-40B4-BE49-F238E27FC236}">
-                <a16:creationId xmlns:a16="http://schemas.microsoft.com/office/drawing/2014/main" id="{602DB773-F867-3E8C-3DC2-48B0C3578659}"/>
+                <a16:creationId xmlns:a16="http://schemas.microsoft.com/office/drawing/2014/main" id="{9F286B1B-78BA-374D-8973-582371CB3166}"/>
               </a:ext>
             </a:extLst>
           </p:cNvPr>
@@ -4253,7 +4253,7 @@
           <p:cNvPr id="21" name="main_start_markdown">
             <a:extLst>
               <a:ext uri="{FF2B5EF4-FFF2-40B4-BE49-F238E27FC236}">
-                <a16:creationId xmlns:a16="http://schemas.microsoft.com/office/drawing/2014/main" id="{BE098F49-6C65-1B39-FC1D-23F74E08BE85}"/>
+                <a16:creationId xmlns:a16="http://schemas.microsoft.com/office/drawing/2014/main" id="{9790F57E-46A1-99D7-D155-44AA1C857D6E}"/>
               </a:ext>
             </a:extLst>
           </p:cNvPr>
@@ -4296,7 +4296,7 @@
           <p:cNvPr id="22" name="main_markdown_splitter">
             <a:extLst>
               <a:ext uri="{FF2B5EF4-FFF2-40B4-BE49-F238E27FC236}">
-                <a16:creationId xmlns:a16="http://schemas.microsoft.com/office/drawing/2014/main" id="{8F2D7F3E-DB2C-E21C-2F44-E549D11A13C1}"/>
+                <a16:creationId xmlns:a16="http://schemas.microsoft.com/office/drawing/2014/main" id="{C2F4E314-4309-189B-0F7B-14DDE809F276}"/>
               </a:ext>
             </a:extLst>
           </p:cNvPr>
@@ -4339,7 +4339,7 @@
           <p:cNvPr id="23" name="main_splitter_ir_seg_1">
             <a:extLst>
               <a:ext uri="{FF2B5EF4-FFF2-40B4-BE49-F238E27FC236}">
-                <a16:creationId xmlns:a16="http://schemas.microsoft.com/office/drawing/2014/main" id="{518563CB-B296-4D23-D9E1-D44B5BCF2B31}"/>
+                <a16:creationId xmlns:a16="http://schemas.microsoft.com/office/drawing/2014/main" id="{1814A0B9-D200-45B9-D791-787139377B76}"/>
               </a:ext>
             </a:extLst>
           </p:cNvPr>
@@ -4382,7 +4382,7 @@
           <p:cNvPr id="24" name="main_splitter_ir_seg_2">
             <a:extLst>
               <a:ext uri="{FF2B5EF4-FFF2-40B4-BE49-F238E27FC236}">
-                <a16:creationId xmlns:a16="http://schemas.microsoft.com/office/drawing/2014/main" id="{F19E6A70-7BA0-EFF4-F21F-E3EF54128623}"/>
+                <a16:creationId xmlns:a16="http://schemas.microsoft.com/office/drawing/2014/main" id="{F65BE2D3-8DC0-DC47-C67B-7790192DD61B}"/>
               </a:ext>
             </a:extLst>
           </p:cNvPr>
@@ -4425,7 +4425,7 @@
           <p:cNvPr id="25" name="main_splitter_ir_seg_3">
             <a:extLst>
               <a:ext uri="{FF2B5EF4-FFF2-40B4-BE49-F238E27FC236}">
-                <a16:creationId xmlns:a16="http://schemas.microsoft.com/office/drawing/2014/main" id="{0C193FA0-5D31-C9BE-1DC7-B6610CA155EA}"/>
+                <a16:creationId xmlns:a16="http://schemas.microsoft.com/office/drawing/2014/main" id="{A9C92626-572E-48B9-438D-E241DC1AD3BB}"/>
               </a:ext>
             </a:extLst>
           </p:cNvPr>
@@ -4468,7 +4468,7 @@
           <p:cNvPr id="26" name="hint_ir_reasoning">
             <a:extLst>
               <a:ext uri="{FF2B5EF4-FFF2-40B4-BE49-F238E27FC236}">
-                <a16:creationId xmlns:a16="http://schemas.microsoft.com/office/drawing/2014/main" id="{31165C7E-7DE6-2A55-6D97-F6CA1F6BBF4C}"/>
+                <a16:creationId xmlns:a16="http://schemas.microsoft.com/office/drawing/2014/main" id="{65BDC9DF-43D0-58D4-DA57-0DF1D60E0ADB}"/>
               </a:ext>
             </a:extLst>
           </p:cNvPr>
@@ -4512,7 +4512,7 @@
           <p:cNvPr id="27" name="main_ir_rules">
             <a:extLst>
               <a:ext uri="{FF2B5EF4-FFF2-40B4-BE49-F238E27FC236}">
-                <a16:creationId xmlns:a16="http://schemas.microsoft.com/office/drawing/2014/main" id="{08A2700A-7A1E-BA07-98AC-FFA36777F390}"/>
+                <a16:creationId xmlns:a16="http://schemas.microsoft.com/office/drawing/2014/main" id="{E83D9E9B-F1B6-14A2-F26A-D6B873D238C9}"/>
               </a:ext>
             </a:extLst>
           </p:cNvPr>
@@ -4555,7 +4555,7 @@
           <p:cNvPr id="28" name="hint_reasoning_rules_seg_1">
             <a:extLst>
               <a:ext uri="{FF2B5EF4-FFF2-40B4-BE49-F238E27FC236}">
-                <a16:creationId xmlns:a16="http://schemas.microsoft.com/office/drawing/2014/main" id="{D870A03F-0DC9-DBFB-C34F-39E57DE6686A}"/>
+                <a16:creationId xmlns:a16="http://schemas.microsoft.com/office/drawing/2014/main" id="{343934FC-AB4E-D744-36DB-13A425EC2CE2}"/>
               </a:ext>
             </a:extLst>
           </p:cNvPr>
@@ -4599,7 +4599,7 @@
           <p:cNvPr id="29" name="hint_reasoning_rules_seg_2">
             <a:extLst>
               <a:ext uri="{FF2B5EF4-FFF2-40B4-BE49-F238E27FC236}">
-                <a16:creationId xmlns:a16="http://schemas.microsoft.com/office/drawing/2014/main" id="{6CE08CD6-1C73-2448-5A5E-62DB6BE6F54A}"/>
+                <a16:creationId xmlns:a16="http://schemas.microsoft.com/office/drawing/2014/main" id="{5DF9EA26-3342-CA24-96A8-F36ACE6F81FA}"/>
               </a:ext>
             </a:extLst>
           </p:cNvPr>
@@ -4643,7 +4643,7 @@
           <p:cNvPr id="30" name="hint_reasoning_rules_seg_3">
             <a:extLst>
               <a:ext uri="{FF2B5EF4-FFF2-40B4-BE49-F238E27FC236}">
-                <a16:creationId xmlns:a16="http://schemas.microsoft.com/office/drawing/2014/main" id="{E16F1DAA-DB21-DA9F-CF74-97280EA92CDC}"/>
+                <a16:creationId xmlns:a16="http://schemas.microsoft.com/office/drawing/2014/main" id="{14D59559-6681-7A96-8583-9CF907AF1287}"/>
               </a:ext>
             </a:extLst>
           </p:cNvPr>
@@ -4687,7 +4687,7 @@
           <p:cNvPr id="31" name="rule_features_recipes">
             <a:extLst>
               <a:ext uri="{FF2B5EF4-FFF2-40B4-BE49-F238E27FC236}">
-                <a16:creationId xmlns:a16="http://schemas.microsoft.com/office/drawing/2014/main" id="{405DA145-DA31-D5E3-5621-8F4CF285FD27}"/>
+                <a16:creationId xmlns:a16="http://schemas.microsoft.com/office/drawing/2014/main" id="{9DA8A0E9-4322-DD5F-7CC2-CB64BD286875}"/>
               </a:ext>
             </a:extLst>
           </p:cNvPr>
@@ -4730,7 +4730,7 @@
           <p:cNvPr id="32" name="rule_recipes_theme">
             <a:extLst>
               <a:ext uri="{FF2B5EF4-FFF2-40B4-BE49-F238E27FC236}">
-                <a16:creationId xmlns:a16="http://schemas.microsoft.com/office/drawing/2014/main" id="{9012AB0E-311C-48E0-5F15-DCC1540050F9}"/>
+                <a16:creationId xmlns:a16="http://schemas.microsoft.com/office/drawing/2014/main" id="{DE8AE2CA-F28F-66FF-1DE3-3B4D4387D13C}"/>
               </a:ext>
             </a:extLst>
           </p:cNvPr>
@@ -4773,7 +4773,7 @@
           <p:cNvPr id="33" name="rule_features_compose">
             <a:extLst>
               <a:ext uri="{FF2B5EF4-FFF2-40B4-BE49-F238E27FC236}">
-                <a16:creationId xmlns:a16="http://schemas.microsoft.com/office/drawing/2014/main" id="{E780197E-0C5F-ED5B-6034-5EE9ABE23CA1}"/>
+                <a16:creationId xmlns:a16="http://schemas.microsoft.com/office/drawing/2014/main" id="{7283F9E5-25C1-3B9F-1DFC-56201C1AC617}"/>
               </a:ext>
             </a:extLst>
           </p:cNvPr>
@@ -4816,7 +4816,7 @@
           <p:cNvPr id="34" name="rule_recipes_objects">
             <a:extLst>
               <a:ext uri="{FF2B5EF4-FFF2-40B4-BE49-F238E27FC236}">
-                <a16:creationId xmlns:a16="http://schemas.microsoft.com/office/drawing/2014/main" id="{3F5F4C82-4452-CA24-5660-CC659046207F}"/>
+                <a16:creationId xmlns:a16="http://schemas.microsoft.com/office/drawing/2014/main" id="{4077CD53-255D-1C5B-658F-358AF9C8DB27}"/>
               </a:ext>
             </a:extLst>
           </p:cNvPr>
@@ -4859,7 +4859,7 @@
           <p:cNvPr id="35" name="rule_theme_decorate">
             <a:extLst>
               <a:ext uri="{FF2B5EF4-FFF2-40B4-BE49-F238E27FC236}">
-                <a16:creationId xmlns:a16="http://schemas.microsoft.com/office/drawing/2014/main" id="{25D9A7F8-B790-C633-326D-FE0106E57E9F}"/>
+                <a16:creationId xmlns:a16="http://schemas.microsoft.com/office/drawing/2014/main" id="{9743DDFA-0476-C161-7ED3-6707C565B2D9}"/>
               </a:ext>
             </a:extLst>
           </p:cNvPr>
@@ -4902,7 +4902,7 @@
           <p:cNvPr id="36" name="rule_compose_objects">
             <a:extLst>
               <a:ext uri="{FF2B5EF4-FFF2-40B4-BE49-F238E27FC236}">
-                <a16:creationId xmlns:a16="http://schemas.microsoft.com/office/drawing/2014/main" id="{3B9D0AAA-ADED-605B-969D-65FB50CDDAF6}"/>
+                <a16:creationId xmlns:a16="http://schemas.microsoft.com/office/drawing/2014/main" id="{5DBF7B4E-FE9A-1E50-9C6F-15CE73D31CD3}"/>
               </a:ext>
             </a:extLst>
           </p:cNvPr>
@@ -4945,7 +4945,7 @@
           <p:cNvPr id="37" name="rule_objects_decorate">
             <a:extLst>
               <a:ext uri="{FF2B5EF4-FFF2-40B4-BE49-F238E27FC236}">
-                <a16:creationId xmlns:a16="http://schemas.microsoft.com/office/drawing/2014/main" id="{041CB320-92D6-E0DE-5D04-6A2C89286D70}"/>
+                <a16:creationId xmlns:a16="http://schemas.microsoft.com/office/drawing/2014/main" id="{BA231A34-5258-5AEA-50C5-93BD96B9F36D}"/>
               </a:ext>
             </a:extLst>
           </p:cNvPr>
@@ -4988,7 +4988,7 @@
           <p:cNvPr id="38" name="main_rules_styled_ir">
             <a:extLst>
               <a:ext uri="{FF2B5EF4-FFF2-40B4-BE49-F238E27FC236}">
-                <a16:creationId xmlns:a16="http://schemas.microsoft.com/office/drawing/2014/main" id="{5066A30E-0AFC-A47B-A343-E10C37FB095B}"/>
+                <a16:creationId xmlns:a16="http://schemas.microsoft.com/office/drawing/2014/main" id="{129D8337-2005-E916-A614-1706335AD186}"/>
               </a:ext>
             </a:extLst>
           </p:cNvPr>
@@ -5031,7 +5031,7 @@
           <p:cNvPr id="39" name="main_styled_renderers">
             <a:extLst>
               <a:ext uri="{FF2B5EF4-FFF2-40B4-BE49-F238E27FC236}">
-                <a16:creationId xmlns:a16="http://schemas.microsoft.com/office/drawing/2014/main" id="{4FE5F9B3-97B0-D5DE-5DA9-B64DD22B0F63}"/>
+                <a16:creationId xmlns:a16="http://schemas.microsoft.com/office/drawing/2014/main" id="{D6FB6AEC-E149-511E-7875-A1D8BFD87DA0}"/>
               </a:ext>
             </a:extLst>
           </p:cNvPr>
@@ -5074,7 +5074,7 @@
           <p:cNvPr id="40" name="validation_loop">
             <a:extLst>
               <a:ext uri="{FF2B5EF4-FFF2-40B4-BE49-F238E27FC236}">
-                <a16:creationId xmlns:a16="http://schemas.microsoft.com/office/drawing/2014/main" id="{7FCD7A21-57EA-4BBC-70B6-29A60D041E45}"/>
+                <a16:creationId xmlns:a16="http://schemas.microsoft.com/office/drawing/2014/main" id="{8C45973C-79C6-0EA5-CBF2-F4703D6484F3}"/>
               </a:ext>
             </a:extLst>
           </p:cNvPr>
@@ -5117,7 +5117,7 @@
           <p:cNvPr id="41" name="source_chip">
             <a:extLst>
               <a:ext uri="{FF2B5EF4-FFF2-40B4-BE49-F238E27FC236}">
-                <a16:creationId xmlns:a16="http://schemas.microsoft.com/office/drawing/2014/main" id="{314D7DCB-BF33-D4C1-BB8F-F682DB4F5B9F}"/>
+                <a16:creationId xmlns:a16="http://schemas.microsoft.com/office/drawing/2014/main" id="{2046CE01-8BE2-2313-3BF0-435F6E247C6D}"/>
               </a:ext>
             </a:extLst>
           </p:cNvPr>
@@ -5196,7 +5196,7 @@
           <p:cNvPr id="42" name="markdown_card">
             <a:extLst>
               <a:ext uri="{FF2B5EF4-FFF2-40B4-BE49-F238E27FC236}">
-                <a16:creationId xmlns:a16="http://schemas.microsoft.com/office/drawing/2014/main" id="{18948A2B-8876-1421-0FEF-1FD9531C1592}"/>
+                <a16:creationId xmlns:a16="http://schemas.microsoft.com/office/drawing/2014/main" id="{9020923E-A7A0-EAC6-8C09-87A3EE088D4F}"/>
               </a:ext>
             </a:extLst>
           </p:cNvPr>
@@ -5259,7 +5259,7 @@
           <p:cNvPr id="43" name="markdown_icon_dot">
             <a:extLst>
               <a:ext uri="{FF2B5EF4-FFF2-40B4-BE49-F238E27FC236}">
-                <a16:creationId xmlns:a16="http://schemas.microsoft.com/office/drawing/2014/main" id="{CBFFAE66-1771-B624-EFC8-9644E233E263}"/>
+                <a16:creationId xmlns:a16="http://schemas.microsoft.com/office/drawing/2014/main" id="{4542739E-5F83-78CC-3298-614547F85055}"/>
               </a:ext>
             </a:extLst>
           </p:cNvPr>
@@ -5329,7 +5329,7 @@
           <p:cNvPr id="44" name="markdown_title">
             <a:extLst>
               <a:ext uri="{FF2B5EF4-FFF2-40B4-BE49-F238E27FC236}">
-                <a16:creationId xmlns:a16="http://schemas.microsoft.com/office/drawing/2014/main" id="{041FDD08-8A1F-9D01-0AA1-DED0B5A502B3}"/>
+                <a16:creationId xmlns:a16="http://schemas.microsoft.com/office/drawing/2014/main" id="{CBAEE2E1-39B2-66C1-4F9A-ECDC25FBA690}"/>
               </a:ext>
             </a:extLst>
           </p:cNvPr>
@@ -5375,7 +5375,7 @@
           <p:cNvPr id="45" name="markdown_line_0">
             <a:extLst>
               <a:ext uri="{FF2B5EF4-FFF2-40B4-BE49-F238E27FC236}">
-                <a16:creationId xmlns:a16="http://schemas.microsoft.com/office/drawing/2014/main" id="{BC7EA232-39CE-A7B1-6C27-ADC13AC4B9BF}"/>
+                <a16:creationId xmlns:a16="http://schemas.microsoft.com/office/drawing/2014/main" id="{4EAAA773-C6EA-BCE4-466E-6833ECE34A77}"/>
               </a:ext>
             </a:extLst>
           </p:cNvPr>
@@ -5421,7 +5421,7 @@
           <p:cNvPr id="46" name="markdown_line_1">
             <a:extLst>
               <a:ext uri="{FF2B5EF4-FFF2-40B4-BE49-F238E27FC236}">
-                <a16:creationId xmlns:a16="http://schemas.microsoft.com/office/drawing/2014/main" id="{333033B6-74C6-8390-BCD7-F5B95464B7FE}"/>
+                <a16:creationId xmlns:a16="http://schemas.microsoft.com/office/drawing/2014/main" id="{00D1B0E9-94B5-FB89-7C32-A9E670024E32}"/>
               </a:ext>
             </a:extLst>
           </p:cNvPr>
@@ -5467,7 +5467,7 @@
           <p:cNvPr id="47" name="splitter_card">
             <a:extLst>
               <a:ext uri="{FF2B5EF4-FFF2-40B4-BE49-F238E27FC236}">
-                <a16:creationId xmlns:a16="http://schemas.microsoft.com/office/drawing/2014/main" id="{5737A75C-5B33-B0D6-1AD2-255877BC452D}"/>
+                <a16:creationId xmlns:a16="http://schemas.microsoft.com/office/drawing/2014/main" id="{0ED08C59-624C-7D0B-17E2-F42869D236D5}"/>
               </a:ext>
             </a:extLst>
           </p:cNvPr>
@@ -5530,7 +5530,7 @@
           <p:cNvPr id="48" name="splitter_icon_dot">
             <a:extLst>
               <a:ext uri="{FF2B5EF4-FFF2-40B4-BE49-F238E27FC236}">
-                <a16:creationId xmlns:a16="http://schemas.microsoft.com/office/drawing/2014/main" id="{3D6502D2-D524-327D-6C97-2BA86A4DEF9C}"/>
+                <a16:creationId xmlns:a16="http://schemas.microsoft.com/office/drawing/2014/main" id="{C9EDA9EE-D1CB-2515-1C31-6D2D3AA2E6E8}"/>
               </a:ext>
             </a:extLst>
           </p:cNvPr>
@@ -5600,7 +5600,7 @@
           <p:cNvPr id="49" name="splitter_title">
             <a:extLst>
               <a:ext uri="{FF2B5EF4-FFF2-40B4-BE49-F238E27FC236}">
-                <a16:creationId xmlns:a16="http://schemas.microsoft.com/office/drawing/2014/main" id="{82472CD3-442F-AD28-E51F-0F95EA972029}"/>
+                <a16:creationId xmlns:a16="http://schemas.microsoft.com/office/drawing/2014/main" id="{D85CE15A-8BD4-5750-388C-4E8298B531E0}"/>
               </a:ext>
             </a:extLst>
           </p:cNvPr>
@@ -5646,7 +5646,7 @@
           <p:cNvPr id="50" name="splitter_line_0">
             <a:extLst>
               <a:ext uri="{FF2B5EF4-FFF2-40B4-BE49-F238E27FC236}">
-                <a16:creationId xmlns:a16="http://schemas.microsoft.com/office/drawing/2014/main" id="{D3B8F10B-45D8-62C5-A053-A363421EBAA2}"/>
+                <a16:creationId xmlns:a16="http://schemas.microsoft.com/office/drawing/2014/main" id="{89CE7732-9DCB-1E2A-E832-3C0746F54E6A}"/>
               </a:ext>
             </a:extLst>
           </p:cNvPr>
@@ -5692,7 +5692,7 @@
           <p:cNvPr id="51" name="splitter_line_1">
             <a:extLst>
               <a:ext uri="{FF2B5EF4-FFF2-40B4-BE49-F238E27FC236}">
-                <a16:creationId xmlns:a16="http://schemas.microsoft.com/office/drawing/2014/main" id="{342E8040-1A68-7AF8-3AF0-5B67A511BFA6}"/>
+                <a16:creationId xmlns:a16="http://schemas.microsoft.com/office/drawing/2014/main" id="{A1C04D44-4F81-3800-8E90-C6330BACDF02}"/>
               </a:ext>
             </a:extLst>
           </p:cNvPr>
@@ -5738,7 +5738,7 @@
           <p:cNvPr id="52" name="ir_core_card">
             <a:extLst>
               <a:ext uri="{FF2B5EF4-FFF2-40B4-BE49-F238E27FC236}">
-                <a16:creationId xmlns:a16="http://schemas.microsoft.com/office/drawing/2014/main" id="{ECEF9804-BDC9-F948-F8C5-E334671EBF46}"/>
+                <a16:creationId xmlns:a16="http://schemas.microsoft.com/office/drawing/2014/main" id="{9855BA5D-7DC4-3F69-DBDA-D29E877A1231}"/>
               </a:ext>
             </a:extLst>
           </p:cNvPr>
@@ -5801,7 +5801,7 @@
           <p:cNvPr id="53" name="ir_core_icon_dot">
             <a:extLst>
               <a:ext uri="{FF2B5EF4-FFF2-40B4-BE49-F238E27FC236}">
-                <a16:creationId xmlns:a16="http://schemas.microsoft.com/office/drawing/2014/main" id="{3CCF7644-A2AB-0958-DAF8-B7BA0B78BB6A}"/>
+                <a16:creationId xmlns:a16="http://schemas.microsoft.com/office/drawing/2014/main" id="{23D326C9-E24B-4FA9-4C3D-3851C6C78CEF}"/>
               </a:ext>
             </a:extLst>
           </p:cNvPr>
@@ -5871,7 +5871,7 @@
           <p:cNvPr id="54" name="ir_core_title">
             <a:extLst>
               <a:ext uri="{FF2B5EF4-FFF2-40B4-BE49-F238E27FC236}">
-                <a16:creationId xmlns:a16="http://schemas.microsoft.com/office/drawing/2014/main" id="{3F5B5399-3D3B-C7D4-4ADE-5C128D45B7C7}"/>
+                <a16:creationId xmlns:a16="http://schemas.microsoft.com/office/drawing/2014/main" id="{EA22A16D-04F2-E1F5-B469-481756BFA0D8}"/>
               </a:ext>
             </a:extLst>
           </p:cNvPr>
@@ -5917,7 +5917,7 @@
           <p:cNvPr id="55" name="ir_core_line_0">
             <a:extLst>
               <a:ext uri="{FF2B5EF4-FFF2-40B4-BE49-F238E27FC236}">
-                <a16:creationId xmlns:a16="http://schemas.microsoft.com/office/drawing/2014/main" id="{04D8043E-364A-9DB4-AB3B-9B5AB40989B2}"/>
+                <a16:creationId xmlns:a16="http://schemas.microsoft.com/office/drawing/2014/main" id="{66AD04E9-1EDA-1850-AE2E-D9BFFBC6B18A}"/>
               </a:ext>
             </a:extLst>
           </p:cNvPr>
@@ -5963,7 +5963,7 @@
           <p:cNvPr id="56" name="ir_core_line_1">
             <a:extLst>
               <a:ext uri="{FF2B5EF4-FFF2-40B4-BE49-F238E27FC236}">
-                <a16:creationId xmlns:a16="http://schemas.microsoft.com/office/drawing/2014/main" id="{E1C2B7BA-8714-0CB4-893B-414E0155ABB9}"/>
+                <a16:creationId xmlns:a16="http://schemas.microsoft.com/office/drawing/2014/main" id="{EBC6818F-2B5F-2435-1A3A-3C16944A3CF0}"/>
               </a:ext>
             </a:extLst>
           </p:cNvPr>
@@ -6009,7 +6009,7 @@
           <p:cNvPr id="57" name="reasoning_card">
             <a:extLst>
               <a:ext uri="{FF2B5EF4-FFF2-40B4-BE49-F238E27FC236}">
-                <a16:creationId xmlns:a16="http://schemas.microsoft.com/office/drawing/2014/main" id="{FE2C03E3-7DED-E1AF-A118-2C5452CB9009}"/>
+                <a16:creationId xmlns:a16="http://schemas.microsoft.com/office/drawing/2014/main" id="{85E84AE3-BCA4-7A0F-CB89-2AA45BA09E38}"/>
               </a:ext>
             </a:extLst>
           </p:cNvPr>
@@ -6072,7 +6072,7 @@
           <p:cNvPr id="58" name="reasoning_icon_dot">
             <a:extLst>
               <a:ext uri="{FF2B5EF4-FFF2-40B4-BE49-F238E27FC236}">
-                <a16:creationId xmlns:a16="http://schemas.microsoft.com/office/drawing/2014/main" id="{FB09F900-6553-C495-2A80-A0687DE7DD79}"/>
+                <a16:creationId xmlns:a16="http://schemas.microsoft.com/office/drawing/2014/main" id="{2F084376-BD51-7B91-B330-A65629F360FC}"/>
               </a:ext>
             </a:extLst>
           </p:cNvPr>
@@ -6142,7 +6142,7 @@
           <p:cNvPr id="59" name="reasoning_title">
             <a:extLst>
               <a:ext uri="{FF2B5EF4-FFF2-40B4-BE49-F238E27FC236}">
-                <a16:creationId xmlns:a16="http://schemas.microsoft.com/office/drawing/2014/main" id="{EC59884C-BEB3-9366-7467-5A35792A385F}"/>
+                <a16:creationId xmlns:a16="http://schemas.microsoft.com/office/drawing/2014/main" id="{1382D06F-3DB7-D0DB-1B0B-D732439E112D}"/>
               </a:ext>
             </a:extLst>
           </p:cNvPr>
@@ -6188,7 +6188,7 @@
           <p:cNvPr id="60" name="reasoning_line_0">
             <a:extLst>
               <a:ext uri="{FF2B5EF4-FFF2-40B4-BE49-F238E27FC236}">
-                <a16:creationId xmlns:a16="http://schemas.microsoft.com/office/drawing/2014/main" id="{D5BB0B04-0574-7EE2-9251-B2022A06C5D0}"/>
+                <a16:creationId xmlns:a16="http://schemas.microsoft.com/office/drawing/2014/main" id="{46DDCA3D-3EA3-38DF-7FCE-EE638BF8FC41}"/>
               </a:ext>
             </a:extLst>
           </p:cNvPr>
@@ -6234,7 +6234,7 @@
           <p:cNvPr id="61" name="reasoning_guard">
             <a:extLst>
               <a:ext uri="{FF2B5EF4-FFF2-40B4-BE49-F238E27FC236}">
-                <a16:creationId xmlns:a16="http://schemas.microsoft.com/office/drawing/2014/main" id="{CC933524-681C-F846-49DD-8A0471359A6A}"/>
+                <a16:creationId xmlns:a16="http://schemas.microsoft.com/office/drawing/2014/main" id="{0C5D30D6-3AFF-3DBB-C11F-9C4B2749AA3F}"/>
               </a:ext>
             </a:extLst>
           </p:cNvPr>
@@ -6313,7 +6313,7 @@
           <p:cNvPr id="62" name="reasoning_limit">
             <a:extLst>
               <a:ext uri="{FF2B5EF4-FFF2-40B4-BE49-F238E27FC236}">
-                <a16:creationId xmlns:a16="http://schemas.microsoft.com/office/drawing/2014/main" id="{EA214860-A4AD-1C70-8DE2-EAE0FD008087}"/>
+                <a16:creationId xmlns:a16="http://schemas.microsoft.com/office/drawing/2014/main" id="{528CBC99-FD75-2C5D-1C2A-4178C03D1C50}"/>
               </a:ext>
             </a:extLst>
           </p:cNvPr>
@@ -6359,7 +6359,7 @@
           <p:cNvPr id="63" name="rule_engine_card">
             <a:extLst>
               <a:ext uri="{FF2B5EF4-FFF2-40B4-BE49-F238E27FC236}">
-                <a16:creationId xmlns:a16="http://schemas.microsoft.com/office/drawing/2014/main" id="{B41B3472-0DC2-75D4-6C92-53429434CF10}"/>
+                <a16:creationId xmlns:a16="http://schemas.microsoft.com/office/drawing/2014/main" id="{745D7222-9359-5B65-D254-93A4D34ED514}"/>
               </a:ext>
             </a:extLst>
           </p:cNvPr>
@@ -6422,7 +6422,7 @@
           <p:cNvPr id="64" name="rule_engine_title">
             <a:extLst>
               <a:ext uri="{FF2B5EF4-FFF2-40B4-BE49-F238E27FC236}">
-                <a16:creationId xmlns:a16="http://schemas.microsoft.com/office/drawing/2014/main" id="{3B1949F7-64DF-440A-6EF3-479B24198141}"/>
+                <a16:creationId xmlns:a16="http://schemas.microsoft.com/office/drawing/2014/main" id="{CFF8F8A8-63AF-A833-1CD8-97A9BE328252}"/>
               </a:ext>
             </a:extLst>
           </p:cNvPr>
@@ -6468,7 +6468,7 @@
           <p:cNvPr id="65" name="rule_engine_body">
             <a:extLst>
               <a:ext uri="{FF2B5EF4-FFF2-40B4-BE49-F238E27FC236}">
-                <a16:creationId xmlns:a16="http://schemas.microsoft.com/office/drawing/2014/main" id="{8E314015-4209-7ACB-215B-28F56B23E1C8}"/>
+                <a16:creationId xmlns:a16="http://schemas.microsoft.com/office/drawing/2014/main" id="{A8141090-0E27-A657-A556-9537606F0871}"/>
               </a:ext>
             </a:extLst>
           </p:cNvPr>
@@ -6514,7 +6514,7 @@
           <p:cNvPr id="66" name="features_card">
             <a:extLst>
               <a:ext uri="{FF2B5EF4-FFF2-40B4-BE49-F238E27FC236}">
-                <a16:creationId xmlns:a16="http://schemas.microsoft.com/office/drawing/2014/main" id="{14AD705A-519A-F959-9A54-671F43A6F1E5}"/>
+                <a16:creationId xmlns:a16="http://schemas.microsoft.com/office/drawing/2014/main" id="{4BCD436C-646C-A0DC-6641-7CB4A070D304}"/>
               </a:ext>
             </a:extLst>
           </p:cNvPr>
@@ -6577,7 +6577,7 @@
           <p:cNvPr id="67" name="features_icon_dot">
             <a:extLst>
               <a:ext uri="{FF2B5EF4-FFF2-40B4-BE49-F238E27FC236}">
-                <a16:creationId xmlns:a16="http://schemas.microsoft.com/office/drawing/2014/main" id="{C805DACF-8E4F-B284-1F47-08D81B7836FD}"/>
+                <a16:creationId xmlns:a16="http://schemas.microsoft.com/office/drawing/2014/main" id="{6401D63F-2F77-88D7-FE3A-776F72CA763D}"/>
               </a:ext>
             </a:extLst>
           </p:cNvPr>
@@ -6647,7 +6647,7 @@
           <p:cNvPr id="68" name="features_title">
             <a:extLst>
               <a:ext uri="{FF2B5EF4-FFF2-40B4-BE49-F238E27FC236}">
-                <a16:creationId xmlns:a16="http://schemas.microsoft.com/office/drawing/2014/main" id="{FB5BE84B-C940-0E08-F61A-539A5EED6DF7}"/>
+                <a16:creationId xmlns:a16="http://schemas.microsoft.com/office/drawing/2014/main" id="{8B187371-857B-37CB-06B0-640C6ECA9396}"/>
               </a:ext>
             </a:extLst>
           </p:cNvPr>
@@ -6693,7 +6693,7 @@
           <p:cNvPr id="69" name="features_line_0">
             <a:extLst>
               <a:ext uri="{FF2B5EF4-FFF2-40B4-BE49-F238E27FC236}">
-                <a16:creationId xmlns:a16="http://schemas.microsoft.com/office/drawing/2014/main" id="{887B8254-3A01-2CA4-6662-BE9877AD4DC9}"/>
+                <a16:creationId xmlns:a16="http://schemas.microsoft.com/office/drawing/2014/main" id="{37ABD299-C4E3-6FC1-6571-1F89DCED2022}"/>
               </a:ext>
             </a:extLst>
           </p:cNvPr>
@@ -6739,7 +6739,7 @@
           <p:cNvPr id="70" name="features_line_1">
             <a:extLst>
               <a:ext uri="{FF2B5EF4-FFF2-40B4-BE49-F238E27FC236}">
-                <a16:creationId xmlns:a16="http://schemas.microsoft.com/office/drawing/2014/main" id="{29DD07BA-4109-B369-84F1-60F1152DDFD6}"/>
+                <a16:creationId xmlns:a16="http://schemas.microsoft.com/office/drawing/2014/main" id="{BC3DF741-6A07-300A-BF43-0F9A3737AC5E}"/>
               </a:ext>
             </a:extLst>
           </p:cNvPr>
@@ -6785,7 +6785,7 @@
           <p:cNvPr id="71" name="recipes_card">
             <a:extLst>
               <a:ext uri="{FF2B5EF4-FFF2-40B4-BE49-F238E27FC236}">
-                <a16:creationId xmlns:a16="http://schemas.microsoft.com/office/drawing/2014/main" id="{ADFE3A65-8CD8-CD46-5CF2-C4429B502CF5}"/>
+                <a16:creationId xmlns:a16="http://schemas.microsoft.com/office/drawing/2014/main" id="{3AE53943-B32E-1C70-CBF0-E191E03AA065}"/>
               </a:ext>
             </a:extLst>
           </p:cNvPr>
@@ -6848,7 +6848,7 @@
           <p:cNvPr id="72" name="recipes_icon_dot">
             <a:extLst>
               <a:ext uri="{FF2B5EF4-FFF2-40B4-BE49-F238E27FC236}">
-                <a16:creationId xmlns:a16="http://schemas.microsoft.com/office/drawing/2014/main" id="{8AF02895-5E87-0F7C-AC59-B425E1B220A8}"/>
+                <a16:creationId xmlns:a16="http://schemas.microsoft.com/office/drawing/2014/main" id="{3A9ED321-12C9-7721-0503-4A9D7FF21569}"/>
               </a:ext>
             </a:extLst>
           </p:cNvPr>
@@ -6918,7 +6918,7 @@
           <p:cNvPr id="73" name="recipes_title">
             <a:extLst>
               <a:ext uri="{FF2B5EF4-FFF2-40B4-BE49-F238E27FC236}">
-                <a16:creationId xmlns:a16="http://schemas.microsoft.com/office/drawing/2014/main" id="{97155847-2409-2FE6-EF1C-DF7266D86255}"/>
+                <a16:creationId xmlns:a16="http://schemas.microsoft.com/office/drawing/2014/main" id="{D292963D-F50D-D3C6-B016-29FC83232F7B}"/>
               </a:ext>
             </a:extLst>
           </p:cNvPr>
@@ -6964,7 +6964,7 @@
           <p:cNvPr id="74" name="recipes_line_0">
             <a:extLst>
               <a:ext uri="{FF2B5EF4-FFF2-40B4-BE49-F238E27FC236}">
-                <a16:creationId xmlns:a16="http://schemas.microsoft.com/office/drawing/2014/main" id="{E32817B2-E8A8-5B54-77DE-0ED7FCB35036}"/>
+                <a16:creationId xmlns:a16="http://schemas.microsoft.com/office/drawing/2014/main" id="{BA80A026-EF70-E7F9-D6FC-58F9B8C5DC7C}"/>
               </a:ext>
             </a:extLst>
           </p:cNvPr>
@@ -7010,7 +7010,7 @@
           <p:cNvPr id="75" name="recipes_line_1">
             <a:extLst>
               <a:ext uri="{FF2B5EF4-FFF2-40B4-BE49-F238E27FC236}">
-                <a16:creationId xmlns:a16="http://schemas.microsoft.com/office/drawing/2014/main" id="{69E73E46-5182-B0EB-54C0-D916E9383D92}"/>
+                <a16:creationId xmlns:a16="http://schemas.microsoft.com/office/drawing/2014/main" id="{22828760-E8A7-80A6-FD72-C01863D13259}"/>
               </a:ext>
             </a:extLst>
           </p:cNvPr>
@@ -7056,7 +7056,7 @@
           <p:cNvPr id="76" name="theme_card">
             <a:extLst>
               <a:ext uri="{FF2B5EF4-FFF2-40B4-BE49-F238E27FC236}">
-                <a16:creationId xmlns:a16="http://schemas.microsoft.com/office/drawing/2014/main" id="{0AC995FF-49E8-A40C-A7C4-598719F90C95}"/>
+                <a16:creationId xmlns:a16="http://schemas.microsoft.com/office/drawing/2014/main" id="{F3DD550B-6C10-2BBD-9378-C0BD0F4E03FE}"/>
               </a:ext>
             </a:extLst>
           </p:cNvPr>
@@ -7119,7 +7119,7 @@
           <p:cNvPr id="77" name="theme_icon_dot">
             <a:extLst>
               <a:ext uri="{FF2B5EF4-FFF2-40B4-BE49-F238E27FC236}">
-                <a16:creationId xmlns:a16="http://schemas.microsoft.com/office/drawing/2014/main" id="{B186186F-86AB-0A1F-C61E-4D6551AA1B4B}"/>
+                <a16:creationId xmlns:a16="http://schemas.microsoft.com/office/drawing/2014/main" id="{C8AD4E8D-9C9C-37FF-C685-DD9484FC0EE6}"/>
               </a:ext>
             </a:extLst>
           </p:cNvPr>
@@ -7189,7 +7189,7 @@
           <p:cNvPr id="78" name="theme_title">
             <a:extLst>
               <a:ext uri="{FF2B5EF4-FFF2-40B4-BE49-F238E27FC236}">
-                <a16:creationId xmlns:a16="http://schemas.microsoft.com/office/drawing/2014/main" id="{6AFA71E7-C03E-83AB-628C-4F79C2C7691A}"/>
+                <a16:creationId xmlns:a16="http://schemas.microsoft.com/office/drawing/2014/main" id="{79A61A7D-44BE-AA88-7E75-533D5E0E1DC6}"/>
               </a:ext>
             </a:extLst>
           </p:cNvPr>
@@ -7235,7 +7235,7 @@
           <p:cNvPr id="79" name="theme_line_0">
             <a:extLst>
               <a:ext uri="{FF2B5EF4-FFF2-40B4-BE49-F238E27FC236}">
-                <a16:creationId xmlns:a16="http://schemas.microsoft.com/office/drawing/2014/main" id="{7CB09E92-0E06-8170-84BF-79E3D509375C}"/>
+                <a16:creationId xmlns:a16="http://schemas.microsoft.com/office/drawing/2014/main" id="{9B5EF170-567F-3AFB-D19A-56B45412ADDF}"/>
               </a:ext>
             </a:extLst>
           </p:cNvPr>
@@ -7281,7 +7281,7 @@
           <p:cNvPr id="80" name="theme_line_1">
             <a:extLst>
               <a:ext uri="{FF2B5EF4-FFF2-40B4-BE49-F238E27FC236}">
-                <a16:creationId xmlns:a16="http://schemas.microsoft.com/office/drawing/2014/main" id="{6C2BCF8E-A141-4B4F-9D26-C0956C2B828C}"/>
+                <a16:creationId xmlns:a16="http://schemas.microsoft.com/office/drawing/2014/main" id="{DF3EAC28-04E8-A030-B434-B67EE8880479}"/>
               </a:ext>
             </a:extLst>
           </p:cNvPr>
@@ -7327,7 +7327,7 @@
           <p:cNvPr id="81" name="compose_card">
             <a:extLst>
               <a:ext uri="{FF2B5EF4-FFF2-40B4-BE49-F238E27FC236}">
-                <a16:creationId xmlns:a16="http://schemas.microsoft.com/office/drawing/2014/main" id="{FB4DFEB8-9E72-E755-385C-C363FCF08220}"/>
+                <a16:creationId xmlns:a16="http://schemas.microsoft.com/office/drawing/2014/main" id="{5C3523A9-ADDE-8AF4-EB8D-A507CC5E59A7}"/>
               </a:ext>
             </a:extLst>
           </p:cNvPr>
@@ -7390,7 +7390,7 @@
           <p:cNvPr id="82" name="compose_icon_dot">
             <a:extLst>
               <a:ext uri="{FF2B5EF4-FFF2-40B4-BE49-F238E27FC236}">
-                <a16:creationId xmlns:a16="http://schemas.microsoft.com/office/drawing/2014/main" id="{1D360E61-1786-2BB4-D3C4-1D909F49C356}"/>
+                <a16:creationId xmlns:a16="http://schemas.microsoft.com/office/drawing/2014/main" id="{4BE5AA95-DEEF-8596-4F0D-10C194ACA286}"/>
               </a:ext>
             </a:extLst>
           </p:cNvPr>
@@ -7460,7 +7460,7 @@
           <p:cNvPr id="83" name="compose_title">
             <a:extLst>
               <a:ext uri="{FF2B5EF4-FFF2-40B4-BE49-F238E27FC236}">
-                <a16:creationId xmlns:a16="http://schemas.microsoft.com/office/drawing/2014/main" id="{BA240F06-951C-D300-9593-49B3175151EF}"/>
+                <a16:creationId xmlns:a16="http://schemas.microsoft.com/office/drawing/2014/main" id="{6C18A6BC-EFA5-39BD-2243-D757F2BE7693}"/>
               </a:ext>
             </a:extLst>
           </p:cNvPr>
@@ -7506,7 +7506,7 @@
           <p:cNvPr id="84" name="compose_line_0">
             <a:extLst>
               <a:ext uri="{FF2B5EF4-FFF2-40B4-BE49-F238E27FC236}">
-                <a16:creationId xmlns:a16="http://schemas.microsoft.com/office/drawing/2014/main" id="{9A50F16B-2622-C09E-01EF-E8C0EFFC3B75}"/>
+                <a16:creationId xmlns:a16="http://schemas.microsoft.com/office/drawing/2014/main" id="{594DD277-53B1-1F39-BE4C-1ECED0AEE911}"/>
               </a:ext>
             </a:extLst>
           </p:cNvPr>
@@ -7552,7 +7552,7 @@
           <p:cNvPr id="85" name="compose_line_1">
             <a:extLst>
               <a:ext uri="{FF2B5EF4-FFF2-40B4-BE49-F238E27FC236}">
-                <a16:creationId xmlns:a16="http://schemas.microsoft.com/office/drawing/2014/main" id="{38C2A6B8-5A66-F917-4DD5-E678CD5EDCC8}"/>
+                <a16:creationId xmlns:a16="http://schemas.microsoft.com/office/drawing/2014/main" id="{E21B0CFD-D3EA-82FA-0EE0-1BE11821767B}"/>
               </a:ext>
             </a:extLst>
           </p:cNvPr>
@@ -7598,7 +7598,7 @@
           <p:cNvPr id="86" name="objects_card">
             <a:extLst>
               <a:ext uri="{FF2B5EF4-FFF2-40B4-BE49-F238E27FC236}">
-                <a16:creationId xmlns:a16="http://schemas.microsoft.com/office/drawing/2014/main" id="{936E70B6-48DC-F30C-B263-F537451857A3}"/>
+                <a16:creationId xmlns:a16="http://schemas.microsoft.com/office/drawing/2014/main" id="{06688210-B3AA-B93D-6A17-DE6731E94EEF}"/>
               </a:ext>
             </a:extLst>
           </p:cNvPr>
@@ -7661,7 +7661,7 @@
           <p:cNvPr id="87" name="objects_icon_dot">
             <a:extLst>
               <a:ext uri="{FF2B5EF4-FFF2-40B4-BE49-F238E27FC236}">
-                <a16:creationId xmlns:a16="http://schemas.microsoft.com/office/drawing/2014/main" id="{A6AF59F5-69EB-A367-1023-72B70A369591}"/>
+                <a16:creationId xmlns:a16="http://schemas.microsoft.com/office/drawing/2014/main" id="{2B16306B-D055-8615-A137-0641614C88B8}"/>
               </a:ext>
             </a:extLst>
           </p:cNvPr>
@@ -7731,7 +7731,7 @@
           <p:cNvPr id="88" name="objects_title">
             <a:extLst>
               <a:ext uri="{FF2B5EF4-FFF2-40B4-BE49-F238E27FC236}">
-                <a16:creationId xmlns:a16="http://schemas.microsoft.com/office/drawing/2014/main" id="{713F6BC0-52A7-1909-5F21-4012E18BB1D8}"/>
+                <a16:creationId xmlns:a16="http://schemas.microsoft.com/office/drawing/2014/main" id="{9A889512-B09F-FBE8-B944-60647B569D45}"/>
               </a:ext>
             </a:extLst>
           </p:cNvPr>
@@ -7777,7 +7777,7 @@
           <p:cNvPr id="89" name="objects_line_0">
             <a:extLst>
               <a:ext uri="{FF2B5EF4-FFF2-40B4-BE49-F238E27FC236}">
-                <a16:creationId xmlns:a16="http://schemas.microsoft.com/office/drawing/2014/main" id="{C9A276DB-06CC-D893-D60C-569345C9C4EA}"/>
+                <a16:creationId xmlns:a16="http://schemas.microsoft.com/office/drawing/2014/main" id="{5D612A22-2A9D-EB66-0B77-4904A8FF8F31}"/>
               </a:ext>
             </a:extLst>
           </p:cNvPr>
@@ -7823,7 +7823,7 @@
           <p:cNvPr id="90" name="objects_line_1">
             <a:extLst>
               <a:ext uri="{FF2B5EF4-FFF2-40B4-BE49-F238E27FC236}">
-                <a16:creationId xmlns:a16="http://schemas.microsoft.com/office/drawing/2014/main" id="{EB85426D-B946-8DA9-0DFF-A2799E099B8C}"/>
+                <a16:creationId xmlns:a16="http://schemas.microsoft.com/office/drawing/2014/main" id="{C981F517-41DD-73AB-7DCC-440DDE3818A6}"/>
               </a:ext>
             </a:extLst>
           </p:cNvPr>
@@ -7869,7 +7869,7 @@
           <p:cNvPr id="91" name="decorate_card">
             <a:extLst>
               <a:ext uri="{FF2B5EF4-FFF2-40B4-BE49-F238E27FC236}">
-                <a16:creationId xmlns:a16="http://schemas.microsoft.com/office/drawing/2014/main" id="{02BB35E0-CC5A-1754-9D4D-EA28E316C091}"/>
+                <a16:creationId xmlns:a16="http://schemas.microsoft.com/office/drawing/2014/main" id="{8B5AF0F3-55C2-3C65-D26F-ED8D61DCB28E}"/>
               </a:ext>
             </a:extLst>
           </p:cNvPr>
@@ -7932,7 +7932,7 @@
           <p:cNvPr id="92" name="decorate_icon_dot">
             <a:extLst>
               <a:ext uri="{FF2B5EF4-FFF2-40B4-BE49-F238E27FC236}">
-                <a16:creationId xmlns:a16="http://schemas.microsoft.com/office/drawing/2014/main" id="{F9D656CB-9CFC-4A0B-891A-14B89F488F50}"/>
+                <a16:creationId xmlns:a16="http://schemas.microsoft.com/office/drawing/2014/main" id="{A1CCDC85-0A03-2EF2-5FA1-7A205F2792E1}"/>
               </a:ext>
             </a:extLst>
           </p:cNvPr>
@@ -8002,7 +8002,7 @@
           <p:cNvPr id="93" name="decorate_title">
             <a:extLst>
               <a:ext uri="{FF2B5EF4-FFF2-40B4-BE49-F238E27FC236}">
-                <a16:creationId xmlns:a16="http://schemas.microsoft.com/office/drawing/2014/main" id="{C23C25BF-2CC5-E2A6-719C-CCEBF0AA3077}"/>
+                <a16:creationId xmlns:a16="http://schemas.microsoft.com/office/drawing/2014/main" id="{ED31583C-777F-15D3-DD54-123BA46C7423}"/>
               </a:ext>
             </a:extLst>
           </p:cNvPr>
@@ -8048,7 +8048,7 @@
           <p:cNvPr id="94" name="decorate_line_0">
             <a:extLst>
               <a:ext uri="{FF2B5EF4-FFF2-40B4-BE49-F238E27FC236}">
-                <a16:creationId xmlns:a16="http://schemas.microsoft.com/office/drawing/2014/main" id="{99FCF203-A2D6-B9DD-5D50-5AF8B52800A5}"/>
+                <a16:creationId xmlns:a16="http://schemas.microsoft.com/office/drawing/2014/main" id="{3B2B83E8-A92B-C569-7BBE-522C053FD48B}"/>
               </a:ext>
             </a:extLst>
           </p:cNvPr>
@@ -8094,7 +8094,7 @@
           <p:cNvPr id="95" name="decorate_line_1">
             <a:extLst>
               <a:ext uri="{FF2B5EF4-FFF2-40B4-BE49-F238E27FC236}">
-                <a16:creationId xmlns:a16="http://schemas.microsoft.com/office/drawing/2014/main" id="{5EEAE406-D2CE-384C-DC11-8C4A19D174F3}"/>
+                <a16:creationId xmlns:a16="http://schemas.microsoft.com/office/drawing/2014/main" id="{6F43CADB-366A-3C71-7E85-4E6DA281FD58}"/>
               </a:ext>
             </a:extLst>
           </p:cNvPr>
@@ -8140,7 +8140,7 @@
           <p:cNvPr id="96" name="styled_ir_card">
             <a:extLst>
               <a:ext uri="{FF2B5EF4-FFF2-40B4-BE49-F238E27FC236}">
-                <a16:creationId xmlns:a16="http://schemas.microsoft.com/office/drawing/2014/main" id="{97609E78-0AE4-197F-66D7-36C1CECBA675}"/>
+                <a16:creationId xmlns:a16="http://schemas.microsoft.com/office/drawing/2014/main" id="{523403BB-7AE8-CF6F-0FCE-8A377F9B7E12}"/>
               </a:ext>
             </a:extLst>
           </p:cNvPr>
@@ -8203,7 +8203,7 @@
           <p:cNvPr id="97" name="styled_ir_icon_dot">
             <a:extLst>
               <a:ext uri="{FF2B5EF4-FFF2-40B4-BE49-F238E27FC236}">
-                <a16:creationId xmlns:a16="http://schemas.microsoft.com/office/drawing/2014/main" id="{B5387B41-CE34-C947-304F-EFDB82E9224A}"/>
+                <a16:creationId xmlns:a16="http://schemas.microsoft.com/office/drawing/2014/main" id="{C2A28057-A018-382A-64F2-E9DD51D76C0C}"/>
               </a:ext>
             </a:extLst>
           </p:cNvPr>
@@ -8273,7 +8273,7 @@
           <p:cNvPr id="98" name="styled_ir_title">
             <a:extLst>
               <a:ext uri="{FF2B5EF4-FFF2-40B4-BE49-F238E27FC236}">
-                <a16:creationId xmlns:a16="http://schemas.microsoft.com/office/drawing/2014/main" id="{D24AC9CD-BDE3-3463-A6A2-FA8ABFD718F8}"/>
+                <a16:creationId xmlns:a16="http://schemas.microsoft.com/office/drawing/2014/main" id="{7FF261AD-E7B8-293A-7333-EE8240B43A5F}"/>
               </a:ext>
             </a:extLst>
           </p:cNvPr>
@@ -8319,7 +8319,7 @@
           <p:cNvPr id="99" name="styled_ir_line_0">
             <a:extLst>
               <a:ext uri="{FF2B5EF4-FFF2-40B4-BE49-F238E27FC236}">
-                <a16:creationId xmlns:a16="http://schemas.microsoft.com/office/drawing/2014/main" id="{56A5CAE5-5204-131D-BE44-7DE69088F236}"/>
+                <a16:creationId xmlns:a16="http://schemas.microsoft.com/office/drawing/2014/main" id="{425D0084-2DD0-964E-5452-B2B4AC4B219C}"/>
               </a:ext>
             </a:extLst>
           </p:cNvPr>
@@ -8365,7 +8365,7 @@
           <p:cNvPr id="100" name="styled_ir_line_1">
             <a:extLst>
               <a:ext uri="{FF2B5EF4-FFF2-40B4-BE49-F238E27FC236}">
-                <a16:creationId xmlns:a16="http://schemas.microsoft.com/office/drawing/2014/main" id="{38FB674D-08E1-ECF1-2747-651E4442E2E2}"/>
+                <a16:creationId xmlns:a16="http://schemas.microsoft.com/office/drawing/2014/main" id="{A843B5E0-13DB-DCC4-C60C-30BB989B03D6}"/>
               </a:ext>
             </a:extLst>
           </p:cNvPr>
@@ -8411,7 +8411,7 @@
           <p:cNvPr id="101" name="renderers_card">
             <a:extLst>
               <a:ext uri="{FF2B5EF4-FFF2-40B4-BE49-F238E27FC236}">
-                <a16:creationId xmlns:a16="http://schemas.microsoft.com/office/drawing/2014/main" id="{9575D116-9394-57A3-B2A0-13CD47FA3336}"/>
+                <a16:creationId xmlns:a16="http://schemas.microsoft.com/office/drawing/2014/main" id="{62EF4FAA-D3FC-7290-8E23-46046C7A56DD}"/>
               </a:ext>
             </a:extLst>
           </p:cNvPr>
@@ -8474,7 +8474,7 @@
           <p:cNvPr id="102" name="renderers_icon_dot">
             <a:extLst>
               <a:ext uri="{FF2B5EF4-FFF2-40B4-BE49-F238E27FC236}">
-                <a16:creationId xmlns:a16="http://schemas.microsoft.com/office/drawing/2014/main" id="{15CED09C-E919-90C6-017E-40A7E970F56F}"/>
+                <a16:creationId xmlns:a16="http://schemas.microsoft.com/office/drawing/2014/main" id="{482B26D0-99EF-3D19-7400-8BD36B55764C}"/>
               </a:ext>
             </a:extLst>
           </p:cNvPr>
@@ -8544,7 +8544,7 @@
           <p:cNvPr id="103" name="renderers_title">
             <a:extLst>
               <a:ext uri="{FF2B5EF4-FFF2-40B4-BE49-F238E27FC236}">
-                <a16:creationId xmlns:a16="http://schemas.microsoft.com/office/drawing/2014/main" id="{FAA06E00-EF9C-EC4E-7763-B6BE6B8AC7E4}"/>
+                <a16:creationId xmlns:a16="http://schemas.microsoft.com/office/drawing/2014/main" id="{380D8D62-40A9-99D7-B169-6173EE086559}"/>
               </a:ext>
             </a:extLst>
           </p:cNvPr>
@@ -8590,7 +8590,7 @@
           <p:cNvPr id="104" name="renderers_line_0">
             <a:extLst>
               <a:ext uri="{FF2B5EF4-FFF2-40B4-BE49-F238E27FC236}">
-                <a16:creationId xmlns:a16="http://schemas.microsoft.com/office/drawing/2014/main" id="{4241F1AB-768C-52A7-DF21-4AFA81CD7199}"/>
+                <a16:creationId xmlns:a16="http://schemas.microsoft.com/office/drawing/2014/main" id="{63258503-2E6F-C29E-3E76-B190B493E347}"/>
               </a:ext>
             </a:extLst>
           </p:cNvPr>
@@ -8636,7 +8636,7 @@
           <p:cNvPr id="105" name="renderers_line_1">
             <a:extLst>
               <a:ext uri="{FF2B5EF4-FFF2-40B4-BE49-F238E27FC236}">
-                <a16:creationId xmlns:a16="http://schemas.microsoft.com/office/drawing/2014/main" id="{C7405F49-C60D-B6BA-F1C9-3AA767E1AE3C}"/>
+                <a16:creationId xmlns:a16="http://schemas.microsoft.com/office/drawing/2014/main" id="{74CAE021-E395-D4A1-3A42-4D6C4F96B079}"/>
               </a:ext>
             </a:extLst>
           </p:cNvPr>
@@ -8682,7 +8682,7 @@
           <p:cNvPr id="106" name="visual_check">
             <a:extLst>
               <a:ext uri="{FF2B5EF4-FFF2-40B4-BE49-F238E27FC236}">
-                <a16:creationId xmlns:a16="http://schemas.microsoft.com/office/drawing/2014/main" id="{BA648C92-9629-7A02-49D3-7A657B043C55}"/>
+                <a16:creationId xmlns:a16="http://schemas.microsoft.com/office/drawing/2014/main" id="{7B785062-9613-AD97-17D7-EA42482124F5}"/>
               </a:ext>
             </a:extLst>
           </p:cNvPr>
@@ -8745,7 +8745,7 @@
           <p:cNvPr id="107" name="visual_check_stripe">
             <a:extLst>
               <a:ext uri="{FF2B5EF4-FFF2-40B4-BE49-F238E27FC236}">
-                <a16:creationId xmlns:a16="http://schemas.microsoft.com/office/drawing/2014/main" id="{9CB56335-C107-DF23-79DB-4124CC41D3F2}"/>
+                <a16:creationId xmlns:a16="http://schemas.microsoft.com/office/drawing/2014/main" id="{5D91FBA7-FFE2-8974-B6E1-136EE316BE27}"/>
               </a:ext>
             </a:extLst>
           </p:cNvPr>
@@ -8799,7 +8799,7 @@
           <p:cNvPr id="108" name="visual_check_seal_icon_dot">
             <a:extLst>
               <a:ext uri="{FF2B5EF4-FFF2-40B4-BE49-F238E27FC236}">
-                <a16:creationId xmlns:a16="http://schemas.microsoft.com/office/drawing/2014/main" id="{F6868A6A-8706-B001-C9C4-76E1C2C9E485}"/>
+                <a16:creationId xmlns:a16="http://schemas.microsoft.com/office/drawing/2014/main" id="{FEE0972C-FD20-BF3E-B1FE-8D53C92C252E}"/>
               </a:ext>
             </a:extLst>
           </p:cNvPr>
@@ -8869,7 +8869,7 @@
           <p:cNvPr id="109" name="visual_check_label">
             <a:extLst>
               <a:ext uri="{FF2B5EF4-FFF2-40B4-BE49-F238E27FC236}">
-                <a16:creationId xmlns:a16="http://schemas.microsoft.com/office/drawing/2014/main" id="{75504339-A50D-AF9B-46CA-7DED47D236B7}"/>
+                <a16:creationId xmlns:a16="http://schemas.microsoft.com/office/drawing/2014/main" id="{BD2DF70F-FB12-82EE-F74B-0A0F5DD87C9F}"/>
               </a:ext>
             </a:extLst>
           </p:cNvPr>
@@ -8915,7 +8915,7 @@
           <p:cNvPr id="110" name="visual_check_text">
             <a:extLst>
               <a:ext uri="{FF2B5EF4-FFF2-40B4-BE49-F238E27FC236}">
-                <a16:creationId xmlns:a16="http://schemas.microsoft.com/office/drawing/2014/main" id="{BE3B8FFC-7B9A-A597-CC1C-B350FD87C7DC}"/>
+                <a16:creationId xmlns:a16="http://schemas.microsoft.com/office/drawing/2014/main" id="{F7335E6E-F882-71C2-1E4B-28D8E687008D}"/>
               </a:ext>
             </a:extLst>
           </p:cNvPr>
@@ -8961,7 +8961,7 @@
           <p:cNvPr id="111" name="coherence_band">
             <a:extLst>
               <a:ext uri="{FF2B5EF4-FFF2-40B4-BE49-F238E27FC236}">
-                <a16:creationId xmlns:a16="http://schemas.microsoft.com/office/drawing/2014/main" id="{4E9303F8-C245-1A1C-2EBC-EE24B93668CE}"/>
+                <a16:creationId xmlns:a16="http://schemas.microsoft.com/office/drawing/2014/main" id="{08CB1353-7F17-2F85-7472-B2C3FC78BB42}"/>
               </a:ext>
             </a:extLst>
           </p:cNvPr>
@@ -9024,7 +9024,7 @@
           <p:cNvPr id="112" name="coherence_title">
             <a:extLst>
               <a:ext uri="{FF2B5EF4-FFF2-40B4-BE49-F238E27FC236}">
-                <a16:creationId xmlns:a16="http://schemas.microsoft.com/office/drawing/2014/main" id="{98571319-ABF2-3BD3-8D9D-27F658979238}"/>
+                <a16:creationId xmlns:a16="http://schemas.microsoft.com/office/drawing/2014/main" id="{1E1224B4-0E3D-E283-C8C2-781E03C6EAEC}"/>
               </a:ext>
             </a:extLst>
           </p:cNvPr>
@@ -9070,7 +9070,7 @@
           <p:cNvPr id="113" name="coherence_body">
             <a:extLst>
               <a:ext uri="{FF2B5EF4-FFF2-40B4-BE49-F238E27FC236}">
-                <a16:creationId xmlns:a16="http://schemas.microsoft.com/office/drawing/2014/main" id="{20C5F1F6-7EA9-CEA4-35DD-78A382CEC310}"/>
+                <a16:creationId xmlns:a16="http://schemas.microsoft.com/office/drawing/2014/main" id="{3490E3A9-14B4-E37A-FB39-F8879CD42ED9}"/>
               </a:ext>
             </a:extLst>
           </p:cNvPr>
@@ -9114,7 +9114,7 @@
     </p:spTree>
     <p:extLst>
       <p:ext uri="{BB962C8B-B14F-4D97-AF65-F5344CB8AC3E}">
-        <p14:creationId xmlns:p14="http://schemas.microsoft.com/office/powerpoint/2010/main" val="1595088913"/>
+        <p14:creationId xmlns:p14="http://schemas.microsoft.com/office/powerpoint/2010/main" val="2527544794"/>
       </p:ext>
     </p:extLst>
   </p:cSld>

</xml_diff>